<commit_message>
Complete Route2Zero 2.0 acceptance release
</commit_message>
<xml_diff>
--- a/output/submission/Route2Zero_Prototype_Demonstration.pptx
+++ b/output/submission/Route2Zero_Prototype_Demonstration.pptx
@@ -2,30 +2,30 @@
 <file path=ppt/presentation.xml><?xml version="1.0" encoding="utf-8"?>
 <p:presentation xmlns:p="http://schemas.openxmlformats.org/presentationml/2006/main">
   <p:sldMasterIdLst>
-    <p:sldMasterId xmlns:r="http://schemas.openxmlformats.org/officeDocument/2006/relationships" id="2147483648" r:id="R36ab8485138b459c"/>
+    <p:sldMasterId xmlns:r="http://schemas.openxmlformats.org/officeDocument/2006/relationships" id="2147483648" r:id="Re689df812c834c65"/>
   </p:sldMasterIdLst>
   <p:notesMasterIdLst>
-    <p:notesMasterId xmlns:r="http://schemas.openxmlformats.org/officeDocument/2006/relationships" r:id="R24ef34d457704d75"/>
+    <p:notesMasterId xmlns:r="http://schemas.openxmlformats.org/officeDocument/2006/relationships" r:id="R57c9c500a20e4e4e"/>
   </p:notesMasterIdLst>
   <p:sldIdLst>
-    <p:sldId xmlns:r="http://schemas.openxmlformats.org/officeDocument/2006/relationships" id="256" r:id="Re641e82c8c014490"/>
-    <p:sldId xmlns:r="http://schemas.openxmlformats.org/officeDocument/2006/relationships" id="257" r:id="R9b984c8f4ff341d1"/>
-    <p:sldId xmlns:r="http://schemas.openxmlformats.org/officeDocument/2006/relationships" id="258" r:id="Rdd8ef741e7d54ce3"/>
-    <p:sldId xmlns:r="http://schemas.openxmlformats.org/officeDocument/2006/relationships" id="259" r:id="R4c3418277ff849bf"/>
-    <p:sldId xmlns:r="http://schemas.openxmlformats.org/officeDocument/2006/relationships" id="260" r:id="Rc15ef68fe9d447b8"/>
-    <p:sldId xmlns:r="http://schemas.openxmlformats.org/officeDocument/2006/relationships" id="261" r:id="R5b9e8871b5ec4727"/>
-    <p:sldId xmlns:r="http://schemas.openxmlformats.org/officeDocument/2006/relationships" id="262" r:id="R43de285e52654597"/>
-    <p:sldId xmlns:r="http://schemas.openxmlformats.org/officeDocument/2006/relationships" id="263" r:id="R54a058fdaea44661"/>
-    <p:sldId xmlns:r="http://schemas.openxmlformats.org/officeDocument/2006/relationships" id="264" r:id="R83994d199f984cfa"/>
-    <p:sldId xmlns:r="http://schemas.openxmlformats.org/officeDocument/2006/relationships" id="265" r:id="Rf3cf34ede448418b"/>
-    <p:sldId xmlns:r="http://schemas.openxmlformats.org/officeDocument/2006/relationships" id="266" r:id="R89f4ef580ad943a1"/>
-    <p:sldId xmlns:r="http://schemas.openxmlformats.org/officeDocument/2006/relationships" id="267" r:id="R3f3f51854008427c"/>
-    <p:sldId xmlns:r="http://schemas.openxmlformats.org/officeDocument/2006/relationships" id="268" r:id="R356eea4b1e1b4cc1"/>
-    <p:sldId xmlns:r="http://schemas.openxmlformats.org/officeDocument/2006/relationships" id="269" r:id="R62a36649d4944fd9"/>
-    <p:sldId xmlns:r="http://schemas.openxmlformats.org/officeDocument/2006/relationships" id="270" r:id="Rcab90d9a98874728"/>
-    <p:sldId xmlns:r="http://schemas.openxmlformats.org/officeDocument/2006/relationships" id="271" r:id="Rf6912e16444d4409"/>
-    <p:sldId xmlns:r="http://schemas.openxmlformats.org/officeDocument/2006/relationships" id="272" r:id="Rb58fbed338f74361"/>
-    <p:sldId xmlns:r="http://schemas.openxmlformats.org/officeDocument/2006/relationships" id="273" r:id="Rc8237e6aec0643a9"/>
+    <p:sldId xmlns:r="http://schemas.openxmlformats.org/officeDocument/2006/relationships" id="256" r:id="Rf4dab43fb6db4fb8"/>
+    <p:sldId xmlns:r="http://schemas.openxmlformats.org/officeDocument/2006/relationships" id="257" r:id="R01b704caacdd4b0a"/>
+    <p:sldId xmlns:r="http://schemas.openxmlformats.org/officeDocument/2006/relationships" id="258" r:id="Rcbc82ad5d9c64c23"/>
+    <p:sldId xmlns:r="http://schemas.openxmlformats.org/officeDocument/2006/relationships" id="259" r:id="R1295507b2e8a4e90"/>
+    <p:sldId xmlns:r="http://schemas.openxmlformats.org/officeDocument/2006/relationships" id="260" r:id="Rc27e455919cc4129"/>
+    <p:sldId xmlns:r="http://schemas.openxmlformats.org/officeDocument/2006/relationships" id="261" r:id="R44d81ebf65274cd1"/>
+    <p:sldId xmlns:r="http://schemas.openxmlformats.org/officeDocument/2006/relationships" id="262" r:id="R16d575af63e34cc2"/>
+    <p:sldId xmlns:r="http://schemas.openxmlformats.org/officeDocument/2006/relationships" id="263" r:id="Rca1b417ea2164807"/>
+    <p:sldId xmlns:r="http://schemas.openxmlformats.org/officeDocument/2006/relationships" id="264" r:id="Reb37ea308e0842ba"/>
+    <p:sldId xmlns:r="http://schemas.openxmlformats.org/officeDocument/2006/relationships" id="265" r:id="Rbb5d7323d5c24d49"/>
+    <p:sldId xmlns:r="http://schemas.openxmlformats.org/officeDocument/2006/relationships" id="266" r:id="R52da9c02cf5e40b1"/>
+    <p:sldId xmlns:r="http://schemas.openxmlformats.org/officeDocument/2006/relationships" id="267" r:id="Rb8067d3f9e7640e8"/>
+    <p:sldId xmlns:r="http://schemas.openxmlformats.org/officeDocument/2006/relationships" id="268" r:id="Rc373777a5626486b"/>
+    <p:sldId xmlns:r="http://schemas.openxmlformats.org/officeDocument/2006/relationships" id="269" r:id="R0dbfb5a2e3fc4887"/>
+    <p:sldId xmlns:r="http://schemas.openxmlformats.org/officeDocument/2006/relationships" id="270" r:id="R1c7f9beb7b744059"/>
+    <p:sldId xmlns:r="http://schemas.openxmlformats.org/officeDocument/2006/relationships" id="271" r:id="Rcea7b755c4354801"/>
+    <p:sldId xmlns:r="http://schemas.openxmlformats.org/officeDocument/2006/relationships" id="272" r:id="R42adc46232c24106"/>
+    <p:sldId xmlns:r="http://schemas.openxmlformats.org/officeDocument/2006/relationships" id="273" r:id="R442099fd7eb04ed5"/>
   </p:sldIdLst>
   <p:sldSz cx="12192000" cy="6858000"/>
   <p:notesSz cx="6858000" cy="9144000"/>
@@ -1932,7 +1932,7 @@
   </p:cSld>
   <p:clrMap bg1="lt1" tx1="dk1" bg2="lt2" tx2="dk2" accent1="accent1" accent2="accent2" accent3="accent3" accent4="accent4" accent5="accent5" accent6="accent6" hlink="hlink" folHlink="folHlink"/>
   <p:sldLayoutIdLst>
-    <p:sldLayoutId xmlns:r="http://schemas.openxmlformats.org/officeDocument/2006/relationships" id="2147483649" r:id="R19499c82b29047c9"/>
+    <p:sldLayoutId xmlns:r="http://schemas.openxmlformats.org/officeDocument/2006/relationships" id="2147483649" r:id="Rd46a596da8c44783"/>
   </p:sldLayoutIdLst>
   <p:txStyles>
     <p:titleStyle>
@@ -2648,7 +2648,7 @@
           <p:cNvPr id="19" name="">
             <a:extLst xmlns:a="http://schemas.openxmlformats.org/drawingml/2006/main">
               <a:ext uri="{FF2B5EF4-FFF2-40B4-BE49-F238E27FC236}">
-                <a16:creationId xmlns:a16="http://schemas.microsoft.com/office/drawing/2014/main" id="{9F23883F-4AC5-432E-8B99-775247C2A5FE}"/>
+                <a16:creationId xmlns:a16="http://schemas.microsoft.com/office/drawing/2014/main" id="{4C90C812-EFCB-4E04-A53B-B9C800851F37}"/>
               </a:ext>
             </a:extLst>
           </p:cNvPr>
@@ -2710,7 +2710,7 @@
                 <a:latin typeface="Arial"/>
                 <a:ea typeface="Arial"/>
                 <a:cs typeface="Arial"/>
-                <a:hlinkClick xmlns:r="http://schemas.openxmlformats.org/officeDocument/2006/relationships" r:id="Rcf09499e94d84b8b"/>
+                <a:hlinkClick xmlns:r="http://schemas.openxmlformats.org/officeDocument/2006/relationships" r:id="R9e84c11dc8bd45be"/>
               </a:rPr>
               <a:t>https://github.com/qjmre23/Route2Zero</a:t>
             </a:r>
@@ -2733,7 +2733,7 @@
                 <a:latin typeface="Arial"/>
                 <a:ea typeface="Arial"/>
                 <a:cs typeface="Arial"/>
-                <a:hlinkClick xmlns:r="http://schemas.openxmlformats.org/officeDocument/2006/relationships" r:id="Rd4e5fb60784a466e"/>
+                <a:hlinkClick xmlns:r="http://schemas.openxmlformats.org/officeDocument/2006/relationships" r:id="R3bca2482fba14810"/>
               </a:rPr>
               <a:t>https://route2zero.netlify.app/</a:t>
             </a:r>
@@ -2749,8 +2749,8 @@
           <p:nvPr/>
         </p:nvPicPr>
         <p:blipFill>
-          <a:blip xmlns:r="http://schemas.openxmlformats.org/officeDocument/2006/relationships" xmlns:a="http://schemas.openxmlformats.org/drawingml/2006/main" r:embed="R95206e0b149c4557"/>
-          <a:srcRect xmlns:a="http://schemas.openxmlformats.org/drawingml/2006/main" l="18537" t="0" r="18537" b="0"/>
+          <a:blip xmlns:r="http://schemas.openxmlformats.org/officeDocument/2006/relationships" xmlns:a="http://schemas.openxmlformats.org/drawingml/2006/main" r:embed="R97704ece54bc4a18"/>
+          <a:srcRect xmlns:a="http://schemas.openxmlformats.org/drawingml/2006/main" l="18532" t="0" r="18532" b="0"/>
           <a:stretch xmlns:a="http://schemas.openxmlformats.org/drawingml/2006/main">
             <a:fillRect l="0" t="0" r="0" b="0"/>
           </a:stretch>
@@ -2770,7 +2770,7 @@
           <p:cNvPr id="3" name="">
             <a:extLst xmlns:a="http://schemas.openxmlformats.org/drawingml/2006/main">
               <a:ext uri="{FF2B5EF4-FFF2-40B4-BE49-F238E27FC236}">
-                <a16:creationId xmlns:a16="http://schemas.microsoft.com/office/drawing/2014/main" id="{3EBC614C-0C70-4FF4-AE31-DBEEB747F24F}"/>
+                <a16:creationId xmlns:a16="http://schemas.microsoft.com/office/drawing/2014/main" id="{7729FC7A-BA60-43C0-8DE1-7BB55C704F03}"/>
               </a:ext>
             </a:extLst>
           </p:cNvPr>
@@ -2816,7 +2816,7 @@
           <p:cNvPr id="4" name="">
             <a:extLst xmlns:a="http://schemas.openxmlformats.org/drawingml/2006/main">
               <a:ext uri="{FF2B5EF4-FFF2-40B4-BE49-F238E27FC236}">
-                <a16:creationId xmlns:a16="http://schemas.microsoft.com/office/drawing/2014/main" id="{92EB07B3-E0B3-43CE-8A32-0B3215BC7D1F}"/>
+                <a16:creationId xmlns:a16="http://schemas.microsoft.com/office/drawing/2014/main" id="{6D0094FB-2F36-477C-9843-C2D57B57E8F5}"/>
               </a:ext>
             </a:extLst>
           </p:cNvPr>
@@ -2878,7 +2878,7 @@
           <p:cNvPr id="5" name="">
             <a:extLst xmlns:a="http://schemas.openxmlformats.org/drawingml/2006/main">
               <a:ext uri="{FF2B5EF4-FFF2-40B4-BE49-F238E27FC236}">
-                <a16:creationId xmlns:a16="http://schemas.microsoft.com/office/drawing/2014/main" id="{60860869-EA95-4EAB-B500-FEE01066B576}"/>
+                <a16:creationId xmlns:a16="http://schemas.microsoft.com/office/drawing/2014/main" id="{999B4C15-87B3-4BC9-94EE-E55ECEE1F19E}"/>
               </a:ext>
             </a:extLst>
           </p:cNvPr>
@@ -2940,7 +2940,7 @@
           <p:cNvPr id="6" name="">
             <a:extLst xmlns:a="http://schemas.openxmlformats.org/drawingml/2006/main">
               <a:ext uri="{FF2B5EF4-FFF2-40B4-BE49-F238E27FC236}">
-                <a16:creationId xmlns:a16="http://schemas.microsoft.com/office/drawing/2014/main" id="{F9DDBEA7-6774-41D0-B639-22A67468BABE}"/>
+                <a16:creationId xmlns:a16="http://schemas.microsoft.com/office/drawing/2014/main" id="{12D3B2DC-C568-4BCE-9A63-9E6314C839BF}"/>
               </a:ext>
             </a:extLst>
           </p:cNvPr>
@@ -3002,7 +3002,7 @@
           <p:cNvPr id="7" name="">
             <a:extLst xmlns:a="http://schemas.openxmlformats.org/drawingml/2006/main">
               <a:ext uri="{FF2B5EF4-FFF2-40B4-BE49-F238E27FC236}">
-                <a16:creationId xmlns:a16="http://schemas.microsoft.com/office/drawing/2014/main" id="{A7180F5D-87FD-4456-A360-70CF1C8C9AC9}"/>
+                <a16:creationId xmlns:a16="http://schemas.microsoft.com/office/drawing/2014/main" id="{5B4D791C-2390-4790-A717-78B79D0C3E64}"/>
               </a:ext>
             </a:extLst>
           </p:cNvPr>
@@ -3064,7 +3064,7 @@
           <p:cNvPr id="8" name="">
             <a:extLst xmlns:a="http://schemas.openxmlformats.org/drawingml/2006/main">
               <a:ext uri="{FF2B5EF4-FFF2-40B4-BE49-F238E27FC236}">
-                <a16:creationId xmlns:a16="http://schemas.microsoft.com/office/drawing/2014/main" id="{2003A456-A145-4E39-9453-799B3140D550}"/>
+                <a16:creationId xmlns:a16="http://schemas.microsoft.com/office/drawing/2014/main" id="{ADB1D409-44A9-4E80-80EB-F92A834E0925}"/>
               </a:ext>
             </a:extLst>
           </p:cNvPr>
@@ -3116,7 +3116,7 @@
                 <a:ea typeface="Arial"/>
                 <a:cs typeface="Arial"/>
               </a:rPr>
-              <a:t>r2z-16690ccbe328</a:t>
+              <a:t>r2z-45c4ba076af9</a:t>
             </a:r>
           </a:p>
         </p:txBody>
@@ -3126,7 +3126,7 @@
           <p:cNvPr id="9" name="">
             <a:extLst xmlns:a="http://schemas.openxmlformats.org/drawingml/2006/main">
               <a:ext uri="{FF2B5EF4-FFF2-40B4-BE49-F238E27FC236}">
-                <a16:creationId xmlns:a16="http://schemas.microsoft.com/office/drawing/2014/main" id="{D69B6EE6-858B-4EB9-A1AD-71281A25C32B}"/>
+                <a16:creationId xmlns:a16="http://schemas.microsoft.com/office/drawing/2014/main" id="{56A6A426-7F6A-4A73-BE65-E60B81FD50F6}"/>
               </a:ext>
             </a:extLst>
           </p:cNvPr>
@@ -3188,7 +3188,7 @@
           <p:cNvPr id="10" name="">
             <a:extLst xmlns:a="http://schemas.openxmlformats.org/drawingml/2006/main">
               <a:ext uri="{FF2B5EF4-FFF2-40B4-BE49-F238E27FC236}">
-                <a16:creationId xmlns:a16="http://schemas.microsoft.com/office/drawing/2014/main" id="{FA532862-A587-4B3B-9460-48DC6C9D1364}"/>
+                <a16:creationId xmlns:a16="http://schemas.microsoft.com/office/drawing/2014/main" id="{CD6109DA-3061-4424-BC79-2DF98BDF8F6E}"/>
               </a:ext>
             </a:extLst>
           </p:cNvPr>
@@ -3250,7 +3250,7 @@
           <p:cNvPr id="11" name="">
             <a:extLst xmlns:a="http://schemas.openxmlformats.org/drawingml/2006/main">
               <a:ext uri="{FF2B5EF4-FFF2-40B4-BE49-F238E27FC236}">
-                <a16:creationId xmlns:a16="http://schemas.microsoft.com/office/drawing/2014/main" id="{87800BA8-906F-4411-89E9-3CA16A2829F9}"/>
+                <a16:creationId xmlns:a16="http://schemas.microsoft.com/office/drawing/2014/main" id="{681962F5-44D2-46A6-B9BD-70E325A3B801}"/>
               </a:ext>
             </a:extLst>
           </p:cNvPr>
@@ -3312,7 +3312,7 @@
           <p:cNvPr id="12" name="">
             <a:extLst xmlns:a="http://schemas.openxmlformats.org/drawingml/2006/main">
               <a:ext uri="{FF2B5EF4-FFF2-40B4-BE49-F238E27FC236}">
-                <a16:creationId xmlns:a16="http://schemas.microsoft.com/office/drawing/2014/main" id="{28A31D62-04A1-40EB-BAB3-4F4083D8F447}"/>
+                <a16:creationId xmlns:a16="http://schemas.microsoft.com/office/drawing/2014/main" id="{A0D9BED4-4132-4352-9110-86F0CE540D61}"/>
               </a:ext>
             </a:extLst>
           </p:cNvPr>
@@ -3364,7 +3364,7 @@
                 <a:ea typeface="Arial"/>
                 <a:cs typeface="Arial"/>
               </a:rPr>
-              <a:t>scn-c46e1d86c1</a:t>
+              <a:t>scn-e0f12f397e</a:t>
             </a:r>
           </a:p>
         </p:txBody>
@@ -3374,7 +3374,7 @@
           <p:cNvPr id="13" name="">
             <a:extLst xmlns:a="http://schemas.openxmlformats.org/drawingml/2006/main">
               <a:ext uri="{FF2B5EF4-FFF2-40B4-BE49-F238E27FC236}">
-                <a16:creationId xmlns:a16="http://schemas.microsoft.com/office/drawing/2014/main" id="{CA15FD46-86D2-4757-904B-C2F12F15A152}"/>
+                <a16:creationId xmlns:a16="http://schemas.microsoft.com/office/drawing/2014/main" id="{5151BF67-488D-4F72-839C-0CB7FD695CCF}"/>
               </a:ext>
             </a:extLst>
           </p:cNvPr>
@@ -3436,7 +3436,7 @@
           <p:cNvPr id="14" name="">
             <a:extLst xmlns:a="http://schemas.openxmlformats.org/drawingml/2006/main">
               <a:ext uri="{FF2B5EF4-FFF2-40B4-BE49-F238E27FC236}">
-                <a16:creationId xmlns:a16="http://schemas.microsoft.com/office/drawing/2014/main" id="{A51A1DFD-B7B2-461D-A4F8-F485F4D58151}"/>
+                <a16:creationId xmlns:a16="http://schemas.microsoft.com/office/drawing/2014/main" id="{367E2684-4B06-4C19-BAFD-8BDB71974B43}"/>
               </a:ext>
             </a:extLst>
           </p:cNvPr>
@@ -3488,7 +3488,7 @@
                 <a:ea typeface="Arial"/>
                 <a:cs typeface="Arial"/>
               </a:rPr>
-              <a:t>20 Aug 2026 · 04:47 UTC</a:t>
+              <a:t>20 Aug 2026 · 06:25 UTC</a:t>
             </a:r>
           </a:p>
         </p:txBody>
@@ -3498,7 +3498,7 @@
           <p:cNvPr id="15" name="">
             <a:extLst xmlns:a="http://schemas.openxmlformats.org/drawingml/2006/main">
               <a:ext uri="{FF2B5EF4-FFF2-40B4-BE49-F238E27FC236}">
-                <a16:creationId xmlns:a16="http://schemas.microsoft.com/office/drawing/2014/main" id="{FB4E3CB6-EC3F-4C25-A49C-DFAFF132A9CF}"/>
+                <a16:creationId xmlns:a16="http://schemas.microsoft.com/office/drawing/2014/main" id="{1C151492-436F-4335-856C-7ED837A2B489}"/>
               </a:ext>
             </a:extLst>
           </p:cNvPr>
@@ -3560,7 +3560,7 @@
           <p:cNvPr id="16" name="">
             <a:extLst xmlns:a="http://schemas.openxmlformats.org/drawingml/2006/main">
               <a:ext uri="{FF2B5EF4-FFF2-40B4-BE49-F238E27FC236}">
-                <a16:creationId xmlns:a16="http://schemas.microsoft.com/office/drawing/2014/main" id="{8E9DFD41-0B4D-4894-914B-843B70AD7E3E}"/>
+                <a16:creationId xmlns:a16="http://schemas.microsoft.com/office/drawing/2014/main" id="{42B1BF0B-5381-4ADC-94EA-944BDA584172}"/>
               </a:ext>
             </a:extLst>
           </p:cNvPr>
@@ -3591,7 +3591,7 @@
           <p:cNvPr id="17" name="">
             <a:extLst xmlns:a="http://schemas.openxmlformats.org/drawingml/2006/main">
               <a:ext uri="{FF2B5EF4-FFF2-40B4-BE49-F238E27FC236}">
-                <a16:creationId xmlns:a16="http://schemas.microsoft.com/office/drawing/2014/main" id="{F5313E8E-7DAB-4E3B-B669-5122D0521935}"/>
+                <a16:creationId xmlns:a16="http://schemas.microsoft.com/office/drawing/2014/main" id="{E7A448C1-264A-46A0-85E2-993ED6E59181}"/>
               </a:ext>
             </a:extLst>
           </p:cNvPr>
@@ -3643,7 +3643,7 @@
                 <a:ea typeface="Arial"/>
                 <a:cs typeface="Arial"/>
               </a:rPr>
-              <a:t>r2z-16690ccbe328 · scn-c46e1d86c1</a:t>
+              <a:t>r2z-45c4ba076af9 · scn-e0f12f397e</a:t>
             </a:r>
           </a:p>
         </p:txBody>
@@ -3653,7 +3653,7 @@
           <p:cNvPr id="18" name="">
             <a:extLst xmlns:a="http://schemas.openxmlformats.org/drawingml/2006/main">
               <a:ext uri="{FF2B5EF4-FFF2-40B4-BE49-F238E27FC236}">
-                <a16:creationId xmlns:a16="http://schemas.microsoft.com/office/drawing/2014/main" id="{9DAAAEDA-9EA9-4CED-A63B-CF47EBD1330E}"/>
+                <a16:creationId xmlns:a16="http://schemas.microsoft.com/office/drawing/2014/main" id="{75BB1448-AB44-4FB8-9D96-2FCBEF7CBF4B}"/>
               </a:ext>
             </a:extLst>
           </p:cNvPr>
@@ -3713,7 +3713,7 @@
     </p:spTree>
     <p:extLst>
       <p:ext uri="{BB962C8B-B14F-4D97-AF65-F5344CB8AC3E}">
-        <p14:creationId xmlns:p14="http://schemas.microsoft.com/office/powerpoint/2010/main" val="1642998172"/>
+        <p14:creationId xmlns:p14="http://schemas.microsoft.com/office/powerpoint/2010/main" val="813090047"/>
       </p:ext>
     </p:extLst>
   </p:cSld>
@@ -3744,7 +3744,7 @@
           <p:cNvPr id="21" name="">
             <a:extLst xmlns:a="http://schemas.openxmlformats.org/drawingml/2006/main">
               <a:ext uri="{FF2B5EF4-FFF2-40B4-BE49-F238E27FC236}">
-                <a16:creationId xmlns:a16="http://schemas.microsoft.com/office/drawing/2014/main" id="{C2B6827E-6380-4741-9F7C-640FCE8C6C9A}"/>
+                <a16:creationId xmlns:a16="http://schemas.microsoft.com/office/drawing/2014/main" id="{DE0BAA39-415A-4FAE-A99D-E7FF82D411C0}"/>
               </a:ext>
             </a:extLst>
           </p:cNvPr>
@@ -3806,7 +3806,7 @@
                 <a:latin typeface="Arial"/>
                 <a:ea typeface="Arial"/>
                 <a:cs typeface="Arial"/>
-                <a:hlinkClick xmlns:r="http://schemas.openxmlformats.org/officeDocument/2006/relationships" r:id="Rfe464da8f1df41b3"/>
+                <a:hlinkClick xmlns:r="http://schemas.openxmlformats.org/officeDocument/2006/relationships" r:id="R7311fda201124ed0"/>
               </a:rPr>
               <a:t>https://github.com/qjmre23/Route2Zero</a:t>
             </a:r>
@@ -3829,7 +3829,7 @@
                 <a:latin typeface="Arial"/>
                 <a:ea typeface="Arial"/>
                 <a:cs typeface="Arial"/>
-                <a:hlinkClick xmlns:r="http://schemas.openxmlformats.org/officeDocument/2006/relationships" r:id="R1db0b77002804282"/>
+                <a:hlinkClick xmlns:r="http://schemas.openxmlformats.org/officeDocument/2006/relationships" r:id="R4dd5b8eec56a49f7"/>
               </a:rPr>
               <a:t>https://route2zero.netlify.app/</a:t>
             </a:r>
@@ -3841,7 +3841,7 @@
           <p:cNvPr id="2" name="">
             <a:extLst xmlns:a="http://schemas.openxmlformats.org/drawingml/2006/main">
               <a:ext uri="{FF2B5EF4-FFF2-40B4-BE49-F238E27FC236}">
-                <a16:creationId xmlns:a16="http://schemas.microsoft.com/office/drawing/2014/main" id="{9BD6BBBC-BAE8-491C-A6F1-CBF4DAA80A32}"/>
+                <a16:creationId xmlns:a16="http://schemas.microsoft.com/office/drawing/2014/main" id="{B2A54CE1-B8AF-4B8D-8C50-097D7BD3B451}"/>
               </a:ext>
             </a:extLst>
           </p:cNvPr>
@@ -3903,7 +3903,7 @@
           <p:cNvPr id="3" name="">
             <a:extLst xmlns:a="http://schemas.openxmlformats.org/drawingml/2006/main">
               <a:ext uri="{FF2B5EF4-FFF2-40B4-BE49-F238E27FC236}">
-                <a16:creationId xmlns:a16="http://schemas.microsoft.com/office/drawing/2014/main" id="{0089038C-499A-4198-A1A9-50F276F375F5}"/>
+                <a16:creationId xmlns:a16="http://schemas.microsoft.com/office/drawing/2014/main" id="{0EFA1DAF-2197-48A3-B6F1-981C4C9BC459}"/>
               </a:ext>
             </a:extLst>
           </p:cNvPr>
@@ -3969,8 +3969,8 @@
           <p:nvPr/>
         </p:nvPicPr>
         <p:blipFill>
-          <a:blip xmlns:r="http://schemas.openxmlformats.org/officeDocument/2006/relationships" xmlns:a="http://schemas.openxmlformats.org/drawingml/2006/main" r:embed="R4ad6e46d2c684696"/>
-          <a:srcRect xmlns:a="http://schemas.openxmlformats.org/drawingml/2006/main" l="0" t="15675" r="0" b="15675"/>
+          <a:blip xmlns:r="http://schemas.openxmlformats.org/officeDocument/2006/relationships" xmlns:a="http://schemas.openxmlformats.org/drawingml/2006/main" r:embed="Rbd726a4f1c4c4cc7"/>
+          <a:srcRect xmlns:a="http://schemas.openxmlformats.org/drawingml/2006/main" l="0" t="15682" r="0" b="15682"/>
           <a:stretch xmlns:a="http://schemas.openxmlformats.org/drawingml/2006/main">
             <a:fillRect l="0" t="0" r="0" b="0"/>
           </a:stretch>
@@ -3992,7 +3992,7 @@
           <p:cNvPr id="5" name="">
             <a:extLst xmlns:a="http://schemas.openxmlformats.org/drawingml/2006/main">
               <a:ext uri="{FF2B5EF4-FFF2-40B4-BE49-F238E27FC236}">
-                <a16:creationId xmlns:a16="http://schemas.microsoft.com/office/drawing/2014/main" id="{6B4B85E7-199F-4887-B2B0-EEDC74529224}"/>
+                <a16:creationId xmlns:a16="http://schemas.microsoft.com/office/drawing/2014/main" id="{55762E46-0A2A-47EE-8FB2-D4159477738E}"/>
               </a:ext>
             </a:extLst>
           </p:cNvPr>
@@ -4025,7 +4025,7 @@
           <p:cNvPr id="6" name="">
             <a:extLst xmlns:a="http://schemas.openxmlformats.org/drawingml/2006/main">
               <a:ext uri="{FF2B5EF4-FFF2-40B4-BE49-F238E27FC236}">
-                <a16:creationId xmlns:a16="http://schemas.microsoft.com/office/drawing/2014/main" id="{6BCC3AA8-88E6-471F-9311-E09C3862DFE8}"/>
+                <a16:creationId xmlns:a16="http://schemas.microsoft.com/office/drawing/2014/main" id="{49E9E90E-F15C-4479-BE99-B776DBD26F3A}"/>
               </a:ext>
             </a:extLst>
           </p:cNvPr>
@@ -4056,7 +4056,7 @@
           <p:cNvPr id="7" name="">
             <a:extLst xmlns:a="http://schemas.openxmlformats.org/drawingml/2006/main">
               <a:ext uri="{FF2B5EF4-FFF2-40B4-BE49-F238E27FC236}">
-                <a16:creationId xmlns:a16="http://schemas.microsoft.com/office/drawing/2014/main" id="{5679B660-1FAD-45B0-9CF1-47F47BA26A84}"/>
+                <a16:creationId xmlns:a16="http://schemas.microsoft.com/office/drawing/2014/main" id="{8D682BC8-F44B-4C63-A7A8-0606C77ACB9E}"/>
               </a:ext>
             </a:extLst>
           </p:cNvPr>
@@ -4118,7 +4118,7 @@
           <p:cNvPr id="8" name="">
             <a:extLst xmlns:a="http://schemas.openxmlformats.org/drawingml/2006/main">
               <a:ext uri="{FF2B5EF4-FFF2-40B4-BE49-F238E27FC236}">
-                <a16:creationId xmlns:a16="http://schemas.microsoft.com/office/drawing/2014/main" id="{534679FC-00C2-4877-B8AA-2CE44140EE7E}"/>
+                <a16:creationId xmlns:a16="http://schemas.microsoft.com/office/drawing/2014/main" id="{E7DE9D35-6F94-4D0D-9F98-2D5E80E2ACB8}"/>
               </a:ext>
             </a:extLst>
           </p:cNvPr>
@@ -4153,7 +4153,7 @@
           <p:cNvPr id="9" name="">
             <a:extLst xmlns:a="http://schemas.openxmlformats.org/drawingml/2006/main">
               <a:ext uri="{FF2B5EF4-FFF2-40B4-BE49-F238E27FC236}">
-                <a16:creationId xmlns:a16="http://schemas.microsoft.com/office/drawing/2014/main" id="{49434D79-D802-4737-9663-2A698C0122A0}"/>
+                <a16:creationId xmlns:a16="http://schemas.microsoft.com/office/drawing/2014/main" id="{B8CD98C9-5CC0-487C-92E5-B7E93DDFEE5A}"/>
               </a:ext>
             </a:extLst>
           </p:cNvPr>
@@ -4215,7 +4215,7 @@
           <p:cNvPr id="10" name="">
             <a:extLst xmlns:a="http://schemas.openxmlformats.org/drawingml/2006/main">
               <a:ext uri="{FF2B5EF4-FFF2-40B4-BE49-F238E27FC236}">
-                <a16:creationId xmlns:a16="http://schemas.microsoft.com/office/drawing/2014/main" id="{3A944461-4D9A-41A9-9A41-3B8CD0B69DD3}"/>
+                <a16:creationId xmlns:a16="http://schemas.microsoft.com/office/drawing/2014/main" id="{AB17C3CC-389A-4C96-AEA5-6FF3A7ACF210}"/>
               </a:ext>
             </a:extLst>
           </p:cNvPr>
@@ -4246,7 +4246,7 @@
           <p:cNvPr id="11" name="">
             <a:extLst xmlns:a="http://schemas.openxmlformats.org/drawingml/2006/main">
               <a:ext uri="{FF2B5EF4-FFF2-40B4-BE49-F238E27FC236}">
-                <a16:creationId xmlns:a16="http://schemas.microsoft.com/office/drawing/2014/main" id="{A74A97CD-8CD7-4475-B23A-478A5765284A}"/>
+                <a16:creationId xmlns:a16="http://schemas.microsoft.com/office/drawing/2014/main" id="{11A31755-2B43-445C-9CDE-7F4746FC05CF}"/>
               </a:ext>
             </a:extLst>
           </p:cNvPr>
@@ -4308,7 +4308,7 @@
           <p:cNvPr id="12" name="">
             <a:extLst xmlns:a="http://schemas.openxmlformats.org/drawingml/2006/main">
               <a:ext uri="{FF2B5EF4-FFF2-40B4-BE49-F238E27FC236}">
-                <a16:creationId xmlns:a16="http://schemas.microsoft.com/office/drawing/2014/main" id="{9A6B8DA3-B238-4658-BC5F-6361F089E7F9}"/>
+                <a16:creationId xmlns:a16="http://schemas.microsoft.com/office/drawing/2014/main" id="{8DEF8F15-3348-4D14-A0A8-0A2E2A574F8A}"/>
               </a:ext>
             </a:extLst>
           </p:cNvPr>
@@ -4343,7 +4343,7 @@
           <p:cNvPr id="13" name="">
             <a:extLst xmlns:a="http://schemas.openxmlformats.org/drawingml/2006/main">
               <a:ext uri="{FF2B5EF4-FFF2-40B4-BE49-F238E27FC236}">
-                <a16:creationId xmlns:a16="http://schemas.microsoft.com/office/drawing/2014/main" id="{94BB4806-6ADD-48EE-9E62-94668BAAB67A}"/>
+                <a16:creationId xmlns:a16="http://schemas.microsoft.com/office/drawing/2014/main" id="{8DC402DC-195A-474E-9609-309B0FB85FEF}"/>
               </a:ext>
             </a:extLst>
           </p:cNvPr>
@@ -4405,7 +4405,7 @@
           <p:cNvPr id="14" name="">
             <a:extLst xmlns:a="http://schemas.openxmlformats.org/drawingml/2006/main">
               <a:ext uri="{FF2B5EF4-FFF2-40B4-BE49-F238E27FC236}">
-                <a16:creationId xmlns:a16="http://schemas.microsoft.com/office/drawing/2014/main" id="{C56B3640-F920-4363-888A-122A8A3985EC}"/>
+                <a16:creationId xmlns:a16="http://schemas.microsoft.com/office/drawing/2014/main" id="{60C2DFCE-7BDF-40EC-BACF-EC5477F08E34}"/>
               </a:ext>
             </a:extLst>
           </p:cNvPr>
@@ -4436,7 +4436,7 @@
           <p:cNvPr id="15" name="">
             <a:extLst xmlns:a="http://schemas.openxmlformats.org/drawingml/2006/main">
               <a:ext uri="{FF2B5EF4-FFF2-40B4-BE49-F238E27FC236}">
-                <a16:creationId xmlns:a16="http://schemas.microsoft.com/office/drawing/2014/main" id="{C888128F-44BF-4847-B089-D9793A4398FE}"/>
+                <a16:creationId xmlns:a16="http://schemas.microsoft.com/office/drawing/2014/main" id="{92DCC326-9F3A-49BA-B0DA-149C330FC72B}"/>
               </a:ext>
             </a:extLst>
           </p:cNvPr>
@@ -4498,7 +4498,7 @@
           <p:cNvPr id="16" name="">
             <a:extLst xmlns:a="http://schemas.openxmlformats.org/drawingml/2006/main">
               <a:ext uri="{FF2B5EF4-FFF2-40B4-BE49-F238E27FC236}">
-                <a16:creationId xmlns:a16="http://schemas.microsoft.com/office/drawing/2014/main" id="{F2BDCA56-80A5-43F2-A935-D25DFBFA9413}"/>
+                <a16:creationId xmlns:a16="http://schemas.microsoft.com/office/drawing/2014/main" id="{ADF3F49E-812E-4BA3-92AF-13C37C227699}"/>
               </a:ext>
             </a:extLst>
           </p:cNvPr>
@@ -4533,7 +4533,7 @@
           <p:cNvPr id="17" name="">
             <a:extLst xmlns:a="http://schemas.openxmlformats.org/drawingml/2006/main">
               <a:ext uri="{FF2B5EF4-FFF2-40B4-BE49-F238E27FC236}">
-                <a16:creationId xmlns:a16="http://schemas.microsoft.com/office/drawing/2014/main" id="{70346365-D51B-4459-BCA3-A84E5767F534}"/>
+                <a16:creationId xmlns:a16="http://schemas.microsoft.com/office/drawing/2014/main" id="{28B997F8-8C54-4719-888A-BCD09DBE3227}"/>
               </a:ext>
             </a:extLst>
           </p:cNvPr>
@@ -4595,7 +4595,7 @@
           <p:cNvPr id="18" name="">
             <a:extLst xmlns:a="http://schemas.openxmlformats.org/drawingml/2006/main">
               <a:ext uri="{FF2B5EF4-FFF2-40B4-BE49-F238E27FC236}">
-                <a16:creationId xmlns:a16="http://schemas.microsoft.com/office/drawing/2014/main" id="{F0DC5299-43F7-45FE-A023-8A2F9C562413}"/>
+                <a16:creationId xmlns:a16="http://schemas.microsoft.com/office/drawing/2014/main" id="{639F9329-E432-4241-A79B-ACCB211AC799}"/>
               </a:ext>
             </a:extLst>
           </p:cNvPr>
@@ -4626,7 +4626,7 @@
           <p:cNvPr id="19" name="">
             <a:extLst xmlns:a="http://schemas.openxmlformats.org/drawingml/2006/main">
               <a:ext uri="{FF2B5EF4-FFF2-40B4-BE49-F238E27FC236}">
-                <a16:creationId xmlns:a16="http://schemas.microsoft.com/office/drawing/2014/main" id="{4B75957B-E8FD-496C-865A-FBD88A526205}"/>
+                <a16:creationId xmlns:a16="http://schemas.microsoft.com/office/drawing/2014/main" id="{0D06B269-B8D2-41EB-AD1D-08B27C277AB5}"/>
               </a:ext>
             </a:extLst>
           </p:cNvPr>
@@ -4678,7 +4678,7 @@
                 <a:ea typeface="Arial"/>
                 <a:cs typeface="Arial"/>
               </a:rPr>
-              <a:t>r2z-16690ccbe328 · scn-c46e1d86c1</a:t>
+              <a:t>r2z-45c4ba076af9 · scn-e0f12f397e</a:t>
             </a:r>
           </a:p>
         </p:txBody>
@@ -4688,7 +4688,7 @@
           <p:cNvPr id="20" name="">
             <a:extLst xmlns:a="http://schemas.openxmlformats.org/drawingml/2006/main">
               <a:ext uri="{FF2B5EF4-FFF2-40B4-BE49-F238E27FC236}">
-                <a16:creationId xmlns:a16="http://schemas.microsoft.com/office/drawing/2014/main" id="{A4B0D627-E6DA-418E-93DC-FE5D62563156}"/>
+                <a16:creationId xmlns:a16="http://schemas.microsoft.com/office/drawing/2014/main" id="{DD520A43-9A8D-487F-B89F-8B57F63BBF79}"/>
               </a:ext>
             </a:extLst>
           </p:cNvPr>
@@ -4748,7 +4748,7 @@
     </p:spTree>
     <p:extLst>
       <p:ext uri="{BB962C8B-B14F-4D97-AF65-F5344CB8AC3E}">
-        <p14:creationId xmlns:p14="http://schemas.microsoft.com/office/powerpoint/2010/main" val="1714620260"/>
+        <p14:creationId xmlns:p14="http://schemas.microsoft.com/office/powerpoint/2010/main" val="308826420"/>
       </p:ext>
     </p:extLst>
   </p:cSld>
@@ -4779,7 +4779,7 @@
           <p:cNvPr id="21" name="">
             <a:extLst xmlns:a="http://schemas.openxmlformats.org/drawingml/2006/main">
               <a:ext uri="{FF2B5EF4-FFF2-40B4-BE49-F238E27FC236}">
-                <a16:creationId xmlns:a16="http://schemas.microsoft.com/office/drawing/2014/main" id="{7C7EB873-D791-4027-A100-5E497DFB1441}"/>
+                <a16:creationId xmlns:a16="http://schemas.microsoft.com/office/drawing/2014/main" id="{11117A0F-B540-49B2-93D2-59A9B4166132}"/>
               </a:ext>
             </a:extLst>
           </p:cNvPr>
@@ -4841,7 +4841,7 @@
                 <a:latin typeface="Arial"/>
                 <a:ea typeface="Arial"/>
                 <a:cs typeface="Arial"/>
-                <a:hlinkClick xmlns:r="http://schemas.openxmlformats.org/officeDocument/2006/relationships" r:id="R4a581852f99a4137"/>
+                <a:hlinkClick xmlns:r="http://schemas.openxmlformats.org/officeDocument/2006/relationships" r:id="Rc5082f7f8e484e55"/>
               </a:rPr>
               <a:t>https://github.com/qjmre23/Route2Zero</a:t>
             </a:r>
@@ -4864,7 +4864,7 @@
                 <a:latin typeface="Arial"/>
                 <a:ea typeface="Arial"/>
                 <a:cs typeface="Arial"/>
-                <a:hlinkClick xmlns:r="http://schemas.openxmlformats.org/officeDocument/2006/relationships" r:id="R887d1f5b08684272"/>
+                <a:hlinkClick xmlns:r="http://schemas.openxmlformats.org/officeDocument/2006/relationships" r:id="R72641b94238d4f02"/>
               </a:rPr>
               <a:t>https://route2zero.netlify.app/</a:t>
             </a:r>
@@ -4876,7 +4876,7 @@
           <p:cNvPr id="2" name="">
             <a:extLst xmlns:a="http://schemas.openxmlformats.org/drawingml/2006/main">
               <a:ext uri="{FF2B5EF4-FFF2-40B4-BE49-F238E27FC236}">
-                <a16:creationId xmlns:a16="http://schemas.microsoft.com/office/drawing/2014/main" id="{C6A0AFD3-FF46-4501-8C11-3EE1FFA2DD42}"/>
+                <a16:creationId xmlns:a16="http://schemas.microsoft.com/office/drawing/2014/main" id="{8824FC71-68AF-45C5-8E13-5D8AF036B30B}"/>
               </a:ext>
             </a:extLst>
           </p:cNvPr>
@@ -4938,7 +4938,7 @@
           <p:cNvPr id="3" name="">
             <a:extLst xmlns:a="http://schemas.openxmlformats.org/drawingml/2006/main">
               <a:ext uri="{FF2B5EF4-FFF2-40B4-BE49-F238E27FC236}">
-                <a16:creationId xmlns:a16="http://schemas.microsoft.com/office/drawing/2014/main" id="{C7EA6E6B-0E4D-4332-A34D-4A95A3E658DF}"/>
+                <a16:creationId xmlns:a16="http://schemas.microsoft.com/office/drawing/2014/main" id="{135A5A10-7374-466E-A85C-AACBD57C3C3F}"/>
               </a:ext>
             </a:extLst>
           </p:cNvPr>
@@ -5004,8 +5004,8 @@
           <p:nvPr/>
         </p:nvPicPr>
         <p:blipFill>
-          <a:blip xmlns:r="http://schemas.openxmlformats.org/officeDocument/2006/relationships" xmlns:a="http://schemas.openxmlformats.org/drawingml/2006/main" r:embed="Rdcdaa1cfb3634156"/>
-          <a:srcRect xmlns:a="http://schemas.openxmlformats.org/drawingml/2006/main" l="0" t="15675" r="0" b="15675"/>
+          <a:blip xmlns:r="http://schemas.openxmlformats.org/officeDocument/2006/relationships" xmlns:a="http://schemas.openxmlformats.org/drawingml/2006/main" r:embed="R96d2c32fc80f47c3"/>
+          <a:srcRect xmlns:a="http://schemas.openxmlformats.org/drawingml/2006/main" l="0" t="15682" r="0" b="15682"/>
           <a:stretch xmlns:a="http://schemas.openxmlformats.org/drawingml/2006/main">
             <a:fillRect l="0" t="0" r="0" b="0"/>
           </a:stretch>
@@ -5027,7 +5027,7 @@
           <p:cNvPr id="5" name="">
             <a:extLst xmlns:a="http://schemas.openxmlformats.org/drawingml/2006/main">
               <a:ext uri="{FF2B5EF4-FFF2-40B4-BE49-F238E27FC236}">
-                <a16:creationId xmlns:a16="http://schemas.microsoft.com/office/drawing/2014/main" id="{9646A598-9F51-476B-981F-2CFA68B81ADF}"/>
+                <a16:creationId xmlns:a16="http://schemas.microsoft.com/office/drawing/2014/main" id="{0D80D135-C8CB-463D-AF87-3BDCFBA32848}"/>
               </a:ext>
             </a:extLst>
           </p:cNvPr>
@@ -5060,7 +5060,7 @@
           <p:cNvPr id="6" name="">
             <a:extLst xmlns:a="http://schemas.openxmlformats.org/drawingml/2006/main">
               <a:ext uri="{FF2B5EF4-FFF2-40B4-BE49-F238E27FC236}">
-                <a16:creationId xmlns:a16="http://schemas.microsoft.com/office/drawing/2014/main" id="{2C18A7F1-C91A-4154-BC45-7265B7497372}"/>
+                <a16:creationId xmlns:a16="http://schemas.microsoft.com/office/drawing/2014/main" id="{8BB529B8-1C54-4F7E-B209-7D6AEBD3F154}"/>
               </a:ext>
             </a:extLst>
           </p:cNvPr>
@@ -5091,7 +5091,7 @@
           <p:cNvPr id="7" name="">
             <a:extLst xmlns:a="http://schemas.openxmlformats.org/drawingml/2006/main">
               <a:ext uri="{FF2B5EF4-FFF2-40B4-BE49-F238E27FC236}">
-                <a16:creationId xmlns:a16="http://schemas.microsoft.com/office/drawing/2014/main" id="{8F61D3AD-CFCF-410E-8A8C-C4EAA2222A79}"/>
+                <a16:creationId xmlns:a16="http://schemas.microsoft.com/office/drawing/2014/main" id="{AE7AF0DB-099D-4F06-B019-DFB4D28570A5}"/>
               </a:ext>
             </a:extLst>
           </p:cNvPr>
@@ -5153,7 +5153,7 @@
           <p:cNvPr id="8" name="">
             <a:extLst xmlns:a="http://schemas.openxmlformats.org/drawingml/2006/main">
               <a:ext uri="{FF2B5EF4-FFF2-40B4-BE49-F238E27FC236}">
-                <a16:creationId xmlns:a16="http://schemas.microsoft.com/office/drawing/2014/main" id="{C773003B-FBC9-4489-B16F-960552475908}"/>
+                <a16:creationId xmlns:a16="http://schemas.microsoft.com/office/drawing/2014/main" id="{90CC2244-8B02-409E-BF38-CFA1E2A8A378}"/>
               </a:ext>
             </a:extLst>
           </p:cNvPr>
@@ -5188,7 +5188,7 @@
           <p:cNvPr id="9" name="">
             <a:extLst xmlns:a="http://schemas.openxmlformats.org/drawingml/2006/main">
               <a:ext uri="{FF2B5EF4-FFF2-40B4-BE49-F238E27FC236}">
-                <a16:creationId xmlns:a16="http://schemas.microsoft.com/office/drawing/2014/main" id="{975FFFF8-9FE3-4839-8999-9238A5988EFB}"/>
+                <a16:creationId xmlns:a16="http://schemas.microsoft.com/office/drawing/2014/main" id="{77E7BF88-5023-4348-B367-C2E3877710D7}"/>
               </a:ext>
             </a:extLst>
           </p:cNvPr>
@@ -5240,7 +5240,7 @@
                 <a:ea typeface="Arial"/>
                 <a:cs typeface="Arial"/>
               </a:rPr>
-              <a:t>Priority 79.97</a:t>
+              <a:t>Priority 79.07</a:t>
             </a:r>
           </a:p>
         </p:txBody>
@@ -5250,7 +5250,7 @@
           <p:cNvPr id="10" name="">
             <a:extLst xmlns:a="http://schemas.openxmlformats.org/drawingml/2006/main">
               <a:ext uri="{FF2B5EF4-FFF2-40B4-BE49-F238E27FC236}">
-                <a16:creationId xmlns:a16="http://schemas.microsoft.com/office/drawing/2014/main" id="{D332B097-4BAF-4D97-84E2-EDCC8A49EB33}"/>
+                <a16:creationId xmlns:a16="http://schemas.microsoft.com/office/drawing/2014/main" id="{18C59F92-C1A6-4C16-8FE4-D0B89279C401}"/>
               </a:ext>
             </a:extLst>
           </p:cNvPr>
@@ -5281,7 +5281,7 @@
           <p:cNvPr id="11" name="">
             <a:extLst xmlns:a="http://schemas.openxmlformats.org/drawingml/2006/main">
               <a:ext uri="{FF2B5EF4-FFF2-40B4-BE49-F238E27FC236}">
-                <a16:creationId xmlns:a16="http://schemas.microsoft.com/office/drawing/2014/main" id="{692F3447-142B-4A6F-BAAD-885C31BC11DA}"/>
+                <a16:creationId xmlns:a16="http://schemas.microsoft.com/office/drawing/2014/main" id="{F55E09FC-75D6-4895-9D52-381E56425558}"/>
               </a:ext>
             </a:extLst>
           </p:cNvPr>
@@ -5343,7 +5343,7 @@
           <p:cNvPr id="12" name="">
             <a:extLst xmlns:a="http://schemas.openxmlformats.org/drawingml/2006/main">
               <a:ext uri="{FF2B5EF4-FFF2-40B4-BE49-F238E27FC236}">
-                <a16:creationId xmlns:a16="http://schemas.microsoft.com/office/drawing/2014/main" id="{6B68C770-EA33-4CB6-8218-58EC2EE96BF7}"/>
+                <a16:creationId xmlns:a16="http://schemas.microsoft.com/office/drawing/2014/main" id="{6C25E8E6-5B68-4D1D-95DE-7FC7824DA148}"/>
               </a:ext>
             </a:extLst>
           </p:cNvPr>
@@ -5378,7 +5378,7 @@
           <p:cNvPr id="13" name="">
             <a:extLst xmlns:a="http://schemas.openxmlformats.org/drawingml/2006/main">
               <a:ext uri="{FF2B5EF4-FFF2-40B4-BE49-F238E27FC236}">
-                <a16:creationId xmlns:a16="http://schemas.microsoft.com/office/drawing/2014/main" id="{FBE9BDC5-FFDD-413F-B1EC-01BE42A0F01A}"/>
+                <a16:creationId xmlns:a16="http://schemas.microsoft.com/office/drawing/2014/main" id="{3B37D4E6-9BF4-4ED5-8666-79C6A0488FE9}"/>
               </a:ext>
             </a:extLst>
           </p:cNvPr>
@@ -5440,7 +5440,7 @@
           <p:cNvPr id="14" name="">
             <a:extLst xmlns:a="http://schemas.openxmlformats.org/drawingml/2006/main">
               <a:ext uri="{FF2B5EF4-FFF2-40B4-BE49-F238E27FC236}">
-                <a16:creationId xmlns:a16="http://schemas.microsoft.com/office/drawing/2014/main" id="{FE7E8CD2-B785-42EA-B92F-F4C904659734}"/>
+                <a16:creationId xmlns:a16="http://schemas.microsoft.com/office/drawing/2014/main" id="{229A1CAD-90CD-4D44-B990-6AABE49409A9}"/>
               </a:ext>
             </a:extLst>
           </p:cNvPr>
@@ -5471,7 +5471,7 @@
           <p:cNvPr id="15" name="">
             <a:extLst xmlns:a="http://schemas.openxmlformats.org/drawingml/2006/main">
               <a:ext uri="{FF2B5EF4-FFF2-40B4-BE49-F238E27FC236}">
-                <a16:creationId xmlns:a16="http://schemas.microsoft.com/office/drawing/2014/main" id="{170F99DA-165B-4BEF-851C-CA6A5E8E02FE}"/>
+                <a16:creationId xmlns:a16="http://schemas.microsoft.com/office/drawing/2014/main" id="{35480E14-BAB9-46EC-88F0-004594528BFB}"/>
               </a:ext>
             </a:extLst>
           </p:cNvPr>
@@ -5533,7 +5533,7 @@
           <p:cNvPr id="16" name="">
             <a:extLst xmlns:a="http://schemas.openxmlformats.org/drawingml/2006/main">
               <a:ext uri="{FF2B5EF4-FFF2-40B4-BE49-F238E27FC236}">
-                <a16:creationId xmlns:a16="http://schemas.microsoft.com/office/drawing/2014/main" id="{A0ED0D9A-EE43-454A-8EC1-A535B0225C0C}"/>
+                <a16:creationId xmlns:a16="http://schemas.microsoft.com/office/drawing/2014/main" id="{54F00CCC-BEEF-4405-8F31-D9EF869A8683}"/>
               </a:ext>
             </a:extLst>
           </p:cNvPr>
@@ -5568,7 +5568,7 @@
           <p:cNvPr id="17" name="">
             <a:extLst xmlns:a="http://schemas.openxmlformats.org/drawingml/2006/main">
               <a:ext uri="{FF2B5EF4-FFF2-40B4-BE49-F238E27FC236}">
-                <a16:creationId xmlns:a16="http://schemas.microsoft.com/office/drawing/2014/main" id="{6A6FC43A-7526-4CD1-AF35-7B96998FC8F3}"/>
+                <a16:creationId xmlns:a16="http://schemas.microsoft.com/office/drawing/2014/main" id="{0A13BE8C-8B4F-41AA-8A02-ABC3FE378BFA}"/>
               </a:ext>
             </a:extLst>
           </p:cNvPr>
@@ -5630,7 +5630,7 @@
           <p:cNvPr id="18" name="">
             <a:extLst xmlns:a="http://schemas.openxmlformats.org/drawingml/2006/main">
               <a:ext uri="{FF2B5EF4-FFF2-40B4-BE49-F238E27FC236}">
-                <a16:creationId xmlns:a16="http://schemas.microsoft.com/office/drawing/2014/main" id="{12276A88-D105-48F1-8D4D-18E33EE510E6}"/>
+                <a16:creationId xmlns:a16="http://schemas.microsoft.com/office/drawing/2014/main" id="{838FF171-6C0D-466B-9478-3024A03FCA12}"/>
               </a:ext>
             </a:extLst>
           </p:cNvPr>
@@ -5661,7 +5661,7 @@
           <p:cNvPr id="19" name="">
             <a:extLst xmlns:a="http://schemas.openxmlformats.org/drawingml/2006/main">
               <a:ext uri="{FF2B5EF4-FFF2-40B4-BE49-F238E27FC236}">
-                <a16:creationId xmlns:a16="http://schemas.microsoft.com/office/drawing/2014/main" id="{AA40FA38-0EFE-48AB-8015-2CDA9727EF29}"/>
+                <a16:creationId xmlns:a16="http://schemas.microsoft.com/office/drawing/2014/main" id="{6CA21A42-353F-435A-A8E5-877CF821B3CC}"/>
               </a:ext>
             </a:extLst>
           </p:cNvPr>
@@ -5713,7 +5713,7 @@
                 <a:ea typeface="Arial"/>
                 <a:cs typeface="Arial"/>
               </a:rPr>
-              <a:t>r2z-16690ccbe328 · scn-c46e1d86c1</a:t>
+              <a:t>r2z-45c4ba076af9 · scn-e0f12f397e</a:t>
             </a:r>
           </a:p>
         </p:txBody>
@@ -5723,7 +5723,7 @@
           <p:cNvPr id="20" name="">
             <a:extLst xmlns:a="http://schemas.openxmlformats.org/drawingml/2006/main">
               <a:ext uri="{FF2B5EF4-FFF2-40B4-BE49-F238E27FC236}">
-                <a16:creationId xmlns:a16="http://schemas.microsoft.com/office/drawing/2014/main" id="{5F4732ED-3E67-4E66-AB4D-5A16C52CA032}"/>
+                <a16:creationId xmlns:a16="http://schemas.microsoft.com/office/drawing/2014/main" id="{E98F41DA-7C05-4130-ABB1-A70A1BDC25C6}"/>
               </a:ext>
             </a:extLst>
           </p:cNvPr>
@@ -5783,7 +5783,7 @@
     </p:spTree>
     <p:extLst>
       <p:ext uri="{BB962C8B-B14F-4D97-AF65-F5344CB8AC3E}">
-        <p14:creationId xmlns:p14="http://schemas.microsoft.com/office/powerpoint/2010/main" val="2133848528"/>
+        <p14:creationId xmlns:p14="http://schemas.microsoft.com/office/powerpoint/2010/main" val="805001017"/>
       </p:ext>
     </p:extLst>
   </p:cSld>
@@ -5814,7 +5814,7 @@
           <p:cNvPr id="23" name="">
             <a:extLst xmlns:a="http://schemas.openxmlformats.org/drawingml/2006/main">
               <a:ext uri="{FF2B5EF4-FFF2-40B4-BE49-F238E27FC236}">
-                <a16:creationId xmlns:a16="http://schemas.microsoft.com/office/drawing/2014/main" id="{4D5A629A-F09B-4380-95EE-011EEDA0F215}"/>
+                <a16:creationId xmlns:a16="http://schemas.microsoft.com/office/drawing/2014/main" id="{14EEC3A9-36D6-4526-8CBC-C307C0371AE3}"/>
               </a:ext>
             </a:extLst>
           </p:cNvPr>
@@ -5876,7 +5876,7 @@
                 <a:latin typeface="Arial"/>
                 <a:ea typeface="Arial"/>
                 <a:cs typeface="Arial"/>
-                <a:hlinkClick xmlns:r="http://schemas.openxmlformats.org/officeDocument/2006/relationships" r:id="Ra1bbc2b11912423e"/>
+                <a:hlinkClick xmlns:r="http://schemas.openxmlformats.org/officeDocument/2006/relationships" r:id="Rb71933e77e424ef5"/>
               </a:rPr>
               <a:t>https://github.com/qjmre23/Route2Zero</a:t>
             </a:r>
@@ -5899,7 +5899,7 @@
                 <a:latin typeface="Arial"/>
                 <a:ea typeface="Arial"/>
                 <a:cs typeface="Arial"/>
-                <a:hlinkClick xmlns:r="http://schemas.openxmlformats.org/officeDocument/2006/relationships" r:id="Ref31aa92e91140b3"/>
+                <a:hlinkClick xmlns:r="http://schemas.openxmlformats.org/officeDocument/2006/relationships" r:id="R6e437e12bde547b7"/>
               </a:rPr>
               <a:t>https://route2zero.netlify.app/</a:t>
             </a:r>
@@ -5911,7 +5911,7 @@
           <p:cNvPr id="2" name="">
             <a:extLst xmlns:a="http://schemas.openxmlformats.org/drawingml/2006/main">
               <a:ext uri="{FF2B5EF4-FFF2-40B4-BE49-F238E27FC236}">
-                <a16:creationId xmlns:a16="http://schemas.microsoft.com/office/drawing/2014/main" id="{A5F5296A-F9CA-4B5D-907B-B36390A519B8}"/>
+                <a16:creationId xmlns:a16="http://schemas.microsoft.com/office/drawing/2014/main" id="{681107B5-D7E0-482D-B89F-DCEFF364CE15}"/>
               </a:ext>
             </a:extLst>
           </p:cNvPr>
@@ -5973,7 +5973,7 @@
           <p:cNvPr id="3" name="">
             <a:extLst xmlns:a="http://schemas.openxmlformats.org/drawingml/2006/main">
               <a:ext uri="{FF2B5EF4-FFF2-40B4-BE49-F238E27FC236}">
-                <a16:creationId xmlns:a16="http://schemas.microsoft.com/office/drawing/2014/main" id="{405B93FE-C796-4C25-A11A-2FC69682F782}"/>
+                <a16:creationId xmlns:a16="http://schemas.microsoft.com/office/drawing/2014/main" id="{91365181-190E-489E-B18A-7A0FF8492225}"/>
               </a:ext>
             </a:extLst>
           </p:cNvPr>
@@ -6039,8 +6039,8 @@
           <p:nvPr/>
         </p:nvPicPr>
         <p:blipFill>
-          <a:blip xmlns:r="http://schemas.openxmlformats.org/officeDocument/2006/relationships" xmlns:a="http://schemas.openxmlformats.org/drawingml/2006/main" r:embed="R9852fcef6f184a5f"/>
-          <a:srcRect xmlns:a="http://schemas.openxmlformats.org/drawingml/2006/main" l="4628" t="0" r="4628" b="0"/>
+          <a:blip xmlns:r="http://schemas.openxmlformats.org/officeDocument/2006/relationships" xmlns:a="http://schemas.openxmlformats.org/drawingml/2006/main" r:embed="Raff5f06faacf4160"/>
+          <a:srcRect xmlns:a="http://schemas.openxmlformats.org/drawingml/2006/main" l="4619" t="0" r="4619" b="0"/>
           <a:stretch xmlns:a="http://schemas.openxmlformats.org/drawingml/2006/main">
             <a:fillRect l="0" t="0" r="0" b="0"/>
           </a:stretch>
@@ -6062,7 +6062,7 @@
           <p:cNvPr id="5" name="">
             <a:extLst xmlns:a="http://schemas.openxmlformats.org/drawingml/2006/main">
               <a:ext uri="{FF2B5EF4-FFF2-40B4-BE49-F238E27FC236}">
-                <a16:creationId xmlns:a16="http://schemas.microsoft.com/office/drawing/2014/main" id="{680BC1F5-08A4-4DE5-99CB-80054275133E}"/>
+                <a16:creationId xmlns:a16="http://schemas.microsoft.com/office/drawing/2014/main" id="{4A3EEC4F-797C-4AB9-8E88-C5957945E547}"/>
               </a:ext>
             </a:extLst>
           </p:cNvPr>
@@ -6095,7 +6095,7 @@
           <p:cNvPr id="6" name="">
             <a:extLst xmlns:a="http://schemas.openxmlformats.org/drawingml/2006/main">
               <a:ext uri="{FF2B5EF4-FFF2-40B4-BE49-F238E27FC236}">
-                <a16:creationId xmlns:a16="http://schemas.microsoft.com/office/drawing/2014/main" id="{D2C270A3-F38A-4F50-8217-CA74E3FC27BA}"/>
+                <a16:creationId xmlns:a16="http://schemas.microsoft.com/office/drawing/2014/main" id="{65AD7348-9E6E-49D2-BBF4-BC4EA47963C0}"/>
               </a:ext>
             </a:extLst>
           </p:cNvPr>
@@ -6157,7 +6157,7 @@
           <p:cNvPr id="7" name="">
             <a:extLst xmlns:a="http://schemas.openxmlformats.org/drawingml/2006/main">
               <a:ext uri="{FF2B5EF4-FFF2-40B4-BE49-F238E27FC236}">
-                <a16:creationId xmlns:a16="http://schemas.microsoft.com/office/drawing/2014/main" id="{1314FCC6-8CD5-4BCE-9890-E3C976DFAC9E}"/>
+                <a16:creationId xmlns:a16="http://schemas.microsoft.com/office/drawing/2014/main" id="{D4DFDF8F-DD5A-41E8-91F9-BDC669168722}"/>
               </a:ext>
             </a:extLst>
           </p:cNvPr>
@@ -6219,7 +6219,7 @@
           <p:cNvPr id="8" name="">
             <a:extLst xmlns:a="http://schemas.openxmlformats.org/drawingml/2006/main">
               <a:ext uri="{FF2B5EF4-FFF2-40B4-BE49-F238E27FC236}">
-                <a16:creationId xmlns:a16="http://schemas.microsoft.com/office/drawing/2014/main" id="{6728B488-9F3C-41F2-8AEB-D382F00ADFC6}"/>
+                <a16:creationId xmlns:a16="http://schemas.microsoft.com/office/drawing/2014/main" id="{ADC09B4E-C18A-4D01-ACB1-E4B2AE235957}"/>
               </a:ext>
             </a:extLst>
           </p:cNvPr>
@@ -6281,7 +6281,7 @@
           <p:cNvPr id="9" name="">
             <a:extLst xmlns:a="http://schemas.openxmlformats.org/drawingml/2006/main">
               <a:ext uri="{FF2B5EF4-FFF2-40B4-BE49-F238E27FC236}">
-                <a16:creationId xmlns:a16="http://schemas.microsoft.com/office/drawing/2014/main" id="{4687ED1C-F05B-41B3-87E8-4F9CC8A6E170}"/>
+                <a16:creationId xmlns:a16="http://schemas.microsoft.com/office/drawing/2014/main" id="{34786B19-14D6-4301-B005-A5A488F04BB4}"/>
               </a:ext>
             </a:extLst>
           </p:cNvPr>
@@ -6343,7 +6343,7 @@
           <p:cNvPr id="10" name="">
             <a:extLst xmlns:a="http://schemas.openxmlformats.org/drawingml/2006/main">
               <a:ext uri="{FF2B5EF4-FFF2-40B4-BE49-F238E27FC236}">
-                <a16:creationId xmlns:a16="http://schemas.microsoft.com/office/drawing/2014/main" id="{B8E94140-819B-4E6C-8F5B-A8BAEACDE722}"/>
+                <a16:creationId xmlns:a16="http://schemas.microsoft.com/office/drawing/2014/main" id="{4C283E31-5182-474C-8F50-91EB59E2D213}"/>
               </a:ext>
             </a:extLst>
           </p:cNvPr>
@@ -6405,7 +6405,7 @@
           <p:cNvPr id="11" name="">
             <a:extLst xmlns:a="http://schemas.openxmlformats.org/drawingml/2006/main">
               <a:ext uri="{FF2B5EF4-FFF2-40B4-BE49-F238E27FC236}">
-                <a16:creationId xmlns:a16="http://schemas.microsoft.com/office/drawing/2014/main" id="{59BBDA94-1515-4578-BF4C-CA058BA12AA8}"/>
+                <a16:creationId xmlns:a16="http://schemas.microsoft.com/office/drawing/2014/main" id="{615E614E-833E-41AF-BD55-56F1495530ED}"/>
               </a:ext>
             </a:extLst>
           </p:cNvPr>
@@ -6440,7 +6440,7 @@
           <p:cNvPr id="12" name="">
             <a:extLst xmlns:a="http://schemas.openxmlformats.org/drawingml/2006/main">
               <a:ext uri="{FF2B5EF4-FFF2-40B4-BE49-F238E27FC236}">
-                <a16:creationId xmlns:a16="http://schemas.microsoft.com/office/drawing/2014/main" id="{EC27DA44-4B4F-4027-887D-6E1F0EF24038}"/>
+                <a16:creationId xmlns:a16="http://schemas.microsoft.com/office/drawing/2014/main" id="{F2930A52-DA94-41FE-A0A8-F8009D45E6A5}"/>
               </a:ext>
             </a:extLst>
           </p:cNvPr>
@@ -6502,7 +6502,7 @@
           <p:cNvPr id="13" name="">
             <a:extLst xmlns:a="http://schemas.openxmlformats.org/drawingml/2006/main">
               <a:ext uri="{FF2B5EF4-FFF2-40B4-BE49-F238E27FC236}">
-                <a16:creationId xmlns:a16="http://schemas.microsoft.com/office/drawing/2014/main" id="{179D3D8F-B78D-4504-A42C-A61056EB92BF}"/>
+                <a16:creationId xmlns:a16="http://schemas.microsoft.com/office/drawing/2014/main" id="{3CA30152-CE86-4CC1-93A6-6FD30DEBFBE3}"/>
               </a:ext>
             </a:extLst>
           </p:cNvPr>
@@ -6564,7 +6564,7 @@
           <p:cNvPr id="14" name="">
             <a:extLst xmlns:a="http://schemas.openxmlformats.org/drawingml/2006/main">
               <a:ext uri="{FF2B5EF4-FFF2-40B4-BE49-F238E27FC236}">
-                <a16:creationId xmlns:a16="http://schemas.microsoft.com/office/drawing/2014/main" id="{4C27CE05-0F4D-49D0-AD7E-41E67F2FC94C}"/>
+                <a16:creationId xmlns:a16="http://schemas.microsoft.com/office/drawing/2014/main" id="{2E460FCE-5BDC-46FB-86DA-47F036F3EA90}"/>
               </a:ext>
             </a:extLst>
           </p:cNvPr>
@@ -6626,7 +6626,7 @@
           <p:cNvPr id="15" name="">
             <a:extLst xmlns:a="http://schemas.openxmlformats.org/drawingml/2006/main">
               <a:ext uri="{FF2B5EF4-FFF2-40B4-BE49-F238E27FC236}">
-                <a16:creationId xmlns:a16="http://schemas.microsoft.com/office/drawing/2014/main" id="{49763B8E-60A7-40A2-9763-AD21FE7B7BF2}"/>
+                <a16:creationId xmlns:a16="http://schemas.microsoft.com/office/drawing/2014/main" id="{2D797D02-1C8A-4347-A110-2A643F5938A1}"/>
               </a:ext>
             </a:extLst>
           </p:cNvPr>
@@ -6688,7 +6688,7 @@
           <p:cNvPr id="16" name="">
             <a:extLst xmlns:a="http://schemas.openxmlformats.org/drawingml/2006/main">
               <a:ext uri="{FF2B5EF4-FFF2-40B4-BE49-F238E27FC236}">
-                <a16:creationId xmlns:a16="http://schemas.microsoft.com/office/drawing/2014/main" id="{EDB274C3-54F3-4A6E-B315-86B266792809}"/>
+                <a16:creationId xmlns:a16="http://schemas.microsoft.com/office/drawing/2014/main" id="{A18A43C3-71AE-4861-B298-30D0F5D6DCE5}"/>
               </a:ext>
             </a:extLst>
           </p:cNvPr>
@@ -6750,7 +6750,7 @@
           <p:cNvPr id="17" name="">
             <a:extLst xmlns:a="http://schemas.openxmlformats.org/drawingml/2006/main">
               <a:ext uri="{FF2B5EF4-FFF2-40B4-BE49-F238E27FC236}">
-                <a16:creationId xmlns:a16="http://schemas.microsoft.com/office/drawing/2014/main" id="{362A4D88-A9F1-4E44-848C-D8DC11058257}"/>
+                <a16:creationId xmlns:a16="http://schemas.microsoft.com/office/drawing/2014/main" id="{355B986C-7D18-405B-BA7B-D5B67E092C24}"/>
               </a:ext>
             </a:extLst>
           </p:cNvPr>
@@ -6812,7 +6812,7 @@
           <p:cNvPr id="18" name="">
             <a:extLst xmlns:a="http://schemas.openxmlformats.org/drawingml/2006/main">
               <a:ext uri="{FF2B5EF4-FFF2-40B4-BE49-F238E27FC236}">
-                <a16:creationId xmlns:a16="http://schemas.microsoft.com/office/drawing/2014/main" id="{1E43B981-8CE2-4629-BA2D-D42CC515B793}"/>
+                <a16:creationId xmlns:a16="http://schemas.microsoft.com/office/drawing/2014/main" id="{770F5844-D65B-42E1-9C2E-5C710DEE5AB7}"/>
               </a:ext>
             </a:extLst>
           </p:cNvPr>
@@ -6847,7 +6847,7 @@
           <p:cNvPr id="19" name="">
             <a:extLst xmlns:a="http://schemas.openxmlformats.org/drawingml/2006/main">
               <a:ext uri="{FF2B5EF4-FFF2-40B4-BE49-F238E27FC236}">
-                <a16:creationId xmlns:a16="http://schemas.microsoft.com/office/drawing/2014/main" id="{D60FDB63-A06E-4390-860B-0DB2381CBE80}"/>
+                <a16:creationId xmlns:a16="http://schemas.microsoft.com/office/drawing/2014/main" id="{5F9B8435-36E9-4237-AA47-F4914A736CEA}"/>
               </a:ext>
             </a:extLst>
           </p:cNvPr>
@@ -6909,7 +6909,7 @@
           <p:cNvPr id="20" name="">
             <a:extLst xmlns:a="http://schemas.openxmlformats.org/drawingml/2006/main">
               <a:ext uri="{FF2B5EF4-FFF2-40B4-BE49-F238E27FC236}">
-                <a16:creationId xmlns:a16="http://schemas.microsoft.com/office/drawing/2014/main" id="{EEBE0C60-0E1F-4ED0-A1E4-69DCC4E2AEA1}"/>
+                <a16:creationId xmlns:a16="http://schemas.microsoft.com/office/drawing/2014/main" id="{6D660200-4156-4045-A217-7F0D81170EC6}"/>
               </a:ext>
             </a:extLst>
           </p:cNvPr>
@@ -6940,7 +6940,7 @@
           <p:cNvPr id="21" name="">
             <a:extLst xmlns:a="http://schemas.openxmlformats.org/drawingml/2006/main">
               <a:ext uri="{FF2B5EF4-FFF2-40B4-BE49-F238E27FC236}">
-                <a16:creationId xmlns:a16="http://schemas.microsoft.com/office/drawing/2014/main" id="{9C73F6EA-5947-44E0-BC52-528CBF648429}"/>
+                <a16:creationId xmlns:a16="http://schemas.microsoft.com/office/drawing/2014/main" id="{E7139446-0394-44E1-939F-0B37A53FF924}"/>
               </a:ext>
             </a:extLst>
           </p:cNvPr>
@@ -6992,7 +6992,7 @@
                 <a:ea typeface="Arial"/>
                 <a:cs typeface="Arial"/>
               </a:rPr>
-              <a:t>r2z-16690ccbe328 · seed 20260820 · 5,000 simulations</a:t>
+              <a:t>r2z-45c4ba076af9 · seed 20260820 · 5,000 simulations</a:t>
             </a:r>
           </a:p>
         </p:txBody>
@@ -7002,7 +7002,7 @@
           <p:cNvPr id="22" name="">
             <a:extLst xmlns:a="http://schemas.openxmlformats.org/drawingml/2006/main">
               <a:ext uri="{FF2B5EF4-FFF2-40B4-BE49-F238E27FC236}">
-                <a16:creationId xmlns:a16="http://schemas.microsoft.com/office/drawing/2014/main" id="{83F09F65-62A9-4F68-B7A4-CD7953F3E21E}"/>
+                <a16:creationId xmlns:a16="http://schemas.microsoft.com/office/drawing/2014/main" id="{B0CDE31F-1A4A-4303-AACF-21455B00DCD1}"/>
               </a:ext>
             </a:extLst>
           </p:cNvPr>
@@ -7062,7 +7062,7 @@
     </p:spTree>
     <p:extLst>
       <p:ext uri="{BB962C8B-B14F-4D97-AF65-F5344CB8AC3E}">
-        <p14:creationId xmlns:p14="http://schemas.microsoft.com/office/powerpoint/2010/main" val="2010574044"/>
+        <p14:creationId xmlns:p14="http://schemas.microsoft.com/office/powerpoint/2010/main" val="1120414718"/>
       </p:ext>
     </p:extLst>
   </p:cSld>
@@ -7093,7 +7093,7 @@
           <p:cNvPr id="21" name="">
             <a:extLst xmlns:a="http://schemas.openxmlformats.org/drawingml/2006/main">
               <a:ext uri="{FF2B5EF4-FFF2-40B4-BE49-F238E27FC236}">
-                <a16:creationId xmlns:a16="http://schemas.microsoft.com/office/drawing/2014/main" id="{64070F52-2F99-465A-A966-68DF05498231}"/>
+                <a16:creationId xmlns:a16="http://schemas.microsoft.com/office/drawing/2014/main" id="{48259CBD-08E9-4290-8691-4C2A130CCB32}"/>
               </a:ext>
             </a:extLst>
           </p:cNvPr>
@@ -7155,7 +7155,7 @@
                 <a:latin typeface="Arial"/>
                 <a:ea typeface="Arial"/>
                 <a:cs typeface="Arial"/>
-                <a:hlinkClick xmlns:r="http://schemas.openxmlformats.org/officeDocument/2006/relationships" r:id="R32b4eccb4b184b14"/>
+                <a:hlinkClick xmlns:r="http://schemas.openxmlformats.org/officeDocument/2006/relationships" r:id="Ra5553416c2de4239"/>
               </a:rPr>
               <a:t>https://github.com/qjmre23/Route2Zero</a:t>
             </a:r>
@@ -7178,7 +7178,7 @@
                 <a:latin typeface="Arial"/>
                 <a:ea typeface="Arial"/>
                 <a:cs typeface="Arial"/>
-                <a:hlinkClick xmlns:r="http://schemas.openxmlformats.org/officeDocument/2006/relationships" r:id="R02205a130fd044df"/>
+                <a:hlinkClick xmlns:r="http://schemas.openxmlformats.org/officeDocument/2006/relationships" r:id="R672278ac31cb4c67"/>
               </a:rPr>
               <a:t>https://route2zero.netlify.app/</a:t>
             </a:r>
@@ -7190,7 +7190,7 @@
           <p:cNvPr id="2" name="">
             <a:extLst xmlns:a="http://schemas.openxmlformats.org/drawingml/2006/main">
               <a:ext uri="{FF2B5EF4-FFF2-40B4-BE49-F238E27FC236}">
-                <a16:creationId xmlns:a16="http://schemas.microsoft.com/office/drawing/2014/main" id="{F45394B1-0A40-455D-81D9-1C79393B0674}"/>
+                <a16:creationId xmlns:a16="http://schemas.microsoft.com/office/drawing/2014/main" id="{F762F23E-D754-4DA0-88E9-58C90ED83CB5}"/>
               </a:ext>
             </a:extLst>
           </p:cNvPr>
@@ -7252,7 +7252,7 @@
           <p:cNvPr id="3" name="">
             <a:extLst xmlns:a="http://schemas.openxmlformats.org/drawingml/2006/main">
               <a:ext uri="{FF2B5EF4-FFF2-40B4-BE49-F238E27FC236}">
-                <a16:creationId xmlns:a16="http://schemas.microsoft.com/office/drawing/2014/main" id="{01CCE56D-6A75-4D25-AB52-4708D47BD43A}"/>
+                <a16:creationId xmlns:a16="http://schemas.microsoft.com/office/drawing/2014/main" id="{FAA8C0CA-EF99-4E69-BE6C-77659D83EB6B}"/>
               </a:ext>
             </a:extLst>
           </p:cNvPr>
@@ -7318,8 +7318,8 @@
           <p:nvPr/>
         </p:nvPicPr>
         <p:blipFill>
-          <a:blip xmlns:r="http://schemas.openxmlformats.org/officeDocument/2006/relationships" xmlns:a="http://schemas.openxmlformats.org/drawingml/2006/main" r:embed="Rb5a81f31ea5f41bc"/>
-          <a:srcRect xmlns:a="http://schemas.openxmlformats.org/drawingml/2006/main" l="0" t="15675" r="0" b="15675"/>
+          <a:blip xmlns:r="http://schemas.openxmlformats.org/officeDocument/2006/relationships" xmlns:a="http://schemas.openxmlformats.org/drawingml/2006/main" r:embed="R2c0e20d81f0341d7"/>
+          <a:srcRect xmlns:a="http://schemas.openxmlformats.org/drawingml/2006/main" l="0" t="15682" r="0" b="15682"/>
           <a:stretch xmlns:a="http://schemas.openxmlformats.org/drawingml/2006/main">
             <a:fillRect l="0" t="0" r="0" b="0"/>
           </a:stretch>
@@ -7341,7 +7341,7 @@
           <p:cNvPr id="5" name="">
             <a:extLst xmlns:a="http://schemas.openxmlformats.org/drawingml/2006/main">
               <a:ext uri="{FF2B5EF4-FFF2-40B4-BE49-F238E27FC236}">
-                <a16:creationId xmlns:a16="http://schemas.microsoft.com/office/drawing/2014/main" id="{DF272AF7-F3BF-4F41-9210-6E6028C044C0}"/>
+                <a16:creationId xmlns:a16="http://schemas.microsoft.com/office/drawing/2014/main" id="{70B6CD51-D89A-4D47-AA2A-DC5E0CA37ACE}"/>
               </a:ext>
             </a:extLst>
           </p:cNvPr>
@@ -7374,7 +7374,7 @@
           <p:cNvPr id="6" name="">
             <a:extLst xmlns:a="http://schemas.openxmlformats.org/drawingml/2006/main">
               <a:ext uri="{FF2B5EF4-FFF2-40B4-BE49-F238E27FC236}">
-                <a16:creationId xmlns:a16="http://schemas.microsoft.com/office/drawing/2014/main" id="{D66635B3-30E1-40C1-AB39-21D0D8D7361B}"/>
+                <a16:creationId xmlns:a16="http://schemas.microsoft.com/office/drawing/2014/main" id="{A42B41FE-26DF-4B35-B5D0-462EE8B56C20}"/>
               </a:ext>
             </a:extLst>
           </p:cNvPr>
@@ -7405,7 +7405,7 @@
           <p:cNvPr id="7" name="">
             <a:extLst xmlns:a="http://schemas.openxmlformats.org/drawingml/2006/main">
               <a:ext uri="{FF2B5EF4-FFF2-40B4-BE49-F238E27FC236}">
-                <a16:creationId xmlns:a16="http://schemas.microsoft.com/office/drawing/2014/main" id="{5C544518-4F53-4D58-83D3-00A59519E959}"/>
+                <a16:creationId xmlns:a16="http://schemas.microsoft.com/office/drawing/2014/main" id="{991336F3-4044-47F4-90A4-BC16649389D6}"/>
               </a:ext>
             </a:extLst>
           </p:cNvPr>
@@ -7467,7 +7467,7 @@
           <p:cNvPr id="8" name="">
             <a:extLst xmlns:a="http://schemas.openxmlformats.org/drawingml/2006/main">
               <a:ext uri="{FF2B5EF4-FFF2-40B4-BE49-F238E27FC236}">
-                <a16:creationId xmlns:a16="http://schemas.microsoft.com/office/drawing/2014/main" id="{30645219-C2C8-49F0-AA3A-A4FF850EF380}"/>
+                <a16:creationId xmlns:a16="http://schemas.microsoft.com/office/drawing/2014/main" id="{60F947D7-AD78-499D-85D4-3C79480C949E}"/>
               </a:ext>
             </a:extLst>
           </p:cNvPr>
@@ -7502,7 +7502,7 @@
           <p:cNvPr id="9" name="">
             <a:extLst xmlns:a="http://schemas.openxmlformats.org/drawingml/2006/main">
               <a:ext uri="{FF2B5EF4-FFF2-40B4-BE49-F238E27FC236}">
-                <a16:creationId xmlns:a16="http://schemas.microsoft.com/office/drawing/2014/main" id="{DC5D6CF7-D681-4409-81D1-D1BB435CC7AB}"/>
+                <a16:creationId xmlns:a16="http://schemas.microsoft.com/office/drawing/2014/main" id="{39CBCCD3-9B8C-4BC6-9E16-CC51F4C1E5FC}"/>
               </a:ext>
             </a:extLst>
           </p:cNvPr>
@@ -7564,7 +7564,7 @@
           <p:cNvPr id="10" name="">
             <a:extLst xmlns:a="http://schemas.openxmlformats.org/drawingml/2006/main">
               <a:ext uri="{FF2B5EF4-FFF2-40B4-BE49-F238E27FC236}">
-                <a16:creationId xmlns:a16="http://schemas.microsoft.com/office/drawing/2014/main" id="{C22AA760-1985-4DE9-BEA6-077BF4E95EC6}"/>
+                <a16:creationId xmlns:a16="http://schemas.microsoft.com/office/drawing/2014/main" id="{8343A782-9FFD-47FE-9D12-2398830B5DAB}"/>
               </a:ext>
             </a:extLst>
           </p:cNvPr>
@@ -7595,7 +7595,7 @@
           <p:cNvPr id="11" name="">
             <a:extLst xmlns:a="http://schemas.openxmlformats.org/drawingml/2006/main">
               <a:ext uri="{FF2B5EF4-FFF2-40B4-BE49-F238E27FC236}">
-                <a16:creationId xmlns:a16="http://schemas.microsoft.com/office/drawing/2014/main" id="{F37DAD46-06CF-4AB0-93D2-907BD08858E7}"/>
+                <a16:creationId xmlns:a16="http://schemas.microsoft.com/office/drawing/2014/main" id="{92659B9E-23EA-4F39-92EC-2ACD022040BC}"/>
               </a:ext>
             </a:extLst>
           </p:cNvPr>
@@ -7657,7 +7657,7 @@
           <p:cNvPr id="12" name="">
             <a:extLst xmlns:a="http://schemas.openxmlformats.org/drawingml/2006/main">
               <a:ext uri="{FF2B5EF4-FFF2-40B4-BE49-F238E27FC236}">
-                <a16:creationId xmlns:a16="http://schemas.microsoft.com/office/drawing/2014/main" id="{92D78E5F-5014-4805-8D19-924A3129F612}"/>
+                <a16:creationId xmlns:a16="http://schemas.microsoft.com/office/drawing/2014/main" id="{68EED8E7-A397-4553-A917-C142046DD53D}"/>
               </a:ext>
             </a:extLst>
           </p:cNvPr>
@@ -7692,7 +7692,7 @@
           <p:cNvPr id="13" name="">
             <a:extLst xmlns:a="http://schemas.openxmlformats.org/drawingml/2006/main">
               <a:ext uri="{FF2B5EF4-FFF2-40B4-BE49-F238E27FC236}">
-                <a16:creationId xmlns:a16="http://schemas.microsoft.com/office/drawing/2014/main" id="{5B014DB4-18D3-47B3-8D1E-9AFC4DC44725}"/>
+                <a16:creationId xmlns:a16="http://schemas.microsoft.com/office/drawing/2014/main" id="{655E0059-FBF3-4410-B2DA-72A5CA3E3752}"/>
               </a:ext>
             </a:extLst>
           </p:cNvPr>
@@ -7754,7 +7754,7 @@
           <p:cNvPr id="14" name="">
             <a:extLst xmlns:a="http://schemas.openxmlformats.org/drawingml/2006/main">
               <a:ext uri="{FF2B5EF4-FFF2-40B4-BE49-F238E27FC236}">
-                <a16:creationId xmlns:a16="http://schemas.microsoft.com/office/drawing/2014/main" id="{09ECD58D-A80E-4D00-BD8D-539EB89D4D70}"/>
+                <a16:creationId xmlns:a16="http://schemas.microsoft.com/office/drawing/2014/main" id="{A2BCB441-064F-415F-8277-0BC0ED55F6DF}"/>
               </a:ext>
             </a:extLst>
           </p:cNvPr>
@@ -7785,7 +7785,7 @@
           <p:cNvPr id="15" name="">
             <a:extLst xmlns:a="http://schemas.openxmlformats.org/drawingml/2006/main">
               <a:ext uri="{FF2B5EF4-FFF2-40B4-BE49-F238E27FC236}">
-                <a16:creationId xmlns:a16="http://schemas.microsoft.com/office/drawing/2014/main" id="{03D1F7B4-685A-41ED-ABF3-2AC2110FC412}"/>
+                <a16:creationId xmlns:a16="http://schemas.microsoft.com/office/drawing/2014/main" id="{11978923-2961-4EF3-A2A4-99B8E5533C7A}"/>
               </a:ext>
             </a:extLst>
           </p:cNvPr>
@@ -7847,7 +7847,7 @@
           <p:cNvPr id="16" name="">
             <a:extLst xmlns:a="http://schemas.openxmlformats.org/drawingml/2006/main">
               <a:ext uri="{FF2B5EF4-FFF2-40B4-BE49-F238E27FC236}">
-                <a16:creationId xmlns:a16="http://schemas.microsoft.com/office/drawing/2014/main" id="{A7F6F1B7-16C3-44F6-BF68-48CD0814CA1E}"/>
+                <a16:creationId xmlns:a16="http://schemas.microsoft.com/office/drawing/2014/main" id="{7BFE6790-619F-4A45-A90E-869C7F0349BD}"/>
               </a:ext>
             </a:extLst>
           </p:cNvPr>
@@ -7882,7 +7882,7 @@
           <p:cNvPr id="17" name="">
             <a:extLst xmlns:a="http://schemas.openxmlformats.org/drawingml/2006/main">
               <a:ext uri="{FF2B5EF4-FFF2-40B4-BE49-F238E27FC236}">
-                <a16:creationId xmlns:a16="http://schemas.microsoft.com/office/drawing/2014/main" id="{BB1A125D-1F53-4F51-AB09-126D7D2FC881}"/>
+                <a16:creationId xmlns:a16="http://schemas.microsoft.com/office/drawing/2014/main" id="{6D5B0E49-B4DA-4A42-B5DF-0801AC730A07}"/>
               </a:ext>
             </a:extLst>
           </p:cNvPr>
@@ -7944,7 +7944,7 @@
           <p:cNvPr id="18" name="">
             <a:extLst xmlns:a="http://schemas.openxmlformats.org/drawingml/2006/main">
               <a:ext uri="{FF2B5EF4-FFF2-40B4-BE49-F238E27FC236}">
-                <a16:creationId xmlns:a16="http://schemas.microsoft.com/office/drawing/2014/main" id="{A7ED6AE8-14FC-49FC-8B28-97E39C588A5B}"/>
+                <a16:creationId xmlns:a16="http://schemas.microsoft.com/office/drawing/2014/main" id="{0ED0F858-6EB2-4C7D-9743-58EAB3153452}"/>
               </a:ext>
             </a:extLst>
           </p:cNvPr>
@@ -7975,7 +7975,7 @@
           <p:cNvPr id="19" name="">
             <a:extLst xmlns:a="http://schemas.openxmlformats.org/drawingml/2006/main">
               <a:ext uri="{FF2B5EF4-FFF2-40B4-BE49-F238E27FC236}">
-                <a16:creationId xmlns:a16="http://schemas.microsoft.com/office/drawing/2014/main" id="{EE6E33D3-B3FC-4D84-A668-174D326F2848}"/>
+                <a16:creationId xmlns:a16="http://schemas.microsoft.com/office/drawing/2014/main" id="{BB09A3EE-D4F4-45DE-B2EB-B89B1F563D36}"/>
               </a:ext>
             </a:extLst>
           </p:cNvPr>
@@ -8027,7 +8027,7 @@
                 <a:ea typeface="Arial"/>
                 <a:cs typeface="Arial"/>
               </a:rPr>
-              <a:t>r2z-16690ccbe328 · scn-c46e1d86c1</a:t>
+              <a:t>r2z-45c4ba076af9 · scn-e0f12f397e</a:t>
             </a:r>
           </a:p>
         </p:txBody>
@@ -8037,7 +8037,7 @@
           <p:cNvPr id="20" name="">
             <a:extLst xmlns:a="http://schemas.openxmlformats.org/drawingml/2006/main">
               <a:ext uri="{FF2B5EF4-FFF2-40B4-BE49-F238E27FC236}">
-                <a16:creationId xmlns:a16="http://schemas.microsoft.com/office/drawing/2014/main" id="{EF33F6CF-5BB4-499B-BE36-2AA59F8FAD3B}"/>
+                <a16:creationId xmlns:a16="http://schemas.microsoft.com/office/drawing/2014/main" id="{88B894F9-FED2-4A06-8F91-247215691677}"/>
               </a:ext>
             </a:extLst>
           </p:cNvPr>
@@ -8097,7 +8097,7 @@
     </p:spTree>
     <p:extLst>
       <p:ext uri="{BB962C8B-B14F-4D97-AF65-F5344CB8AC3E}">
-        <p14:creationId xmlns:p14="http://schemas.microsoft.com/office/powerpoint/2010/main" val="326160950"/>
+        <p14:creationId xmlns:p14="http://schemas.microsoft.com/office/powerpoint/2010/main" val="153512392"/>
       </p:ext>
     </p:extLst>
   </p:cSld>
@@ -8128,7 +8128,7 @@
           <p:cNvPr id="21" name="">
             <a:extLst xmlns:a="http://schemas.openxmlformats.org/drawingml/2006/main">
               <a:ext uri="{FF2B5EF4-FFF2-40B4-BE49-F238E27FC236}">
-                <a16:creationId xmlns:a16="http://schemas.microsoft.com/office/drawing/2014/main" id="{01F9349D-333A-4DB0-9740-B725DEC58A3B}"/>
+                <a16:creationId xmlns:a16="http://schemas.microsoft.com/office/drawing/2014/main" id="{39DDAE7F-02CA-467B-9BF6-F1C54E1430EB}"/>
               </a:ext>
             </a:extLst>
           </p:cNvPr>
@@ -8190,7 +8190,7 @@
                 <a:latin typeface="Arial"/>
                 <a:ea typeface="Arial"/>
                 <a:cs typeface="Arial"/>
-                <a:hlinkClick xmlns:r="http://schemas.openxmlformats.org/officeDocument/2006/relationships" r:id="Rf630f8f6a9b4499b"/>
+                <a:hlinkClick xmlns:r="http://schemas.openxmlformats.org/officeDocument/2006/relationships" r:id="Rbfc81434e068450c"/>
               </a:rPr>
               <a:t>https://github.com/qjmre23/Route2Zero</a:t>
             </a:r>
@@ -8213,7 +8213,7 @@
                 <a:latin typeface="Arial"/>
                 <a:ea typeface="Arial"/>
                 <a:cs typeface="Arial"/>
-                <a:hlinkClick xmlns:r="http://schemas.openxmlformats.org/officeDocument/2006/relationships" r:id="Rf161ef728d1c4ea3"/>
+                <a:hlinkClick xmlns:r="http://schemas.openxmlformats.org/officeDocument/2006/relationships" r:id="R48a252a755e34df6"/>
               </a:rPr>
               <a:t>https://route2zero.netlify.app/</a:t>
             </a:r>
@@ -8225,7 +8225,7 @@
           <p:cNvPr id="2" name="">
             <a:extLst xmlns:a="http://schemas.openxmlformats.org/drawingml/2006/main">
               <a:ext uri="{FF2B5EF4-FFF2-40B4-BE49-F238E27FC236}">
-                <a16:creationId xmlns:a16="http://schemas.microsoft.com/office/drawing/2014/main" id="{3424436E-39C9-49A6-8B42-504E00E097C6}"/>
+                <a16:creationId xmlns:a16="http://schemas.microsoft.com/office/drawing/2014/main" id="{52C3187A-9E1C-4E4D-9AC5-CA12DF5018BE}"/>
               </a:ext>
             </a:extLst>
           </p:cNvPr>
@@ -8287,7 +8287,7 @@
           <p:cNvPr id="3" name="">
             <a:extLst xmlns:a="http://schemas.openxmlformats.org/drawingml/2006/main">
               <a:ext uri="{FF2B5EF4-FFF2-40B4-BE49-F238E27FC236}">
-                <a16:creationId xmlns:a16="http://schemas.microsoft.com/office/drawing/2014/main" id="{79C9ED17-EFA6-43BB-8293-7F8C35CD882A}"/>
+                <a16:creationId xmlns:a16="http://schemas.microsoft.com/office/drawing/2014/main" id="{8D08A143-0E4E-460F-9D70-B4AD84990AEF}"/>
               </a:ext>
             </a:extLst>
           </p:cNvPr>
@@ -8353,8 +8353,8 @@
           <p:nvPr/>
         </p:nvPicPr>
         <p:blipFill>
-          <a:blip xmlns:r="http://schemas.openxmlformats.org/officeDocument/2006/relationships" xmlns:a="http://schemas.openxmlformats.org/drawingml/2006/main" r:embed="Rfb2904b4e2704a12"/>
-          <a:srcRect xmlns:a="http://schemas.openxmlformats.org/drawingml/2006/main" l="0" t="15675" r="0" b="15675"/>
+          <a:blip xmlns:r="http://schemas.openxmlformats.org/officeDocument/2006/relationships" xmlns:a="http://schemas.openxmlformats.org/drawingml/2006/main" r:embed="R63f19056564a41ee"/>
+          <a:srcRect xmlns:a="http://schemas.openxmlformats.org/drawingml/2006/main" l="0" t="15682" r="0" b="15682"/>
           <a:stretch xmlns:a="http://schemas.openxmlformats.org/drawingml/2006/main">
             <a:fillRect l="0" t="0" r="0" b="0"/>
           </a:stretch>
@@ -8376,7 +8376,7 @@
           <p:cNvPr id="5" name="">
             <a:extLst xmlns:a="http://schemas.openxmlformats.org/drawingml/2006/main">
               <a:ext uri="{FF2B5EF4-FFF2-40B4-BE49-F238E27FC236}">
-                <a16:creationId xmlns:a16="http://schemas.microsoft.com/office/drawing/2014/main" id="{A1DE30FF-85F6-47A6-9282-BE2DA8BEA520}"/>
+                <a16:creationId xmlns:a16="http://schemas.microsoft.com/office/drawing/2014/main" id="{83AFFD2A-C71B-41B8-B090-127FBFA85240}"/>
               </a:ext>
             </a:extLst>
           </p:cNvPr>
@@ -8409,7 +8409,7 @@
           <p:cNvPr id="6" name="">
             <a:extLst xmlns:a="http://schemas.openxmlformats.org/drawingml/2006/main">
               <a:ext uri="{FF2B5EF4-FFF2-40B4-BE49-F238E27FC236}">
-                <a16:creationId xmlns:a16="http://schemas.microsoft.com/office/drawing/2014/main" id="{1B665890-5470-4111-9EF5-BE775D60D08D}"/>
+                <a16:creationId xmlns:a16="http://schemas.microsoft.com/office/drawing/2014/main" id="{C38F4570-32DC-48A2-8006-D1ACFB67A9EF}"/>
               </a:ext>
             </a:extLst>
           </p:cNvPr>
@@ -8440,7 +8440,7 @@
           <p:cNvPr id="7" name="">
             <a:extLst xmlns:a="http://schemas.openxmlformats.org/drawingml/2006/main">
               <a:ext uri="{FF2B5EF4-FFF2-40B4-BE49-F238E27FC236}">
-                <a16:creationId xmlns:a16="http://schemas.microsoft.com/office/drawing/2014/main" id="{152C8DDF-6355-4864-9213-023FB39E820F}"/>
+                <a16:creationId xmlns:a16="http://schemas.microsoft.com/office/drawing/2014/main" id="{8C4A16C6-1551-499C-9522-BA67A311B930}"/>
               </a:ext>
             </a:extLst>
           </p:cNvPr>
@@ -8502,7 +8502,7 @@
           <p:cNvPr id="8" name="">
             <a:extLst xmlns:a="http://schemas.openxmlformats.org/drawingml/2006/main">
               <a:ext uri="{FF2B5EF4-FFF2-40B4-BE49-F238E27FC236}">
-                <a16:creationId xmlns:a16="http://schemas.microsoft.com/office/drawing/2014/main" id="{E35AB844-FB67-4F79-BC37-657E6CE1A75E}"/>
+                <a16:creationId xmlns:a16="http://schemas.microsoft.com/office/drawing/2014/main" id="{4FC5CD19-7863-404F-96CB-4F74A933665D}"/>
               </a:ext>
             </a:extLst>
           </p:cNvPr>
@@ -8537,7 +8537,7 @@
           <p:cNvPr id="9" name="">
             <a:extLst xmlns:a="http://schemas.openxmlformats.org/drawingml/2006/main">
               <a:ext uri="{FF2B5EF4-FFF2-40B4-BE49-F238E27FC236}">
-                <a16:creationId xmlns:a16="http://schemas.microsoft.com/office/drawing/2014/main" id="{2A96C967-A122-4ACE-B24E-CFB57E7F060D}"/>
+                <a16:creationId xmlns:a16="http://schemas.microsoft.com/office/drawing/2014/main" id="{354880AA-859E-434A-B5BE-DCF9CB735CB1}"/>
               </a:ext>
             </a:extLst>
           </p:cNvPr>
@@ -8599,7 +8599,7 @@
           <p:cNvPr id="10" name="">
             <a:extLst xmlns:a="http://schemas.openxmlformats.org/drawingml/2006/main">
               <a:ext uri="{FF2B5EF4-FFF2-40B4-BE49-F238E27FC236}">
-                <a16:creationId xmlns:a16="http://schemas.microsoft.com/office/drawing/2014/main" id="{41E442B7-8A6B-436C-8B37-E2B7EDDEC6C0}"/>
+                <a16:creationId xmlns:a16="http://schemas.microsoft.com/office/drawing/2014/main" id="{92C6E053-63A1-4C19-9E62-AE3F1FD2C00D}"/>
               </a:ext>
             </a:extLst>
           </p:cNvPr>
@@ -8630,7 +8630,7 @@
           <p:cNvPr id="11" name="">
             <a:extLst xmlns:a="http://schemas.openxmlformats.org/drawingml/2006/main">
               <a:ext uri="{FF2B5EF4-FFF2-40B4-BE49-F238E27FC236}">
-                <a16:creationId xmlns:a16="http://schemas.microsoft.com/office/drawing/2014/main" id="{27A3A545-37D3-435F-B5B8-652ED66D62BD}"/>
+                <a16:creationId xmlns:a16="http://schemas.microsoft.com/office/drawing/2014/main" id="{C972F62B-4FD9-49D7-A381-DC08E701F6C3}"/>
               </a:ext>
             </a:extLst>
           </p:cNvPr>
@@ -8692,7 +8692,7 @@
           <p:cNvPr id="12" name="">
             <a:extLst xmlns:a="http://schemas.openxmlformats.org/drawingml/2006/main">
               <a:ext uri="{FF2B5EF4-FFF2-40B4-BE49-F238E27FC236}">
-                <a16:creationId xmlns:a16="http://schemas.microsoft.com/office/drawing/2014/main" id="{871440A0-4DA1-44F7-971D-9BA936A396F0}"/>
+                <a16:creationId xmlns:a16="http://schemas.microsoft.com/office/drawing/2014/main" id="{944687E8-A815-4891-9AF7-A526CF7BAC82}"/>
               </a:ext>
             </a:extLst>
           </p:cNvPr>
@@ -8727,7 +8727,7 @@
           <p:cNvPr id="13" name="">
             <a:extLst xmlns:a="http://schemas.openxmlformats.org/drawingml/2006/main">
               <a:ext uri="{FF2B5EF4-FFF2-40B4-BE49-F238E27FC236}">
-                <a16:creationId xmlns:a16="http://schemas.microsoft.com/office/drawing/2014/main" id="{730DF907-5EA0-4872-BD75-E03C886D327C}"/>
+                <a16:creationId xmlns:a16="http://schemas.microsoft.com/office/drawing/2014/main" id="{110C6EC7-5FF7-4103-9ACA-55136050D453}"/>
               </a:ext>
             </a:extLst>
           </p:cNvPr>
@@ -8789,7 +8789,7 @@
           <p:cNvPr id="14" name="">
             <a:extLst xmlns:a="http://schemas.openxmlformats.org/drawingml/2006/main">
               <a:ext uri="{FF2B5EF4-FFF2-40B4-BE49-F238E27FC236}">
-                <a16:creationId xmlns:a16="http://schemas.microsoft.com/office/drawing/2014/main" id="{CDC09591-C89D-447A-B12F-26777215A82B}"/>
+                <a16:creationId xmlns:a16="http://schemas.microsoft.com/office/drawing/2014/main" id="{51493B82-1603-4D72-BA08-FE6C97154375}"/>
               </a:ext>
             </a:extLst>
           </p:cNvPr>
@@ -8820,7 +8820,7 @@
           <p:cNvPr id="15" name="">
             <a:extLst xmlns:a="http://schemas.openxmlformats.org/drawingml/2006/main">
               <a:ext uri="{FF2B5EF4-FFF2-40B4-BE49-F238E27FC236}">
-                <a16:creationId xmlns:a16="http://schemas.microsoft.com/office/drawing/2014/main" id="{FB3276B3-8192-40DB-8D24-2CF5EBBC9BBA}"/>
+                <a16:creationId xmlns:a16="http://schemas.microsoft.com/office/drawing/2014/main" id="{94EF57F2-C5F7-4634-BE71-708CB4F733AD}"/>
               </a:ext>
             </a:extLst>
           </p:cNvPr>
@@ -8882,7 +8882,7 @@
           <p:cNvPr id="16" name="">
             <a:extLst xmlns:a="http://schemas.openxmlformats.org/drawingml/2006/main">
               <a:ext uri="{FF2B5EF4-FFF2-40B4-BE49-F238E27FC236}">
-                <a16:creationId xmlns:a16="http://schemas.microsoft.com/office/drawing/2014/main" id="{2F794D34-EC77-4F3A-8B36-46EEA748508E}"/>
+                <a16:creationId xmlns:a16="http://schemas.microsoft.com/office/drawing/2014/main" id="{A264568B-BAA5-4ACE-AD20-EE09F91C519A}"/>
               </a:ext>
             </a:extLst>
           </p:cNvPr>
@@ -8917,7 +8917,7 @@
           <p:cNvPr id="17" name="">
             <a:extLst xmlns:a="http://schemas.openxmlformats.org/drawingml/2006/main">
               <a:ext uri="{FF2B5EF4-FFF2-40B4-BE49-F238E27FC236}">
-                <a16:creationId xmlns:a16="http://schemas.microsoft.com/office/drawing/2014/main" id="{23A163A6-E0B3-4E68-BC38-4D4D2D9C68F7}"/>
+                <a16:creationId xmlns:a16="http://schemas.microsoft.com/office/drawing/2014/main" id="{2EFD63AF-662D-498B-994C-7D05AF34E7BA}"/>
               </a:ext>
             </a:extLst>
           </p:cNvPr>
@@ -8979,7 +8979,7 @@
           <p:cNvPr id="18" name="">
             <a:extLst xmlns:a="http://schemas.openxmlformats.org/drawingml/2006/main">
               <a:ext uri="{FF2B5EF4-FFF2-40B4-BE49-F238E27FC236}">
-                <a16:creationId xmlns:a16="http://schemas.microsoft.com/office/drawing/2014/main" id="{B507EE6D-A182-4C61-B75A-3AC2FD810DDF}"/>
+                <a16:creationId xmlns:a16="http://schemas.microsoft.com/office/drawing/2014/main" id="{21F05F76-B450-4595-84E9-5DF273932A87}"/>
               </a:ext>
             </a:extLst>
           </p:cNvPr>
@@ -9010,7 +9010,7 @@
           <p:cNvPr id="19" name="">
             <a:extLst xmlns:a="http://schemas.openxmlformats.org/drawingml/2006/main">
               <a:ext uri="{FF2B5EF4-FFF2-40B4-BE49-F238E27FC236}">
-                <a16:creationId xmlns:a16="http://schemas.microsoft.com/office/drawing/2014/main" id="{E362C9DF-BBFD-4AF7-A082-16EB9AF9340C}"/>
+                <a16:creationId xmlns:a16="http://schemas.microsoft.com/office/drawing/2014/main" id="{6DFA7AF7-E630-4B86-B441-A498902B99F9}"/>
               </a:ext>
             </a:extLst>
           </p:cNvPr>
@@ -9062,7 +9062,7 @@
                 <a:ea typeface="Arial"/>
                 <a:cs typeface="Arial"/>
               </a:rPr>
-              <a:t>r2z-16690ccbe328 · scn-c46e1d86c1</a:t>
+              <a:t>r2z-45c4ba076af9 · scn-e0f12f397e</a:t>
             </a:r>
           </a:p>
         </p:txBody>
@@ -9072,7 +9072,7 @@
           <p:cNvPr id="20" name="">
             <a:extLst xmlns:a="http://schemas.openxmlformats.org/drawingml/2006/main">
               <a:ext uri="{FF2B5EF4-FFF2-40B4-BE49-F238E27FC236}">
-                <a16:creationId xmlns:a16="http://schemas.microsoft.com/office/drawing/2014/main" id="{E956BA3F-0444-461A-9918-E2FDE0075FFB}"/>
+                <a16:creationId xmlns:a16="http://schemas.microsoft.com/office/drawing/2014/main" id="{F943DBF4-A96E-4C58-8D46-A3D341CD06A6}"/>
               </a:ext>
             </a:extLst>
           </p:cNvPr>
@@ -9132,7 +9132,7 @@
     </p:spTree>
     <p:extLst>
       <p:ext uri="{BB962C8B-B14F-4D97-AF65-F5344CB8AC3E}">
-        <p14:creationId xmlns:p14="http://schemas.microsoft.com/office/powerpoint/2010/main" val="1670358029"/>
+        <p14:creationId xmlns:p14="http://schemas.microsoft.com/office/powerpoint/2010/main" val="298330804"/>
       </p:ext>
     </p:extLst>
   </p:cSld>
@@ -9163,7 +9163,7 @@
           <p:cNvPr id="21" name="">
             <a:extLst xmlns:a="http://schemas.openxmlformats.org/drawingml/2006/main">
               <a:ext uri="{FF2B5EF4-FFF2-40B4-BE49-F238E27FC236}">
-                <a16:creationId xmlns:a16="http://schemas.microsoft.com/office/drawing/2014/main" id="{6D269953-9BB7-4E3D-B7B4-B89CF3CDD11E}"/>
+                <a16:creationId xmlns:a16="http://schemas.microsoft.com/office/drawing/2014/main" id="{2360B48D-DCB9-4D31-B879-F62B83DE7209}"/>
               </a:ext>
             </a:extLst>
           </p:cNvPr>
@@ -9225,7 +9225,7 @@
                 <a:latin typeface="Arial"/>
                 <a:ea typeface="Arial"/>
                 <a:cs typeface="Arial"/>
-                <a:hlinkClick xmlns:r="http://schemas.openxmlformats.org/officeDocument/2006/relationships" r:id="R0af38e30172f418d"/>
+                <a:hlinkClick xmlns:r="http://schemas.openxmlformats.org/officeDocument/2006/relationships" r:id="R5c4db1de1e724b13"/>
               </a:rPr>
               <a:t>https://github.com/qjmre23/Route2Zero</a:t>
             </a:r>
@@ -9248,7 +9248,7 @@
                 <a:latin typeface="Arial"/>
                 <a:ea typeface="Arial"/>
                 <a:cs typeface="Arial"/>
-                <a:hlinkClick xmlns:r="http://schemas.openxmlformats.org/officeDocument/2006/relationships" r:id="Rdcf9871cc49f4bee"/>
+                <a:hlinkClick xmlns:r="http://schemas.openxmlformats.org/officeDocument/2006/relationships" r:id="Rfc99eb89eaca436d"/>
               </a:rPr>
               <a:t>https://route2zero.netlify.app/</a:t>
             </a:r>
@@ -9260,7 +9260,7 @@
           <p:cNvPr id="2" name="">
             <a:extLst xmlns:a="http://schemas.openxmlformats.org/drawingml/2006/main">
               <a:ext uri="{FF2B5EF4-FFF2-40B4-BE49-F238E27FC236}">
-                <a16:creationId xmlns:a16="http://schemas.microsoft.com/office/drawing/2014/main" id="{1E9F4E48-8CE9-4C59-A200-E7D41DED8CC1}"/>
+                <a16:creationId xmlns:a16="http://schemas.microsoft.com/office/drawing/2014/main" id="{411D1855-AFE6-4DE7-BBCA-22CEA593FF8B}"/>
               </a:ext>
             </a:extLst>
           </p:cNvPr>
@@ -9322,7 +9322,7 @@
           <p:cNvPr id="3" name="">
             <a:extLst xmlns:a="http://schemas.openxmlformats.org/drawingml/2006/main">
               <a:ext uri="{FF2B5EF4-FFF2-40B4-BE49-F238E27FC236}">
-                <a16:creationId xmlns:a16="http://schemas.microsoft.com/office/drawing/2014/main" id="{5CBE9518-159B-4CDE-8247-A449681B6FA7}"/>
+                <a16:creationId xmlns:a16="http://schemas.microsoft.com/office/drawing/2014/main" id="{86763176-1511-4E5E-863F-3CABC50327D8}"/>
               </a:ext>
             </a:extLst>
           </p:cNvPr>
@@ -9388,8 +9388,8 @@
           <p:nvPr/>
         </p:nvPicPr>
         <p:blipFill>
-          <a:blip xmlns:r="http://schemas.openxmlformats.org/officeDocument/2006/relationships" xmlns:a="http://schemas.openxmlformats.org/drawingml/2006/main" r:embed="R8168f90614b446fb"/>
-          <a:srcRect xmlns:a="http://schemas.openxmlformats.org/drawingml/2006/main" l="0" t="15675" r="0" b="15675"/>
+          <a:blip xmlns:r="http://schemas.openxmlformats.org/officeDocument/2006/relationships" xmlns:a="http://schemas.openxmlformats.org/drawingml/2006/main" r:embed="Ref8773061a864a4e"/>
+          <a:srcRect xmlns:a="http://schemas.openxmlformats.org/drawingml/2006/main" l="0" t="15682" r="0" b="15682"/>
           <a:stretch xmlns:a="http://schemas.openxmlformats.org/drawingml/2006/main">
             <a:fillRect l="0" t="0" r="0" b="0"/>
           </a:stretch>
@@ -9411,7 +9411,7 @@
           <p:cNvPr id="5" name="">
             <a:extLst xmlns:a="http://schemas.openxmlformats.org/drawingml/2006/main">
               <a:ext uri="{FF2B5EF4-FFF2-40B4-BE49-F238E27FC236}">
-                <a16:creationId xmlns:a16="http://schemas.microsoft.com/office/drawing/2014/main" id="{ABA5DC40-3936-40E3-A200-FCA37BE2EA0A}"/>
+                <a16:creationId xmlns:a16="http://schemas.microsoft.com/office/drawing/2014/main" id="{1CF95636-24E9-4380-9128-EB2B541EDE51}"/>
               </a:ext>
             </a:extLst>
           </p:cNvPr>
@@ -9444,7 +9444,7 @@
           <p:cNvPr id="6" name="">
             <a:extLst xmlns:a="http://schemas.openxmlformats.org/drawingml/2006/main">
               <a:ext uri="{FF2B5EF4-FFF2-40B4-BE49-F238E27FC236}">
-                <a16:creationId xmlns:a16="http://schemas.microsoft.com/office/drawing/2014/main" id="{FDBAF86B-BFE1-4519-AB91-A359C79683D1}"/>
+                <a16:creationId xmlns:a16="http://schemas.microsoft.com/office/drawing/2014/main" id="{988CD953-2EE9-4026-879A-6AE4F2963F86}"/>
               </a:ext>
             </a:extLst>
           </p:cNvPr>
@@ -9475,7 +9475,7 @@
           <p:cNvPr id="7" name="">
             <a:extLst xmlns:a="http://schemas.openxmlformats.org/drawingml/2006/main">
               <a:ext uri="{FF2B5EF4-FFF2-40B4-BE49-F238E27FC236}">
-                <a16:creationId xmlns:a16="http://schemas.microsoft.com/office/drawing/2014/main" id="{9C44BAF9-FC9A-4AC9-9DD1-EC9F80CB799D}"/>
+                <a16:creationId xmlns:a16="http://schemas.microsoft.com/office/drawing/2014/main" id="{F3EA18D3-3BAA-4146-BC7B-B53590E5C293}"/>
               </a:ext>
             </a:extLst>
           </p:cNvPr>
@@ -9537,7 +9537,7 @@
           <p:cNvPr id="8" name="">
             <a:extLst xmlns:a="http://schemas.openxmlformats.org/drawingml/2006/main">
               <a:ext uri="{FF2B5EF4-FFF2-40B4-BE49-F238E27FC236}">
-                <a16:creationId xmlns:a16="http://schemas.microsoft.com/office/drawing/2014/main" id="{E08420BC-6599-4390-9B30-2D646EA46AB5}"/>
+                <a16:creationId xmlns:a16="http://schemas.microsoft.com/office/drawing/2014/main" id="{6D78A0A3-3312-48CA-9B00-D6C228671B19}"/>
               </a:ext>
             </a:extLst>
           </p:cNvPr>
@@ -9572,7 +9572,7 @@
           <p:cNvPr id="9" name="">
             <a:extLst xmlns:a="http://schemas.openxmlformats.org/drawingml/2006/main">
               <a:ext uri="{FF2B5EF4-FFF2-40B4-BE49-F238E27FC236}">
-                <a16:creationId xmlns:a16="http://schemas.microsoft.com/office/drawing/2014/main" id="{94AC3CA3-F494-4CA1-A3D8-89A49060FC7D}"/>
+                <a16:creationId xmlns:a16="http://schemas.microsoft.com/office/drawing/2014/main" id="{332B9D40-6378-4319-A5E7-5FBCDAA0D9AF}"/>
               </a:ext>
             </a:extLst>
           </p:cNvPr>
@@ -9634,7 +9634,7 @@
           <p:cNvPr id="10" name="">
             <a:extLst xmlns:a="http://schemas.openxmlformats.org/drawingml/2006/main">
               <a:ext uri="{FF2B5EF4-FFF2-40B4-BE49-F238E27FC236}">
-                <a16:creationId xmlns:a16="http://schemas.microsoft.com/office/drawing/2014/main" id="{107D8B6E-CBF5-49B3-A281-4D443CAC0FC1}"/>
+                <a16:creationId xmlns:a16="http://schemas.microsoft.com/office/drawing/2014/main" id="{AF0A6380-FE92-46D3-BB9F-2E8BBEFEB958}"/>
               </a:ext>
             </a:extLst>
           </p:cNvPr>
@@ -9665,7 +9665,7 @@
           <p:cNvPr id="11" name="">
             <a:extLst xmlns:a="http://schemas.openxmlformats.org/drawingml/2006/main">
               <a:ext uri="{FF2B5EF4-FFF2-40B4-BE49-F238E27FC236}">
-                <a16:creationId xmlns:a16="http://schemas.microsoft.com/office/drawing/2014/main" id="{2DF0D488-B920-429F-A97F-1B43ABFD8958}"/>
+                <a16:creationId xmlns:a16="http://schemas.microsoft.com/office/drawing/2014/main" id="{EEAD0B3F-D131-4621-AB60-6763D709180A}"/>
               </a:ext>
             </a:extLst>
           </p:cNvPr>
@@ -9727,7 +9727,7 @@
           <p:cNvPr id="12" name="">
             <a:extLst xmlns:a="http://schemas.openxmlformats.org/drawingml/2006/main">
               <a:ext uri="{FF2B5EF4-FFF2-40B4-BE49-F238E27FC236}">
-                <a16:creationId xmlns:a16="http://schemas.microsoft.com/office/drawing/2014/main" id="{57366DA7-C72F-403E-A5BC-1170325C9EDD}"/>
+                <a16:creationId xmlns:a16="http://schemas.microsoft.com/office/drawing/2014/main" id="{AE0AFCEA-36B6-4F3B-87F8-D12AE11BC14A}"/>
               </a:ext>
             </a:extLst>
           </p:cNvPr>
@@ -9762,7 +9762,7 @@
           <p:cNvPr id="13" name="">
             <a:extLst xmlns:a="http://schemas.openxmlformats.org/drawingml/2006/main">
               <a:ext uri="{FF2B5EF4-FFF2-40B4-BE49-F238E27FC236}">
-                <a16:creationId xmlns:a16="http://schemas.microsoft.com/office/drawing/2014/main" id="{22AE7590-3C55-4150-9A0C-F9E5CE062AE8}"/>
+                <a16:creationId xmlns:a16="http://schemas.microsoft.com/office/drawing/2014/main" id="{B5DE75FC-737D-4F58-8413-51B544C63F01}"/>
               </a:ext>
             </a:extLst>
           </p:cNvPr>
@@ -9824,7 +9824,7 @@
           <p:cNvPr id="14" name="">
             <a:extLst xmlns:a="http://schemas.openxmlformats.org/drawingml/2006/main">
               <a:ext uri="{FF2B5EF4-FFF2-40B4-BE49-F238E27FC236}">
-                <a16:creationId xmlns:a16="http://schemas.microsoft.com/office/drawing/2014/main" id="{0BA26EF6-7FE4-4684-A152-D36A2839EBBC}"/>
+                <a16:creationId xmlns:a16="http://schemas.microsoft.com/office/drawing/2014/main" id="{496897F9-A35C-40F6-8619-F3CFFC38872B}"/>
               </a:ext>
             </a:extLst>
           </p:cNvPr>
@@ -9855,7 +9855,7 @@
           <p:cNvPr id="15" name="">
             <a:extLst xmlns:a="http://schemas.openxmlformats.org/drawingml/2006/main">
               <a:ext uri="{FF2B5EF4-FFF2-40B4-BE49-F238E27FC236}">
-                <a16:creationId xmlns:a16="http://schemas.microsoft.com/office/drawing/2014/main" id="{F83B2431-AC24-470D-BDBE-3EF58A64AAB6}"/>
+                <a16:creationId xmlns:a16="http://schemas.microsoft.com/office/drawing/2014/main" id="{AF3B0CF0-62E4-43E6-8EFB-C5A05C4982BD}"/>
               </a:ext>
             </a:extLst>
           </p:cNvPr>
@@ -9917,7 +9917,7 @@
           <p:cNvPr id="16" name="">
             <a:extLst xmlns:a="http://schemas.openxmlformats.org/drawingml/2006/main">
               <a:ext uri="{FF2B5EF4-FFF2-40B4-BE49-F238E27FC236}">
-                <a16:creationId xmlns:a16="http://schemas.microsoft.com/office/drawing/2014/main" id="{C4FBD3CE-32B4-44AC-8E91-C71E45507D14}"/>
+                <a16:creationId xmlns:a16="http://schemas.microsoft.com/office/drawing/2014/main" id="{6BE5DB8A-FB2B-41C3-9BD4-11897AD9E627}"/>
               </a:ext>
             </a:extLst>
           </p:cNvPr>
@@ -9952,7 +9952,7 @@
           <p:cNvPr id="17" name="">
             <a:extLst xmlns:a="http://schemas.openxmlformats.org/drawingml/2006/main">
               <a:ext uri="{FF2B5EF4-FFF2-40B4-BE49-F238E27FC236}">
-                <a16:creationId xmlns:a16="http://schemas.microsoft.com/office/drawing/2014/main" id="{791E7382-BAF6-4311-B508-82C59D2C69CD}"/>
+                <a16:creationId xmlns:a16="http://schemas.microsoft.com/office/drawing/2014/main" id="{8330167D-B66F-491C-A53D-528A2BE3A9EB}"/>
               </a:ext>
             </a:extLst>
           </p:cNvPr>
@@ -10014,7 +10014,7 @@
           <p:cNvPr id="18" name="">
             <a:extLst xmlns:a="http://schemas.openxmlformats.org/drawingml/2006/main">
               <a:ext uri="{FF2B5EF4-FFF2-40B4-BE49-F238E27FC236}">
-                <a16:creationId xmlns:a16="http://schemas.microsoft.com/office/drawing/2014/main" id="{E3C293F3-A325-43DE-A479-375CD4FA0F07}"/>
+                <a16:creationId xmlns:a16="http://schemas.microsoft.com/office/drawing/2014/main" id="{D55FF083-371B-4BF7-A297-6EFA39BF06B6}"/>
               </a:ext>
             </a:extLst>
           </p:cNvPr>
@@ -10045,7 +10045,7 @@
           <p:cNvPr id="19" name="">
             <a:extLst xmlns:a="http://schemas.openxmlformats.org/drawingml/2006/main">
               <a:ext uri="{FF2B5EF4-FFF2-40B4-BE49-F238E27FC236}">
-                <a16:creationId xmlns:a16="http://schemas.microsoft.com/office/drawing/2014/main" id="{94ED3271-F384-40A7-B03A-F1B073D2C93C}"/>
+                <a16:creationId xmlns:a16="http://schemas.microsoft.com/office/drawing/2014/main" id="{A9B02DA2-ACA8-4EFF-9AF1-41C429628F3E}"/>
               </a:ext>
             </a:extLst>
           </p:cNvPr>
@@ -10097,7 +10097,7 @@
                 <a:ea typeface="Arial"/>
                 <a:cs typeface="Arial"/>
               </a:rPr>
-              <a:t>r2z-16690ccbe328 · scn-c46e1d86c1</a:t>
+              <a:t>r2z-45c4ba076af9 · scn-e0f12f397e</a:t>
             </a:r>
           </a:p>
         </p:txBody>
@@ -10107,7 +10107,7 @@
           <p:cNvPr id="20" name="">
             <a:extLst xmlns:a="http://schemas.openxmlformats.org/drawingml/2006/main">
               <a:ext uri="{FF2B5EF4-FFF2-40B4-BE49-F238E27FC236}">
-                <a16:creationId xmlns:a16="http://schemas.microsoft.com/office/drawing/2014/main" id="{A49B1D75-9626-4183-A882-884BB4F8E34E}"/>
+                <a16:creationId xmlns:a16="http://schemas.microsoft.com/office/drawing/2014/main" id="{0F807CE2-1C72-4E81-84B8-31C9EDAE42E9}"/>
               </a:ext>
             </a:extLst>
           </p:cNvPr>
@@ -10167,7 +10167,7 @@
     </p:spTree>
     <p:extLst>
       <p:ext uri="{BB962C8B-B14F-4D97-AF65-F5344CB8AC3E}">
-        <p14:creationId xmlns:p14="http://schemas.microsoft.com/office/powerpoint/2010/main" val="726724279"/>
+        <p14:creationId xmlns:p14="http://schemas.microsoft.com/office/powerpoint/2010/main" val="720463715"/>
       </p:ext>
     </p:extLst>
   </p:cSld>
@@ -10198,7 +10198,7 @@
           <p:cNvPr id="21" name="">
             <a:extLst xmlns:a="http://schemas.openxmlformats.org/drawingml/2006/main">
               <a:ext uri="{FF2B5EF4-FFF2-40B4-BE49-F238E27FC236}">
-                <a16:creationId xmlns:a16="http://schemas.microsoft.com/office/drawing/2014/main" id="{F98751A4-4495-448C-AF1F-B06F00EBAD2B}"/>
+                <a16:creationId xmlns:a16="http://schemas.microsoft.com/office/drawing/2014/main" id="{28B3C04F-A9D3-4092-8FFF-E8A9AE25EDD5}"/>
               </a:ext>
             </a:extLst>
           </p:cNvPr>
@@ -10260,7 +10260,7 @@
                 <a:latin typeface="Arial"/>
                 <a:ea typeface="Arial"/>
                 <a:cs typeface="Arial"/>
-                <a:hlinkClick xmlns:r="http://schemas.openxmlformats.org/officeDocument/2006/relationships" r:id="R78caf57ec38d4b29"/>
+                <a:hlinkClick xmlns:r="http://schemas.openxmlformats.org/officeDocument/2006/relationships" r:id="R161225931eac4f14"/>
               </a:rPr>
               <a:t>https://github.com/qjmre23/Route2Zero</a:t>
             </a:r>
@@ -10283,7 +10283,7 @@
                 <a:latin typeface="Arial"/>
                 <a:ea typeface="Arial"/>
                 <a:cs typeface="Arial"/>
-                <a:hlinkClick xmlns:r="http://schemas.openxmlformats.org/officeDocument/2006/relationships" r:id="R47ec8f8171f44aee"/>
+                <a:hlinkClick xmlns:r="http://schemas.openxmlformats.org/officeDocument/2006/relationships" r:id="Raaddd1d3705a496a"/>
               </a:rPr>
               <a:t>https://route2zero.netlify.app/</a:t>
             </a:r>
@@ -10295,7 +10295,7 @@
           <p:cNvPr id="2" name="">
             <a:extLst xmlns:a="http://schemas.openxmlformats.org/drawingml/2006/main">
               <a:ext uri="{FF2B5EF4-FFF2-40B4-BE49-F238E27FC236}">
-                <a16:creationId xmlns:a16="http://schemas.microsoft.com/office/drawing/2014/main" id="{BC2A254C-17AD-4F71-84B6-8071A396B3FA}"/>
+                <a16:creationId xmlns:a16="http://schemas.microsoft.com/office/drawing/2014/main" id="{C95EAFF6-DA9A-4100-886B-089E9E3CAF7D}"/>
               </a:ext>
             </a:extLst>
           </p:cNvPr>
@@ -10357,7 +10357,7 @@
           <p:cNvPr id="3" name="">
             <a:extLst xmlns:a="http://schemas.openxmlformats.org/drawingml/2006/main">
               <a:ext uri="{FF2B5EF4-FFF2-40B4-BE49-F238E27FC236}">
-                <a16:creationId xmlns:a16="http://schemas.microsoft.com/office/drawing/2014/main" id="{6AC36435-AFA5-4DC5-B8E4-7AD5A6E50981}"/>
+                <a16:creationId xmlns:a16="http://schemas.microsoft.com/office/drawing/2014/main" id="{9EA276C1-16E5-4769-8DE8-E7EF5DDA3463}"/>
               </a:ext>
             </a:extLst>
           </p:cNvPr>
@@ -10423,8 +10423,8 @@
           <p:nvPr/>
         </p:nvPicPr>
         <p:blipFill>
-          <a:blip xmlns:r="http://schemas.openxmlformats.org/officeDocument/2006/relationships" xmlns:a="http://schemas.openxmlformats.org/drawingml/2006/main" r:embed="Rfdff9e85474447f6"/>
-          <a:srcRect xmlns:a="http://schemas.openxmlformats.org/drawingml/2006/main" l="0" t="15675" r="0" b="15675"/>
+          <a:blip xmlns:r="http://schemas.openxmlformats.org/officeDocument/2006/relationships" xmlns:a="http://schemas.openxmlformats.org/drawingml/2006/main" r:embed="R7c995d37b94e4ff4"/>
+          <a:srcRect xmlns:a="http://schemas.openxmlformats.org/drawingml/2006/main" l="0" t="15682" r="0" b="15682"/>
           <a:stretch xmlns:a="http://schemas.openxmlformats.org/drawingml/2006/main">
             <a:fillRect l="0" t="0" r="0" b="0"/>
           </a:stretch>
@@ -10446,7 +10446,7 @@
           <p:cNvPr id="5" name="">
             <a:extLst xmlns:a="http://schemas.openxmlformats.org/drawingml/2006/main">
               <a:ext uri="{FF2B5EF4-FFF2-40B4-BE49-F238E27FC236}">
-                <a16:creationId xmlns:a16="http://schemas.microsoft.com/office/drawing/2014/main" id="{C32C5C9F-C1EC-4E5D-B3E5-307ED3AD0EE0}"/>
+                <a16:creationId xmlns:a16="http://schemas.microsoft.com/office/drawing/2014/main" id="{EC1E8F63-C824-42FB-9844-3A62CC7DF0F7}"/>
               </a:ext>
             </a:extLst>
           </p:cNvPr>
@@ -10479,7 +10479,7 @@
           <p:cNvPr id="6" name="">
             <a:extLst xmlns:a="http://schemas.openxmlformats.org/drawingml/2006/main">
               <a:ext uri="{FF2B5EF4-FFF2-40B4-BE49-F238E27FC236}">
-                <a16:creationId xmlns:a16="http://schemas.microsoft.com/office/drawing/2014/main" id="{9BE46AD2-F51C-42FD-A237-201B113F57EA}"/>
+                <a16:creationId xmlns:a16="http://schemas.microsoft.com/office/drawing/2014/main" id="{A890230F-7916-44FB-85CF-27AE1C070837}"/>
               </a:ext>
             </a:extLst>
           </p:cNvPr>
@@ -10510,7 +10510,7 @@
           <p:cNvPr id="7" name="">
             <a:extLst xmlns:a="http://schemas.openxmlformats.org/drawingml/2006/main">
               <a:ext uri="{FF2B5EF4-FFF2-40B4-BE49-F238E27FC236}">
-                <a16:creationId xmlns:a16="http://schemas.microsoft.com/office/drawing/2014/main" id="{6C96064A-D1BE-4C80-9D59-397A5E934E5F}"/>
+                <a16:creationId xmlns:a16="http://schemas.microsoft.com/office/drawing/2014/main" id="{7A8A1669-2D2C-41AB-B155-4F9D28760379}"/>
               </a:ext>
             </a:extLst>
           </p:cNvPr>
@@ -10572,7 +10572,7 @@
           <p:cNvPr id="8" name="">
             <a:extLst xmlns:a="http://schemas.openxmlformats.org/drawingml/2006/main">
               <a:ext uri="{FF2B5EF4-FFF2-40B4-BE49-F238E27FC236}">
-                <a16:creationId xmlns:a16="http://schemas.microsoft.com/office/drawing/2014/main" id="{12615894-8DE9-4DF6-BE2D-38F8B84872D2}"/>
+                <a16:creationId xmlns:a16="http://schemas.microsoft.com/office/drawing/2014/main" id="{7BE0B37B-9BC5-4B61-B44D-B729D540BEA5}"/>
               </a:ext>
             </a:extLst>
           </p:cNvPr>
@@ -10607,7 +10607,7 @@
           <p:cNvPr id="9" name="">
             <a:extLst xmlns:a="http://schemas.openxmlformats.org/drawingml/2006/main">
               <a:ext uri="{FF2B5EF4-FFF2-40B4-BE49-F238E27FC236}">
-                <a16:creationId xmlns:a16="http://schemas.microsoft.com/office/drawing/2014/main" id="{35BF0E2C-CAD6-45B9-81A5-FB8BF9CB04E9}"/>
+                <a16:creationId xmlns:a16="http://schemas.microsoft.com/office/drawing/2014/main" id="{D1C363EC-061B-4F50-80DF-42C9A59F9C70}"/>
               </a:ext>
             </a:extLst>
           </p:cNvPr>
@@ -10669,7 +10669,7 @@
           <p:cNvPr id="10" name="">
             <a:extLst xmlns:a="http://schemas.openxmlformats.org/drawingml/2006/main">
               <a:ext uri="{FF2B5EF4-FFF2-40B4-BE49-F238E27FC236}">
-                <a16:creationId xmlns:a16="http://schemas.microsoft.com/office/drawing/2014/main" id="{4AE4E98B-F9C4-4EEF-A349-3A24772C8002}"/>
+                <a16:creationId xmlns:a16="http://schemas.microsoft.com/office/drawing/2014/main" id="{6FF047FC-6096-4491-A3D9-01EC6B814746}"/>
               </a:ext>
             </a:extLst>
           </p:cNvPr>
@@ -10700,7 +10700,7 @@
           <p:cNvPr id="11" name="">
             <a:extLst xmlns:a="http://schemas.openxmlformats.org/drawingml/2006/main">
               <a:ext uri="{FF2B5EF4-FFF2-40B4-BE49-F238E27FC236}">
-                <a16:creationId xmlns:a16="http://schemas.microsoft.com/office/drawing/2014/main" id="{0FF09139-F6E2-40CE-A4F5-EBFC6C3F3F69}"/>
+                <a16:creationId xmlns:a16="http://schemas.microsoft.com/office/drawing/2014/main" id="{FAD30834-6A7A-4CF6-B1CB-6CFF05C5F84F}"/>
               </a:ext>
             </a:extLst>
           </p:cNvPr>
@@ -10762,7 +10762,7 @@
           <p:cNvPr id="12" name="">
             <a:extLst xmlns:a="http://schemas.openxmlformats.org/drawingml/2006/main">
               <a:ext uri="{FF2B5EF4-FFF2-40B4-BE49-F238E27FC236}">
-                <a16:creationId xmlns:a16="http://schemas.microsoft.com/office/drawing/2014/main" id="{DD796656-8BF7-4030-AC84-68A2CF89204A}"/>
+                <a16:creationId xmlns:a16="http://schemas.microsoft.com/office/drawing/2014/main" id="{72E02D39-58FE-4C42-BE60-6C99F1295FE7}"/>
               </a:ext>
             </a:extLst>
           </p:cNvPr>
@@ -10797,7 +10797,7 @@
           <p:cNvPr id="13" name="">
             <a:extLst xmlns:a="http://schemas.openxmlformats.org/drawingml/2006/main">
               <a:ext uri="{FF2B5EF4-FFF2-40B4-BE49-F238E27FC236}">
-                <a16:creationId xmlns:a16="http://schemas.microsoft.com/office/drawing/2014/main" id="{D57C117D-E58A-4671-A3A3-2EAB47FC4F4B}"/>
+                <a16:creationId xmlns:a16="http://schemas.microsoft.com/office/drawing/2014/main" id="{0939959A-F178-4946-A6A3-956ACF9B0A4F}"/>
               </a:ext>
             </a:extLst>
           </p:cNvPr>
@@ -10859,7 +10859,7 @@
           <p:cNvPr id="14" name="">
             <a:extLst xmlns:a="http://schemas.openxmlformats.org/drawingml/2006/main">
               <a:ext uri="{FF2B5EF4-FFF2-40B4-BE49-F238E27FC236}">
-                <a16:creationId xmlns:a16="http://schemas.microsoft.com/office/drawing/2014/main" id="{B482FF09-3A97-413A-AE6B-672E9A18C61E}"/>
+                <a16:creationId xmlns:a16="http://schemas.microsoft.com/office/drawing/2014/main" id="{A282BA7B-9DF0-41B1-8E43-E7AE0523D376}"/>
               </a:ext>
             </a:extLst>
           </p:cNvPr>
@@ -10890,7 +10890,7 @@
           <p:cNvPr id="15" name="">
             <a:extLst xmlns:a="http://schemas.openxmlformats.org/drawingml/2006/main">
               <a:ext uri="{FF2B5EF4-FFF2-40B4-BE49-F238E27FC236}">
-                <a16:creationId xmlns:a16="http://schemas.microsoft.com/office/drawing/2014/main" id="{10C7E1BE-0414-4BE5-BA41-2D78012A8900}"/>
+                <a16:creationId xmlns:a16="http://schemas.microsoft.com/office/drawing/2014/main" id="{02FAC867-3043-44C9-A6E0-CE3BC9D3B0BD}"/>
               </a:ext>
             </a:extLst>
           </p:cNvPr>
@@ -10952,7 +10952,7 @@
           <p:cNvPr id="16" name="">
             <a:extLst xmlns:a="http://schemas.openxmlformats.org/drawingml/2006/main">
               <a:ext uri="{FF2B5EF4-FFF2-40B4-BE49-F238E27FC236}">
-                <a16:creationId xmlns:a16="http://schemas.microsoft.com/office/drawing/2014/main" id="{41C413FC-7A35-4DBB-98C7-492545A145E7}"/>
+                <a16:creationId xmlns:a16="http://schemas.microsoft.com/office/drawing/2014/main" id="{9B0B9A97-E677-4A98-8F2B-1943A13682FD}"/>
               </a:ext>
             </a:extLst>
           </p:cNvPr>
@@ -10987,7 +10987,7 @@
           <p:cNvPr id="17" name="">
             <a:extLst xmlns:a="http://schemas.openxmlformats.org/drawingml/2006/main">
               <a:ext uri="{FF2B5EF4-FFF2-40B4-BE49-F238E27FC236}">
-                <a16:creationId xmlns:a16="http://schemas.microsoft.com/office/drawing/2014/main" id="{C072A061-E4D5-4D91-9F27-865C547B9572}"/>
+                <a16:creationId xmlns:a16="http://schemas.microsoft.com/office/drawing/2014/main" id="{983272AB-8C3E-4863-8B28-29E3946F1B61}"/>
               </a:ext>
             </a:extLst>
           </p:cNvPr>
@@ -11049,7 +11049,7 @@
           <p:cNvPr id="18" name="">
             <a:extLst xmlns:a="http://schemas.openxmlformats.org/drawingml/2006/main">
               <a:ext uri="{FF2B5EF4-FFF2-40B4-BE49-F238E27FC236}">
-                <a16:creationId xmlns:a16="http://schemas.microsoft.com/office/drawing/2014/main" id="{5A328498-1E1D-4CEE-BB8F-78DAC6062E42}"/>
+                <a16:creationId xmlns:a16="http://schemas.microsoft.com/office/drawing/2014/main" id="{4CE2A13C-4AD8-4F0B-9106-118463AE4632}"/>
               </a:ext>
             </a:extLst>
           </p:cNvPr>
@@ -11080,7 +11080,7 @@
           <p:cNvPr id="19" name="">
             <a:extLst xmlns:a="http://schemas.openxmlformats.org/drawingml/2006/main">
               <a:ext uri="{FF2B5EF4-FFF2-40B4-BE49-F238E27FC236}">
-                <a16:creationId xmlns:a16="http://schemas.microsoft.com/office/drawing/2014/main" id="{EBB71DB1-9FB7-4BFC-B7CD-89A6F602C93D}"/>
+                <a16:creationId xmlns:a16="http://schemas.microsoft.com/office/drawing/2014/main" id="{3FCA7B85-2DCD-4B80-B385-710864510059}"/>
               </a:ext>
             </a:extLst>
           </p:cNvPr>
@@ -11132,7 +11132,7 @@
                 <a:ea typeface="Arial"/>
                 <a:cs typeface="Arial"/>
               </a:rPr>
-              <a:t>r2z-16690ccbe328 · scn-c46e1d86c1</a:t>
+              <a:t>r2z-45c4ba076af9 · scn-e0f12f397e</a:t>
             </a:r>
           </a:p>
         </p:txBody>
@@ -11142,7 +11142,7 @@
           <p:cNvPr id="20" name="">
             <a:extLst xmlns:a="http://schemas.openxmlformats.org/drawingml/2006/main">
               <a:ext uri="{FF2B5EF4-FFF2-40B4-BE49-F238E27FC236}">
-                <a16:creationId xmlns:a16="http://schemas.microsoft.com/office/drawing/2014/main" id="{F2557379-2240-485A-A9DD-D0ACE2815DA5}"/>
+                <a16:creationId xmlns:a16="http://schemas.microsoft.com/office/drawing/2014/main" id="{014F18E0-A342-414B-AB51-F1BDB3AB660B}"/>
               </a:ext>
             </a:extLst>
           </p:cNvPr>
@@ -11202,7 +11202,7 @@
     </p:spTree>
     <p:extLst>
       <p:ext uri="{BB962C8B-B14F-4D97-AF65-F5344CB8AC3E}">
-        <p14:creationId xmlns:p14="http://schemas.microsoft.com/office/powerpoint/2010/main" val="1834970186"/>
+        <p14:creationId xmlns:p14="http://schemas.microsoft.com/office/powerpoint/2010/main" val="751568943"/>
       </p:ext>
     </p:extLst>
   </p:cSld>
@@ -11233,7 +11233,7 @@
           <p:cNvPr id="21" name="">
             <a:extLst xmlns:a="http://schemas.openxmlformats.org/drawingml/2006/main">
               <a:ext uri="{FF2B5EF4-FFF2-40B4-BE49-F238E27FC236}">
-                <a16:creationId xmlns:a16="http://schemas.microsoft.com/office/drawing/2014/main" id="{C51691F2-516C-49E9-A4EC-D9133E09C56A}"/>
+                <a16:creationId xmlns:a16="http://schemas.microsoft.com/office/drawing/2014/main" id="{F8625C3B-4191-4F1C-86C3-8D0334673B71}"/>
               </a:ext>
             </a:extLst>
           </p:cNvPr>
@@ -11295,7 +11295,7 @@
                 <a:latin typeface="Arial"/>
                 <a:ea typeface="Arial"/>
                 <a:cs typeface="Arial"/>
-                <a:hlinkClick xmlns:r="http://schemas.openxmlformats.org/officeDocument/2006/relationships" r:id="Rac3c46383a4649cf"/>
+                <a:hlinkClick xmlns:r="http://schemas.openxmlformats.org/officeDocument/2006/relationships" r:id="R5b9b7b1229494e1b"/>
               </a:rPr>
               <a:t>https://github.com/qjmre23/Route2Zero</a:t>
             </a:r>
@@ -11318,7 +11318,7 @@
                 <a:latin typeface="Arial"/>
                 <a:ea typeface="Arial"/>
                 <a:cs typeface="Arial"/>
-                <a:hlinkClick xmlns:r="http://schemas.openxmlformats.org/officeDocument/2006/relationships" r:id="Rae6a91cdda13417a"/>
+                <a:hlinkClick xmlns:r="http://schemas.openxmlformats.org/officeDocument/2006/relationships" r:id="R9d1ba7e6525c42e8"/>
               </a:rPr>
               <a:t>https://route2zero.netlify.app/</a:t>
             </a:r>
@@ -11330,7 +11330,7 @@
           <p:cNvPr id="2" name="">
             <a:extLst xmlns:a="http://schemas.openxmlformats.org/drawingml/2006/main">
               <a:ext uri="{FF2B5EF4-FFF2-40B4-BE49-F238E27FC236}">
-                <a16:creationId xmlns:a16="http://schemas.microsoft.com/office/drawing/2014/main" id="{EE4B0651-AEFB-45FE-B229-7F869B9F90B8}"/>
+                <a16:creationId xmlns:a16="http://schemas.microsoft.com/office/drawing/2014/main" id="{3EAB013D-24D0-42F5-81B0-7B3F9A86F48A}"/>
               </a:ext>
             </a:extLst>
           </p:cNvPr>
@@ -11392,7 +11392,7 @@
           <p:cNvPr id="3" name="">
             <a:extLst xmlns:a="http://schemas.openxmlformats.org/drawingml/2006/main">
               <a:ext uri="{FF2B5EF4-FFF2-40B4-BE49-F238E27FC236}">
-                <a16:creationId xmlns:a16="http://schemas.microsoft.com/office/drawing/2014/main" id="{6E9F498A-462C-406D-A22D-0AC19578E2DF}"/>
+                <a16:creationId xmlns:a16="http://schemas.microsoft.com/office/drawing/2014/main" id="{B76245D5-9421-41A9-8CC3-9DF610F0C55A}"/>
               </a:ext>
             </a:extLst>
           </p:cNvPr>
@@ -11458,8 +11458,8 @@
           <p:nvPr/>
         </p:nvPicPr>
         <p:blipFill>
-          <a:blip xmlns:r="http://schemas.openxmlformats.org/officeDocument/2006/relationships" xmlns:a="http://schemas.openxmlformats.org/drawingml/2006/main" r:embed="Rdde91c21660f4da4"/>
-          <a:srcRect xmlns:a="http://schemas.openxmlformats.org/drawingml/2006/main" l="0" t="15675" r="0" b="15675"/>
+          <a:blip xmlns:r="http://schemas.openxmlformats.org/officeDocument/2006/relationships" xmlns:a="http://schemas.openxmlformats.org/drawingml/2006/main" r:embed="R182e358f2ea14dc3"/>
+          <a:srcRect xmlns:a="http://schemas.openxmlformats.org/drawingml/2006/main" l="0" t="15682" r="0" b="15682"/>
           <a:stretch xmlns:a="http://schemas.openxmlformats.org/drawingml/2006/main">
             <a:fillRect l="0" t="0" r="0" b="0"/>
           </a:stretch>
@@ -11481,7 +11481,7 @@
           <p:cNvPr id="5" name="">
             <a:extLst xmlns:a="http://schemas.openxmlformats.org/drawingml/2006/main">
               <a:ext uri="{FF2B5EF4-FFF2-40B4-BE49-F238E27FC236}">
-                <a16:creationId xmlns:a16="http://schemas.microsoft.com/office/drawing/2014/main" id="{2E469D08-5726-472D-A3F1-FD571890F718}"/>
+                <a16:creationId xmlns:a16="http://schemas.microsoft.com/office/drawing/2014/main" id="{FB5AB50A-07C6-46A7-A08F-8BF76BA112BE}"/>
               </a:ext>
             </a:extLst>
           </p:cNvPr>
@@ -11514,7 +11514,7 @@
           <p:cNvPr id="6" name="">
             <a:extLst xmlns:a="http://schemas.openxmlformats.org/drawingml/2006/main">
               <a:ext uri="{FF2B5EF4-FFF2-40B4-BE49-F238E27FC236}">
-                <a16:creationId xmlns:a16="http://schemas.microsoft.com/office/drawing/2014/main" id="{0EBC761E-941F-4387-9BD0-7985A31D0A00}"/>
+                <a16:creationId xmlns:a16="http://schemas.microsoft.com/office/drawing/2014/main" id="{6448EED7-7AB0-4753-B603-D416611440A3}"/>
               </a:ext>
             </a:extLst>
           </p:cNvPr>
@@ -11545,7 +11545,7 @@
           <p:cNvPr id="7" name="">
             <a:extLst xmlns:a="http://schemas.openxmlformats.org/drawingml/2006/main">
               <a:ext uri="{FF2B5EF4-FFF2-40B4-BE49-F238E27FC236}">
-                <a16:creationId xmlns:a16="http://schemas.microsoft.com/office/drawing/2014/main" id="{9EAED630-E1DC-4832-BE0C-671B909EF82B}"/>
+                <a16:creationId xmlns:a16="http://schemas.microsoft.com/office/drawing/2014/main" id="{D11FF9E8-284D-4294-8C34-3EAD602471B1}"/>
               </a:ext>
             </a:extLst>
           </p:cNvPr>
@@ -11607,7 +11607,7 @@
           <p:cNvPr id="8" name="">
             <a:extLst xmlns:a="http://schemas.openxmlformats.org/drawingml/2006/main">
               <a:ext uri="{FF2B5EF4-FFF2-40B4-BE49-F238E27FC236}">
-                <a16:creationId xmlns:a16="http://schemas.microsoft.com/office/drawing/2014/main" id="{31C0C847-BD23-4164-86B2-218444B5E3CB}"/>
+                <a16:creationId xmlns:a16="http://schemas.microsoft.com/office/drawing/2014/main" id="{B2F9EF93-5FAC-4020-95D9-26908E97D776}"/>
               </a:ext>
             </a:extLst>
           </p:cNvPr>
@@ -11642,7 +11642,7 @@
           <p:cNvPr id="9" name="">
             <a:extLst xmlns:a="http://schemas.openxmlformats.org/drawingml/2006/main">
               <a:ext uri="{FF2B5EF4-FFF2-40B4-BE49-F238E27FC236}">
-                <a16:creationId xmlns:a16="http://schemas.microsoft.com/office/drawing/2014/main" id="{E226F75B-2A2B-47C4-B457-CF9CD7F0FB44}"/>
+                <a16:creationId xmlns:a16="http://schemas.microsoft.com/office/drawing/2014/main" id="{E2DE7E4D-E3BE-422F-AF0B-931FB2542595}"/>
               </a:ext>
             </a:extLst>
           </p:cNvPr>
@@ -11704,7 +11704,7 @@
           <p:cNvPr id="10" name="">
             <a:extLst xmlns:a="http://schemas.openxmlformats.org/drawingml/2006/main">
               <a:ext uri="{FF2B5EF4-FFF2-40B4-BE49-F238E27FC236}">
-                <a16:creationId xmlns:a16="http://schemas.microsoft.com/office/drawing/2014/main" id="{05F5B5B8-AD90-4002-8DBA-4F105DF235BE}"/>
+                <a16:creationId xmlns:a16="http://schemas.microsoft.com/office/drawing/2014/main" id="{AD37EC6E-883E-4FF2-A4FE-AB526DD9B70C}"/>
               </a:ext>
             </a:extLst>
           </p:cNvPr>
@@ -11735,7 +11735,7 @@
           <p:cNvPr id="11" name="">
             <a:extLst xmlns:a="http://schemas.openxmlformats.org/drawingml/2006/main">
               <a:ext uri="{FF2B5EF4-FFF2-40B4-BE49-F238E27FC236}">
-                <a16:creationId xmlns:a16="http://schemas.microsoft.com/office/drawing/2014/main" id="{52FAA658-667C-4031-80CC-A3828F123043}"/>
+                <a16:creationId xmlns:a16="http://schemas.microsoft.com/office/drawing/2014/main" id="{64C67C3B-4E77-43A3-896B-9011F9785B8B}"/>
               </a:ext>
             </a:extLst>
           </p:cNvPr>
@@ -11797,7 +11797,7 @@
           <p:cNvPr id="12" name="">
             <a:extLst xmlns:a="http://schemas.openxmlformats.org/drawingml/2006/main">
               <a:ext uri="{FF2B5EF4-FFF2-40B4-BE49-F238E27FC236}">
-                <a16:creationId xmlns:a16="http://schemas.microsoft.com/office/drawing/2014/main" id="{C54DAD4D-425E-4056-9B32-B6780859125F}"/>
+                <a16:creationId xmlns:a16="http://schemas.microsoft.com/office/drawing/2014/main" id="{22224937-9098-40E2-B7D9-FF9714BE5754}"/>
               </a:ext>
             </a:extLst>
           </p:cNvPr>
@@ -11832,7 +11832,7 @@
           <p:cNvPr id="13" name="">
             <a:extLst xmlns:a="http://schemas.openxmlformats.org/drawingml/2006/main">
               <a:ext uri="{FF2B5EF4-FFF2-40B4-BE49-F238E27FC236}">
-                <a16:creationId xmlns:a16="http://schemas.microsoft.com/office/drawing/2014/main" id="{D29296B0-D9E1-402C-ADDB-3F70F84D3832}"/>
+                <a16:creationId xmlns:a16="http://schemas.microsoft.com/office/drawing/2014/main" id="{8FC41D42-8650-4824-9136-957F46E58E2A}"/>
               </a:ext>
             </a:extLst>
           </p:cNvPr>
@@ -11894,7 +11894,7 @@
           <p:cNvPr id="14" name="">
             <a:extLst xmlns:a="http://schemas.openxmlformats.org/drawingml/2006/main">
               <a:ext uri="{FF2B5EF4-FFF2-40B4-BE49-F238E27FC236}">
-                <a16:creationId xmlns:a16="http://schemas.microsoft.com/office/drawing/2014/main" id="{03669AB9-0530-4845-9966-342D6B4C2030}"/>
+                <a16:creationId xmlns:a16="http://schemas.microsoft.com/office/drawing/2014/main" id="{35D74737-B943-413D-90BC-CBFD58193AB8}"/>
               </a:ext>
             </a:extLst>
           </p:cNvPr>
@@ -11925,7 +11925,7 @@
           <p:cNvPr id="15" name="">
             <a:extLst xmlns:a="http://schemas.openxmlformats.org/drawingml/2006/main">
               <a:ext uri="{FF2B5EF4-FFF2-40B4-BE49-F238E27FC236}">
-                <a16:creationId xmlns:a16="http://schemas.microsoft.com/office/drawing/2014/main" id="{98CB58D8-4C4F-47C5-A058-65FCF1FC7BD2}"/>
+                <a16:creationId xmlns:a16="http://schemas.microsoft.com/office/drawing/2014/main" id="{56D9AA6A-235C-4684-916A-FC465F9C548A}"/>
               </a:ext>
             </a:extLst>
           </p:cNvPr>
@@ -11987,7 +11987,7 @@
           <p:cNvPr id="16" name="">
             <a:extLst xmlns:a="http://schemas.openxmlformats.org/drawingml/2006/main">
               <a:ext uri="{FF2B5EF4-FFF2-40B4-BE49-F238E27FC236}">
-                <a16:creationId xmlns:a16="http://schemas.microsoft.com/office/drawing/2014/main" id="{ACEBE16E-496D-41FF-81CD-C8733277C937}"/>
+                <a16:creationId xmlns:a16="http://schemas.microsoft.com/office/drawing/2014/main" id="{40CD9A91-1075-4D62-8642-78CF471E7446}"/>
               </a:ext>
             </a:extLst>
           </p:cNvPr>
@@ -12022,7 +12022,7 @@
           <p:cNvPr id="17" name="">
             <a:extLst xmlns:a="http://schemas.openxmlformats.org/drawingml/2006/main">
               <a:ext uri="{FF2B5EF4-FFF2-40B4-BE49-F238E27FC236}">
-                <a16:creationId xmlns:a16="http://schemas.microsoft.com/office/drawing/2014/main" id="{5E941020-DE25-4CC0-900D-655184ADC3CC}"/>
+                <a16:creationId xmlns:a16="http://schemas.microsoft.com/office/drawing/2014/main" id="{2019BECE-CBC7-4367-B02A-F08E456ACFD2}"/>
               </a:ext>
             </a:extLst>
           </p:cNvPr>
@@ -12084,7 +12084,7 @@
           <p:cNvPr id="18" name="">
             <a:extLst xmlns:a="http://schemas.openxmlformats.org/drawingml/2006/main">
               <a:ext uri="{FF2B5EF4-FFF2-40B4-BE49-F238E27FC236}">
-                <a16:creationId xmlns:a16="http://schemas.microsoft.com/office/drawing/2014/main" id="{3440D892-C859-46E7-A5DE-D7043118AE09}"/>
+                <a16:creationId xmlns:a16="http://schemas.microsoft.com/office/drawing/2014/main" id="{778AAB4A-D23D-4499-A597-77A8E5FFE2B5}"/>
               </a:ext>
             </a:extLst>
           </p:cNvPr>
@@ -12115,7 +12115,7 @@
           <p:cNvPr id="19" name="">
             <a:extLst xmlns:a="http://schemas.openxmlformats.org/drawingml/2006/main">
               <a:ext uri="{FF2B5EF4-FFF2-40B4-BE49-F238E27FC236}">
-                <a16:creationId xmlns:a16="http://schemas.microsoft.com/office/drawing/2014/main" id="{4977218A-4E95-4B13-B94E-B49927B9387D}"/>
+                <a16:creationId xmlns:a16="http://schemas.microsoft.com/office/drawing/2014/main" id="{3ECF5261-5FCA-4424-A19D-F2E86E7018E1}"/>
               </a:ext>
             </a:extLst>
           </p:cNvPr>
@@ -12167,7 +12167,7 @@
                 <a:ea typeface="Arial"/>
                 <a:cs typeface="Arial"/>
               </a:rPr>
-              <a:t>r2z-16690ccbe328 · scn-c46e1d86c1</a:t>
+              <a:t>r2z-45c4ba076af9 · scn-e0f12f397e</a:t>
             </a:r>
           </a:p>
         </p:txBody>
@@ -12177,7 +12177,7 @@
           <p:cNvPr id="20" name="">
             <a:extLst xmlns:a="http://schemas.openxmlformats.org/drawingml/2006/main">
               <a:ext uri="{FF2B5EF4-FFF2-40B4-BE49-F238E27FC236}">
-                <a16:creationId xmlns:a16="http://schemas.microsoft.com/office/drawing/2014/main" id="{CF3DD505-30A4-4D1A-8393-345C338D364B}"/>
+                <a16:creationId xmlns:a16="http://schemas.microsoft.com/office/drawing/2014/main" id="{233027B2-064E-425D-A7C0-DCA6110FEDA2}"/>
               </a:ext>
             </a:extLst>
           </p:cNvPr>
@@ -12237,7 +12237,7 @@
     </p:spTree>
     <p:extLst>
       <p:ext uri="{BB962C8B-B14F-4D97-AF65-F5344CB8AC3E}">
-        <p14:creationId xmlns:p14="http://schemas.microsoft.com/office/powerpoint/2010/main" val="1455715872"/>
+        <p14:creationId xmlns:p14="http://schemas.microsoft.com/office/powerpoint/2010/main" val="1620183756"/>
       </p:ext>
     </p:extLst>
   </p:cSld>
@@ -12265,10 +12265,10 @@
       </p:grpSpPr>
       <p:sp>
         <p:nvSpPr>
-          <p:cNvPr id="30" name="">
-            <a:extLst xmlns:a="http://schemas.openxmlformats.org/drawingml/2006/main">
-              <a:ext uri="{FF2B5EF4-FFF2-40B4-BE49-F238E27FC236}">
-                <a16:creationId xmlns:a16="http://schemas.microsoft.com/office/drawing/2014/main" id="{C45B4AE9-6828-4017-933D-FB7E49D51D37}"/>
+          <p:cNvPr id="31" name="">
+            <a:extLst xmlns:a="http://schemas.openxmlformats.org/drawingml/2006/main">
+              <a:ext uri="{FF2B5EF4-FFF2-40B4-BE49-F238E27FC236}">
+                <a16:creationId xmlns:a16="http://schemas.microsoft.com/office/drawing/2014/main" id="{D525F3D2-E764-4C19-ABDD-FA2750AB6296}"/>
               </a:ext>
             </a:extLst>
           </p:cNvPr>
@@ -12330,7 +12330,7 @@
                 <a:latin typeface="Arial"/>
                 <a:ea typeface="Arial"/>
                 <a:cs typeface="Arial"/>
-                <a:hlinkClick xmlns:r="http://schemas.openxmlformats.org/officeDocument/2006/relationships" r:id="R2c1c6bf3a97a4f49"/>
+                <a:hlinkClick xmlns:r="http://schemas.openxmlformats.org/officeDocument/2006/relationships" r:id="R1de50d237d27480c"/>
               </a:rPr>
               <a:t>https://github.com/qjmre23/Route2Zero</a:t>
             </a:r>
@@ -12353,7 +12353,7 @@
                 <a:latin typeface="Arial"/>
                 <a:ea typeface="Arial"/>
                 <a:cs typeface="Arial"/>
-                <a:hlinkClick xmlns:r="http://schemas.openxmlformats.org/officeDocument/2006/relationships" r:id="R76ffdab504c64bb3"/>
+                <a:hlinkClick xmlns:r="http://schemas.openxmlformats.org/officeDocument/2006/relationships" r:id="R7252fed34eed4f92"/>
               </a:rPr>
               <a:t>https://route2zero.netlify.app/</a:t>
             </a:r>
@@ -12365,7 +12365,7 @@
           <p:cNvPr id="2" name="">
             <a:extLst xmlns:a="http://schemas.openxmlformats.org/drawingml/2006/main">
               <a:ext uri="{FF2B5EF4-FFF2-40B4-BE49-F238E27FC236}">
-                <a16:creationId xmlns:a16="http://schemas.microsoft.com/office/drawing/2014/main" id="{47FC48CC-D6B6-42D3-A5F6-44496841BF35}"/>
+                <a16:creationId xmlns:a16="http://schemas.microsoft.com/office/drawing/2014/main" id="{3E5CB07E-F574-4970-8086-A8FF7EB36DD1}"/>
               </a:ext>
             </a:extLst>
           </p:cNvPr>
@@ -12427,7 +12427,7 @@
           <p:cNvPr id="3" name="">
             <a:extLst xmlns:a="http://schemas.openxmlformats.org/drawingml/2006/main">
               <a:ext uri="{FF2B5EF4-FFF2-40B4-BE49-F238E27FC236}">
-                <a16:creationId xmlns:a16="http://schemas.microsoft.com/office/drawing/2014/main" id="{27746C18-AF52-4446-9439-5C5B343FE32D}"/>
+                <a16:creationId xmlns:a16="http://schemas.microsoft.com/office/drawing/2014/main" id="{D3B93810-B546-4298-902F-9F8BD3391DDF}"/>
               </a:ext>
             </a:extLst>
           </p:cNvPr>
@@ -12486,15 +12486,15 @@
       </p:sp>
       <p:pic>
         <p:nvPicPr>
-          <p:cNvPr id="33" name=""/>
+          <p:cNvPr id="34" name=""/>
           <p:cNvPicPr>
             <a:picLocks xmlns:a="http://schemas.openxmlformats.org/drawingml/2006/main" noChangeAspect="1"/>
           </p:cNvPicPr>
           <p:nvPr/>
         </p:nvPicPr>
         <p:blipFill>
-          <a:blip xmlns:r="http://schemas.openxmlformats.org/officeDocument/2006/relationships" xmlns:a="http://schemas.openxmlformats.org/drawingml/2006/main" r:embed="R644f126f147a4def"/>
-          <a:srcRect xmlns:a="http://schemas.openxmlformats.org/drawingml/2006/main" l="4103" t="0" r="4103" b="0"/>
+          <a:blip xmlns:r="http://schemas.openxmlformats.org/officeDocument/2006/relationships" xmlns:a="http://schemas.openxmlformats.org/drawingml/2006/main" r:embed="Rad97727575914efd"/>
+          <a:srcRect xmlns:a="http://schemas.openxmlformats.org/drawingml/2006/main" l="4095" t="0" r="4095" b="0"/>
           <a:stretch xmlns:a="http://schemas.openxmlformats.org/drawingml/2006/main">
             <a:fillRect l="0" t="0" r="0" b="0"/>
           </a:stretch>
@@ -12516,7 +12516,7 @@
           <p:cNvPr id="5" name="">
             <a:extLst xmlns:a="http://schemas.openxmlformats.org/drawingml/2006/main">
               <a:ext uri="{FF2B5EF4-FFF2-40B4-BE49-F238E27FC236}">
-                <a16:creationId xmlns:a16="http://schemas.microsoft.com/office/drawing/2014/main" id="{228A87E0-CD95-4961-8DEF-41673C3C4CD6}"/>
+                <a16:creationId xmlns:a16="http://schemas.microsoft.com/office/drawing/2014/main" id="{E11F78A6-1BFE-486A-BF4F-D7BD680A7C7F}"/>
               </a:ext>
             </a:extLst>
           </p:cNvPr>
@@ -12549,7 +12549,7 @@
           <p:cNvPr id="6" name="">
             <a:extLst xmlns:a="http://schemas.openxmlformats.org/drawingml/2006/main">
               <a:ext uri="{FF2B5EF4-FFF2-40B4-BE49-F238E27FC236}">
-                <a16:creationId xmlns:a16="http://schemas.microsoft.com/office/drawing/2014/main" id="{83F8357B-987D-47C9-AAC6-52DBDCEA5817}"/>
+                <a16:creationId xmlns:a16="http://schemas.microsoft.com/office/drawing/2014/main" id="{A226B3C0-1909-4B79-9354-E0BE20148FEC}"/>
               </a:ext>
             </a:extLst>
           </p:cNvPr>
@@ -12611,7 +12611,7 @@
           <p:cNvPr id="7" name="">
             <a:extLst xmlns:a="http://schemas.openxmlformats.org/drawingml/2006/main">
               <a:ext uri="{FF2B5EF4-FFF2-40B4-BE49-F238E27FC236}">
-                <a16:creationId xmlns:a16="http://schemas.microsoft.com/office/drawing/2014/main" id="{53D0FA09-11CC-4C2D-8008-8161701D32D7}"/>
+                <a16:creationId xmlns:a16="http://schemas.microsoft.com/office/drawing/2014/main" id="{E153A1E6-2DFC-4960-AC49-574C855A4546}"/>
               </a:ext>
             </a:extLst>
           </p:cNvPr>
@@ -12663,7 +12663,7 @@
                 <a:ea typeface="Arial"/>
                 <a:cs typeface="Arial"/>
               </a:rPr>
-              <a:t>r2z-16690ccbe328</a:t>
+              <a:t>r2z-45c4ba076af9</a:t>
             </a:r>
           </a:p>
         </p:txBody>
@@ -12673,7 +12673,7 @@
           <p:cNvPr id="8" name="">
             <a:extLst xmlns:a="http://schemas.openxmlformats.org/drawingml/2006/main">
               <a:ext uri="{FF2B5EF4-FFF2-40B4-BE49-F238E27FC236}">
-                <a16:creationId xmlns:a16="http://schemas.microsoft.com/office/drawing/2014/main" id="{A17389C3-926F-4415-9B6A-E294479B00A6}"/>
+                <a16:creationId xmlns:a16="http://schemas.microsoft.com/office/drawing/2014/main" id="{D3BC039B-37F3-4B87-85EA-F134EAED5531}"/>
               </a:ext>
             </a:extLst>
           </p:cNvPr>
@@ -12704,7 +12704,7 @@
           <p:cNvPr id="9" name="">
             <a:extLst xmlns:a="http://schemas.openxmlformats.org/drawingml/2006/main">
               <a:ext uri="{FF2B5EF4-FFF2-40B4-BE49-F238E27FC236}">
-                <a16:creationId xmlns:a16="http://schemas.microsoft.com/office/drawing/2014/main" id="{B27122A5-6F6F-4BC5-A30E-3B96BF83E643}"/>
+                <a16:creationId xmlns:a16="http://schemas.microsoft.com/office/drawing/2014/main" id="{7AD69AAF-7E77-4036-BDE2-4983DB7D882F}"/>
               </a:ext>
             </a:extLst>
           </p:cNvPr>
@@ -12766,7 +12766,7 @@
           <p:cNvPr id="10" name="">
             <a:extLst xmlns:a="http://schemas.openxmlformats.org/drawingml/2006/main">
               <a:ext uri="{FF2B5EF4-FFF2-40B4-BE49-F238E27FC236}">
-                <a16:creationId xmlns:a16="http://schemas.microsoft.com/office/drawing/2014/main" id="{6A02DF4E-F01C-4643-9EDB-7134D5AF3A1B}"/>
+                <a16:creationId xmlns:a16="http://schemas.microsoft.com/office/drawing/2014/main" id="{4DD770C3-9DE2-4FE0-8744-59FE6C1EE4BA}"/>
               </a:ext>
             </a:extLst>
           </p:cNvPr>
@@ -12818,7 +12818,7 @@
                 <a:ea typeface="Arial"/>
                 <a:cs typeface="Arial"/>
               </a:rPr>
-              <a:t>scn-c46e1d86c1</a:t>
+              <a:t>scn-e0f12f397e</a:t>
             </a:r>
           </a:p>
         </p:txBody>
@@ -12828,7 +12828,7 @@
           <p:cNvPr id="11" name="">
             <a:extLst xmlns:a="http://schemas.openxmlformats.org/drawingml/2006/main">
               <a:ext uri="{FF2B5EF4-FFF2-40B4-BE49-F238E27FC236}">
-                <a16:creationId xmlns:a16="http://schemas.microsoft.com/office/drawing/2014/main" id="{EABD0C4F-BBE8-4CFE-9B75-9314E4C22D38}"/>
+                <a16:creationId xmlns:a16="http://schemas.microsoft.com/office/drawing/2014/main" id="{AD20C3C4-CFA0-41F0-8425-9E494755B77A}"/>
               </a:ext>
             </a:extLst>
           </p:cNvPr>
@@ -12859,7 +12859,7 @@
           <p:cNvPr id="12" name="">
             <a:extLst xmlns:a="http://schemas.openxmlformats.org/drawingml/2006/main">
               <a:ext uri="{FF2B5EF4-FFF2-40B4-BE49-F238E27FC236}">
-                <a16:creationId xmlns:a16="http://schemas.microsoft.com/office/drawing/2014/main" id="{78E36A67-0240-4144-A83E-1FF9679E785A}"/>
+                <a16:creationId xmlns:a16="http://schemas.microsoft.com/office/drawing/2014/main" id="{C46902B3-51B8-4DC8-A10C-67EC507DD231}"/>
               </a:ext>
             </a:extLst>
           </p:cNvPr>
@@ -12921,7 +12921,7 @@
           <p:cNvPr id="13" name="">
             <a:extLst xmlns:a="http://schemas.openxmlformats.org/drawingml/2006/main">
               <a:ext uri="{FF2B5EF4-FFF2-40B4-BE49-F238E27FC236}">
-                <a16:creationId xmlns:a16="http://schemas.microsoft.com/office/drawing/2014/main" id="{2E504A16-4D1D-411A-B406-316086D24DA5}"/>
+                <a16:creationId xmlns:a16="http://schemas.microsoft.com/office/drawing/2014/main" id="{E04BC2D3-6B2C-4AB7-AFF6-EEC3A51931DD}"/>
               </a:ext>
             </a:extLst>
           </p:cNvPr>
@@ -12983,7 +12983,7 @@
           <p:cNvPr id="14" name="">
             <a:extLst xmlns:a="http://schemas.openxmlformats.org/drawingml/2006/main">
               <a:ext uri="{FF2B5EF4-FFF2-40B4-BE49-F238E27FC236}">
-                <a16:creationId xmlns:a16="http://schemas.microsoft.com/office/drawing/2014/main" id="{BFA1B689-9F11-4116-81A5-F55CF80F30CD}"/>
+                <a16:creationId xmlns:a16="http://schemas.microsoft.com/office/drawing/2014/main" id="{2E50D6B2-CA89-4F94-9FE1-C324929AA834}"/>
               </a:ext>
             </a:extLst>
           </p:cNvPr>
@@ -13014,7 +13014,7 @@
           <p:cNvPr id="15" name="">
             <a:extLst xmlns:a="http://schemas.openxmlformats.org/drawingml/2006/main">
               <a:ext uri="{FF2B5EF4-FFF2-40B4-BE49-F238E27FC236}">
-                <a16:creationId xmlns:a16="http://schemas.microsoft.com/office/drawing/2014/main" id="{478F9604-8F2C-4419-AA3E-C7FA604C4400}"/>
+                <a16:creationId xmlns:a16="http://schemas.microsoft.com/office/drawing/2014/main" id="{5943B417-F187-427C-9EAE-B30D8C152AF0}"/>
               </a:ext>
             </a:extLst>
           </p:cNvPr>
@@ -13076,7 +13076,7 @@
           <p:cNvPr id="16" name="">
             <a:extLst xmlns:a="http://schemas.openxmlformats.org/drawingml/2006/main">
               <a:ext uri="{FF2B5EF4-FFF2-40B4-BE49-F238E27FC236}">
-                <a16:creationId xmlns:a16="http://schemas.microsoft.com/office/drawing/2014/main" id="{DAC1BC26-DA76-4F62-88A4-DA058EA9CE59}"/>
+                <a16:creationId xmlns:a16="http://schemas.microsoft.com/office/drawing/2014/main" id="{0D77702D-E577-48ED-B6A7-0DBAD09F58FD}"/>
               </a:ext>
             </a:extLst>
           </p:cNvPr>
@@ -13138,7 +13138,7 @@
           <p:cNvPr id="17" name="">
             <a:extLst xmlns:a="http://schemas.openxmlformats.org/drawingml/2006/main">
               <a:ext uri="{FF2B5EF4-FFF2-40B4-BE49-F238E27FC236}">
-                <a16:creationId xmlns:a16="http://schemas.microsoft.com/office/drawing/2014/main" id="{12578127-C28F-445E-95C8-37F9960F73FE}"/>
+                <a16:creationId xmlns:a16="http://schemas.microsoft.com/office/drawing/2014/main" id="{7CE59BB3-7422-4500-9ADB-80995978B2D6}"/>
               </a:ext>
             </a:extLst>
           </p:cNvPr>
@@ -13169,7 +13169,7 @@
           <p:cNvPr id="18" name="">
             <a:extLst xmlns:a="http://schemas.openxmlformats.org/drawingml/2006/main">
               <a:ext uri="{FF2B5EF4-FFF2-40B4-BE49-F238E27FC236}">
-                <a16:creationId xmlns:a16="http://schemas.microsoft.com/office/drawing/2014/main" id="{C89E049C-1DB4-4B56-92E1-97B420A1F5D9}"/>
+                <a16:creationId xmlns:a16="http://schemas.microsoft.com/office/drawing/2014/main" id="{C435895A-15E9-45EC-B5CD-0174C323AF78}"/>
               </a:ext>
             </a:extLst>
           </p:cNvPr>
@@ -13231,7 +13231,7 @@
           <p:cNvPr id="19" name="">
             <a:extLst xmlns:a="http://schemas.openxmlformats.org/drawingml/2006/main">
               <a:ext uri="{FF2B5EF4-FFF2-40B4-BE49-F238E27FC236}">
-                <a16:creationId xmlns:a16="http://schemas.microsoft.com/office/drawing/2014/main" id="{3A150090-7D88-4E62-8246-E41504282201}"/>
+                <a16:creationId xmlns:a16="http://schemas.microsoft.com/office/drawing/2014/main" id="{7A45831D-3692-4B0B-89BA-453B949C429D}"/>
               </a:ext>
             </a:extLst>
           </p:cNvPr>
@@ -13293,7 +13293,7 @@
           <p:cNvPr id="20" name="">
             <a:extLst xmlns:a="http://schemas.openxmlformats.org/drawingml/2006/main">
               <a:ext uri="{FF2B5EF4-FFF2-40B4-BE49-F238E27FC236}">
-                <a16:creationId xmlns:a16="http://schemas.microsoft.com/office/drawing/2014/main" id="{514C3343-FA70-4C5A-ADF1-D84C2AC1F611}"/>
+                <a16:creationId xmlns:a16="http://schemas.microsoft.com/office/drawing/2014/main" id="{0B874253-2C08-4EE8-8B62-8CDA4A13C489}"/>
               </a:ext>
             </a:extLst>
           </p:cNvPr>
@@ -13324,7 +13324,7 @@
           <p:cNvPr id="21" name="">
             <a:extLst xmlns:a="http://schemas.openxmlformats.org/drawingml/2006/main">
               <a:ext uri="{FF2B5EF4-FFF2-40B4-BE49-F238E27FC236}">
-                <a16:creationId xmlns:a16="http://schemas.microsoft.com/office/drawing/2014/main" id="{4688443D-C198-4893-B96E-CE8DCD9C58E1}"/>
+                <a16:creationId xmlns:a16="http://schemas.microsoft.com/office/drawing/2014/main" id="{16E3319C-70CC-454B-8D13-7C89E55F549E}"/>
               </a:ext>
             </a:extLst>
           </p:cNvPr>
@@ -13386,7 +13386,7 @@
           <p:cNvPr id="22" name="">
             <a:extLst xmlns:a="http://schemas.openxmlformats.org/drawingml/2006/main">
               <a:ext uri="{FF2B5EF4-FFF2-40B4-BE49-F238E27FC236}">
-                <a16:creationId xmlns:a16="http://schemas.microsoft.com/office/drawing/2014/main" id="{10EED700-7472-4D1B-8D85-600B9D0F53E2}"/>
+                <a16:creationId xmlns:a16="http://schemas.microsoft.com/office/drawing/2014/main" id="{18F62179-05ED-45F3-BAE9-6139D6565CBD}"/>
               </a:ext>
             </a:extLst>
           </p:cNvPr>
@@ -13448,7 +13448,7 @@
           <p:cNvPr id="23" name="">
             <a:extLst xmlns:a="http://schemas.openxmlformats.org/drawingml/2006/main">
               <a:ext uri="{FF2B5EF4-FFF2-40B4-BE49-F238E27FC236}">
-                <a16:creationId xmlns:a16="http://schemas.microsoft.com/office/drawing/2014/main" id="{5B5451C7-01D4-4344-AA27-C2749B01DCAA}"/>
+                <a16:creationId xmlns:a16="http://schemas.microsoft.com/office/drawing/2014/main" id="{16C754E4-0FB8-455C-8C6C-58902684D4A9}"/>
               </a:ext>
             </a:extLst>
           </p:cNvPr>
@@ -13479,19 +13479,19 @@
           <p:cNvPr id="24" name="">
             <a:extLst xmlns:a="http://schemas.openxmlformats.org/drawingml/2006/main">
               <a:ext uri="{FF2B5EF4-FFF2-40B4-BE49-F238E27FC236}">
-                <a16:creationId xmlns:a16="http://schemas.microsoft.com/office/drawing/2014/main" id="{363D4638-0442-4DC3-818F-112D27FE176C}"/>
-              </a:ext>
-            </a:extLst>
-          </p:cNvPr>
-          <p:cNvSpPr>
-            <a:spLocks xmlns:a="http://schemas.openxmlformats.org/drawingml/2006/main" noGrp="1"/>
-          </p:cNvSpPr>
-          <p:nvPr/>
-        </p:nvSpPr>
-        <p:spPr>
-          <a:xfrm xmlns:a="http://schemas.openxmlformats.org/drawingml/2006/main">
-            <a:off x="685800" y="5734050"/>
-            <a:ext cx="10382250" cy="295275"/>
+                <a16:creationId xmlns:a16="http://schemas.microsoft.com/office/drawing/2014/main" id="{F6EAFD89-97E5-422D-A77C-09ED87F9FFDB}"/>
+              </a:ext>
+            </a:extLst>
+          </p:cNvPr>
+          <p:cNvSpPr>
+            <a:spLocks xmlns:a="http://schemas.openxmlformats.org/drawingml/2006/main" noGrp="1"/>
+          </p:cNvSpPr>
+          <p:nvPr/>
+        </p:nvSpPr>
+        <p:spPr>
+          <a:xfrm xmlns:a="http://schemas.openxmlformats.org/drawingml/2006/main">
+            <a:off x="685800" y="5486400"/>
+            <a:ext cx="10382250" cy="133350"/>
           </a:xfrm>
           <a:prstGeom xmlns:a="http://schemas.openxmlformats.org/drawingml/2006/main" prst="rect">
             <a:avLst/>
@@ -13513,9 +13513,9 @@
                 <a:spcPct val="100000"/>
               </a:lnSpc>
               <a:buNone/>
-              <a:defRPr sz="1088" b="1" i="0">
-                <a:solidFill>
-                  <a:srgbClr val="9FB4CE"/>
+              <a:defRPr sz="660" b="0" i="0">
+                <a:solidFill>
+                  <a:srgbClr val="8FA7C8"/>
                 </a:solidFill>
                 <a:latin typeface="Arial"/>
                 <a:ea typeface="Arial"/>
@@ -13523,15 +13523,15 @@
               </a:defRPr>
             </a:pPr>
             <a:r>
-              <a:rPr sz="1088" b="1" i="0">
-                <a:solidFill>
-                  <a:srgbClr val="9FB4CE"/>
-                </a:solidFill>
-                <a:latin typeface="Arial"/>
-                <a:ea typeface="Arial"/>
-                <a:cs typeface="Arial"/>
-              </a:rPr>
-              <a:t>SOURCE EVIDENCE → ML → CLIMATE / EQUITY / READINESS → CONFIDENCE → POLICY → SENSITIVITY → PORTFOLIO → VALIDATION</a:t>
+              <a:rPr sz="660" b="0" i="0">
+                <a:solidFill>
+                  <a:srgbClr val="8FA7C8"/>
+                </a:solidFill>
+                <a:latin typeface="Arial"/>
+                <a:ea typeface="Arial"/>
+                <a:cs typeface="Arial"/>
+              </a:rPr>
+              <a:t>Team Larpers · John Marwin Ebona · Isaac Marcus · Andrei Dela Cruz · Russel Mendez</a:t>
             </a:r>
           </a:p>
         </p:txBody>
@@ -13541,19 +13541,19 @@
           <p:cNvPr id="25" name="">
             <a:extLst xmlns:a="http://schemas.openxmlformats.org/drawingml/2006/main">
               <a:ext uri="{FF2B5EF4-FFF2-40B4-BE49-F238E27FC236}">
-                <a16:creationId xmlns:a16="http://schemas.microsoft.com/office/drawing/2014/main" id="{3512AABE-2F2B-46A4-B4B8-EF738A64BF01}"/>
-              </a:ext>
-            </a:extLst>
-          </p:cNvPr>
-          <p:cNvSpPr>
-            <a:spLocks xmlns:a="http://schemas.openxmlformats.org/drawingml/2006/main" noGrp="1"/>
-          </p:cNvSpPr>
-          <p:nvPr/>
-        </p:nvSpPr>
-        <p:spPr>
-          <a:xfrm xmlns:a="http://schemas.openxmlformats.org/drawingml/2006/main">
-            <a:off x="685800" y="6115050"/>
-            <a:ext cx="10382250" cy="285750"/>
+                <a16:creationId xmlns:a16="http://schemas.microsoft.com/office/drawing/2014/main" id="{F9906BC3-D327-4ED5-BD88-CBD303617198}"/>
+              </a:ext>
+            </a:extLst>
+          </p:cNvPr>
+          <p:cNvSpPr>
+            <a:spLocks xmlns:a="http://schemas.openxmlformats.org/drawingml/2006/main" noGrp="1"/>
+          </p:cNvSpPr>
+          <p:nvPr/>
+        </p:nvSpPr>
+        <p:spPr>
+          <a:xfrm xmlns:a="http://schemas.openxmlformats.org/drawingml/2006/main">
+            <a:off x="685800" y="5638800"/>
+            <a:ext cx="10382250" cy="133350"/>
           </a:xfrm>
           <a:prstGeom xmlns:a="http://schemas.openxmlformats.org/drawingml/2006/main" prst="rect">
             <a:avLst/>
@@ -13575,9 +13575,9 @@
                 <a:spcPct val="100000"/>
               </a:lnSpc>
               <a:buNone/>
-              <a:defRPr sz="1425" b="1" i="0">
-                <a:solidFill>
-                  <a:srgbClr val="FFFFFF"/>
+              <a:defRPr sz="660" b="0" i="0">
+                <a:solidFill>
+                  <a:srgbClr val="8FA7C8"/>
                 </a:solidFill>
                 <a:latin typeface="Arial"/>
                 <a:ea typeface="Arial"/>
@@ -13585,15 +13585,15 @@
               </a:defRPr>
             </a:pPr>
             <a:r>
-              <a:rPr sz="1425" b="1" i="0">
-                <a:solidFill>
-                  <a:srgbClr val="FFFFFF"/>
-                </a:solidFill>
-                <a:latin typeface="Arial"/>
-                <a:ea typeface="Arial"/>
-                <a:cs typeface="Arial"/>
-              </a:rPr>
-              <a:t>Route2Zero is not asking the city to trust one score. It shows what remains true when assumptions are challenged.</a:t>
+              <a:rPr sz="660" b="0" i="0">
+                <a:solidFill>
+                  <a:srgbClr val="8FA7C8"/>
+                </a:solidFill>
+                <a:latin typeface="Arial"/>
+                <a:ea typeface="Arial"/>
+                <a:cs typeface="Arial"/>
+              </a:rPr>
+              <a:t>TRISTIAN JAMES CABALAR · JOHN MICHAEL PALAGANAS · Carl Nueva · JOSEPH CLARENCE PARAYAOAN</a:t>
             </a:r>
           </a:p>
         </p:txBody>
@@ -13603,19 +13603,19 @@
           <p:cNvPr id="26" name="">
             <a:extLst xmlns:a="http://schemas.openxmlformats.org/drawingml/2006/main">
               <a:ext uri="{FF2B5EF4-FFF2-40B4-BE49-F238E27FC236}">
-                <a16:creationId xmlns:a16="http://schemas.microsoft.com/office/drawing/2014/main" id="{76412FDE-0FFE-481F-88EE-0CD006B8FE2B}"/>
-              </a:ext>
-            </a:extLst>
-          </p:cNvPr>
-          <p:cNvSpPr>
-            <a:spLocks xmlns:a="http://schemas.openxmlformats.org/drawingml/2006/main" noGrp="1"/>
-          </p:cNvSpPr>
-          <p:nvPr/>
-        </p:nvSpPr>
-        <p:spPr>
-          <a:xfrm xmlns:a="http://schemas.openxmlformats.org/drawingml/2006/main">
-            <a:off x="685800" y="6372225"/>
-            <a:ext cx="10382250" cy="133350"/>
+                <a16:creationId xmlns:a16="http://schemas.microsoft.com/office/drawing/2014/main" id="{FEA64C77-75C4-4796-90FC-CDC795409DE6}"/>
+              </a:ext>
+            </a:extLst>
+          </p:cNvPr>
+          <p:cNvSpPr>
+            <a:spLocks xmlns:a="http://schemas.openxmlformats.org/drawingml/2006/main" noGrp="1"/>
+          </p:cNvSpPr>
+          <p:nvPr/>
+        </p:nvSpPr>
+        <p:spPr>
+          <a:xfrm xmlns:a="http://schemas.openxmlformats.org/drawingml/2006/main">
+            <a:off x="685800" y="5819775"/>
+            <a:ext cx="10382250" cy="238125"/>
           </a:xfrm>
           <a:prstGeom xmlns:a="http://schemas.openxmlformats.org/drawingml/2006/main" prst="rect">
             <a:avLst/>
@@ -13637,9 +13637,9 @@
                 <a:spcPct val="100000"/>
               </a:lnSpc>
               <a:buNone/>
-              <a:defRPr sz="675" b="0" i="0">
-                <a:solidFill>
-                  <a:srgbClr val="8FA7C8"/>
+              <a:defRPr sz="1050" b="1" i="0">
+                <a:solidFill>
+                  <a:srgbClr val="9FB4CE"/>
                 </a:solidFill>
                 <a:latin typeface="Arial"/>
                 <a:ea typeface="Arial"/>
@@ -13647,15 +13647,15 @@
               </a:defRPr>
             </a:pPr>
             <a:r>
-              <a:rPr sz="675" b="0" i="0">
-                <a:solidFill>
-                  <a:srgbClr val="8FA7C8"/>
-                </a:solidFill>
-                <a:latin typeface="Arial"/>
-                <a:ea typeface="Arial"/>
-                <a:cs typeface="Arial"/>
-              </a:rPr>
-              <a:t>Team Larpers · John Marwin Ebona · Prince Marl · Joaquin Sarmiento · Isaac Marcus · Andrei Dela Cruz · Russel Mendez · Tj Moreno · JM Palaganas</a:t>
+              <a:rPr sz="1050" b="1" i="0">
+                <a:solidFill>
+                  <a:srgbClr val="9FB4CE"/>
+                </a:solidFill>
+                <a:latin typeface="Arial"/>
+                <a:ea typeface="Arial"/>
+                <a:cs typeface="Arial"/>
+              </a:rPr>
+              <a:t>SOURCE EVIDENCE → ML → CLIMATE / EQUITY / READINESS → CONFIDENCE → POLICY → SENSITIVITY → PORTFOLIO → VALIDATION</a:t>
             </a:r>
           </a:p>
         </p:txBody>
@@ -13665,7 +13665,69 @@
           <p:cNvPr id="27" name="">
             <a:extLst xmlns:a="http://schemas.openxmlformats.org/drawingml/2006/main">
               <a:ext uri="{FF2B5EF4-FFF2-40B4-BE49-F238E27FC236}">
-                <a16:creationId xmlns:a16="http://schemas.microsoft.com/office/drawing/2014/main" id="{EE8029C7-671E-4F62-A0A0-3614EECC1A9D}"/>
+                <a16:creationId xmlns:a16="http://schemas.microsoft.com/office/drawing/2014/main" id="{BA5E15B3-7D77-4D2C-A119-F44D12767E23}"/>
+              </a:ext>
+            </a:extLst>
+          </p:cNvPr>
+          <p:cNvSpPr>
+            <a:spLocks xmlns:a="http://schemas.openxmlformats.org/drawingml/2006/main" noGrp="1"/>
+          </p:cNvSpPr>
+          <p:nvPr/>
+        </p:nvSpPr>
+        <p:spPr>
+          <a:xfrm xmlns:a="http://schemas.openxmlformats.org/drawingml/2006/main">
+            <a:off x="685800" y="6096000"/>
+            <a:ext cx="10382250" cy="295275"/>
+          </a:xfrm>
+          <a:prstGeom xmlns:a="http://schemas.openxmlformats.org/drawingml/2006/main" prst="rect">
+            <a:avLst/>
+          </a:prstGeom>
+          <a:noFill xmlns:a="http://schemas.openxmlformats.org/drawingml/2006/main"/>
+          <a:ln xmlns:a="http://schemas.openxmlformats.org/drawingml/2006/main" w="0">
+            <a:noFill/>
+            <a:prstDash val="solid"/>
+          </a:ln>
+        </p:spPr>
+        <p:txBody>
+          <a:bodyPr xmlns:a="http://schemas.openxmlformats.org/drawingml/2006/main" lIns="0" tIns="0" rIns="0" bIns="0" anchor="t">
+            <a:normAutofit fontScale="100000"/>
+          </a:bodyPr>
+          <a:lstStyle xmlns:a="http://schemas.openxmlformats.org/drawingml/2006/main"/>
+          <a:p xmlns:a="http://schemas.openxmlformats.org/drawingml/2006/main">
+            <a:pPr algn="ctr">
+              <a:lnSpc>
+                <a:spcPct val="100000"/>
+              </a:lnSpc>
+              <a:buNone/>
+              <a:defRPr sz="1350" b="1" i="0">
+                <a:solidFill>
+                  <a:srgbClr val="FFFFFF"/>
+                </a:solidFill>
+                <a:latin typeface="Arial"/>
+                <a:ea typeface="Arial"/>
+                <a:cs typeface="Arial"/>
+              </a:defRPr>
+            </a:pPr>
+            <a:r>
+              <a:rPr sz="1350" b="1" i="0">
+                <a:solidFill>
+                  <a:srgbClr val="FFFFFF"/>
+                </a:solidFill>
+                <a:latin typeface="Arial"/>
+                <a:ea typeface="Arial"/>
+                <a:cs typeface="Arial"/>
+              </a:rPr>
+              <a:t>Route2Zero is not asking the city to trust one score. It shows what remains true when assumptions are challenged.</a:t>
+            </a:r>
+          </a:p>
+        </p:txBody>
+      </p:sp>
+      <p:sp>
+        <p:nvSpPr>
+          <p:cNvPr id="28" name="">
+            <a:extLst xmlns:a="http://schemas.openxmlformats.org/drawingml/2006/main">
+              <a:ext uri="{FF2B5EF4-FFF2-40B4-BE49-F238E27FC236}">
+                <a16:creationId xmlns:a16="http://schemas.microsoft.com/office/drawing/2014/main" id="{635D0464-3A11-430A-8B8D-707273195E30}"/>
               </a:ext>
             </a:extLst>
           </p:cNvPr>
@@ -13693,10 +13755,10 @@
       </p:sp>
       <p:sp>
         <p:nvSpPr>
-          <p:cNvPr id="28" name="">
-            <a:extLst xmlns:a="http://schemas.openxmlformats.org/drawingml/2006/main">
-              <a:ext uri="{FF2B5EF4-FFF2-40B4-BE49-F238E27FC236}">
-                <a16:creationId xmlns:a16="http://schemas.microsoft.com/office/drawing/2014/main" id="{00158996-2524-40AC-9899-2193C1D5383B}"/>
+          <p:cNvPr id="29" name="">
+            <a:extLst xmlns:a="http://schemas.openxmlformats.org/drawingml/2006/main">
+              <a:ext uri="{FF2B5EF4-FFF2-40B4-BE49-F238E27FC236}">
+                <a16:creationId xmlns:a16="http://schemas.microsoft.com/office/drawing/2014/main" id="{83318DDC-9272-474D-A3E2-0215BD68FACE}"/>
               </a:ext>
             </a:extLst>
           </p:cNvPr>
@@ -13748,17 +13810,17 @@
                 <a:ea typeface="Arial"/>
                 <a:cs typeface="Arial"/>
               </a:rPr>
-              <a:t>r2z-16690ccbe328 · scn-c46e1d86c1</a:t>
-            </a:r>
-          </a:p>
-        </p:txBody>
-      </p:sp>
-      <p:sp>
-        <p:nvSpPr>
-          <p:cNvPr id="29" name="">
-            <a:extLst xmlns:a="http://schemas.openxmlformats.org/drawingml/2006/main">
-              <a:ext uri="{FF2B5EF4-FFF2-40B4-BE49-F238E27FC236}">
-                <a16:creationId xmlns:a16="http://schemas.microsoft.com/office/drawing/2014/main" id="{19DBD5C3-E398-490C-B790-57F2914E3175}"/>
+              <a:t>r2z-45c4ba076af9 · scn-e0f12f397e</a:t>
+            </a:r>
+          </a:p>
+        </p:txBody>
+      </p:sp>
+      <p:sp>
+        <p:nvSpPr>
+          <p:cNvPr id="30" name="">
+            <a:extLst xmlns:a="http://schemas.openxmlformats.org/drawingml/2006/main">
+              <a:ext uri="{FF2B5EF4-FFF2-40B4-BE49-F238E27FC236}">
+                <a16:creationId xmlns:a16="http://schemas.microsoft.com/office/drawing/2014/main" id="{360304F2-0B5D-4DD1-A10E-8813BB34EC07}"/>
               </a:ext>
             </a:extLst>
           </p:cNvPr>
@@ -13818,7 +13880,7 @@
     </p:spTree>
     <p:extLst>
       <p:ext uri="{BB962C8B-B14F-4D97-AF65-F5344CB8AC3E}">
-        <p14:creationId xmlns:p14="http://schemas.microsoft.com/office/powerpoint/2010/main" val="2137870472"/>
+        <p14:creationId xmlns:p14="http://schemas.microsoft.com/office/powerpoint/2010/main" val="1197059605"/>
       </p:ext>
     </p:extLst>
   </p:cSld>
@@ -13849,7 +13911,7 @@
           <p:cNvPr id="37" name="">
             <a:extLst xmlns:a="http://schemas.openxmlformats.org/drawingml/2006/main">
               <a:ext uri="{FF2B5EF4-FFF2-40B4-BE49-F238E27FC236}">
-                <a16:creationId xmlns:a16="http://schemas.microsoft.com/office/drawing/2014/main" id="{F09546CF-FCCD-49F4-BFF4-A31593D4AB51}"/>
+                <a16:creationId xmlns:a16="http://schemas.microsoft.com/office/drawing/2014/main" id="{FF032895-E4AA-498C-A02D-F3FE16E27E8B}"/>
               </a:ext>
             </a:extLst>
           </p:cNvPr>
@@ -13911,7 +13973,7 @@
                 <a:latin typeface="Arial"/>
                 <a:ea typeface="Arial"/>
                 <a:cs typeface="Arial"/>
-                <a:hlinkClick xmlns:r="http://schemas.openxmlformats.org/officeDocument/2006/relationships" r:id="Ra58b8c5edf7a4cd6"/>
+                <a:hlinkClick xmlns:r="http://schemas.openxmlformats.org/officeDocument/2006/relationships" r:id="R8e66c87a2c7e4d0a"/>
               </a:rPr>
               <a:t>https://github.com/qjmre23/Route2Zero</a:t>
             </a:r>
@@ -13934,7 +13996,7 @@
                 <a:latin typeface="Arial"/>
                 <a:ea typeface="Arial"/>
                 <a:cs typeface="Arial"/>
-                <a:hlinkClick xmlns:r="http://schemas.openxmlformats.org/officeDocument/2006/relationships" r:id="Ra40282d37ed249f5"/>
+                <a:hlinkClick xmlns:r="http://schemas.openxmlformats.org/officeDocument/2006/relationships" r:id="R55a12648fcf74dfc"/>
               </a:rPr>
               <a:t>https://route2zero.netlify.app/</a:t>
             </a:r>
@@ -13946,7 +14008,7 @@
           <p:cNvPr id="2" name="">
             <a:extLst xmlns:a="http://schemas.openxmlformats.org/drawingml/2006/main">
               <a:ext uri="{FF2B5EF4-FFF2-40B4-BE49-F238E27FC236}">
-                <a16:creationId xmlns:a16="http://schemas.microsoft.com/office/drawing/2014/main" id="{2FFE5AFC-A313-4801-A422-376765EBFC41}"/>
+                <a16:creationId xmlns:a16="http://schemas.microsoft.com/office/drawing/2014/main" id="{8ABAA050-997D-46EC-8916-402C17D5668B}"/>
               </a:ext>
             </a:extLst>
           </p:cNvPr>
@@ -14008,7 +14070,7 @@
           <p:cNvPr id="3" name="">
             <a:extLst xmlns:a="http://schemas.openxmlformats.org/drawingml/2006/main">
               <a:ext uri="{FF2B5EF4-FFF2-40B4-BE49-F238E27FC236}">
-                <a16:creationId xmlns:a16="http://schemas.microsoft.com/office/drawing/2014/main" id="{89AC9B38-7F95-40FE-BCE5-B9A512D6D634}"/>
+                <a16:creationId xmlns:a16="http://schemas.microsoft.com/office/drawing/2014/main" id="{65A449C9-AB80-446D-8A0E-E66C9B63DE7C}"/>
               </a:ext>
             </a:extLst>
           </p:cNvPr>
@@ -14070,7 +14132,7 @@
           <p:cNvPr id="4" name="">
             <a:extLst xmlns:a="http://schemas.openxmlformats.org/drawingml/2006/main">
               <a:ext uri="{FF2B5EF4-FFF2-40B4-BE49-F238E27FC236}">
-                <a16:creationId xmlns:a16="http://schemas.microsoft.com/office/drawing/2014/main" id="{B182F4C5-37C1-45D8-9AF7-0E0DB489B651}"/>
+                <a16:creationId xmlns:a16="http://schemas.microsoft.com/office/drawing/2014/main" id="{D3118599-BE10-4E38-B729-C877FE9C17AD}"/>
               </a:ext>
             </a:extLst>
           </p:cNvPr>
@@ -14132,7 +14194,7 @@
           <p:cNvPr id="5" name="">
             <a:extLst xmlns:a="http://schemas.openxmlformats.org/drawingml/2006/main">
               <a:ext uri="{FF2B5EF4-FFF2-40B4-BE49-F238E27FC236}">
-                <a16:creationId xmlns:a16="http://schemas.microsoft.com/office/drawing/2014/main" id="{B5162FE9-DE00-46C8-92E0-BF31DDC7B6B0}"/>
+                <a16:creationId xmlns:a16="http://schemas.microsoft.com/office/drawing/2014/main" id="{55CA4108-3AC6-417E-BEE4-73176250335B}"/>
               </a:ext>
             </a:extLst>
           </p:cNvPr>
@@ -14163,7 +14225,7 @@
           <p:cNvPr id="6" name="">
             <a:extLst xmlns:a="http://schemas.openxmlformats.org/drawingml/2006/main">
               <a:ext uri="{FF2B5EF4-FFF2-40B4-BE49-F238E27FC236}">
-                <a16:creationId xmlns:a16="http://schemas.microsoft.com/office/drawing/2014/main" id="{E5E45BF8-295A-4FCF-8243-F00A1767415A}"/>
+                <a16:creationId xmlns:a16="http://schemas.microsoft.com/office/drawing/2014/main" id="{125CC15A-1AE7-4782-8777-5C74325343D5}"/>
               </a:ext>
             </a:extLst>
           </p:cNvPr>
@@ -14225,7 +14287,7 @@
           <p:cNvPr id="7" name="">
             <a:extLst xmlns:a="http://schemas.openxmlformats.org/drawingml/2006/main">
               <a:ext uri="{FF2B5EF4-FFF2-40B4-BE49-F238E27FC236}">
-                <a16:creationId xmlns:a16="http://schemas.microsoft.com/office/drawing/2014/main" id="{4AE49FA5-4667-4400-949F-3AD3DAF2B49E}"/>
+                <a16:creationId xmlns:a16="http://schemas.microsoft.com/office/drawing/2014/main" id="{5696D128-BAC1-4D28-8264-A5B3CAEFF253}"/>
               </a:ext>
             </a:extLst>
           </p:cNvPr>
@@ -14256,7 +14318,7 @@
           <p:cNvPr id="8" name="">
             <a:extLst xmlns:a="http://schemas.openxmlformats.org/drawingml/2006/main">
               <a:ext uri="{FF2B5EF4-FFF2-40B4-BE49-F238E27FC236}">
-                <a16:creationId xmlns:a16="http://schemas.microsoft.com/office/drawing/2014/main" id="{5E04850E-4758-4EDD-837D-506FDEC9F84D}"/>
+                <a16:creationId xmlns:a16="http://schemas.microsoft.com/office/drawing/2014/main" id="{23D55950-76A3-41E9-8D2B-86B56E3A8754}"/>
               </a:ext>
             </a:extLst>
           </p:cNvPr>
@@ -14318,7 +14380,7 @@
           <p:cNvPr id="9" name="">
             <a:extLst xmlns:a="http://schemas.openxmlformats.org/drawingml/2006/main">
               <a:ext uri="{FF2B5EF4-FFF2-40B4-BE49-F238E27FC236}">
-                <a16:creationId xmlns:a16="http://schemas.microsoft.com/office/drawing/2014/main" id="{D48FA997-D0AB-4013-995B-DC9125F2285A}"/>
+                <a16:creationId xmlns:a16="http://schemas.microsoft.com/office/drawing/2014/main" id="{7C19A5D2-7846-4B79-9F59-233433A6D475}"/>
               </a:ext>
             </a:extLst>
           </p:cNvPr>
@@ -14349,7 +14411,7 @@
           <p:cNvPr id="10" name="">
             <a:extLst xmlns:a="http://schemas.openxmlformats.org/drawingml/2006/main">
               <a:ext uri="{FF2B5EF4-FFF2-40B4-BE49-F238E27FC236}">
-                <a16:creationId xmlns:a16="http://schemas.microsoft.com/office/drawing/2014/main" id="{B3129EB5-52B7-468C-BDBA-0A0160A22FC3}"/>
+                <a16:creationId xmlns:a16="http://schemas.microsoft.com/office/drawing/2014/main" id="{F6C54A83-21A4-4A63-BA23-7A23D70156D4}"/>
               </a:ext>
             </a:extLst>
           </p:cNvPr>
@@ -14411,7 +14473,7 @@
           <p:cNvPr id="11" name="">
             <a:extLst xmlns:a="http://schemas.openxmlformats.org/drawingml/2006/main">
               <a:ext uri="{FF2B5EF4-FFF2-40B4-BE49-F238E27FC236}">
-                <a16:creationId xmlns:a16="http://schemas.microsoft.com/office/drawing/2014/main" id="{7C2A555F-F02D-4213-80B4-A646F1C0CD91}"/>
+                <a16:creationId xmlns:a16="http://schemas.microsoft.com/office/drawing/2014/main" id="{A8681221-3505-4845-B800-471DCCE80FA5}"/>
               </a:ext>
             </a:extLst>
           </p:cNvPr>
@@ -14442,7 +14504,7 @@
           <p:cNvPr id="12" name="">
             <a:extLst xmlns:a="http://schemas.openxmlformats.org/drawingml/2006/main">
               <a:ext uri="{FF2B5EF4-FFF2-40B4-BE49-F238E27FC236}">
-                <a16:creationId xmlns:a16="http://schemas.microsoft.com/office/drawing/2014/main" id="{091795A5-32D5-46A5-AD3B-5DBB58DAA573}"/>
+                <a16:creationId xmlns:a16="http://schemas.microsoft.com/office/drawing/2014/main" id="{5A0F58A0-E3C2-4E8F-9E7D-967D95CE8F99}"/>
               </a:ext>
             </a:extLst>
           </p:cNvPr>
@@ -14504,7 +14566,7 @@
           <p:cNvPr id="13" name="">
             <a:extLst xmlns:a="http://schemas.openxmlformats.org/drawingml/2006/main">
               <a:ext uri="{FF2B5EF4-FFF2-40B4-BE49-F238E27FC236}">
-                <a16:creationId xmlns:a16="http://schemas.microsoft.com/office/drawing/2014/main" id="{2306EBC9-4FEE-4DE9-BCCB-99E7ED6911BE}"/>
+                <a16:creationId xmlns:a16="http://schemas.microsoft.com/office/drawing/2014/main" id="{019FE228-930C-4CDF-96D4-1C167417EFAD}"/>
               </a:ext>
             </a:extLst>
           </p:cNvPr>
@@ -14535,7 +14597,7 @@
           <p:cNvPr id="14" name="">
             <a:extLst xmlns:a="http://schemas.openxmlformats.org/drawingml/2006/main">
               <a:ext uri="{FF2B5EF4-FFF2-40B4-BE49-F238E27FC236}">
-                <a16:creationId xmlns:a16="http://schemas.microsoft.com/office/drawing/2014/main" id="{0784B10D-CDE3-425F-A25E-BB495A71C6BD}"/>
+                <a16:creationId xmlns:a16="http://schemas.microsoft.com/office/drawing/2014/main" id="{4296928A-395E-4F30-A2A4-830FFC81AF66}"/>
               </a:ext>
             </a:extLst>
           </p:cNvPr>
@@ -14597,7 +14659,7 @@
           <p:cNvPr id="15" name="">
             <a:extLst xmlns:a="http://schemas.openxmlformats.org/drawingml/2006/main">
               <a:ext uri="{FF2B5EF4-FFF2-40B4-BE49-F238E27FC236}">
-                <a16:creationId xmlns:a16="http://schemas.microsoft.com/office/drawing/2014/main" id="{E802CB37-0B34-46C1-A89B-9F97361EE462}"/>
+                <a16:creationId xmlns:a16="http://schemas.microsoft.com/office/drawing/2014/main" id="{E76D3F2A-F8E6-476A-A9E9-6727795E1172}"/>
               </a:ext>
             </a:extLst>
           </p:cNvPr>
@@ -14628,7 +14690,7 @@
           <p:cNvPr id="16" name="">
             <a:extLst xmlns:a="http://schemas.openxmlformats.org/drawingml/2006/main">
               <a:ext uri="{FF2B5EF4-FFF2-40B4-BE49-F238E27FC236}">
-                <a16:creationId xmlns:a16="http://schemas.microsoft.com/office/drawing/2014/main" id="{1A35D5F3-6E0F-4DB1-99B4-98D310C6E6E5}"/>
+                <a16:creationId xmlns:a16="http://schemas.microsoft.com/office/drawing/2014/main" id="{F50D65C1-F5CC-42FA-AC52-DB8F5C74770A}"/>
               </a:ext>
             </a:extLst>
           </p:cNvPr>
@@ -14690,7 +14752,7 @@
           <p:cNvPr id="17" name="">
             <a:extLst xmlns:a="http://schemas.openxmlformats.org/drawingml/2006/main">
               <a:ext uri="{FF2B5EF4-FFF2-40B4-BE49-F238E27FC236}">
-                <a16:creationId xmlns:a16="http://schemas.microsoft.com/office/drawing/2014/main" id="{B273E3DB-0FB6-46A4-88CB-6FFA56474A7E}"/>
+                <a16:creationId xmlns:a16="http://schemas.microsoft.com/office/drawing/2014/main" id="{198B6D90-FE1D-41F5-893E-09185010F7E9}"/>
               </a:ext>
             </a:extLst>
           </p:cNvPr>
@@ -14721,7 +14783,7 @@
           <p:cNvPr id="18" name="">
             <a:extLst xmlns:a="http://schemas.openxmlformats.org/drawingml/2006/main">
               <a:ext uri="{FF2B5EF4-FFF2-40B4-BE49-F238E27FC236}">
-                <a16:creationId xmlns:a16="http://schemas.microsoft.com/office/drawing/2014/main" id="{A892668A-FC3C-427F-B407-0B44BFF5CB95}"/>
+                <a16:creationId xmlns:a16="http://schemas.microsoft.com/office/drawing/2014/main" id="{4138962F-6AF6-4FCB-9122-C7A976F0B45C}"/>
               </a:ext>
             </a:extLst>
           </p:cNvPr>
@@ -14783,7 +14845,7 @@
           <p:cNvPr id="19" name="">
             <a:extLst xmlns:a="http://schemas.openxmlformats.org/drawingml/2006/main">
               <a:ext uri="{FF2B5EF4-FFF2-40B4-BE49-F238E27FC236}">
-                <a16:creationId xmlns:a16="http://schemas.microsoft.com/office/drawing/2014/main" id="{2D1C1DA7-1B97-4316-9AD5-15BAB46167E5}"/>
+                <a16:creationId xmlns:a16="http://schemas.microsoft.com/office/drawing/2014/main" id="{E342C5EA-6185-4EFE-9525-FF3B8A1AB655}"/>
               </a:ext>
             </a:extLst>
           </p:cNvPr>
@@ -14814,7 +14876,7 @@
           <p:cNvPr id="20" name="">
             <a:extLst xmlns:a="http://schemas.openxmlformats.org/drawingml/2006/main">
               <a:ext uri="{FF2B5EF4-FFF2-40B4-BE49-F238E27FC236}">
-                <a16:creationId xmlns:a16="http://schemas.microsoft.com/office/drawing/2014/main" id="{ED33C97D-521C-4FD2-8DAA-F9D810991130}"/>
+                <a16:creationId xmlns:a16="http://schemas.microsoft.com/office/drawing/2014/main" id="{A1474AAE-1F21-4E9A-8F3F-2D2DB1C2593E}"/>
               </a:ext>
             </a:extLst>
           </p:cNvPr>
@@ -14876,7 +14938,7 @@
           <p:cNvPr id="21" name="">
             <a:extLst xmlns:a="http://schemas.openxmlformats.org/drawingml/2006/main">
               <a:ext uri="{FF2B5EF4-FFF2-40B4-BE49-F238E27FC236}">
-                <a16:creationId xmlns:a16="http://schemas.microsoft.com/office/drawing/2014/main" id="{2697DEFD-92A3-4FB2-A475-4662CB33F1E1}"/>
+                <a16:creationId xmlns:a16="http://schemas.microsoft.com/office/drawing/2014/main" id="{BCA4498C-833E-4990-8995-3E3ED9A70EF2}"/>
               </a:ext>
             </a:extLst>
           </p:cNvPr>
@@ -14907,7 +14969,7 @@
           <p:cNvPr id="22" name="">
             <a:extLst xmlns:a="http://schemas.openxmlformats.org/drawingml/2006/main">
               <a:ext uri="{FF2B5EF4-FFF2-40B4-BE49-F238E27FC236}">
-                <a16:creationId xmlns:a16="http://schemas.microsoft.com/office/drawing/2014/main" id="{5064731F-85C0-4B10-B638-56538ECCFE5A}"/>
+                <a16:creationId xmlns:a16="http://schemas.microsoft.com/office/drawing/2014/main" id="{D663AE87-F069-4B4A-82D7-C9C8CF2AC7D5}"/>
               </a:ext>
             </a:extLst>
           </p:cNvPr>
@@ -14969,7 +15031,7 @@
           <p:cNvPr id="23" name="">
             <a:extLst xmlns:a="http://schemas.openxmlformats.org/drawingml/2006/main">
               <a:ext uri="{FF2B5EF4-FFF2-40B4-BE49-F238E27FC236}">
-                <a16:creationId xmlns:a16="http://schemas.microsoft.com/office/drawing/2014/main" id="{6CEBEB42-4CA8-4BC2-8EA3-9FD30FD4C190}"/>
+                <a16:creationId xmlns:a16="http://schemas.microsoft.com/office/drawing/2014/main" id="{688AA637-637F-4CFD-9D8A-1C5EAF604F9B}"/>
               </a:ext>
             </a:extLst>
           </p:cNvPr>
@@ -15000,7 +15062,7 @@
           <p:cNvPr id="24" name="">
             <a:extLst xmlns:a="http://schemas.openxmlformats.org/drawingml/2006/main">
               <a:ext uri="{FF2B5EF4-FFF2-40B4-BE49-F238E27FC236}">
-                <a16:creationId xmlns:a16="http://schemas.microsoft.com/office/drawing/2014/main" id="{1FD26B85-47C0-4CF4-97BE-5DF46D595F33}"/>
+                <a16:creationId xmlns:a16="http://schemas.microsoft.com/office/drawing/2014/main" id="{7B7D7DEB-15ED-4EBA-AD9F-E0DEE79189E7}"/>
               </a:ext>
             </a:extLst>
           </p:cNvPr>
@@ -15062,7 +15124,7 @@
           <p:cNvPr id="25" name="">
             <a:extLst xmlns:a="http://schemas.openxmlformats.org/drawingml/2006/main">
               <a:ext uri="{FF2B5EF4-FFF2-40B4-BE49-F238E27FC236}">
-                <a16:creationId xmlns:a16="http://schemas.microsoft.com/office/drawing/2014/main" id="{4C3D0102-7E98-4DB6-840E-F154E0318050}"/>
+                <a16:creationId xmlns:a16="http://schemas.microsoft.com/office/drawing/2014/main" id="{98B6506B-4114-4458-A7B8-31E5B3DAE18E}"/>
               </a:ext>
             </a:extLst>
           </p:cNvPr>
@@ -15093,7 +15155,7 @@
           <p:cNvPr id="26" name="">
             <a:extLst xmlns:a="http://schemas.openxmlformats.org/drawingml/2006/main">
               <a:ext uri="{FF2B5EF4-FFF2-40B4-BE49-F238E27FC236}">
-                <a16:creationId xmlns:a16="http://schemas.microsoft.com/office/drawing/2014/main" id="{B3F089B3-73F5-4778-ACB7-7A790FE6434E}"/>
+                <a16:creationId xmlns:a16="http://schemas.microsoft.com/office/drawing/2014/main" id="{A38CB9B2-EA7D-4450-98EC-7E9DC22F78BC}"/>
               </a:ext>
             </a:extLst>
           </p:cNvPr>
@@ -15155,7 +15217,7 @@
           <p:cNvPr id="27" name="">
             <a:extLst xmlns:a="http://schemas.openxmlformats.org/drawingml/2006/main">
               <a:ext uri="{FF2B5EF4-FFF2-40B4-BE49-F238E27FC236}">
-                <a16:creationId xmlns:a16="http://schemas.microsoft.com/office/drawing/2014/main" id="{C5B8FB13-BA48-4F42-8179-438805FD96E9}"/>
+                <a16:creationId xmlns:a16="http://schemas.microsoft.com/office/drawing/2014/main" id="{D4AEE78C-EFC8-43D1-A8CF-89E1B5FA3B3B}"/>
               </a:ext>
             </a:extLst>
           </p:cNvPr>
@@ -15186,7 +15248,7 @@
           <p:cNvPr id="28" name="">
             <a:extLst xmlns:a="http://schemas.openxmlformats.org/drawingml/2006/main">
               <a:ext uri="{FF2B5EF4-FFF2-40B4-BE49-F238E27FC236}">
-                <a16:creationId xmlns:a16="http://schemas.microsoft.com/office/drawing/2014/main" id="{AF549D55-DDAB-48B7-8717-E4E685C14253}"/>
+                <a16:creationId xmlns:a16="http://schemas.microsoft.com/office/drawing/2014/main" id="{AD9DEA03-01FC-42A0-89D6-864B16FB8879}"/>
               </a:ext>
             </a:extLst>
           </p:cNvPr>
@@ -15248,7 +15310,7 @@
           <p:cNvPr id="29" name="">
             <a:extLst xmlns:a="http://schemas.openxmlformats.org/drawingml/2006/main">
               <a:ext uri="{FF2B5EF4-FFF2-40B4-BE49-F238E27FC236}">
-                <a16:creationId xmlns:a16="http://schemas.microsoft.com/office/drawing/2014/main" id="{8F90712C-8163-4236-ADF1-A8A3155E0A1D}"/>
+                <a16:creationId xmlns:a16="http://schemas.microsoft.com/office/drawing/2014/main" id="{E8C5F16A-A68F-4040-9E6E-567497029D93}"/>
               </a:ext>
             </a:extLst>
           </p:cNvPr>
@@ -15279,7 +15341,7 @@
           <p:cNvPr id="30" name="">
             <a:extLst xmlns:a="http://schemas.openxmlformats.org/drawingml/2006/main">
               <a:ext uri="{FF2B5EF4-FFF2-40B4-BE49-F238E27FC236}">
-                <a16:creationId xmlns:a16="http://schemas.microsoft.com/office/drawing/2014/main" id="{557BDBE2-FF57-4299-B9EE-B73F2F08FB30}"/>
+                <a16:creationId xmlns:a16="http://schemas.microsoft.com/office/drawing/2014/main" id="{7B4E265B-5198-4B11-A9E4-244E0F0D7047}"/>
               </a:ext>
             </a:extLst>
           </p:cNvPr>
@@ -15341,7 +15403,7 @@
           <p:cNvPr id="31" name="">
             <a:extLst xmlns:a="http://schemas.openxmlformats.org/drawingml/2006/main">
               <a:ext uri="{FF2B5EF4-FFF2-40B4-BE49-F238E27FC236}">
-                <a16:creationId xmlns:a16="http://schemas.microsoft.com/office/drawing/2014/main" id="{D527614F-1160-4EF5-9B01-D4602D06A6E8}"/>
+                <a16:creationId xmlns:a16="http://schemas.microsoft.com/office/drawing/2014/main" id="{1E5D3D30-04F8-429E-AACA-38865802A7FE}"/>
               </a:ext>
             </a:extLst>
           </p:cNvPr>
@@ -15403,7 +15465,7 @@
           <p:cNvPr id="32" name="">
             <a:extLst xmlns:a="http://schemas.openxmlformats.org/drawingml/2006/main">
               <a:ext uri="{FF2B5EF4-FFF2-40B4-BE49-F238E27FC236}">
-                <a16:creationId xmlns:a16="http://schemas.microsoft.com/office/drawing/2014/main" id="{06624C6A-D3FB-4E46-BC13-EE7774BAD39B}"/>
+                <a16:creationId xmlns:a16="http://schemas.microsoft.com/office/drawing/2014/main" id="{593BE115-F2F0-4989-B3FD-86FBFC969CF2}"/>
               </a:ext>
             </a:extLst>
           </p:cNvPr>
@@ -15436,7 +15498,7 @@
           <p:cNvPr id="33" name="">
             <a:extLst xmlns:a="http://schemas.openxmlformats.org/drawingml/2006/main">
               <a:ext uri="{FF2B5EF4-FFF2-40B4-BE49-F238E27FC236}">
-                <a16:creationId xmlns:a16="http://schemas.microsoft.com/office/drawing/2014/main" id="{766A5F14-6D33-4807-8F98-B3F959117538}"/>
+                <a16:creationId xmlns:a16="http://schemas.microsoft.com/office/drawing/2014/main" id="{2DC5A4FD-8908-4DDB-815D-9FB99AF32F33}"/>
               </a:ext>
             </a:extLst>
           </p:cNvPr>
@@ -15488,7 +15550,7 @@
                 <a:ea typeface="Arial"/>
                 <a:cs typeface="Arial"/>
               </a:rPr>
-              <a:t>Scenario scn-c46e1d86c1</a:t>
+              <a:t>Scenario scn-e0f12f397e</a:t>
             </a:r>
           </a:p>
         </p:txBody>
@@ -15498,7 +15560,7 @@
           <p:cNvPr id="34" name="">
             <a:extLst xmlns:a="http://schemas.openxmlformats.org/drawingml/2006/main">
               <a:ext uri="{FF2B5EF4-FFF2-40B4-BE49-F238E27FC236}">
-                <a16:creationId xmlns:a16="http://schemas.microsoft.com/office/drawing/2014/main" id="{16081426-EA01-49C4-9A7D-081C4208A9EC}"/>
+                <a16:creationId xmlns:a16="http://schemas.microsoft.com/office/drawing/2014/main" id="{E5F408AF-7C59-4DC7-A3E9-29B282B744C9}"/>
               </a:ext>
             </a:extLst>
           </p:cNvPr>
@@ -15529,7 +15591,7 @@
           <p:cNvPr id="35" name="">
             <a:extLst xmlns:a="http://schemas.openxmlformats.org/drawingml/2006/main">
               <a:ext uri="{FF2B5EF4-FFF2-40B4-BE49-F238E27FC236}">
-                <a16:creationId xmlns:a16="http://schemas.microsoft.com/office/drawing/2014/main" id="{27013870-461E-4683-A099-57F191DE735B}"/>
+                <a16:creationId xmlns:a16="http://schemas.microsoft.com/office/drawing/2014/main" id="{10735DE0-44EB-4D22-8C17-C29C68160079}"/>
               </a:ext>
             </a:extLst>
           </p:cNvPr>
@@ -15581,7 +15643,7 @@
                 <a:ea typeface="Arial"/>
                 <a:cs typeface="Arial"/>
               </a:rPr>
-              <a:t>r2z-16690ccbe328 · scn-c46e1d86c1</a:t>
+              <a:t>r2z-45c4ba076af9 · scn-e0f12f397e</a:t>
             </a:r>
           </a:p>
         </p:txBody>
@@ -15591,7 +15653,7 @@
           <p:cNvPr id="36" name="">
             <a:extLst xmlns:a="http://schemas.openxmlformats.org/drawingml/2006/main">
               <a:ext uri="{FF2B5EF4-FFF2-40B4-BE49-F238E27FC236}">
-                <a16:creationId xmlns:a16="http://schemas.microsoft.com/office/drawing/2014/main" id="{3C02308F-83D9-4FEC-8B90-9C7FFBD7435A}"/>
+                <a16:creationId xmlns:a16="http://schemas.microsoft.com/office/drawing/2014/main" id="{6E2A68B5-9045-435C-8ED9-8EEC7B3F5090}"/>
               </a:ext>
             </a:extLst>
           </p:cNvPr>
@@ -15651,7 +15713,7 @@
     </p:spTree>
     <p:extLst>
       <p:ext uri="{BB962C8B-B14F-4D97-AF65-F5344CB8AC3E}">
-        <p14:creationId xmlns:p14="http://schemas.microsoft.com/office/powerpoint/2010/main" val="907260726"/>
+        <p14:creationId xmlns:p14="http://schemas.microsoft.com/office/powerpoint/2010/main" val="1390827338"/>
       </p:ext>
     </p:extLst>
   </p:cSld>
@@ -15682,7 +15744,7 @@
           <p:cNvPr id="21" name="">
             <a:extLst xmlns:a="http://schemas.openxmlformats.org/drawingml/2006/main">
               <a:ext uri="{FF2B5EF4-FFF2-40B4-BE49-F238E27FC236}">
-                <a16:creationId xmlns:a16="http://schemas.microsoft.com/office/drawing/2014/main" id="{BEAE4641-2061-4392-8622-5DE7D3FC3425}"/>
+                <a16:creationId xmlns:a16="http://schemas.microsoft.com/office/drawing/2014/main" id="{129492F6-7682-49F8-9D99-F163068F2C0A}"/>
               </a:ext>
             </a:extLst>
           </p:cNvPr>
@@ -15744,7 +15806,7 @@
                 <a:latin typeface="Arial"/>
                 <a:ea typeface="Arial"/>
                 <a:cs typeface="Arial"/>
-                <a:hlinkClick xmlns:r="http://schemas.openxmlformats.org/officeDocument/2006/relationships" r:id="R9861ed7c5e704ed4"/>
+                <a:hlinkClick xmlns:r="http://schemas.openxmlformats.org/officeDocument/2006/relationships" r:id="R2f95a511d8964732"/>
               </a:rPr>
               <a:t>https://github.com/qjmre23/Route2Zero</a:t>
             </a:r>
@@ -15767,7 +15829,7 @@
                 <a:latin typeface="Arial"/>
                 <a:ea typeface="Arial"/>
                 <a:cs typeface="Arial"/>
-                <a:hlinkClick xmlns:r="http://schemas.openxmlformats.org/officeDocument/2006/relationships" r:id="R3560966087564b82"/>
+                <a:hlinkClick xmlns:r="http://schemas.openxmlformats.org/officeDocument/2006/relationships" r:id="R98be2ef8e4974488"/>
               </a:rPr>
               <a:t>https://route2zero.netlify.app/</a:t>
             </a:r>
@@ -15779,7 +15841,7 @@
           <p:cNvPr id="2" name="">
             <a:extLst xmlns:a="http://schemas.openxmlformats.org/drawingml/2006/main">
               <a:ext uri="{FF2B5EF4-FFF2-40B4-BE49-F238E27FC236}">
-                <a16:creationId xmlns:a16="http://schemas.microsoft.com/office/drawing/2014/main" id="{7A7FB32A-B077-45C5-B68A-4228FBFAD9D6}"/>
+                <a16:creationId xmlns:a16="http://schemas.microsoft.com/office/drawing/2014/main" id="{57A44D6A-C469-41A9-A809-7EBB9031C9C4}"/>
               </a:ext>
             </a:extLst>
           </p:cNvPr>
@@ -15841,7 +15903,7 @@
           <p:cNvPr id="3" name="">
             <a:extLst xmlns:a="http://schemas.openxmlformats.org/drawingml/2006/main">
               <a:ext uri="{FF2B5EF4-FFF2-40B4-BE49-F238E27FC236}">
-                <a16:creationId xmlns:a16="http://schemas.microsoft.com/office/drawing/2014/main" id="{5140E555-5AC6-4430-BCD0-ED8B54A584C4}"/>
+                <a16:creationId xmlns:a16="http://schemas.microsoft.com/office/drawing/2014/main" id="{24254EC4-3AE1-40F9-8B8F-C253A0174EE9}"/>
               </a:ext>
             </a:extLst>
           </p:cNvPr>
@@ -15907,8 +15969,8 @@
           <p:nvPr/>
         </p:nvPicPr>
         <p:blipFill>
-          <a:blip xmlns:r="http://schemas.openxmlformats.org/officeDocument/2006/relationships" xmlns:a="http://schemas.openxmlformats.org/drawingml/2006/main" r:embed="R0c639428723e4e4b"/>
-          <a:srcRect xmlns:a="http://schemas.openxmlformats.org/drawingml/2006/main" l="0" t="15675" r="0" b="15675"/>
+          <a:blip xmlns:r="http://schemas.openxmlformats.org/officeDocument/2006/relationships" xmlns:a="http://schemas.openxmlformats.org/drawingml/2006/main" r:embed="R1346776189664d70"/>
+          <a:srcRect xmlns:a="http://schemas.openxmlformats.org/drawingml/2006/main" l="0" t="15682" r="0" b="15682"/>
           <a:stretch xmlns:a="http://schemas.openxmlformats.org/drawingml/2006/main">
             <a:fillRect l="0" t="0" r="0" b="0"/>
           </a:stretch>
@@ -15930,7 +15992,7 @@
           <p:cNvPr id="5" name="">
             <a:extLst xmlns:a="http://schemas.openxmlformats.org/drawingml/2006/main">
               <a:ext uri="{FF2B5EF4-FFF2-40B4-BE49-F238E27FC236}">
-                <a16:creationId xmlns:a16="http://schemas.microsoft.com/office/drawing/2014/main" id="{06548BEA-7337-44B2-8308-30820CF86D77}"/>
+                <a16:creationId xmlns:a16="http://schemas.microsoft.com/office/drawing/2014/main" id="{50638FFA-76D9-44C0-9D1E-01901E3F5A00}"/>
               </a:ext>
             </a:extLst>
           </p:cNvPr>
@@ -15963,7 +16025,7 @@
           <p:cNvPr id="6" name="">
             <a:extLst xmlns:a="http://schemas.openxmlformats.org/drawingml/2006/main">
               <a:ext uri="{FF2B5EF4-FFF2-40B4-BE49-F238E27FC236}">
-                <a16:creationId xmlns:a16="http://schemas.microsoft.com/office/drawing/2014/main" id="{2E7B22A7-23B1-4EDD-81E7-6A1C64968041}"/>
+                <a16:creationId xmlns:a16="http://schemas.microsoft.com/office/drawing/2014/main" id="{BFBA8D4A-431D-41B8-B361-3A385ADDEE5E}"/>
               </a:ext>
             </a:extLst>
           </p:cNvPr>
@@ -15994,7 +16056,7 @@
           <p:cNvPr id="7" name="">
             <a:extLst xmlns:a="http://schemas.openxmlformats.org/drawingml/2006/main">
               <a:ext uri="{FF2B5EF4-FFF2-40B4-BE49-F238E27FC236}">
-                <a16:creationId xmlns:a16="http://schemas.microsoft.com/office/drawing/2014/main" id="{2BFD9934-5A0A-4B67-A1BD-74EA5CC0D03F}"/>
+                <a16:creationId xmlns:a16="http://schemas.microsoft.com/office/drawing/2014/main" id="{15D9C86A-879D-4F6F-A24A-BB5F0471FF3F}"/>
               </a:ext>
             </a:extLst>
           </p:cNvPr>
@@ -16056,7 +16118,7 @@
           <p:cNvPr id="8" name="">
             <a:extLst xmlns:a="http://schemas.openxmlformats.org/drawingml/2006/main">
               <a:ext uri="{FF2B5EF4-FFF2-40B4-BE49-F238E27FC236}">
-                <a16:creationId xmlns:a16="http://schemas.microsoft.com/office/drawing/2014/main" id="{3AC73F94-FC75-4A6F-B7F0-24BB33875FFB}"/>
+                <a16:creationId xmlns:a16="http://schemas.microsoft.com/office/drawing/2014/main" id="{5A1C6C1C-DDCA-4615-8589-D5C2EADC3851}"/>
               </a:ext>
             </a:extLst>
           </p:cNvPr>
@@ -16091,7 +16153,7 @@
           <p:cNvPr id="9" name="">
             <a:extLst xmlns:a="http://schemas.openxmlformats.org/drawingml/2006/main">
               <a:ext uri="{FF2B5EF4-FFF2-40B4-BE49-F238E27FC236}">
-                <a16:creationId xmlns:a16="http://schemas.microsoft.com/office/drawing/2014/main" id="{FA53444F-212B-4AD6-BC5D-E6E60295FE0D}"/>
+                <a16:creationId xmlns:a16="http://schemas.microsoft.com/office/drawing/2014/main" id="{6337047B-2E17-4ABA-BF65-3B499C9B6E0C}"/>
               </a:ext>
             </a:extLst>
           </p:cNvPr>
@@ -16153,7 +16215,7 @@
           <p:cNvPr id="10" name="">
             <a:extLst xmlns:a="http://schemas.openxmlformats.org/drawingml/2006/main">
               <a:ext uri="{FF2B5EF4-FFF2-40B4-BE49-F238E27FC236}">
-                <a16:creationId xmlns:a16="http://schemas.microsoft.com/office/drawing/2014/main" id="{7A5BDE8C-F98C-42E9-9644-93AE2B5A76D3}"/>
+                <a16:creationId xmlns:a16="http://schemas.microsoft.com/office/drawing/2014/main" id="{C48E97B4-042B-4B42-B3A8-161EAE5D0ADC}"/>
               </a:ext>
             </a:extLst>
           </p:cNvPr>
@@ -16184,7 +16246,7 @@
           <p:cNvPr id="11" name="">
             <a:extLst xmlns:a="http://schemas.openxmlformats.org/drawingml/2006/main">
               <a:ext uri="{FF2B5EF4-FFF2-40B4-BE49-F238E27FC236}">
-                <a16:creationId xmlns:a16="http://schemas.microsoft.com/office/drawing/2014/main" id="{262F6D7F-E5CD-48AC-873E-CC20F802DAC6}"/>
+                <a16:creationId xmlns:a16="http://schemas.microsoft.com/office/drawing/2014/main" id="{09034925-33F0-4D56-8829-81FC5F46D0FA}"/>
               </a:ext>
             </a:extLst>
           </p:cNvPr>
@@ -16246,7 +16308,7 @@
           <p:cNvPr id="12" name="">
             <a:extLst xmlns:a="http://schemas.openxmlformats.org/drawingml/2006/main">
               <a:ext uri="{FF2B5EF4-FFF2-40B4-BE49-F238E27FC236}">
-                <a16:creationId xmlns:a16="http://schemas.microsoft.com/office/drawing/2014/main" id="{4866D7B5-B7A3-4DE9-961E-041291C9199D}"/>
+                <a16:creationId xmlns:a16="http://schemas.microsoft.com/office/drawing/2014/main" id="{3FCCB837-6E4A-49F7-A266-3F8A3EF5CF76}"/>
               </a:ext>
             </a:extLst>
           </p:cNvPr>
@@ -16281,7 +16343,7 @@
           <p:cNvPr id="13" name="">
             <a:extLst xmlns:a="http://schemas.openxmlformats.org/drawingml/2006/main">
               <a:ext uri="{FF2B5EF4-FFF2-40B4-BE49-F238E27FC236}">
-                <a16:creationId xmlns:a16="http://schemas.microsoft.com/office/drawing/2014/main" id="{27C0371C-5399-4D3F-8E08-C756C6FB1286}"/>
+                <a16:creationId xmlns:a16="http://schemas.microsoft.com/office/drawing/2014/main" id="{12612497-65C9-47DD-8BA2-6926CFCE5ADF}"/>
               </a:ext>
             </a:extLst>
           </p:cNvPr>
@@ -16343,7 +16405,7 @@
           <p:cNvPr id="14" name="">
             <a:extLst xmlns:a="http://schemas.openxmlformats.org/drawingml/2006/main">
               <a:ext uri="{FF2B5EF4-FFF2-40B4-BE49-F238E27FC236}">
-                <a16:creationId xmlns:a16="http://schemas.microsoft.com/office/drawing/2014/main" id="{764603DC-E167-44B3-B62A-D88983C7E118}"/>
+                <a16:creationId xmlns:a16="http://schemas.microsoft.com/office/drawing/2014/main" id="{2BD1D627-3E78-4A1D-84E5-506B5B896A87}"/>
               </a:ext>
             </a:extLst>
           </p:cNvPr>
@@ -16374,7 +16436,7 @@
           <p:cNvPr id="15" name="">
             <a:extLst xmlns:a="http://schemas.openxmlformats.org/drawingml/2006/main">
               <a:ext uri="{FF2B5EF4-FFF2-40B4-BE49-F238E27FC236}">
-                <a16:creationId xmlns:a16="http://schemas.microsoft.com/office/drawing/2014/main" id="{6F0644A0-BA48-4FD0-A099-65093878E259}"/>
+                <a16:creationId xmlns:a16="http://schemas.microsoft.com/office/drawing/2014/main" id="{169A4B23-3C3E-4D9C-98A1-DFFBB9184049}"/>
               </a:ext>
             </a:extLst>
           </p:cNvPr>
@@ -16436,7 +16498,7 @@
           <p:cNvPr id="16" name="">
             <a:extLst xmlns:a="http://schemas.openxmlformats.org/drawingml/2006/main">
               <a:ext uri="{FF2B5EF4-FFF2-40B4-BE49-F238E27FC236}">
-                <a16:creationId xmlns:a16="http://schemas.microsoft.com/office/drawing/2014/main" id="{08C02AF8-176D-48D1-B7E2-E207AA438A61}"/>
+                <a16:creationId xmlns:a16="http://schemas.microsoft.com/office/drawing/2014/main" id="{7E3E771B-40B5-404D-9CCD-44AD8D7A9D42}"/>
               </a:ext>
             </a:extLst>
           </p:cNvPr>
@@ -16471,7 +16533,7 @@
           <p:cNvPr id="17" name="">
             <a:extLst xmlns:a="http://schemas.openxmlformats.org/drawingml/2006/main">
               <a:ext uri="{FF2B5EF4-FFF2-40B4-BE49-F238E27FC236}">
-                <a16:creationId xmlns:a16="http://schemas.microsoft.com/office/drawing/2014/main" id="{DAF81DA0-A475-43BA-9166-0C64F5D335A6}"/>
+                <a16:creationId xmlns:a16="http://schemas.microsoft.com/office/drawing/2014/main" id="{861F40F2-B0D8-47E1-9D46-E71DAE1FAA30}"/>
               </a:ext>
             </a:extLst>
           </p:cNvPr>
@@ -16533,7 +16595,7 @@
           <p:cNvPr id="18" name="">
             <a:extLst xmlns:a="http://schemas.openxmlformats.org/drawingml/2006/main">
               <a:ext uri="{FF2B5EF4-FFF2-40B4-BE49-F238E27FC236}">
-                <a16:creationId xmlns:a16="http://schemas.microsoft.com/office/drawing/2014/main" id="{98E2396C-CCB2-43E2-8938-22938073BD2A}"/>
+                <a16:creationId xmlns:a16="http://schemas.microsoft.com/office/drawing/2014/main" id="{6744F369-C10F-4E83-894D-657DB756B5C9}"/>
               </a:ext>
             </a:extLst>
           </p:cNvPr>
@@ -16564,7 +16626,7 @@
           <p:cNvPr id="19" name="">
             <a:extLst xmlns:a="http://schemas.openxmlformats.org/drawingml/2006/main">
               <a:ext uri="{FF2B5EF4-FFF2-40B4-BE49-F238E27FC236}">
-                <a16:creationId xmlns:a16="http://schemas.microsoft.com/office/drawing/2014/main" id="{96AF63A6-9302-4AA9-BF2F-C98412E074FB}"/>
+                <a16:creationId xmlns:a16="http://schemas.microsoft.com/office/drawing/2014/main" id="{CCE7E7CF-C476-4F7C-B653-84A4C6115C18}"/>
               </a:ext>
             </a:extLst>
           </p:cNvPr>
@@ -16616,7 +16678,7 @@
                 <a:ea typeface="Arial"/>
                 <a:cs typeface="Arial"/>
               </a:rPr>
-              <a:t>r2z-16690ccbe328 · scn-c46e1d86c1</a:t>
+              <a:t>r2z-45c4ba076af9 · scn-e0f12f397e</a:t>
             </a:r>
           </a:p>
         </p:txBody>
@@ -16626,7 +16688,7 @@
           <p:cNvPr id="20" name="">
             <a:extLst xmlns:a="http://schemas.openxmlformats.org/drawingml/2006/main">
               <a:ext uri="{FF2B5EF4-FFF2-40B4-BE49-F238E27FC236}">
-                <a16:creationId xmlns:a16="http://schemas.microsoft.com/office/drawing/2014/main" id="{AE0C1D26-99F0-44B3-8305-C7874268717F}"/>
+                <a16:creationId xmlns:a16="http://schemas.microsoft.com/office/drawing/2014/main" id="{5B941FCE-DABB-4FAF-BA00-A2438572219C}"/>
               </a:ext>
             </a:extLst>
           </p:cNvPr>
@@ -16686,7 +16748,7 @@
     </p:spTree>
     <p:extLst>
       <p:ext uri="{BB962C8B-B14F-4D97-AF65-F5344CB8AC3E}">
-        <p14:creationId xmlns:p14="http://schemas.microsoft.com/office/powerpoint/2010/main" val="429617820"/>
+        <p14:creationId xmlns:p14="http://schemas.microsoft.com/office/powerpoint/2010/main" val="1920008480"/>
       </p:ext>
     </p:extLst>
   </p:cSld>
@@ -16717,7 +16779,7 @@
           <p:cNvPr id="21" name="">
             <a:extLst xmlns:a="http://schemas.openxmlformats.org/drawingml/2006/main">
               <a:ext uri="{FF2B5EF4-FFF2-40B4-BE49-F238E27FC236}">
-                <a16:creationId xmlns:a16="http://schemas.microsoft.com/office/drawing/2014/main" id="{B11A8A11-B7AB-4122-84E5-F86F171F2154}"/>
+                <a16:creationId xmlns:a16="http://schemas.microsoft.com/office/drawing/2014/main" id="{26739F3C-AAA7-4BDB-8F53-5922E3BD3C68}"/>
               </a:ext>
             </a:extLst>
           </p:cNvPr>
@@ -16779,7 +16841,7 @@
                 <a:latin typeface="Arial"/>
                 <a:ea typeface="Arial"/>
                 <a:cs typeface="Arial"/>
-                <a:hlinkClick xmlns:r="http://schemas.openxmlformats.org/officeDocument/2006/relationships" r:id="R2470214d6b814897"/>
+                <a:hlinkClick xmlns:r="http://schemas.openxmlformats.org/officeDocument/2006/relationships" r:id="R5e8578cdbf014263"/>
               </a:rPr>
               <a:t>https://github.com/qjmre23/Route2Zero</a:t>
             </a:r>
@@ -16802,7 +16864,7 @@
                 <a:latin typeface="Arial"/>
                 <a:ea typeface="Arial"/>
                 <a:cs typeface="Arial"/>
-                <a:hlinkClick xmlns:r="http://schemas.openxmlformats.org/officeDocument/2006/relationships" r:id="Re19e849c18284b84"/>
+                <a:hlinkClick xmlns:r="http://schemas.openxmlformats.org/officeDocument/2006/relationships" r:id="R044409e2a0d74794"/>
               </a:rPr>
               <a:t>https://route2zero.netlify.app/</a:t>
             </a:r>
@@ -16814,7 +16876,7 @@
           <p:cNvPr id="2" name="">
             <a:extLst xmlns:a="http://schemas.openxmlformats.org/drawingml/2006/main">
               <a:ext uri="{FF2B5EF4-FFF2-40B4-BE49-F238E27FC236}">
-                <a16:creationId xmlns:a16="http://schemas.microsoft.com/office/drawing/2014/main" id="{862812F0-50B8-4C69-916E-02DD6F609764}"/>
+                <a16:creationId xmlns:a16="http://schemas.microsoft.com/office/drawing/2014/main" id="{1F0B0CD9-3888-44B4-B396-F46B5844A2BD}"/>
               </a:ext>
             </a:extLst>
           </p:cNvPr>
@@ -16876,7 +16938,7 @@
           <p:cNvPr id="3" name="">
             <a:extLst xmlns:a="http://schemas.openxmlformats.org/drawingml/2006/main">
               <a:ext uri="{FF2B5EF4-FFF2-40B4-BE49-F238E27FC236}">
-                <a16:creationId xmlns:a16="http://schemas.microsoft.com/office/drawing/2014/main" id="{AF37089E-F7E4-48E7-ABB3-45858B67A7F1}"/>
+                <a16:creationId xmlns:a16="http://schemas.microsoft.com/office/drawing/2014/main" id="{953FC5B3-7469-402A-B98E-D27AE2622BE6}"/>
               </a:ext>
             </a:extLst>
           </p:cNvPr>
@@ -16942,8 +17004,8 @@
           <p:nvPr/>
         </p:nvPicPr>
         <p:blipFill>
-          <a:blip xmlns:r="http://schemas.openxmlformats.org/officeDocument/2006/relationships" xmlns:a="http://schemas.openxmlformats.org/drawingml/2006/main" r:embed="Rdb64d4616a494bda"/>
-          <a:srcRect xmlns:a="http://schemas.openxmlformats.org/drawingml/2006/main" l="0" t="15675" r="0" b="15675"/>
+          <a:blip xmlns:r="http://schemas.openxmlformats.org/officeDocument/2006/relationships" xmlns:a="http://schemas.openxmlformats.org/drawingml/2006/main" r:embed="R97c1c69b4c58469d"/>
+          <a:srcRect xmlns:a="http://schemas.openxmlformats.org/drawingml/2006/main" l="0" t="15682" r="0" b="15682"/>
           <a:stretch xmlns:a="http://schemas.openxmlformats.org/drawingml/2006/main">
             <a:fillRect l="0" t="0" r="0" b="0"/>
           </a:stretch>
@@ -16965,7 +17027,7 @@
           <p:cNvPr id="5" name="">
             <a:extLst xmlns:a="http://schemas.openxmlformats.org/drawingml/2006/main">
               <a:ext uri="{FF2B5EF4-FFF2-40B4-BE49-F238E27FC236}">
-                <a16:creationId xmlns:a16="http://schemas.microsoft.com/office/drawing/2014/main" id="{FA3AFB40-BDB4-4DD0-9C1C-CDDD2FD0CA2B}"/>
+                <a16:creationId xmlns:a16="http://schemas.microsoft.com/office/drawing/2014/main" id="{0B9206E1-E03E-4C3E-8C03-925076DDC860}"/>
               </a:ext>
             </a:extLst>
           </p:cNvPr>
@@ -16998,7 +17060,7 @@
           <p:cNvPr id="6" name="">
             <a:extLst xmlns:a="http://schemas.openxmlformats.org/drawingml/2006/main">
               <a:ext uri="{FF2B5EF4-FFF2-40B4-BE49-F238E27FC236}">
-                <a16:creationId xmlns:a16="http://schemas.microsoft.com/office/drawing/2014/main" id="{96006D8D-9E12-42DD-8B8F-B9E6ED67A5A9}"/>
+                <a16:creationId xmlns:a16="http://schemas.microsoft.com/office/drawing/2014/main" id="{3B792E6C-17E2-43B5-BC0D-259B88C36FA0}"/>
               </a:ext>
             </a:extLst>
           </p:cNvPr>
@@ -17029,7 +17091,7 @@
           <p:cNvPr id="7" name="">
             <a:extLst xmlns:a="http://schemas.openxmlformats.org/drawingml/2006/main">
               <a:ext uri="{FF2B5EF4-FFF2-40B4-BE49-F238E27FC236}">
-                <a16:creationId xmlns:a16="http://schemas.microsoft.com/office/drawing/2014/main" id="{CCDB81FF-32B9-47C5-BF9A-12B126F530E2}"/>
+                <a16:creationId xmlns:a16="http://schemas.microsoft.com/office/drawing/2014/main" id="{47602AF2-2EBF-4B97-A31D-F13771DBD19E}"/>
               </a:ext>
             </a:extLst>
           </p:cNvPr>
@@ -17091,7 +17153,7 @@
           <p:cNvPr id="8" name="">
             <a:extLst xmlns:a="http://schemas.openxmlformats.org/drawingml/2006/main">
               <a:ext uri="{FF2B5EF4-FFF2-40B4-BE49-F238E27FC236}">
-                <a16:creationId xmlns:a16="http://schemas.microsoft.com/office/drawing/2014/main" id="{80D75ABB-BE99-4C3A-A679-9A7107DD3F16}"/>
+                <a16:creationId xmlns:a16="http://schemas.microsoft.com/office/drawing/2014/main" id="{6C120A14-57D4-4C16-8DDC-58EBF13E50F5}"/>
               </a:ext>
             </a:extLst>
           </p:cNvPr>
@@ -17126,7 +17188,7 @@
           <p:cNvPr id="9" name="">
             <a:extLst xmlns:a="http://schemas.openxmlformats.org/drawingml/2006/main">
               <a:ext uri="{FF2B5EF4-FFF2-40B4-BE49-F238E27FC236}">
-                <a16:creationId xmlns:a16="http://schemas.microsoft.com/office/drawing/2014/main" id="{C89031EF-AEF7-424A-B487-0604B170244D}"/>
+                <a16:creationId xmlns:a16="http://schemas.microsoft.com/office/drawing/2014/main" id="{D2D259F4-C381-466A-A771-99BED67CB019}"/>
               </a:ext>
             </a:extLst>
           </p:cNvPr>
@@ -17188,7 +17250,7 @@
           <p:cNvPr id="10" name="">
             <a:extLst xmlns:a="http://schemas.openxmlformats.org/drawingml/2006/main">
               <a:ext uri="{FF2B5EF4-FFF2-40B4-BE49-F238E27FC236}">
-                <a16:creationId xmlns:a16="http://schemas.microsoft.com/office/drawing/2014/main" id="{87BA9EDA-7258-40CF-933F-4677F5931110}"/>
+                <a16:creationId xmlns:a16="http://schemas.microsoft.com/office/drawing/2014/main" id="{ACA6BB18-EF94-45FB-980A-A18EE34BC8FC}"/>
               </a:ext>
             </a:extLst>
           </p:cNvPr>
@@ -17219,7 +17281,7 @@
           <p:cNvPr id="11" name="">
             <a:extLst xmlns:a="http://schemas.openxmlformats.org/drawingml/2006/main">
               <a:ext uri="{FF2B5EF4-FFF2-40B4-BE49-F238E27FC236}">
-                <a16:creationId xmlns:a16="http://schemas.microsoft.com/office/drawing/2014/main" id="{95014BE6-7440-4F02-B793-E44A79F6B154}"/>
+                <a16:creationId xmlns:a16="http://schemas.microsoft.com/office/drawing/2014/main" id="{950439A6-B937-4F35-82C8-0CD232648AD7}"/>
               </a:ext>
             </a:extLst>
           </p:cNvPr>
@@ -17281,7 +17343,7 @@
           <p:cNvPr id="12" name="">
             <a:extLst xmlns:a="http://schemas.openxmlformats.org/drawingml/2006/main">
               <a:ext uri="{FF2B5EF4-FFF2-40B4-BE49-F238E27FC236}">
-                <a16:creationId xmlns:a16="http://schemas.microsoft.com/office/drawing/2014/main" id="{202102AC-8B00-4B4B-9386-0A574D521A11}"/>
+                <a16:creationId xmlns:a16="http://schemas.microsoft.com/office/drawing/2014/main" id="{DFA41867-7E3B-4860-816C-545E145E2D8E}"/>
               </a:ext>
             </a:extLst>
           </p:cNvPr>
@@ -17316,7 +17378,7 @@
           <p:cNvPr id="13" name="">
             <a:extLst xmlns:a="http://schemas.openxmlformats.org/drawingml/2006/main">
               <a:ext uri="{FF2B5EF4-FFF2-40B4-BE49-F238E27FC236}">
-                <a16:creationId xmlns:a16="http://schemas.microsoft.com/office/drawing/2014/main" id="{200AF7BB-A54D-450D-85E4-0F98221A6297}"/>
+                <a16:creationId xmlns:a16="http://schemas.microsoft.com/office/drawing/2014/main" id="{2C527B58-50F2-411F-A832-7653D254C5A8}"/>
               </a:ext>
             </a:extLst>
           </p:cNvPr>
@@ -17378,7 +17440,7 @@
           <p:cNvPr id="14" name="">
             <a:extLst xmlns:a="http://schemas.openxmlformats.org/drawingml/2006/main">
               <a:ext uri="{FF2B5EF4-FFF2-40B4-BE49-F238E27FC236}">
-                <a16:creationId xmlns:a16="http://schemas.microsoft.com/office/drawing/2014/main" id="{055C1B77-B0E1-40BB-81DF-54EDBB8BB32B}"/>
+                <a16:creationId xmlns:a16="http://schemas.microsoft.com/office/drawing/2014/main" id="{FD1B3931-CAED-456E-957C-8A100234E104}"/>
               </a:ext>
             </a:extLst>
           </p:cNvPr>
@@ -17409,7 +17471,7 @@
           <p:cNvPr id="15" name="">
             <a:extLst xmlns:a="http://schemas.openxmlformats.org/drawingml/2006/main">
               <a:ext uri="{FF2B5EF4-FFF2-40B4-BE49-F238E27FC236}">
-                <a16:creationId xmlns:a16="http://schemas.microsoft.com/office/drawing/2014/main" id="{F29AD882-4039-4134-8C49-36A81C8AF8B7}"/>
+                <a16:creationId xmlns:a16="http://schemas.microsoft.com/office/drawing/2014/main" id="{77F54574-8C41-49CC-935F-FF067FAD0C99}"/>
               </a:ext>
             </a:extLst>
           </p:cNvPr>
@@ -17471,7 +17533,7 @@
           <p:cNvPr id="16" name="">
             <a:extLst xmlns:a="http://schemas.openxmlformats.org/drawingml/2006/main">
               <a:ext uri="{FF2B5EF4-FFF2-40B4-BE49-F238E27FC236}">
-                <a16:creationId xmlns:a16="http://schemas.microsoft.com/office/drawing/2014/main" id="{3EEEE2E1-4C78-4DB6-A2E2-45F56B064A3B}"/>
+                <a16:creationId xmlns:a16="http://schemas.microsoft.com/office/drawing/2014/main" id="{F17BF1C5-254D-4B45-9BDE-3D444ECE9087}"/>
               </a:ext>
             </a:extLst>
           </p:cNvPr>
@@ -17506,7 +17568,7 @@
           <p:cNvPr id="17" name="">
             <a:extLst xmlns:a="http://schemas.openxmlformats.org/drawingml/2006/main">
               <a:ext uri="{FF2B5EF4-FFF2-40B4-BE49-F238E27FC236}">
-                <a16:creationId xmlns:a16="http://schemas.microsoft.com/office/drawing/2014/main" id="{68D3DB2A-9ABB-4CB0-A9CB-B7E992BFDEED}"/>
+                <a16:creationId xmlns:a16="http://schemas.microsoft.com/office/drawing/2014/main" id="{85025F02-A52B-4F23-AC75-F9A78E9D841C}"/>
               </a:ext>
             </a:extLst>
           </p:cNvPr>
@@ -17568,7 +17630,7 @@
           <p:cNvPr id="18" name="">
             <a:extLst xmlns:a="http://schemas.openxmlformats.org/drawingml/2006/main">
               <a:ext uri="{FF2B5EF4-FFF2-40B4-BE49-F238E27FC236}">
-                <a16:creationId xmlns:a16="http://schemas.microsoft.com/office/drawing/2014/main" id="{DD85F184-E417-4C7E-9612-CC43B534A53E}"/>
+                <a16:creationId xmlns:a16="http://schemas.microsoft.com/office/drawing/2014/main" id="{88B8B171-3692-46B7-B48F-277EE4F3791B}"/>
               </a:ext>
             </a:extLst>
           </p:cNvPr>
@@ -17599,7 +17661,7 @@
           <p:cNvPr id="19" name="">
             <a:extLst xmlns:a="http://schemas.openxmlformats.org/drawingml/2006/main">
               <a:ext uri="{FF2B5EF4-FFF2-40B4-BE49-F238E27FC236}">
-                <a16:creationId xmlns:a16="http://schemas.microsoft.com/office/drawing/2014/main" id="{27388CF8-F61B-4F34-9545-4ECB4E51F10C}"/>
+                <a16:creationId xmlns:a16="http://schemas.microsoft.com/office/drawing/2014/main" id="{7D3CBB00-C0B4-4744-A264-02628ECFF47E}"/>
               </a:ext>
             </a:extLst>
           </p:cNvPr>
@@ -17651,7 +17713,7 @@
                 <a:ea typeface="Arial"/>
                 <a:cs typeface="Arial"/>
               </a:rPr>
-              <a:t>r2z-16690ccbe328 · scn-c46e1d86c1</a:t>
+              <a:t>r2z-45c4ba076af9 · scn-e0f12f397e</a:t>
             </a:r>
           </a:p>
         </p:txBody>
@@ -17661,7 +17723,7 @@
           <p:cNvPr id="20" name="">
             <a:extLst xmlns:a="http://schemas.openxmlformats.org/drawingml/2006/main">
               <a:ext uri="{FF2B5EF4-FFF2-40B4-BE49-F238E27FC236}">
-                <a16:creationId xmlns:a16="http://schemas.microsoft.com/office/drawing/2014/main" id="{B6EDFCB3-DC8C-4D67-944F-042F46E9004E}"/>
+                <a16:creationId xmlns:a16="http://schemas.microsoft.com/office/drawing/2014/main" id="{0CA0A3AA-95E8-40ED-BDFE-94329A73A3DB}"/>
               </a:ext>
             </a:extLst>
           </p:cNvPr>
@@ -17721,7 +17783,7 @@
     </p:spTree>
     <p:extLst>
       <p:ext uri="{BB962C8B-B14F-4D97-AF65-F5344CB8AC3E}">
-        <p14:creationId xmlns:p14="http://schemas.microsoft.com/office/powerpoint/2010/main" val="1001814824"/>
+        <p14:creationId xmlns:p14="http://schemas.microsoft.com/office/powerpoint/2010/main" val="1127813318"/>
       </p:ext>
     </p:extLst>
   </p:cSld>
@@ -17752,7 +17814,7 @@
           <p:cNvPr id="21" name="">
             <a:extLst xmlns:a="http://schemas.openxmlformats.org/drawingml/2006/main">
               <a:ext uri="{FF2B5EF4-FFF2-40B4-BE49-F238E27FC236}">
-                <a16:creationId xmlns:a16="http://schemas.microsoft.com/office/drawing/2014/main" id="{3C503C72-512D-459D-9D7A-8C1401CA1AA0}"/>
+                <a16:creationId xmlns:a16="http://schemas.microsoft.com/office/drawing/2014/main" id="{AD6FD905-DA66-4783-A947-FA2507C71659}"/>
               </a:ext>
             </a:extLst>
           </p:cNvPr>
@@ -17814,7 +17876,7 @@
                 <a:latin typeface="Arial"/>
                 <a:ea typeface="Arial"/>
                 <a:cs typeface="Arial"/>
-                <a:hlinkClick xmlns:r="http://schemas.openxmlformats.org/officeDocument/2006/relationships" r:id="R4c05eb7c46624520"/>
+                <a:hlinkClick xmlns:r="http://schemas.openxmlformats.org/officeDocument/2006/relationships" r:id="Ra454b9f95e3e40e8"/>
               </a:rPr>
               <a:t>https://github.com/qjmre23/Route2Zero</a:t>
             </a:r>
@@ -17837,7 +17899,7 @@
                 <a:latin typeface="Arial"/>
                 <a:ea typeface="Arial"/>
                 <a:cs typeface="Arial"/>
-                <a:hlinkClick xmlns:r="http://schemas.openxmlformats.org/officeDocument/2006/relationships" r:id="Rbb2a590b449b4a9a"/>
+                <a:hlinkClick xmlns:r="http://schemas.openxmlformats.org/officeDocument/2006/relationships" r:id="Rc1c022a454a44ba1"/>
               </a:rPr>
               <a:t>https://route2zero.netlify.app/</a:t>
             </a:r>
@@ -17849,7 +17911,7 @@
           <p:cNvPr id="2" name="">
             <a:extLst xmlns:a="http://schemas.openxmlformats.org/drawingml/2006/main">
               <a:ext uri="{FF2B5EF4-FFF2-40B4-BE49-F238E27FC236}">
-                <a16:creationId xmlns:a16="http://schemas.microsoft.com/office/drawing/2014/main" id="{367EBB77-0545-455A-BF63-54480DBCDBFF}"/>
+                <a16:creationId xmlns:a16="http://schemas.microsoft.com/office/drawing/2014/main" id="{63720D7F-8D9B-40C4-8F5D-A83D506F8135}"/>
               </a:ext>
             </a:extLst>
           </p:cNvPr>
@@ -17911,7 +17973,7 @@
           <p:cNvPr id="3" name="">
             <a:extLst xmlns:a="http://schemas.openxmlformats.org/drawingml/2006/main">
               <a:ext uri="{FF2B5EF4-FFF2-40B4-BE49-F238E27FC236}">
-                <a16:creationId xmlns:a16="http://schemas.microsoft.com/office/drawing/2014/main" id="{57CCAB38-3B7E-4F6F-B138-56D8BCAEE6B3}"/>
+                <a16:creationId xmlns:a16="http://schemas.microsoft.com/office/drawing/2014/main" id="{0C484802-D568-4902-A0DC-3B39DAEA90AF}"/>
               </a:ext>
             </a:extLst>
           </p:cNvPr>
@@ -17977,8 +18039,8 @@
           <p:nvPr/>
         </p:nvPicPr>
         <p:blipFill>
-          <a:blip xmlns:r="http://schemas.openxmlformats.org/officeDocument/2006/relationships" xmlns:a="http://schemas.openxmlformats.org/drawingml/2006/main" r:embed="Rf947b72e02304e72"/>
-          <a:srcRect xmlns:a="http://schemas.openxmlformats.org/drawingml/2006/main" l="0" t="15675" r="0" b="15675"/>
+          <a:blip xmlns:r="http://schemas.openxmlformats.org/officeDocument/2006/relationships" xmlns:a="http://schemas.openxmlformats.org/drawingml/2006/main" r:embed="R2c497cbf9475429b"/>
+          <a:srcRect xmlns:a="http://schemas.openxmlformats.org/drawingml/2006/main" l="0" t="15682" r="0" b="15682"/>
           <a:stretch xmlns:a="http://schemas.openxmlformats.org/drawingml/2006/main">
             <a:fillRect l="0" t="0" r="0" b="0"/>
           </a:stretch>
@@ -18000,7 +18062,7 @@
           <p:cNvPr id="5" name="">
             <a:extLst xmlns:a="http://schemas.openxmlformats.org/drawingml/2006/main">
               <a:ext uri="{FF2B5EF4-FFF2-40B4-BE49-F238E27FC236}">
-                <a16:creationId xmlns:a16="http://schemas.microsoft.com/office/drawing/2014/main" id="{A197F906-09F8-4C7F-8A21-691F467CE48F}"/>
+                <a16:creationId xmlns:a16="http://schemas.microsoft.com/office/drawing/2014/main" id="{4F709154-929B-4D4E-A2A4-2D123D48F0E5}"/>
               </a:ext>
             </a:extLst>
           </p:cNvPr>
@@ -18033,7 +18095,7 @@
           <p:cNvPr id="6" name="">
             <a:extLst xmlns:a="http://schemas.openxmlformats.org/drawingml/2006/main">
               <a:ext uri="{FF2B5EF4-FFF2-40B4-BE49-F238E27FC236}">
-                <a16:creationId xmlns:a16="http://schemas.microsoft.com/office/drawing/2014/main" id="{E32DE901-0A5D-4F41-8E8E-5236E9522FEC}"/>
+                <a16:creationId xmlns:a16="http://schemas.microsoft.com/office/drawing/2014/main" id="{67AF5A36-3DBF-44DA-A1CF-A485FC8F9F09}"/>
               </a:ext>
             </a:extLst>
           </p:cNvPr>
@@ -18064,7 +18126,7 @@
           <p:cNvPr id="7" name="">
             <a:extLst xmlns:a="http://schemas.openxmlformats.org/drawingml/2006/main">
               <a:ext uri="{FF2B5EF4-FFF2-40B4-BE49-F238E27FC236}">
-                <a16:creationId xmlns:a16="http://schemas.microsoft.com/office/drawing/2014/main" id="{F744B5A7-B3B9-44B4-AFF8-A870F5BEF603}"/>
+                <a16:creationId xmlns:a16="http://schemas.microsoft.com/office/drawing/2014/main" id="{5376EBB2-1753-4015-982E-85027C466576}"/>
               </a:ext>
             </a:extLst>
           </p:cNvPr>
@@ -18126,7 +18188,7 @@
           <p:cNvPr id="8" name="">
             <a:extLst xmlns:a="http://schemas.openxmlformats.org/drawingml/2006/main">
               <a:ext uri="{FF2B5EF4-FFF2-40B4-BE49-F238E27FC236}">
-                <a16:creationId xmlns:a16="http://schemas.microsoft.com/office/drawing/2014/main" id="{56286945-B88A-4EFE-879B-83F5C78AE9C2}"/>
+                <a16:creationId xmlns:a16="http://schemas.microsoft.com/office/drawing/2014/main" id="{9B0DF665-B770-40D7-9117-641E324B0D1A}"/>
               </a:ext>
             </a:extLst>
           </p:cNvPr>
@@ -18161,7 +18223,7 @@
           <p:cNvPr id="9" name="">
             <a:extLst xmlns:a="http://schemas.openxmlformats.org/drawingml/2006/main">
               <a:ext uri="{FF2B5EF4-FFF2-40B4-BE49-F238E27FC236}">
-                <a16:creationId xmlns:a16="http://schemas.microsoft.com/office/drawing/2014/main" id="{66AC2B97-E691-4186-A6B4-8F8098FE4885}"/>
+                <a16:creationId xmlns:a16="http://schemas.microsoft.com/office/drawing/2014/main" id="{6289F56E-7071-4648-84F0-BABED6BE699F}"/>
               </a:ext>
             </a:extLst>
           </p:cNvPr>
@@ -18223,7 +18285,7 @@
           <p:cNvPr id="10" name="">
             <a:extLst xmlns:a="http://schemas.openxmlformats.org/drawingml/2006/main">
               <a:ext uri="{FF2B5EF4-FFF2-40B4-BE49-F238E27FC236}">
-                <a16:creationId xmlns:a16="http://schemas.microsoft.com/office/drawing/2014/main" id="{977CED66-E6F4-4699-A111-5BC87B035B5C}"/>
+                <a16:creationId xmlns:a16="http://schemas.microsoft.com/office/drawing/2014/main" id="{20FDDCC7-7A1F-4271-97BC-E8E97104DBC8}"/>
               </a:ext>
             </a:extLst>
           </p:cNvPr>
@@ -18254,7 +18316,7 @@
           <p:cNvPr id="11" name="">
             <a:extLst xmlns:a="http://schemas.openxmlformats.org/drawingml/2006/main">
               <a:ext uri="{FF2B5EF4-FFF2-40B4-BE49-F238E27FC236}">
-                <a16:creationId xmlns:a16="http://schemas.microsoft.com/office/drawing/2014/main" id="{57352F06-7C89-41F1-8117-547D453DA8CB}"/>
+                <a16:creationId xmlns:a16="http://schemas.microsoft.com/office/drawing/2014/main" id="{01AE05EE-D363-4461-90F3-C67FEB159DAD}"/>
               </a:ext>
             </a:extLst>
           </p:cNvPr>
@@ -18316,7 +18378,7 @@
           <p:cNvPr id="12" name="">
             <a:extLst xmlns:a="http://schemas.openxmlformats.org/drawingml/2006/main">
               <a:ext uri="{FF2B5EF4-FFF2-40B4-BE49-F238E27FC236}">
-                <a16:creationId xmlns:a16="http://schemas.microsoft.com/office/drawing/2014/main" id="{B347F195-2BA9-40D7-80BB-C376C53CEB68}"/>
+                <a16:creationId xmlns:a16="http://schemas.microsoft.com/office/drawing/2014/main" id="{33A469B7-318C-4AC0-AE82-8DE3F4F829AC}"/>
               </a:ext>
             </a:extLst>
           </p:cNvPr>
@@ -18351,7 +18413,7 @@
           <p:cNvPr id="13" name="">
             <a:extLst xmlns:a="http://schemas.openxmlformats.org/drawingml/2006/main">
               <a:ext uri="{FF2B5EF4-FFF2-40B4-BE49-F238E27FC236}">
-                <a16:creationId xmlns:a16="http://schemas.microsoft.com/office/drawing/2014/main" id="{E5DF7554-E39C-4774-88E1-A3FE440926F9}"/>
+                <a16:creationId xmlns:a16="http://schemas.microsoft.com/office/drawing/2014/main" id="{6E78A877-6964-49DA-A230-42498DA9625F}"/>
               </a:ext>
             </a:extLst>
           </p:cNvPr>
@@ -18413,7 +18475,7 @@
           <p:cNvPr id="14" name="">
             <a:extLst xmlns:a="http://schemas.openxmlformats.org/drawingml/2006/main">
               <a:ext uri="{FF2B5EF4-FFF2-40B4-BE49-F238E27FC236}">
-                <a16:creationId xmlns:a16="http://schemas.microsoft.com/office/drawing/2014/main" id="{A2653FBA-81C7-4B14-87C5-EB306E146A2F}"/>
+                <a16:creationId xmlns:a16="http://schemas.microsoft.com/office/drawing/2014/main" id="{C12845ED-97E0-450A-AA84-A5B30BA0E3A3}"/>
               </a:ext>
             </a:extLst>
           </p:cNvPr>
@@ -18444,7 +18506,7 @@
           <p:cNvPr id="15" name="">
             <a:extLst xmlns:a="http://schemas.openxmlformats.org/drawingml/2006/main">
               <a:ext uri="{FF2B5EF4-FFF2-40B4-BE49-F238E27FC236}">
-                <a16:creationId xmlns:a16="http://schemas.microsoft.com/office/drawing/2014/main" id="{3DBCC72E-53E5-499A-BCD9-3E9C54846191}"/>
+                <a16:creationId xmlns:a16="http://schemas.microsoft.com/office/drawing/2014/main" id="{4A66A590-182E-42E5-9DA8-D28F1A07027A}"/>
               </a:ext>
             </a:extLst>
           </p:cNvPr>
@@ -18506,7 +18568,7 @@
           <p:cNvPr id="16" name="">
             <a:extLst xmlns:a="http://schemas.openxmlformats.org/drawingml/2006/main">
               <a:ext uri="{FF2B5EF4-FFF2-40B4-BE49-F238E27FC236}">
-                <a16:creationId xmlns:a16="http://schemas.microsoft.com/office/drawing/2014/main" id="{CD3A08E1-CE06-40DF-845D-6181EF8AC9F5}"/>
+                <a16:creationId xmlns:a16="http://schemas.microsoft.com/office/drawing/2014/main" id="{677E7A66-203A-467C-ABF1-5E1816FC0D27}"/>
               </a:ext>
             </a:extLst>
           </p:cNvPr>
@@ -18541,7 +18603,7 @@
           <p:cNvPr id="17" name="">
             <a:extLst xmlns:a="http://schemas.openxmlformats.org/drawingml/2006/main">
               <a:ext uri="{FF2B5EF4-FFF2-40B4-BE49-F238E27FC236}">
-                <a16:creationId xmlns:a16="http://schemas.microsoft.com/office/drawing/2014/main" id="{D777FDBF-3460-4AD3-8090-917C3F20F94E}"/>
+                <a16:creationId xmlns:a16="http://schemas.microsoft.com/office/drawing/2014/main" id="{41A025D8-6005-46CB-B330-DC8B26789483}"/>
               </a:ext>
             </a:extLst>
           </p:cNvPr>
@@ -18603,7 +18665,7 @@
           <p:cNvPr id="18" name="">
             <a:extLst xmlns:a="http://schemas.openxmlformats.org/drawingml/2006/main">
               <a:ext uri="{FF2B5EF4-FFF2-40B4-BE49-F238E27FC236}">
-                <a16:creationId xmlns:a16="http://schemas.microsoft.com/office/drawing/2014/main" id="{897A79D1-78F2-48D3-9863-208819D35545}"/>
+                <a16:creationId xmlns:a16="http://schemas.microsoft.com/office/drawing/2014/main" id="{77582C5D-A290-4F62-AFF3-792B14663023}"/>
               </a:ext>
             </a:extLst>
           </p:cNvPr>
@@ -18634,7 +18696,7 @@
           <p:cNvPr id="19" name="">
             <a:extLst xmlns:a="http://schemas.openxmlformats.org/drawingml/2006/main">
               <a:ext uri="{FF2B5EF4-FFF2-40B4-BE49-F238E27FC236}">
-                <a16:creationId xmlns:a16="http://schemas.microsoft.com/office/drawing/2014/main" id="{50CBF7B7-B705-4220-867E-3369501A6BFD}"/>
+                <a16:creationId xmlns:a16="http://schemas.microsoft.com/office/drawing/2014/main" id="{B4B366DC-2BC6-43E4-8245-D6C5C67FD4EC}"/>
               </a:ext>
             </a:extLst>
           </p:cNvPr>
@@ -18686,7 +18748,7 @@
                 <a:ea typeface="Arial"/>
                 <a:cs typeface="Arial"/>
               </a:rPr>
-              <a:t>r2z-16690ccbe328 · scn-c46e1d86c1</a:t>
+              <a:t>r2z-45c4ba076af9 · scn-e0f12f397e</a:t>
             </a:r>
           </a:p>
         </p:txBody>
@@ -18696,7 +18758,7 @@
           <p:cNvPr id="20" name="">
             <a:extLst xmlns:a="http://schemas.openxmlformats.org/drawingml/2006/main">
               <a:ext uri="{FF2B5EF4-FFF2-40B4-BE49-F238E27FC236}">
-                <a16:creationId xmlns:a16="http://schemas.microsoft.com/office/drawing/2014/main" id="{388CCEA4-32B7-41B2-A4B1-B4520878891A}"/>
+                <a16:creationId xmlns:a16="http://schemas.microsoft.com/office/drawing/2014/main" id="{91DC556C-9631-44E2-A270-88A38FDF49BA}"/>
               </a:ext>
             </a:extLst>
           </p:cNvPr>
@@ -18756,7 +18818,7 @@
     </p:spTree>
     <p:extLst>
       <p:ext uri="{BB962C8B-B14F-4D97-AF65-F5344CB8AC3E}">
-        <p14:creationId xmlns:p14="http://schemas.microsoft.com/office/powerpoint/2010/main" val="504410744"/>
+        <p14:creationId xmlns:p14="http://schemas.microsoft.com/office/powerpoint/2010/main" val="954501906"/>
       </p:ext>
     </p:extLst>
   </p:cSld>
@@ -18787,7 +18849,7 @@
           <p:cNvPr id="17" name="">
             <a:extLst xmlns:a="http://schemas.openxmlformats.org/drawingml/2006/main">
               <a:ext uri="{FF2B5EF4-FFF2-40B4-BE49-F238E27FC236}">
-                <a16:creationId xmlns:a16="http://schemas.microsoft.com/office/drawing/2014/main" id="{6BA6BADD-1485-45CF-98B9-12FA383FDE3E}"/>
+                <a16:creationId xmlns:a16="http://schemas.microsoft.com/office/drawing/2014/main" id="{08513D43-BC96-4086-BF45-0DDE97931A32}"/>
               </a:ext>
             </a:extLst>
           </p:cNvPr>
@@ -18849,7 +18911,7 @@
                 <a:latin typeface="Arial"/>
                 <a:ea typeface="Arial"/>
                 <a:cs typeface="Arial"/>
-                <a:hlinkClick xmlns:r="http://schemas.openxmlformats.org/officeDocument/2006/relationships" r:id="Re0b83362ef134589"/>
+                <a:hlinkClick xmlns:r="http://schemas.openxmlformats.org/officeDocument/2006/relationships" r:id="Rc0dc9fc2464c41d7"/>
               </a:rPr>
               <a:t>https://github.com/qjmre23/Route2Zero</a:t>
             </a:r>
@@ -18872,7 +18934,7 @@
                 <a:latin typeface="Arial"/>
                 <a:ea typeface="Arial"/>
                 <a:cs typeface="Arial"/>
-                <a:hlinkClick xmlns:r="http://schemas.openxmlformats.org/officeDocument/2006/relationships" r:id="R6480bf8fa4e34991"/>
+                <a:hlinkClick xmlns:r="http://schemas.openxmlformats.org/officeDocument/2006/relationships" r:id="R85fb04dadd984088"/>
               </a:rPr>
               <a:t>https://route2zero.netlify.app/</a:t>
             </a:r>
@@ -18884,7 +18946,7 @@
           <p:cNvPr id="2" name="">
             <a:extLst xmlns:a="http://schemas.openxmlformats.org/drawingml/2006/main">
               <a:ext uri="{FF2B5EF4-FFF2-40B4-BE49-F238E27FC236}">
-                <a16:creationId xmlns:a16="http://schemas.microsoft.com/office/drawing/2014/main" id="{35729E0E-4880-4151-8F40-C0A24468B32E}"/>
+                <a16:creationId xmlns:a16="http://schemas.microsoft.com/office/drawing/2014/main" id="{95F19019-2819-4709-9BA7-714D5EBED6F8}"/>
               </a:ext>
             </a:extLst>
           </p:cNvPr>
@@ -18946,7 +19008,7 @@
           <p:cNvPr id="3" name="">
             <a:extLst xmlns:a="http://schemas.openxmlformats.org/drawingml/2006/main">
               <a:ext uri="{FF2B5EF4-FFF2-40B4-BE49-F238E27FC236}">
-                <a16:creationId xmlns:a16="http://schemas.microsoft.com/office/drawing/2014/main" id="{7C9B394F-57DF-49FE-91A5-2F2E0A5E2195}"/>
+                <a16:creationId xmlns:a16="http://schemas.microsoft.com/office/drawing/2014/main" id="{E0958DF7-44E8-404E-A694-A75ADDD3DD40}"/>
               </a:ext>
             </a:extLst>
           </p:cNvPr>
@@ -19012,8 +19074,8 @@
           <p:nvPr/>
         </p:nvPicPr>
         <p:blipFill>
-          <a:blip xmlns:r="http://schemas.openxmlformats.org/officeDocument/2006/relationships" xmlns:a="http://schemas.openxmlformats.org/drawingml/2006/main" r:embed="Rb9e1cbca2b8040fb"/>
-          <a:srcRect xmlns:a="http://schemas.openxmlformats.org/drawingml/2006/main" l="5025" t="0" r="5025" b="0"/>
+          <a:blip xmlns:r="http://schemas.openxmlformats.org/officeDocument/2006/relationships" xmlns:a="http://schemas.openxmlformats.org/drawingml/2006/main" r:embed="R6940568855044bd8"/>
+          <a:srcRect xmlns:a="http://schemas.openxmlformats.org/drawingml/2006/main" l="5016" t="0" r="5016" b="0"/>
           <a:stretch xmlns:a="http://schemas.openxmlformats.org/drawingml/2006/main">
             <a:fillRect l="0" t="0" r="0" b="0"/>
           </a:stretch>
@@ -19035,7 +19097,7 @@
           <p:cNvPr id="5" name="">
             <a:extLst xmlns:a="http://schemas.openxmlformats.org/drawingml/2006/main">
               <a:ext uri="{FF2B5EF4-FFF2-40B4-BE49-F238E27FC236}">
-                <a16:creationId xmlns:a16="http://schemas.microsoft.com/office/drawing/2014/main" id="{AD3F91F0-9740-44C7-8D97-4F10809465CD}"/>
+                <a16:creationId xmlns:a16="http://schemas.microsoft.com/office/drawing/2014/main" id="{A7A4A3CB-5DFE-4C46-AD31-2E58508F3294}"/>
               </a:ext>
             </a:extLst>
           </p:cNvPr>
@@ -19075,7 +19137,7 @@
         </p:xfrm>
         <a:graphic xmlns:a="http://schemas.openxmlformats.org/drawingml/2006/main">
           <a:graphicData uri="http://schemas.openxmlformats.org/drawingml/2006/chart">
-            <c:chart xmlns:r="http://schemas.openxmlformats.org/officeDocument/2006/relationships" xmlns:c="http://schemas.openxmlformats.org/drawingml/2006/chart" r:id="Ra09a45c203a543c2"/>
+            <c:chart xmlns:r="http://schemas.openxmlformats.org/officeDocument/2006/relationships" xmlns:c="http://schemas.openxmlformats.org/drawingml/2006/chart" r:id="R899890b68ef242c3"/>
           </a:graphicData>
         </a:graphic>
       </p:graphicFrame>
@@ -19084,7 +19146,7 @@
           <p:cNvPr id="7" name="">
             <a:extLst xmlns:a="http://schemas.openxmlformats.org/drawingml/2006/main">
               <a:ext uri="{FF2B5EF4-FFF2-40B4-BE49-F238E27FC236}">
-                <a16:creationId xmlns:a16="http://schemas.microsoft.com/office/drawing/2014/main" id="{ABD979CA-CF6E-41A4-AC65-3317FE1A5C87}"/>
+                <a16:creationId xmlns:a16="http://schemas.microsoft.com/office/drawing/2014/main" id="{6323C2C9-AF1A-4312-9A41-17B3771395B0}"/>
               </a:ext>
             </a:extLst>
           </p:cNvPr>
@@ -19146,7 +19208,7 @@
           <p:cNvPr id="8" name="">
             <a:extLst xmlns:a="http://schemas.openxmlformats.org/drawingml/2006/main">
               <a:ext uri="{FF2B5EF4-FFF2-40B4-BE49-F238E27FC236}">
-                <a16:creationId xmlns:a16="http://schemas.microsoft.com/office/drawing/2014/main" id="{D1955B4A-FC07-49F6-81C4-3A23A8A42668}"/>
+                <a16:creationId xmlns:a16="http://schemas.microsoft.com/office/drawing/2014/main" id="{D5597ED1-4225-4C7F-BC1E-28BF2B9ADC96}"/>
               </a:ext>
             </a:extLst>
           </p:cNvPr>
@@ -19208,7 +19270,7 @@
           <p:cNvPr id="9" name="">
             <a:extLst xmlns:a="http://schemas.openxmlformats.org/drawingml/2006/main">
               <a:ext uri="{FF2B5EF4-FFF2-40B4-BE49-F238E27FC236}">
-                <a16:creationId xmlns:a16="http://schemas.microsoft.com/office/drawing/2014/main" id="{E10C733F-F9F9-48EE-993B-5F619BA9838A}"/>
+                <a16:creationId xmlns:a16="http://schemas.microsoft.com/office/drawing/2014/main" id="{3AB57108-6153-4042-A025-3402227EFBA4}"/>
               </a:ext>
             </a:extLst>
           </p:cNvPr>
@@ -19270,7 +19332,7 @@
           <p:cNvPr id="10" name="">
             <a:extLst xmlns:a="http://schemas.openxmlformats.org/drawingml/2006/main">
               <a:ext uri="{FF2B5EF4-FFF2-40B4-BE49-F238E27FC236}">
-                <a16:creationId xmlns:a16="http://schemas.microsoft.com/office/drawing/2014/main" id="{C308EA8D-5BF3-4DD3-8B9C-50A4CCC1881B}"/>
+                <a16:creationId xmlns:a16="http://schemas.microsoft.com/office/drawing/2014/main" id="{A26538E4-72F7-4422-B02A-394B59F17674}"/>
               </a:ext>
             </a:extLst>
           </p:cNvPr>
@@ -19303,7 +19365,7 @@
           <p:cNvPr id="11" name="">
             <a:extLst xmlns:a="http://schemas.openxmlformats.org/drawingml/2006/main">
               <a:ext uri="{FF2B5EF4-FFF2-40B4-BE49-F238E27FC236}">
-                <a16:creationId xmlns:a16="http://schemas.microsoft.com/office/drawing/2014/main" id="{1602A20D-06CF-4C61-99F5-B54A92CEB830}"/>
+                <a16:creationId xmlns:a16="http://schemas.microsoft.com/office/drawing/2014/main" id="{C48DD0F5-542C-4304-ADE1-6BA340CED7B5}"/>
               </a:ext>
             </a:extLst>
           </p:cNvPr>
@@ -19365,7 +19427,7 @@
           <p:cNvPr id="12" name="">
             <a:extLst xmlns:a="http://schemas.openxmlformats.org/drawingml/2006/main">
               <a:ext uri="{FF2B5EF4-FFF2-40B4-BE49-F238E27FC236}">
-                <a16:creationId xmlns:a16="http://schemas.microsoft.com/office/drawing/2014/main" id="{295732A9-225A-4AD6-9A0B-DB2A3905E515}"/>
+                <a16:creationId xmlns:a16="http://schemas.microsoft.com/office/drawing/2014/main" id="{9C2EB36B-35A8-4BC5-8F3B-4A4A9386C20A}"/>
               </a:ext>
             </a:extLst>
           </p:cNvPr>
@@ -19398,7 +19460,7 @@
           <p:cNvPr id="13" name="">
             <a:extLst xmlns:a="http://schemas.openxmlformats.org/drawingml/2006/main">
               <a:ext uri="{FF2B5EF4-FFF2-40B4-BE49-F238E27FC236}">
-                <a16:creationId xmlns:a16="http://schemas.microsoft.com/office/drawing/2014/main" id="{2F8E3751-5236-40FD-B0A5-37721BB5F4DC}"/>
+                <a16:creationId xmlns:a16="http://schemas.microsoft.com/office/drawing/2014/main" id="{110983E5-4D5D-4A8D-A104-323AA5F7D75B}"/>
               </a:ext>
             </a:extLst>
           </p:cNvPr>
@@ -19460,7 +19522,7 @@
           <p:cNvPr id="14" name="">
             <a:extLst xmlns:a="http://schemas.openxmlformats.org/drawingml/2006/main">
               <a:ext uri="{FF2B5EF4-FFF2-40B4-BE49-F238E27FC236}">
-                <a16:creationId xmlns:a16="http://schemas.microsoft.com/office/drawing/2014/main" id="{A32F7642-360A-447B-87FA-E7C2F0B92C63}"/>
+                <a16:creationId xmlns:a16="http://schemas.microsoft.com/office/drawing/2014/main" id="{08D93A82-5939-4026-B114-A70FA183A9F2}"/>
               </a:ext>
             </a:extLst>
           </p:cNvPr>
@@ -19491,7 +19553,7 @@
           <p:cNvPr id="15" name="">
             <a:extLst xmlns:a="http://schemas.openxmlformats.org/drawingml/2006/main">
               <a:ext uri="{FF2B5EF4-FFF2-40B4-BE49-F238E27FC236}">
-                <a16:creationId xmlns:a16="http://schemas.microsoft.com/office/drawing/2014/main" id="{CC5F545C-1F78-4D66-AA9F-50C52076530D}"/>
+                <a16:creationId xmlns:a16="http://schemas.microsoft.com/office/drawing/2014/main" id="{DE78BE23-B98F-4279-8CDC-B3A8E7FB1187}"/>
               </a:ext>
             </a:extLst>
           </p:cNvPr>
@@ -19543,7 +19605,7 @@
                 <a:ea typeface="Arial"/>
                 <a:cs typeface="Arial"/>
               </a:rPr>
-              <a:t>r2z-16690ccbe328 · service-v1-266e0b1d</a:t>
+              <a:t>r2z-45c4ba076af9 · service-v1-266e0b1d</a:t>
             </a:r>
           </a:p>
         </p:txBody>
@@ -19553,7 +19615,7 @@
           <p:cNvPr id="16" name="">
             <a:extLst xmlns:a="http://schemas.openxmlformats.org/drawingml/2006/main">
               <a:ext uri="{FF2B5EF4-FFF2-40B4-BE49-F238E27FC236}">
-                <a16:creationId xmlns:a16="http://schemas.microsoft.com/office/drawing/2014/main" id="{4F7FBF64-E401-4439-AD4D-D183FB4E28F2}"/>
+                <a16:creationId xmlns:a16="http://schemas.microsoft.com/office/drawing/2014/main" id="{9A09CA8E-122C-4BC6-97A6-3968F20A8CEF}"/>
               </a:ext>
             </a:extLst>
           </p:cNvPr>
@@ -19613,7 +19675,7 @@
     </p:spTree>
     <p:extLst>
       <p:ext uri="{BB962C8B-B14F-4D97-AF65-F5344CB8AC3E}">
-        <p14:creationId xmlns:p14="http://schemas.microsoft.com/office/powerpoint/2010/main" val="386075493"/>
+        <p14:creationId xmlns:p14="http://schemas.microsoft.com/office/powerpoint/2010/main" val="274697942"/>
       </p:ext>
     </p:extLst>
   </p:cSld>
@@ -19644,7 +19706,7 @@
           <p:cNvPr id="21" name="">
             <a:extLst xmlns:a="http://schemas.openxmlformats.org/drawingml/2006/main">
               <a:ext uri="{FF2B5EF4-FFF2-40B4-BE49-F238E27FC236}">
-                <a16:creationId xmlns:a16="http://schemas.microsoft.com/office/drawing/2014/main" id="{36ABCF9E-C8F8-4983-BD52-3FEDD02CD9C9}"/>
+                <a16:creationId xmlns:a16="http://schemas.microsoft.com/office/drawing/2014/main" id="{3961020B-F679-4DB8-BD6A-5CAD59DCAB55}"/>
               </a:ext>
             </a:extLst>
           </p:cNvPr>
@@ -19706,7 +19768,7 @@
                 <a:latin typeface="Arial"/>
                 <a:ea typeface="Arial"/>
                 <a:cs typeface="Arial"/>
-                <a:hlinkClick xmlns:r="http://schemas.openxmlformats.org/officeDocument/2006/relationships" r:id="R14af01314458467c"/>
+                <a:hlinkClick xmlns:r="http://schemas.openxmlformats.org/officeDocument/2006/relationships" r:id="R2a548ca2a85a4a4e"/>
               </a:rPr>
               <a:t>https://github.com/qjmre23/Route2Zero</a:t>
             </a:r>
@@ -19729,7 +19791,7 @@
                 <a:latin typeface="Arial"/>
                 <a:ea typeface="Arial"/>
                 <a:cs typeface="Arial"/>
-                <a:hlinkClick xmlns:r="http://schemas.openxmlformats.org/officeDocument/2006/relationships" r:id="Rf5669062bba44d52"/>
+                <a:hlinkClick xmlns:r="http://schemas.openxmlformats.org/officeDocument/2006/relationships" r:id="R24ad57f1ed5d43fa"/>
               </a:rPr>
               <a:t>https://route2zero.netlify.app/</a:t>
             </a:r>
@@ -19741,7 +19803,7 @@
           <p:cNvPr id="2" name="">
             <a:extLst xmlns:a="http://schemas.openxmlformats.org/drawingml/2006/main">
               <a:ext uri="{FF2B5EF4-FFF2-40B4-BE49-F238E27FC236}">
-                <a16:creationId xmlns:a16="http://schemas.microsoft.com/office/drawing/2014/main" id="{8F02E6D6-5723-4432-A8D8-72A15490026C}"/>
+                <a16:creationId xmlns:a16="http://schemas.microsoft.com/office/drawing/2014/main" id="{65738D18-EE93-4F8A-9843-DAC2C60BDF26}"/>
               </a:ext>
             </a:extLst>
           </p:cNvPr>
@@ -19803,7 +19865,7 @@
           <p:cNvPr id="3" name="">
             <a:extLst xmlns:a="http://schemas.openxmlformats.org/drawingml/2006/main">
               <a:ext uri="{FF2B5EF4-FFF2-40B4-BE49-F238E27FC236}">
-                <a16:creationId xmlns:a16="http://schemas.microsoft.com/office/drawing/2014/main" id="{B0CAD4FF-CB29-4DB3-BB84-DD38B0C3D91A}"/>
+                <a16:creationId xmlns:a16="http://schemas.microsoft.com/office/drawing/2014/main" id="{DB47DD70-D8D2-4E9D-BE3E-25C590A7FC8A}"/>
               </a:ext>
             </a:extLst>
           </p:cNvPr>
@@ -19869,8 +19931,8 @@
           <p:nvPr/>
         </p:nvPicPr>
         <p:blipFill>
-          <a:blip xmlns:r="http://schemas.openxmlformats.org/officeDocument/2006/relationships" xmlns:a="http://schemas.openxmlformats.org/drawingml/2006/main" r:embed="R63caafc0d15f408b"/>
-          <a:srcRect xmlns:a="http://schemas.openxmlformats.org/drawingml/2006/main" l="0" t="15675" r="0" b="15675"/>
+          <a:blip xmlns:r="http://schemas.openxmlformats.org/officeDocument/2006/relationships" xmlns:a="http://schemas.openxmlformats.org/drawingml/2006/main" r:embed="R35342a0362dc47fc"/>
+          <a:srcRect xmlns:a="http://schemas.openxmlformats.org/drawingml/2006/main" l="0" t="15682" r="0" b="15682"/>
           <a:stretch xmlns:a="http://schemas.openxmlformats.org/drawingml/2006/main">
             <a:fillRect l="0" t="0" r="0" b="0"/>
           </a:stretch>
@@ -19892,7 +19954,7 @@
           <p:cNvPr id="5" name="">
             <a:extLst xmlns:a="http://schemas.openxmlformats.org/drawingml/2006/main">
               <a:ext uri="{FF2B5EF4-FFF2-40B4-BE49-F238E27FC236}">
-                <a16:creationId xmlns:a16="http://schemas.microsoft.com/office/drawing/2014/main" id="{AAF6610E-472E-42F4-B8A2-F89E1FBFC546}"/>
+                <a16:creationId xmlns:a16="http://schemas.microsoft.com/office/drawing/2014/main" id="{44298CAB-43A4-49BC-9D6D-E8DC44E0A01A}"/>
               </a:ext>
             </a:extLst>
           </p:cNvPr>
@@ -19925,7 +19987,7 @@
           <p:cNvPr id="6" name="">
             <a:extLst xmlns:a="http://schemas.openxmlformats.org/drawingml/2006/main">
               <a:ext uri="{FF2B5EF4-FFF2-40B4-BE49-F238E27FC236}">
-                <a16:creationId xmlns:a16="http://schemas.microsoft.com/office/drawing/2014/main" id="{91410F44-A179-4EDB-BF7A-B7DF8719E146}"/>
+                <a16:creationId xmlns:a16="http://schemas.microsoft.com/office/drawing/2014/main" id="{BFE8E0A3-310B-45DB-AD2D-84D5468D1300}"/>
               </a:ext>
             </a:extLst>
           </p:cNvPr>
@@ -19956,7 +20018,7 @@
           <p:cNvPr id="7" name="">
             <a:extLst xmlns:a="http://schemas.openxmlformats.org/drawingml/2006/main">
               <a:ext uri="{FF2B5EF4-FFF2-40B4-BE49-F238E27FC236}">
-                <a16:creationId xmlns:a16="http://schemas.microsoft.com/office/drawing/2014/main" id="{9E3E9562-0271-46A9-BDA3-7AEFEB145A91}"/>
+                <a16:creationId xmlns:a16="http://schemas.microsoft.com/office/drawing/2014/main" id="{D8609D6A-7E28-4738-A66D-15F4A5911E8F}"/>
               </a:ext>
             </a:extLst>
           </p:cNvPr>
@@ -20018,7 +20080,7 @@
           <p:cNvPr id="8" name="">
             <a:extLst xmlns:a="http://schemas.openxmlformats.org/drawingml/2006/main">
               <a:ext uri="{FF2B5EF4-FFF2-40B4-BE49-F238E27FC236}">
-                <a16:creationId xmlns:a16="http://schemas.microsoft.com/office/drawing/2014/main" id="{E1B4B1B2-1B38-4E5D-9BB9-ABF21A3F8734}"/>
+                <a16:creationId xmlns:a16="http://schemas.microsoft.com/office/drawing/2014/main" id="{D61F8F9D-4371-4439-8A35-23DA15EFC9CC}"/>
               </a:ext>
             </a:extLst>
           </p:cNvPr>
@@ -20053,7 +20115,7 @@
           <p:cNvPr id="9" name="">
             <a:extLst xmlns:a="http://schemas.openxmlformats.org/drawingml/2006/main">
               <a:ext uri="{FF2B5EF4-FFF2-40B4-BE49-F238E27FC236}">
-                <a16:creationId xmlns:a16="http://schemas.microsoft.com/office/drawing/2014/main" id="{442C3131-6845-410A-87C2-5015C4042389}"/>
+                <a16:creationId xmlns:a16="http://schemas.microsoft.com/office/drawing/2014/main" id="{6709DCC7-522D-4BB5-9DDB-8B2B0751D403}"/>
               </a:ext>
             </a:extLst>
           </p:cNvPr>
@@ -20115,7 +20177,7 @@
           <p:cNvPr id="10" name="">
             <a:extLst xmlns:a="http://schemas.openxmlformats.org/drawingml/2006/main">
               <a:ext uri="{FF2B5EF4-FFF2-40B4-BE49-F238E27FC236}">
-                <a16:creationId xmlns:a16="http://schemas.microsoft.com/office/drawing/2014/main" id="{5BD8E215-41A0-4098-97E0-E6C06CAD0DE0}"/>
+                <a16:creationId xmlns:a16="http://schemas.microsoft.com/office/drawing/2014/main" id="{41E2728D-C592-4031-A50F-D81F91A866B9}"/>
               </a:ext>
             </a:extLst>
           </p:cNvPr>
@@ -20146,7 +20208,7 @@
           <p:cNvPr id="11" name="">
             <a:extLst xmlns:a="http://schemas.openxmlformats.org/drawingml/2006/main">
               <a:ext uri="{FF2B5EF4-FFF2-40B4-BE49-F238E27FC236}">
-                <a16:creationId xmlns:a16="http://schemas.microsoft.com/office/drawing/2014/main" id="{0BC0D54E-0B68-41C0-9FC7-DB7AE09182BC}"/>
+                <a16:creationId xmlns:a16="http://schemas.microsoft.com/office/drawing/2014/main" id="{9EA704FD-1EB6-44BF-A91B-E290853B8111}"/>
               </a:ext>
             </a:extLst>
           </p:cNvPr>
@@ -20208,7 +20270,7 @@
           <p:cNvPr id="12" name="">
             <a:extLst xmlns:a="http://schemas.openxmlformats.org/drawingml/2006/main">
               <a:ext uri="{FF2B5EF4-FFF2-40B4-BE49-F238E27FC236}">
-                <a16:creationId xmlns:a16="http://schemas.microsoft.com/office/drawing/2014/main" id="{29025057-D3C0-49E2-BB27-E249A3F972E0}"/>
+                <a16:creationId xmlns:a16="http://schemas.microsoft.com/office/drawing/2014/main" id="{1404004C-AA9E-48BC-AA78-CAA4FA40B7C7}"/>
               </a:ext>
             </a:extLst>
           </p:cNvPr>
@@ -20243,7 +20305,7 @@
           <p:cNvPr id="13" name="">
             <a:extLst xmlns:a="http://schemas.openxmlformats.org/drawingml/2006/main">
               <a:ext uri="{FF2B5EF4-FFF2-40B4-BE49-F238E27FC236}">
-                <a16:creationId xmlns:a16="http://schemas.microsoft.com/office/drawing/2014/main" id="{6C4DA195-797B-4DF0-840B-B557BD2B7064}"/>
+                <a16:creationId xmlns:a16="http://schemas.microsoft.com/office/drawing/2014/main" id="{575986A1-1829-40FC-AAB3-3501A9BAEFEC}"/>
               </a:ext>
             </a:extLst>
           </p:cNvPr>
@@ -20305,7 +20367,7 @@
           <p:cNvPr id="14" name="">
             <a:extLst xmlns:a="http://schemas.openxmlformats.org/drawingml/2006/main">
               <a:ext uri="{FF2B5EF4-FFF2-40B4-BE49-F238E27FC236}">
-                <a16:creationId xmlns:a16="http://schemas.microsoft.com/office/drawing/2014/main" id="{48F8CA54-CF42-49DE-9001-89802B15A789}"/>
+                <a16:creationId xmlns:a16="http://schemas.microsoft.com/office/drawing/2014/main" id="{487575CD-4644-4749-BA62-289642796CBB}"/>
               </a:ext>
             </a:extLst>
           </p:cNvPr>
@@ -20336,7 +20398,7 @@
           <p:cNvPr id="15" name="">
             <a:extLst xmlns:a="http://schemas.openxmlformats.org/drawingml/2006/main">
               <a:ext uri="{FF2B5EF4-FFF2-40B4-BE49-F238E27FC236}">
-                <a16:creationId xmlns:a16="http://schemas.microsoft.com/office/drawing/2014/main" id="{F81F0E9F-318C-4C06-8B91-FD53E82ACCCF}"/>
+                <a16:creationId xmlns:a16="http://schemas.microsoft.com/office/drawing/2014/main" id="{11C10E4F-146D-4543-AB58-D24C36C04FEB}"/>
               </a:ext>
             </a:extLst>
           </p:cNvPr>
@@ -20398,7 +20460,7 @@
           <p:cNvPr id="16" name="">
             <a:extLst xmlns:a="http://schemas.openxmlformats.org/drawingml/2006/main">
               <a:ext uri="{FF2B5EF4-FFF2-40B4-BE49-F238E27FC236}">
-                <a16:creationId xmlns:a16="http://schemas.microsoft.com/office/drawing/2014/main" id="{01DC61AA-0F5A-476B-8DB0-14A913E099FF}"/>
+                <a16:creationId xmlns:a16="http://schemas.microsoft.com/office/drawing/2014/main" id="{FFA7BCDE-D844-4BAE-936A-D5FC30462EBF}"/>
               </a:ext>
             </a:extLst>
           </p:cNvPr>
@@ -20433,7 +20495,7 @@
           <p:cNvPr id="17" name="">
             <a:extLst xmlns:a="http://schemas.openxmlformats.org/drawingml/2006/main">
               <a:ext uri="{FF2B5EF4-FFF2-40B4-BE49-F238E27FC236}">
-                <a16:creationId xmlns:a16="http://schemas.microsoft.com/office/drawing/2014/main" id="{8F24CF53-071D-48A4-83F5-D0DF044A78A2}"/>
+                <a16:creationId xmlns:a16="http://schemas.microsoft.com/office/drawing/2014/main" id="{B7752EC0-917F-434C-9748-CB5B994D7BC8}"/>
               </a:ext>
             </a:extLst>
           </p:cNvPr>
@@ -20495,7 +20557,7 @@
           <p:cNvPr id="18" name="">
             <a:extLst xmlns:a="http://schemas.openxmlformats.org/drawingml/2006/main">
               <a:ext uri="{FF2B5EF4-FFF2-40B4-BE49-F238E27FC236}">
-                <a16:creationId xmlns:a16="http://schemas.microsoft.com/office/drawing/2014/main" id="{72DFA657-DF4F-420C-A329-2D734E5E0B4A}"/>
+                <a16:creationId xmlns:a16="http://schemas.microsoft.com/office/drawing/2014/main" id="{F306B2F0-13BD-4959-8D82-B6D4591213A4}"/>
               </a:ext>
             </a:extLst>
           </p:cNvPr>
@@ -20526,7 +20588,7 @@
           <p:cNvPr id="19" name="">
             <a:extLst xmlns:a="http://schemas.openxmlformats.org/drawingml/2006/main">
               <a:ext uri="{FF2B5EF4-FFF2-40B4-BE49-F238E27FC236}">
-                <a16:creationId xmlns:a16="http://schemas.microsoft.com/office/drawing/2014/main" id="{63A70D3D-6674-4340-8E28-CFE02EBC200E}"/>
+                <a16:creationId xmlns:a16="http://schemas.microsoft.com/office/drawing/2014/main" id="{39A3ADD7-B33F-4ECA-BE37-C3C412EA3645}"/>
               </a:ext>
             </a:extLst>
           </p:cNvPr>
@@ -20578,7 +20640,7 @@
                 <a:ea typeface="Arial"/>
                 <a:cs typeface="Arial"/>
               </a:rPr>
-              <a:t>r2z-16690ccbe328 · scn-c46e1d86c1</a:t>
+              <a:t>r2z-45c4ba076af9 · scn-e0f12f397e</a:t>
             </a:r>
           </a:p>
         </p:txBody>
@@ -20588,7 +20650,7 @@
           <p:cNvPr id="20" name="">
             <a:extLst xmlns:a="http://schemas.openxmlformats.org/drawingml/2006/main">
               <a:ext uri="{FF2B5EF4-FFF2-40B4-BE49-F238E27FC236}">
-                <a16:creationId xmlns:a16="http://schemas.microsoft.com/office/drawing/2014/main" id="{00711FC4-2085-444C-B1F6-45BC3F8ECA85}"/>
+                <a16:creationId xmlns:a16="http://schemas.microsoft.com/office/drawing/2014/main" id="{7D056E0A-8380-4929-89C8-BDEDE1575C8F}"/>
               </a:ext>
             </a:extLst>
           </p:cNvPr>
@@ -20648,7 +20710,7 @@
     </p:spTree>
     <p:extLst>
       <p:ext uri="{BB962C8B-B14F-4D97-AF65-F5344CB8AC3E}">
-        <p14:creationId xmlns:p14="http://schemas.microsoft.com/office/powerpoint/2010/main" val="1216914050"/>
+        <p14:creationId xmlns:p14="http://schemas.microsoft.com/office/powerpoint/2010/main" val="1645645204"/>
       </p:ext>
     </p:extLst>
   </p:cSld>
@@ -20679,7 +20741,7 @@
           <p:cNvPr id="21" name="">
             <a:extLst xmlns:a="http://schemas.openxmlformats.org/drawingml/2006/main">
               <a:ext uri="{FF2B5EF4-FFF2-40B4-BE49-F238E27FC236}">
-                <a16:creationId xmlns:a16="http://schemas.microsoft.com/office/drawing/2014/main" id="{9406F098-26A8-48B3-A875-916A87AAB606}"/>
+                <a16:creationId xmlns:a16="http://schemas.microsoft.com/office/drawing/2014/main" id="{44218676-072B-4CBD-BB31-014F48E0A06C}"/>
               </a:ext>
             </a:extLst>
           </p:cNvPr>
@@ -20741,7 +20803,7 @@
                 <a:latin typeface="Arial"/>
                 <a:ea typeface="Arial"/>
                 <a:cs typeface="Arial"/>
-                <a:hlinkClick xmlns:r="http://schemas.openxmlformats.org/officeDocument/2006/relationships" r:id="Re2cc5e9193df4345"/>
+                <a:hlinkClick xmlns:r="http://schemas.openxmlformats.org/officeDocument/2006/relationships" r:id="R99642d6859ac4903"/>
               </a:rPr>
               <a:t>https://github.com/qjmre23/Route2Zero</a:t>
             </a:r>
@@ -20764,7 +20826,7 @@
                 <a:latin typeface="Arial"/>
                 <a:ea typeface="Arial"/>
                 <a:cs typeface="Arial"/>
-                <a:hlinkClick xmlns:r="http://schemas.openxmlformats.org/officeDocument/2006/relationships" r:id="R433cb4f9e2544e8a"/>
+                <a:hlinkClick xmlns:r="http://schemas.openxmlformats.org/officeDocument/2006/relationships" r:id="R056a70e73e6346ea"/>
               </a:rPr>
               <a:t>https://route2zero.netlify.app/</a:t>
             </a:r>
@@ -20776,7 +20838,7 @@
           <p:cNvPr id="2" name="">
             <a:extLst xmlns:a="http://schemas.openxmlformats.org/drawingml/2006/main">
               <a:ext uri="{FF2B5EF4-FFF2-40B4-BE49-F238E27FC236}">
-                <a16:creationId xmlns:a16="http://schemas.microsoft.com/office/drawing/2014/main" id="{A4FEC7AB-4E2A-4D2B-9D59-108D21EFF806}"/>
+                <a16:creationId xmlns:a16="http://schemas.microsoft.com/office/drawing/2014/main" id="{1C821107-21D5-49F4-B0E0-BE1F2F3CEC93}"/>
               </a:ext>
             </a:extLst>
           </p:cNvPr>
@@ -20838,7 +20900,7 @@
           <p:cNvPr id="3" name="">
             <a:extLst xmlns:a="http://schemas.openxmlformats.org/drawingml/2006/main">
               <a:ext uri="{FF2B5EF4-FFF2-40B4-BE49-F238E27FC236}">
-                <a16:creationId xmlns:a16="http://schemas.microsoft.com/office/drawing/2014/main" id="{C5D5AF61-AF06-4A88-854F-2D7F3F17F285}"/>
+                <a16:creationId xmlns:a16="http://schemas.microsoft.com/office/drawing/2014/main" id="{0AE54A01-F0A4-41DB-88E9-758C6C64FF78}"/>
               </a:ext>
             </a:extLst>
           </p:cNvPr>
@@ -20904,8 +20966,8 @@
           <p:nvPr/>
         </p:nvPicPr>
         <p:blipFill>
-          <a:blip xmlns:r="http://schemas.openxmlformats.org/officeDocument/2006/relationships" xmlns:a="http://schemas.openxmlformats.org/drawingml/2006/main" r:embed="Rc56eb2ab1c2c49b9"/>
-          <a:srcRect xmlns:a="http://schemas.openxmlformats.org/drawingml/2006/main" l="0" t="15675" r="0" b="15675"/>
+          <a:blip xmlns:r="http://schemas.openxmlformats.org/officeDocument/2006/relationships" xmlns:a="http://schemas.openxmlformats.org/drawingml/2006/main" r:embed="R84d0a5244b2b4836"/>
+          <a:srcRect xmlns:a="http://schemas.openxmlformats.org/drawingml/2006/main" l="0" t="15682" r="0" b="15682"/>
           <a:stretch xmlns:a="http://schemas.openxmlformats.org/drawingml/2006/main">
             <a:fillRect l="0" t="0" r="0" b="0"/>
           </a:stretch>
@@ -20927,7 +20989,7 @@
           <p:cNvPr id="5" name="">
             <a:extLst xmlns:a="http://schemas.openxmlformats.org/drawingml/2006/main">
               <a:ext uri="{FF2B5EF4-FFF2-40B4-BE49-F238E27FC236}">
-                <a16:creationId xmlns:a16="http://schemas.microsoft.com/office/drawing/2014/main" id="{6E5489ED-A515-4C94-9FC9-0C163BCA2A83}"/>
+                <a16:creationId xmlns:a16="http://schemas.microsoft.com/office/drawing/2014/main" id="{57983AD8-7B59-49AE-B76C-37F6C231A176}"/>
               </a:ext>
             </a:extLst>
           </p:cNvPr>
@@ -20960,7 +21022,7 @@
           <p:cNvPr id="6" name="">
             <a:extLst xmlns:a="http://schemas.openxmlformats.org/drawingml/2006/main">
               <a:ext uri="{FF2B5EF4-FFF2-40B4-BE49-F238E27FC236}">
-                <a16:creationId xmlns:a16="http://schemas.microsoft.com/office/drawing/2014/main" id="{03AED868-4FE0-4B60-9676-E424D970B8E9}"/>
+                <a16:creationId xmlns:a16="http://schemas.microsoft.com/office/drawing/2014/main" id="{47BFBB56-5F8D-4EAA-83CC-421C302C200E}"/>
               </a:ext>
             </a:extLst>
           </p:cNvPr>
@@ -20991,7 +21053,7 @@
           <p:cNvPr id="7" name="">
             <a:extLst xmlns:a="http://schemas.openxmlformats.org/drawingml/2006/main">
               <a:ext uri="{FF2B5EF4-FFF2-40B4-BE49-F238E27FC236}">
-                <a16:creationId xmlns:a16="http://schemas.microsoft.com/office/drawing/2014/main" id="{B90D7654-BEC1-4E85-88B9-AF9C84CAC625}"/>
+                <a16:creationId xmlns:a16="http://schemas.microsoft.com/office/drawing/2014/main" id="{4A5DAE8E-A591-4746-85D0-B734E5BAC728}"/>
               </a:ext>
             </a:extLst>
           </p:cNvPr>
@@ -21053,7 +21115,7 @@
           <p:cNvPr id="8" name="">
             <a:extLst xmlns:a="http://schemas.openxmlformats.org/drawingml/2006/main">
               <a:ext uri="{FF2B5EF4-FFF2-40B4-BE49-F238E27FC236}">
-                <a16:creationId xmlns:a16="http://schemas.microsoft.com/office/drawing/2014/main" id="{84BA05BC-7FAD-47EE-899C-631EC92EBE82}"/>
+                <a16:creationId xmlns:a16="http://schemas.microsoft.com/office/drawing/2014/main" id="{430A20AF-A4C1-484C-924D-A8F553982495}"/>
               </a:ext>
             </a:extLst>
           </p:cNvPr>
@@ -21088,7 +21150,7 @@
           <p:cNvPr id="9" name="">
             <a:extLst xmlns:a="http://schemas.openxmlformats.org/drawingml/2006/main">
               <a:ext uri="{FF2B5EF4-FFF2-40B4-BE49-F238E27FC236}">
-                <a16:creationId xmlns:a16="http://schemas.microsoft.com/office/drawing/2014/main" id="{38D19485-B1B2-4582-AE3B-79AB4069E663}"/>
+                <a16:creationId xmlns:a16="http://schemas.microsoft.com/office/drawing/2014/main" id="{FBC07EC3-9E1A-402D-A895-978477C1FC25}"/>
               </a:ext>
             </a:extLst>
           </p:cNvPr>
@@ -21150,7 +21212,7 @@
           <p:cNvPr id="10" name="">
             <a:extLst xmlns:a="http://schemas.openxmlformats.org/drawingml/2006/main">
               <a:ext uri="{FF2B5EF4-FFF2-40B4-BE49-F238E27FC236}">
-                <a16:creationId xmlns:a16="http://schemas.microsoft.com/office/drawing/2014/main" id="{839AF295-C4C6-41CB-B78F-C6099EDD941C}"/>
+                <a16:creationId xmlns:a16="http://schemas.microsoft.com/office/drawing/2014/main" id="{B60D64E0-9B88-47DE-A459-302C79EDC904}"/>
               </a:ext>
             </a:extLst>
           </p:cNvPr>
@@ -21181,7 +21243,7 @@
           <p:cNvPr id="11" name="">
             <a:extLst xmlns:a="http://schemas.openxmlformats.org/drawingml/2006/main">
               <a:ext uri="{FF2B5EF4-FFF2-40B4-BE49-F238E27FC236}">
-                <a16:creationId xmlns:a16="http://schemas.microsoft.com/office/drawing/2014/main" id="{75B7E714-6F4E-449A-83BB-F490E8FB78D4}"/>
+                <a16:creationId xmlns:a16="http://schemas.microsoft.com/office/drawing/2014/main" id="{CA08FD2D-DA89-484F-9B8F-7C26D171AFD2}"/>
               </a:ext>
             </a:extLst>
           </p:cNvPr>
@@ -21243,7 +21305,7 @@
           <p:cNvPr id="12" name="">
             <a:extLst xmlns:a="http://schemas.openxmlformats.org/drawingml/2006/main">
               <a:ext uri="{FF2B5EF4-FFF2-40B4-BE49-F238E27FC236}">
-                <a16:creationId xmlns:a16="http://schemas.microsoft.com/office/drawing/2014/main" id="{587E5B7D-95BB-47C4-A41D-85C1D6365E74}"/>
+                <a16:creationId xmlns:a16="http://schemas.microsoft.com/office/drawing/2014/main" id="{D3E8B688-8DC4-4D3A-BD47-D2D232384D32}"/>
               </a:ext>
             </a:extLst>
           </p:cNvPr>
@@ -21278,7 +21340,7 @@
           <p:cNvPr id="13" name="">
             <a:extLst xmlns:a="http://schemas.openxmlformats.org/drawingml/2006/main">
               <a:ext uri="{FF2B5EF4-FFF2-40B4-BE49-F238E27FC236}">
-                <a16:creationId xmlns:a16="http://schemas.microsoft.com/office/drawing/2014/main" id="{67CACFA9-A944-415D-B055-3A0882573559}"/>
+                <a16:creationId xmlns:a16="http://schemas.microsoft.com/office/drawing/2014/main" id="{74F5AB34-192C-4483-917A-27727BE2BBB6}"/>
               </a:ext>
             </a:extLst>
           </p:cNvPr>
@@ -21340,7 +21402,7 @@
           <p:cNvPr id="14" name="">
             <a:extLst xmlns:a="http://schemas.openxmlformats.org/drawingml/2006/main">
               <a:ext uri="{FF2B5EF4-FFF2-40B4-BE49-F238E27FC236}">
-                <a16:creationId xmlns:a16="http://schemas.microsoft.com/office/drawing/2014/main" id="{503F3504-AA4E-4D28-BBAA-46EA858C23C9}"/>
+                <a16:creationId xmlns:a16="http://schemas.microsoft.com/office/drawing/2014/main" id="{4B81963A-5389-440E-9A0F-FFF8D34A8298}"/>
               </a:ext>
             </a:extLst>
           </p:cNvPr>
@@ -21371,7 +21433,7 @@
           <p:cNvPr id="15" name="">
             <a:extLst xmlns:a="http://schemas.openxmlformats.org/drawingml/2006/main">
               <a:ext uri="{FF2B5EF4-FFF2-40B4-BE49-F238E27FC236}">
-                <a16:creationId xmlns:a16="http://schemas.microsoft.com/office/drawing/2014/main" id="{8A9D73D5-1CC4-421E-94F3-CBAA34D17E1F}"/>
+                <a16:creationId xmlns:a16="http://schemas.microsoft.com/office/drawing/2014/main" id="{CAAD2B3D-42CE-42D0-9283-D2BADEF4CF8E}"/>
               </a:ext>
             </a:extLst>
           </p:cNvPr>
@@ -21433,7 +21495,7 @@
           <p:cNvPr id="16" name="">
             <a:extLst xmlns:a="http://schemas.openxmlformats.org/drawingml/2006/main">
               <a:ext uri="{FF2B5EF4-FFF2-40B4-BE49-F238E27FC236}">
-                <a16:creationId xmlns:a16="http://schemas.microsoft.com/office/drawing/2014/main" id="{095D5413-3216-4F23-8C9E-9F629C5551A7}"/>
+                <a16:creationId xmlns:a16="http://schemas.microsoft.com/office/drawing/2014/main" id="{331D12F5-DE49-40FF-B790-4050179B81FE}"/>
               </a:ext>
             </a:extLst>
           </p:cNvPr>
@@ -21468,7 +21530,7 @@
           <p:cNvPr id="17" name="">
             <a:extLst xmlns:a="http://schemas.openxmlformats.org/drawingml/2006/main">
               <a:ext uri="{FF2B5EF4-FFF2-40B4-BE49-F238E27FC236}">
-                <a16:creationId xmlns:a16="http://schemas.microsoft.com/office/drawing/2014/main" id="{CC7B1542-835E-40CD-A240-53DDC23C5BA8}"/>
+                <a16:creationId xmlns:a16="http://schemas.microsoft.com/office/drawing/2014/main" id="{E2AA0EFF-3D05-4EA0-B49B-D16B9996B211}"/>
               </a:ext>
             </a:extLst>
           </p:cNvPr>
@@ -21530,7 +21592,7 @@
           <p:cNvPr id="18" name="">
             <a:extLst xmlns:a="http://schemas.openxmlformats.org/drawingml/2006/main">
               <a:ext uri="{FF2B5EF4-FFF2-40B4-BE49-F238E27FC236}">
-                <a16:creationId xmlns:a16="http://schemas.microsoft.com/office/drawing/2014/main" id="{00A8BDE8-1B8C-445A-9428-5C5B02274298}"/>
+                <a16:creationId xmlns:a16="http://schemas.microsoft.com/office/drawing/2014/main" id="{1CE69BC4-52B4-450C-9B78-F2785F622EB5}"/>
               </a:ext>
             </a:extLst>
           </p:cNvPr>
@@ -21561,7 +21623,7 @@
           <p:cNvPr id="19" name="">
             <a:extLst xmlns:a="http://schemas.openxmlformats.org/drawingml/2006/main">
               <a:ext uri="{FF2B5EF4-FFF2-40B4-BE49-F238E27FC236}">
-                <a16:creationId xmlns:a16="http://schemas.microsoft.com/office/drawing/2014/main" id="{6AC13AEF-7A97-4553-8EBE-3B8253644C01}"/>
+                <a16:creationId xmlns:a16="http://schemas.microsoft.com/office/drawing/2014/main" id="{0F5AC1AD-2E85-4D53-A585-B3E244C52D10}"/>
               </a:ext>
             </a:extLst>
           </p:cNvPr>
@@ -21613,7 +21675,7 @@
                 <a:ea typeface="Arial"/>
                 <a:cs typeface="Arial"/>
               </a:rPr>
-              <a:t>r2z-16690ccbe328 · scn-c46e1d86c1</a:t>
+              <a:t>r2z-45c4ba076af9 · scn-e0f12f397e</a:t>
             </a:r>
           </a:p>
         </p:txBody>
@@ -21623,7 +21685,7 @@
           <p:cNvPr id="20" name="">
             <a:extLst xmlns:a="http://schemas.openxmlformats.org/drawingml/2006/main">
               <a:ext uri="{FF2B5EF4-FFF2-40B4-BE49-F238E27FC236}">
-                <a16:creationId xmlns:a16="http://schemas.microsoft.com/office/drawing/2014/main" id="{E4C21F7B-A41F-4C8D-972D-08F119F5B895}"/>
+                <a16:creationId xmlns:a16="http://schemas.microsoft.com/office/drawing/2014/main" id="{0681C57D-8BC0-4DBA-8747-B4792DE9A8FD}"/>
               </a:ext>
             </a:extLst>
           </p:cNvPr>
@@ -21683,7 +21745,7 @@
     </p:spTree>
     <p:extLst>
       <p:ext uri="{BB962C8B-B14F-4D97-AF65-F5344CB8AC3E}">
-        <p14:creationId xmlns:p14="http://schemas.microsoft.com/office/powerpoint/2010/main" val="624759285"/>
+        <p14:creationId xmlns:p14="http://schemas.microsoft.com/office/powerpoint/2010/main" val="695763126"/>
       </p:ext>
     </p:extLst>
   </p:cSld>
@@ -21714,7 +21776,7 @@
           <p:cNvPr id="21" name="">
             <a:extLst xmlns:a="http://schemas.openxmlformats.org/drawingml/2006/main">
               <a:ext uri="{FF2B5EF4-FFF2-40B4-BE49-F238E27FC236}">
-                <a16:creationId xmlns:a16="http://schemas.microsoft.com/office/drawing/2014/main" id="{63A99755-1C35-4A90-BBB2-FA20B2C87D1D}"/>
+                <a16:creationId xmlns:a16="http://schemas.microsoft.com/office/drawing/2014/main" id="{DD38CDE3-489E-4B0F-AA17-5E37865755B4}"/>
               </a:ext>
             </a:extLst>
           </p:cNvPr>
@@ -21776,7 +21838,7 @@
                 <a:latin typeface="Arial"/>
                 <a:ea typeface="Arial"/>
                 <a:cs typeface="Arial"/>
-                <a:hlinkClick xmlns:r="http://schemas.openxmlformats.org/officeDocument/2006/relationships" r:id="R8cf50868c1a34373"/>
+                <a:hlinkClick xmlns:r="http://schemas.openxmlformats.org/officeDocument/2006/relationships" r:id="R5644a8e16c3348bd"/>
               </a:rPr>
               <a:t>https://github.com/qjmre23/Route2Zero</a:t>
             </a:r>
@@ -21799,7 +21861,7 @@
                 <a:latin typeface="Arial"/>
                 <a:ea typeface="Arial"/>
                 <a:cs typeface="Arial"/>
-                <a:hlinkClick xmlns:r="http://schemas.openxmlformats.org/officeDocument/2006/relationships" r:id="Rec45c1aa0b1a4a29"/>
+                <a:hlinkClick xmlns:r="http://schemas.openxmlformats.org/officeDocument/2006/relationships" r:id="R9d9cde2513934a19"/>
               </a:rPr>
               <a:t>https://route2zero.netlify.app/</a:t>
             </a:r>
@@ -21811,7 +21873,7 @@
           <p:cNvPr id="2" name="">
             <a:extLst xmlns:a="http://schemas.openxmlformats.org/drawingml/2006/main">
               <a:ext uri="{FF2B5EF4-FFF2-40B4-BE49-F238E27FC236}">
-                <a16:creationId xmlns:a16="http://schemas.microsoft.com/office/drawing/2014/main" id="{E3657C5E-E5E8-4016-B8A6-DB4D90BC75B3}"/>
+                <a16:creationId xmlns:a16="http://schemas.microsoft.com/office/drawing/2014/main" id="{FD412999-0F71-46B7-B61C-37D61829AA65}"/>
               </a:ext>
             </a:extLst>
           </p:cNvPr>
@@ -21873,7 +21935,7 @@
           <p:cNvPr id="3" name="">
             <a:extLst xmlns:a="http://schemas.openxmlformats.org/drawingml/2006/main">
               <a:ext uri="{FF2B5EF4-FFF2-40B4-BE49-F238E27FC236}">
-                <a16:creationId xmlns:a16="http://schemas.microsoft.com/office/drawing/2014/main" id="{3004A9E1-7CCA-458D-927F-A202A285389C}"/>
+                <a16:creationId xmlns:a16="http://schemas.microsoft.com/office/drawing/2014/main" id="{BA65117B-6D7A-4A71-888A-1759668A2F62}"/>
               </a:ext>
             </a:extLst>
           </p:cNvPr>
@@ -21939,8 +22001,8 @@
           <p:nvPr/>
         </p:nvPicPr>
         <p:blipFill>
-          <a:blip xmlns:r="http://schemas.openxmlformats.org/officeDocument/2006/relationships" xmlns:a="http://schemas.openxmlformats.org/drawingml/2006/main" r:embed="Rf989d62dd16145b1"/>
-          <a:srcRect xmlns:a="http://schemas.openxmlformats.org/drawingml/2006/main" l="0" t="15675" r="0" b="15675"/>
+          <a:blip xmlns:r="http://schemas.openxmlformats.org/officeDocument/2006/relationships" xmlns:a="http://schemas.openxmlformats.org/drawingml/2006/main" r:embed="R88ad4374e1d14634"/>
+          <a:srcRect xmlns:a="http://schemas.openxmlformats.org/drawingml/2006/main" l="0" t="15682" r="0" b="15682"/>
           <a:stretch xmlns:a="http://schemas.openxmlformats.org/drawingml/2006/main">
             <a:fillRect l="0" t="0" r="0" b="0"/>
           </a:stretch>
@@ -21962,7 +22024,7 @@
           <p:cNvPr id="5" name="">
             <a:extLst xmlns:a="http://schemas.openxmlformats.org/drawingml/2006/main">
               <a:ext uri="{FF2B5EF4-FFF2-40B4-BE49-F238E27FC236}">
-                <a16:creationId xmlns:a16="http://schemas.microsoft.com/office/drawing/2014/main" id="{7C3F4222-ABFE-428A-A7F5-A758353A73A6}"/>
+                <a16:creationId xmlns:a16="http://schemas.microsoft.com/office/drawing/2014/main" id="{3D688004-1EEB-4AE1-9C52-29D3C5A48A47}"/>
               </a:ext>
             </a:extLst>
           </p:cNvPr>
@@ -21995,7 +22057,7 @@
           <p:cNvPr id="6" name="">
             <a:extLst xmlns:a="http://schemas.openxmlformats.org/drawingml/2006/main">
               <a:ext uri="{FF2B5EF4-FFF2-40B4-BE49-F238E27FC236}">
-                <a16:creationId xmlns:a16="http://schemas.microsoft.com/office/drawing/2014/main" id="{878F28CE-6CB0-4F47-A6F6-2F3A708DB717}"/>
+                <a16:creationId xmlns:a16="http://schemas.microsoft.com/office/drawing/2014/main" id="{D9790D84-A1F3-44B1-8C25-168DC80A93FC}"/>
               </a:ext>
             </a:extLst>
           </p:cNvPr>
@@ -22026,7 +22088,7 @@
           <p:cNvPr id="7" name="">
             <a:extLst xmlns:a="http://schemas.openxmlformats.org/drawingml/2006/main">
               <a:ext uri="{FF2B5EF4-FFF2-40B4-BE49-F238E27FC236}">
-                <a16:creationId xmlns:a16="http://schemas.microsoft.com/office/drawing/2014/main" id="{9D45783E-A1EB-44E5-8A1C-8DA42638ACA1}"/>
+                <a16:creationId xmlns:a16="http://schemas.microsoft.com/office/drawing/2014/main" id="{B8C6949A-DE03-4165-9252-324DFE4F30C4}"/>
               </a:ext>
             </a:extLst>
           </p:cNvPr>
@@ -22088,7 +22150,7 @@
           <p:cNvPr id="8" name="">
             <a:extLst xmlns:a="http://schemas.openxmlformats.org/drawingml/2006/main">
               <a:ext uri="{FF2B5EF4-FFF2-40B4-BE49-F238E27FC236}">
-                <a16:creationId xmlns:a16="http://schemas.microsoft.com/office/drawing/2014/main" id="{593EF73C-A724-4968-8E46-AA2B9C8E819F}"/>
+                <a16:creationId xmlns:a16="http://schemas.microsoft.com/office/drawing/2014/main" id="{8EB119D5-083E-406A-A045-09F7F1E34BE9}"/>
               </a:ext>
             </a:extLst>
           </p:cNvPr>
@@ -22123,7 +22185,7 @@
           <p:cNvPr id="9" name="">
             <a:extLst xmlns:a="http://schemas.openxmlformats.org/drawingml/2006/main">
               <a:ext uri="{FF2B5EF4-FFF2-40B4-BE49-F238E27FC236}">
-                <a16:creationId xmlns:a16="http://schemas.microsoft.com/office/drawing/2014/main" id="{4E51D931-FF47-447C-83AA-46A10D44E268}"/>
+                <a16:creationId xmlns:a16="http://schemas.microsoft.com/office/drawing/2014/main" id="{34CA9500-C31B-477E-823E-3910A04EC1BE}"/>
               </a:ext>
             </a:extLst>
           </p:cNvPr>
@@ -22185,7 +22247,7 @@
           <p:cNvPr id="10" name="">
             <a:extLst xmlns:a="http://schemas.openxmlformats.org/drawingml/2006/main">
               <a:ext uri="{FF2B5EF4-FFF2-40B4-BE49-F238E27FC236}">
-                <a16:creationId xmlns:a16="http://schemas.microsoft.com/office/drawing/2014/main" id="{7D8EB0A0-2A1A-4E9E-8010-6C8F589F6042}"/>
+                <a16:creationId xmlns:a16="http://schemas.microsoft.com/office/drawing/2014/main" id="{A161B08F-4995-4B30-BBDE-5BBCF1E3E02A}"/>
               </a:ext>
             </a:extLst>
           </p:cNvPr>
@@ -22216,7 +22278,7 @@
           <p:cNvPr id="11" name="">
             <a:extLst xmlns:a="http://schemas.openxmlformats.org/drawingml/2006/main">
               <a:ext uri="{FF2B5EF4-FFF2-40B4-BE49-F238E27FC236}">
-                <a16:creationId xmlns:a16="http://schemas.microsoft.com/office/drawing/2014/main" id="{2035019B-4866-4785-84C0-BDE7E885B8E2}"/>
+                <a16:creationId xmlns:a16="http://schemas.microsoft.com/office/drawing/2014/main" id="{6008C69A-83DD-4032-9C9A-D24BC4083318}"/>
               </a:ext>
             </a:extLst>
           </p:cNvPr>
@@ -22278,7 +22340,7 @@
           <p:cNvPr id="12" name="">
             <a:extLst xmlns:a="http://schemas.openxmlformats.org/drawingml/2006/main">
               <a:ext uri="{FF2B5EF4-FFF2-40B4-BE49-F238E27FC236}">
-                <a16:creationId xmlns:a16="http://schemas.microsoft.com/office/drawing/2014/main" id="{402A100E-93C7-49FD-99E2-F0AE317CCCC2}"/>
+                <a16:creationId xmlns:a16="http://schemas.microsoft.com/office/drawing/2014/main" id="{7A7DBB57-D5CA-462A-BA83-67812AB9825E}"/>
               </a:ext>
             </a:extLst>
           </p:cNvPr>
@@ -22313,7 +22375,7 @@
           <p:cNvPr id="13" name="">
             <a:extLst xmlns:a="http://schemas.openxmlformats.org/drawingml/2006/main">
               <a:ext uri="{FF2B5EF4-FFF2-40B4-BE49-F238E27FC236}">
-                <a16:creationId xmlns:a16="http://schemas.microsoft.com/office/drawing/2014/main" id="{335E178F-7007-4B46-8576-5EBF52FA9993}"/>
+                <a16:creationId xmlns:a16="http://schemas.microsoft.com/office/drawing/2014/main" id="{F514F28C-D285-4AD8-9DB5-4EAF1D666B14}"/>
               </a:ext>
             </a:extLst>
           </p:cNvPr>
@@ -22375,7 +22437,7 @@
           <p:cNvPr id="14" name="">
             <a:extLst xmlns:a="http://schemas.openxmlformats.org/drawingml/2006/main">
               <a:ext uri="{FF2B5EF4-FFF2-40B4-BE49-F238E27FC236}">
-                <a16:creationId xmlns:a16="http://schemas.microsoft.com/office/drawing/2014/main" id="{763F6B37-27D5-415A-BCD8-2E8D55252E36}"/>
+                <a16:creationId xmlns:a16="http://schemas.microsoft.com/office/drawing/2014/main" id="{5C46A5A8-AC46-4D32-9E90-69A53804C156}"/>
               </a:ext>
             </a:extLst>
           </p:cNvPr>
@@ -22406,7 +22468,7 @@
           <p:cNvPr id="15" name="">
             <a:extLst xmlns:a="http://schemas.openxmlformats.org/drawingml/2006/main">
               <a:ext uri="{FF2B5EF4-FFF2-40B4-BE49-F238E27FC236}">
-                <a16:creationId xmlns:a16="http://schemas.microsoft.com/office/drawing/2014/main" id="{93010C5A-F996-4843-8AF8-02D1D2CA4DA9}"/>
+                <a16:creationId xmlns:a16="http://schemas.microsoft.com/office/drawing/2014/main" id="{1D24152B-7B1C-468D-8616-F694EF09BDB6}"/>
               </a:ext>
             </a:extLst>
           </p:cNvPr>
@@ -22468,7 +22530,7 @@
           <p:cNvPr id="16" name="">
             <a:extLst xmlns:a="http://schemas.openxmlformats.org/drawingml/2006/main">
               <a:ext uri="{FF2B5EF4-FFF2-40B4-BE49-F238E27FC236}">
-                <a16:creationId xmlns:a16="http://schemas.microsoft.com/office/drawing/2014/main" id="{028E23D1-3056-49FC-B956-D26B9DD6AACF}"/>
+                <a16:creationId xmlns:a16="http://schemas.microsoft.com/office/drawing/2014/main" id="{F2D8285A-7D70-4CD0-8BC5-82AFD31C77C0}"/>
               </a:ext>
             </a:extLst>
           </p:cNvPr>
@@ -22503,7 +22565,7 @@
           <p:cNvPr id="17" name="">
             <a:extLst xmlns:a="http://schemas.openxmlformats.org/drawingml/2006/main">
               <a:ext uri="{FF2B5EF4-FFF2-40B4-BE49-F238E27FC236}">
-                <a16:creationId xmlns:a16="http://schemas.microsoft.com/office/drawing/2014/main" id="{B08BD457-E0A2-407A-8DB3-255F3D12F099}"/>
+                <a16:creationId xmlns:a16="http://schemas.microsoft.com/office/drawing/2014/main" id="{EA82FE8C-F140-48EA-A808-4713EAF34998}"/>
               </a:ext>
             </a:extLst>
           </p:cNvPr>
@@ -22565,7 +22627,7 @@
           <p:cNvPr id="18" name="">
             <a:extLst xmlns:a="http://schemas.openxmlformats.org/drawingml/2006/main">
               <a:ext uri="{FF2B5EF4-FFF2-40B4-BE49-F238E27FC236}">
-                <a16:creationId xmlns:a16="http://schemas.microsoft.com/office/drawing/2014/main" id="{2C8596FF-746B-4BB6-AF24-B3B29C4218F4}"/>
+                <a16:creationId xmlns:a16="http://schemas.microsoft.com/office/drawing/2014/main" id="{38F9E61B-CEBA-48E8-9504-600FEAB91CE4}"/>
               </a:ext>
             </a:extLst>
           </p:cNvPr>
@@ -22596,7 +22658,7 @@
           <p:cNvPr id="19" name="">
             <a:extLst xmlns:a="http://schemas.openxmlformats.org/drawingml/2006/main">
               <a:ext uri="{FF2B5EF4-FFF2-40B4-BE49-F238E27FC236}">
-                <a16:creationId xmlns:a16="http://schemas.microsoft.com/office/drawing/2014/main" id="{633A9EFD-3209-4624-AF6B-3D313C3055B5}"/>
+                <a16:creationId xmlns:a16="http://schemas.microsoft.com/office/drawing/2014/main" id="{400B9BDF-8CDC-4FAF-8A5B-9F7670248D3D}"/>
               </a:ext>
             </a:extLst>
           </p:cNvPr>
@@ -22648,7 +22710,7 @@
                 <a:ea typeface="Arial"/>
                 <a:cs typeface="Arial"/>
               </a:rPr>
-              <a:t>r2z-16690ccbe328 · scn-c46e1d86c1</a:t>
+              <a:t>r2z-45c4ba076af9 · scn-e0f12f397e</a:t>
             </a:r>
           </a:p>
         </p:txBody>
@@ -22658,7 +22720,7 @@
           <p:cNvPr id="20" name="">
             <a:extLst xmlns:a="http://schemas.openxmlformats.org/drawingml/2006/main">
               <a:ext uri="{FF2B5EF4-FFF2-40B4-BE49-F238E27FC236}">
-                <a16:creationId xmlns:a16="http://schemas.microsoft.com/office/drawing/2014/main" id="{4C13560B-E38F-4D96-A054-7D89F1297251}"/>
+                <a16:creationId xmlns:a16="http://schemas.microsoft.com/office/drawing/2014/main" id="{02F78AAC-0B26-42EF-B101-CEFA71179847}"/>
               </a:ext>
             </a:extLst>
           </p:cNvPr>
@@ -22718,7 +22780,7 @@
     </p:spTree>
     <p:extLst>
       <p:ext uri="{BB962C8B-B14F-4D97-AF65-F5344CB8AC3E}">
-        <p14:creationId xmlns:p14="http://schemas.microsoft.com/office/powerpoint/2010/main" val="1907115575"/>
+        <p14:creationId xmlns:p14="http://schemas.microsoft.com/office/powerpoint/2010/main" val="556513748"/>
       </p:ext>
     </p:extLst>
   </p:cSld>

</xml_diff>

<commit_message>
Make pipeline checksums cross-platform
</commit_message>
<xml_diff>
--- a/output/submission/Route2Zero_Prototype_Demonstration.pptx
+++ b/output/submission/Route2Zero_Prototype_Demonstration.pptx
@@ -2,30 +2,30 @@
 <file path=ppt/presentation.xml><?xml version="1.0" encoding="utf-8"?>
 <p:presentation xmlns:p="http://schemas.openxmlformats.org/presentationml/2006/main">
   <p:sldMasterIdLst>
-    <p:sldMasterId xmlns:r="http://schemas.openxmlformats.org/officeDocument/2006/relationships" id="2147483648" r:id="Re689df812c834c65"/>
+    <p:sldMasterId xmlns:r="http://schemas.openxmlformats.org/officeDocument/2006/relationships" id="2147483648" r:id="Re153d8f9ebc44da4"/>
   </p:sldMasterIdLst>
   <p:notesMasterIdLst>
-    <p:notesMasterId xmlns:r="http://schemas.openxmlformats.org/officeDocument/2006/relationships" r:id="R57c9c500a20e4e4e"/>
+    <p:notesMasterId xmlns:r="http://schemas.openxmlformats.org/officeDocument/2006/relationships" r:id="R3e2582f1dbd14d5c"/>
   </p:notesMasterIdLst>
   <p:sldIdLst>
-    <p:sldId xmlns:r="http://schemas.openxmlformats.org/officeDocument/2006/relationships" id="256" r:id="Rf4dab43fb6db4fb8"/>
-    <p:sldId xmlns:r="http://schemas.openxmlformats.org/officeDocument/2006/relationships" id="257" r:id="R01b704caacdd4b0a"/>
-    <p:sldId xmlns:r="http://schemas.openxmlformats.org/officeDocument/2006/relationships" id="258" r:id="Rcbc82ad5d9c64c23"/>
-    <p:sldId xmlns:r="http://schemas.openxmlformats.org/officeDocument/2006/relationships" id="259" r:id="R1295507b2e8a4e90"/>
-    <p:sldId xmlns:r="http://schemas.openxmlformats.org/officeDocument/2006/relationships" id="260" r:id="Rc27e455919cc4129"/>
-    <p:sldId xmlns:r="http://schemas.openxmlformats.org/officeDocument/2006/relationships" id="261" r:id="R44d81ebf65274cd1"/>
-    <p:sldId xmlns:r="http://schemas.openxmlformats.org/officeDocument/2006/relationships" id="262" r:id="R16d575af63e34cc2"/>
-    <p:sldId xmlns:r="http://schemas.openxmlformats.org/officeDocument/2006/relationships" id="263" r:id="Rca1b417ea2164807"/>
-    <p:sldId xmlns:r="http://schemas.openxmlformats.org/officeDocument/2006/relationships" id="264" r:id="Reb37ea308e0842ba"/>
-    <p:sldId xmlns:r="http://schemas.openxmlformats.org/officeDocument/2006/relationships" id="265" r:id="Rbb5d7323d5c24d49"/>
-    <p:sldId xmlns:r="http://schemas.openxmlformats.org/officeDocument/2006/relationships" id="266" r:id="R52da9c02cf5e40b1"/>
-    <p:sldId xmlns:r="http://schemas.openxmlformats.org/officeDocument/2006/relationships" id="267" r:id="Rb8067d3f9e7640e8"/>
-    <p:sldId xmlns:r="http://schemas.openxmlformats.org/officeDocument/2006/relationships" id="268" r:id="Rc373777a5626486b"/>
-    <p:sldId xmlns:r="http://schemas.openxmlformats.org/officeDocument/2006/relationships" id="269" r:id="R0dbfb5a2e3fc4887"/>
-    <p:sldId xmlns:r="http://schemas.openxmlformats.org/officeDocument/2006/relationships" id="270" r:id="R1c7f9beb7b744059"/>
-    <p:sldId xmlns:r="http://schemas.openxmlformats.org/officeDocument/2006/relationships" id="271" r:id="Rcea7b755c4354801"/>
-    <p:sldId xmlns:r="http://schemas.openxmlformats.org/officeDocument/2006/relationships" id="272" r:id="R42adc46232c24106"/>
-    <p:sldId xmlns:r="http://schemas.openxmlformats.org/officeDocument/2006/relationships" id="273" r:id="R442099fd7eb04ed5"/>
+    <p:sldId xmlns:r="http://schemas.openxmlformats.org/officeDocument/2006/relationships" id="256" r:id="Rc7a9bfd6012d4864"/>
+    <p:sldId xmlns:r="http://schemas.openxmlformats.org/officeDocument/2006/relationships" id="257" r:id="R00f1afe0dae44b24"/>
+    <p:sldId xmlns:r="http://schemas.openxmlformats.org/officeDocument/2006/relationships" id="258" r:id="Re51ca26d2749480b"/>
+    <p:sldId xmlns:r="http://schemas.openxmlformats.org/officeDocument/2006/relationships" id="259" r:id="Ra704eaef2ea347e9"/>
+    <p:sldId xmlns:r="http://schemas.openxmlformats.org/officeDocument/2006/relationships" id="260" r:id="R2e815fb2abd64684"/>
+    <p:sldId xmlns:r="http://schemas.openxmlformats.org/officeDocument/2006/relationships" id="261" r:id="Re55801838e664008"/>
+    <p:sldId xmlns:r="http://schemas.openxmlformats.org/officeDocument/2006/relationships" id="262" r:id="Rf5e0e332cd2c40e9"/>
+    <p:sldId xmlns:r="http://schemas.openxmlformats.org/officeDocument/2006/relationships" id="263" r:id="R41c58c2548d24fb6"/>
+    <p:sldId xmlns:r="http://schemas.openxmlformats.org/officeDocument/2006/relationships" id="264" r:id="Ree807fc7e56748a1"/>
+    <p:sldId xmlns:r="http://schemas.openxmlformats.org/officeDocument/2006/relationships" id="265" r:id="Rd64b8e05fa69437b"/>
+    <p:sldId xmlns:r="http://schemas.openxmlformats.org/officeDocument/2006/relationships" id="266" r:id="R59a29a09484745e3"/>
+    <p:sldId xmlns:r="http://schemas.openxmlformats.org/officeDocument/2006/relationships" id="267" r:id="R31e040841b984386"/>
+    <p:sldId xmlns:r="http://schemas.openxmlformats.org/officeDocument/2006/relationships" id="268" r:id="R0a007cf2ff054e6a"/>
+    <p:sldId xmlns:r="http://schemas.openxmlformats.org/officeDocument/2006/relationships" id="269" r:id="R59e610da815d4047"/>
+    <p:sldId xmlns:r="http://schemas.openxmlformats.org/officeDocument/2006/relationships" id="270" r:id="R50011a81862c43b9"/>
+    <p:sldId xmlns:r="http://schemas.openxmlformats.org/officeDocument/2006/relationships" id="271" r:id="Re28a721ceaf14a78"/>
+    <p:sldId xmlns:r="http://schemas.openxmlformats.org/officeDocument/2006/relationships" id="272" r:id="R8fe50a8f4a4d43e7"/>
+    <p:sldId xmlns:r="http://schemas.openxmlformats.org/officeDocument/2006/relationships" id="273" r:id="R00dfed42930e487f"/>
   </p:sldIdLst>
   <p:sldSz cx="12192000" cy="6858000"/>
   <p:notesSz cx="6858000" cy="9144000"/>
@@ -1932,7 +1932,7 @@
   </p:cSld>
   <p:clrMap bg1="lt1" tx1="dk1" bg2="lt2" tx2="dk2" accent1="accent1" accent2="accent2" accent3="accent3" accent4="accent4" accent5="accent5" accent6="accent6" hlink="hlink" folHlink="folHlink"/>
   <p:sldLayoutIdLst>
-    <p:sldLayoutId xmlns:r="http://schemas.openxmlformats.org/officeDocument/2006/relationships" id="2147483649" r:id="Rd46a596da8c44783"/>
+    <p:sldLayoutId xmlns:r="http://schemas.openxmlformats.org/officeDocument/2006/relationships" id="2147483649" r:id="R4e2360d9abee431e"/>
   </p:sldLayoutIdLst>
   <p:txStyles>
     <p:titleStyle>
@@ -2648,7 +2648,7 @@
           <p:cNvPr id="19" name="">
             <a:extLst xmlns:a="http://schemas.openxmlformats.org/drawingml/2006/main">
               <a:ext uri="{FF2B5EF4-FFF2-40B4-BE49-F238E27FC236}">
-                <a16:creationId xmlns:a16="http://schemas.microsoft.com/office/drawing/2014/main" id="{4C90C812-EFCB-4E04-A53B-B9C800851F37}"/>
+                <a16:creationId xmlns:a16="http://schemas.microsoft.com/office/drawing/2014/main" id="{315E89F1-50B1-4593-8835-1C550AB51445}"/>
               </a:ext>
             </a:extLst>
           </p:cNvPr>
@@ -2710,7 +2710,7 @@
                 <a:latin typeface="Arial"/>
                 <a:ea typeface="Arial"/>
                 <a:cs typeface="Arial"/>
-                <a:hlinkClick xmlns:r="http://schemas.openxmlformats.org/officeDocument/2006/relationships" r:id="R9e84c11dc8bd45be"/>
+                <a:hlinkClick xmlns:r="http://schemas.openxmlformats.org/officeDocument/2006/relationships" r:id="R3d600b7e4d3c4c66"/>
               </a:rPr>
               <a:t>https://github.com/qjmre23/Route2Zero</a:t>
             </a:r>
@@ -2733,7 +2733,7 @@
                 <a:latin typeface="Arial"/>
                 <a:ea typeface="Arial"/>
                 <a:cs typeface="Arial"/>
-                <a:hlinkClick xmlns:r="http://schemas.openxmlformats.org/officeDocument/2006/relationships" r:id="R3bca2482fba14810"/>
+                <a:hlinkClick xmlns:r="http://schemas.openxmlformats.org/officeDocument/2006/relationships" r:id="Rc6c04c354b4e4dab"/>
               </a:rPr>
               <a:t>https://route2zero.netlify.app/</a:t>
             </a:r>
@@ -2749,7 +2749,7 @@
           <p:nvPr/>
         </p:nvPicPr>
         <p:blipFill>
-          <a:blip xmlns:r="http://schemas.openxmlformats.org/officeDocument/2006/relationships" xmlns:a="http://schemas.openxmlformats.org/drawingml/2006/main" r:embed="R97704ece54bc4a18"/>
+          <a:blip xmlns:r="http://schemas.openxmlformats.org/officeDocument/2006/relationships" xmlns:a="http://schemas.openxmlformats.org/drawingml/2006/main" r:embed="Rd1ec0b263a7b45cb"/>
           <a:srcRect xmlns:a="http://schemas.openxmlformats.org/drawingml/2006/main" l="18532" t="0" r="18532" b="0"/>
           <a:stretch xmlns:a="http://schemas.openxmlformats.org/drawingml/2006/main">
             <a:fillRect l="0" t="0" r="0" b="0"/>
@@ -2770,7 +2770,7 @@
           <p:cNvPr id="3" name="">
             <a:extLst xmlns:a="http://schemas.openxmlformats.org/drawingml/2006/main">
               <a:ext uri="{FF2B5EF4-FFF2-40B4-BE49-F238E27FC236}">
-                <a16:creationId xmlns:a16="http://schemas.microsoft.com/office/drawing/2014/main" id="{7729FC7A-BA60-43C0-8DE1-7BB55C704F03}"/>
+                <a16:creationId xmlns:a16="http://schemas.microsoft.com/office/drawing/2014/main" id="{D9E7865C-C5C9-4B82-A1EE-3104F49C170A}"/>
               </a:ext>
             </a:extLst>
           </p:cNvPr>
@@ -2816,7 +2816,7 @@
           <p:cNvPr id="4" name="">
             <a:extLst xmlns:a="http://schemas.openxmlformats.org/drawingml/2006/main">
               <a:ext uri="{FF2B5EF4-FFF2-40B4-BE49-F238E27FC236}">
-                <a16:creationId xmlns:a16="http://schemas.microsoft.com/office/drawing/2014/main" id="{6D0094FB-2F36-477C-9843-C2D57B57E8F5}"/>
+                <a16:creationId xmlns:a16="http://schemas.microsoft.com/office/drawing/2014/main" id="{60F49254-BBD0-4732-AF8D-C7CE78FFCC61}"/>
               </a:ext>
             </a:extLst>
           </p:cNvPr>
@@ -2878,7 +2878,7 @@
           <p:cNvPr id="5" name="">
             <a:extLst xmlns:a="http://schemas.openxmlformats.org/drawingml/2006/main">
               <a:ext uri="{FF2B5EF4-FFF2-40B4-BE49-F238E27FC236}">
-                <a16:creationId xmlns:a16="http://schemas.microsoft.com/office/drawing/2014/main" id="{999B4C15-87B3-4BC9-94EE-E55ECEE1F19E}"/>
+                <a16:creationId xmlns:a16="http://schemas.microsoft.com/office/drawing/2014/main" id="{AE94CC14-57B7-447F-8D39-6640B37F6345}"/>
               </a:ext>
             </a:extLst>
           </p:cNvPr>
@@ -2940,7 +2940,7 @@
           <p:cNvPr id="6" name="">
             <a:extLst xmlns:a="http://schemas.openxmlformats.org/drawingml/2006/main">
               <a:ext uri="{FF2B5EF4-FFF2-40B4-BE49-F238E27FC236}">
-                <a16:creationId xmlns:a16="http://schemas.microsoft.com/office/drawing/2014/main" id="{12D3B2DC-C568-4BCE-9A63-9E6314C839BF}"/>
+                <a16:creationId xmlns:a16="http://schemas.microsoft.com/office/drawing/2014/main" id="{F301299C-C63A-42F4-876E-AEC8895B218C}"/>
               </a:ext>
             </a:extLst>
           </p:cNvPr>
@@ -3002,7 +3002,7 @@
           <p:cNvPr id="7" name="">
             <a:extLst xmlns:a="http://schemas.openxmlformats.org/drawingml/2006/main">
               <a:ext uri="{FF2B5EF4-FFF2-40B4-BE49-F238E27FC236}">
-                <a16:creationId xmlns:a16="http://schemas.microsoft.com/office/drawing/2014/main" id="{5B4D791C-2390-4790-A717-78B79D0C3E64}"/>
+                <a16:creationId xmlns:a16="http://schemas.microsoft.com/office/drawing/2014/main" id="{B606C9FE-E160-4DEB-BB7D-D7D6857B7724}"/>
               </a:ext>
             </a:extLst>
           </p:cNvPr>
@@ -3064,7 +3064,7 @@
           <p:cNvPr id="8" name="">
             <a:extLst xmlns:a="http://schemas.openxmlformats.org/drawingml/2006/main">
               <a:ext uri="{FF2B5EF4-FFF2-40B4-BE49-F238E27FC236}">
-                <a16:creationId xmlns:a16="http://schemas.microsoft.com/office/drawing/2014/main" id="{ADB1D409-44A9-4E80-80EB-F92A834E0925}"/>
+                <a16:creationId xmlns:a16="http://schemas.microsoft.com/office/drawing/2014/main" id="{4245F058-28BE-4405-B5E6-AB4BEF6BF90E}"/>
               </a:ext>
             </a:extLst>
           </p:cNvPr>
@@ -3126,7 +3126,7 @@
           <p:cNvPr id="9" name="">
             <a:extLst xmlns:a="http://schemas.openxmlformats.org/drawingml/2006/main">
               <a:ext uri="{FF2B5EF4-FFF2-40B4-BE49-F238E27FC236}">
-                <a16:creationId xmlns:a16="http://schemas.microsoft.com/office/drawing/2014/main" id="{56A6A426-7F6A-4A73-BE65-E60B81FD50F6}"/>
+                <a16:creationId xmlns:a16="http://schemas.microsoft.com/office/drawing/2014/main" id="{9D58E703-7EFB-47CA-AD39-2F86E922BF41}"/>
               </a:ext>
             </a:extLst>
           </p:cNvPr>
@@ -3188,7 +3188,7 @@
           <p:cNvPr id="10" name="">
             <a:extLst xmlns:a="http://schemas.openxmlformats.org/drawingml/2006/main">
               <a:ext uri="{FF2B5EF4-FFF2-40B4-BE49-F238E27FC236}">
-                <a16:creationId xmlns:a16="http://schemas.microsoft.com/office/drawing/2014/main" id="{CD6109DA-3061-4424-BC79-2DF98BDF8F6E}"/>
+                <a16:creationId xmlns:a16="http://schemas.microsoft.com/office/drawing/2014/main" id="{452F3AF5-68D8-45CC-B2C6-6FA163F7BB95}"/>
               </a:ext>
             </a:extLst>
           </p:cNvPr>
@@ -3250,7 +3250,7 @@
           <p:cNvPr id="11" name="">
             <a:extLst xmlns:a="http://schemas.openxmlformats.org/drawingml/2006/main">
               <a:ext uri="{FF2B5EF4-FFF2-40B4-BE49-F238E27FC236}">
-                <a16:creationId xmlns:a16="http://schemas.microsoft.com/office/drawing/2014/main" id="{681962F5-44D2-46A6-B9BD-70E325A3B801}"/>
+                <a16:creationId xmlns:a16="http://schemas.microsoft.com/office/drawing/2014/main" id="{8B77EB9F-BFAD-47A5-BF9E-F0565EC90721}"/>
               </a:ext>
             </a:extLst>
           </p:cNvPr>
@@ -3312,7 +3312,7 @@
           <p:cNvPr id="12" name="">
             <a:extLst xmlns:a="http://schemas.openxmlformats.org/drawingml/2006/main">
               <a:ext uri="{FF2B5EF4-FFF2-40B4-BE49-F238E27FC236}">
-                <a16:creationId xmlns:a16="http://schemas.microsoft.com/office/drawing/2014/main" id="{A0D9BED4-4132-4352-9110-86F0CE540D61}"/>
+                <a16:creationId xmlns:a16="http://schemas.microsoft.com/office/drawing/2014/main" id="{59A94D92-08D7-4FA7-84BF-CA2758942240}"/>
               </a:ext>
             </a:extLst>
           </p:cNvPr>
@@ -3374,7 +3374,7 @@
           <p:cNvPr id="13" name="">
             <a:extLst xmlns:a="http://schemas.openxmlformats.org/drawingml/2006/main">
               <a:ext uri="{FF2B5EF4-FFF2-40B4-BE49-F238E27FC236}">
-                <a16:creationId xmlns:a16="http://schemas.microsoft.com/office/drawing/2014/main" id="{5151BF67-488D-4F72-839C-0CB7FD695CCF}"/>
+                <a16:creationId xmlns:a16="http://schemas.microsoft.com/office/drawing/2014/main" id="{DD8F80D0-69FA-419F-8D81-69FBCB7E94F6}"/>
               </a:ext>
             </a:extLst>
           </p:cNvPr>
@@ -3436,7 +3436,7 @@
           <p:cNvPr id="14" name="">
             <a:extLst xmlns:a="http://schemas.openxmlformats.org/drawingml/2006/main">
               <a:ext uri="{FF2B5EF4-FFF2-40B4-BE49-F238E27FC236}">
-                <a16:creationId xmlns:a16="http://schemas.microsoft.com/office/drawing/2014/main" id="{367E2684-4B06-4C19-BAFD-8BDB71974B43}"/>
+                <a16:creationId xmlns:a16="http://schemas.microsoft.com/office/drawing/2014/main" id="{EA9FA33D-64E1-44C3-B838-9C1FEA9E2638}"/>
               </a:ext>
             </a:extLst>
           </p:cNvPr>
@@ -3488,7 +3488,7 @@
                 <a:ea typeface="Arial"/>
                 <a:cs typeface="Arial"/>
               </a:rPr>
-              <a:t>20 Aug 2026 · 06:25 UTC</a:t>
+              <a:t>20 Aug 2026 · 06:49 UTC</a:t>
             </a:r>
           </a:p>
         </p:txBody>
@@ -3498,7 +3498,7 @@
           <p:cNvPr id="15" name="">
             <a:extLst xmlns:a="http://schemas.openxmlformats.org/drawingml/2006/main">
               <a:ext uri="{FF2B5EF4-FFF2-40B4-BE49-F238E27FC236}">
-                <a16:creationId xmlns:a16="http://schemas.microsoft.com/office/drawing/2014/main" id="{1C151492-436F-4335-856C-7ED837A2B489}"/>
+                <a16:creationId xmlns:a16="http://schemas.microsoft.com/office/drawing/2014/main" id="{D17D786E-7357-498D-AB37-4E5B801E229B}"/>
               </a:ext>
             </a:extLst>
           </p:cNvPr>
@@ -3560,7 +3560,7 @@
           <p:cNvPr id="16" name="">
             <a:extLst xmlns:a="http://schemas.openxmlformats.org/drawingml/2006/main">
               <a:ext uri="{FF2B5EF4-FFF2-40B4-BE49-F238E27FC236}">
-                <a16:creationId xmlns:a16="http://schemas.microsoft.com/office/drawing/2014/main" id="{42B1BF0B-5381-4ADC-94EA-944BDA584172}"/>
+                <a16:creationId xmlns:a16="http://schemas.microsoft.com/office/drawing/2014/main" id="{506B5FBC-ECF7-4EC9-B86E-8ED8D433DC09}"/>
               </a:ext>
             </a:extLst>
           </p:cNvPr>
@@ -3591,7 +3591,7 @@
           <p:cNvPr id="17" name="">
             <a:extLst xmlns:a="http://schemas.openxmlformats.org/drawingml/2006/main">
               <a:ext uri="{FF2B5EF4-FFF2-40B4-BE49-F238E27FC236}">
-                <a16:creationId xmlns:a16="http://schemas.microsoft.com/office/drawing/2014/main" id="{E7A448C1-264A-46A0-85E2-993ED6E59181}"/>
+                <a16:creationId xmlns:a16="http://schemas.microsoft.com/office/drawing/2014/main" id="{DE864291-7338-4ACB-8371-0CD15015C559}"/>
               </a:ext>
             </a:extLst>
           </p:cNvPr>
@@ -3653,7 +3653,7 @@
           <p:cNvPr id="18" name="">
             <a:extLst xmlns:a="http://schemas.openxmlformats.org/drawingml/2006/main">
               <a:ext uri="{FF2B5EF4-FFF2-40B4-BE49-F238E27FC236}">
-                <a16:creationId xmlns:a16="http://schemas.microsoft.com/office/drawing/2014/main" id="{75BB1448-AB44-4FB8-9D96-2FCBEF7CBF4B}"/>
+                <a16:creationId xmlns:a16="http://schemas.microsoft.com/office/drawing/2014/main" id="{4A91F440-E9E8-4DC2-9649-3A9081FCAB7A}"/>
               </a:ext>
             </a:extLst>
           </p:cNvPr>
@@ -3713,7 +3713,7 @@
     </p:spTree>
     <p:extLst>
       <p:ext uri="{BB962C8B-B14F-4D97-AF65-F5344CB8AC3E}">
-        <p14:creationId xmlns:p14="http://schemas.microsoft.com/office/powerpoint/2010/main" val="813090047"/>
+        <p14:creationId xmlns:p14="http://schemas.microsoft.com/office/powerpoint/2010/main" val="682066051"/>
       </p:ext>
     </p:extLst>
   </p:cSld>
@@ -3744,7 +3744,7 @@
           <p:cNvPr id="21" name="">
             <a:extLst xmlns:a="http://schemas.openxmlformats.org/drawingml/2006/main">
               <a:ext uri="{FF2B5EF4-FFF2-40B4-BE49-F238E27FC236}">
-                <a16:creationId xmlns:a16="http://schemas.microsoft.com/office/drawing/2014/main" id="{DE0BAA39-415A-4FAE-A99D-E7FF82D411C0}"/>
+                <a16:creationId xmlns:a16="http://schemas.microsoft.com/office/drawing/2014/main" id="{10A88C73-68D8-49F9-8387-F5BA4449F27B}"/>
               </a:ext>
             </a:extLst>
           </p:cNvPr>
@@ -3806,7 +3806,7 @@
                 <a:latin typeface="Arial"/>
                 <a:ea typeface="Arial"/>
                 <a:cs typeface="Arial"/>
-                <a:hlinkClick xmlns:r="http://schemas.openxmlformats.org/officeDocument/2006/relationships" r:id="R7311fda201124ed0"/>
+                <a:hlinkClick xmlns:r="http://schemas.openxmlformats.org/officeDocument/2006/relationships" r:id="R68b2d4942c574d05"/>
               </a:rPr>
               <a:t>https://github.com/qjmre23/Route2Zero</a:t>
             </a:r>
@@ -3829,7 +3829,7 @@
                 <a:latin typeface="Arial"/>
                 <a:ea typeface="Arial"/>
                 <a:cs typeface="Arial"/>
-                <a:hlinkClick xmlns:r="http://schemas.openxmlformats.org/officeDocument/2006/relationships" r:id="R4dd5b8eec56a49f7"/>
+                <a:hlinkClick xmlns:r="http://schemas.openxmlformats.org/officeDocument/2006/relationships" r:id="R2a7fa5a81ed84fc9"/>
               </a:rPr>
               <a:t>https://route2zero.netlify.app/</a:t>
             </a:r>
@@ -3841,7 +3841,7 @@
           <p:cNvPr id="2" name="">
             <a:extLst xmlns:a="http://schemas.openxmlformats.org/drawingml/2006/main">
               <a:ext uri="{FF2B5EF4-FFF2-40B4-BE49-F238E27FC236}">
-                <a16:creationId xmlns:a16="http://schemas.microsoft.com/office/drawing/2014/main" id="{B2A54CE1-B8AF-4B8D-8C50-097D7BD3B451}"/>
+                <a16:creationId xmlns:a16="http://schemas.microsoft.com/office/drawing/2014/main" id="{E1D0CCE0-B005-416B-AB99-7DFDB49CB4EA}"/>
               </a:ext>
             </a:extLst>
           </p:cNvPr>
@@ -3903,7 +3903,7 @@
           <p:cNvPr id="3" name="">
             <a:extLst xmlns:a="http://schemas.openxmlformats.org/drawingml/2006/main">
               <a:ext uri="{FF2B5EF4-FFF2-40B4-BE49-F238E27FC236}">
-                <a16:creationId xmlns:a16="http://schemas.microsoft.com/office/drawing/2014/main" id="{0EFA1DAF-2197-48A3-B6F1-981C4C9BC459}"/>
+                <a16:creationId xmlns:a16="http://schemas.microsoft.com/office/drawing/2014/main" id="{B70553B9-AA4C-4272-9567-9C1046B66E80}"/>
               </a:ext>
             </a:extLst>
           </p:cNvPr>
@@ -3969,7 +3969,7 @@
           <p:nvPr/>
         </p:nvPicPr>
         <p:blipFill>
-          <a:blip xmlns:r="http://schemas.openxmlformats.org/officeDocument/2006/relationships" xmlns:a="http://schemas.openxmlformats.org/drawingml/2006/main" r:embed="Rbd726a4f1c4c4cc7"/>
+          <a:blip xmlns:r="http://schemas.openxmlformats.org/officeDocument/2006/relationships" xmlns:a="http://schemas.openxmlformats.org/drawingml/2006/main" r:embed="R16b123f9fcdd41a4"/>
           <a:srcRect xmlns:a="http://schemas.openxmlformats.org/drawingml/2006/main" l="0" t="15682" r="0" b="15682"/>
           <a:stretch xmlns:a="http://schemas.openxmlformats.org/drawingml/2006/main">
             <a:fillRect l="0" t="0" r="0" b="0"/>
@@ -3992,7 +3992,7 @@
           <p:cNvPr id="5" name="">
             <a:extLst xmlns:a="http://schemas.openxmlformats.org/drawingml/2006/main">
               <a:ext uri="{FF2B5EF4-FFF2-40B4-BE49-F238E27FC236}">
-                <a16:creationId xmlns:a16="http://schemas.microsoft.com/office/drawing/2014/main" id="{55762E46-0A2A-47EE-8FB2-D4159477738E}"/>
+                <a16:creationId xmlns:a16="http://schemas.microsoft.com/office/drawing/2014/main" id="{1F671DB4-0B2F-4D2D-B92C-F19FFC90FCBB}"/>
               </a:ext>
             </a:extLst>
           </p:cNvPr>
@@ -4025,7 +4025,7 @@
           <p:cNvPr id="6" name="">
             <a:extLst xmlns:a="http://schemas.openxmlformats.org/drawingml/2006/main">
               <a:ext uri="{FF2B5EF4-FFF2-40B4-BE49-F238E27FC236}">
-                <a16:creationId xmlns:a16="http://schemas.microsoft.com/office/drawing/2014/main" id="{49E9E90E-F15C-4479-BE99-B776DBD26F3A}"/>
+                <a16:creationId xmlns:a16="http://schemas.microsoft.com/office/drawing/2014/main" id="{2E789B0C-70B6-4FFF-B53A-6B8E3E80EEE5}"/>
               </a:ext>
             </a:extLst>
           </p:cNvPr>
@@ -4056,7 +4056,7 @@
           <p:cNvPr id="7" name="">
             <a:extLst xmlns:a="http://schemas.openxmlformats.org/drawingml/2006/main">
               <a:ext uri="{FF2B5EF4-FFF2-40B4-BE49-F238E27FC236}">
-                <a16:creationId xmlns:a16="http://schemas.microsoft.com/office/drawing/2014/main" id="{8D682BC8-F44B-4C63-A7A8-0606C77ACB9E}"/>
+                <a16:creationId xmlns:a16="http://schemas.microsoft.com/office/drawing/2014/main" id="{4F53E3F0-DB33-4E53-B628-C741446CBFB1}"/>
               </a:ext>
             </a:extLst>
           </p:cNvPr>
@@ -4118,7 +4118,7 @@
           <p:cNvPr id="8" name="">
             <a:extLst xmlns:a="http://schemas.openxmlformats.org/drawingml/2006/main">
               <a:ext uri="{FF2B5EF4-FFF2-40B4-BE49-F238E27FC236}">
-                <a16:creationId xmlns:a16="http://schemas.microsoft.com/office/drawing/2014/main" id="{E7DE9D35-6F94-4D0D-9F98-2D5E80E2ACB8}"/>
+                <a16:creationId xmlns:a16="http://schemas.microsoft.com/office/drawing/2014/main" id="{AE16FD46-A810-4A8B-8E21-C2D2A3792A59}"/>
               </a:ext>
             </a:extLst>
           </p:cNvPr>
@@ -4153,7 +4153,7 @@
           <p:cNvPr id="9" name="">
             <a:extLst xmlns:a="http://schemas.openxmlformats.org/drawingml/2006/main">
               <a:ext uri="{FF2B5EF4-FFF2-40B4-BE49-F238E27FC236}">
-                <a16:creationId xmlns:a16="http://schemas.microsoft.com/office/drawing/2014/main" id="{B8CD98C9-5CC0-487C-92E5-B7E93DDFEE5A}"/>
+                <a16:creationId xmlns:a16="http://schemas.microsoft.com/office/drawing/2014/main" id="{F61E5F90-03EE-42E2-9DD1-B6ED0EA9C249}"/>
               </a:ext>
             </a:extLst>
           </p:cNvPr>
@@ -4215,7 +4215,7 @@
           <p:cNvPr id="10" name="">
             <a:extLst xmlns:a="http://schemas.openxmlformats.org/drawingml/2006/main">
               <a:ext uri="{FF2B5EF4-FFF2-40B4-BE49-F238E27FC236}">
-                <a16:creationId xmlns:a16="http://schemas.microsoft.com/office/drawing/2014/main" id="{AB17C3CC-389A-4C96-AEA5-6FF3A7ACF210}"/>
+                <a16:creationId xmlns:a16="http://schemas.microsoft.com/office/drawing/2014/main" id="{D996EA77-ADCA-461E-8F6E-4E55CB80E04E}"/>
               </a:ext>
             </a:extLst>
           </p:cNvPr>
@@ -4246,7 +4246,7 @@
           <p:cNvPr id="11" name="">
             <a:extLst xmlns:a="http://schemas.openxmlformats.org/drawingml/2006/main">
               <a:ext uri="{FF2B5EF4-FFF2-40B4-BE49-F238E27FC236}">
-                <a16:creationId xmlns:a16="http://schemas.microsoft.com/office/drawing/2014/main" id="{11A31755-2B43-445C-9CDE-7F4746FC05CF}"/>
+                <a16:creationId xmlns:a16="http://schemas.microsoft.com/office/drawing/2014/main" id="{E3DC5DED-4A0A-45D6-865A-1CB11B419451}"/>
               </a:ext>
             </a:extLst>
           </p:cNvPr>
@@ -4308,7 +4308,7 @@
           <p:cNvPr id="12" name="">
             <a:extLst xmlns:a="http://schemas.openxmlformats.org/drawingml/2006/main">
               <a:ext uri="{FF2B5EF4-FFF2-40B4-BE49-F238E27FC236}">
-                <a16:creationId xmlns:a16="http://schemas.microsoft.com/office/drawing/2014/main" id="{8DEF8F15-3348-4D14-A0A8-0A2E2A574F8A}"/>
+                <a16:creationId xmlns:a16="http://schemas.microsoft.com/office/drawing/2014/main" id="{A17D276C-AE69-4C86-8C35-4C7EB8ED030C}"/>
               </a:ext>
             </a:extLst>
           </p:cNvPr>
@@ -4343,7 +4343,7 @@
           <p:cNvPr id="13" name="">
             <a:extLst xmlns:a="http://schemas.openxmlformats.org/drawingml/2006/main">
               <a:ext uri="{FF2B5EF4-FFF2-40B4-BE49-F238E27FC236}">
-                <a16:creationId xmlns:a16="http://schemas.microsoft.com/office/drawing/2014/main" id="{8DC402DC-195A-474E-9609-309B0FB85FEF}"/>
+                <a16:creationId xmlns:a16="http://schemas.microsoft.com/office/drawing/2014/main" id="{E4ADEC62-493F-40ED-825A-E66F2EFAAA91}"/>
               </a:ext>
             </a:extLst>
           </p:cNvPr>
@@ -4405,7 +4405,7 @@
           <p:cNvPr id="14" name="">
             <a:extLst xmlns:a="http://schemas.openxmlformats.org/drawingml/2006/main">
               <a:ext uri="{FF2B5EF4-FFF2-40B4-BE49-F238E27FC236}">
-                <a16:creationId xmlns:a16="http://schemas.microsoft.com/office/drawing/2014/main" id="{60C2DFCE-7BDF-40EC-BACF-EC5477F08E34}"/>
+                <a16:creationId xmlns:a16="http://schemas.microsoft.com/office/drawing/2014/main" id="{00A9F811-FEF4-4968-93B1-8E822C2E706E}"/>
               </a:ext>
             </a:extLst>
           </p:cNvPr>
@@ -4436,7 +4436,7 @@
           <p:cNvPr id="15" name="">
             <a:extLst xmlns:a="http://schemas.openxmlformats.org/drawingml/2006/main">
               <a:ext uri="{FF2B5EF4-FFF2-40B4-BE49-F238E27FC236}">
-                <a16:creationId xmlns:a16="http://schemas.microsoft.com/office/drawing/2014/main" id="{92DCC326-9F3A-49BA-B0DA-149C330FC72B}"/>
+                <a16:creationId xmlns:a16="http://schemas.microsoft.com/office/drawing/2014/main" id="{2ED16CA5-A2ED-4F1A-A50B-C2FF5FE41A89}"/>
               </a:ext>
             </a:extLst>
           </p:cNvPr>
@@ -4498,7 +4498,7 @@
           <p:cNvPr id="16" name="">
             <a:extLst xmlns:a="http://schemas.openxmlformats.org/drawingml/2006/main">
               <a:ext uri="{FF2B5EF4-FFF2-40B4-BE49-F238E27FC236}">
-                <a16:creationId xmlns:a16="http://schemas.microsoft.com/office/drawing/2014/main" id="{ADF3F49E-812E-4BA3-92AF-13C37C227699}"/>
+                <a16:creationId xmlns:a16="http://schemas.microsoft.com/office/drawing/2014/main" id="{54D151FA-7381-46F8-BD01-10DDAE685CFD}"/>
               </a:ext>
             </a:extLst>
           </p:cNvPr>
@@ -4533,7 +4533,7 @@
           <p:cNvPr id="17" name="">
             <a:extLst xmlns:a="http://schemas.openxmlformats.org/drawingml/2006/main">
               <a:ext uri="{FF2B5EF4-FFF2-40B4-BE49-F238E27FC236}">
-                <a16:creationId xmlns:a16="http://schemas.microsoft.com/office/drawing/2014/main" id="{28B997F8-8C54-4719-888A-BCD09DBE3227}"/>
+                <a16:creationId xmlns:a16="http://schemas.microsoft.com/office/drawing/2014/main" id="{1CD4E033-103A-424C-A014-7AC63BB58139}"/>
               </a:ext>
             </a:extLst>
           </p:cNvPr>
@@ -4595,7 +4595,7 @@
           <p:cNvPr id="18" name="">
             <a:extLst xmlns:a="http://schemas.openxmlformats.org/drawingml/2006/main">
               <a:ext uri="{FF2B5EF4-FFF2-40B4-BE49-F238E27FC236}">
-                <a16:creationId xmlns:a16="http://schemas.microsoft.com/office/drawing/2014/main" id="{639F9329-E432-4241-A79B-ACCB211AC799}"/>
+                <a16:creationId xmlns:a16="http://schemas.microsoft.com/office/drawing/2014/main" id="{42F7B4B9-3E45-4049-B4D3-6A8D884A0300}"/>
               </a:ext>
             </a:extLst>
           </p:cNvPr>
@@ -4626,7 +4626,7 @@
           <p:cNvPr id="19" name="">
             <a:extLst xmlns:a="http://schemas.openxmlformats.org/drawingml/2006/main">
               <a:ext uri="{FF2B5EF4-FFF2-40B4-BE49-F238E27FC236}">
-                <a16:creationId xmlns:a16="http://schemas.microsoft.com/office/drawing/2014/main" id="{0D06B269-B8D2-41EB-AD1D-08B27C277AB5}"/>
+                <a16:creationId xmlns:a16="http://schemas.microsoft.com/office/drawing/2014/main" id="{B977B7A5-A5EB-43F6-A091-485C89FFF628}"/>
               </a:ext>
             </a:extLst>
           </p:cNvPr>
@@ -4688,7 +4688,7 @@
           <p:cNvPr id="20" name="">
             <a:extLst xmlns:a="http://schemas.openxmlformats.org/drawingml/2006/main">
               <a:ext uri="{FF2B5EF4-FFF2-40B4-BE49-F238E27FC236}">
-                <a16:creationId xmlns:a16="http://schemas.microsoft.com/office/drawing/2014/main" id="{DD520A43-9A8D-487F-B89F-8B57F63BBF79}"/>
+                <a16:creationId xmlns:a16="http://schemas.microsoft.com/office/drawing/2014/main" id="{4CD26FA0-C331-442D-894F-976E0F2F7D99}"/>
               </a:ext>
             </a:extLst>
           </p:cNvPr>
@@ -4748,7 +4748,7 @@
     </p:spTree>
     <p:extLst>
       <p:ext uri="{BB962C8B-B14F-4D97-AF65-F5344CB8AC3E}">
-        <p14:creationId xmlns:p14="http://schemas.microsoft.com/office/powerpoint/2010/main" val="308826420"/>
+        <p14:creationId xmlns:p14="http://schemas.microsoft.com/office/powerpoint/2010/main" val="1444805656"/>
       </p:ext>
     </p:extLst>
   </p:cSld>
@@ -4779,7 +4779,7 @@
           <p:cNvPr id="21" name="">
             <a:extLst xmlns:a="http://schemas.openxmlformats.org/drawingml/2006/main">
               <a:ext uri="{FF2B5EF4-FFF2-40B4-BE49-F238E27FC236}">
-                <a16:creationId xmlns:a16="http://schemas.microsoft.com/office/drawing/2014/main" id="{11117A0F-B540-49B2-93D2-59A9B4166132}"/>
+                <a16:creationId xmlns:a16="http://schemas.microsoft.com/office/drawing/2014/main" id="{7C1918A1-CB21-41D0-B039-4DF6783C30B0}"/>
               </a:ext>
             </a:extLst>
           </p:cNvPr>
@@ -4841,7 +4841,7 @@
                 <a:latin typeface="Arial"/>
                 <a:ea typeface="Arial"/>
                 <a:cs typeface="Arial"/>
-                <a:hlinkClick xmlns:r="http://schemas.openxmlformats.org/officeDocument/2006/relationships" r:id="Rc5082f7f8e484e55"/>
+                <a:hlinkClick xmlns:r="http://schemas.openxmlformats.org/officeDocument/2006/relationships" r:id="Re5d4b3cd6bee40be"/>
               </a:rPr>
               <a:t>https://github.com/qjmre23/Route2Zero</a:t>
             </a:r>
@@ -4864,7 +4864,7 @@
                 <a:latin typeface="Arial"/>
                 <a:ea typeface="Arial"/>
                 <a:cs typeface="Arial"/>
-                <a:hlinkClick xmlns:r="http://schemas.openxmlformats.org/officeDocument/2006/relationships" r:id="R72641b94238d4f02"/>
+                <a:hlinkClick xmlns:r="http://schemas.openxmlformats.org/officeDocument/2006/relationships" r:id="Rcb7287f14c624adf"/>
               </a:rPr>
               <a:t>https://route2zero.netlify.app/</a:t>
             </a:r>
@@ -4876,7 +4876,7 @@
           <p:cNvPr id="2" name="">
             <a:extLst xmlns:a="http://schemas.openxmlformats.org/drawingml/2006/main">
               <a:ext uri="{FF2B5EF4-FFF2-40B4-BE49-F238E27FC236}">
-                <a16:creationId xmlns:a16="http://schemas.microsoft.com/office/drawing/2014/main" id="{8824FC71-68AF-45C5-8E13-5D8AF036B30B}"/>
+                <a16:creationId xmlns:a16="http://schemas.microsoft.com/office/drawing/2014/main" id="{76385C9B-A9C6-4A43-998D-86D3DDE4AA82}"/>
               </a:ext>
             </a:extLst>
           </p:cNvPr>
@@ -4938,7 +4938,7 @@
           <p:cNvPr id="3" name="">
             <a:extLst xmlns:a="http://schemas.openxmlformats.org/drawingml/2006/main">
               <a:ext uri="{FF2B5EF4-FFF2-40B4-BE49-F238E27FC236}">
-                <a16:creationId xmlns:a16="http://schemas.microsoft.com/office/drawing/2014/main" id="{135A5A10-7374-466E-A85C-AACBD57C3C3F}"/>
+                <a16:creationId xmlns:a16="http://schemas.microsoft.com/office/drawing/2014/main" id="{302E7DB7-FF64-4B61-BED2-4362C0E5259E}"/>
               </a:ext>
             </a:extLst>
           </p:cNvPr>
@@ -5004,7 +5004,7 @@
           <p:nvPr/>
         </p:nvPicPr>
         <p:blipFill>
-          <a:blip xmlns:r="http://schemas.openxmlformats.org/officeDocument/2006/relationships" xmlns:a="http://schemas.openxmlformats.org/drawingml/2006/main" r:embed="R96d2c32fc80f47c3"/>
+          <a:blip xmlns:r="http://schemas.openxmlformats.org/officeDocument/2006/relationships" xmlns:a="http://schemas.openxmlformats.org/drawingml/2006/main" r:embed="Rb0f506f29aef49c5"/>
           <a:srcRect xmlns:a="http://schemas.openxmlformats.org/drawingml/2006/main" l="0" t="15682" r="0" b="15682"/>
           <a:stretch xmlns:a="http://schemas.openxmlformats.org/drawingml/2006/main">
             <a:fillRect l="0" t="0" r="0" b="0"/>
@@ -5027,7 +5027,7 @@
           <p:cNvPr id="5" name="">
             <a:extLst xmlns:a="http://schemas.openxmlformats.org/drawingml/2006/main">
               <a:ext uri="{FF2B5EF4-FFF2-40B4-BE49-F238E27FC236}">
-                <a16:creationId xmlns:a16="http://schemas.microsoft.com/office/drawing/2014/main" id="{0D80D135-C8CB-463D-AF87-3BDCFBA32848}"/>
+                <a16:creationId xmlns:a16="http://schemas.microsoft.com/office/drawing/2014/main" id="{879FDD42-0542-4161-A76E-1B917831A6D2}"/>
               </a:ext>
             </a:extLst>
           </p:cNvPr>
@@ -5060,7 +5060,7 @@
           <p:cNvPr id="6" name="">
             <a:extLst xmlns:a="http://schemas.openxmlformats.org/drawingml/2006/main">
               <a:ext uri="{FF2B5EF4-FFF2-40B4-BE49-F238E27FC236}">
-                <a16:creationId xmlns:a16="http://schemas.microsoft.com/office/drawing/2014/main" id="{8BB529B8-1C54-4F7E-B209-7D6AEBD3F154}"/>
+                <a16:creationId xmlns:a16="http://schemas.microsoft.com/office/drawing/2014/main" id="{5DAD85C1-E7C3-41A3-A9DE-F6CEB2D53A4D}"/>
               </a:ext>
             </a:extLst>
           </p:cNvPr>
@@ -5091,7 +5091,7 @@
           <p:cNvPr id="7" name="">
             <a:extLst xmlns:a="http://schemas.openxmlformats.org/drawingml/2006/main">
               <a:ext uri="{FF2B5EF4-FFF2-40B4-BE49-F238E27FC236}">
-                <a16:creationId xmlns:a16="http://schemas.microsoft.com/office/drawing/2014/main" id="{AE7AF0DB-099D-4F06-B019-DFB4D28570A5}"/>
+                <a16:creationId xmlns:a16="http://schemas.microsoft.com/office/drawing/2014/main" id="{FC21E089-982F-4EE8-89A2-5769C59F6358}"/>
               </a:ext>
             </a:extLst>
           </p:cNvPr>
@@ -5153,7 +5153,7 @@
           <p:cNvPr id="8" name="">
             <a:extLst xmlns:a="http://schemas.openxmlformats.org/drawingml/2006/main">
               <a:ext uri="{FF2B5EF4-FFF2-40B4-BE49-F238E27FC236}">
-                <a16:creationId xmlns:a16="http://schemas.microsoft.com/office/drawing/2014/main" id="{90CC2244-8B02-409E-BF38-CFA1E2A8A378}"/>
+                <a16:creationId xmlns:a16="http://schemas.microsoft.com/office/drawing/2014/main" id="{F7F02B0B-41F2-4706-A4AC-6BEE52E7DE7B}"/>
               </a:ext>
             </a:extLst>
           </p:cNvPr>
@@ -5188,7 +5188,7 @@
           <p:cNvPr id="9" name="">
             <a:extLst xmlns:a="http://schemas.openxmlformats.org/drawingml/2006/main">
               <a:ext uri="{FF2B5EF4-FFF2-40B4-BE49-F238E27FC236}">
-                <a16:creationId xmlns:a16="http://schemas.microsoft.com/office/drawing/2014/main" id="{77E7BF88-5023-4348-B367-C2E3877710D7}"/>
+                <a16:creationId xmlns:a16="http://schemas.microsoft.com/office/drawing/2014/main" id="{2D4171D3-3DD6-4E8F-BF4D-A5ECC17BC13D}"/>
               </a:ext>
             </a:extLst>
           </p:cNvPr>
@@ -5250,7 +5250,7 @@
           <p:cNvPr id="10" name="">
             <a:extLst xmlns:a="http://schemas.openxmlformats.org/drawingml/2006/main">
               <a:ext uri="{FF2B5EF4-FFF2-40B4-BE49-F238E27FC236}">
-                <a16:creationId xmlns:a16="http://schemas.microsoft.com/office/drawing/2014/main" id="{18C59F92-C1A6-4C16-8FE4-D0B89279C401}"/>
+                <a16:creationId xmlns:a16="http://schemas.microsoft.com/office/drawing/2014/main" id="{1B51BAD8-E7C1-426B-A3B8-88F246583105}"/>
               </a:ext>
             </a:extLst>
           </p:cNvPr>
@@ -5281,7 +5281,7 @@
           <p:cNvPr id="11" name="">
             <a:extLst xmlns:a="http://schemas.openxmlformats.org/drawingml/2006/main">
               <a:ext uri="{FF2B5EF4-FFF2-40B4-BE49-F238E27FC236}">
-                <a16:creationId xmlns:a16="http://schemas.microsoft.com/office/drawing/2014/main" id="{F55E09FC-75D6-4895-9D52-381E56425558}"/>
+                <a16:creationId xmlns:a16="http://schemas.microsoft.com/office/drawing/2014/main" id="{EA03960F-5046-4A25-B454-15C3A66BA436}"/>
               </a:ext>
             </a:extLst>
           </p:cNvPr>
@@ -5343,7 +5343,7 @@
           <p:cNvPr id="12" name="">
             <a:extLst xmlns:a="http://schemas.openxmlformats.org/drawingml/2006/main">
               <a:ext uri="{FF2B5EF4-FFF2-40B4-BE49-F238E27FC236}">
-                <a16:creationId xmlns:a16="http://schemas.microsoft.com/office/drawing/2014/main" id="{6C25E8E6-5B68-4D1D-95DE-7FC7824DA148}"/>
+                <a16:creationId xmlns:a16="http://schemas.microsoft.com/office/drawing/2014/main" id="{794D3792-416D-4944-B3CD-0C0F86E79D0C}"/>
               </a:ext>
             </a:extLst>
           </p:cNvPr>
@@ -5378,7 +5378,7 @@
           <p:cNvPr id="13" name="">
             <a:extLst xmlns:a="http://schemas.openxmlformats.org/drawingml/2006/main">
               <a:ext uri="{FF2B5EF4-FFF2-40B4-BE49-F238E27FC236}">
-                <a16:creationId xmlns:a16="http://schemas.microsoft.com/office/drawing/2014/main" id="{3B37D4E6-9BF4-4ED5-8666-79C6A0488FE9}"/>
+                <a16:creationId xmlns:a16="http://schemas.microsoft.com/office/drawing/2014/main" id="{2AD2527D-4A6B-480F-95E6-87AEBFF31751}"/>
               </a:ext>
             </a:extLst>
           </p:cNvPr>
@@ -5440,7 +5440,7 @@
           <p:cNvPr id="14" name="">
             <a:extLst xmlns:a="http://schemas.openxmlformats.org/drawingml/2006/main">
               <a:ext uri="{FF2B5EF4-FFF2-40B4-BE49-F238E27FC236}">
-                <a16:creationId xmlns:a16="http://schemas.microsoft.com/office/drawing/2014/main" id="{229A1CAD-90CD-4D44-B990-6AABE49409A9}"/>
+                <a16:creationId xmlns:a16="http://schemas.microsoft.com/office/drawing/2014/main" id="{BDA57C33-9658-4A2C-BD98-806290039D48}"/>
               </a:ext>
             </a:extLst>
           </p:cNvPr>
@@ -5471,7 +5471,7 @@
           <p:cNvPr id="15" name="">
             <a:extLst xmlns:a="http://schemas.openxmlformats.org/drawingml/2006/main">
               <a:ext uri="{FF2B5EF4-FFF2-40B4-BE49-F238E27FC236}">
-                <a16:creationId xmlns:a16="http://schemas.microsoft.com/office/drawing/2014/main" id="{35480E14-BAB9-46EC-88F0-004594528BFB}"/>
+                <a16:creationId xmlns:a16="http://schemas.microsoft.com/office/drawing/2014/main" id="{B522045C-5104-48C1-8313-313D93EA885F}"/>
               </a:ext>
             </a:extLst>
           </p:cNvPr>
@@ -5533,7 +5533,7 @@
           <p:cNvPr id="16" name="">
             <a:extLst xmlns:a="http://schemas.openxmlformats.org/drawingml/2006/main">
               <a:ext uri="{FF2B5EF4-FFF2-40B4-BE49-F238E27FC236}">
-                <a16:creationId xmlns:a16="http://schemas.microsoft.com/office/drawing/2014/main" id="{54F00CCC-BEEF-4405-8F31-D9EF869A8683}"/>
+                <a16:creationId xmlns:a16="http://schemas.microsoft.com/office/drawing/2014/main" id="{7CA246F0-C4D5-447E-85AC-CFF2F0A7AF05}"/>
               </a:ext>
             </a:extLst>
           </p:cNvPr>
@@ -5568,7 +5568,7 @@
           <p:cNvPr id="17" name="">
             <a:extLst xmlns:a="http://schemas.openxmlformats.org/drawingml/2006/main">
               <a:ext uri="{FF2B5EF4-FFF2-40B4-BE49-F238E27FC236}">
-                <a16:creationId xmlns:a16="http://schemas.microsoft.com/office/drawing/2014/main" id="{0A13BE8C-8B4F-41AA-8A02-ABC3FE378BFA}"/>
+                <a16:creationId xmlns:a16="http://schemas.microsoft.com/office/drawing/2014/main" id="{EC13F0E3-7CDC-492C-BC79-9B969AA0C922}"/>
               </a:ext>
             </a:extLst>
           </p:cNvPr>
@@ -5630,7 +5630,7 @@
           <p:cNvPr id="18" name="">
             <a:extLst xmlns:a="http://schemas.openxmlformats.org/drawingml/2006/main">
               <a:ext uri="{FF2B5EF4-FFF2-40B4-BE49-F238E27FC236}">
-                <a16:creationId xmlns:a16="http://schemas.microsoft.com/office/drawing/2014/main" id="{838FF171-6C0D-466B-9478-3024A03FCA12}"/>
+                <a16:creationId xmlns:a16="http://schemas.microsoft.com/office/drawing/2014/main" id="{5DF85B1D-C834-4102-ACB7-687A62539F4A}"/>
               </a:ext>
             </a:extLst>
           </p:cNvPr>
@@ -5661,7 +5661,7 @@
           <p:cNvPr id="19" name="">
             <a:extLst xmlns:a="http://schemas.openxmlformats.org/drawingml/2006/main">
               <a:ext uri="{FF2B5EF4-FFF2-40B4-BE49-F238E27FC236}">
-                <a16:creationId xmlns:a16="http://schemas.microsoft.com/office/drawing/2014/main" id="{6CA21A42-353F-435A-A8E5-877CF821B3CC}"/>
+                <a16:creationId xmlns:a16="http://schemas.microsoft.com/office/drawing/2014/main" id="{275D2E31-C2DF-4A5C-AF1E-F2EEE8AE7929}"/>
               </a:ext>
             </a:extLst>
           </p:cNvPr>
@@ -5723,7 +5723,7 @@
           <p:cNvPr id="20" name="">
             <a:extLst xmlns:a="http://schemas.openxmlformats.org/drawingml/2006/main">
               <a:ext uri="{FF2B5EF4-FFF2-40B4-BE49-F238E27FC236}">
-                <a16:creationId xmlns:a16="http://schemas.microsoft.com/office/drawing/2014/main" id="{E98F41DA-7C05-4130-ABB1-A70A1BDC25C6}"/>
+                <a16:creationId xmlns:a16="http://schemas.microsoft.com/office/drawing/2014/main" id="{EDB7A568-0FF4-41DE-AEB1-A9CD10AD9AA7}"/>
               </a:ext>
             </a:extLst>
           </p:cNvPr>
@@ -5783,7 +5783,7 @@
     </p:spTree>
     <p:extLst>
       <p:ext uri="{BB962C8B-B14F-4D97-AF65-F5344CB8AC3E}">
-        <p14:creationId xmlns:p14="http://schemas.microsoft.com/office/powerpoint/2010/main" val="805001017"/>
+        <p14:creationId xmlns:p14="http://schemas.microsoft.com/office/powerpoint/2010/main" val="1909276260"/>
       </p:ext>
     </p:extLst>
   </p:cSld>
@@ -5814,7 +5814,7 @@
           <p:cNvPr id="23" name="">
             <a:extLst xmlns:a="http://schemas.openxmlformats.org/drawingml/2006/main">
               <a:ext uri="{FF2B5EF4-FFF2-40B4-BE49-F238E27FC236}">
-                <a16:creationId xmlns:a16="http://schemas.microsoft.com/office/drawing/2014/main" id="{14EEC3A9-36D6-4526-8CBC-C307C0371AE3}"/>
+                <a16:creationId xmlns:a16="http://schemas.microsoft.com/office/drawing/2014/main" id="{1EBBAFA9-6FC2-4629-B578-F36F3D162D83}"/>
               </a:ext>
             </a:extLst>
           </p:cNvPr>
@@ -5876,7 +5876,7 @@
                 <a:latin typeface="Arial"/>
                 <a:ea typeface="Arial"/>
                 <a:cs typeface="Arial"/>
-                <a:hlinkClick xmlns:r="http://schemas.openxmlformats.org/officeDocument/2006/relationships" r:id="Rb71933e77e424ef5"/>
+                <a:hlinkClick xmlns:r="http://schemas.openxmlformats.org/officeDocument/2006/relationships" r:id="Re51fad9adb11444a"/>
               </a:rPr>
               <a:t>https://github.com/qjmre23/Route2Zero</a:t>
             </a:r>
@@ -5899,7 +5899,7 @@
                 <a:latin typeface="Arial"/>
                 <a:ea typeface="Arial"/>
                 <a:cs typeface="Arial"/>
-                <a:hlinkClick xmlns:r="http://schemas.openxmlformats.org/officeDocument/2006/relationships" r:id="R6e437e12bde547b7"/>
+                <a:hlinkClick xmlns:r="http://schemas.openxmlformats.org/officeDocument/2006/relationships" r:id="R36f4ac39f11b4286"/>
               </a:rPr>
               <a:t>https://route2zero.netlify.app/</a:t>
             </a:r>
@@ -5911,7 +5911,7 @@
           <p:cNvPr id="2" name="">
             <a:extLst xmlns:a="http://schemas.openxmlformats.org/drawingml/2006/main">
               <a:ext uri="{FF2B5EF4-FFF2-40B4-BE49-F238E27FC236}">
-                <a16:creationId xmlns:a16="http://schemas.microsoft.com/office/drawing/2014/main" id="{681107B5-D7E0-482D-B89F-DCEFF364CE15}"/>
+                <a16:creationId xmlns:a16="http://schemas.microsoft.com/office/drawing/2014/main" id="{E4CCEA86-2594-47B6-9C54-B98C3E4D55A2}"/>
               </a:ext>
             </a:extLst>
           </p:cNvPr>
@@ -5973,7 +5973,7 @@
           <p:cNvPr id="3" name="">
             <a:extLst xmlns:a="http://schemas.openxmlformats.org/drawingml/2006/main">
               <a:ext uri="{FF2B5EF4-FFF2-40B4-BE49-F238E27FC236}">
-                <a16:creationId xmlns:a16="http://schemas.microsoft.com/office/drawing/2014/main" id="{91365181-190E-489E-B18A-7A0FF8492225}"/>
+                <a16:creationId xmlns:a16="http://schemas.microsoft.com/office/drawing/2014/main" id="{146FBFBB-F268-48B8-95B1-48B4AD8CDE4A}"/>
               </a:ext>
             </a:extLst>
           </p:cNvPr>
@@ -6039,7 +6039,7 @@
           <p:nvPr/>
         </p:nvPicPr>
         <p:blipFill>
-          <a:blip xmlns:r="http://schemas.openxmlformats.org/officeDocument/2006/relationships" xmlns:a="http://schemas.openxmlformats.org/drawingml/2006/main" r:embed="Raff5f06faacf4160"/>
+          <a:blip xmlns:r="http://schemas.openxmlformats.org/officeDocument/2006/relationships" xmlns:a="http://schemas.openxmlformats.org/drawingml/2006/main" r:embed="Rc20ae86debe046b3"/>
           <a:srcRect xmlns:a="http://schemas.openxmlformats.org/drawingml/2006/main" l="4619" t="0" r="4619" b="0"/>
           <a:stretch xmlns:a="http://schemas.openxmlformats.org/drawingml/2006/main">
             <a:fillRect l="0" t="0" r="0" b="0"/>
@@ -6062,7 +6062,7 @@
           <p:cNvPr id="5" name="">
             <a:extLst xmlns:a="http://schemas.openxmlformats.org/drawingml/2006/main">
               <a:ext uri="{FF2B5EF4-FFF2-40B4-BE49-F238E27FC236}">
-                <a16:creationId xmlns:a16="http://schemas.microsoft.com/office/drawing/2014/main" id="{4A3EEC4F-797C-4AB9-8E88-C5957945E547}"/>
+                <a16:creationId xmlns:a16="http://schemas.microsoft.com/office/drawing/2014/main" id="{9020F6CC-6512-485E-BDAD-D7CDE82105D2}"/>
               </a:ext>
             </a:extLst>
           </p:cNvPr>
@@ -6095,7 +6095,7 @@
           <p:cNvPr id="6" name="">
             <a:extLst xmlns:a="http://schemas.openxmlformats.org/drawingml/2006/main">
               <a:ext uri="{FF2B5EF4-FFF2-40B4-BE49-F238E27FC236}">
-                <a16:creationId xmlns:a16="http://schemas.microsoft.com/office/drawing/2014/main" id="{65AD7348-9E6E-49D2-BBF4-BC4EA47963C0}"/>
+                <a16:creationId xmlns:a16="http://schemas.microsoft.com/office/drawing/2014/main" id="{F11469EE-B667-47CF-BA13-F82095651DF6}"/>
               </a:ext>
             </a:extLst>
           </p:cNvPr>
@@ -6157,7 +6157,7 @@
           <p:cNvPr id="7" name="">
             <a:extLst xmlns:a="http://schemas.openxmlformats.org/drawingml/2006/main">
               <a:ext uri="{FF2B5EF4-FFF2-40B4-BE49-F238E27FC236}">
-                <a16:creationId xmlns:a16="http://schemas.microsoft.com/office/drawing/2014/main" id="{D4DFDF8F-DD5A-41E8-91F9-BDC669168722}"/>
+                <a16:creationId xmlns:a16="http://schemas.microsoft.com/office/drawing/2014/main" id="{E1B41532-2C4F-4ADC-8D45-4AD10AAD3EFB}"/>
               </a:ext>
             </a:extLst>
           </p:cNvPr>
@@ -6219,7 +6219,7 @@
           <p:cNvPr id="8" name="">
             <a:extLst xmlns:a="http://schemas.openxmlformats.org/drawingml/2006/main">
               <a:ext uri="{FF2B5EF4-FFF2-40B4-BE49-F238E27FC236}">
-                <a16:creationId xmlns:a16="http://schemas.microsoft.com/office/drawing/2014/main" id="{ADC09B4E-C18A-4D01-ACB1-E4B2AE235957}"/>
+                <a16:creationId xmlns:a16="http://schemas.microsoft.com/office/drawing/2014/main" id="{E7E2CDE1-EBF6-4657-9D37-3AAA8F4F5C2F}"/>
               </a:ext>
             </a:extLst>
           </p:cNvPr>
@@ -6281,7 +6281,7 @@
           <p:cNvPr id="9" name="">
             <a:extLst xmlns:a="http://schemas.openxmlformats.org/drawingml/2006/main">
               <a:ext uri="{FF2B5EF4-FFF2-40B4-BE49-F238E27FC236}">
-                <a16:creationId xmlns:a16="http://schemas.microsoft.com/office/drawing/2014/main" id="{34786B19-14D6-4301-B005-A5A488F04BB4}"/>
+                <a16:creationId xmlns:a16="http://schemas.microsoft.com/office/drawing/2014/main" id="{AEA04618-B5BC-44DB-9B1A-4C5A92730EC6}"/>
               </a:ext>
             </a:extLst>
           </p:cNvPr>
@@ -6343,7 +6343,7 @@
           <p:cNvPr id="10" name="">
             <a:extLst xmlns:a="http://schemas.openxmlformats.org/drawingml/2006/main">
               <a:ext uri="{FF2B5EF4-FFF2-40B4-BE49-F238E27FC236}">
-                <a16:creationId xmlns:a16="http://schemas.microsoft.com/office/drawing/2014/main" id="{4C283E31-5182-474C-8F50-91EB59E2D213}"/>
+                <a16:creationId xmlns:a16="http://schemas.microsoft.com/office/drawing/2014/main" id="{5B030BD2-DCD2-4A12-B1CF-BC9F585B794C}"/>
               </a:ext>
             </a:extLst>
           </p:cNvPr>
@@ -6405,7 +6405,7 @@
           <p:cNvPr id="11" name="">
             <a:extLst xmlns:a="http://schemas.openxmlformats.org/drawingml/2006/main">
               <a:ext uri="{FF2B5EF4-FFF2-40B4-BE49-F238E27FC236}">
-                <a16:creationId xmlns:a16="http://schemas.microsoft.com/office/drawing/2014/main" id="{615E614E-833E-41AF-BD55-56F1495530ED}"/>
+                <a16:creationId xmlns:a16="http://schemas.microsoft.com/office/drawing/2014/main" id="{484FB4F8-8063-4FF2-878D-0296849014B6}"/>
               </a:ext>
             </a:extLst>
           </p:cNvPr>
@@ -6440,7 +6440,7 @@
           <p:cNvPr id="12" name="">
             <a:extLst xmlns:a="http://schemas.openxmlformats.org/drawingml/2006/main">
               <a:ext uri="{FF2B5EF4-FFF2-40B4-BE49-F238E27FC236}">
-                <a16:creationId xmlns:a16="http://schemas.microsoft.com/office/drawing/2014/main" id="{F2930A52-DA94-41FE-A0A8-F8009D45E6A5}"/>
+                <a16:creationId xmlns:a16="http://schemas.microsoft.com/office/drawing/2014/main" id="{9AB9F963-36CA-42F6-BD60-0EBBFF972EEE}"/>
               </a:ext>
             </a:extLst>
           </p:cNvPr>
@@ -6502,7 +6502,7 @@
           <p:cNvPr id="13" name="">
             <a:extLst xmlns:a="http://schemas.openxmlformats.org/drawingml/2006/main">
               <a:ext uri="{FF2B5EF4-FFF2-40B4-BE49-F238E27FC236}">
-                <a16:creationId xmlns:a16="http://schemas.microsoft.com/office/drawing/2014/main" id="{3CA30152-CE86-4CC1-93A6-6FD30DEBFBE3}"/>
+                <a16:creationId xmlns:a16="http://schemas.microsoft.com/office/drawing/2014/main" id="{C38F641D-F2EF-4693-9038-16153DB126A5}"/>
               </a:ext>
             </a:extLst>
           </p:cNvPr>
@@ -6564,7 +6564,7 @@
           <p:cNvPr id="14" name="">
             <a:extLst xmlns:a="http://schemas.openxmlformats.org/drawingml/2006/main">
               <a:ext uri="{FF2B5EF4-FFF2-40B4-BE49-F238E27FC236}">
-                <a16:creationId xmlns:a16="http://schemas.microsoft.com/office/drawing/2014/main" id="{2E460FCE-5BDC-46FB-86DA-47F036F3EA90}"/>
+                <a16:creationId xmlns:a16="http://schemas.microsoft.com/office/drawing/2014/main" id="{7895D338-F5C2-4A54-AF80-C62766A1E85F}"/>
               </a:ext>
             </a:extLst>
           </p:cNvPr>
@@ -6626,7 +6626,7 @@
           <p:cNvPr id="15" name="">
             <a:extLst xmlns:a="http://schemas.openxmlformats.org/drawingml/2006/main">
               <a:ext uri="{FF2B5EF4-FFF2-40B4-BE49-F238E27FC236}">
-                <a16:creationId xmlns:a16="http://schemas.microsoft.com/office/drawing/2014/main" id="{2D797D02-1C8A-4347-A110-2A643F5938A1}"/>
+                <a16:creationId xmlns:a16="http://schemas.microsoft.com/office/drawing/2014/main" id="{1FC18D80-B837-4DA3-ACA5-AA82D3FE1BA4}"/>
               </a:ext>
             </a:extLst>
           </p:cNvPr>
@@ -6688,7 +6688,7 @@
           <p:cNvPr id="16" name="">
             <a:extLst xmlns:a="http://schemas.openxmlformats.org/drawingml/2006/main">
               <a:ext uri="{FF2B5EF4-FFF2-40B4-BE49-F238E27FC236}">
-                <a16:creationId xmlns:a16="http://schemas.microsoft.com/office/drawing/2014/main" id="{A18A43C3-71AE-4861-B298-30D0F5D6DCE5}"/>
+                <a16:creationId xmlns:a16="http://schemas.microsoft.com/office/drawing/2014/main" id="{87D21296-45F1-4921-9D49-D17CE64B1A95}"/>
               </a:ext>
             </a:extLst>
           </p:cNvPr>
@@ -6750,7 +6750,7 @@
           <p:cNvPr id="17" name="">
             <a:extLst xmlns:a="http://schemas.openxmlformats.org/drawingml/2006/main">
               <a:ext uri="{FF2B5EF4-FFF2-40B4-BE49-F238E27FC236}">
-                <a16:creationId xmlns:a16="http://schemas.microsoft.com/office/drawing/2014/main" id="{355B986C-7D18-405B-BA7B-D5B67E092C24}"/>
+                <a16:creationId xmlns:a16="http://schemas.microsoft.com/office/drawing/2014/main" id="{CB003029-4F44-438A-8894-2156829A749A}"/>
               </a:ext>
             </a:extLst>
           </p:cNvPr>
@@ -6812,7 +6812,7 @@
           <p:cNvPr id="18" name="">
             <a:extLst xmlns:a="http://schemas.openxmlformats.org/drawingml/2006/main">
               <a:ext uri="{FF2B5EF4-FFF2-40B4-BE49-F238E27FC236}">
-                <a16:creationId xmlns:a16="http://schemas.microsoft.com/office/drawing/2014/main" id="{770F5844-D65B-42E1-9C2E-5C710DEE5AB7}"/>
+                <a16:creationId xmlns:a16="http://schemas.microsoft.com/office/drawing/2014/main" id="{BC358DD7-572D-4DEA-ACE1-C805863C6A04}"/>
               </a:ext>
             </a:extLst>
           </p:cNvPr>
@@ -6847,7 +6847,7 @@
           <p:cNvPr id="19" name="">
             <a:extLst xmlns:a="http://schemas.openxmlformats.org/drawingml/2006/main">
               <a:ext uri="{FF2B5EF4-FFF2-40B4-BE49-F238E27FC236}">
-                <a16:creationId xmlns:a16="http://schemas.microsoft.com/office/drawing/2014/main" id="{5F9B8435-36E9-4237-AA47-F4914A736CEA}"/>
+                <a16:creationId xmlns:a16="http://schemas.microsoft.com/office/drawing/2014/main" id="{B8EC8AC7-BE74-4C16-9D75-8E60E96EF5B1}"/>
               </a:ext>
             </a:extLst>
           </p:cNvPr>
@@ -6909,7 +6909,7 @@
           <p:cNvPr id="20" name="">
             <a:extLst xmlns:a="http://schemas.openxmlformats.org/drawingml/2006/main">
               <a:ext uri="{FF2B5EF4-FFF2-40B4-BE49-F238E27FC236}">
-                <a16:creationId xmlns:a16="http://schemas.microsoft.com/office/drawing/2014/main" id="{6D660200-4156-4045-A217-7F0D81170EC6}"/>
+                <a16:creationId xmlns:a16="http://schemas.microsoft.com/office/drawing/2014/main" id="{A4F6E03B-DB8E-4F98-B6B4-309712CA93FF}"/>
               </a:ext>
             </a:extLst>
           </p:cNvPr>
@@ -6940,7 +6940,7 @@
           <p:cNvPr id="21" name="">
             <a:extLst xmlns:a="http://schemas.openxmlformats.org/drawingml/2006/main">
               <a:ext uri="{FF2B5EF4-FFF2-40B4-BE49-F238E27FC236}">
-                <a16:creationId xmlns:a16="http://schemas.microsoft.com/office/drawing/2014/main" id="{E7139446-0394-44E1-939F-0B37A53FF924}"/>
+                <a16:creationId xmlns:a16="http://schemas.microsoft.com/office/drawing/2014/main" id="{61A78734-7B67-46D3-9F2F-F3ECDED4E4CA}"/>
               </a:ext>
             </a:extLst>
           </p:cNvPr>
@@ -7002,7 +7002,7 @@
           <p:cNvPr id="22" name="">
             <a:extLst xmlns:a="http://schemas.openxmlformats.org/drawingml/2006/main">
               <a:ext uri="{FF2B5EF4-FFF2-40B4-BE49-F238E27FC236}">
-                <a16:creationId xmlns:a16="http://schemas.microsoft.com/office/drawing/2014/main" id="{B0CDE31F-1A4A-4303-AACF-21455B00DCD1}"/>
+                <a16:creationId xmlns:a16="http://schemas.microsoft.com/office/drawing/2014/main" id="{D837D9F5-BB73-453B-ADD1-9C49F19A317D}"/>
               </a:ext>
             </a:extLst>
           </p:cNvPr>
@@ -7062,7 +7062,7 @@
     </p:spTree>
     <p:extLst>
       <p:ext uri="{BB962C8B-B14F-4D97-AF65-F5344CB8AC3E}">
-        <p14:creationId xmlns:p14="http://schemas.microsoft.com/office/powerpoint/2010/main" val="1120414718"/>
+        <p14:creationId xmlns:p14="http://schemas.microsoft.com/office/powerpoint/2010/main" val="285006190"/>
       </p:ext>
     </p:extLst>
   </p:cSld>
@@ -7093,7 +7093,7 @@
           <p:cNvPr id="21" name="">
             <a:extLst xmlns:a="http://schemas.openxmlformats.org/drawingml/2006/main">
               <a:ext uri="{FF2B5EF4-FFF2-40B4-BE49-F238E27FC236}">
-                <a16:creationId xmlns:a16="http://schemas.microsoft.com/office/drawing/2014/main" id="{48259CBD-08E9-4290-8691-4C2A130CCB32}"/>
+                <a16:creationId xmlns:a16="http://schemas.microsoft.com/office/drawing/2014/main" id="{CA42BE52-29BC-48C7-B6BD-DFA64F587F68}"/>
               </a:ext>
             </a:extLst>
           </p:cNvPr>
@@ -7155,7 +7155,7 @@
                 <a:latin typeface="Arial"/>
                 <a:ea typeface="Arial"/>
                 <a:cs typeface="Arial"/>
-                <a:hlinkClick xmlns:r="http://schemas.openxmlformats.org/officeDocument/2006/relationships" r:id="Ra5553416c2de4239"/>
+                <a:hlinkClick xmlns:r="http://schemas.openxmlformats.org/officeDocument/2006/relationships" r:id="R2ddd3db6770f438e"/>
               </a:rPr>
               <a:t>https://github.com/qjmre23/Route2Zero</a:t>
             </a:r>
@@ -7178,7 +7178,7 @@
                 <a:latin typeface="Arial"/>
                 <a:ea typeface="Arial"/>
                 <a:cs typeface="Arial"/>
-                <a:hlinkClick xmlns:r="http://schemas.openxmlformats.org/officeDocument/2006/relationships" r:id="R672278ac31cb4c67"/>
+                <a:hlinkClick xmlns:r="http://schemas.openxmlformats.org/officeDocument/2006/relationships" r:id="R2b9d461bd7b7496b"/>
               </a:rPr>
               <a:t>https://route2zero.netlify.app/</a:t>
             </a:r>
@@ -7190,7 +7190,7 @@
           <p:cNvPr id="2" name="">
             <a:extLst xmlns:a="http://schemas.openxmlformats.org/drawingml/2006/main">
               <a:ext uri="{FF2B5EF4-FFF2-40B4-BE49-F238E27FC236}">
-                <a16:creationId xmlns:a16="http://schemas.microsoft.com/office/drawing/2014/main" id="{F762F23E-D754-4DA0-88E9-58C90ED83CB5}"/>
+                <a16:creationId xmlns:a16="http://schemas.microsoft.com/office/drawing/2014/main" id="{BE3D89EE-65D0-4489-93D3-D349E28809A3}"/>
               </a:ext>
             </a:extLst>
           </p:cNvPr>
@@ -7252,7 +7252,7 @@
           <p:cNvPr id="3" name="">
             <a:extLst xmlns:a="http://schemas.openxmlformats.org/drawingml/2006/main">
               <a:ext uri="{FF2B5EF4-FFF2-40B4-BE49-F238E27FC236}">
-                <a16:creationId xmlns:a16="http://schemas.microsoft.com/office/drawing/2014/main" id="{FAA8C0CA-EF99-4E69-BE6C-77659D83EB6B}"/>
+                <a16:creationId xmlns:a16="http://schemas.microsoft.com/office/drawing/2014/main" id="{F93D7AD9-E156-464C-8405-BEBC28725300}"/>
               </a:ext>
             </a:extLst>
           </p:cNvPr>
@@ -7318,7 +7318,7 @@
           <p:nvPr/>
         </p:nvPicPr>
         <p:blipFill>
-          <a:blip xmlns:r="http://schemas.openxmlformats.org/officeDocument/2006/relationships" xmlns:a="http://schemas.openxmlformats.org/drawingml/2006/main" r:embed="R2c0e20d81f0341d7"/>
+          <a:blip xmlns:r="http://schemas.openxmlformats.org/officeDocument/2006/relationships" xmlns:a="http://schemas.openxmlformats.org/drawingml/2006/main" r:embed="Re68edb04560449fa"/>
           <a:srcRect xmlns:a="http://schemas.openxmlformats.org/drawingml/2006/main" l="0" t="15682" r="0" b="15682"/>
           <a:stretch xmlns:a="http://schemas.openxmlformats.org/drawingml/2006/main">
             <a:fillRect l="0" t="0" r="0" b="0"/>
@@ -7341,7 +7341,7 @@
           <p:cNvPr id="5" name="">
             <a:extLst xmlns:a="http://schemas.openxmlformats.org/drawingml/2006/main">
               <a:ext uri="{FF2B5EF4-FFF2-40B4-BE49-F238E27FC236}">
-                <a16:creationId xmlns:a16="http://schemas.microsoft.com/office/drawing/2014/main" id="{70B6CD51-D89A-4D47-AA2A-DC5E0CA37ACE}"/>
+                <a16:creationId xmlns:a16="http://schemas.microsoft.com/office/drawing/2014/main" id="{C86CBAD2-BD72-4D04-B20C-1C6BD3FFAC75}"/>
               </a:ext>
             </a:extLst>
           </p:cNvPr>
@@ -7374,7 +7374,7 @@
           <p:cNvPr id="6" name="">
             <a:extLst xmlns:a="http://schemas.openxmlformats.org/drawingml/2006/main">
               <a:ext uri="{FF2B5EF4-FFF2-40B4-BE49-F238E27FC236}">
-                <a16:creationId xmlns:a16="http://schemas.microsoft.com/office/drawing/2014/main" id="{A42B41FE-26DF-4B35-B5D0-462EE8B56C20}"/>
+                <a16:creationId xmlns:a16="http://schemas.microsoft.com/office/drawing/2014/main" id="{B1E8D807-F8F2-4D52-9F67-1A44321FA806}"/>
               </a:ext>
             </a:extLst>
           </p:cNvPr>
@@ -7405,7 +7405,7 @@
           <p:cNvPr id="7" name="">
             <a:extLst xmlns:a="http://schemas.openxmlformats.org/drawingml/2006/main">
               <a:ext uri="{FF2B5EF4-FFF2-40B4-BE49-F238E27FC236}">
-                <a16:creationId xmlns:a16="http://schemas.microsoft.com/office/drawing/2014/main" id="{991336F3-4044-47F4-90A4-BC16649389D6}"/>
+                <a16:creationId xmlns:a16="http://schemas.microsoft.com/office/drawing/2014/main" id="{0B48EB8A-9D8C-4529-B075-B0B1F40A7996}"/>
               </a:ext>
             </a:extLst>
           </p:cNvPr>
@@ -7467,7 +7467,7 @@
           <p:cNvPr id="8" name="">
             <a:extLst xmlns:a="http://schemas.openxmlformats.org/drawingml/2006/main">
               <a:ext uri="{FF2B5EF4-FFF2-40B4-BE49-F238E27FC236}">
-                <a16:creationId xmlns:a16="http://schemas.microsoft.com/office/drawing/2014/main" id="{60F947D7-AD78-499D-85D4-3C79480C949E}"/>
+                <a16:creationId xmlns:a16="http://schemas.microsoft.com/office/drawing/2014/main" id="{31426C01-8EDF-4B22-B14F-3483C019FFEE}"/>
               </a:ext>
             </a:extLst>
           </p:cNvPr>
@@ -7502,7 +7502,7 @@
           <p:cNvPr id="9" name="">
             <a:extLst xmlns:a="http://schemas.openxmlformats.org/drawingml/2006/main">
               <a:ext uri="{FF2B5EF4-FFF2-40B4-BE49-F238E27FC236}">
-                <a16:creationId xmlns:a16="http://schemas.microsoft.com/office/drawing/2014/main" id="{39CBCCD3-9B8C-4BC6-9E16-CC51F4C1E5FC}"/>
+                <a16:creationId xmlns:a16="http://schemas.microsoft.com/office/drawing/2014/main" id="{C801E70E-71E7-47DB-A092-8D2F29E83971}"/>
               </a:ext>
             </a:extLst>
           </p:cNvPr>
@@ -7564,7 +7564,7 @@
           <p:cNvPr id="10" name="">
             <a:extLst xmlns:a="http://schemas.openxmlformats.org/drawingml/2006/main">
               <a:ext uri="{FF2B5EF4-FFF2-40B4-BE49-F238E27FC236}">
-                <a16:creationId xmlns:a16="http://schemas.microsoft.com/office/drawing/2014/main" id="{8343A782-9FFD-47FE-9D12-2398830B5DAB}"/>
+                <a16:creationId xmlns:a16="http://schemas.microsoft.com/office/drawing/2014/main" id="{FF61BDE3-8AC9-4A06-89E2-6357B59762AF}"/>
               </a:ext>
             </a:extLst>
           </p:cNvPr>
@@ -7595,7 +7595,7 @@
           <p:cNvPr id="11" name="">
             <a:extLst xmlns:a="http://schemas.openxmlformats.org/drawingml/2006/main">
               <a:ext uri="{FF2B5EF4-FFF2-40B4-BE49-F238E27FC236}">
-                <a16:creationId xmlns:a16="http://schemas.microsoft.com/office/drawing/2014/main" id="{92659B9E-23EA-4F39-92EC-2ACD022040BC}"/>
+                <a16:creationId xmlns:a16="http://schemas.microsoft.com/office/drawing/2014/main" id="{757B56F0-2924-45FB-A125-DEFFAEE1C66E}"/>
               </a:ext>
             </a:extLst>
           </p:cNvPr>
@@ -7657,7 +7657,7 @@
           <p:cNvPr id="12" name="">
             <a:extLst xmlns:a="http://schemas.openxmlformats.org/drawingml/2006/main">
               <a:ext uri="{FF2B5EF4-FFF2-40B4-BE49-F238E27FC236}">
-                <a16:creationId xmlns:a16="http://schemas.microsoft.com/office/drawing/2014/main" id="{68EED8E7-A397-4553-A917-C142046DD53D}"/>
+                <a16:creationId xmlns:a16="http://schemas.microsoft.com/office/drawing/2014/main" id="{DD96BB99-C2A8-4FE3-B08F-56C91B2A8D7D}"/>
               </a:ext>
             </a:extLst>
           </p:cNvPr>
@@ -7692,7 +7692,7 @@
           <p:cNvPr id="13" name="">
             <a:extLst xmlns:a="http://schemas.openxmlformats.org/drawingml/2006/main">
               <a:ext uri="{FF2B5EF4-FFF2-40B4-BE49-F238E27FC236}">
-                <a16:creationId xmlns:a16="http://schemas.microsoft.com/office/drawing/2014/main" id="{655E0059-FBF3-4410-B2DA-72A5CA3E3752}"/>
+                <a16:creationId xmlns:a16="http://schemas.microsoft.com/office/drawing/2014/main" id="{46F97CB6-0CB2-490E-921B-4FD90156FFAE}"/>
               </a:ext>
             </a:extLst>
           </p:cNvPr>
@@ -7754,7 +7754,7 @@
           <p:cNvPr id="14" name="">
             <a:extLst xmlns:a="http://schemas.openxmlformats.org/drawingml/2006/main">
               <a:ext uri="{FF2B5EF4-FFF2-40B4-BE49-F238E27FC236}">
-                <a16:creationId xmlns:a16="http://schemas.microsoft.com/office/drawing/2014/main" id="{A2BCB441-064F-415F-8277-0BC0ED55F6DF}"/>
+                <a16:creationId xmlns:a16="http://schemas.microsoft.com/office/drawing/2014/main" id="{EBCFC923-14FD-4D3A-BF80-153000AFEE2F}"/>
               </a:ext>
             </a:extLst>
           </p:cNvPr>
@@ -7785,7 +7785,7 @@
           <p:cNvPr id="15" name="">
             <a:extLst xmlns:a="http://schemas.openxmlformats.org/drawingml/2006/main">
               <a:ext uri="{FF2B5EF4-FFF2-40B4-BE49-F238E27FC236}">
-                <a16:creationId xmlns:a16="http://schemas.microsoft.com/office/drawing/2014/main" id="{11978923-2961-4EF3-A2A4-99B8E5533C7A}"/>
+                <a16:creationId xmlns:a16="http://schemas.microsoft.com/office/drawing/2014/main" id="{4FAD98E8-DAA1-4DD6-BDDD-C35CD1EDBF8A}"/>
               </a:ext>
             </a:extLst>
           </p:cNvPr>
@@ -7847,7 +7847,7 @@
           <p:cNvPr id="16" name="">
             <a:extLst xmlns:a="http://schemas.openxmlformats.org/drawingml/2006/main">
               <a:ext uri="{FF2B5EF4-FFF2-40B4-BE49-F238E27FC236}">
-                <a16:creationId xmlns:a16="http://schemas.microsoft.com/office/drawing/2014/main" id="{7BFE6790-619F-4A45-A90E-869C7F0349BD}"/>
+                <a16:creationId xmlns:a16="http://schemas.microsoft.com/office/drawing/2014/main" id="{42B79B89-CFBC-47F2-8E7B-ADB4839FC518}"/>
               </a:ext>
             </a:extLst>
           </p:cNvPr>
@@ -7882,7 +7882,7 @@
           <p:cNvPr id="17" name="">
             <a:extLst xmlns:a="http://schemas.openxmlformats.org/drawingml/2006/main">
               <a:ext uri="{FF2B5EF4-FFF2-40B4-BE49-F238E27FC236}">
-                <a16:creationId xmlns:a16="http://schemas.microsoft.com/office/drawing/2014/main" id="{6D5B0E49-B4DA-4A42-B5DF-0801AC730A07}"/>
+                <a16:creationId xmlns:a16="http://schemas.microsoft.com/office/drawing/2014/main" id="{2EFEFE13-6D6A-4BAA-9440-47F08AD60074}"/>
               </a:ext>
             </a:extLst>
           </p:cNvPr>
@@ -7944,7 +7944,7 @@
           <p:cNvPr id="18" name="">
             <a:extLst xmlns:a="http://schemas.openxmlformats.org/drawingml/2006/main">
               <a:ext uri="{FF2B5EF4-FFF2-40B4-BE49-F238E27FC236}">
-                <a16:creationId xmlns:a16="http://schemas.microsoft.com/office/drawing/2014/main" id="{0ED0F858-6EB2-4C7D-9743-58EAB3153452}"/>
+                <a16:creationId xmlns:a16="http://schemas.microsoft.com/office/drawing/2014/main" id="{3C683528-5264-45A0-9525-D09794E50618}"/>
               </a:ext>
             </a:extLst>
           </p:cNvPr>
@@ -7975,7 +7975,7 @@
           <p:cNvPr id="19" name="">
             <a:extLst xmlns:a="http://schemas.openxmlformats.org/drawingml/2006/main">
               <a:ext uri="{FF2B5EF4-FFF2-40B4-BE49-F238E27FC236}">
-                <a16:creationId xmlns:a16="http://schemas.microsoft.com/office/drawing/2014/main" id="{BB09A3EE-D4F4-45DE-B2EB-B89B1F563D36}"/>
+                <a16:creationId xmlns:a16="http://schemas.microsoft.com/office/drawing/2014/main" id="{645956D2-690F-440B-B7E8-A23675B86B46}"/>
               </a:ext>
             </a:extLst>
           </p:cNvPr>
@@ -8037,7 +8037,7 @@
           <p:cNvPr id="20" name="">
             <a:extLst xmlns:a="http://schemas.openxmlformats.org/drawingml/2006/main">
               <a:ext uri="{FF2B5EF4-FFF2-40B4-BE49-F238E27FC236}">
-                <a16:creationId xmlns:a16="http://schemas.microsoft.com/office/drawing/2014/main" id="{88B894F9-FED2-4A06-8F91-247215691677}"/>
+                <a16:creationId xmlns:a16="http://schemas.microsoft.com/office/drawing/2014/main" id="{8A7E2785-EE9A-45AD-B156-83FFBCFE8AF6}"/>
               </a:ext>
             </a:extLst>
           </p:cNvPr>
@@ -8097,7 +8097,7 @@
     </p:spTree>
     <p:extLst>
       <p:ext uri="{BB962C8B-B14F-4D97-AF65-F5344CB8AC3E}">
-        <p14:creationId xmlns:p14="http://schemas.microsoft.com/office/powerpoint/2010/main" val="153512392"/>
+        <p14:creationId xmlns:p14="http://schemas.microsoft.com/office/powerpoint/2010/main" val="1355343971"/>
       </p:ext>
     </p:extLst>
   </p:cSld>
@@ -8128,7 +8128,7 @@
           <p:cNvPr id="21" name="">
             <a:extLst xmlns:a="http://schemas.openxmlformats.org/drawingml/2006/main">
               <a:ext uri="{FF2B5EF4-FFF2-40B4-BE49-F238E27FC236}">
-                <a16:creationId xmlns:a16="http://schemas.microsoft.com/office/drawing/2014/main" id="{39DDAE7F-02CA-467B-9BF6-F1C54E1430EB}"/>
+                <a16:creationId xmlns:a16="http://schemas.microsoft.com/office/drawing/2014/main" id="{39D17051-3B02-4BAE-890B-5D9CF4FBFF44}"/>
               </a:ext>
             </a:extLst>
           </p:cNvPr>
@@ -8190,7 +8190,7 @@
                 <a:latin typeface="Arial"/>
                 <a:ea typeface="Arial"/>
                 <a:cs typeface="Arial"/>
-                <a:hlinkClick xmlns:r="http://schemas.openxmlformats.org/officeDocument/2006/relationships" r:id="Rbfc81434e068450c"/>
+                <a:hlinkClick xmlns:r="http://schemas.openxmlformats.org/officeDocument/2006/relationships" r:id="R4080e14999d34150"/>
               </a:rPr>
               <a:t>https://github.com/qjmre23/Route2Zero</a:t>
             </a:r>
@@ -8213,7 +8213,7 @@
                 <a:latin typeface="Arial"/>
                 <a:ea typeface="Arial"/>
                 <a:cs typeface="Arial"/>
-                <a:hlinkClick xmlns:r="http://schemas.openxmlformats.org/officeDocument/2006/relationships" r:id="R48a252a755e34df6"/>
+                <a:hlinkClick xmlns:r="http://schemas.openxmlformats.org/officeDocument/2006/relationships" r:id="R037350c161b44e59"/>
               </a:rPr>
               <a:t>https://route2zero.netlify.app/</a:t>
             </a:r>
@@ -8225,7 +8225,7 @@
           <p:cNvPr id="2" name="">
             <a:extLst xmlns:a="http://schemas.openxmlformats.org/drawingml/2006/main">
               <a:ext uri="{FF2B5EF4-FFF2-40B4-BE49-F238E27FC236}">
-                <a16:creationId xmlns:a16="http://schemas.microsoft.com/office/drawing/2014/main" id="{52C3187A-9E1C-4E4D-9AC5-CA12DF5018BE}"/>
+                <a16:creationId xmlns:a16="http://schemas.microsoft.com/office/drawing/2014/main" id="{774905F7-8DCB-4998-B649-E1FB47BB1127}"/>
               </a:ext>
             </a:extLst>
           </p:cNvPr>
@@ -8287,7 +8287,7 @@
           <p:cNvPr id="3" name="">
             <a:extLst xmlns:a="http://schemas.openxmlformats.org/drawingml/2006/main">
               <a:ext uri="{FF2B5EF4-FFF2-40B4-BE49-F238E27FC236}">
-                <a16:creationId xmlns:a16="http://schemas.microsoft.com/office/drawing/2014/main" id="{8D08A143-0E4E-460F-9D70-B4AD84990AEF}"/>
+                <a16:creationId xmlns:a16="http://schemas.microsoft.com/office/drawing/2014/main" id="{34BACBB2-903D-4CF4-B938-4851CCB2F5CF}"/>
               </a:ext>
             </a:extLst>
           </p:cNvPr>
@@ -8353,7 +8353,7 @@
           <p:nvPr/>
         </p:nvPicPr>
         <p:blipFill>
-          <a:blip xmlns:r="http://schemas.openxmlformats.org/officeDocument/2006/relationships" xmlns:a="http://schemas.openxmlformats.org/drawingml/2006/main" r:embed="R63f19056564a41ee"/>
+          <a:blip xmlns:r="http://schemas.openxmlformats.org/officeDocument/2006/relationships" xmlns:a="http://schemas.openxmlformats.org/drawingml/2006/main" r:embed="R9e36d3ea4a7f468f"/>
           <a:srcRect xmlns:a="http://schemas.openxmlformats.org/drawingml/2006/main" l="0" t="15682" r="0" b="15682"/>
           <a:stretch xmlns:a="http://schemas.openxmlformats.org/drawingml/2006/main">
             <a:fillRect l="0" t="0" r="0" b="0"/>
@@ -8376,7 +8376,7 @@
           <p:cNvPr id="5" name="">
             <a:extLst xmlns:a="http://schemas.openxmlformats.org/drawingml/2006/main">
               <a:ext uri="{FF2B5EF4-FFF2-40B4-BE49-F238E27FC236}">
-                <a16:creationId xmlns:a16="http://schemas.microsoft.com/office/drawing/2014/main" id="{83AFFD2A-C71B-41B8-B090-127FBFA85240}"/>
+                <a16:creationId xmlns:a16="http://schemas.microsoft.com/office/drawing/2014/main" id="{60CFDC64-DA7A-4890-99FF-47DD2A1E4251}"/>
               </a:ext>
             </a:extLst>
           </p:cNvPr>
@@ -8409,7 +8409,7 @@
           <p:cNvPr id="6" name="">
             <a:extLst xmlns:a="http://schemas.openxmlformats.org/drawingml/2006/main">
               <a:ext uri="{FF2B5EF4-FFF2-40B4-BE49-F238E27FC236}">
-                <a16:creationId xmlns:a16="http://schemas.microsoft.com/office/drawing/2014/main" id="{C38F4570-32DC-48A2-8006-D1ACFB67A9EF}"/>
+                <a16:creationId xmlns:a16="http://schemas.microsoft.com/office/drawing/2014/main" id="{35532292-94E5-46C6-B70F-DBE875B9EED9}"/>
               </a:ext>
             </a:extLst>
           </p:cNvPr>
@@ -8440,7 +8440,7 @@
           <p:cNvPr id="7" name="">
             <a:extLst xmlns:a="http://schemas.openxmlformats.org/drawingml/2006/main">
               <a:ext uri="{FF2B5EF4-FFF2-40B4-BE49-F238E27FC236}">
-                <a16:creationId xmlns:a16="http://schemas.microsoft.com/office/drawing/2014/main" id="{8C4A16C6-1551-499C-9522-BA67A311B930}"/>
+                <a16:creationId xmlns:a16="http://schemas.microsoft.com/office/drawing/2014/main" id="{DE8D0A93-2035-4F1F-8D25-87ADC7C1F303}"/>
               </a:ext>
             </a:extLst>
           </p:cNvPr>
@@ -8502,7 +8502,7 @@
           <p:cNvPr id="8" name="">
             <a:extLst xmlns:a="http://schemas.openxmlformats.org/drawingml/2006/main">
               <a:ext uri="{FF2B5EF4-FFF2-40B4-BE49-F238E27FC236}">
-                <a16:creationId xmlns:a16="http://schemas.microsoft.com/office/drawing/2014/main" id="{4FC5CD19-7863-404F-96CB-4F74A933665D}"/>
+                <a16:creationId xmlns:a16="http://schemas.microsoft.com/office/drawing/2014/main" id="{B240260B-1E81-4519-A530-907BFF177543}"/>
               </a:ext>
             </a:extLst>
           </p:cNvPr>
@@ -8537,7 +8537,7 @@
           <p:cNvPr id="9" name="">
             <a:extLst xmlns:a="http://schemas.openxmlformats.org/drawingml/2006/main">
               <a:ext uri="{FF2B5EF4-FFF2-40B4-BE49-F238E27FC236}">
-                <a16:creationId xmlns:a16="http://schemas.microsoft.com/office/drawing/2014/main" id="{354880AA-859E-434A-B5BE-DCF9CB735CB1}"/>
+                <a16:creationId xmlns:a16="http://schemas.microsoft.com/office/drawing/2014/main" id="{A7C24F7C-5BC8-44F8-8CBB-16E8C458E1D7}"/>
               </a:ext>
             </a:extLst>
           </p:cNvPr>
@@ -8599,7 +8599,7 @@
           <p:cNvPr id="10" name="">
             <a:extLst xmlns:a="http://schemas.openxmlformats.org/drawingml/2006/main">
               <a:ext uri="{FF2B5EF4-FFF2-40B4-BE49-F238E27FC236}">
-                <a16:creationId xmlns:a16="http://schemas.microsoft.com/office/drawing/2014/main" id="{92C6E053-63A1-4C19-9E62-AE3F1FD2C00D}"/>
+                <a16:creationId xmlns:a16="http://schemas.microsoft.com/office/drawing/2014/main" id="{FEDE25F0-5207-4423-9BDB-5E2646C8B69C}"/>
               </a:ext>
             </a:extLst>
           </p:cNvPr>
@@ -8630,7 +8630,7 @@
           <p:cNvPr id="11" name="">
             <a:extLst xmlns:a="http://schemas.openxmlformats.org/drawingml/2006/main">
               <a:ext uri="{FF2B5EF4-FFF2-40B4-BE49-F238E27FC236}">
-                <a16:creationId xmlns:a16="http://schemas.microsoft.com/office/drawing/2014/main" id="{C972F62B-4FD9-49D7-A381-DC08E701F6C3}"/>
+                <a16:creationId xmlns:a16="http://schemas.microsoft.com/office/drawing/2014/main" id="{9313AB53-0D1E-4EFC-B9B4-E3A6ECE107AB}"/>
               </a:ext>
             </a:extLst>
           </p:cNvPr>
@@ -8692,7 +8692,7 @@
           <p:cNvPr id="12" name="">
             <a:extLst xmlns:a="http://schemas.openxmlformats.org/drawingml/2006/main">
               <a:ext uri="{FF2B5EF4-FFF2-40B4-BE49-F238E27FC236}">
-                <a16:creationId xmlns:a16="http://schemas.microsoft.com/office/drawing/2014/main" id="{944687E8-A815-4891-9AF7-A526CF7BAC82}"/>
+                <a16:creationId xmlns:a16="http://schemas.microsoft.com/office/drawing/2014/main" id="{847F3713-3A28-4072-984F-2969D7E82C0E}"/>
               </a:ext>
             </a:extLst>
           </p:cNvPr>
@@ -8727,7 +8727,7 @@
           <p:cNvPr id="13" name="">
             <a:extLst xmlns:a="http://schemas.openxmlformats.org/drawingml/2006/main">
               <a:ext uri="{FF2B5EF4-FFF2-40B4-BE49-F238E27FC236}">
-                <a16:creationId xmlns:a16="http://schemas.microsoft.com/office/drawing/2014/main" id="{110C6EC7-5FF7-4103-9ACA-55136050D453}"/>
+                <a16:creationId xmlns:a16="http://schemas.microsoft.com/office/drawing/2014/main" id="{1B5BCC62-CEAF-47DF-8E9F-BF29AC69CBF8}"/>
               </a:ext>
             </a:extLst>
           </p:cNvPr>
@@ -8789,7 +8789,7 @@
           <p:cNvPr id="14" name="">
             <a:extLst xmlns:a="http://schemas.openxmlformats.org/drawingml/2006/main">
               <a:ext uri="{FF2B5EF4-FFF2-40B4-BE49-F238E27FC236}">
-                <a16:creationId xmlns:a16="http://schemas.microsoft.com/office/drawing/2014/main" id="{51493B82-1603-4D72-BA08-FE6C97154375}"/>
+                <a16:creationId xmlns:a16="http://schemas.microsoft.com/office/drawing/2014/main" id="{970FAA6F-129F-4F56-9BEF-094247E47530}"/>
               </a:ext>
             </a:extLst>
           </p:cNvPr>
@@ -8820,7 +8820,7 @@
           <p:cNvPr id="15" name="">
             <a:extLst xmlns:a="http://schemas.openxmlformats.org/drawingml/2006/main">
               <a:ext uri="{FF2B5EF4-FFF2-40B4-BE49-F238E27FC236}">
-                <a16:creationId xmlns:a16="http://schemas.microsoft.com/office/drawing/2014/main" id="{94EF57F2-C5F7-4634-BE71-708CB4F733AD}"/>
+                <a16:creationId xmlns:a16="http://schemas.microsoft.com/office/drawing/2014/main" id="{7E089662-47AC-40BA-ABCC-E6FED3C73E4B}"/>
               </a:ext>
             </a:extLst>
           </p:cNvPr>
@@ -8882,7 +8882,7 @@
           <p:cNvPr id="16" name="">
             <a:extLst xmlns:a="http://schemas.openxmlformats.org/drawingml/2006/main">
               <a:ext uri="{FF2B5EF4-FFF2-40B4-BE49-F238E27FC236}">
-                <a16:creationId xmlns:a16="http://schemas.microsoft.com/office/drawing/2014/main" id="{A264568B-BAA5-4ACE-AD20-EE09F91C519A}"/>
+                <a16:creationId xmlns:a16="http://schemas.microsoft.com/office/drawing/2014/main" id="{294A8D38-60F7-4B65-9B19-C3473FC6E428}"/>
               </a:ext>
             </a:extLst>
           </p:cNvPr>
@@ -8917,7 +8917,7 @@
           <p:cNvPr id="17" name="">
             <a:extLst xmlns:a="http://schemas.openxmlformats.org/drawingml/2006/main">
               <a:ext uri="{FF2B5EF4-FFF2-40B4-BE49-F238E27FC236}">
-                <a16:creationId xmlns:a16="http://schemas.microsoft.com/office/drawing/2014/main" id="{2EFD63AF-662D-498B-994C-7D05AF34E7BA}"/>
+                <a16:creationId xmlns:a16="http://schemas.microsoft.com/office/drawing/2014/main" id="{9BCF3450-3459-4B4F-B82D-6EF65FA0EC0D}"/>
               </a:ext>
             </a:extLst>
           </p:cNvPr>
@@ -8979,7 +8979,7 @@
           <p:cNvPr id="18" name="">
             <a:extLst xmlns:a="http://schemas.openxmlformats.org/drawingml/2006/main">
               <a:ext uri="{FF2B5EF4-FFF2-40B4-BE49-F238E27FC236}">
-                <a16:creationId xmlns:a16="http://schemas.microsoft.com/office/drawing/2014/main" id="{21F05F76-B450-4595-84E9-5DF273932A87}"/>
+                <a16:creationId xmlns:a16="http://schemas.microsoft.com/office/drawing/2014/main" id="{0B5BB666-115B-4B96-A2BE-069198B75B72}"/>
               </a:ext>
             </a:extLst>
           </p:cNvPr>
@@ -9010,7 +9010,7 @@
           <p:cNvPr id="19" name="">
             <a:extLst xmlns:a="http://schemas.openxmlformats.org/drawingml/2006/main">
               <a:ext uri="{FF2B5EF4-FFF2-40B4-BE49-F238E27FC236}">
-                <a16:creationId xmlns:a16="http://schemas.microsoft.com/office/drawing/2014/main" id="{6DFA7AF7-E630-4B86-B441-A498902B99F9}"/>
+                <a16:creationId xmlns:a16="http://schemas.microsoft.com/office/drawing/2014/main" id="{C866EE63-9BD0-46BD-B67C-83AF846889BB}"/>
               </a:ext>
             </a:extLst>
           </p:cNvPr>
@@ -9072,7 +9072,7 @@
           <p:cNvPr id="20" name="">
             <a:extLst xmlns:a="http://schemas.openxmlformats.org/drawingml/2006/main">
               <a:ext uri="{FF2B5EF4-FFF2-40B4-BE49-F238E27FC236}">
-                <a16:creationId xmlns:a16="http://schemas.microsoft.com/office/drawing/2014/main" id="{F943DBF4-A96E-4C58-8D46-A3D341CD06A6}"/>
+                <a16:creationId xmlns:a16="http://schemas.microsoft.com/office/drawing/2014/main" id="{34EC071A-9496-413B-AC9A-8B921751CB23}"/>
               </a:ext>
             </a:extLst>
           </p:cNvPr>
@@ -9132,7 +9132,7 @@
     </p:spTree>
     <p:extLst>
       <p:ext uri="{BB962C8B-B14F-4D97-AF65-F5344CB8AC3E}">
-        <p14:creationId xmlns:p14="http://schemas.microsoft.com/office/powerpoint/2010/main" val="298330804"/>
+        <p14:creationId xmlns:p14="http://schemas.microsoft.com/office/powerpoint/2010/main" val="1008475127"/>
       </p:ext>
     </p:extLst>
   </p:cSld>
@@ -9163,7 +9163,7 @@
           <p:cNvPr id="21" name="">
             <a:extLst xmlns:a="http://schemas.openxmlformats.org/drawingml/2006/main">
               <a:ext uri="{FF2B5EF4-FFF2-40B4-BE49-F238E27FC236}">
-                <a16:creationId xmlns:a16="http://schemas.microsoft.com/office/drawing/2014/main" id="{2360B48D-DCB9-4D31-B879-F62B83DE7209}"/>
+                <a16:creationId xmlns:a16="http://schemas.microsoft.com/office/drawing/2014/main" id="{26E84505-125F-49F5-8389-545A8308C926}"/>
               </a:ext>
             </a:extLst>
           </p:cNvPr>
@@ -9225,7 +9225,7 @@
                 <a:latin typeface="Arial"/>
                 <a:ea typeface="Arial"/>
                 <a:cs typeface="Arial"/>
-                <a:hlinkClick xmlns:r="http://schemas.openxmlformats.org/officeDocument/2006/relationships" r:id="R5c4db1de1e724b13"/>
+                <a:hlinkClick xmlns:r="http://schemas.openxmlformats.org/officeDocument/2006/relationships" r:id="R3380ffcac88d41ef"/>
               </a:rPr>
               <a:t>https://github.com/qjmre23/Route2Zero</a:t>
             </a:r>
@@ -9248,7 +9248,7 @@
                 <a:latin typeface="Arial"/>
                 <a:ea typeface="Arial"/>
                 <a:cs typeface="Arial"/>
-                <a:hlinkClick xmlns:r="http://schemas.openxmlformats.org/officeDocument/2006/relationships" r:id="Rfc99eb89eaca436d"/>
+                <a:hlinkClick xmlns:r="http://schemas.openxmlformats.org/officeDocument/2006/relationships" r:id="R4f5ce02a5aed4af4"/>
               </a:rPr>
               <a:t>https://route2zero.netlify.app/</a:t>
             </a:r>
@@ -9260,7 +9260,7 @@
           <p:cNvPr id="2" name="">
             <a:extLst xmlns:a="http://schemas.openxmlformats.org/drawingml/2006/main">
               <a:ext uri="{FF2B5EF4-FFF2-40B4-BE49-F238E27FC236}">
-                <a16:creationId xmlns:a16="http://schemas.microsoft.com/office/drawing/2014/main" id="{411D1855-AFE6-4DE7-BBCA-22CEA593FF8B}"/>
+                <a16:creationId xmlns:a16="http://schemas.microsoft.com/office/drawing/2014/main" id="{E69D34C1-FBE4-4CE7-8876-AEF9C2DB4BD3}"/>
               </a:ext>
             </a:extLst>
           </p:cNvPr>
@@ -9322,7 +9322,7 @@
           <p:cNvPr id="3" name="">
             <a:extLst xmlns:a="http://schemas.openxmlformats.org/drawingml/2006/main">
               <a:ext uri="{FF2B5EF4-FFF2-40B4-BE49-F238E27FC236}">
-                <a16:creationId xmlns:a16="http://schemas.microsoft.com/office/drawing/2014/main" id="{86763176-1511-4E5E-863F-3CABC50327D8}"/>
+                <a16:creationId xmlns:a16="http://schemas.microsoft.com/office/drawing/2014/main" id="{F754B134-F667-4E7E-96A0-AC1A9BCA51F1}"/>
               </a:ext>
             </a:extLst>
           </p:cNvPr>
@@ -9388,7 +9388,7 @@
           <p:nvPr/>
         </p:nvPicPr>
         <p:blipFill>
-          <a:blip xmlns:r="http://schemas.openxmlformats.org/officeDocument/2006/relationships" xmlns:a="http://schemas.openxmlformats.org/drawingml/2006/main" r:embed="Ref8773061a864a4e"/>
+          <a:blip xmlns:r="http://schemas.openxmlformats.org/officeDocument/2006/relationships" xmlns:a="http://schemas.openxmlformats.org/drawingml/2006/main" r:embed="R1dd00c21938b4cb2"/>
           <a:srcRect xmlns:a="http://schemas.openxmlformats.org/drawingml/2006/main" l="0" t="15682" r="0" b="15682"/>
           <a:stretch xmlns:a="http://schemas.openxmlformats.org/drawingml/2006/main">
             <a:fillRect l="0" t="0" r="0" b="0"/>
@@ -9411,7 +9411,7 @@
           <p:cNvPr id="5" name="">
             <a:extLst xmlns:a="http://schemas.openxmlformats.org/drawingml/2006/main">
               <a:ext uri="{FF2B5EF4-FFF2-40B4-BE49-F238E27FC236}">
-                <a16:creationId xmlns:a16="http://schemas.microsoft.com/office/drawing/2014/main" id="{1CF95636-24E9-4380-9128-EB2B541EDE51}"/>
+                <a16:creationId xmlns:a16="http://schemas.microsoft.com/office/drawing/2014/main" id="{D72619FD-951C-420C-BE3E-985DC68F9382}"/>
               </a:ext>
             </a:extLst>
           </p:cNvPr>
@@ -9444,7 +9444,7 @@
           <p:cNvPr id="6" name="">
             <a:extLst xmlns:a="http://schemas.openxmlformats.org/drawingml/2006/main">
               <a:ext uri="{FF2B5EF4-FFF2-40B4-BE49-F238E27FC236}">
-                <a16:creationId xmlns:a16="http://schemas.microsoft.com/office/drawing/2014/main" id="{988CD953-2EE9-4026-879A-6AE4F2963F86}"/>
+                <a16:creationId xmlns:a16="http://schemas.microsoft.com/office/drawing/2014/main" id="{917851C4-A991-4CA7-A48F-E352D9196D8E}"/>
               </a:ext>
             </a:extLst>
           </p:cNvPr>
@@ -9475,7 +9475,7 @@
           <p:cNvPr id="7" name="">
             <a:extLst xmlns:a="http://schemas.openxmlformats.org/drawingml/2006/main">
               <a:ext uri="{FF2B5EF4-FFF2-40B4-BE49-F238E27FC236}">
-                <a16:creationId xmlns:a16="http://schemas.microsoft.com/office/drawing/2014/main" id="{F3EA18D3-3BAA-4146-BC7B-B53590E5C293}"/>
+                <a16:creationId xmlns:a16="http://schemas.microsoft.com/office/drawing/2014/main" id="{270ED4C5-238C-447F-B2C6-7AF664B4E33B}"/>
               </a:ext>
             </a:extLst>
           </p:cNvPr>
@@ -9537,7 +9537,7 @@
           <p:cNvPr id="8" name="">
             <a:extLst xmlns:a="http://schemas.openxmlformats.org/drawingml/2006/main">
               <a:ext uri="{FF2B5EF4-FFF2-40B4-BE49-F238E27FC236}">
-                <a16:creationId xmlns:a16="http://schemas.microsoft.com/office/drawing/2014/main" id="{6D78A0A3-3312-48CA-9B00-D6C228671B19}"/>
+                <a16:creationId xmlns:a16="http://schemas.microsoft.com/office/drawing/2014/main" id="{4F1E9BC9-95CC-47A7-A5D3-39D6CDAFD51E}"/>
               </a:ext>
             </a:extLst>
           </p:cNvPr>
@@ -9572,7 +9572,7 @@
           <p:cNvPr id="9" name="">
             <a:extLst xmlns:a="http://schemas.openxmlformats.org/drawingml/2006/main">
               <a:ext uri="{FF2B5EF4-FFF2-40B4-BE49-F238E27FC236}">
-                <a16:creationId xmlns:a16="http://schemas.microsoft.com/office/drawing/2014/main" id="{332B9D40-6378-4319-A5E7-5FBCDAA0D9AF}"/>
+                <a16:creationId xmlns:a16="http://schemas.microsoft.com/office/drawing/2014/main" id="{FF21772B-1AE4-41B4-9A50-9E0AF315FAE9}"/>
               </a:ext>
             </a:extLst>
           </p:cNvPr>
@@ -9634,7 +9634,7 @@
           <p:cNvPr id="10" name="">
             <a:extLst xmlns:a="http://schemas.openxmlformats.org/drawingml/2006/main">
               <a:ext uri="{FF2B5EF4-FFF2-40B4-BE49-F238E27FC236}">
-                <a16:creationId xmlns:a16="http://schemas.microsoft.com/office/drawing/2014/main" id="{AF0A6380-FE92-46D3-BB9F-2E8BBEFEB958}"/>
+                <a16:creationId xmlns:a16="http://schemas.microsoft.com/office/drawing/2014/main" id="{ECE9F057-5A54-4A90-ADE9-053614EC76DF}"/>
               </a:ext>
             </a:extLst>
           </p:cNvPr>
@@ -9665,7 +9665,7 @@
           <p:cNvPr id="11" name="">
             <a:extLst xmlns:a="http://schemas.openxmlformats.org/drawingml/2006/main">
               <a:ext uri="{FF2B5EF4-FFF2-40B4-BE49-F238E27FC236}">
-                <a16:creationId xmlns:a16="http://schemas.microsoft.com/office/drawing/2014/main" id="{EEAD0B3F-D131-4621-AB60-6763D709180A}"/>
+                <a16:creationId xmlns:a16="http://schemas.microsoft.com/office/drawing/2014/main" id="{70B4C343-A0FF-429B-BD23-931CAF0D4A1D}"/>
               </a:ext>
             </a:extLst>
           </p:cNvPr>
@@ -9727,7 +9727,7 @@
           <p:cNvPr id="12" name="">
             <a:extLst xmlns:a="http://schemas.openxmlformats.org/drawingml/2006/main">
               <a:ext uri="{FF2B5EF4-FFF2-40B4-BE49-F238E27FC236}">
-                <a16:creationId xmlns:a16="http://schemas.microsoft.com/office/drawing/2014/main" id="{AE0AFCEA-36B6-4F3B-87F8-D12AE11BC14A}"/>
+                <a16:creationId xmlns:a16="http://schemas.microsoft.com/office/drawing/2014/main" id="{B2A177CA-B3F9-4FDA-8402-C7455AE53E31}"/>
               </a:ext>
             </a:extLst>
           </p:cNvPr>
@@ -9762,7 +9762,7 @@
           <p:cNvPr id="13" name="">
             <a:extLst xmlns:a="http://schemas.openxmlformats.org/drawingml/2006/main">
               <a:ext uri="{FF2B5EF4-FFF2-40B4-BE49-F238E27FC236}">
-                <a16:creationId xmlns:a16="http://schemas.microsoft.com/office/drawing/2014/main" id="{B5DE75FC-737D-4F58-8413-51B544C63F01}"/>
+                <a16:creationId xmlns:a16="http://schemas.microsoft.com/office/drawing/2014/main" id="{3DFF43DB-7E3D-4696-AE18-A6F6975DEB03}"/>
               </a:ext>
             </a:extLst>
           </p:cNvPr>
@@ -9824,7 +9824,7 @@
           <p:cNvPr id="14" name="">
             <a:extLst xmlns:a="http://schemas.openxmlformats.org/drawingml/2006/main">
               <a:ext uri="{FF2B5EF4-FFF2-40B4-BE49-F238E27FC236}">
-                <a16:creationId xmlns:a16="http://schemas.microsoft.com/office/drawing/2014/main" id="{496897F9-A35C-40F6-8619-F3CFFC38872B}"/>
+                <a16:creationId xmlns:a16="http://schemas.microsoft.com/office/drawing/2014/main" id="{B1EC832E-024C-4A13-BA6F-ED45B52A499B}"/>
               </a:ext>
             </a:extLst>
           </p:cNvPr>
@@ -9855,7 +9855,7 @@
           <p:cNvPr id="15" name="">
             <a:extLst xmlns:a="http://schemas.openxmlformats.org/drawingml/2006/main">
               <a:ext uri="{FF2B5EF4-FFF2-40B4-BE49-F238E27FC236}">
-                <a16:creationId xmlns:a16="http://schemas.microsoft.com/office/drawing/2014/main" id="{AF3B0CF0-62E4-43E6-8EFB-C5A05C4982BD}"/>
+                <a16:creationId xmlns:a16="http://schemas.microsoft.com/office/drawing/2014/main" id="{6F47E45D-3AB8-48BB-96B0-C530E9FC6695}"/>
               </a:ext>
             </a:extLst>
           </p:cNvPr>
@@ -9917,7 +9917,7 @@
           <p:cNvPr id="16" name="">
             <a:extLst xmlns:a="http://schemas.openxmlformats.org/drawingml/2006/main">
               <a:ext uri="{FF2B5EF4-FFF2-40B4-BE49-F238E27FC236}">
-                <a16:creationId xmlns:a16="http://schemas.microsoft.com/office/drawing/2014/main" id="{6BE5DB8A-FB2B-41C3-9BD4-11897AD9E627}"/>
+                <a16:creationId xmlns:a16="http://schemas.microsoft.com/office/drawing/2014/main" id="{B40BC1F5-644E-478E-B59B-FC7542EE0817}"/>
               </a:ext>
             </a:extLst>
           </p:cNvPr>
@@ -9952,7 +9952,7 @@
           <p:cNvPr id="17" name="">
             <a:extLst xmlns:a="http://schemas.openxmlformats.org/drawingml/2006/main">
               <a:ext uri="{FF2B5EF4-FFF2-40B4-BE49-F238E27FC236}">
-                <a16:creationId xmlns:a16="http://schemas.microsoft.com/office/drawing/2014/main" id="{8330167D-B66F-491C-A53D-528A2BE3A9EB}"/>
+                <a16:creationId xmlns:a16="http://schemas.microsoft.com/office/drawing/2014/main" id="{FD4C97BD-C977-4A05-9A8A-2705E0E946EF}"/>
               </a:ext>
             </a:extLst>
           </p:cNvPr>
@@ -10014,7 +10014,7 @@
           <p:cNvPr id="18" name="">
             <a:extLst xmlns:a="http://schemas.openxmlformats.org/drawingml/2006/main">
               <a:ext uri="{FF2B5EF4-FFF2-40B4-BE49-F238E27FC236}">
-                <a16:creationId xmlns:a16="http://schemas.microsoft.com/office/drawing/2014/main" id="{D55FF083-371B-4BF7-A297-6EFA39BF06B6}"/>
+                <a16:creationId xmlns:a16="http://schemas.microsoft.com/office/drawing/2014/main" id="{C6F02131-15E9-4178-A940-A9F167A6EEB4}"/>
               </a:ext>
             </a:extLst>
           </p:cNvPr>
@@ -10045,7 +10045,7 @@
           <p:cNvPr id="19" name="">
             <a:extLst xmlns:a="http://schemas.openxmlformats.org/drawingml/2006/main">
               <a:ext uri="{FF2B5EF4-FFF2-40B4-BE49-F238E27FC236}">
-                <a16:creationId xmlns:a16="http://schemas.microsoft.com/office/drawing/2014/main" id="{A9B02DA2-ACA8-4EFF-9AF1-41C429628F3E}"/>
+                <a16:creationId xmlns:a16="http://schemas.microsoft.com/office/drawing/2014/main" id="{AFA77872-33E6-428B-8C73-3724B4A37354}"/>
               </a:ext>
             </a:extLst>
           </p:cNvPr>
@@ -10107,7 +10107,7 @@
           <p:cNvPr id="20" name="">
             <a:extLst xmlns:a="http://schemas.openxmlformats.org/drawingml/2006/main">
               <a:ext uri="{FF2B5EF4-FFF2-40B4-BE49-F238E27FC236}">
-                <a16:creationId xmlns:a16="http://schemas.microsoft.com/office/drawing/2014/main" id="{0F807CE2-1C72-4E81-84B8-31C9EDAE42E9}"/>
+                <a16:creationId xmlns:a16="http://schemas.microsoft.com/office/drawing/2014/main" id="{6085CC3C-37EF-432C-AD94-CE4A10690D97}"/>
               </a:ext>
             </a:extLst>
           </p:cNvPr>
@@ -10167,7 +10167,7 @@
     </p:spTree>
     <p:extLst>
       <p:ext uri="{BB962C8B-B14F-4D97-AF65-F5344CB8AC3E}">
-        <p14:creationId xmlns:p14="http://schemas.microsoft.com/office/powerpoint/2010/main" val="720463715"/>
+        <p14:creationId xmlns:p14="http://schemas.microsoft.com/office/powerpoint/2010/main" val="1929702462"/>
       </p:ext>
     </p:extLst>
   </p:cSld>
@@ -10198,7 +10198,7 @@
           <p:cNvPr id="21" name="">
             <a:extLst xmlns:a="http://schemas.openxmlformats.org/drawingml/2006/main">
               <a:ext uri="{FF2B5EF4-FFF2-40B4-BE49-F238E27FC236}">
-                <a16:creationId xmlns:a16="http://schemas.microsoft.com/office/drawing/2014/main" id="{28B3C04F-A9D3-4092-8FFF-E8A9AE25EDD5}"/>
+                <a16:creationId xmlns:a16="http://schemas.microsoft.com/office/drawing/2014/main" id="{266D9532-1519-4886-BEF2-0B884B327082}"/>
               </a:ext>
             </a:extLst>
           </p:cNvPr>
@@ -10260,7 +10260,7 @@
                 <a:latin typeface="Arial"/>
                 <a:ea typeface="Arial"/>
                 <a:cs typeface="Arial"/>
-                <a:hlinkClick xmlns:r="http://schemas.openxmlformats.org/officeDocument/2006/relationships" r:id="R161225931eac4f14"/>
+                <a:hlinkClick xmlns:r="http://schemas.openxmlformats.org/officeDocument/2006/relationships" r:id="R9bdaaf2a6db74593"/>
               </a:rPr>
               <a:t>https://github.com/qjmre23/Route2Zero</a:t>
             </a:r>
@@ -10283,7 +10283,7 @@
                 <a:latin typeface="Arial"/>
                 <a:ea typeface="Arial"/>
                 <a:cs typeface="Arial"/>
-                <a:hlinkClick xmlns:r="http://schemas.openxmlformats.org/officeDocument/2006/relationships" r:id="Raaddd1d3705a496a"/>
+                <a:hlinkClick xmlns:r="http://schemas.openxmlformats.org/officeDocument/2006/relationships" r:id="Rb203ac499a2b4e92"/>
               </a:rPr>
               <a:t>https://route2zero.netlify.app/</a:t>
             </a:r>
@@ -10295,7 +10295,7 @@
           <p:cNvPr id="2" name="">
             <a:extLst xmlns:a="http://schemas.openxmlformats.org/drawingml/2006/main">
               <a:ext uri="{FF2B5EF4-FFF2-40B4-BE49-F238E27FC236}">
-                <a16:creationId xmlns:a16="http://schemas.microsoft.com/office/drawing/2014/main" id="{C95EAFF6-DA9A-4100-886B-089E9E3CAF7D}"/>
+                <a16:creationId xmlns:a16="http://schemas.microsoft.com/office/drawing/2014/main" id="{2C3CB7C9-2BD7-40DA-9D77-80338499E9C5}"/>
               </a:ext>
             </a:extLst>
           </p:cNvPr>
@@ -10357,7 +10357,7 @@
           <p:cNvPr id="3" name="">
             <a:extLst xmlns:a="http://schemas.openxmlformats.org/drawingml/2006/main">
               <a:ext uri="{FF2B5EF4-FFF2-40B4-BE49-F238E27FC236}">
-                <a16:creationId xmlns:a16="http://schemas.microsoft.com/office/drawing/2014/main" id="{9EA276C1-16E5-4769-8DE8-E7EF5DDA3463}"/>
+                <a16:creationId xmlns:a16="http://schemas.microsoft.com/office/drawing/2014/main" id="{3F6189BD-B402-4743-9361-45F7894B3121}"/>
               </a:ext>
             </a:extLst>
           </p:cNvPr>
@@ -10423,7 +10423,7 @@
           <p:nvPr/>
         </p:nvPicPr>
         <p:blipFill>
-          <a:blip xmlns:r="http://schemas.openxmlformats.org/officeDocument/2006/relationships" xmlns:a="http://schemas.openxmlformats.org/drawingml/2006/main" r:embed="R7c995d37b94e4ff4"/>
+          <a:blip xmlns:r="http://schemas.openxmlformats.org/officeDocument/2006/relationships" xmlns:a="http://schemas.openxmlformats.org/drawingml/2006/main" r:embed="R77c41e6b25fc4ca9"/>
           <a:srcRect xmlns:a="http://schemas.openxmlformats.org/drawingml/2006/main" l="0" t="15682" r="0" b="15682"/>
           <a:stretch xmlns:a="http://schemas.openxmlformats.org/drawingml/2006/main">
             <a:fillRect l="0" t="0" r="0" b="0"/>
@@ -10446,7 +10446,7 @@
           <p:cNvPr id="5" name="">
             <a:extLst xmlns:a="http://schemas.openxmlformats.org/drawingml/2006/main">
               <a:ext uri="{FF2B5EF4-FFF2-40B4-BE49-F238E27FC236}">
-                <a16:creationId xmlns:a16="http://schemas.microsoft.com/office/drawing/2014/main" id="{EC1E8F63-C824-42FB-9844-3A62CC7DF0F7}"/>
+                <a16:creationId xmlns:a16="http://schemas.microsoft.com/office/drawing/2014/main" id="{9D10663E-CC9D-4A3F-B8B6-597332C4144C}"/>
               </a:ext>
             </a:extLst>
           </p:cNvPr>
@@ -10479,7 +10479,7 @@
           <p:cNvPr id="6" name="">
             <a:extLst xmlns:a="http://schemas.openxmlformats.org/drawingml/2006/main">
               <a:ext uri="{FF2B5EF4-FFF2-40B4-BE49-F238E27FC236}">
-                <a16:creationId xmlns:a16="http://schemas.microsoft.com/office/drawing/2014/main" id="{A890230F-7916-44FB-85CF-27AE1C070837}"/>
+                <a16:creationId xmlns:a16="http://schemas.microsoft.com/office/drawing/2014/main" id="{A18BF786-3E54-426E-B251-C0B18286409F}"/>
               </a:ext>
             </a:extLst>
           </p:cNvPr>
@@ -10510,7 +10510,7 @@
           <p:cNvPr id="7" name="">
             <a:extLst xmlns:a="http://schemas.openxmlformats.org/drawingml/2006/main">
               <a:ext uri="{FF2B5EF4-FFF2-40B4-BE49-F238E27FC236}">
-                <a16:creationId xmlns:a16="http://schemas.microsoft.com/office/drawing/2014/main" id="{7A8A1669-2D2C-41AB-B155-4F9D28760379}"/>
+                <a16:creationId xmlns:a16="http://schemas.microsoft.com/office/drawing/2014/main" id="{CEF79DC5-A983-4E31-B52E-9DC9D16602BF}"/>
               </a:ext>
             </a:extLst>
           </p:cNvPr>
@@ -10572,7 +10572,7 @@
           <p:cNvPr id="8" name="">
             <a:extLst xmlns:a="http://schemas.openxmlformats.org/drawingml/2006/main">
               <a:ext uri="{FF2B5EF4-FFF2-40B4-BE49-F238E27FC236}">
-                <a16:creationId xmlns:a16="http://schemas.microsoft.com/office/drawing/2014/main" id="{7BE0B37B-9BC5-4B61-B44D-B729D540BEA5}"/>
+                <a16:creationId xmlns:a16="http://schemas.microsoft.com/office/drawing/2014/main" id="{A6A05433-3EA5-4544-93A8-6858A9342D5E}"/>
               </a:ext>
             </a:extLst>
           </p:cNvPr>
@@ -10607,7 +10607,7 @@
           <p:cNvPr id="9" name="">
             <a:extLst xmlns:a="http://schemas.openxmlformats.org/drawingml/2006/main">
               <a:ext uri="{FF2B5EF4-FFF2-40B4-BE49-F238E27FC236}">
-                <a16:creationId xmlns:a16="http://schemas.microsoft.com/office/drawing/2014/main" id="{D1C363EC-061B-4F50-80DF-42C9A59F9C70}"/>
+                <a16:creationId xmlns:a16="http://schemas.microsoft.com/office/drawing/2014/main" id="{F17CBFB3-E64C-4FAE-982E-0686021D9ED9}"/>
               </a:ext>
             </a:extLst>
           </p:cNvPr>
@@ -10669,7 +10669,7 @@
           <p:cNvPr id="10" name="">
             <a:extLst xmlns:a="http://schemas.openxmlformats.org/drawingml/2006/main">
               <a:ext uri="{FF2B5EF4-FFF2-40B4-BE49-F238E27FC236}">
-                <a16:creationId xmlns:a16="http://schemas.microsoft.com/office/drawing/2014/main" id="{6FF047FC-6096-4491-A3D9-01EC6B814746}"/>
+                <a16:creationId xmlns:a16="http://schemas.microsoft.com/office/drawing/2014/main" id="{277BE7DC-39CD-4EB6-B3AA-B5809D21E7E9}"/>
               </a:ext>
             </a:extLst>
           </p:cNvPr>
@@ -10700,7 +10700,7 @@
           <p:cNvPr id="11" name="">
             <a:extLst xmlns:a="http://schemas.openxmlformats.org/drawingml/2006/main">
               <a:ext uri="{FF2B5EF4-FFF2-40B4-BE49-F238E27FC236}">
-                <a16:creationId xmlns:a16="http://schemas.microsoft.com/office/drawing/2014/main" id="{FAD30834-6A7A-4CF6-B1CB-6CFF05C5F84F}"/>
+                <a16:creationId xmlns:a16="http://schemas.microsoft.com/office/drawing/2014/main" id="{F445DA8D-007B-467F-A26A-8B95A77CC259}"/>
               </a:ext>
             </a:extLst>
           </p:cNvPr>
@@ -10762,7 +10762,7 @@
           <p:cNvPr id="12" name="">
             <a:extLst xmlns:a="http://schemas.openxmlformats.org/drawingml/2006/main">
               <a:ext uri="{FF2B5EF4-FFF2-40B4-BE49-F238E27FC236}">
-                <a16:creationId xmlns:a16="http://schemas.microsoft.com/office/drawing/2014/main" id="{72E02D39-58FE-4C42-BE60-6C99F1295FE7}"/>
+                <a16:creationId xmlns:a16="http://schemas.microsoft.com/office/drawing/2014/main" id="{C35BC762-8B97-4AD4-9059-492B15BC7DA5}"/>
               </a:ext>
             </a:extLst>
           </p:cNvPr>
@@ -10797,7 +10797,7 @@
           <p:cNvPr id="13" name="">
             <a:extLst xmlns:a="http://schemas.openxmlformats.org/drawingml/2006/main">
               <a:ext uri="{FF2B5EF4-FFF2-40B4-BE49-F238E27FC236}">
-                <a16:creationId xmlns:a16="http://schemas.microsoft.com/office/drawing/2014/main" id="{0939959A-F178-4946-A6A3-956ACF9B0A4F}"/>
+                <a16:creationId xmlns:a16="http://schemas.microsoft.com/office/drawing/2014/main" id="{13D39F1D-8058-44F7-873A-369781E9EDB6}"/>
               </a:ext>
             </a:extLst>
           </p:cNvPr>
@@ -10859,7 +10859,7 @@
           <p:cNvPr id="14" name="">
             <a:extLst xmlns:a="http://schemas.openxmlformats.org/drawingml/2006/main">
               <a:ext uri="{FF2B5EF4-FFF2-40B4-BE49-F238E27FC236}">
-                <a16:creationId xmlns:a16="http://schemas.microsoft.com/office/drawing/2014/main" id="{A282BA7B-9DF0-41B1-8E43-E7AE0523D376}"/>
+                <a16:creationId xmlns:a16="http://schemas.microsoft.com/office/drawing/2014/main" id="{CEDB3460-1E3F-4A24-BF18-76822C796593}"/>
               </a:ext>
             </a:extLst>
           </p:cNvPr>
@@ -10890,7 +10890,7 @@
           <p:cNvPr id="15" name="">
             <a:extLst xmlns:a="http://schemas.openxmlformats.org/drawingml/2006/main">
               <a:ext uri="{FF2B5EF4-FFF2-40B4-BE49-F238E27FC236}">
-                <a16:creationId xmlns:a16="http://schemas.microsoft.com/office/drawing/2014/main" id="{02FAC867-3043-44C9-A6E0-CE3BC9D3B0BD}"/>
+                <a16:creationId xmlns:a16="http://schemas.microsoft.com/office/drawing/2014/main" id="{31CE1973-704E-4CF6-B737-949831E8A1BB}"/>
               </a:ext>
             </a:extLst>
           </p:cNvPr>
@@ -10952,7 +10952,7 @@
           <p:cNvPr id="16" name="">
             <a:extLst xmlns:a="http://schemas.openxmlformats.org/drawingml/2006/main">
               <a:ext uri="{FF2B5EF4-FFF2-40B4-BE49-F238E27FC236}">
-                <a16:creationId xmlns:a16="http://schemas.microsoft.com/office/drawing/2014/main" id="{9B0B9A97-E677-4A98-8F2B-1943A13682FD}"/>
+                <a16:creationId xmlns:a16="http://schemas.microsoft.com/office/drawing/2014/main" id="{1122A4D7-F21E-4EE1-9BD0-0FBE6C06121B}"/>
               </a:ext>
             </a:extLst>
           </p:cNvPr>
@@ -10987,7 +10987,7 @@
           <p:cNvPr id="17" name="">
             <a:extLst xmlns:a="http://schemas.openxmlformats.org/drawingml/2006/main">
               <a:ext uri="{FF2B5EF4-FFF2-40B4-BE49-F238E27FC236}">
-                <a16:creationId xmlns:a16="http://schemas.microsoft.com/office/drawing/2014/main" id="{983272AB-8C3E-4863-8B28-29E3946F1B61}"/>
+                <a16:creationId xmlns:a16="http://schemas.microsoft.com/office/drawing/2014/main" id="{EF2AF372-AD3C-4640-AEF1-27A91F48DEA4}"/>
               </a:ext>
             </a:extLst>
           </p:cNvPr>
@@ -11049,7 +11049,7 @@
           <p:cNvPr id="18" name="">
             <a:extLst xmlns:a="http://schemas.openxmlformats.org/drawingml/2006/main">
               <a:ext uri="{FF2B5EF4-FFF2-40B4-BE49-F238E27FC236}">
-                <a16:creationId xmlns:a16="http://schemas.microsoft.com/office/drawing/2014/main" id="{4CE2A13C-4AD8-4F0B-9106-118463AE4632}"/>
+                <a16:creationId xmlns:a16="http://schemas.microsoft.com/office/drawing/2014/main" id="{C376840A-EDF0-4483-BACF-57F0A432998F}"/>
               </a:ext>
             </a:extLst>
           </p:cNvPr>
@@ -11080,7 +11080,7 @@
           <p:cNvPr id="19" name="">
             <a:extLst xmlns:a="http://schemas.openxmlformats.org/drawingml/2006/main">
               <a:ext uri="{FF2B5EF4-FFF2-40B4-BE49-F238E27FC236}">
-                <a16:creationId xmlns:a16="http://schemas.microsoft.com/office/drawing/2014/main" id="{3FCA7B85-2DCD-4B80-B385-710864510059}"/>
+                <a16:creationId xmlns:a16="http://schemas.microsoft.com/office/drawing/2014/main" id="{9989C95A-1E37-4C7D-9D0C-DB539034812F}"/>
               </a:ext>
             </a:extLst>
           </p:cNvPr>
@@ -11142,7 +11142,7 @@
           <p:cNvPr id="20" name="">
             <a:extLst xmlns:a="http://schemas.openxmlformats.org/drawingml/2006/main">
               <a:ext uri="{FF2B5EF4-FFF2-40B4-BE49-F238E27FC236}">
-                <a16:creationId xmlns:a16="http://schemas.microsoft.com/office/drawing/2014/main" id="{014F18E0-A342-414B-AB51-F1BDB3AB660B}"/>
+                <a16:creationId xmlns:a16="http://schemas.microsoft.com/office/drawing/2014/main" id="{6B311C9E-4057-4B29-BDF9-8FCF4DCDC5EE}"/>
               </a:ext>
             </a:extLst>
           </p:cNvPr>
@@ -11202,7 +11202,7 @@
     </p:spTree>
     <p:extLst>
       <p:ext uri="{BB962C8B-B14F-4D97-AF65-F5344CB8AC3E}">
-        <p14:creationId xmlns:p14="http://schemas.microsoft.com/office/powerpoint/2010/main" val="751568943"/>
+        <p14:creationId xmlns:p14="http://schemas.microsoft.com/office/powerpoint/2010/main" val="1362574139"/>
       </p:ext>
     </p:extLst>
   </p:cSld>
@@ -11233,7 +11233,7 @@
           <p:cNvPr id="21" name="">
             <a:extLst xmlns:a="http://schemas.openxmlformats.org/drawingml/2006/main">
               <a:ext uri="{FF2B5EF4-FFF2-40B4-BE49-F238E27FC236}">
-                <a16:creationId xmlns:a16="http://schemas.microsoft.com/office/drawing/2014/main" id="{F8625C3B-4191-4F1C-86C3-8D0334673B71}"/>
+                <a16:creationId xmlns:a16="http://schemas.microsoft.com/office/drawing/2014/main" id="{7AD57115-D81F-4267-8168-9D0C070A2422}"/>
               </a:ext>
             </a:extLst>
           </p:cNvPr>
@@ -11295,7 +11295,7 @@
                 <a:latin typeface="Arial"/>
                 <a:ea typeface="Arial"/>
                 <a:cs typeface="Arial"/>
-                <a:hlinkClick xmlns:r="http://schemas.openxmlformats.org/officeDocument/2006/relationships" r:id="R5b9b7b1229494e1b"/>
+                <a:hlinkClick xmlns:r="http://schemas.openxmlformats.org/officeDocument/2006/relationships" r:id="R111a6e9d43cd4a37"/>
               </a:rPr>
               <a:t>https://github.com/qjmre23/Route2Zero</a:t>
             </a:r>
@@ -11318,7 +11318,7 @@
                 <a:latin typeface="Arial"/>
                 <a:ea typeface="Arial"/>
                 <a:cs typeface="Arial"/>
-                <a:hlinkClick xmlns:r="http://schemas.openxmlformats.org/officeDocument/2006/relationships" r:id="R9d1ba7e6525c42e8"/>
+                <a:hlinkClick xmlns:r="http://schemas.openxmlformats.org/officeDocument/2006/relationships" r:id="R1564f4678a7f400a"/>
               </a:rPr>
               <a:t>https://route2zero.netlify.app/</a:t>
             </a:r>
@@ -11330,7 +11330,7 @@
           <p:cNvPr id="2" name="">
             <a:extLst xmlns:a="http://schemas.openxmlformats.org/drawingml/2006/main">
               <a:ext uri="{FF2B5EF4-FFF2-40B4-BE49-F238E27FC236}">
-                <a16:creationId xmlns:a16="http://schemas.microsoft.com/office/drawing/2014/main" id="{3EAB013D-24D0-42F5-81B0-7B3F9A86F48A}"/>
+                <a16:creationId xmlns:a16="http://schemas.microsoft.com/office/drawing/2014/main" id="{32A5E2B3-B711-4EC9-BF5C-EEE716D44698}"/>
               </a:ext>
             </a:extLst>
           </p:cNvPr>
@@ -11392,7 +11392,7 @@
           <p:cNvPr id="3" name="">
             <a:extLst xmlns:a="http://schemas.openxmlformats.org/drawingml/2006/main">
               <a:ext uri="{FF2B5EF4-FFF2-40B4-BE49-F238E27FC236}">
-                <a16:creationId xmlns:a16="http://schemas.microsoft.com/office/drawing/2014/main" id="{B76245D5-9421-41A9-8CC3-9DF610F0C55A}"/>
+                <a16:creationId xmlns:a16="http://schemas.microsoft.com/office/drawing/2014/main" id="{6611EEB5-224F-4DEC-8582-31A733ED4EF0}"/>
               </a:ext>
             </a:extLst>
           </p:cNvPr>
@@ -11458,7 +11458,7 @@
           <p:nvPr/>
         </p:nvPicPr>
         <p:blipFill>
-          <a:blip xmlns:r="http://schemas.openxmlformats.org/officeDocument/2006/relationships" xmlns:a="http://schemas.openxmlformats.org/drawingml/2006/main" r:embed="R182e358f2ea14dc3"/>
+          <a:blip xmlns:r="http://schemas.openxmlformats.org/officeDocument/2006/relationships" xmlns:a="http://schemas.openxmlformats.org/drawingml/2006/main" r:embed="R0cd8379eef694cb6"/>
           <a:srcRect xmlns:a="http://schemas.openxmlformats.org/drawingml/2006/main" l="0" t="15682" r="0" b="15682"/>
           <a:stretch xmlns:a="http://schemas.openxmlformats.org/drawingml/2006/main">
             <a:fillRect l="0" t="0" r="0" b="0"/>
@@ -11481,7 +11481,7 @@
           <p:cNvPr id="5" name="">
             <a:extLst xmlns:a="http://schemas.openxmlformats.org/drawingml/2006/main">
               <a:ext uri="{FF2B5EF4-FFF2-40B4-BE49-F238E27FC236}">
-                <a16:creationId xmlns:a16="http://schemas.microsoft.com/office/drawing/2014/main" id="{FB5AB50A-07C6-46A7-A08F-8BF76BA112BE}"/>
+                <a16:creationId xmlns:a16="http://schemas.microsoft.com/office/drawing/2014/main" id="{CA0ED506-5BA2-49DC-B685-C5050DA34796}"/>
               </a:ext>
             </a:extLst>
           </p:cNvPr>
@@ -11514,7 +11514,7 @@
           <p:cNvPr id="6" name="">
             <a:extLst xmlns:a="http://schemas.openxmlformats.org/drawingml/2006/main">
               <a:ext uri="{FF2B5EF4-FFF2-40B4-BE49-F238E27FC236}">
-                <a16:creationId xmlns:a16="http://schemas.microsoft.com/office/drawing/2014/main" id="{6448EED7-7AB0-4753-B603-D416611440A3}"/>
+                <a16:creationId xmlns:a16="http://schemas.microsoft.com/office/drawing/2014/main" id="{843F3824-A1DE-483B-B9FD-87C999AA899A}"/>
               </a:ext>
             </a:extLst>
           </p:cNvPr>
@@ -11545,7 +11545,7 @@
           <p:cNvPr id="7" name="">
             <a:extLst xmlns:a="http://schemas.openxmlformats.org/drawingml/2006/main">
               <a:ext uri="{FF2B5EF4-FFF2-40B4-BE49-F238E27FC236}">
-                <a16:creationId xmlns:a16="http://schemas.microsoft.com/office/drawing/2014/main" id="{D11FF9E8-284D-4294-8C34-3EAD602471B1}"/>
+                <a16:creationId xmlns:a16="http://schemas.microsoft.com/office/drawing/2014/main" id="{2DDA46F6-6291-4648-BEBD-F890FFC451F1}"/>
               </a:ext>
             </a:extLst>
           </p:cNvPr>
@@ -11607,7 +11607,7 @@
           <p:cNvPr id="8" name="">
             <a:extLst xmlns:a="http://schemas.openxmlformats.org/drawingml/2006/main">
               <a:ext uri="{FF2B5EF4-FFF2-40B4-BE49-F238E27FC236}">
-                <a16:creationId xmlns:a16="http://schemas.microsoft.com/office/drawing/2014/main" id="{B2F9EF93-5FAC-4020-95D9-26908E97D776}"/>
+                <a16:creationId xmlns:a16="http://schemas.microsoft.com/office/drawing/2014/main" id="{2B055987-E70D-4F1F-8BE9-13D153199845}"/>
               </a:ext>
             </a:extLst>
           </p:cNvPr>
@@ -11642,7 +11642,7 @@
           <p:cNvPr id="9" name="">
             <a:extLst xmlns:a="http://schemas.openxmlformats.org/drawingml/2006/main">
               <a:ext uri="{FF2B5EF4-FFF2-40B4-BE49-F238E27FC236}">
-                <a16:creationId xmlns:a16="http://schemas.microsoft.com/office/drawing/2014/main" id="{E2DE7E4D-E3BE-422F-AF0B-931FB2542595}"/>
+                <a16:creationId xmlns:a16="http://schemas.microsoft.com/office/drawing/2014/main" id="{CFE07CDB-2236-4B70-B3EB-B26C8A9AD1A0}"/>
               </a:ext>
             </a:extLst>
           </p:cNvPr>
@@ -11704,7 +11704,7 @@
           <p:cNvPr id="10" name="">
             <a:extLst xmlns:a="http://schemas.openxmlformats.org/drawingml/2006/main">
               <a:ext uri="{FF2B5EF4-FFF2-40B4-BE49-F238E27FC236}">
-                <a16:creationId xmlns:a16="http://schemas.microsoft.com/office/drawing/2014/main" id="{AD37EC6E-883E-4FF2-A4FE-AB526DD9B70C}"/>
+                <a16:creationId xmlns:a16="http://schemas.microsoft.com/office/drawing/2014/main" id="{7ECDD807-D114-4687-9ACB-C701F04E4517}"/>
               </a:ext>
             </a:extLst>
           </p:cNvPr>
@@ -11735,7 +11735,7 @@
           <p:cNvPr id="11" name="">
             <a:extLst xmlns:a="http://schemas.openxmlformats.org/drawingml/2006/main">
               <a:ext uri="{FF2B5EF4-FFF2-40B4-BE49-F238E27FC236}">
-                <a16:creationId xmlns:a16="http://schemas.microsoft.com/office/drawing/2014/main" id="{64C67C3B-4E77-43A3-896B-9011F9785B8B}"/>
+                <a16:creationId xmlns:a16="http://schemas.microsoft.com/office/drawing/2014/main" id="{5F1BD1DD-F399-438C-9E2F-EDBEB432117A}"/>
               </a:ext>
             </a:extLst>
           </p:cNvPr>
@@ -11797,7 +11797,7 @@
           <p:cNvPr id="12" name="">
             <a:extLst xmlns:a="http://schemas.openxmlformats.org/drawingml/2006/main">
               <a:ext uri="{FF2B5EF4-FFF2-40B4-BE49-F238E27FC236}">
-                <a16:creationId xmlns:a16="http://schemas.microsoft.com/office/drawing/2014/main" id="{22224937-9098-40E2-B7D9-FF9714BE5754}"/>
+                <a16:creationId xmlns:a16="http://schemas.microsoft.com/office/drawing/2014/main" id="{E35A3185-BFB0-49F9-8027-754F9C56B11A}"/>
               </a:ext>
             </a:extLst>
           </p:cNvPr>
@@ -11832,7 +11832,7 @@
           <p:cNvPr id="13" name="">
             <a:extLst xmlns:a="http://schemas.openxmlformats.org/drawingml/2006/main">
               <a:ext uri="{FF2B5EF4-FFF2-40B4-BE49-F238E27FC236}">
-                <a16:creationId xmlns:a16="http://schemas.microsoft.com/office/drawing/2014/main" id="{8FC41D42-8650-4824-9136-957F46E58E2A}"/>
+                <a16:creationId xmlns:a16="http://schemas.microsoft.com/office/drawing/2014/main" id="{5D71A341-FE33-4F07-9C67-51707C0CF583}"/>
               </a:ext>
             </a:extLst>
           </p:cNvPr>
@@ -11894,7 +11894,7 @@
           <p:cNvPr id="14" name="">
             <a:extLst xmlns:a="http://schemas.openxmlformats.org/drawingml/2006/main">
               <a:ext uri="{FF2B5EF4-FFF2-40B4-BE49-F238E27FC236}">
-                <a16:creationId xmlns:a16="http://schemas.microsoft.com/office/drawing/2014/main" id="{35D74737-B943-413D-90BC-CBFD58193AB8}"/>
+                <a16:creationId xmlns:a16="http://schemas.microsoft.com/office/drawing/2014/main" id="{910FC2DC-A458-4E9E-9DA0-D25D0762819B}"/>
               </a:ext>
             </a:extLst>
           </p:cNvPr>
@@ -11925,7 +11925,7 @@
           <p:cNvPr id="15" name="">
             <a:extLst xmlns:a="http://schemas.openxmlformats.org/drawingml/2006/main">
               <a:ext uri="{FF2B5EF4-FFF2-40B4-BE49-F238E27FC236}">
-                <a16:creationId xmlns:a16="http://schemas.microsoft.com/office/drawing/2014/main" id="{56D9AA6A-235C-4684-916A-FC465F9C548A}"/>
+                <a16:creationId xmlns:a16="http://schemas.microsoft.com/office/drawing/2014/main" id="{C010B08A-18ED-4BA6-BD2D-FB1545D27E97}"/>
               </a:ext>
             </a:extLst>
           </p:cNvPr>
@@ -11987,7 +11987,7 @@
           <p:cNvPr id="16" name="">
             <a:extLst xmlns:a="http://schemas.openxmlformats.org/drawingml/2006/main">
               <a:ext uri="{FF2B5EF4-FFF2-40B4-BE49-F238E27FC236}">
-                <a16:creationId xmlns:a16="http://schemas.microsoft.com/office/drawing/2014/main" id="{40CD9A91-1075-4D62-8642-78CF471E7446}"/>
+                <a16:creationId xmlns:a16="http://schemas.microsoft.com/office/drawing/2014/main" id="{57739DA4-8854-4B8D-9D2B-1C88867F58FC}"/>
               </a:ext>
             </a:extLst>
           </p:cNvPr>
@@ -12022,7 +12022,7 @@
           <p:cNvPr id="17" name="">
             <a:extLst xmlns:a="http://schemas.openxmlformats.org/drawingml/2006/main">
               <a:ext uri="{FF2B5EF4-FFF2-40B4-BE49-F238E27FC236}">
-                <a16:creationId xmlns:a16="http://schemas.microsoft.com/office/drawing/2014/main" id="{2019BECE-CBC7-4367-B02A-F08E456ACFD2}"/>
+                <a16:creationId xmlns:a16="http://schemas.microsoft.com/office/drawing/2014/main" id="{FADF725C-B07E-4AB0-8BD0-E5BBA64492C3}"/>
               </a:ext>
             </a:extLst>
           </p:cNvPr>
@@ -12084,7 +12084,7 @@
           <p:cNvPr id="18" name="">
             <a:extLst xmlns:a="http://schemas.openxmlformats.org/drawingml/2006/main">
               <a:ext uri="{FF2B5EF4-FFF2-40B4-BE49-F238E27FC236}">
-                <a16:creationId xmlns:a16="http://schemas.microsoft.com/office/drawing/2014/main" id="{778AAB4A-D23D-4499-A597-77A8E5FFE2B5}"/>
+                <a16:creationId xmlns:a16="http://schemas.microsoft.com/office/drawing/2014/main" id="{A81C33C8-62DB-4569-BFD7-8A85BCA90C87}"/>
               </a:ext>
             </a:extLst>
           </p:cNvPr>
@@ -12115,7 +12115,7 @@
           <p:cNvPr id="19" name="">
             <a:extLst xmlns:a="http://schemas.openxmlformats.org/drawingml/2006/main">
               <a:ext uri="{FF2B5EF4-FFF2-40B4-BE49-F238E27FC236}">
-                <a16:creationId xmlns:a16="http://schemas.microsoft.com/office/drawing/2014/main" id="{3ECF5261-5FCA-4424-A19D-F2E86E7018E1}"/>
+                <a16:creationId xmlns:a16="http://schemas.microsoft.com/office/drawing/2014/main" id="{872DA631-42A1-4457-96A5-CD7A17D1F7E7}"/>
               </a:ext>
             </a:extLst>
           </p:cNvPr>
@@ -12177,7 +12177,7 @@
           <p:cNvPr id="20" name="">
             <a:extLst xmlns:a="http://schemas.openxmlformats.org/drawingml/2006/main">
               <a:ext uri="{FF2B5EF4-FFF2-40B4-BE49-F238E27FC236}">
-                <a16:creationId xmlns:a16="http://schemas.microsoft.com/office/drawing/2014/main" id="{233027B2-064E-425D-A7C0-DCA6110FEDA2}"/>
+                <a16:creationId xmlns:a16="http://schemas.microsoft.com/office/drawing/2014/main" id="{9D29D5E8-ABA6-4E2C-8E87-7BBC1333D9AD}"/>
               </a:ext>
             </a:extLst>
           </p:cNvPr>
@@ -12237,7 +12237,7 @@
     </p:spTree>
     <p:extLst>
       <p:ext uri="{BB962C8B-B14F-4D97-AF65-F5344CB8AC3E}">
-        <p14:creationId xmlns:p14="http://schemas.microsoft.com/office/powerpoint/2010/main" val="1620183756"/>
+        <p14:creationId xmlns:p14="http://schemas.microsoft.com/office/powerpoint/2010/main" val="164077655"/>
       </p:ext>
     </p:extLst>
   </p:cSld>
@@ -12268,7 +12268,7 @@
           <p:cNvPr id="31" name="">
             <a:extLst xmlns:a="http://schemas.openxmlformats.org/drawingml/2006/main">
               <a:ext uri="{FF2B5EF4-FFF2-40B4-BE49-F238E27FC236}">
-                <a16:creationId xmlns:a16="http://schemas.microsoft.com/office/drawing/2014/main" id="{D525F3D2-E764-4C19-ABDD-FA2750AB6296}"/>
+                <a16:creationId xmlns:a16="http://schemas.microsoft.com/office/drawing/2014/main" id="{576E6C0C-77D3-4C29-864A-E7DB3E6BC1AA}"/>
               </a:ext>
             </a:extLst>
           </p:cNvPr>
@@ -12330,7 +12330,7 @@
                 <a:latin typeface="Arial"/>
                 <a:ea typeface="Arial"/>
                 <a:cs typeface="Arial"/>
-                <a:hlinkClick xmlns:r="http://schemas.openxmlformats.org/officeDocument/2006/relationships" r:id="R1de50d237d27480c"/>
+                <a:hlinkClick xmlns:r="http://schemas.openxmlformats.org/officeDocument/2006/relationships" r:id="R8d425478cc414217"/>
               </a:rPr>
               <a:t>https://github.com/qjmre23/Route2Zero</a:t>
             </a:r>
@@ -12353,7 +12353,7 @@
                 <a:latin typeface="Arial"/>
                 <a:ea typeface="Arial"/>
                 <a:cs typeface="Arial"/>
-                <a:hlinkClick xmlns:r="http://schemas.openxmlformats.org/officeDocument/2006/relationships" r:id="R7252fed34eed4f92"/>
+                <a:hlinkClick xmlns:r="http://schemas.openxmlformats.org/officeDocument/2006/relationships" r:id="R4318f29eeac045ba"/>
               </a:rPr>
               <a:t>https://route2zero.netlify.app/</a:t>
             </a:r>
@@ -12365,7 +12365,7 @@
           <p:cNvPr id="2" name="">
             <a:extLst xmlns:a="http://schemas.openxmlformats.org/drawingml/2006/main">
               <a:ext uri="{FF2B5EF4-FFF2-40B4-BE49-F238E27FC236}">
-                <a16:creationId xmlns:a16="http://schemas.microsoft.com/office/drawing/2014/main" id="{3E5CB07E-F574-4970-8086-A8FF7EB36DD1}"/>
+                <a16:creationId xmlns:a16="http://schemas.microsoft.com/office/drawing/2014/main" id="{0C9EB3A3-015B-452A-8A40-DF069802AEAA}"/>
               </a:ext>
             </a:extLst>
           </p:cNvPr>
@@ -12427,7 +12427,7 @@
           <p:cNvPr id="3" name="">
             <a:extLst xmlns:a="http://schemas.openxmlformats.org/drawingml/2006/main">
               <a:ext uri="{FF2B5EF4-FFF2-40B4-BE49-F238E27FC236}">
-                <a16:creationId xmlns:a16="http://schemas.microsoft.com/office/drawing/2014/main" id="{D3B93810-B546-4298-902F-9F8BD3391DDF}"/>
+                <a16:creationId xmlns:a16="http://schemas.microsoft.com/office/drawing/2014/main" id="{43D9A25D-7E0E-42F1-BB55-23B79A537F8B}"/>
               </a:ext>
             </a:extLst>
           </p:cNvPr>
@@ -12493,7 +12493,7 @@
           <p:nvPr/>
         </p:nvPicPr>
         <p:blipFill>
-          <a:blip xmlns:r="http://schemas.openxmlformats.org/officeDocument/2006/relationships" xmlns:a="http://schemas.openxmlformats.org/drawingml/2006/main" r:embed="Rad97727575914efd"/>
+          <a:blip xmlns:r="http://schemas.openxmlformats.org/officeDocument/2006/relationships" xmlns:a="http://schemas.openxmlformats.org/drawingml/2006/main" r:embed="Rc6573a0930f54657"/>
           <a:srcRect xmlns:a="http://schemas.openxmlformats.org/drawingml/2006/main" l="4095" t="0" r="4095" b="0"/>
           <a:stretch xmlns:a="http://schemas.openxmlformats.org/drawingml/2006/main">
             <a:fillRect l="0" t="0" r="0" b="0"/>
@@ -12516,7 +12516,7 @@
           <p:cNvPr id="5" name="">
             <a:extLst xmlns:a="http://schemas.openxmlformats.org/drawingml/2006/main">
               <a:ext uri="{FF2B5EF4-FFF2-40B4-BE49-F238E27FC236}">
-                <a16:creationId xmlns:a16="http://schemas.microsoft.com/office/drawing/2014/main" id="{E11F78A6-1BFE-486A-BF4F-D7BD680A7C7F}"/>
+                <a16:creationId xmlns:a16="http://schemas.microsoft.com/office/drawing/2014/main" id="{E189BD5E-AD85-49BE-9A99-0247B201D5AB}"/>
               </a:ext>
             </a:extLst>
           </p:cNvPr>
@@ -12549,7 +12549,7 @@
           <p:cNvPr id="6" name="">
             <a:extLst xmlns:a="http://schemas.openxmlformats.org/drawingml/2006/main">
               <a:ext uri="{FF2B5EF4-FFF2-40B4-BE49-F238E27FC236}">
-                <a16:creationId xmlns:a16="http://schemas.microsoft.com/office/drawing/2014/main" id="{A226B3C0-1909-4B79-9354-E0BE20148FEC}"/>
+                <a16:creationId xmlns:a16="http://schemas.microsoft.com/office/drawing/2014/main" id="{D1F4D95F-8EF8-49ED-B8A1-0BA1C0B19B82}"/>
               </a:ext>
             </a:extLst>
           </p:cNvPr>
@@ -12611,7 +12611,7 @@
           <p:cNvPr id="7" name="">
             <a:extLst xmlns:a="http://schemas.openxmlformats.org/drawingml/2006/main">
               <a:ext uri="{FF2B5EF4-FFF2-40B4-BE49-F238E27FC236}">
-                <a16:creationId xmlns:a16="http://schemas.microsoft.com/office/drawing/2014/main" id="{E153A1E6-2DFC-4960-AC49-574C855A4546}"/>
+                <a16:creationId xmlns:a16="http://schemas.microsoft.com/office/drawing/2014/main" id="{AEF07AFD-59A5-4CB4-9BCF-9499FFE7E2C5}"/>
               </a:ext>
             </a:extLst>
           </p:cNvPr>
@@ -12673,7 +12673,7 @@
           <p:cNvPr id="8" name="">
             <a:extLst xmlns:a="http://schemas.openxmlformats.org/drawingml/2006/main">
               <a:ext uri="{FF2B5EF4-FFF2-40B4-BE49-F238E27FC236}">
-                <a16:creationId xmlns:a16="http://schemas.microsoft.com/office/drawing/2014/main" id="{D3BC039B-37F3-4B87-85EA-F134EAED5531}"/>
+                <a16:creationId xmlns:a16="http://schemas.microsoft.com/office/drawing/2014/main" id="{E72D50E8-4599-4021-A323-1651B6F47E2F}"/>
               </a:ext>
             </a:extLst>
           </p:cNvPr>
@@ -12704,7 +12704,7 @@
           <p:cNvPr id="9" name="">
             <a:extLst xmlns:a="http://schemas.openxmlformats.org/drawingml/2006/main">
               <a:ext uri="{FF2B5EF4-FFF2-40B4-BE49-F238E27FC236}">
-                <a16:creationId xmlns:a16="http://schemas.microsoft.com/office/drawing/2014/main" id="{7AD69AAF-7E77-4036-BDE2-4983DB7D882F}"/>
+                <a16:creationId xmlns:a16="http://schemas.microsoft.com/office/drawing/2014/main" id="{04D1FBA4-1203-449E-ABEF-A478254282AF}"/>
               </a:ext>
             </a:extLst>
           </p:cNvPr>
@@ -12766,7 +12766,7 @@
           <p:cNvPr id="10" name="">
             <a:extLst xmlns:a="http://schemas.openxmlformats.org/drawingml/2006/main">
               <a:ext uri="{FF2B5EF4-FFF2-40B4-BE49-F238E27FC236}">
-                <a16:creationId xmlns:a16="http://schemas.microsoft.com/office/drawing/2014/main" id="{4DD770C3-9DE2-4FE0-8744-59FE6C1EE4BA}"/>
+                <a16:creationId xmlns:a16="http://schemas.microsoft.com/office/drawing/2014/main" id="{211CA387-E476-4AC6-8915-3B9C8FF54E20}"/>
               </a:ext>
             </a:extLst>
           </p:cNvPr>
@@ -12828,7 +12828,7 @@
           <p:cNvPr id="11" name="">
             <a:extLst xmlns:a="http://schemas.openxmlformats.org/drawingml/2006/main">
               <a:ext uri="{FF2B5EF4-FFF2-40B4-BE49-F238E27FC236}">
-                <a16:creationId xmlns:a16="http://schemas.microsoft.com/office/drawing/2014/main" id="{AD20C3C4-CFA0-41F0-8425-9E494755B77A}"/>
+                <a16:creationId xmlns:a16="http://schemas.microsoft.com/office/drawing/2014/main" id="{B04A20B5-1453-47C0-87AA-EF83DDB3514E}"/>
               </a:ext>
             </a:extLst>
           </p:cNvPr>
@@ -12859,7 +12859,7 @@
           <p:cNvPr id="12" name="">
             <a:extLst xmlns:a="http://schemas.openxmlformats.org/drawingml/2006/main">
               <a:ext uri="{FF2B5EF4-FFF2-40B4-BE49-F238E27FC236}">
-                <a16:creationId xmlns:a16="http://schemas.microsoft.com/office/drawing/2014/main" id="{C46902B3-51B8-4DC8-A10C-67EC507DD231}"/>
+                <a16:creationId xmlns:a16="http://schemas.microsoft.com/office/drawing/2014/main" id="{B614D05F-1548-44BB-AE9D-9C5315020EA3}"/>
               </a:ext>
             </a:extLst>
           </p:cNvPr>
@@ -12921,7 +12921,7 @@
           <p:cNvPr id="13" name="">
             <a:extLst xmlns:a="http://schemas.openxmlformats.org/drawingml/2006/main">
               <a:ext uri="{FF2B5EF4-FFF2-40B4-BE49-F238E27FC236}">
-                <a16:creationId xmlns:a16="http://schemas.microsoft.com/office/drawing/2014/main" id="{E04BC2D3-6B2C-4AB7-AFF6-EEC3A51931DD}"/>
+                <a16:creationId xmlns:a16="http://schemas.microsoft.com/office/drawing/2014/main" id="{473FFA85-937F-4A92-87FC-62BDFF910B4D}"/>
               </a:ext>
             </a:extLst>
           </p:cNvPr>
@@ -12983,7 +12983,7 @@
           <p:cNvPr id="14" name="">
             <a:extLst xmlns:a="http://schemas.openxmlformats.org/drawingml/2006/main">
               <a:ext uri="{FF2B5EF4-FFF2-40B4-BE49-F238E27FC236}">
-                <a16:creationId xmlns:a16="http://schemas.microsoft.com/office/drawing/2014/main" id="{2E50D6B2-CA89-4F94-9FE1-C324929AA834}"/>
+                <a16:creationId xmlns:a16="http://schemas.microsoft.com/office/drawing/2014/main" id="{26FC096E-06BE-4CD5-B77D-5ED94343B2CB}"/>
               </a:ext>
             </a:extLst>
           </p:cNvPr>
@@ -13014,7 +13014,7 @@
           <p:cNvPr id="15" name="">
             <a:extLst xmlns:a="http://schemas.openxmlformats.org/drawingml/2006/main">
               <a:ext uri="{FF2B5EF4-FFF2-40B4-BE49-F238E27FC236}">
-                <a16:creationId xmlns:a16="http://schemas.microsoft.com/office/drawing/2014/main" id="{5943B417-F187-427C-9EAE-B30D8C152AF0}"/>
+                <a16:creationId xmlns:a16="http://schemas.microsoft.com/office/drawing/2014/main" id="{E25348FA-88B7-4018-81F2-EA5D44A89803}"/>
               </a:ext>
             </a:extLst>
           </p:cNvPr>
@@ -13076,7 +13076,7 @@
           <p:cNvPr id="16" name="">
             <a:extLst xmlns:a="http://schemas.openxmlformats.org/drawingml/2006/main">
               <a:ext uri="{FF2B5EF4-FFF2-40B4-BE49-F238E27FC236}">
-                <a16:creationId xmlns:a16="http://schemas.microsoft.com/office/drawing/2014/main" id="{0D77702D-E577-48ED-B6A7-0DBAD09F58FD}"/>
+                <a16:creationId xmlns:a16="http://schemas.microsoft.com/office/drawing/2014/main" id="{F031B57F-ECD5-488C-9AC6-A07663F8903E}"/>
               </a:ext>
             </a:extLst>
           </p:cNvPr>
@@ -13138,7 +13138,7 @@
           <p:cNvPr id="17" name="">
             <a:extLst xmlns:a="http://schemas.openxmlformats.org/drawingml/2006/main">
               <a:ext uri="{FF2B5EF4-FFF2-40B4-BE49-F238E27FC236}">
-                <a16:creationId xmlns:a16="http://schemas.microsoft.com/office/drawing/2014/main" id="{7CE59BB3-7422-4500-9ADB-80995978B2D6}"/>
+                <a16:creationId xmlns:a16="http://schemas.microsoft.com/office/drawing/2014/main" id="{BF70B9FD-4967-4055-A472-1E454450DE24}"/>
               </a:ext>
             </a:extLst>
           </p:cNvPr>
@@ -13169,7 +13169,7 @@
           <p:cNvPr id="18" name="">
             <a:extLst xmlns:a="http://schemas.openxmlformats.org/drawingml/2006/main">
               <a:ext uri="{FF2B5EF4-FFF2-40B4-BE49-F238E27FC236}">
-                <a16:creationId xmlns:a16="http://schemas.microsoft.com/office/drawing/2014/main" id="{C435895A-15E9-45EC-B5CD-0174C323AF78}"/>
+                <a16:creationId xmlns:a16="http://schemas.microsoft.com/office/drawing/2014/main" id="{D5EE03D4-5F85-4A1C-97AC-486A8FEE4E85}"/>
               </a:ext>
             </a:extLst>
           </p:cNvPr>
@@ -13231,7 +13231,7 @@
           <p:cNvPr id="19" name="">
             <a:extLst xmlns:a="http://schemas.openxmlformats.org/drawingml/2006/main">
               <a:ext uri="{FF2B5EF4-FFF2-40B4-BE49-F238E27FC236}">
-                <a16:creationId xmlns:a16="http://schemas.microsoft.com/office/drawing/2014/main" id="{7A45831D-3692-4B0B-89BA-453B949C429D}"/>
+                <a16:creationId xmlns:a16="http://schemas.microsoft.com/office/drawing/2014/main" id="{CEC4611B-F56A-417E-9D6A-A272CE54872D}"/>
               </a:ext>
             </a:extLst>
           </p:cNvPr>
@@ -13293,7 +13293,7 @@
           <p:cNvPr id="20" name="">
             <a:extLst xmlns:a="http://schemas.openxmlformats.org/drawingml/2006/main">
               <a:ext uri="{FF2B5EF4-FFF2-40B4-BE49-F238E27FC236}">
-                <a16:creationId xmlns:a16="http://schemas.microsoft.com/office/drawing/2014/main" id="{0B874253-2C08-4EE8-8B62-8CDA4A13C489}"/>
+                <a16:creationId xmlns:a16="http://schemas.microsoft.com/office/drawing/2014/main" id="{7F7987CB-BE18-4403-A864-A5FE3B40AF9A}"/>
               </a:ext>
             </a:extLst>
           </p:cNvPr>
@@ -13324,7 +13324,7 @@
           <p:cNvPr id="21" name="">
             <a:extLst xmlns:a="http://schemas.openxmlformats.org/drawingml/2006/main">
               <a:ext uri="{FF2B5EF4-FFF2-40B4-BE49-F238E27FC236}">
-                <a16:creationId xmlns:a16="http://schemas.microsoft.com/office/drawing/2014/main" id="{16E3319C-70CC-454B-8D13-7C89E55F549E}"/>
+                <a16:creationId xmlns:a16="http://schemas.microsoft.com/office/drawing/2014/main" id="{9C5E4568-CFDB-4B5D-8706-E73C1AE34B28}"/>
               </a:ext>
             </a:extLst>
           </p:cNvPr>
@@ -13386,7 +13386,7 @@
           <p:cNvPr id="22" name="">
             <a:extLst xmlns:a="http://schemas.openxmlformats.org/drawingml/2006/main">
               <a:ext uri="{FF2B5EF4-FFF2-40B4-BE49-F238E27FC236}">
-                <a16:creationId xmlns:a16="http://schemas.microsoft.com/office/drawing/2014/main" id="{18F62179-05ED-45F3-BAE9-6139D6565CBD}"/>
+                <a16:creationId xmlns:a16="http://schemas.microsoft.com/office/drawing/2014/main" id="{A4A674BF-E609-4D7D-A5BB-F01A5104B94C}"/>
               </a:ext>
             </a:extLst>
           </p:cNvPr>
@@ -13448,7 +13448,7 @@
           <p:cNvPr id="23" name="">
             <a:extLst xmlns:a="http://schemas.openxmlformats.org/drawingml/2006/main">
               <a:ext uri="{FF2B5EF4-FFF2-40B4-BE49-F238E27FC236}">
-                <a16:creationId xmlns:a16="http://schemas.microsoft.com/office/drawing/2014/main" id="{16C754E4-0FB8-455C-8C6C-58902684D4A9}"/>
+                <a16:creationId xmlns:a16="http://schemas.microsoft.com/office/drawing/2014/main" id="{843A77AB-B852-49AF-B472-AC05450AA463}"/>
               </a:ext>
             </a:extLst>
           </p:cNvPr>
@@ -13479,7 +13479,7 @@
           <p:cNvPr id="24" name="">
             <a:extLst xmlns:a="http://schemas.openxmlformats.org/drawingml/2006/main">
               <a:ext uri="{FF2B5EF4-FFF2-40B4-BE49-F238E27FC236}">
-                <a16:creationId xmlns:a16="http://schemas.microsoft.com/office/drawing/2014/main" id="{F6EAFD89-97E5-422D-A77C-09ED87F9FFDB}"/>
+                <a16:creationId xmlns:a16="http://schemas.microsoft.com/office/drawing/2014/main" id="{DA065CDF-8DC7-416A-BEC3-34502E2EFB01}"/>
               </a:ext>
             </a:extLst>
           </p:cNvPr>
@@ -13541,7 +13541,7 @@
           <p:cNvPr id="25" name="">
             <a:extLst xmlns:a="http://schemas.openxmlformats.org/drawingml/2006/main">
               <a:ext uri="{FF2B5EF4-FFF2-40B4-BE49-F238E27FC236}">
-                <a16:creationId xmlns:a16="http://schemas.microsoft.com/office/drawing/2014/main" id="{F9906BC3-D327-4ED5-BD88-CBD303617198}"/>
+                <a16:creationId xmlns:a16="http://schemas.microsoft.com/office/drawing/2014/main" id="{D52A23A6-BFEC-4EFE-9AB5-87D5E6D53808}"/>
               </a:ext>
             </a:extLst>
           </p:cNvPr>
@@ -13603,7 +13603,7 @@
           <p:cNvPr id="26" name="">
             <a:extLst xmlns:a="http://schemas.openxmlformats.org/drawingml/2006/main">
               <a:ext uri="{FF2B5EF4-FFF2-40B4-BE49-F238E27FC236}">
-                <a16:creationId xmlns:a16="http://schemas.microsoft.com/office/drawing/2014/main" id="{FEA64C77-75C4-4796-90FC-CDC795409DE6}"/>
+                <a16:creationId xmlns:a16="http://schemas.microsoft.com/office/drawing/2014/main" id="{BE75802F-1341-47E4-8CC3-F706C51BEF56}"/>
               </a:ext>
             </a:extLst>
           </p:cNvPr>
@@ -13665,7 +13665,7 @@
           <p:cNvPr id="27" name="">
             <a:extLst xmlns:a="http://schemas.openxmlformats.org/drawingml/2006/main">
               <a:ext uri="{FF2B5EF4-FFF2-40B4-BE49-F238E27FC236}">
-                <a16:creationId xmlns:a16="http://schemas.microsoft.com/office/drawing/2014/main" id="{BA5E15B3-7D77-4D2C-A119-F44D12767E23}"/>
+                <a16:creationId xmlns:a16="http://schemas.microsoft.com/office/drawing/2014/main" id="{09537165-0A86-4CF7-8A27-E14D76E99E8B}"/>
               </a:ext>
             </a:extLst>
           </p:cNvPr>
@@ -13727,7 +13727,7 @@
           <p:cNvPr id="28" name="">
             <a:extLst xmlns:a="http://schemas.openxmlformats.org/drawingml/2006/main">
               <a:ext uri="{FF2B5EF4-FFF2-40B4-BE49-F238E27FC236}">
-                <a16:creationId xmlns:a16="http://schemas.microsoft.com/office/drawing/2014/main" id="{635D0464-3A11-430A-8B8D-707273195E30}"/>
+                <a16:creationId xmlns:a16="http://schemas.microsoft.com/office/drawing/2014/main" id="{977C63B4-62E2-41D5-80F7-D048DCE4C910}"/>
               </a:ext>
             </a:extLst>
           </p:cNvPr>
@@ -13758,7 +13758,7 @@
           <p:cNvPr id="29" name="">
             <a:extLst xmlns:a="http://schemas.openxmlformats.org/drawingml/2006/main">
               <a:ext uri="{FF2B5EF4-FFF2-40B4-BE49-F238E27FC236}">
-                <a16:creationId xmlns:a16="http://schemas.microsoft.com/office/drawing/2014/main" id="{83318DDC-9272-474D-A3E2-0215BD68FACE}"/>
+                <a16:creationId xmlns:a16="http://schemas.microsoft.com/office/drawing/2014/main" id="{FE2AE25A-3959-4BD3-93DE-39F7D551E60A}"/>
               </a:ext>
             </a:extLst>
           </p:cNvPr>
@@ -13820,7 +13820,7 @@
           <p:cNvPr id="30" name="">
             <a:extLst xmlns:a="http://schemas.openxmlformats.org/drawingml/2006/main">
               <a:ext uri="{FF2B5EF4-FFF2-40B4-BE49-F238E27FC236}">
-                <a16:creationId xmlns:a16="http://schemas.microsoft.com/office/drawing/2014/main" id="{360304F2-0B5D-4DD1-A10E-8813BB34EC07}"/>
+                <a16:creationId xmlns:a16="http://schemas.microsoft.com/office/drawing/2014/main" id="{29F27B68-7973-41AE-AB47-8F2125D9BEAE}"/>
               </a:ext>
             </a:extLst>
           </p:cNvPr>
@@ -13880,7 +13880,7 @@
     </p:spTree>
     <p:extLst>
       <p:ext uri="{BB962C8B-B14F-4D97-AF65-F5344CB8AC3E}">
-        <p14:creationId xmlns:p14="http://schemas.microsoft.com/office/powerpoint/2010/main" val="1197059605"/>
+        <p14:creationId xmlns:p14="http://schemas.microsoft.com/office/powerpoint/2010/main" val="2142259789"/>
       </p:ext>
     </p:extLst>
   </p:cSld>
@@ -13911,7 +13911,7 @@
           <p:cNvPr id="37" name="">
             <a:extLst xmlns:a="http://schemas.openxmlformats.org/drawingml/2006/main">
               <a:ext uri="{FF2B5EF4-FFF2-40B4-BE49-F238E27FC236}">
-                <a16:creationId xmlns:a16="http://schemas.microsoft.com/office/drawing/2014/main" id="{FF032895-E4AA-498C-A02D-F3FE16E27E8B}"/>
+                <a16:creationId xmlns:a16="http://schemas.microsoft.com/office/drawing/2014/main" id="{EA876BBF-DC27-4C0D-A943-6264F9D7C166}"/>
               </a:ext>
             </a:extLst>
           </p:cNvPr>
@@ -13973,7 +13973,7 @@
                 <a:latin typeface="Arial"/>
                 <a:ea typeface="Arial"/>
                 <a:cs typeface="Arial"/>
-                <a:hlinkClick xmlns:r="http://schemas.openxmlformats.org/officeDocument/2006/relationships" r:id="R8e66c87a2c7e4d0a"/>
+                <a:hlinkClick xmlns:r="http://schemas.openxmlformats.org/officeDocument/2006/relationships" r:id="R87accbf24c624032"/>
               </a:rPr>
               <a:t>https://github.com/qjmre23/Route2Zero</a:t>
             </a:r>
@@ -13996,7 +13996,7 @@
                 <a:latin typeface="Arial"/>
                 <a:ea typeface="Arial"/>
                 <a:cs typeface="Arial"/>
-                <a:hlinkClick xmlns:r="http://schemas.openxmlformats.org/officeDocument/2006/relationships" r:id="R55a12648fcf74dfc"/>
+                <a:hlinkClick xmlns:r="http://schemas.openxmlformats.org/officeDocument/2006/relationships" r:id="R43fcaec610394db8"/>
               </a:rPr>
               <a:t>https://route2zero.netlify.app/</a:t>
             </a:r>
@@ -14008,7 +14008,7 @@
           <p:cNvPr id="2" name="">
             <a:extLst xmlns:a="http://schemas.openxmlformats.org/drawingml/2006/main">
               <a:ext uri="{FF2B5EF4-FFF2-40B4-BE49-F238E27FC236}">
-                <a16:creationId xmlns:a16="http://schemas.microsoft.com/office/drawing/2014/main" id="{8ABAA050-997D-46EC-8916-402C17D5668B}"/>
+                <a16:creationId xmlns:a16="http://schemas.microsoft.com/office/drawing/2014/main" id="{0A6C4F35-A6C4-49EE-B50E-9223180EE019}"/>
               </a:ext>
             </a:extLst>
           </p:cNvPr>
@@ -14070,7 +14070,7 @@
           <p:cNvPr id="3" name="">
             <a:extLst xmlns:a="http://schemas.openxmlformats.org/drawingml/2006/main">
               <a:ext uri="{FF2B5EF4-FFF2-40B4-BE49-F238E27FC236}">
-                <a16:creationId xmlns:a16="http://schemas.microsoft.com/office/drawing/2014/main" id="{65A449C9-AB80-446D-8A0E-E66C9B63DE7C}"/>
+                <a16:creationId xmlns:a16="http://schemas.microsoft.com/office/drawing/2014/main" id="{EF03DC0F-9F0B-482A-BFCB-1542453ADC32}"/>
               </a:ext>
             </a:extLst>
           </p:cNvPr>
@@ -14132,7 +14132,7 @@
           <p:cNvPr id="4" name="">
             <a:extLst xmlns:a="http://schemas.openxmlformats.org/drawingml/2006/main">
               <a:ext uri="{FF2B5EF4-FFF2-40B4-BE49-F238E27FC236}">
-                <a16:creationId xmlns:a16="http://schemas.microsoft.com/office/drawing/2014/main" id="{D3118599-BE10-4E38-B729-C877FE9C17AD}"/>
+                <a16:creationId xmlns:a16="http://schemas.microsoft.com/office/drawing/2014/main" id="{7FF19135-9B2B-48EE-A751-7F9F7F5987CB}"/>
               </a:ext>
             </a:extLst>
           </p:cNvPr>
@@ -14194,7 +14194,7 @@
           <p:cNvPr id="5" name="">
             <a:extLst xmlns:a="http://schemas.openxmlformats.org/drawingml/2006/main">
               <a:ext uri="{FF2B5EF4-FFF2-40B4-BE49-F238E27FC236}">
-                <a16:creationId xmlns:a16="http://schemas.microsoft.com/office/drawing/2014/main" id="{55CA4108-3AC6-417E-BEE4-73176250335B}"/>
+                <a16:creationId xmlns:a16="http://schemas.microsoft.com/office/drawing/2014/main" id="{0E19DD89-6E00-4A41-A7CE-6E96D204D538}"/>
               </a:ext>
             </a:extLst>
           </p:cNvPr>
@@ -14225,7 +14225,7 @@
           <p:cNvPr id="6" name="">
             <a:extLst xmlns:a="http://schemas.openxmlformats.org/drawingml/2006/main">
               <a:ext uri="{FF2B5EF4-FFF2-40B4-BE49-F238E27FC236}">
-                <a16:creationId xmlns:a16="http://schemas.microsoft.com/office/drawing/2014/main" id="{125CC15A-1AE7-4782-8777-5C74325343D5}"/>
+                <a16:creationId xmlns:a16="http://schemas.microsoft.com/office/drawing/2014/main" id="{CCD3250B-B123-420C-871E-0BB73ED5FB64}"/>
               </a:ext>
             </a:extLst>
           </p:cNvPr>
@@ -14287,7 +14287,7 @@
           <p:cNvPr id="7" name="">
             <a:extLst xmlns:a="http://schemas.openxmlformats.org/drawingml/2006/main">
               <a:ext uri="{FF2B5EF4-FFF2-40B4-BE49-F238E27FC236}">
-                <a16:creationId xmlns:a16="http://schemas.microsoft.com/office/drawing/2014/main" id="{5696D128-BAC1-4D28-8264-A5B3CAEFF253}"/>
+                <a16:creationId xmlns:a16="http://schemas.microsoft.com/office/drawing/2014/main" id="{5BA7C016-DF2C-4406-A866-A1470C0D3645}"/>
               </a:ext>
             </a:extLst>
           </p:cNvPr>
@@ -14318,7 +14318,7 @@
           <p:cNvPr id="8" name="">
             <a:extLst xmlns:a="http://schemas.openxmlformats.org/drawingml/2006/main">
               <a:ext uri="{FF2B5EF4-FFF2-40B4-BE49-F238E27FC236}">
-                <a16:creationId xmlns:a16="http://schemas.microsoft.com/office/drawing/2014/main" id="{23D55950-76A3-41E9-8D2B-86B56E3A8754}"/>
+                <a16:creationId xmlns:a16="http://schemas.microsoft.com/office/drawing/2014/main" id="{19378EC4-5248-4B0C-AE93-89378CAAD506}"/>
               </a:ext>
             </a:extLst>
           </p:cNvPr>
@@ -14380,7 +14380,7 @@
           <p:cNvPr id="9" name="">
             <a:extLst xmlns:a="http://schemas.openxmlformats.org/drawingml/2006/main">
               <a:ext uri="{FF2B5EF4-FFF2-40B4-BE49-F238E27FC236}">
-                <a16:creationId xmlns:a16="http://schemas.microsoft.com/office/drawing/2014/main" id="{7C19A5D2-7846-4B79-9F59-233433A6D475}"/>
+                <a16:creationId xmlns:a16="http://schemas.microsoft.com/office/drawing/2014/main" id="{8D5D8561-7C2A-4426-877B-6BB31AB91C61}"/>
               </a:ext>
             </a:extLst>
           </p:cNvPr>
@@ -14411,7 +14411,7 @@
           <p:cNvPr id="10" name="">
             <a:extLst xmlns:a="http://schemas.openxmlformats.org/drawingml/2006/main">
               <a:ext uri="{FF2B5EF4-FFF2-40B4-BE49-F238E27FC236}">
-                <a16:creationId xmlns:a16="http://schemas.microsoft.com/office/drawing/2014/main" id="{F6C54A83-21A4-4A63-BA23-7A23D70156D4}"/>
+                <a16:creationId xmlns:a16="http://schemas.microsoft.com/office/drawing/2014/main" id="{CC515855-EA9D-4848-ADB6-547564D15E6D}"/>
               </a:ext>
             </a:extLst>
           </p:cNvPr>
@@ -14473,7 +14473,7 @@
           <p:cNvPr id="11" name="">
             <a:extLst xmlns:a="http://schemas.openxmlformats.org/drawingml/2006/main">
               <a:ext uri="{FF2B5EF4-FFF2-40B4-BE49-F238E27FC236}">
-                <a16:creationId xmlns:a16="http://schemas.microsoft.com/office/drawing/2014/main" id="{A8681221-3505-4845-B800-471DCCE80FA5}"/>
+                <a16:creationId xmlns:a16="http://schemas.microsoft.com/office/drawing/2014/main" id="{B98B3DFB-D858-4DE3-9761-0C8B6048F252}"/>
               </a:ext>
             </a:extLst>
           </p:cNvPr>
@@ -14504,7 +14504,7 @@
           <p:cNvPr id="12" name="">
             <a:extLst xmlns:a="http://schemas.openxmlformats.org/drawingml/2006/main">
               <a:ext uri="{FF2B5EF4-FFF2-40B4-BE49-F238E27FC236}">
-                <a16:creationId xmlns:a16="http://schemas.microsoft.com/office/drawing/2014/main" id="{5A0F58A0-E3C2-4E8F-9E7D-967D95CE8F99}"/>
+                <a16:creationId xmlns:a16="http://schemas.microsoft.com/office/drawing/2014/main" id="{6C361E91-FCEE-454E-8099-3384DD31DE1E}"/>
               </a:ext>
             </a:extLst>
           </p:cNvPr>
@@ -14566,7 +14566,7 @@
           <p:cNvPr id="13" name="">
             <a:extLst xmlns:a="http://schemas.openxmlformats.org/drawingml/2006/main">
               <a:ext uri="{FF2B5EF4-FFF2-40B4-BE49-F238E27FC236}">
-                <a16:creationId xmlns:a16="http://schemas.microsoft.com/office/drawing/2014/main" id="{019FE228-930C-4CDF-96D4-1C167417EFAD}"/>
+                <a16:creationId xmlns:a16="http://schemas.microsoft.com/office/drawing/2014/main" id="{BF069036-8189-4F1C-88C5-88ECC712CC0E}"/>
               </a:ext>
             </a:extLst>
           </p:cNvPr>
@@ -14597,7 +14597,7 @@
           <p:cNvPr id="14" name="">
             <a:extLst xmlns:a="http://schemas.openxmlformats.org/drawingml/2006/main">
               <a:ext uri="{FF2B5EF4-FFF2-40B4-BE49-F238E27FC236}">
-                <a16:creationId xmlns:a16="http://schemas.microsoft.com/office/drawing/2014/main" id="{4296928A-395E-4F30-A2A4-830FFC81AF66}"/>
+                <a16:creationId xmlns:a16="http://schemas.microsoft.com/office/drawing/2014/main" id="{9775E002-85AF-4D12-9B83-654F5A0BC77E}"/>
               </a:ext>
             </a:extLst>
           </p:cNvPr>
@@ -14659,7 +14659,7 @@
           <p:cNvPr id="15" name="">
             <a:extLst xmlns:a="http://schemas.openxmlformats.org/drawingml/2006/main">
               <a:ext uri="{FF2B5EF4-FFF2-40B4-BE49-F238E27FC236}">
-                <a16:creationId xmlns:a16="http://schemas.microsoft.com/office/drawing/2014/main" id="{E76D3F2A-F8E6-476A-A9E9-6727795E1172}"/>
+                <a16:creationId xmlns:a16="http://schemas.microsoft.com/office/drawing/2014/main" id="{3002414A-F8CB-4DBF-9C68-846CA728EF75}"/>
               </a:ext>
             </a:extLst>
           </p:cNvPr>
@@ -14690,7 +14690,7 @@
           <p:cNvPr id="16" name="">
             <a:extLst xmlns:a="http://schemas.openxmlformats.org/drawingml/2006/main">
               <a:ext uri="{FF2B5EF4-FFF2-40B4-BE49-F238E27FC236}">
-                <a16:creationId xmlns:a16="http://schemas.microsoft.com/office/drawing/2014/main" id="{F50D65C1-F5CC-42FA-AC52-DB8F5C74770A}"/>
+                <a16:creationId xmlns:a16="http://schemas.microsoft.com/office/drawing/2014/main" id="{19B601CE-6503-425E-9707-FE7F2D218E7B}"/>
               </a:ext>
             </a:extLst>
           </p:cNvPr>
@@ -14752,7 +14752,7 @@
           <p:cNvPr id="17" name="">
             <a:extLst xmlns:a="http://schemas.openxmlformats.org/drawingml/2006/main">
               <a:ext uri="{FF2B5EF4-FFF2-40B4-BE49-F238E27FC236}">
-                <a16:creationId xmlns:a16="http://schemas.microsoft.com/office/drawing/2014/main" id="{198B6D90-FE1D-41F5-893E-09185010F7E9}"/>
+                <a16:creationId xmlns:a16="http://schemas.microsoft.com/office/drawing/2014/main" id="{3A9DBD3F-A1A6-488A-BB77-4708C4800C6E}"/>
               </a:ext>
             </a:extLst>
           </p:cNvPr>
@@ -14783,7 +14783,7 @@
           <p:cNvPr id="18" name="">
             <a:extLst xmlns:a="http://schemas.openxmlformats.org/drawingml/2006/main">
               <a:ext uri="{FF2B5EF4-FFF2-40B4-BE49-F238E27FC236}">
-                <a16:creationId xmlns:a16="http://schemas.microsoft.com/office/drawing/2014/main" id="{4138962F-6AF6-4FCB-9122-C7A976F0B45C}"/>
+                <a16:creationId xmlns:a16="http://schemas.microsoft.com/office/drawing/2014/main" id="{FFCD2EDD-4ACD-4859-8B98-D04B122DFF89}"/>
               </a:ext>
             </a:extLst>
           </p:cNvPr>
@@ -14845,7 +14845,7 @@
           <p:cNvPr id="19" name="">
             <a:extLst xmlns:a="http://schemas.openxmlformats.org/drawingml/2006/main">
               <a:ext uri="{FF2B5EF4-FFF2-40B4-BE49-F238E27FC236}">
-                <a16:creationId xmlns:a16="http://schemas.microsoft.com/office/drawing/2014/main" id="{E342C5EA-6185-4EFE-9525-FF3B8A1AB655}"/>
+                <a16:creationId xmlns:a16="http://schemas.microsoft.com/office/drawing/2014/main" id="{B9EBA372-A0A5-4D04-89D1-5A6995A87554}"/>
               </a:ext>
             </a:extLst>
           </p:cNvPr>
@@ -14876,7 +14876,7 @@
           <p:cNvPr id="20" name="">
             <a:extLst xmlns:a="http://schemas.openxmlformats.org/drawingml/2006/main">
               <a:ext uri="{FF2B5EF4-FFF2-40B4-BE49-F238E27FC236}">
-                <a16:creationId xmlns:a16="http://schemas.microsoft.com/office/drawing/2014/main" id="{A1474AAE-1F21-4E9A-8F3F-2D2DB1C2593E}"/>
+                <a16:creationId xmlns:a16="http://schemas.microsoft.com/office/drawing/2014/main" id="{68194CA9-5487-4903-8384-8B03A8AC6C97}"/>
               </a:ext>
             </a:extLst>
           </p:cNvPr>
@@ -14938,7 +14938,7 @@
           <p:cNvPr id="21" name="">
             <a:extLst xmlns:a="http://schemas.openxmlformats.org/drawingml/2006/main">
               <a:ext uri="{FF2B5EF4-FFF2-40B4-BE49-F238E27FC236}">
-                <a16:creationId xmlns:a16="http://schemas.microsoft.com/office/drawing/2014/main" id="{BCA4498C-833E-4990-8995-3E3ED9A70EF2}"/>
+                <a16:creationId xmlns:a16="http://schemas.microsoft.com/office/drawing/2014/main" id="{28A7B68B-CA4F-4271-9015-B22A8691DB78}"/>
               </a:ext>
             </a:extLst>
           </p:cNvPr>
@@ -14969,7 +14969,7 @@
           <p:cNvPr id="22" name="">
             <a:extLst xmlns:a="http://schemas.openxmlformats.org/drawingml/2006/main">
               <a:ext uri="{FF2B5EF4-FFF2-40B4-BE49-F238E27FC236}">
-                <a16:creationId xmlns:a16="http://schemas.microsoft.com/office/drawing/2014/main" id="{D663AE87-F069-4B4A-82D7-C9C8CF2AC7D5}"/>
+                <a16:creationId xmlns:a16="http://schemas.microsoft.com/office/drawing/2014/main" id="{263BC526-B631-48A4-A923-801BBBA10EF0}"/>
               </a:ext>
             </a:extLst>
           </p:cNvPr>
@@ -15031,7 +15031,7 @@
           <p:cNvPr id="23" name="">
             <a:extLst xmlns:a="http://schemas.openxmlformats.org/drawingml/2006/main">
               <a:ext uri="{FF2B5EF4-FFF2-40B4-BE49-F238E27FC236}">
-                <a16:creationId xmlns:a16="http://schemas.microsoft.com/office/drawing/2014/main" id="{688AA637-637F-4CFD-9D8A-1C5EAF604F9B}"/>
+                <a16:creationId xmlns:a16="http://schemas.microsoft.com/office/drawing/2014/main" id="{7CC4274D-C7E9-4AF6-A3ED-39A51E592F21}"/>
               </a:ext>
             </a:extLst>
           </p:cNvPr>
@@ -15062,7 +15062,7 @@
           <p:cNvPr id="24" name="">
             <a:extLst xmlns:a="http://schemas.openxmlformats.org/drawingml/2006/main">
               <a:ext uri="{FF2B5EF4-FFF2-40B4-BE49-F238E27FC236}">
-                <a16:creationId xmlns:a16="http://schemas.microsoft.com/office/drawing/2014/main" id="{7B7D7DEB-15ED-4EBA-AD9F-E0DEE79189E7}"/>
+                <a16:creationId xmlns:a16="http://schemas.microsoft.com/office/drawing/2014/main" id="{DD5C0C1C-D9A9-4B1F-9F24-2F07FA7A6388}"/>
               </a:ext>
             </a:extLst>
           </p:cNvPr>
@@ -15124,7 +15124,7 @@
           <p:cNvPr id="25" name="">
             <a:extLst xmlns:a="http://schemas.openxmlformats.org/drawingml/2006/main">
               <a:ext uri="{FF2B5EF4-FFF2-40B4-BE49-F238E27FC236}">
-                <a16:creationId xmlns:a16="http://schemas.microsoft.com/office/drawing/2014/main" id="{98B6506B-4114-4458-A7B8-31E5B3DAE18E}"/>
+                <a16:creationId xmlns:a16="http://schemas.microsoft.com/office/drawing/2014/main" id="{59F67496-D24A-42D1-9C40-B57DDC30F1B9}"/>
               </a:ext>
             </a:extLst>
           </p:cNvPr>
@@ -15155,7 +15155,7 @@
           <p:cNvPr id="26" name="">
             <a:extLst xmlns:a="http://schemas.openxmlformats.org/drawingml/2006/main">
               <a:ext uri="{FF2B5EF4-FFF2-40B4-BE49-F238E27FC236}">
-                <a16:creationId xmlns:a16="http://schemas.microsoft.com/office/drawing/2014/main" id="{A38CB9B2-EA7D-4450-98EC-7E9DC22F78BC}"/>
+                <a16:creationId xmlns:a16="http://schemas.microsoft.com/office/drawing/2014/main" id="{C399267B-01FD-4262-8FDD-3448C2FDDBC6}"/>
               </a:ext>
             </a:extLst>
           </p:cNvPr>
@@ -15217,7 +15217,7 @@
           <p:cNvPr id="27" name="">
             <a:extLst xmlns:a="http://schemas.openxmlformats.org/drawingml/2006/main">
               <a:ext uri="{FF2B5EF4-FFF2-40B4-BE49-F238E27FC236}">
-                <a16:creationId xmlns:a16="http://schemas.microsoft.com/office/drawing/2014/main" id="{D4AEE78C-EFC8-43D1-A8CF-89E1B5FA3B3B}"/>
+                <a16:creationId xmlns:a16="http://schemas.microsoft.com/office/drawing/2014/main" id="{EF1B715C-44A3-4D3E-8707-45A66816169E}"/>
               </a:ext>
             </a:extLst>
           </p:cNvPr>
@@ -15248,7 +15248,7 @@
           <p:cNvPr id="28" name="">
             <a:extLst xmlns:a="http://schemas.openxmlformats.org/drawingml/2006/main">
               <a:ext uri="{FF2B5EF4-FFF2-40B4-BE49-F238E27FC236}">
-                <a16:creationId xmlns:a16="http://schemas.microsoft.com/office/drawing/2014/main" id="{AD9DEA03-01FC-42A0-89D6-864B16FB8879}"/>
+                <a16:creationId xmlns:a16="http://schemas.microsoft.com/office/drawing/2014/main" id="{B3675C41-2B7A-44DD-A713-2DD5FAD9F981}"/>
               </a:ext>
             </a:extLst>
           </p:cNvPr>
@@ -15310,7 +15310,7 @@
           <p:cNvPr id="29" name="">
             <a:extLst xmlns:a="http://schemas.openxmlformats.org/drawingml/2006/main">
               <a:ext uri="{FF2B5EF4-FFF2-40B4-BE49-F238E27FC236}">
-                <a16:creationId xmlns:a16="http://schemas.microsoft.com/office/drawing/2014/main" id="{E8C5F16A-A68F-4040-9E6E-567497029D93}"/>
+                <a16:creationId xmlns:a16="http://schemas.microsoft.com/office/drawing/2014/main" id="{46A4CD9B-F9FD-4569-A27D-00A376B62703}"/>
               </a:ext>
             </a:extLst>
           </p:cNvPr>
@@ -15341,7 +15341,7 @@
           <p:cNvPr id="30" name="">
             <a:extLst xmlns:a="http://schemas.openxmlformats.org/drawingml/2006/main">
               <a:ext uri="{FF2B5EF4-FFF2-40B4-BE49-F238E27FC236}">
-                <a16:creationId xmlns:a16="http://schemas.microsoft.com/office/drawing/2014/main" id="{7B4E265B-5198-4B11-A9E4-244E0F0D7047}"/>
+                <a16:creationId xmlns:a16="http://schemas.microsoft.com/office/drawing/2014/main" id="{8FD503D0-1C9B-4185-B35B-B99F56D5D185}"/>
               </a:ext>
             </a:extLst>
           </p:cNvPr>
@@ -15403,7 +15403,7 @@
           <p:cNvPr id="31" name="">
             <a:extLst xmlns:a="http://schemas.openxmlformats.org/drawingml/2006/main">
               <a:ext uri="{FF2B5EF4-FFF2-40B4-BE49-F238E27FC236}">
-                <a16:creationId xmlns:a16="http://schemas.microsoft.com/office/drawing/2014/main" id="{1E5D3D30-04F8-429E-AACA-38865802A7FE}"/>
+                <a16:creationId xmlns:a16="http://schemas.microsoft.com/office/drawing/2014/main" id="{07EA095F-469F-455D-A853-5012DA541F10}"/>
               </a:ext>
             </a:extLst>
           </p:cNvPr>
@@ -15465,7 +15465,7 @@
           <p:cNvPr id="32" name="">
             <a:extLst xmlns:a="http://schemas.openxmlformats.org/drawingml/2006/main">
               <a:ext uri="{FF2B5EF4-FFF2-40B4-BE49-F238E27FC236}">
-                <a16:creationId xmlns:a16="http://schemas.microsoft.com/office/drawing/2014/main" id="{593BE115-F2F0-4989-B3FD-86FBFC969CF2}"/>
+                <a16:creationId xmlns:a16="http://schemas.microsoft.com/office/drawing/2014/main" id="{7ABD1C22-019C-493B-8737-315D4354FABA}"/>
               </a:ext>
             </a:extLst>
           </p:cNvPr>
@@ -15498,7 +15498,7 @@
           <p:cNvPr id="33" name="">
             <a:extLst xmlns:a="http://schemas.openxmlformats.org/drawingml/2006/main">
               <a:ext uri="{FF2B5EF4-FFF2-40B4-BE49-F238E27FC236}">
-                <a16:creationId xmlns:a16="http://schemas.microsoft.com/office/drawing/2014/main" id="{2DC5A4FD-8908-4DDB-815D-9FB99AF32F33}"/>
+                <a16:creationId xmlns:a16="http://schemas.microsoft.com/office/drawing/2014/main" id="{75B172B2-5A1C-49A7-8375-38375299D9E8}"/>
               </a:ext>
             </a:extLst>
           </p:cNvPr>
@@ -15560,7 +15560,7 @@
           <p:cNvPr id="34" name="">
             <a:extLst xmlns:a="http://schemas.openxmlformats.org/drawingml/2006/main">
               <a:ext uri="{FF2B5EF4-FFF2-40B4-BE49-F238E27FC236}">
-                <a16:creationId xmlns:a16="http://schemas.microsoft.com/office/drawing/2014/main" id="{E5F408AF-7C59-4DC7-A3E9-29B282B744C9}"/>
+                <a16:creationId xmlns:a16="http://schemas.microsoft.com/office/drawing/2014/main" id="{0E055142-C137-456D-B6DD-4F6F4F308C5B}"/>
               </a:ext>
             </a:extLst>
           </p:cNvPr>
@@ -15591,7 +15591,7 @@
           <p:cNvPr id="35" name="">
             <a:extLst xmlns:a="http://schemas.openxmlformats.org/drawingml/2006/main">
               <a:ext uri="{FF2B5EF4-FFF2-40B4-BE49-F238E27FC236}">
-                <a16:creationId xmlns:a16="http://schemas.microsoft.com/office/drawing/2014/main" id="{10735DE0-44EB-4D22-8C17-C29C68160079}"/>
+                <a16:creationId xmlns:a16="http://schemas.microsoft.com/office/drawing/2014/main" id="{3AD01C8D-C8DA-47A9-8520-3EEBE986E0CA}"/>
               </a:ext>
             </a:extLst>
           </p:cNvPr>
@@ -15653,7 +15653,7 @@
           <p:cNvPr id="36" name="">
             <a:extLst xmlns:a="http://schemas.openxmlformats.org/drawingml/2006/main">
               <a:ext uri="{FF2B5EF4-FFF2-40B4-BE49-F238E27FC236}">
-                <a16:creationId xmlns:a16="http://schemas.microsoft.com/office/drawing/2014/main" id="{6E2A68B5-9045-435C-8ED9-8EEC7B3F5090}"/>
+                <a16:creationId xmlns:a16="http://schemas.microsoft.com/office/drawing/2014/main" id="{A1BA40A1-5300-4BD7-9D59-0840C4FDF5FF}"/>
               </a:ext>
             </a:extLst>
           </p:cNvPr>
@@ -15713,7 +15713,7 @@
     </p:spTree>
     <p:extLst>
       <p:ext uri="{BB962C8B-B14F-4D97-AF65-F5344CB8AC3E}">
-        <p14:creationId xmlns:p14="http://schemas.microsoft.com/office/powerpoint/2010/main" val="1390827338"/>
+        <p14:creationId xmlns:p14="http://schemas.microsoft.com/office/powerpoint/2010/main" val="1899987962"/>
       </p:ext>
     </p:extLst>
   </p:cSld>
@@ -15744,7 +15744,7 @@
           <p:cNvPr id="21" name="">
             <a:extLst xmlns:a="http://schemas.openxmlformats.org/drawingml/2006/main">
               <a:ext uri="{FF2B5EF4-FFF2-40B4-BE49-F238E27FC236}">
-                <a16:creationId xmlns:a16="http://schemas.microsoft.com/office/drawing/2014/main" id="{129492F6-7682-49F8-9D99-F163068F2C0A}"/>
+                <a16:creationId xmlns:a16="http://schemas.microsoft.com/office/drawing/2014/main" id="{947E133A-7A22-4E0D-8ACF-AF028DE1A55C}"/>
               </a:ext>
             </a:extLst>
           </p:cNvPr>
@@ -15806,7 +15806,7 @@
                 <a:latin typeface="Arial"/>
                 <a:ea typeface="Arial"/>
                 <a:cs typeface="Arial"/>
-                <a:hlinkClick xmlns:r="http://schemas.openxmlformats.org/officeDocument/2006/relationships" r:id="R2f95a511d8964732"/>
+                <a:hlinkClick xmlns:r="http://schemas.openxmlformats.org/officeDocument/2006/relationships" r:id="Re1b35128984f4de9"/>
               </a:rPr>
               <a:t>https://github.com/qjmre23/Route2Zero</a:t>
             </a:r>
@@ -15829,7 +15829,7 @@
                 <a:latin typeface="Arial"/>
                 <a:ea typeface="Arial"/>
                 <a:cs typeface="Arial"/>
-                <a:hlinkClick xmlns:r="http://schemas.openxmlformats.org/officeDocument/2006/relationships" r:id="R98be2ef8e4974488"/>
+                <a:hlinkClick xmlns:r="http://schemas.openxmlformats.org/officeDocument/2006/relationships" r:id="Rb5049cce517e40d7"/>
               </a:rPr>
               <a:t>https://route2zero.netlify.app/</a:t>
             </a:r>
@@ -15841,7 +15841,7 @@
           <p:cNvPr id="2" name="">
             <a:extLst xmlns:a="http://schemas.openxmlformats.org/drawingml/2006/main">
               <a:ext uri="{FF2B5EF4-FFF2-40B4-BE49-F238E27FC236}">
-                <a16:creationId xmlns:a16="http://schemas.microsoft.com/office/drawing/2014/main" id="{57A44D6A-C469-41A9-A809-7EBB9031C9C4}"/>
+                <a16:creationId xmlns:a16="http://schemas.microsoft.com/office/drawing/2014/main" id="{002AE995-CAD9-4866-AFAE-4775B307005E}"/>
               </a:ext>
             </a:extLst>
           </p:cNvPr>
@@ -15903,7 +15903,7 @@
           <p:cNvPr id="3" name="">
             <a:extLst xmlns:a="http://schemas.openxmlformats.org/drawingml/2006/main">
               <a:ext uri="{FF2B5EF4-FFF2-40B4-BE49-F238E27FC236}">
-                <a16:creationId xmlns:a16="http://schemas.microsoft.com/office/drawing/2014/main" id="{24254EC4-3AE1-40F9-8B8F-C253A0174EE9}"/>
+                <a16:creationId xmlns:a16="http://schemas.microsoft.com/office/drawing/2014/main" id="{0FA7E9B1-2A71-4A97-8B2F-8A4D3C7B47DE}"/>
               </a:ext>
             </a:extLst>
           </p:cNvPr>
@@ -15969,7 +15969,7 @@
           <p:nvPr/>
         </p:nvPicPr>
         <p:blipFill>
-          <a:blip xmlns:r="http://schemas.openxmlformats.org/officeDocument/2006/relationships" xmlns:a="http://schemas.openxmlformats.org/drawingml/2006/main" r:embed="R1346776189664d70"/>
+          <a:blip xmlns:r="http://schemas.openxmlformats.org/officeDocument/2006/relationships" xmlns:a="http://schemas.openxmlformats.org/drawingml/2006/main" r:embed="Rf0d923bb0ba94acd"/>
           <a:srcRect xmlns:a="http://schemas.openxmlformats.org/drawingml/2006/main" l="0" t="15682" r="0" b="15682"/>
           <a:stretch xmlns:a="http://schemas.openxmlformats.org/drawingml/2006/main">
             <a:fillRect l="0" t="0" r="0" b="0"/>
@@ -15992,7 +15992,7 @@
           <p:cNvPr id="5" name="">
             <a:extLst xmlns:a="http://schemas.openxmlformats.org/drawingml/2006/main">
               <a:ext uri="{FF2B5EF4-FFF2-40B4-BE49-F238E27FC236}">
-                <a16:creationId xmlns:a16="http://schemas.microsoft.com/office/drawing/2014/main" id="{50638FFA-76D9-44C0-9D1E-01901E3F5A00}"/>
+                <a16:creationId xmlns:a16="http://schemas.microsoft.com/office/drawing/2014/main" id="{A3A2903C-5737-486B-8506-B02228CA91E9}"/>
               </a:ext>
             </a:extLst>
           </p:cNvPr>
@@ -16025,7 +16025,7 @@
           <p:cNvPr id="6" name="">
             <a:extLst xmlns:a="http://schemas.openxmlformats.org/drawingml/2006/main">
               <a:ext uri="{FF2B5EF4-FFF2-40B4-BE49-F238E27FC236}">
-                <a16:creationId xmlns:a16="http://schemas.microsoft.com/office/drawing/2014/main" id="{BFBA8D4A-431D-41B8-B361-3A385ADDEE5E}"/>
+                <a16:creationId xmlns:a16="http://schemas.microsoft.com/office/drawing/2014/main" id="{FEA9E325-4D28-4C98-AEC9-732BEECE8722}"/>
               </a:ext>
             </a:extLst>
           </p:cNvPr>
@@ -16056,7 +16056,7 @@
           <p:cNvPr id="7" name="">
             <a:extLst xmlns:a="http://schemas.openxmlformats.org/drawingml/2006/main">
               <a:ext uri="{FF2B5EF4-FFF2-40B4-BE49-F238E27FC236}">
-                <a16:creationId xmlns:a16="http://schemas.microsoft.com/office/drawing/2014/main" id="{15D9C86A-879D-4F6F-A24A-BB5F0471FF3F}"/>
+                <a16:creationId xmlns:a16="http://schemas.microsoft.com/office/drawing/2014/main" id="{A0BB4BA9-9AA2-4853-AE44-B91167A95842}"/>
               </a:ext>
             </a:extLst>
           </p:cNvPr>
@@ -16118,7 +16118,7 @@
           <p:cNvPr id="8" name="">
             <a:extLst xmlns:a="http://schemas.openxmlformats.org/drawingml/2006/main">
               <a:ext uri="{FF2B5EF4-FFF2-40B4-BE49-F238E27FC236}">
-                <a16:creationId xmlns:a16="http://schemas.microsoft.com/office/drawing/2014/main" id="{5A1C6C1C-DDCA-4615-8589-D5C2EADC3851}"/>
+                <a16:creationId xmlns:a16="http://schemas.microsoft.com/office/drawing/2014/main" id="{709E2FF7-E8D2-482E-8207-2E880FC1F7C8}"/>
               </a:ext>
             </a:extLst>
           </p:cNvPr>
@@ -16153,7 +16153,7 @@
           <p:cNvPr id="9" name="">
             <a:extLst xmlns:a="http://schemas.openxmlformats.org/drawingml/2006/main">
               <a:ext uri="{FF2B5EF4-FFF2-40B4-BE49-F238E27FC236}">
-                <a16:creationId xmlns:a16="http://schemas.microsoft.com/office/drawing/2014/main" id="{6337047B-2E17-4ABA-BF65-3B499C9B6E0C}"/>
+                <a16:creationId xmlns:a16="http://schemas.microsoft.com/office/drawing/2014/main" id="{17A13D2C-EF25-4581-8BDC-F997BF325FF3}"/>
               </a:ext>
             </a:extLst>
           </p:cNvPr>
@@ -16215,7 +16215,7 @@
           <p:cNvPr id="10" name="">
             <a:extLst xmlns:a="http://schemas.openxmlformats.org/drawingml/2006/main">
               <a:ext uri="{FF2B5EF4-FFF2-40B4-BE49-F238E27FC236}">
-                <a16:creationId xmlns:a16="http://schemas.microsoft.com/office/drawing/2014/main" id="{C48E97B4-042B-4B42-B3A8-161EAE5D0ADC}"/>
+                <a16:creationId xmlns:a16="http://schemas.microsoft.com/office/drawing/2014/main" id="{DC6EBB9A-6218-4CE6-99BF-44A30E4AC230}"/>
               </a:ext>
             </a:extLst>
           </p:cNvPr>
@@ -16246,7 +16246,7 @@
           <p:cNvPr id="11" name="">
             <a:extLst xmlns:a="http://schemas.openxmlformats.org/drawingml/2006/main">
               <a:ext uri="{FF2B5EF4-FFF2-40B4-BE49-F238E27FC236}">
-                <a16:creationId xmlns:a16="http://schemas.microsoft.com/office/drawing/2014/main" id="{09034925-33F0-4D56-8829-81FC5F46D0FA}"/>
+                <a16:creationId xmlns:a16="http://schemas.microsoft.com/office/drawing/2014/main" id="{F7EE9DFC-B3A4-4E97-B39C-7D9FE7EBBC44}"/>
               </a:ext>
             </a:extLst>
           </p:cNvPr>
@@ -16308,7 +16308,7 @@
           <p:cNvPr id="12" name="">
             <a:extLst xmlns:a="http://schemas.openxmlformats.org/drawingml/2006/main">
               <a:ext uri="{FF2B5EF4-FFF2-40B4-BE49-F238E27FC236}">
-                <a16:creationId xmlns:a16="http://schemas.microsoft.com/office/drawing/2014/main" id="{3FCCB837-6E4A-49F7-A266-3F8A3EF5CF76}"/>
+                <a16:creationId xmlns:a16="http://schemas.microsoft.com/office/drawing/2014/main" id="{B7D271A7-C72D-4036-A11E-BCCB6961CB11}"/>
               </a:ext>
             </a:extLst>
           </p:cNvPr>
@@ -16343,7 +16343,7 @@
           <p:cNvPr id="13" name="">
             <a:extLst xmlns:a="http://schemas.openxmlformats.org/drawingml/2006/main">
               <a:ext uri="{FF2B5EF4-FFF2-40B4-BE49-F238E27FC236}">
-                <a16:creationId xmlns:a16="http://schemas.microsoft.com/office/drawing/2014/main" id="{12612497-65C9-47DD-8BA2-6926CFCE5ADF}"/>
+                <a16:creationId xmlns:a16="http://schemas.microsoft.com/office/drawing/2014/main" id="{444FD9EC-F01E-4CF3-84AB-2575D406ED7C}"/>
               </a:ext>
             </a:extLst>
           </p:cNvPr>
@@ -16405,7 +16405,7 @@
           <p:cNvPr id="14" name="">
             <a:extLst xmlns:a="http://schemas.openxmlformats.org/drawingml/2006/main">
               <a:ext uri="{FF2B5EF4-FFF2-40B4-BE49-F238E27FC236}">
-                <a16:creationId xmlns:a16="http://schemas.microsoft.com/office/drawing/2014/main" id="{2BD1D627-3E78-4A1D-84E5-506B5B896A87}"/>
+                <a16:creationId xmlns:a16="http://schemas.microsoft.com/office/drawing/2014/main" id="{02C427CE-0606-4EBE-989E-86AC4E97BDB2}"/>
               </a:ext>
             </a:extLst>
           </p:cNvPr>
@@ -16436,7 +16436,7 @@
           <p:cNvPr id="15" name="">
             <a:extLst xmlns:a="http://schemas.openxmlformats.org/drawingml/2006/main">
               <a:ext uri="{FF2B5EF4-FFF2-40B4-BE49-F238E27FC236}">
-                <a16:creationId xmlns:a16="http://schemas.microsoft.com/office/drawing/2014/main" id="{169A4B23-3C3E-4D9C-98A1-DFFBB9184049}"/>
+                <a16:creationId xmlns:a16="http://schemas.microsoft.com/office/drawing/2014/main" id="{459CDBD6-B4D3-4CC3-845B-ED9D7F4B961A}"/>
               </a:ext>
             </a:extLst>
           </p:cNvPr>
@@ -16498,7 +16498,7 @@
           <p:cNvPr id="16" name="">
             <a:extLst xmlns:a="http://schemas.openxmlformats.org/drawingml/2006/main">
               <a:ext uri="{FF2B5EF4-FFF2-40B4-BE49-F238E27FC236}">
-                <a16:creationId xmlns:a16="http://schemas.microsoft.com/office/drawing/2014/main" id="{7E3E771B-40B5-404D-9CCD-44AD8D7A9D42}"/>
+                <a16:creationId xmlns:a16="http://schemas.microsoft.com/office/drawing/2014/main" id="{ADF8DA8F-4D9F-4BD0-8417-11555BA08246}"/>
               </a:ext>
             </a:extLst>
           </p:cNvPr>
@@ -16533,7 +16533,7 @@
           <p:cNvPr id="17" name="">
             <a:extLst xmlns:a="http://schemas.openxmlformats.org/drawingml/2006/main">
               <a:ext uri="{FF2B5EF4-FFF2-40B4-BE49-F238E27FC236}">
-                <a16:creationId xmlns:a16="http://schemas.microsoft.com/office/drawing/2014/main" id="{861F40F2-B0D8-47E1-9D46-E71DAE1FAA30}"/>
+                <a16:creationId xmlns:a16="http://schemas.microsoft.com/office/drawing/2014/main" id="{9761972C-9AD7-4432-B56F-8413D8975930}"/>
               </a:ext>
             </a:extLst>
           </p:cNvPr>
@@ -16595,7 +16595,7 @@
           <p:cNvPr id="18" name="">
             <a:extLst xmlns:a="http://schemas.openxmlformats.org/drawingml/2006/main">
               <a:ext uri="{FF2B5EF4-FFF2-40B4-BE49-F238E27FC236}">
-                <a16:creationId xmlns:a16="http://schemas.microsoft.com/office/drawing/2014/main" id="{6744F369-C10F-4E83-894D-657DB756B5C9}"/>
+                <a16:creationId xmlns:a16="http://schemas.microsoft.com/office/drawing/2014/main" id="{6D4E3163-2894-4EDC-A4C4-514FD265E804}"/>
               </a:ext>
             </a:extLst>
           </p:cNvPr>
@@ -16626,7 +16626,7 @@
           <p:cNvPr id="19" name="">
             <a:extLst xmlns:a="http://schemas.openxmlformats.org/drawingml/2006/main">
               <a:ext uri="{FF2B5EF4-FFF2-40B4-BE49-F238E27FC236}">
-                <a16:creationId xmlns:a16="http://schemas.microsoft.com/office/drawing/2014/main" id="{CCE7E7CF-C476-4F7C-B653-84A4C6115C18}"/>
+                <a16:creationId xmlns:a16="http://schemas.microsoft.com/office/drawing/2014/main" id="{9A52BC6B-A641-4747-A10F-34ABDC34CEA1}"/>
               </a:ext>
             </a:extLst>
           </p:cNvPr>
@@ -16688,7 +16688,7 @@
           <p:cNvPr id="20" name="">
             <a:extLst xmlns:a="http://schemas.openxmlformats.org/drawingml/2006/main">
               <a:ext uri="{FF2B5EF4-FFF2-40B4-BE49-F238E27FC236}">
-                <a16:creationId xmlns:a16="http://schemas.microsoft.com/office/drawing/2014/main" id="{5B941FCE-DABB-4FAF-BA00-A2438572219C}"/>
+                <a16:creationId xmlns:a16="http://schemas.microsoft.com/office/drawing/2014/main" id="{2815B7A2-593A-43F7-BE3F-659F79BC431E}"/>
               </a:ext>
             </a:extLst>
           </p:cNvPr>
@@ -16748,7 +16748,7 @@
     </p:spTree>
     <p:extLst>
       <p:ext uri="{BB962C8B-B14F-4D97-AF65-F5344CB8AC3E}">
-        <p14:creationId xmlns:p14="http://schemas.microsoft.com/office/powerpoint/2010/main" val="1920008480"/>
+        <p14:creationId xmlns:p14="http://schemas.microsoft.com/office/powerpoint/2010/main" val="1963523672"/>
       </p:ext>
     </p:extLst>
   </p:cSld>
@@ -16779,7 +16779,7 @@
           <p:cNvPr id="21" name="">
             <a:extLst xmlns:a="http://schemas.openxmlformats.org/drawingml/2006/main">
               <a:ext uri="{FF2B5EF4-FFF2-40B4-BE49-F238E27FC236}">
-                <a16:creationId xmlns:a16="http://schemas.microsoft.com/office/drawing/2014/main" id="{26739F3C-AAA7-4BDB-8F53-5922E3BD3C68}"/>
+                <a16:creationId xmlns:a16="http://schemas.microsoft.com/office/drawing/2014/main" id="{6F8BEF90-EF59-4280-9A3E-4C5B1941E8E4}"/>
               </a:ext>
             </a:extLst>
           </p:cNvPr>
@@ -16841,7 +16841,7 @@
                 <a:latin typeface="Arial"/>
                 <a:ea typeface="Arial"/>
                 <a:cs typeface="Arial"/>
-                <a:hlinkClick xmlns:r="http://schemas.openxmlformats.org/officeDocument/2006/relationships" r:id="R5e8578cdbf014263"/>
+                <a:hlinkClick xmlns:r="http://schemas.openxmlformats.org/officeDocument/2006/relationships" r:id="R8b03dbd868774c28"/>
               </a:rPr>
               <a:t>https://github.com/qjmre23/Route2Zero</a:t>
             </a:r>
@@ -16864,7 +16864,7 @@
                 <a:latin typeface="Arial"/>
                 <a:ea typeface="Arial"/>
                 <a:cs typeface="Arial"/>
-                <a:hlinkClick xmlns:r="http://schemas.openxmlformats.org/officeDocument/2006/relationships" r:id="R044409e2a0d74794"/>
+                <a:hlinkClick xmlns:r="http://schemas.openxmlformats.org/officeDocument/2006/relationships" r:id="Rfcc04b3915f7458a"/>
               </a:rPr>
               <a:t>https://route2zero.netlify.app/</a:t>
             </a:r>
@@ -16876,7 +16876,7 @@
           <p:cNvPr id="2" name="">
             <a:extLst xmlns:a="http://schemas.openxmlformats.org/drawingml/2006/main">
               <a:ext uri="{FF2B5EF4-FFF2-40B4-BE49-F238E27FC236}">
-                <a16:creationId xmlns:a16="http://schemas.microsoft.com/office/drawing/2014/main" id="{1F0B0CD9-3888-44B4-B396-F46B5844A2BD}"/>
+                <a16:creationId xmlns:a16="http://schemas.microsoft.com/office/drawing/2014/main" id="{3F7D95D3-A9CA-45EC-AD15-1B11FA33BF3D}"/>
               </a:ext>
             </a:extLst>
           </p:cNvPr>
@@ -16938,7 +16938,7 @@
           <p:cNvPr id="3" name="">
             <a:extLst xmlns:a="http://schemas.openxmlformats.org/drawingml/2006/main">
               <a:ext uri="{FF2B5EF4-FFF2-40B4-BE49-F238E27FC236}">
-                <a16:creationId xmlns:a16="http://schemas.microsoft.com/office/drawing/2014/main" id="{953FC5B3-7469-402A-B98E-D27AE2622BE6}"/>
+                <a16:creationId xmlns:a16="http://schemas.microsoft.com/office/drawing/2014/main" id="{5B940C0D-96CA-4042-8E3E-E06F1F1CF854}"/>
               </a:ext>
             </a:extLst>
           </p:cNvPr>
@@ -17004,7 +17004,7 @@
           <p:nvPr/>
         </p:nvPicPr>
         <p:blipFill>
-          <a:blip xmlns:r="http://schemas.openxmlformats.org/officeDocument/2006/relationships" xmlns:a="http://schemas.openxmlformats.org/drawingml/2006/main" r:embed="R97c1c69b4c58469d"/>
+          <a:blip xmlns:r="http://schemas.openxmlformats.org/officeDocument/2006/relationships" xmlns:a="http://schemas.openxmlformats.org/drawingml/2006/main" r:embed="Rc43aa2c458284bfe"/>
           <a:srcRect xmlns:a="http://schemas.openxmlformats.org/drawingml/2006/main" l="0" t="15682" r="0" b="15682"/>
           <a:stretch xmlns:a="http://schemas.openxmlformats.org/drawingml/2006/main">
             <a:fillRect l="0" t="0" r="0" b="0"/>
@@ -17027,7 +17027,7 @@
           <p:cNvPr id="5" name="">
             <a:extLst xmlns:a="http://schemas.openxmlformats.org/drawingml/2006/main">
               <a:ext uri="{FF2B5EF4-FFF2-40B4-BE49-F238E27FC236}">
-                <a16:creationId xmlns:a16="http://schemas.microsoft.com/office/drawing/2014/main" id="{0B9206E1-E03E-4C3E-8C03-925076DDC860}"/>
+                <a16:creationId xmlns:a16="http://schemas.microsoft.com/office/drawing/2014/main" id="{5A452C52-6D70-46CD-A9AE-E5853864B659}"/>
               </a:ext>
             </a:extLst>
           </p:cNvPr>
@@ -17060,7 +17060,7 @@
           <p:cNvPr id="6" name="">
             <a:extLst xmlns:a="http://schemas.openxmlformats.org/drawingml/2006/main">
               <a:ext uri="{FF2B5EF4-FFF2-40B4-BE49-F238E27FC236}">
-                <a16:creationId xmlns:a16="http://schemas.microsoft.com/office/drawing/2014/main" id="{3B792E6C-17E2-43B5-BC0D-259B88C36FA0}"/>
+                <a16:creationId xmlns:a16="http://schemas.microsoft.com/office/drawing/2014/main" id="{889D6ED5-566A-4E39-8F82-CE97007A9CC7}"/>
               </a:ext>
             </a:extLst>
           </p:cNvPr>
@@ -17091,7 +17091,7 @@
           <p:cNvPr id="7" name="">
             <a:extLst xmlns:a="http://schemas.openxmlformats.org/drawingml/2006/main">
               <a:ext uri="{FF2B5EF4-FFF2-40B4-BE49-F238E27FC236}">
-                <a16:creationId xmlns:a16="http://schemas.microsoft.com/office/drawing/2014/main" id="{47602AF2-2EBF-4B97-A31D-F13771DBD19E}"/>
+                <a16:creationId xmlns:a16="http://schemas.microsoft.com/office/drawing/2014/main" id="{CA8FABC8-D76F-40B7-8749-F41A4709FDAD}"/>
               </a:ext>
             </a:extLst>
           </p:cNvPr>
@@ -17153,7 +17153,7 @@
           <p:cNvPr id="8" name="">
             <a:extLst xmlns:a="http://schemas.openxmlformats.org/drawingml/2006/main">
               <a:ext uri="{FF2B5EF4-FFF2-40B4-BE49-F238E27FC236}">
-                <a16:creationId xmlns:a16="http://schemas.microsoft.com/office/drawing/2014/main" id="{6C120A14-57D4-4C16-8DDC-58EBF13E50F5}"/>
+                <a16:creationId xmlns:a16="http://schemas.microsoft.com/office/drawing/2014/main" id="{1C7BE2F3-98C9-441D-A6D4-1B610D7AF210}"/>
               </a:ext>
             </a:extLst>
           </p:cNvPr>
@@ -17188,7 +17188,7 @@
           <p:cNvPr id="9" name="">
             <a:extLst xmlns:a="http://schemas.openxmlformats.org/drawingml/2006/main">
               <a:ext uri="{FF2B5EF4-FFF2-40B4-BE49-F238E27FC236}">
-                <a16:creationId xmlns:a16="http://schemas.microsoft.com/office/drawing/2014/main" id="{D2D259F4-C381-466A-A771-99BED67CB019}"/>
+                <a16:creationId xmlns:a16="http://schemas.microsoft.com/office/drawing/2014/main" id="{D236BF47-57BC-4572-8176-3FEBF06C26FE}"/>
               </a:ext>
             </a:extLst>
           </p:cNvPr>
@@ -17250,7 +17250,7 @@
           <p:cNvPr id="10" name="">
             <a:extLst xmlns:a="http://schemas.openxmlformats.org/drawingml/2006/main">
               <a:ext uri="{FF2B5EF4-FFF2-40B4-BE49-F238E27FC236}">
-                <a16:creationId xmlns:a16="http://schemas.microsoft.com/office/drawing/2014/main" id="{ACA6BB18-EF94-45FB-980A-A18EE34BC8FC}"/>
+                <a16:creationId xmlns:a16="http://schemas.microsoft.com/office/drawing/2014/main" id="{E9107AE7-8D68-4FE3-B320-AF116710252A}"/>
               </a:ext>
             </a:extLst>
           </p:cNvPr>
@@ -17281,7 +17281,7 @@
           <p:cNvPr id="11" name="">
             <a:extLst xmlns:a="http://schemas.openxmlformats.org/drawingml/2006/main">
               <a:ext uri="{FF2B5EF4-FFF2-40B4-BE49-F238E27FC236}">
-                <a16:creationId xmlns:a16="http://schemas.microsoft.com/office/drawing/2014/main" id="{950439A6-B937-4F35-82C8-0CD232648AD7}"/>
+                <a16:creationId xmlns:a16="http://schemas.microsoft.com/office/drawing/2014/main" id="{3809297D-B4B7-49B0-80C6-91D4DB1DF2BA}"/>
               </a:ext>
             </a:extLst>
           </p:cNvPr>
@@ -17343,7 +17343,7 @@
           <p:cNvPr id="12" name="">
             <a:extLst xmlns:a="http://schemas.openxmlformats.org/drawingml/2006/main">
               <a:ext uri="{FF2B5EF4-FFF2-40B4-BE49-F238E27FC236}">
-                <a16:creationId xmlns:a16="http://schemas.microsoft.com/office/drawing/2014/main" id="{DFA41867-7E3B-4860-816C-545E145E2D8E}"/>
+                <a16:creationId xmlns:a16="http://schemas.microsoft.com/office/drawing/2014/main" id="{F24508CD-EA26-4576-86E0-0906FBFA3753}"/>
               </a:ext>
             </a:extLst>
           </p:cNvPr>
@@ -17378,7 +17378,7 @@
           <p:cNvPr id="13" name="">
             <a:extLst xmlns:a="http://schemas.openxmlformats.org/drawingml/2006/main">
               <a:ext uri="{FF2B5EF4-FFF2-40B4-BE49-F238E27FC236}">
-                <a16:creationId xmlns:a16="http://schemas.microsoft.com/office/drawing/2014/main" id="{2C527B58-50F2-411F-A832-7653D254C5A8}"/>
+                <a16:creationId xmlns:a16="http://schemas.microsoft.com/office/drawing/2014/main" id="{2F8856BA-9BA0-4841-AB4E-0E62415D8E19}"/>
               </a:ext>
             </a:extLst>
           </p:cNvPr>
@@ -17440,7 +17440,7 @@
           <p:cNvPr id="14" name="">
             <a:extLst xmlns:a="http://schemas.openxmlformats.org/drawingml/2006/main">
               <a:ext uri="{FF2B5EF4-FFF2-40B4-BE49-F238E27FC236}">
-                <a16:creationId xmlns:a16="http://schemas.microsoft.com/office/drawing/2014/main" id="{FD1B3931-CAED-456E-957C-8A100234E104}"/>
+                <a16:creationId xmlns:a16="http://schemas.microsoft.com/office/drawing/2014/main" id="{AB0DE387-6B80-4105-9C1E-F8D1D0226B8A}"/>
               </a:ext>
             </a:extLst>
           </p:cNvPr>
@@ -17471,7 +17471,7 @@
           <p:cNvPr id="15" name="">
             <a:extLst xmlns:a="http://schemas.openxmlformats.org/drawingml/2006/main">
               <a:ext uri="{FF2B5EF4-FFF2-40B4-BE49-F238E27FC236}">
-                <a16:creationId xmlns:a16="http://schemas.microsoft.com/office/drawing/2014/main" id="{77F54574-8C41-49CC-935F-FF067FAD0C99}"/>
+                <a16:creationId xmlns:a16="http://schemas.microsoft.com/office/drawing/2014/main" id="{751CE5D6-65DD-4C4A-954E-119F47AFCDC1}"/>
               </a:ext>
             </a:extLst>
           </p:cNvPr>
@@ -17533,7 +17533,7 @@
           <p:cNvPr id="16" name="">
             <a:extLst xmlns:a="http://schemas.openxmlformats.org/drawingml/2006/main">
               <a:ext uri="{FF2B5EF4-FFF2-40B4-BE49-F238E27FC236}">
-                <a16:creationId xmlns:a16="http://schemas.microsoft.com/office/drawing/2014/main" id="{F17BF1C5-254D-4B45-9BDE-3D444ECE9087}"/>
+                <a16:creationId xmlns:a16="http://schemas.microsoft.com/office/drawing/2014/main" id="{604F0046-873A-48D2-A907-12F1E7E8B92C}"/>
               </a:ext>
             </a:extLst>
           </p:cNvPr>
@@ -17568,7 +17568,7 @@
           <p:cNvPr id="17" name="">
             <a:extLst xmlns:a="http://schemas.openxmlformats.org/drawingml/2006/main">
               <a:ext uri="{FF2B5EF4-FFF2-40B4-BE49-F238E27FC236}">
-                <a16:creationId xmlns:a16="http://schemas.microsoft.com/office/drawing/2014/main" id="{85025F02-A52B-4F23-AC75-F9A78E9D841C}"/>
+                <a16:creationId xmlns:a16="http://schemas.microsoft.com/office/drawing/2014/main" id="{0D40DA76-6A08-48D8-AA7A-48F3352D2DC2}"/>
               </a:ext>
             </a:extLst>
           </p:cNvPr>
@@ -17630,7 +17630,7 @@
           <p:cNvPr id="18" name="">
             <a:extLst xmlns:a="http://schemas.openxmlformats.org/drawingml/2006/main">
               <a:ext uri="{FF2B5EF4-FFF2-40B4-BE49-F238E27FC236}">
-                <a16:creationId xmlns:a16="http://schemas.microsoft.com/office/drawing/2014/main" id="{88B8B171-3692-46B7-B48F-277EE4F3791B}"/>
+                <a16:creationId xmlns:a16="http://schemas.microsoft.com/office/drawing/2014/main" id="{0F92D8F2-7B79-47AB-A154-7E449E2FD2DB}"/>
               </a:ext>
             </a:extLst>
           </p:cNvPr>
@@ -17661,7 +17661,7 @@
           <p:cNvPr id="19" name="">
             <a:extLst xmlns:a="http://schemas.openxmlformats.org/drawingml/2006/main">
               <a:ext uri="{FF2B5EF4-FFF2-40B4-BE49-F238E27FC236}">
-                <a16:creationId xmlns:a16="http://schemas.microsoft.com/office/drawing/2014/main" id="{7D3CBB00-C0B4-4744-A264-02628ECFF47E}"/>
+                <a16:creationId xmlns:a16="http://schemas.microsoft.com/office/drawing/2014/main" id="{6F115DCA-497F-4104-8064-41D05ABDAE44}"/>
               </a:ext>
             </a:extLst>
           </p:cNvPr>
@@ -17723,7 +17723,7 @@
           <p:cNvPr id="20" name="">
             <a:extLst xmlns:a="http://schemas.openxmlformats.org/drawingml/2006/main">
               <a:ext uri="{FF2B5EF4-FFF2-40B4-BE49-F238E27FC236}">
-                <a16:creationId xmlns:a16="http://schemas.microsoft.com/office/drawing/2014/main" id="{0CA0A3AA-95E8-40ED-BDFE-94329A73A3DB}"/>
+                <a16:creationId xmlns:a16="http://schemas.microsoft.com/office/drawing/2014/main" id="{5CB7A1D3-16A0-4870-BDC4-67C96F9ACA63}"/>
               </a:ext>
             </a:extLst>
           </p:cNvPr>
@@ -17783,7 +17783,7 @@
     </p:spTree>
     <p:extLst>
       <p:ext uri="{BB962C8B-B14F-4D97-AF65-F5344CB8AC3E}">
-        <p14:creationId xmlns:p14="http://schemas.microsoft.com/office/powerpoint/2010/main" val="1127813318"/>
+        <p14:creationId xmlns:p14="http://schemas.microsoft.com/office/powerpoint/2010/main" val="1187056773"/>
       </p:ext>
     </p:extLst>
   </p:cSld>
@@ -17814,7 +17814,7 @@
           <p:cNvPr id="21" name="">
             <a:extLst xmlns:a="http://schemas.openxmlformats.org/drawingml/2006/main">
               <a:ext uri="{FF2B5EF4-FFF2-40B4-BE49-F238E27FC236}">
-                <a16:creationId xmlns:a16="http://schemas.microsoft.com/office/drawing/2014/main" id="{AD6FD905-DA66-4783-A947-FA2507C71659}"/>
+                <a16:creationId xmlns:a16="http://schemas.microsoft.com/office/drawing/2014/main" id="{B9F1F2CF-96E1-450F-922E-00E2499A02FC}"/>
               </a:ext>
             </a:extLst>
           </p:cNvPr>
@@ -17876,7 +17876,7 @@
                 <a:latin typeface="Arial"/>
                 <a:ea typeface="Arial"/>
                 <a:cs typeface="Arial"/>
-                <a:hlinkClick xmlns:r="http://schemas.openxmlformats.org/officeDocument/2006/relationships" r:id="Ra454b9f95e3e40e8"/>
+                <a:hlinkClick xmlns:r="http://schemas.openxmlformats.org/officeDocument/2006/relationships" r:id="R384e8d82abc4454d"/>
               </a:rPr>
               <a:t>https://github.com/qjmre23/Route2Zero</a:t>
             </a:r>
@@ -17899,7 +17899,7 @@
                 <a:latin typeface="Arial"/>
                 <a:ea typeface="Arial"/>
                 <a:cs typeface="Arial"/>
-                <a:hlinkClick xmlns:r="http://schemas.openxmlformats.org/officeDocument/2006/relationships" r:id="Rc1c022a454a44ba1"/>
+                <a:hlinkClick xmlns:r="http://schemas.openxmlformats.org/officeDocument/2006/relationships" r:id="R905b66babfb94e4f"/>
               </a:rPr>
               <a:t>https://route2zero.netlify.app/</a:t>
             </a:r>
@@ -17911,7 +17911,7 @@
           <p:cNvPr id="2" name="">
             <a:extLst xmlns:a="http://schemas.openxmlformats.org/drawingml/2006/main">
               <a:ext uri="{FF2B5EF4-FFF2-40B4-BE49-F238E27FC236}">
-                <a16:creationId xmlns:a16="http://schemas.microsoft.com/office/drawing/2014/main" id="{63720D7F-8D9B-40C4-8F5D-A83D506F8135}"/>
+                <a16:creationId xmlns:a16="http://schemas.microsoft.com/office/drawing/2014/main" id="{D486A4EF-0C44-45A2-B74B-963AE22601BC}"/>
               </a:ext>
             </a:extLst>
           </p:cNvPr>
@@ -17973,7 +17973,7 @@
           <p:cNvPr id="3" name="">
             <a:extLst xmlns:a="http://schemas.openxmlformats.org/drawingml/2006/main">
               <a:ext uri="{FF2B5EF4-FFF2-40B4-BE49-F238E27FC236}">
-                <a16:creationId xmlns:a16="http://schemas.microsoft.com/office/drawing/2014/main" id="{0C484802-D568-4902-A0DC-3B39DAEA90AF}"/>
+                <a16:creationId xmlns:a16="http://schemas.microsoft.com/office/drawing/2014/main" id="{B7DA47B1-B9C1-4DB9-9898-649D62D1FD1D}"/>
               </a:ext>
             </a:extLst>
           </p:cNvPr>
@@ -18039,7 +18039,7 @@
           <p:nvPr/>
         </p:nvPicPr>
         <p:blipFill>
-          <a:blip xmlns:r="http://schemas.openxmlformats.org/officeDocument/2006/relationships" xmlns:a="http://schemas.openxmlformats.org/drawingml/2006/main" r:embed="R2c497cbf9475429b"/>
+          <a:blip xmlns:r="http://schemas.openxmlformats.org/officeDocument/2006/relationships" xmlns:a="http://schemas.openxmlformats.org/drawingml/2006/main" r:embed="R3a7546985197471b"/>
           <a:srcRect xmlns:a="http://schemas.openxmlformats.org/drawingml/2006/main" l="0" t="15682" r="0" b="15682"/>
           <a:stretch xmlns:a="http://schemas.openxmlformats.org/drawingml/2006/main">
             <a:fillRect l="0" t="0" r="0" b="0"/>
@@ -18062,7 +18062,7 @@
           <p:cNvPr id="5" name="">
             <a:extLst xmlns:a="http://schemas.openxmlformats.org/drawingml/2006/main">
               <a:ext uri="{FF2B5EF4-FFF2-40B4-BE49-F238E27FC236}">
-                <a16:creationId xmlns:a16="http://schemas.microsoft.com/office/drawing/2014/main" id="{4F709154-929B-4D4E-A2A4-2D123D48F0E5}"/>
+                <a16:creationId xmlns:a16="http://schemas.microsoft.com/office/drawing/2014/main" id="{CFD36956-67A5-49B2-85A4-D2035C5C6E90}"/>
               </a:ext>
             </a:extLst>
           </p:cNvPr>
@@ -18095,7 +18095,7 @@
           <p:cNvPr id="6" name="">
             <a:extLst xmlns:a="http://schemas.openxmlformats.org/drawingml/2006/main">
               <a:ext uri="{FF2B5EF4-FFF2-40B4-BE49-F238E27FC236}">
-                <a16:creationId xmlns:a16="http://schemas.microsoft.com/office/drawing/2014/main" id="{67AF5A36-3DBF-44DA-A1CF-A485FC8F9F09}"/>
+                <a16:creationId xmlns:a16="http://schemas.microsoft.com/office/drawing/2014/main" id="{7C77E36C-6972-4566-8EDC-648873B53D13}"/>
               </a:ext>
             </a:extLst>
           </p:cNvPr>
@@ -18126,7 +18126,7 @@
           <p:cNvPr id="7" name="">
             <a:extLst xmlns:a="http://schemas.openxmlformats.org/drawingml/2006/main">
               <a:ext uri="{FF2B5EF4-FFF2-40B4-BE49-F238E27FC236}">
-                <a16:creationId xmlns:a16="http://schemas.microsoft.com/office/drawing/2014/main" id="{5376EBB2-1753-4015-982E-85027C466576}"/>
+                <a16:creationId xmlns:a16="http://schemas.microsoft.com/office/drawing/2014/main" id="{7EA21808-DE34-4AB8-BDA1-2C9FEA8CE27D}"/>
               </a:ext>
             </a:extLst>
           </p:cNvPr>
@@ -18188,7 +18188,7 @@
           <p:cNvPr id="8" name="">
             <a:extLst xmlns:a="http://schemas.openxmlformats.org/drawingml/2006/main">
               <a:ext uri="{FF2B5EF4-FFF2-40B4-BE49-F238E27FC236}">
-                <a16:creationId xmlns:a16="http://schemas.microsoft.com/office/drawing/2014/main" id="{9B0DF665-B770-40D7-9117-641E324B0D1A}"/>
+                <a16:creationId xmlns:a16="http://schemas.microsoft.com/office/drawing/2014/main" id="{D29DB335-EA39-4B1C-972B-E2B96146AAD9}"/>
               </a:ext>
             </a:extLst>
           </p:cNvPr>
@@ -18223,7 +18223,7 @@
           <p:cNvPr id="9" name="">
             <a:extLst xmlns:a="http://schemas.openxmlformats.org/drawingml/2006/main">
               <a:ext uri="{FF2B5EF4-FFF2-40B4-BE49-F238E27FC236}">
-                <a16:creationId xmlns:a16="http://schemas.microsoft.com/office/drawing/2014/main" id="{6289F56E-7071-4648-84F0-BABED6BE699F}"/>
+                <a16:creationId xmlns:a16="http://schemas.microsoft.com/office/drawing/2014/main" id="{21421D96-B1B7-4FC8-B8CD-D1E10A985272}"/>
               </a:ext>
             </a:extLst>
           </p:cNvPr>
@@ -18285,7 +18285,7 @@
           <p:cNvPr id="10" name="">
             <a:extLst xmlns:a="http://schemas.openxmlformats.org/drawingml/2006/main">
               <a:ext uri="{FF2B5EF4-FFF2-40B4-BE49-F238E27FC236}">
-                <a16:creationId xmlns:a16="http://schemas.microsoft.com/office/drawing/2014/main" id="{20FDDCC7-7A1F-4271-97BC-E8E97104DBC8}"/>
+                <a16:creationId xmlns:a16="http://schemas.microsoft.com/office/drawing/2014/main" id="{AE21C170-B4BC-4FF1-8DEB-81A2F8F61310}"/>
               </a:ext>
             </a:extLst>
           </p:cNvPr>
@@ -18316,7 +18316,7 @@
           <p:cNvPr id="11" name="">
             <a:extLst xmlns:a="http://schemas.openxmlformats.org/drawingml/2006/main">
               <a:ext uri="{FF2B5EF4-FFF2-40B4-BE49-F238E27FC236}">
-                <a16:creationId xmlns:a16="http://schemas.microsoft.com/office/drawing/2014/main" id="{01AE05EE-D363-4461-90F3-C67FEB159DAD}"/>
+                <a16:creationId xmlns:a16="http://schemas.microsoft.com/office/drawing/2014/main" id="{F8CC04CD-3796-4982-9CF0-49E46C7A153E}"/>
               </a:ext>
             </a:extLst>
           </p:cNvPr>
@@ -18378,7 +18378,7 @@
           <p:cNvPr id="12" name="">
             <a:extLst xmlns:a="http://schemas.openxmlformats.org/drawingml/2006/main">
               <a:ext uri="{FF2B5EF4-FFF2-40B4-BE49-F238E27FC236}">
-                <a16:creationId xmlns:a16="http://schemas.microsoft.com/office/drawing/2014/main" id="{33A469B7-318C-4AC0-AE82-8DE3F4F829AC}"/>
+                <a16:creationId xmlns:a16="http://schemas.microsoft.com/office/drawing/2014/main" id="{CC42F45B-495B-4C84-AAE9-471480AD8E10}"/>
               </a:ext>
             </a:extLst>
           </p:cNvPr>
@@ -18413,7 +18413,7 @@
           <p:cNvPr id="13" name="">
             <a:extLst xmlns:a="http://schemas.openxmlformats.org/drawingml/2006/main">
               <a:ext uri="{FF2B5EF4-FFF2-40B4-BE49-F238E27FC236}">
-                <a16:creationId xmlns:a16="http://schemas.microsoft.com/office/drawing/2014/main" id="{6E78A877-6964-49DA-A230-42498DA9625F}"/>
+                <a16:creationId xmlns:a16="http://schemas.microsoft.com/office/drawing/2014/main" id="{3BA314D5-CC8B-47DD-8D29-3CB3D54D7DF6}"/>
               </a:ext>
             </a:extLst>
           </p:cNvPr>
@@ -18475,7 +18475,7 @@
           <p:cNvPr id="14" name="">
             <a:extLst xmlns:a="http://schemas.openxmlformats.org/drawingml/2006/main">
               <a:ext uri="{FF2B5EF4-FFF2-40B4-BE49-F238E27FC236}">
-                <a16:creationId xmlns:a16="http://schemas.microsoft.com/office/drawing/2014/main" id="{C12845ED-97E0-450A-AA84-A5B30BA0E3A3}"/>
+                <a16:creationId xmlns:a16="http://schemas.microsoft.com/office/drawing/2014/main" id="{53C4B8CB-4F82-416E-8C7F-B80AFC677DF6}"/>
               </a:ext>
             </a:extLst>
           </p:cNvPr>
@@ -18506,7 +18506,7 @@
           <p:cNvPr id="15" name="">
             <a:extLst xmlns:a="http://schemas.openxmlformats.org/drawingml/2006/main">
               <a:ext uri="{FF2B5EF4-FFF2-40B4-BE49-F238E27FC236}">
-                <a16:creationId xmlns:a16="http://schemas.microsoft.com/office/drawing/2014/main" id="{4A66A590-182E-42E5-9DA8-D28F1A07027A}"/>
+                <a16:creationId xmlns:a16="http://schemas.microsoft.com/office/drawing/2014/main" id="{E5EB763B-A72E-4375-858F-616F2CE1DB72}"/>
               </a:ext>
             </a:extLst>
           </p:cNvPr>
@@ -18568,7 +18568,7 @@
           <p:cNvPr id="16" name="">
             <a:extLst xmlns:a="http://schemas.openxmlformats.org/drawingml/2006/main">
               <a:ext uri="{FF2B5EF4-FFF2-40B4-BE49-F238E27FC236}">
-                <a16:creationId xmlns:a16="http://schemas.microsoft.com/office/drawing/2014/main" id="{677E7A66-203A-467C-ABF1-5E1816FC0D27}"/>
+                <a16:creationId xmlns:a16="http://schemas.microsoft.com/office/drawing/2014/main" id="{7401B7BB-34E5-4052-9798-3B0966E01CBF}"/>
               </a:ext>
             </a:extLst>
           </p:cNvPr>
@@ -18603,7 +18603,7 @@
           <p:cNvPr id="17" name="">
             <a:extLst xmlns:a="http://schemas.openxmlformats.org/drawingml/2006/main">
               <a:ext uri="{FF2B5EF4-FFF2-40B4-BE49-F238E27FC236}">
-                <a16:creationId xmlns:a16="http://schemas.microsoft.com/office/drawing/2014/main" id="{41A025D8-6005-46CB-B330-DC8B26789483}"/>
+                <a16:creationId xmlns:a16="http://schemas.microsoft.com/office/drawing/2014/main" id="{1878CD32-3D2B-4848-A454-7B40BCB61D96}"/>
               </a:ext>
             </a:extLst>
           </p:cNvPr>
@@ -18665,7 +18665,7 @@
           <p:cNvPr id="18" name="">
             <a:extLst xmlns:a="http://schemas.openxmlformats.org/drawingml/2006/main">
               <a:ext uri="{FF2B5EF4-FFF2-40B4-BE49-F238E27FC236}">
-                <a16:creationId xmlns:a16="http://schemas.microsoft.com/office/drawing/2014/main" id="{77582C5D-A290-4F62-AFF3-792B14663023}"/>
+                <a16:creationId xmlns:a16="http://schemas.microsoft.com/office/drawing/2014/main" id="{FF9B5A9C-21B8-4859-A6CC-B33335CCFACD}"/>
               </a:ext>
             </a:extLst>
           </p:cNvPr>
@@ -18696,7 +18696,7 @@
           <p:cNvPr id="19" name="">
             <a:extLst xmlns:a="http://schemas.openxmlformats.org/drawingml/2006/main">
               <a:ext uri="{FF2B5EF4-FFF2-40B4-BE49-F238E27FC236}">
-                <a16:creationId xmlns:a16="http://schemas.microsoft.com/office/drawing/2014/main" id="{B4B366DC-2BC6-43E4-8245-D6C5C67FD4EC}"/>
+                <a16:creationId xmlns:a16="http://schemas.microsoft.com/office/drawing/2014/main" id="{AB8B6F6B-87EF-4EBF-B3B8-828F508E09A7}"/>
               </a:ext>
             </a:extLst>
           </p:cNvPr>
@@ -18758,7 +18758,7 @@
           <p:cNvPr id="20" name="">
             <a:extLst xmlns:a="http://schemas.openxmlformats.org/drawingml/2006/main">
               <a:ext uri="{FF2B5EF4-FFF2-40B4-BE49-F238E27FC236}">
-                <a16:creationId xmlns:a16="http://schemas.microsoft.com/office/drawing/2014/main" id="{91DC556C-9631-44E2-A270-88A38FDF49BA}"/>
+                <a16:creationId xmlns:a16="http://schemas.microsoft.com/office/drawing/2014/main" id="{FCD5EB64-CACA-4616-A6A6-163C956AF55E}"/>
               </a:ext>
             </a:extLst>
           </p:cNvPr>
@@ -18818,7 +18818,7 @@
     </p:spTree>
     <p:extLst>
       <p:ext uri="{BB962C8B-B14F-4D97-AF65-F5344CB8AC3E}">
-        <p14:creationId xmlns:p14="http://schemas.microsoft.com/office/powerpoint/2010/main" val="954501906"/>
+        <p14:creationId xmlns:p14="http://schemas.microsoft.com/office/powerpoint/2010/main" val="905527819"/>
       </p:ext>
     </p:extLst>
   </p:cSld>
@@ -18849,7 +18849,7 @@
           <p:cNvPr id="17" name="">
             <a:extLst xmlns:a="http://schemas.openxmlformats.org/drawingml/2006/main">
               <a:ext uri="{FF2B5EF4-FFF2-40B4-BE49-F238E27FC236}">
-                <a16:creationId xmlns:a16="http://schemas.microsoft.com/office/drawing/2014/main" id="{08513D43-BC96-4086-BF45-0DDE97931A32}"/>
+                <a16:creationId xmlns:a16="http://schemas.microsoft.com/office/drawing/2014/main" id="{04401497-08D6-4E78-8296-7223F2781594}"/>
               </a:ext>
             </a:extLst>
           </p:cNvPr>
@@ -18911,7 +18911,7 @@
                 <a:latin typeface="Arial"/>
                 <a:ea typeface="Arial"/>
                 <a:cs typeface="Arial"/>
-                <a:hlinkClick xmlns:r="http://schemas.openxmlformats.org/officeDocument/2006/relationships" r:id="Rc0dc9fc2464c41d7"/>
+                <a:hlinkClick xmlns:r="http://schemas.openxmlformats.org/officeDocument/2006/relationships" r:id="Rcfb45744fdbb4910"/>
               </a:rPr>
               <a:t>https://github.com/qjmre23/Route2Zero</a:t>
             </a:r>
@@ -18934,7 +18934,7 @@
                 <a:latin typeface="Arial"/>
                 <a:ea typeface="Arial"/>
                 <a:cs typeface="Arial"/>
-                <a:hlinkClick xmlns:r="http://schemas.openxmlformats.org/officeDocument/2006/relationships" r:id="R85fb04dadd984088"/>
+                <a:hlinkClick xmlns:r="http://schemas.openxmlformats.org/officeDocument/2006/relationships" r:id="Rf4f8567e865d4613"/>
               </a:rPr>
               <a:t>https://route2zero.netlify.app/</a:t>
             </a:r>
@@ -18946,7 +18946,7 @@
           <p:cNvPr id="2" name="">
             <a:extLst xmlns:a="http://schemas.openxmlformats.org/drawingml/2006/main">
               <a:ext uri="{FF2B5EF4-FFF2-40B4-BE49-F238E27FC236}">
-                <a16:creationId xmlns:a16="http://schemas.microsoft.com/office/drawing/2014/main" id="{95F19019-2819-4709-9BA7-714D5EBED6F8}"/>
+                <a16:creationId xmlns:a16="http://schemas.microsoft.com/office/drawing/2014/main" id="{B1B3E68B-96F1-4005-87D0-ED284ADEBB64}"/>
               </a:ext>
             </a:extLst>
           </p:cNvPr>
@@ -19008,7 +19008,7 @@
           <p:cNvPr id="3" name="">
             <a:extLst xmlns:a="http://schemas.openxmlformats.org/drawingml/2006/main">
               <a:ext uri="{FF2B5EF4-FFF2-40B4-BE49-F238E27FC236}">
-                <a16:creationId xmlns:a16="http://schemas.microsoft.com/office/drawing/2014/main" id="{E0958DF7-44E8-404E-A694-A75ADDD3DD40}"/>
+                <a16:creationId xmlns:a16="http://schemas.microsoft.com/office/drawing/2014/main" id="{5CFB02CA-D222-4E64-941A-7583E7CED558}"/>
               </a:ext>
             </a:extLst>
           </p:cNvPr>
@@ -19074,7 +19074,7 @@
           <p:nvPr/>
         </p:nvPicPr>
         <p:blipFill>
-          <a:blip xmlns:r="http://schemas.openxmlformats.org/officeDocument/2006/relationships" xmlns:a="http://schemas.openxmlformats.org/drawingml/2006/main" r:embed="R6940568855044bd8"/>
+          <a:blip xmlns:r="http://schemas.openxmlformats.org/officeDocument/2006/relationships" xmlns:a="http://schemas.openxmlformats.org/drawingml/2006/main" r:embed="R28178e9609884fb0"/>
           <a:srcRect xmlns:a="http://schemas.openxmlformats.org/drawingml/2006/main" l="5016" t="0" r="5016" b="0"/>
           <a:stretch xmlns:a="http://schemas.openxmlformats.org/drawingml/2006/main">
             <a:fillRect l="0" t="0" r="0" b="0"/>
@@ -19097,7 +19097,7 @@
           <p:cNvPr id="5" name="">
             <a:extLst xmlns:a="http://schemas.openxmlformats.org/drawingml/2006/main">
               <a:ext uri="{FF2B5EF4-FFF2-40B4-BE49-F238E27FC236}">
-                <a16:creationId xmlns:a16="http://schemas.microsoft.com/office/drawing/2014/main" id="{A7A4A3CB-5DFE-4C46-AD31-2E58508F3294}"/>
+                <a16:creationId xmlns:a16="http://schemas.microsoft.com/office/drawing/2014/main" id="{B1DE471C-2EA4-4D52-87DC-C1C22A12419A}"/>
               </a:ext>
             </a:extLst>
           </p:cNvPr>
@@ -19137,7 +19137,7 @@
         </p:xfrm>
         <a:graphic xmlns:a="http://schemas.openxmlformats.org/drawingml/2006/main">
           <a:graphicData uri="http://schemas.openxmlformats.org/drawingml/2006/chart">
-            <c:chart xmlns:r="http://schemas.openxmlformats.org/officeDocument/2006/relationships" xmlns:c="http://schemas.openxmlformats.org/drawingml/2006/chart" r:id="R899890b68ef242c3"/>
+            <c:chart xmlns:r="http://schemas.openxmlformats.org/officeDocument/2006/relationships" xmlns:c="http://schemas.openxmlformats.org/drawingml/2006/chart" r:id="R04d7bae5dd794303"/>
           </a:graphicData>
         </a:graphic>
       </p:graphicFrame>
@@ -19146,7 +19146,7 @@
           <p:cNvPr id="7" name="">
             <a:extLst xmlns:a="http://schemas.openxmlformats.org/drawingml/2006/main">
               <a:ext uri="{FF2B5EF4-FFF2-40B4-BE49-F238E27FC236}">
-                <a16:creationId xmlns:a16="http://schemas.microsoft.com/office/drawing/2014/main" id="{6323C2C9-AF1A-4312-9A41-17B3771395B0}"/>
+                <a16:creationId xmlns:a16="http://schemas.microsoft.com/office/drawing/2014/main" id="{8781BFAA-F4C5-4FCB-9350-7E19842D9AF3}"/>
               </a:ext>
             </a:extLst>
           </p:cNvPr>
@@ -19208,7 +19208,7 @@
           <p:cNvPr id="8" name="">
             <a:extLst xmlns:a="http://schemas.openxmlformats.org/drawingml/2006/main">
               <a:ext uri="{FF2B5EF4-FFF2-40B4-BE49-F238E27FC236}">
-                <a16:creationId xmlns:a16="http://schemas.microsoft.com/office/drawing/2014/main" id="{D5597ED1-4225-4C7F-BC1E-28BF2B9ADC96}"/>
+                <a16:creationId xmlns:a16="http://schemas.microsoft.com/office/drawing/2014/main" id="{70DC4554-9457-4B50-966F-56E5706FABF3}"/>
               </a:ext>
             </a:extLst>
           </p:cNvPr>
@@ -19270,7 +19270,7 @@
           <p:cNvPr id="9" name="">
             <a:extLst xmlns:a="http://schemas.openxmlformats.org/drawingml/2006/main">
               <a:ext uri="{FF2B5EF4-FFF2-40B4-BE49-F238E27FC236}">
-                <a16:creationId xmlns:a16="http://schemas.microsoft.com/office/drawing/2014/main" id="{3AB57108-6153-4042-A025-3402227EFBA4}"/>
+                <a16:creationId xmlns:a16="http://schemas.microsoft.com/office/drawing/2014/main" id="{5A468C75-8BC0-4BA3-8D11-ACC63555DD69}"/>
               </a:ext>
             </a:extLst>
           </p:cNvPr>
@@ -19332,7 +19332,7 @@
           <p:cNvPr id="10" name="">
             <a:extLst xmlns:a="http://schemas.openxmlformats.org/drawingml/2006/main">
               <a:ext uri="{FF2B5EF4-FFF2-40B4-BE49-F238E27FC236}">
-                <a16:creationId xmlns:a16="http://schemas.microsoft.com/office/drawing/2014/main" id="{A26538E4-72F7-4422-B02A-394B59F17674}"/>
+                <a16:creationId xmlns:a16="http://schemas.microsoft.com/office/drawing/2014/main" id="{5D5CBE6E-AF6E-4737-850D-6FAF37112816}"/>
               </a:ext>
             </a:extLst>
           </p:cNvPr>
@@ -19365,7 +19365,7 @@
           <p:cNvPr id="11" name="">
             <a:extLst xmlns:a="http://schemas.openxmlformats.org/drawingml/2006/main">
               <a:ext uri="{FF2B5EF4-FFF2-40B4-BE49-F238E27FC236}">
-                <a16:creationId xmlns:a16="http://schemas.microsoft.com/office/drawing/2014/main" id="{C48DD0F5-542C-4304-ADE1-6BA340CED7B5}"/>
+                <a16:creationId xmlns:a16="http://schemas.microsoft.com/office/drawing/2014/main" id="{3983BE33-9067-4BC9-9F31-4543C53BA54F}"/>
               </a:ext>
             </a:extLst>
           </p:cNvPr>
@@ -19427,7 +19427,7 @@
           <p:cNvPr id="12" name="">
             <a:extLst xmlns:a="http://schemas.openxmlformats.org/drawingml/2006/main">
               <a:ext uri="{FF2B5EF4-FFF2-40B4-BE49-F238E27FC236}">
-                <a16:creationId xmlns:a16="http://schemas.microsoft.com/office/drawing/2014/main" id="{9C2EB36B-35A8-4BC5-8F3B-4A4A9386C20A}"/>
+                <a16:creationId xmlns:a16="http://schemas.microsoft.com/office/drawing/2014/main" id="{295372CF-1733-4541-A030-E47C413D6EAB}"/>
               </a:ext>
             </a:extLst>
           </p:cNvPr>
@@ -19460,7 +19460,7 @@
           <p:cNvPr id="13" name="">
             <a:extLst xmlns:a="http://schemas.openxmlformats.org/drawingml/2006/main">
               <a:ext uri="{FF2B5EF4-FFF2-40B4-BE49-F238E27FC236}">
-                <a16:creationId xmlns:a16="http://schemas.microsoft.com/office/drawing/2014/main" id="{110983E5-4D5D-4A8D-A104-323AA5F7D75B}"/>
+                <a16:creationId xmlns:a16="http://schemas.microsoft.com/office/drawing/2014/main" id="{732B754A-E035-4B3D-8944-F614B12A8A9A}"/>
               </a:ext>
             </a:extLst>
           </p:cNvPr>
@@ -19522,7 +19522,7 @@
           <p:cNvPr id="14" name="">
             <a:extLst xmlns:a="http://schemas.openxmlformats.org/drawingml/2006/main">
               <a:ext uri="{FF2B5EF4-FFF2-40B4-BE49-F238E27FC236}">
-                <a16:creationId xmlns:a16="http://schemas.microsoft.com/office/drawing/2014/main" id="{08D93A82-5939-4026-B114-A70FA183A9F2}"/>
+                <a16:creationId xmlns:a16="http://schemas.microsoft.com/office/drawing/2014/main" id="{6357C262-224A-44A0-A412-6F553A201115}"/>
               </a:ext>
             </a:extLst>
           </p:cNvPr>
@@ -19553,7 +19553,7 @@
           <p:cNvPr id="15" name="">
             <a:extLst xmlns:a="http://schemas.openxmlformats.org/drawingml/2006/main">
               <a:ext uri="{FF2B5EF4-FFF2-40B4-BE49-F238E27FC236}">
-                <a16:creationId xmlns:a16="http://schemas.microsoft.com/office/drawing/2014/main" id="{DE78BE23-B98F-4279-8CDC-B3A8E7FB1187}"/>
+                <a16:creationId xmlns:a16="http://schemas.microsoft.com/office/drawing/2014/main" id="{61E1763A-11AC-40E4-A33A-07B6837ABE6E}"/>
               </a:ext>
             </a:extLst>
           </p:cNvPr>
@@ -19615,7 +19615,7 @@
           <p:cNvPr id="16" name="">
             <a:extLst xmlns:a="http://schemas.openxmlformats.org/drawingml/2006/main">
               <a:ext uri="{FF2B5EF4-FFF2-40B4-BE49-F238E27FC236}">
-                <a16:creationId xmlns:a16="http://schemas.microsoft.com/office/drawing/2014/main" id="{9A09CA8E-122C-4BC6-97A6-3968F20A8CEF}"/>
+                <a16:creationId xmlns:a16="http://schemas.microsoft.com/office/drawing/2014/main" id="{0CDC739A-0562-4E8E-BE95-E07D56F698FF}"/>
               </a:ext>
             </a:extLst>
           </p:cNvPr>
@@ -19675,7 +19675,7 @@
     </p:spTree>
     <p:extLst>
       <p:ext uri="{BB962C8B-B14F-4D97-AF65-F5344CB8AC3E}">
-        <p14:creationId xmlns:p14="http://schemas.microsoft.com/office/powerpoint/2010/main" val="274697942"/>
+        <p14:creationId xmlns:p14="http://schemas.microsoft.com/office/powerpoint/2010/main" val="1152951150"/>
       </p:ext>
     </p:extLst>
   </p:cSld>
@@ -19706,7 +19706,7 @@
           <p:cNvPr id="21" name="">
             <a:extLst xmlns:a="http://schemas.openxmlformats.org/drawingml/2006/main">
               <a:ext uri="{FF2B5EF4-FFF2-40B4-BE49-F238E27FC236}">
-                <a16:creationId xmlns:a16="http://schemas.microsoft.com/office/drawing/2014/main" id="{3961020B-F679-4DB8-BD6A-5CAD59DCAB55}"/>
+                <a16:creationId xmlns:a16="http://schemas.microsoft.com/office/drawing/2014/main" id="{824ED814-E699-4193-BF13-9FB9B09457D7}"/>
               </a:ext>
             </a:extLst>
           </p:cNvPr>
@@ -19768,7 +19768,7 @@
                 <a:latin typeface="Arial"/>
                 <a:ea typeface="Arial"/>
                 <a:cs typeface="Arial"/>
-                <a:hlinkClick xmlns:r="http://schemas.openxmlformats.org/officeDocument/2006/relationships" r:id="R2a548ca2a85a4a4e"/>
+                <a:hlinkClick xmlns:r="http://schemas.openxmlformats.org/officeDocument/2006/relationships" r:id="Rc6e0685ea57d41bd"/>
               </a:rPr>
               <a:t>https://github.com/qjmre23/Route2Zero</a:t>
             </a:r>
@@ -19791,7 +19791,7 @@
                 <a:latin typeface="Arial"/>
                 <a:ea typeface="Arial"/>
                 <a:cs typeface="Arial"/>
-                <a:hlinkClick xmlns:r="http://schemas.openxmlformats.org/officeDocument/2006/relationships" r:id="R24ad57f1ed5d43fa"/>
+                <a:hlinkClick xmlns:r="http://schemas.openxmlformats.org/officeDocument/2006/relationships" r:id="R4eba4f0a16ad4c04"/>
               </a:rPr>
               <a:t>https://route2zero.netlify.app/</a:t>
             </a:r>
@@ -19803,7 +19803,7 @@
           <p:cNvPr id="2" name="">
             <a:extLst xmlns:a="http://schemas.openxmlformats.org/drawingml/2006/main">
               <a:ext uri="{FF2B5EF4-FFF2-40B4-BE49-F238E27FC236}">
-                <a16:creationId xmlns:a16="http://schemas.microsoft.com/office/drawing/2014/main" id="{65738D18-EE93-4F8A-9843-DAC2C60BDF26}"/>
+                <a16:creationId xmlns:a16="http://schemas.microsoft.com/office/drawing/2014/main" id="{843C7513-8112-443D-A063-60BC666468EA}"/>
               </a:ext>
             </a:extLst>
           </p:cNvPr>
@@ -19865,7 +19865,7 @@
           <p:cNvPr id="3" name="">
             <a:extLst xmlns:a="http://schemas.openxmlformats.org/drawingml/2006/main">
               <a:ext uri="{FF2B5EF4-FFF2-40B4-BE49-F238E27FC236}">
-                <a16:creationId xmlns:a16="http://schemas.microsoft.com/office/drawing/2014/main" id="{DB47DD70-D8D2-4E9D-BE3E-25C590A7FC8A}"/>
+                <a16:creationId xmlns:a16="http://schemas.microsoft.com/office/drawing/2014/main" id="{1FFCFF00-EB69-4ECC-967B-01E1874FCFA1}"/>
               </a:ext>
             </a:extLst>
           </p:cNvPr>
@@ -19931,7 +19931,7 @@
           <p:nvPr/>
         </p:nvPicPr>
         <p:blipFill>
-          <a:blip xmlns:r="http://schemas.openxmlformats.org/officeDocument/2006/relationships" xmlns:a="http://schemas.openxmlformats.org/drawingml/2006/main" r:embed="R35342a0362dc47fc"/>
+          <a:blip xmlns:r="http://schemas.openxmlformats.org/officeDocument/2006/relationships" xmlns:a="http://schemas.openxmlformats.org/drawingml/2006/main" r:embed="R6e8373a1a6f04b0c"/>
           <a:srcRect xmlns:a="http://schemas.openxmlformats.org/drawingml/2006/main" l="0" t="15682" r="0" b="15682"/>
           <a:stretch xmlns:a="http://schemas.openxmlformats.org/drawingml/2006/main">
             <a:fillRect l="0" t="0" r="0" b="0"/>
@@ -19954,7 +19954,7 @@
           <p:cNvPr id="5" name="">
             <a:extLst xmlns:a="http://schemas.openxmlformats.org/drawingml/2006/main">
               <a:ext uri="{FF2B5EF4-FFF2-40B4-BE49-F238E27FC236}">
-                <a16:creationId xmlns:a16="http://schemas.microsoft.com/office/drawing/2014/main" id="{44298CAB-43A4-49BC-9D6D-E8DC44E0A01A}"/>
+                <a16:creationId xmlns:a16="http://schemas.microsoft.com/office/drawing/2014/main" id="{F9D91490-1D01-458A-914C-4EC21A0996C2}"/>
               </a:ext>
             </a:extLst>
           </p:cNvPr>
@@ -19987,7 +19987,7 @@
           <p:cNvPr id="6" name="">
             <a:extLst xmlns:a="http://schemas.openxmlformats.org/drawingml/2006/main">
               <a:ext uri="{FF2B5EF4-FFF2-40B4-BE49-F238E27FC236}">
-                <a16:creationId xmlns:a16="http://schemas.microsoft.com/office/drawing/2014/main" id="{BFE8E0A3-310B-45DB-AD2D-84D5468D1300}"/>
+                <a16:creationId xmlns:a16="http://schemas.microsoft.com/office/drawing/2014/main" id="{E2044176-C99A-46EF-B4DD-BB63921F6410}"/>
               </a:ext>
             </a:extLst>
           </p:cNvPr>
@@ -20018,7 +20018,7 @@
           <p:cNvPr id="7" name="">
             <a:extLst xmlns:a="http://schemas.openxmlformats.org/drawingml/2006/main">
               <a:ext uri="{FF2B5EF4-FFF2-40B4-BE49-F238E27FC236}">
-                <a16:creationId xmlns:a16="http://schemas.microsoft.com/office/drawing/2014/main" id="{D8609D6A-7E28-4738-A66D-15F4A5911E8F}"/>
+                <a16:creationId xmlns:a16="http://schemas.microsoft.com/office/drawing/2014/main" id="{AA00A439-6FE7-4BB5-B1E7-7CA5E344F793}"/>
               </a:ext>
             </a:extLst>
           </p:cNvPr>
@@ -20080,7 +20080,7 @@
           <p:cNvPr id="8" name="">
             <a:extLst xmlns:a="http://schemas.openxmlformats.org/drawingml/2006/main">
               <a:ext uri="{FF2B5EF4-FFF2-40B4-BE49-F238E27FC236}">
-                <a16:creationId xmlns:a16="http://schemas.microsoft.com/office/drawing/2014/main" id="{D61F8F9D-4371-4439-8A35-23DA15EFC9CC}"/>
+                <a16:creationId xmlns:a16="http://schemas.microsoft.com/office/drawing/2014/main" id="{5F951712-291F-4C3D-B499-29DC7E1071BB}"/>
               </a:ext>
             </a:extLst>
           </p:cNvPr>
@@ -20115,7 +20115,7 @@
           <p:cNvPr id="9" name="">
             <a:extLst xmlns:a="http://schemas.openxmlformats.org/drawingml/2006/main">
               <a:ext uri="{FF2B5EF4-FFF2-40B4-BE49-F238E27FC236}">
-                <a16:creationId xmlns:a16="http://schemas.microsoft.com/office/drawing/2014/main" id="{6709DCC7-522D-4BB5-9DDB-8B2B0751D403}"/>
+                <a16:creationId xmlns:a16="http://schemas.microsoft.com/office/drawing/2014/main" id="{19833B4B-3453-4C9C-B17F-A47CDAF85D35}"/>
               </a:ext>
             </a:extLst>
           </p:cNvPr>
@@ -20177,7 +20177,7 @@
           <p:cNvPr id="10" name="">
             <a:extLst xmlns:a="http://schemas.openxmlformats.org/drawingml/2006/main">
               <a:ext uri="{FF2B5EF4-FFF2-40B4-BE49-F238E27FC236}">
-                <a16:creationId xmlns:a16="http://schemas.microsoft.com/office/drawing/2014/main" id="{41E2728D-C592-4031-A50F-D81F91A866B9}"/>
+                <a16:creationId xmlns:a16="http://schemas.microsoft.com/office/drawing/2014/main" id="{654176BE-4DD4-4F6F-8028-668E77FA266F}"/>
               </a:ext>
             </a:extLst>
           </p:cNvPr>
@@ -20208,7 +20208,7 @@
           <p:cNvPr id="11" name="">
             <a:extLst xmlns:a="http://schemas.openxmlformats.org/drawingml/2006/main">
               <a:ext uri="{FF2B5EF4-FFF2-40B4-BE49-F238E27FC236}">
-                <a16:creationId xmlns:a16="http://schemas.microsoft.com/office/drawing/2014/main" id="{9EA704FD-1EB6-44BF-A91B-E290853B8111}"/>
+                <a16:creationId xmlns:a16="http://schemas.microsoft.com/office/drawing/2014/main" id="{64594595-AE20-4457-8709-B541153C410B}"/>
               </a:ext>
             </a:extLst>
           </p:cNvPr>
@@ -20270,7 +20270,7 @@
           <p:cNvPr id="12" name="">
             <a:extLst xmlns:a="http://schemas.openxmlformats.org/drawingml/2006/main">
               <a:ext uri="{FF2B5EF4-FFF2-40B4-BE49-F238E27FC236}">
-                <a16:creationId xmlns:a16="http://schemas.microsoft.com/office/drawing/2014/main" id="{1404004C-AA9E-48BC-AA78-CAA4FA40B7C7}"/>
+                <a16:creationId xmlns:a16="http://schemas.microsoft.com/office/drawing/2014/main" id="{9AD7BC35-14E4-401D-AE00-27A546C5172A}"/>
               </a:ext>
             </a:extLst>
           </p:cNvPr>
@@ -20305,7 +20305,7 @@
           <p:cNvPr id="13" name="">
             <a:extLst xmlns:a="http://schemas.openxmlformats.org/drawingml/2006/main">
               <a:ext uri="{FF2B5EF4-FFF2-40B4-BE49-F238E27FC236}">
-                <a16:creationId xmlns:a16="http://schemas.microsoft.com/office/drawing/2014/main" id="{575986A1-1829-40FC-AAB3-3501A9BAEFEC}"/>
+                <a16:creationId xmlns:a16="http://schemas.microsoft.com/office/drawing/2014/main" id="{0B654666-CEFD-4474-AA39-9E2672C88EF9}"/>
               </a:ext>
             </a:extLst>
           </p:cNvPr>
@@ -20367,7 +20367,7 @@
           <p:cNvPr id="14" name="">
             <a:extLst xmlns:a="http://schemas.openxmlformats.org/drawingml/2006/main">
               <a:ext uri="{FF2B5EF4-FFF2-40B4-BE49-F238E27FC236}">
-                <a16:creationId xmlns:a16="http://schemas.microsoft.com/office/drawing/2014/main" id="{487575CD-4644-4749-BA62-289642796CBB}"/>
+                <a16:creationId xmlns:a16="http://schemas.microsoft.com/office/drawing/2014/main" id="{537E9F02-DFDD-4569-949D-8F87FE183DC7}"/>
               </a:ext>
             </a:extLst>
           </p:cNvPr>
@@ -20398,7 +20398,7 @@
           <p:cNvPr id="15" name="">
             <a:extLst xmlns:a="http://schemas.openxmlformats.org/drawingml/2006/main">
               <a:ext uri="{FF2B5EF4-FFF2-40B4-BE49-F238E27FC236}">
-                <a16:creationId xmlns:a16="http://schemas.microsoft.com/office/drawing/2014/main" id="{11C10E4F-146D-4543-AB58-D24C36C04FEB}"/>
+                <a16:creationId xmlns:a16="http://schemas.microsoft.com/office/drawing/2014/main" id="{0DDBE02D-F5B6-4BFB-8A7C-7DAC518EA75F}"/>
               </a:ext>
             </a:extLst>
           </p:cNvPr>
@@ -20460,7 +20460,7 @@
           <p:cNvPr id="16" name="">
             <a:extLst xmlns:a="http://schemas.openxmlformats.org/drawingml/2006/main">
               <a:ext uri="{FF2B5EF4-FFF2-40B4-BE49-F238E27FC236}">
-                <a16:creationId xmlns:a16="http://schemas.microsoft.com/office/drawing/2014/main" id="{FFA7BCDE-D844-4BAE-936A-D5FC30462EBF}"/>
+                <a16:creationId xmlns:a16="http://schemas.microsoft.com/office/drawing/2014/main" id="{6959121D-223A-4497-9F27-8CD7E7CBCC63}"/>
               </a:ext>
             </a:extLst>
           </p:cNvPr>
@@ -20495,7 +20495,7 @@
           <p:cNvPr id="17" name="">
             <a:extLst xmlns:a="http://schemas.openxmlformats.org/drawingml/2006/main">
               <a:ext uri="{FF2B5EF4-FFF2-40B4-BE49-F238E27FC236}">
-                <a16:creationId xmlns:a16="http://schemas.microsoft.com/office/drawing/2014/main" id="{B7752EC0-917F-434C-9748-CB5B994D7BC8}"/>
+                <a16:creationId xmlns:a16="http://schemas.microsoft.com/office/drawing/2014/main" id="{224FD608-0E31-4B22-A54C-F3397BCDD386}"/>
               </a:ext>
             </a:extLst>
           </p:cNvPr>
@@ -20557,7 +20557,7 @@
           <p:cNvPr id="18" name="">
             <a:extLst xmlns:a="http://schemas.openxmlformats.org/drawingml/2006/main">
               <a:ext uri="{FF2B5EF4-FFF2-40B4-BE49-F238E27FC236}">
-                <a16:creationId xmlns:a16="http://schemas.microsoft.com/office/drawing/2014/main" id="{F306B2F0-13BD-4959-8D82-B6D4591213A4}"/>
+                <a16:creationId xmlns:a16="http://schemas.microsoft.com/office/drawing/2014/main" id="{D5DB4140-3A28-49FE-9EF9-126A2E8FEE88}"/>
               </a:ext>
             </a:extLst>
           </p:cNvPr>
@@ -20588,7 +20588,7 @@
           <p:cNvPr id="19" name="">
             <a:extLst xmlns:a="http://schemas.openxmlformats.org/drawingml/2006/main">
               <a:ext uri="{FF2B5EF4-FFF2-40B4-BE49-F238E27FC236}">
-                <a16:creationId xmlns:a16="http://schemas.microsoft.com/office/drawing/2014/main" id="{39A3ADD7-B33F-4ECA-BE37-C3C412EA3645}"/>
+                <a16:creationId xmlns:a16="http://schemas.microsoft.com/office/drawing/2014/main" id="{803C6E56-6775-4D08-8155-68F4F0ED4C31}"/>
               </a:ext>
             </a:extLst>
           </p:cNvPr>
@@ -20650,7 +20650,7 @@
           <p:cNvPr id="20" name="">
             <a:extLst xmlns:a="http://schemas.openxmlformats.org/drawingml/2006/main">
               <a:ext uri="{FF2B5EF4-FFF2-40B4-BE49-F238E27FC236}">
-                <a16:creationId xmlns:a16="http://schemas.microsoft.com/office/drawing/2014/main" id="{7D056E0A-8380-4929-89C8-BDEDE1575C8F}"/>
+                <a16:creationId xmlns:a16="http://schemas.microsoft.com/office/drawing/2014/main" id="{65B3BD69-6D5D-41DD-9C70-17A69179C948}"/>
               </a:ext>
             </a:extLst>
           </p:cNvPr>
@@ -20710,7 +20710,7 @@
     </p:spTree>
     <p:extLst>
       <p:ext uri="{BB962C8B-B14F-4D97-AF65-F5344CB8AC3E}">
-        <p14:creationId xmlns:p14="http://schemas.microsoft.com/office/powerpoint/2010/main" val="1645645204"/>
+        <p14:creationId xmlns:p14="http://schemas.microsoft.com/office/powerpoint/2010/main" val="1404544069"/>
       </p:ext>
     </p:extLst>
   </p:cSld>
@@ -20741,7 +20741,7 @@
           <p:cNvPr id="21" name="">
             <a:extLst xmlns:a="http://schemas.openxmlformats.org/drawingml/2006/main">
               <a:ext uri="{FF2B5EF4-FFF2-40B4-BE49-F238E27FC236}">
-                <a16:creationId xmlns:a16="http://schemas.microsoft.com/office/drawing/2014/main" id="{44218676-072B-4CBD-BB31-014F48E0A06C}"/>
+                <a16:creationId xmlns:a16="http://schemas.microsoft.com/office/drawing/2014/main" id="{727B226E-AECF-4DCA-BA4B-EF2700053071}"/>
               </a:ext>
             </a:extLst>
           </p:cNvPr>
@@ -20803,7 +20803,7 @@
                 <a:latin typeface="Arial"/>
                 <a:ea typeface="Arial"/>
                 <a:cs typeface="Arial"/>
-                <a:hlinkClick xmlns:r="http://schemas.openxmlformats.org/officeDocument/2006/relationships" r:id="R99642d6859ac4903"/>
+                <a:hlinkClick xmlns:r="http://schemas.openxmlformats.org/officeDocument/2006/relationships" r:id="R51a92587da3540e9"/>
               </a:rPr>
               <a:t>https://github.com/qjmre23/Route2Zero</a:t>
             </a:r>
@@ -20826,7 +20826,7 @@
                 <a:latin typeface="Arial"/>
                 <a:ea typeface="Arial"/>
                 <a:cs typeface="Arial"/>
-                <a:hlinkClick xmlns:r="http://schemas.openxmlformats.org/officeDocument/2006/relationships" r:id="R056a70e73e6346ea"/>
+                <a:hlinkClick xmlns:r="http://schemas.openxmlformats.org/officeDocument/2006/relationships" r:id="R9a42f72467914007"/>
               </a:rPr>
               <a:t>https://route2zero.netlify.app/</a:t>
             </a:r>
@@ -20838,7 +20838,7 @@
           <p:cNvPr id="2" name="">
             <a:extLst xmlns:a="http://schemas.openxmlformats.org/drawingml/2006/main">
               <a:ext uri="{FF2B5EF4-FFF2-40B4-BE49-F238E27FC236}">
-                <a16:creationId xmlns:a16="http://schemas.microsoft.com/office/drawing/2014/main" id="{1C821107-21D5-49F4-B0E0-BE1F2F3CEC93}"/>
+                <a16:creationId xmlns:a16="http://schemas.microsoft.com/office/drawing/2014/main" id="{B45F5E92-7966-44BD-B669-C8D80F2FD185}"/>
               </a:ext>
             </a:extLst>
           </p:cNvPr>
@@ -20900,7 +20900,7 @@
           <p:cNvPr id="3" name="">
             <a:extLst xmlns:a="http://schemas.openxmlformats.org/drawingml/2006/main">
               <a:ext uri="{FF2B5EF4-FFF2-40B4-BE49-F238E27FC236}">
-                <a16:creationId xmlns:a16="http://schemas.microsoft.com/office/drawing/2014/main" id="{0AE54A01-F0A4-41DB-88E9-758C6C64FF78}"/>
+                <a16:creationId xmlns:a16="http://schemas.microsoft.com/office/drawing/2014/main" id="{2BF98ECB-B431-4D2C-991E-F0DD35344992}"/>
               </a:ext>
             </a:extLst>
           </p:cNvPr>
@@ -20966,7 +20966,7 @@
           <p:nvPr/>
         </p:nvPicPr>
         <p:blipFill>
-          <a:blip xmlns:r="http://schemas.openxmlformats.org/officeDocument/2006/relationships" xmlns:a="http://schemas.openxmlformats.org/drawingml/2006/main" r:embed="R84d0a5244b2b4836"/>
+          <a:blip xmlns:r="http://schemas.openxmlformats.org/officeDocument/2006/relationships" xmlns:a="http://schemas.openxmlformats.org/drawingml/2006/main" r:embed="R60ce76578e0344bd"/>
           <a:srcRect xmlns:a="http://schemas.openxmlformats.org/drawingml/2006/main" l="0" t="15682" r="0" b="15682"/>
           <a:stretch xmlns:a="http://schemas.openxmlformats.org/drawingml/2006/main">
             <a:fillRect l="0" t="0" r="0" b="0"/>
@@ -20989,7 +20989,7 @@
           <p:cNvPr id="5" name="">
             <a:extLst xmlns:a="http://schemas.openxmlformats.org/drawingml/2006/main">
               <a:ext uri="{FF2B5EF4-FFF2-40B4-BE49-F238E27FC236}">
-                <a16:creationId xmlns:a16="http://schemas.microsoft.com/office/drawing/2014/main" id="{57983AD8-7B59-49AE-B76C-37F6C231A176}"/>
+                <a16:creationId xmlns:a16="http://schemas.microsoft.com/office/drawing/2014/main" id="{2D78AEFC-4545-42D1-BA63-8C6EBAA248BF}"/>
               </a:ext>
             </a:extLst>
           </p:cNvPr>
@@ -21022,7 +21022,7 @@
           <p:cNvPr id="6" name="">
             <a:extLst xmlns:a="http://schemas.openxmlformats.org/drawingml/2006/main">
               <a:ext uri="{FF2B5EF4-FFF2-40B4-BE49-F238E27FC236}">
-                <a16:creationId xmlns:a16="http://schemas.microsoft.com/office/drawing/2014/main" id="{47BFBB56-5F8D-4EAA-83CC-421C302C200E}"/>
+                <a16:creationId xmlns:a16="http://schemas.microsoft.com/office/drawing/2014/main" id="{55694F7B-EEF0-4630-8A28-DB0725EFDFF5}"/>
               </a:ext>
             </a:extLst>
           </p:cNvPr>
@@ -21053,7 +21053,7 @@
           <p:cNvPr id="7" name="">
             <a:extLst xmlns:a="http://schemas.openxmlformats.org/drawingml/2006/main">
               <a:ext uri="{FF2B5EF4-FFF2-40B4-BE49-F238E27FC236}">
-                <a16:creationId xmlns:a16="http://schemas.microsoft.com/office/drawing/2014/main" id="{4A5DAE8E-A591-4746-85D0-B734E5BAC728}"/>
+                <a16:creationId xmlns:a16="http://schemas.microsoft.com/office/drawing/2014/main" id="{9F345525-95A6-44CA-A516-18BCA3218FFA}"/>
               </a:ext>
             </a:extLst>
           </p:cNvPr>
@@ -21115,7 +21115,7 @@
           <p:cNvPr id="8" name="">
             <a:extLst xmlns:a="http://schemas.openxmlformats.org/drawingml/2006/main">
               <a:ext uri="{FF2B5EF4-FFF2-40B4-BE49-F238E27FC236}">
-                <a16:creationId xmlns:a16="http://schemas.microsoft.com/office/drawing/2014/main" id="{430A20AF-A4C1-484C-924D-A8F553982495}"/>
+                <a16:creationId xmlns:a16="http://schemas.microsoft.com/office/drawing/2014/main" id="{071F5BB7-FE6C-4A70-B4C4-F796BBCCD0C2}"/>
               </a:ext>
             </a:extLst>
           </p:cNvPr>
@@ -21150,7 +21150,7 @@
           <p:cNvPr id="9" name="">
             <a:extLst xmlns:a="http://schemas.openxmlformats.org/drawingml/2006/main">
               <a:ext uri="{FF2B5EF4-FFF2-40B4-BE49-F238E27FC236}">
-                <a16:creationId xmlns:a16="http://schemas.microsoft.com/office/drawing/2014/main" id="{FBC07EC3-9E1A-402D-A895-978477C1FC25}"/>
+                <a16:creationId xmlns:a16="http://schemas.microsoft.com/office/drawing/2014/main" id="{D6BA062B-A329-466A-8F38-EB93E2AAF590}"/>
               </a:ext>
             </a:extLst>
           </p:cNvPr>
@@ -21212,7 +21212,7 @@
           <p:cNvPr id="10" name="">
             <a:extLst xmlns:a="http://schemas.openxmlformats.org/drawingml/2006/main">
               <a:ext uri="{FF2B5EF4-FFF2-40B4-BE49-F238E27FC236}">
-                <a16:creationId xmlns:a16="http://schemas.microsoft.com/office/drawing/2014/main" id="{B60D64E0-9B88-47DE-A459-302C79EDC904}"/>
+                <a16:creationId xmlns:a16="http://schemas.microsoft.com/office/drawing/2014/main" id="{538BF6BB-D9E0-4738-A87A-75A6AFD6FA8B}"/>
               </a:ext>
             </a:extLst>
           </p:cNvPr>
@@ -21243,7 +21243,7 @@
           <p:cNvPr id="11" name="">
             <a:extLst xmlns:a="http://schemas.openxmlformats.org/drawingml/2006/main">
               <a:ext uri="{FF2B5EF4-FFF2-40B4-BE49-F238E27FC236}">
-                <a16:creationId xmlns:a16="http://schemas.microsoft.com/office/drawing/2014/main" id="{CA08FD2D-DA89-484F-9B8F-7C26D171AFD2}"/>
+                <a16:creationId xmlns:a16="http://schemas.microsoft.com/office/drawing/2014/main" id="{111F4074-45C4-4623-868C-41C49C9FA30C}"/>
               </a:ext>
             </a:extLst>
           </p:cNvPr>
@@ -21305,7 +21305,7 @@
           <p:cNvPr id="12" name="">
             <a:extLst xmlns:a="http://schemas.openxmlformats.org/drawingml/2006/main">
               <a:ext uri="{FF2B5EF4-FFF2-40B4-BE49-F238E27FC236}">
-                <a16:creationId xmlns:a16="http://schemas.microsoft.com/office/drawing/2014/main" id="{D3E8B688-8DC4-4D3A-BD47-D2D232384D32}"/>
+                <a16:creationId xmlns:a16="http://schemas.microsoft.com/office/drawing/2014/main" id="{04059F54-6849-4AE9-B9BE-B4063EDDE43E}"/>
               </a:ext>
             </a:extLst>
           </p:cNvPr>
@@ -21340,7 +21340,7 @@
           <p:cNvPr id="13" name="">
             <a:extLst xmlns:a="http://schemas.openxmlformats.org/drawingml/2006/main">
               <a:ext uri="{FF2B5EF4-FFF2-40B4-BE49-F238E27FC236}">
-                <a16:creationId xmlns:a16="http://schemas.microsoft.com/office/drawing/2014/main" id="{74F5AB34-192C-4483-917A-27727BE2BBB6}"/>
+                <a16:creationId xmlns:a16="http://schemas.microsoft.com/office/drawing/2014/main" id="{B6DCA377-46BE-4828-A90D-3D64CC5DA036}"/>
               </a:ext>
             </a:extLst>
           </p:cNvPr>
@@ -21402,7 +21402,7 @@
           <p:cNvPr id="14" name="">
             <a:extLst xmlns:a="http://schemas.openxmlformats.org/drawingml/2006/main">
               <a:ext uri="{FF2B5EF4-FFF2-40B4-BE49-F238E27FC236}">
-                <a16:creationId xmlns:a16="http://schemas.microsoft.com/office/drawing/2014/main" id="{4B81963A-5389-440E-9A0F-FFF8D34A8298}"/>
+                <a16:creationId xmlns:a16="http://schemas.microsoft.com/office/drawing/2014/main" id="{230C791E-A998-46F7-A91E-2484A0ADBE6A}"/>
               </a:ext>
             </a:extLst>
           </p:cNvPr>
@@ -21433,7 +21433,7 @@
           <p:cNvPr id="15" name="">
             <a:extLst xmlns:a="http://schemas.openxmlformats.org/drawingml/2006/main">
               <a:ext uri="{FF2B5EF4-FFF2-40B4-BE49-F238E27FC236}">
-                <a16:creationId xmlns:a16="http://schemas.microsoft.com/office/drawing/2014/main" id="{CAAD2B3D-42CE-42D0-9283-D2BADEF4CF8E}"/>
+                <a16:creationId xmlns:a16="http://schemas.microsoft.com/office/drawing/2014/main" id="{24C315C4-1966-4349-A6DD-D78E575207F4}"/>
               </a:ext>
             </a:extLst>
           </p:cNvPr>
@@ -21495,7 +21495,7 @@
           <p:cNvPr id="16" name="">
             <a:extLst xmlns:a="http://schemas.openxmlformats.org/drawingml/2006/main">
               <a:ext uri="{FF2B5EF4-FFF2-40B4-BE49-F238E27FC236}">
-                <a16:creationId xmlns:a16="http://schemas.microsoft.com/office/drawing/2014/main" id="{331D12F5-DE49-40FF-B790-4050179B81FE}"/>
+                <a16:creationId xmlns:a16="http://schemas.microsoft.com/office/drawing/2014/main" id="{87E2EAD2-6E06-41B2-B117-8CA8B30EFD93}"/>
               </a:ext>
             </a:extLst>
           </p:cNvPr>
@@ -21530,7 +21530,7 @@
           <p:cNvPr id="17" name="">
             <a:extLst xmlns:a="http://schemas.openxmlformats.org/drawingml/2006/main">
               <a:ext uri="{FF2B5EF4-FFF2-40B4-BE49-F238E27FC236}">
-                <a16:creationId xmlns:a16="http://schemas.microsoft.com/office/drawing/2014/main" id="{E2AA0EFF-3D05-4EA0-B49B-D16B9996B211}"/>
+                <a16:creationId xmlns:a16="http://schemas.microsoft.com/office/drawing/2014/main" id="{97745C25-D8F0-4D16-8D79-FDE06D3A8FEA}"/>
               </a:ext>
             </a:extLst>
           </p:cNvPr>
@@ -21592,7 +21592,7 @@
           <p:cNvPr id="18" name="">
             <a:extLst xmlns:a="http://schemas.openxmlformats.org/drawingml/2006/main">
               <a:ext uri="{FF2B5EF4-FFF2-40B4-BE49-F238E27FC236}">
-                <a16:creationId xmlns:a16="http://schemas.microsoft.com/office/drawing/2014/main" id="{1CE69BC4-52B4-450C-9B78-F2785F622EB5}"/>
+                <a16:creationId xmlns:a16="http://schemas.microsoft.com/office/drawing/2014/main" id="{C47BFE72-EABE-43F5-9CD5-74A81309C371}"/>
               </a:ext>
             </a:extLst>
           </p:cNvPr>
@@ -21623,7 +21623,7 @@
           <p:cNvPr id="19" name="">
             <a:extLst xmlns:a="http://schemas.openxmlformats.org/drawingml/2006/main">
               <a:ext uri="{FF2B5EF4-FFF2-40B4-BE49-F238E27FC236}">
-                <a16:creationId xmlns:a16="http://schemas.microsoft.com/office/drawing/2014/main" id="{0F5AC1AD-2E85-4D53-A585-B3E244C52D10}"/>
+                <a16:creationId xmlns:a16="http://schemas.microsoft.com/office/drawing/2014/main" id="{FF7E9DB2-D3F9-4475-A6ED-E44BF83BAB0E}"/>
               </a:ext>
             </a:extLst>
           </p:cNvPr>
@@ -21685,7 +21685,7 @@
           <p:cNvPr id="20" name="">
             <a:extLst xmlns:a="http://schemas.openxmlformats.org/drawingml/2006/main">
               <a:ext uri="{FF2B5EF4-FFF2-40B4-BE49-F238E27FC236}">
-                <a16:creationId xmlns:a16="http://schemas.microsoft.com/office/drawing/2014/main" id="{0681C57D-8BC0-4DBA-8747-B4792DE9A8FD}"/>
+                <a16:creationId xmlns:a16="http://schemas.microsoft.com/office/drawing/2014/main" id="{7FCBCC09-D255-4320-A640-60E258A314A3}"/>
               </a:ext>
             </a:extLst>
           </p:cNvPr>
@@ -21745,7 +21745,7 @@
     </p:spTree>
     <p:extLst>
       <p:ext uri="{BB962C8B-B14F-4D97-AF65-F5344CB8AC3E}">
-        <p14:creationId xmlns:p14="http://schemas.microsoft.com/office/powerpoint/2010/main" val="695763126"/>
+        <p14:creationId xmlns:p14="http://schemas.microsoft.com/office/powerpoint/2010/main" val="1326317487"/>
       </p:ext>
     </p:extLst>
   </p:cSld>
@@ -21776,7 +21776,7 @@
           <p:cNvPr id="21" name="">
             <a:extLst xmlns:a="http://schemas.openxmlformats.org/drawingml/2006/main">
               <a:ext uri="{FF2B5EF4-FFF2-40B4-BE49-F238E27FC236}">
-                <a16:creationId xmlns:a16="http://schemas.microsoft.com/office/drawing/2014/main" id="{DD38CDE3-489E-4B0F-AA17-5E37865755B4}"/>
+                <a16:creationId xmlns:a16="http://schemas.microsoft.com/office/drawing/2014/main" id="{F5D3A843-A557-46A6-A0E2-C8AF038C21F2}"/>
               </a:ext>
             </a:extLst>
           </p:cNvPr>
@@ -21838,7 +21838,7 @@
                 <a:latin typeface="Arial"/>
                 <a:ea typeface="Arial"/>
                 <a:cs typeface="Arial"/>
-                <a:hlinkClick xmlns:r="http://schemas.openxmlformats.org/officeDocument/2006/relationships" r:id="R5644a8e16c3348bd"/>
+                <a:hlinkClick xmlns:r="http://schemas.openxmlformats.org/officeDocument/2006/relationships" r:id="R44911e1bec9b4714"/>
               </a:rPr>
               <a:t>https://github.com/qjmre23/Route2Zero</a:t>
             </a:r>
@@ -21861,7 +21861,7 @@
                 <a:latin typeface="Arial"/>
                 <a:ea typeface="Arial"/>
                 <a:cs typeface="Arial"/>
-                <a:hlinkClick xmlns:r="http://schemas.openxmlformats.org/officeDocument/2006/relationships" r:id="R9d9cde2513934a19"/>
+                <a:hlinkClick xmlns:r="http://schemas.openxmlformats.org/officeDocument/2006/relationships" r:id="R5806a04827ed4b1d"/>
               </a:rPr>
               <a:t>https://route2zero.netlify.app/</a:t>
             </a:r>
@@ -21873,7 +21873,7 @@
           <p:cNvPr id="2" name="">
             <a:extLst xmlns:a="http://schemas.openxmlformats.org/drawingml/2006/main">
               <a:ext uri="{FF2B5EF4-FFF2-40B4-BE49-F238E27FC236}">
-                <a16:creationId xmlns:a16="http://schemas.microsoft.com/office/drawing/2014/main" id="{FD412999-0F71-46B7-B61C-37D61829AA65}"/>
+                <a16:creationId xmlns:a16="http://schemas.microsoft.com/office/drawing/2014/main" id="{70347FA3-AC04-4182-8DBF-D3CA40C931F0}"/>
               </a:ext>
             </a:extLst>
           </p:cNvPr>
@@ -21935,7 +21935,7 @@
           <p:cNvPr id="3" name="">
             <a:extLst xmlns:a="http://schemas.openxmlformats.org/drawingml/2006/main">
               <a:ext uri="{FF2B5EF4-FFF2-40B4-BE49-F238E27FC236}">
-                <a16:creationId xmlns:a16="http://schemas.microsoft.com/office/drawing/2014/main" id="{BA65117B-6D7A-4A71-888A-1759668A2F62}"/>
+                <a16:creationId xmlns:a16="http://schemas.microsoft.com/office/drawing/2014/main" id="{FDE74DBF-56F5-48E9-B887-D333BE3B8CF7}"/>
               </a:ext>
             </a:extLst>
           </p:cNvPr>
@@ -22001,7 +22001,7 @@
           <p:nvPr/>
         </p:nvPicPr>
         <p:blipFill>
-          <a:blip xmlns:r="http://schemas.openxmlformats.org/officeDocument/2006/relationships" xmlns:a="http://schemas.openxmlformats.org/drawingml/2006/main" r:embed="R88ad4374e1d14634"/>
+          <a:blip xmlns:r="http://schemas.openxmlformats.org/officeDocument/2006/relationships" xmlns:a="http://schemas.openxmlformats.org/drawingml/2006/main" r:embed="R26f84a749db84002"/>
           <a:srcRect xmlns:a="http://schemas.openxmlformats.org/drawingml/2006/main" l="0" t="15682" r="0" b="15682"/>
           <a:stretch xmlns:a="http://schemas.openxmlformats.org/drawingml/2006/main">
             <a:fillRect l="0" t="0" r="0" b="0"/>
@@ -22024,7 +22024,7 @@
           <p:cNvPr id="5" name="">
             <a:extLst xmlns:a="http://schemas.openxmlformats.org/drawingml/2006/main">
               <a:ext uri="{FF2B5EF4-FFF2-40B4-BE49-F238E27FC236}">
-                <a16:creationId xmlns:a16="http://schemas.microsoft.com/office/drawing/2014/main" id="{3D688004-1EEB-4AE1-9C52-29D3C5A48A47}"/>
+                <a16:creationId xmlns:a16="http://schemas.microsoft.com/office/drawing/2014/main" id="{7E03EE20-6D2C-4056-93A2-7D3F29930178}"/>
               </a:ext>
             </a:extLst>
           </p:cNvPr>
@@ -22057,7 +22057,7 @@
           <p:cNvPr id="6" name="">
             <a:extLst xmlns:a="http://schemas.openxmlformats.org/drawingml/2006/main">
               <a:ext uri="{FF2B5EF4-FFF2-40B4-BE49-F238E27FC236}">
-                <a16:creationId xmlns:a16="http://schemas.microsoft.com/office/drawing/2014/main" id="{D9790D84-A1F3-44B1-8C25-168DC80A93FC}"/>
+                <a16:creationId xmlns:a16="http://schemas.microsoft.com/office/drawing/2014/main" id="{FCEC5883-F351-4DD5-A502-7E20C1654C96}"/>
               </a:ext>
             </a:extLst>
           </p:cNvPr>
@@ -22088,7 +22088,7 @@
           <p:cNvPr id="7" name="">
             <a:extLst xmlns:a="http://schemas.openxmlformats.org/drawingml/2006/main">
               <a:ext uri="{FF2B5EF4-FFF2-40B4-BE49-F238E27FC236}">
-                <a16:creationId xmlns:a16="http://schemas.microsoft.com/office/drawing/2014/main" id="{B8C6949A-DE03-4165-9252-324DFE4F30C4}"/>
+                <a16:creationId xmlns:a16="http://schemas.microsoft.com/office/drawing/2014/main" id="{BE13BA98-FB11-4FEE-A5C2-CA2E4CB4B905}"/>
               </a:ext>
             </a:extLst>
           </p:cNvPr>
@@ -22150,7 +22150,7 @@
           <p:cNvPr id="8" name="">
             <a:extLst xmlns:a="http://schemas.openxmlformats.org/drawingml/2006/main">
               <a:ext uri="{FF2B5EF4-FFF2-40B4-BE49-F238E27FC236}">
-                <a16:creationId xmlns:a16="http://schemas.microsoft.com/office/drawing/2014/main" id="{8EB119D5-083E-406A-A045-09F7F1E34BE9}"/>
+                <a16:creationId xmlns:a16="http://schemas.microsoft.com/office/drawing/2014/main" id="{AF987B89-93E1-4746-B978-B01DDD0FCE97}"/>
               </a:ext>
             </a:extLst>
           </p:cNvPr>
@@ -22185,7 +22185,7 @@
           <p:cNvPr id="9" name="">
             <a:extLst xmlns:a="http://schemas.openxmlformats.org/drawingml/2006/main">
               <a:ext uri="{FF2B5EF4-FFF2-40B4-BE49-F238E27FC236}">
-                <a16:creationId xmlns:a16="http://schemas.microsoft.com/office/drawing/2014/main" id="{34CA9500-C31B-477E-823E-3910A04EC1BE}"/>
+                <a16:creationId xmlns:a16="http://schemas.microsoft.com/office/drawing/2014/main" id="{13ACE59B-9735-47F8-A1E4-31882C707081}"/>
               </a:ext>
             </a:extLst>
           </p:cNvPr>
@@ -22247,7 +22247,7 @@
           <p:cNvPr id="10" name="">
             <a:extLst xmlns:a="http://schemas.openxmlformats.org/drawingml/2006/main">
               <a:ext uri="{FF2B5EF4-FFF2-40B4-BE49-F238E27FC236}">
-                <a16:creationId xmlns:a16="http://schemas.microsoft.com/office/drawing/2014/main" id="{A161B08F-4995-4B30-BBDE-5BBCF1E3E02A}"/>
+                <a16:creationId xmlns:a16="http://schemas.microsoft.com/office/drawing/2014/main" id="{80EA93D3-E6E7-488E-A283-DEA38A633FB0}"/>
               </a:ext>
             </a:extLst>
           </p:cNvPr>
@@ -22278,7 +22278,7 @@
           <p:cNvPr id="11" name="">
             <a:extLst xmlns:a="http://schemas.openxmlformats.org/drawingml/2006/main">
               <a:ext uri="{FF2B5EF4-FFF2-40B4-BE49-F238E27FC236}">
-                <a16:creationId xmlns:a16="http://schemas.microsoft.com/office/drawing/2014/main" id="{6008C69A-83DD-4032-9C9A-D24BC4083318}"/>
+                <a16:creationId xmlns:a16="http://schemas.microsoft.com/office/drawing/2014/main" id="{2EDD035F-C13F-43ED-8919-D65A77BACDE5}"/>
               </a:ext>
             </a:extLst>
           </p:cNvPr>
@@ -22340,7 +22340,7 @@
           <p:cNvPr id="12" name="">
             <a:extLst xmlns:a="http://schemas.openxmlformats.org/drawingml/2006/main">
               <a:ext uri="{FF2B5EF4-FFF2-40B4-BE49-F238E27FC236}">
-                <a16:creationId xmlns:a16="http://schemas.microsoft.com/office/drawing/2014/main" id="{7A7DBB57-D5CA-462A-BA83-67812AB9825E}"/>
+                <a16:creationId xmlns:a16="http://schemas.microsoft.com/office/drawing/2014/main" id="{914AFE00-908D-4865-A823-DF322EB867B4}"/>
               </a:ext>
             </a:extLst>
           </p:cNvPr>
@@ -22375,7 +22375,7 @@
           <p:cNvPr id="13" name="">
             <a:extLst xmlns:a="http://schemas.openxmlformats.org/drawingml/2006/main">
               <a:ext uri="{FF2B5EF4-FFF2-40B4-BE49-F238E27FC236}">
-                <a16:creationId xmlns:a16="http://schemas.microsoft.com/office/drawing/2014/main" id="{F514F28C-D285-4AD8-9DB5-4EAF1D666B14}"/>
+                <a16:creationId xmlns:a16="http://schemas.microsoft.com/office/drawing/2014/main" id="{D85914FF-4861-4BD2-8043-8C13C9F227B8}"/>
               </a:ext>
             </a:extLst>
           </p:cNvPr>
@@ -22437,7 +22437,7 @@
           <p:cNvPr id="14" name="">
             <a:extLst xmlns:a="http://schemas.openxmlformats.org/drawingml/2006/main">
               <a:ext uri="{FF2B5EF4-FFF2-40B4-BE49-F238E27FC236}">
-                <a16:creationId xmlns:a16="http://schemas.microsoft.com/office/drawing/2014/main" id="{5C46A5A8-AC46-4D32-9E90-69A53804C156}"/>
+                <a16:creationId xmlns:a16="http://schemas.microsoft.com/office/drawing/2014/main" id="{345E769B-1A39-4F70-A181-E0912B694120}"/>
               </a:ext>
             </a:extLst>
           </p:cNvPr>
@@ -22468,7 +22468,7 @@
           <p:cNvPr id="15" name="">
             <a:extLst xmlns:a="http://schemas.openxmlformats.org/drawingml/2006/main">
               <a:ext uri="{FF2B5EF4-FFF2-40B4-BE49-F238E27FC236}">
-                <a16:creationId xmlns:a16="http://schemas.microsoft.com/office/drawing/2014/main" id="{1D24152B-7B1C-468D-8616-F694EF09BDB6}"/>
+                <a16:creationId xmlns:a16="http://schemas.microsoft.com/office/drawing/2014/main" id="{429D8149-F286-43DF-BCC2-03076732D639}"/>
               </a:ext>
             </a:extLst>
           </p:cNvPr>
@@ -22530,7 +22530,7 @@
           <p:cNvPr id="16" name="">
             <a:extLst xmlns:a="http://schemas.openxmlformats.org/drawingml/2006/main">
               <a:ext uri="{FF2B5EF4-FFF2-40B4-BE49-F238E27FC236}">
-                <a16:creationId xmlns:a16="http://schemas.microsoft.com/office/drawing/2014/main" id="{F2D8285A-7D70-4CD0-8BC5-82AFD31C77C0}"/>
+                <a16:creationId xmlns:a16="http://schemas.microsoft.com/office/drawing/2014/main" id="{52539851-2301-4EBC-A942-E07F9A81ED46}"/>
               </a:ext>
             </a:extLst>
           </p:cNvPr>
@@ -22565,7 +22565,7 @@
           <p:cNvPr id="17" name="">
             <a:extLst xmlns:a="http://schemas.openxmlformats.org/drawingml/2006/main">
               <a:ext uri="{FF2B5EF4-FFF2-40B4-BE49-F238E27FC236}">
-                <a16:creationId xmlns:a16="http://schemas.microsoft.com/office/drawing/2014/main" id="{EA82FE8C-F140-48EA-A808-4713EAF34998}"/>
+                <a16:creationId xmlns:a16="http://schemas.microsoft.com/office/drawing/2014/main" id="{9C34A736-BC0C-4352-9D0F-809A63BD547E}"/>
               </a:ext>
             </a:extLst>
           </p:cNvPr>
@@ -22627,7 +22627,7 @@
           <p:cNvPr id="18" name="">
             <a:extLst xmlns:a="http://schemas.openxmlformats.org/drawingml/2006/main">
               <a:ext uri="{FF2B5EF4-FFF2-40B4-BE49-F238E27FC236}">
-                <a16:creationId xmlns:a16="http://schemas.microsoft.com/office/drawing/2014/main" id="{38F9E61B-CEBA-48E8-9504-600FEAB91CE4}"/>
+                <a16:creationId xmlns:a16="http://schemas.microsoft.com/office/drawing/2014/main" id="{D019785E-238E-4D98-8AEA-4C53FBCF117C}"/>
               </a:ext>
             </a:extLst>
           </p:cNvPr>
@@ -22658,7 +22658,7 @@
           <p:cNvPr id="19" name="">
             <a:extLst xmlns:a="http://schemas.openxmlformats.org/drawingml/2006/main">
               <a:ext uri="{FF2B5EF4-FFF2-40B4-BE49-F238E27FC236}">
-                <a16:creationId xmlns:a16="http://schemas.microsoft.com/office/drawing/2014/main" id="{400B9BDF-8CDC-4FAF-8A5B-9F7670248D3D}"/>
+                <a16:creationId xmlns:a16="http://schemas.microsoft.com/office/drawing/2014/main" id="{73812C74-A83C-4FC6-A231-63C21BB8F93C}"/>
               </a:ext>
             </a:extLst>
           </p:cNvPr>
@@ -22720,7 +22720,7 @@
           <p:cNvPr id="20" name="">
             <a:extLst xmlns:a="http://schemas.openxmlformats.org/drawingml/2006/main">
               <a:ext uri="{FF2B5EF4-FFF2-40B4-BE49-F238E27FC236}">
-                <a16:creationId xmlns:a16="http://schemas.microsoft.com/office/drawing/2014/main" id="{02F78AAC-0B26-42EF-B101-CEFA71179847}"/>
+                <a16:creationId xmlns:a16="http://schemas.microsoft.com/office/drawing/2014/main" id="{6C2B2CB9-556A-467B-A2CD-F45B66A77AD6}"/>
               </a:ext>
             </a:extLst>
           </p:cNvPr>
@@ -22780,7 +22780,7 @@
     </p:spTree>
     <p:extLst>
       <p:ext uri="{BB962C8B-B14F-4D97-AF65-F5344CB8AC3E}">
-        <p14:creationId xmlns:p14="http://schemas.microsoft.com/office/powerpoint/2010/main" val="556513748"/>
+        <p14:creationId xmlns:p14="http://schemas.microsoft.com/office/powerpoint/2010/main" val="357255699"/>
       </p:ext>
     </p:extLst>
   </p:cSld>

</xml_diff>

<commit_message>
Record tour narration and reconcile submission artifacts
</commit_message>
<xml_diff>
--- a/output/submission/Route2Zero_Prototype_Demonstration.pptx
+++ b/output/submission/Route2Zero_Prototype_Demonstration.pptx
@@ -164,7 +164,7 @@
             </c:spPr>
             <c:extLst>
               <c:ext xmlns:c16="http://schemas.microsoft.com/office/drawing/2014/chart" uri="{C3380CC4-5D6E-409C-BE32-E72D297353CC}">
-                <c16:uniqueId val="{00000001-5E0A-4F90-ADE5-CB7FC9D5F30D}"/>
+                <c16:uniqueId val="{00000001-03E8-4525-BD97-366997560345}"/>
               </c:ext>
             </c:extLst>
           </c:dPt>
@@ -238,7 +238,7 @@
               </c14:invertSolidFillFmt>
             </c:ext>
             <c:ext xmlns:c16="http://schemas.microsoft.com/office/drawing/2014/chart" uri="{C3380CC4-5D6E-409C-BE32-E72D297353CC}">
-              <c16:uniqueId val="{00000002-5E0A-4F90-ADE5-CB7FC9D5F30D}"/>
+              <c16:uniqueId val="{00000002-03E8-4525-BD97-366997560345}"/>
             </c:ext>
           </c:extLst>
         </c:ser>
@@ -1299,7 +1299,7 @@
           </a:p>
           <a:p>
             <a:r>
-              <a:t>netlify-site/netlify/functions/ai-planner.mjs</a:t>
+              <a:t>netlify-site/netlify/functions/explain.mjs</a:t>
             </a:r>
           </a:p>
         </p:txBody>
@@ -1729,7 +1729,7 @@
           <a:lstStyle/>
           <a:p>
             <a:r>
-              <a:t>The flagship remains historic-only and uses a DERIVED route approximation; the interface does not hide that limitation.</a:t>
+              <a:t>The default view leads with three decisions. Eight supporting signals are available through progressive disclosure.</a:t>
             </a:r>
           </a:p>
           <a:p>
@@ -1903,7 +1903,7 @@
           <a:lstStyle/>
           <a:p>
             <a:r>
-              <a:t>Typology is unsupervised ML and does not add hidden points to the policy score.</a:t>
+              <a:t>The modest silhouette indicates overlapping structure. Typology adds no policy points and predicts no outcome.</a:t>
             </a:r>
           </a:p>
           <a:p>
@@ -1995,7 +1995,7 @@
           <a:lstStyle/>
           <a:p>
             <a:r>
-              <a:t>The low case turns negative when a carbon-intensive grid is paired with an inefficient EV assumption; vehicle efficiency and grid intensity dominate the sensitivity.</a:t>
+              <a:t>The low case turns negative when a carbon-intensive grid is paired with an inefficient EV assumption. The low-high range is a scenario bound, not a statistical confidence interval.</a:t>
             </a:r>
           </a:p>
           <a:p>
@@ -2493,7 +2493,7 @@
             <a:hlinkClick r:id="rId3"/>
             <a:extLst>
               <a:ext uri="{FF2B5EF4-FFF2-40B4-BE49-F238E27FC236}">
-                <a16:creationId xmlns:a16="http://schemas.microsoft.com/office/drawing/2014/main" id="{654D4306-0BAE-4EFD-BDD7-E3BDF951E3A1}"/>
+                <a16:creationId xmlns:a16="http://schemas.microsoft.com/office/drawing/2014/main" id="{F5DE8121-0CCD-41A2-B4EB-F0EBA720F342}"/>
               </a:ext>
             </a:extLst>
           </p:cNvPr>
@@ -2568,7 +2568,7 @@
             <a:hlinkClick r:id="rId4"/>
             <a:extLst>
               <a:ext uri="{FF2B5EF4-FFF2-40B4-BE49-F238E27FC236}">
-                <a16:creationId xmlns:a16="http://schemas.microsoft.com/office/drawing/2014/main" id="{32EB1151-AD6F-497E-AF43-19B0088254D0}"/>
+                <a16:creationId xmlns:a16="http://schemas.microsoft.com/office/drawing/2014/main" id="{B162E345-F350-4F02-9222-03213E6581A9}"/>
               </a:ext>
             </a:extLst>
           </p:cNvPr>
@@ -2667,7 +2667,7 @@
           <p:cNvPr id="4" name="Rectangle 3">
             <a:extLst>
               <a:ext uri="{FF2B5EF4-FFF2-40B4-BE49-F238E27FC236}">
-                <a16:creationId xmlns:a16="http://schemas.microsoft.com/office/drawing/2014/main" id="{6456371E-C5A9-418F-8026-798106E4ABDE}"/>
+                <a16:creationId xmlns:a16="http://schemas.microsoft.com/office/drawing/2014/main" id="{17203677-BC37-413E-BC92-DC107A0BADB6}"/>
               </a:ext>
             </a:extLst>
           </p:cNvPr>
@@ -2713,7 +2713,7 @@
           <p:cNvPr id="5" name="Rectangle 4">
             <a:extLst>
               <a:ext uri="{FF2B5EF4-FFF2-40B4-BE49-F238E27FC236}">
-                <a16:creationId xmlns:a16="http://schemas.microsoft.com/office/drawing/2014/main" id="{9D2FBC70-9006-4C98-83CE-DEFE60DA902E}"/>
+                <a16:creationId xmlns:a16="http://schemas.microsoft.com/office/drawing/2014/main" id="{869EEC55-5B81-4765-B109-FC01755196E1}"/>
               </a:ext>
             </a:extLst>
           </p:cNvPr>
@@ -2775,7 +2775,7 @@
           <p:cNvPr id="6" name="Rectangle 5">
             <a:extLst>
               <a:ext uri="{FF2B5EF4-FFF2-40B4-BE49-F238E27FC236}">
-                <a16:creationId xmlns:a16="http://schemas.microsoft.com/office/drawing/2014/main" id="{69C46DEC-EC30-4F50-A70D-BE38F929C7FE}"/>
+                <a16:creationId xmlns:a16="http://schemas.microsoft.com/office/drawing/2014/main" id="{7B25C864-1E2C-4C8E-8EAF-B7A219E118E7}"/>
               </a:ext>
             </a:extLst>
           </p:cNvPr>
@@ -2837,7 +2837,7 @@
           <p:cNvPr id="7" name="Rectangle 6">
             <a:extLst>
               <a:ext uri="{FF2B5EF4-FFF2-40B4-BE49-F238E27FC236}">
-                <a16:creationId xmlns:a16="http://schemas.microsoft.com/office/drawing/2014/main" id="{7EABE2DD-E56A-4A41-82A6-B7CEC6AC2C7D}"/>
+                <a16:creationId xmlns:a16="http://schemas.microsoft.com/office/drawing/2014/main" id="{B8D699E7-64C7-4C10-8802-04FF575ADF90}"/>
               </a:ext>
             </a:extLst>
           </p:cNvPr>
@@ -2889,7 +2889,7 @@
                 <a:ea typeface="Arial"/>
                 <a:cs typeface="Arial"/>
               </a:rPr>
-              <a:t>A live decision workflow: screen 1,522 corridors, show what is known, and prioritize the evidence needed for a defensible Phase-1 pilot.</a:t>
+              <a:t>Screen 1,522 historic corridor records into 9 priorities for field validation — then show what the city must verify before spending.</a:t>
             </a:r>
           </a:p>
         </p:txBody>
@@ -2899,7 +2899,7 @@
           <p:cNvPr id="8" name="Rectangle 7">
             <a:extLst>
               <a:ext uri="{FF2B5EF4-FFF2-40B4-BE49-F238E27FC236}">
-                <a16:creationId xmlns:a16="http://schemas.microsoft.com/office/drawing/2014/main" id="{ADC46ACC-8D28-4F79-B7B1-2B352F6DA6BC}"/>
+                <a16:creationId xmlns:a16="http://schemas.microsoft.com/office/drawing/2014/main" id="{3E92D9A1-4EA0-448E-8F4B-05034F3F87E6}"/>
               </a:ext>
             </a:extLst>
           </p:cNvPr>
@@ -2961,7 +2961,7 @@
           <p:cNvPr id="9" name="Rectangle 8">
             <a:extLst>
               <a:ext uri="{FF2B5EF4-FFF2-40B4-BE49-F238E27FC236}">
-                <a16:creationId xmlns:a16="http://schemas.microsoft.com/office/drawing/2014/main" id="{FB5D39E5-D7F1-4528-991B-4E6AB67CB8D7}"/>
+                <a16:creationId xmlns:a16="http://schemas.microsoft.com/office/drawing/2014/main" id="{C3A15E6A-9BBB-4D47-83CE-9CAD9142477C}"/>
               </a:ext>
             </a:extLst>
           </p:cNvPr>
@@ -3023,7 +3023,7 @@
           <p:cNvPr id="10" name="Rectangle 9">
             <a:extLst>
               <a:ext uri="{FF2B5EF4-FFF2-40B4-BE49-F238E27FC236}">
-                <a16:creationId xmlns:a16="http://schemas.microsoft.com/office/drawing/2014/main" id="{BEDB5C9E-4603-473C-AB65-B5A552BC7344}"/>
+                <a16:creationId xmlns:a16="http://schemas.microsoft.com/office/drawing/2014/main" id="{6E543582-2BFC-4FDA-982D-7242D8012C1A}"/>
               </a:ext>
             </a:extLst>
           </p:cNvPr>
@@ -3085,7 +3085,7 @@
           <p:cNvPr id="11" name="Rectangle 10">
             <a:extLst>
               <a:ext uri="{FF2B5EF4-FFF2-40B4-BE49-F238E27FC236}">
-                <a16:creationId xmlns:a16="http://schemas.microsoft.com/office/drawing/2014/main" id="{F4628AA9-6834-4D29-BDD3-6E9C8BE06AB4}"/>
+                <a16:creationId xmlns:a16="http://schemas.microsoft.com/office/drawing/2014/main" id="{52323C63-0256-4AA4-A15C-AB46CC603916}"/>
               </a:ext>
             </a:extLst>
           </p:cNvPr>
@@ -3147,7 +3147,7 @@
           <p:cNvPr id="12" name="Rectangle 11">
             <a:extLst>
               <a:ext uri="{FF2B5EF4-FFF2-40B4-BE49-F238E27FC236}">
-                <a16:creationId xmlns:a16="http://schemas.microsoft.com/office/drawing/2014/main" id="{2AB95487-DE43-443B-8ABE-921D109BC8F3}"/>
+                <a16:creationId xmlns:a16="http://schemas.microsoft.com/office/drawing/2014/main" id="{FDD6847E-5CA9-4CDA-B779-772F22B855B7}"/>
               </a:ext>
             </a:extLst>
           </p:cNvPr>
@@ -3209,7 +3209,7 @@
           <p:cNvPr id="13" name="Rectangle 12">
             <a:extLst>
               <a:ext uri="{FF2B5EF4-FFF2-40B4-BE49-F238E27FC236}">
-                <a16:creationId xmlns:a16="http://schemas.microsoft.com/office/drawing/2014/main" id="{DDA90F7C-D342-4147-9CC1-333CD4953FD3}"/>
+                <a16:creationId xmlns:a16="http://schemas.microsoft.com/office/drawing/2014/main" id="{8DF0F915-4024-454B-AB17-8AD3D5D68488}"/>
               </a:ext>
             </a:extLst>
           </p:cNvPr>
@@ -3271,7 +3271,7 @@
           <p:cNvPr id="14" name="Rectangle 13">
             <a:extLst>
               <a:ext uri="{FF2B5EF4-FFF2-40B4-BE49-F238E27FC236}">
-                <a16:creationId xmlns:a16="http://schemas.microsoft.com/office/drawing/2014/main" id="{0BDF133B-06EC-45C7-9357-F1DECEAF3BA2}"/>
+                <a16:creationId xmlns:a16="http://schemas.microsoft.com/office/drawing/2014/main" id="{1E945F98-6D0C-4698-9470-45B9FC5DF6EB}"/>
               </a:ext>
             </a:extLst>
           </p:cNvPr>
@@ -3333,7 +3333,7 @@
           <p:cNvPr id="15" name="Rectangle 14">
             <a:extLst>
               <a:ext uri="{FF2B5EF4-FFF2-40B4-BE49-F238E27FC236}">
-                <a16:creationId xmlns:a16="http://schemas.microsoft.com/office/drawing/2014/main" id="{425CB506-D0AA-4F2F-AFD9-6F203FE7B39D}"/>
+                <a16:creationId xmlns:a16="http://schemas.microsoft.com/office/drawing/2014/main" id="{AF65BB97-FBFD-46AE-B027-57A1CA6C98F8}"/>
               </a:ext>
             </a:extLst>
           </p:cNvPr>
@@ -3395,7 +3395,7 @@
           <p:cNvPr id="16" name="Rectangle 15">
             <a:extLst>
               <a:ext uri="{FF2B5EF4-FFF2-40B4-BE49-F238E27FC236}">
-                <a16:creationId xmlns:a16="http://schemas.microsoft.com/office/drawing/2014/main" id="{FDCAE8CB-6756-4C7B-9952-EE110FEDB421}"/>
+                <a16:creationId xmlns:a16="http://schemas.microsoft.com/office/drawing/2014/main" id="{8F443C12-72CC-4EE2-9586-4F2662BE99B4}"/>
               </a:ext>
             </a:extLst>
           </p:cNvPr>
@@ -3457,7 +3457,7 @@
           <p:cNvPr id="17" name="Rectangle 16">
             <a:extLst>
               <a:ext uri="{FF2B5EF4-FFF2-40B4-BE49-F238E27FC236}">
-                <a16:creationId xmlns:a16="http://schemas.microsoft.com/office/drawing/2014/main" id="{55A3B02F-8682-486C-90C0-EDF99427DD68}"/>
+                <a16:creationId xmlns:a16="http://schemas.microsoft.com/office/drawing/2014/main" id="{83739915-A6E7-460E-AE1D-9EE098E6BC8A}"/>
               </a:ext>
             </a:extLst>
           </p:cNvPr>
@@ -3488,7 +3488,7 @@
           <p:cNvPr id="18" name="Rectangle 17">
             <a:extLst>
               <a:ext uri="{FF2B5EF4-FFF2-40B4-BE49-F238E27FC236}">
-                <a16:creationId xmlns:a16="http://schemas.microsoft.com/office/drawing/2014/main" id="{D93DD951-195C-41E9-B937-CD6296AFB806}"/>
+                <a16:creationId xmlns:a16="http://schemas.microsoft.com/office/drawing/2014/main" id="{BCFB574D-4EE8-48ED-AA89-560D5E8BA9A5}"/>
               </a:ext>
             </a:extLst>
           </p:cNvPr>
@@ -3550,7 +3550,7 @@
           <p:cNvPr id="19" name="Rectangle 18">
             <a:extLst>
               <a:ext uri="{FF2B5EF4-FFF2-40B4-BE49-F238E27FC236}">
-                <a16:creationId xmlns:a16="http://schemas.microsoft.com/office/drawing/2014/main" id="{0333D043-3D0B-4A2C-BF13-4A83A31BEA8A}"/>
+                <a16:creationId xmlns:a16="http://schemas.microsoft.com/office/drawing/2014/main" id="{89AB4920-49D0-47D5-BBD5-7E2D3C43FFCA}"/>
               </a:ext>
             </a:extLst>
           </p:cNvPr>
@@ -3610,7 +3610,7 @@
     </p:spTree>
     <p:extLst>
       <p:ext uri="{BB962C8B-B14F-4D97-AF65-F5344CB8AC3E}">
-        <p14:creationId xmlns:p14="http://schemas.microsoft.com/office/powerpoint/2010/main" val="400751015"/>
+        <p14:creationId xmlns:p14="http://schemas.microsoft.com/office/powerpoint/2010/main" val="1089284717"/>
       </p:ext>
     </p:extLst>
   </p:cSld>
@@ -3651,7 +3651,7 @@
             <a:hlinkClick r:id="rId3"/>
             <a:extLst>
               <a:ext uri="{FF2B5EF4-FFF2-40B4-BE49-F238E27FC236}">
-                <a16:creationId xmlns:a16="http://schemas.microsoft.com/office/drawing/2014/main" id="{B7E87A1B-36CF-46FF-8F60-53B5C12B7DB8}"/>
+                <a16:creationId xmlns:a16="http://schemas.microsoft.com/office/drawing/2014/main" id="{4B3D9B78-3222-4750-925A-A35C39DE1670}"/>
               </a:ext>
             </a:extLst>
           </p:cNvPr>
@@ -3726,7 +3726,7 @@
             <a:hlinkClick r:id="rId4"/>
             <a:extLst>
               <a:ext uri="{FF2B5EF4-FFF2-40B4-BE49-F238E27FC236}">
-                <a16:creationId xmlns:a16="http://schemas.microsoft.com/office/drawing/2014/main" id="{4DEE2765-909A-4B27-BB66-910AD1D9C5E0}"/>
+                <a16:creationId xmlns:a16="http://schemas.microsoft.com/office/drawing/2014/main" id="{DF0BBE3C-C2C3-4B50-A378-FBE6CD68DD05}"/>
               </a:ext>
             </a:extLst>
           </p:cNvPr>
@@ -3800,7 +3800,7 @@
           <p:cNvPr id="3" name="Rectangle 2">
             <a:extLst>
               <a:ext uri="{FF2B5EF4-FFF2-40B4-BE49-F238E27FC236}">
-                <a16:creationId xmlns:a16="http://schemas.microsoft.com/office/drawing/2014/main" id="{4F77D8AE-C934-45A3-B746-987D7F12467B}"/>
+                <a16:creationId xmlns:a16="http://schemas.microsoft.com/office/drawing/2014/main" id="{71BF3587-812B-494C-BE3C-D21A703E349E}"/>
               </a:ext>
             </a:extLst>
           </p:cNvPr>
@@ -3862,7 +3862,7 @@
           <p:cNvPr id="4" name="Rectangle 3">
             <a:extLst>
               <a:ext uri="{FF2B5EF4-FFF2-40B4-BE49-F238E27FC236}">
-                <a16:creationId xmlns:a16="http://schemas.microsoft.com/office/drawing/2014/main" id="{45BBDCFB-24C6-41A4-A242-15FEE839B9AA}"/>
+                <a16:creationId xmlns:a16="http://schemas.microsoft.com/office/drawing/2014/main" id="{E636017A-BC47-4A16-BC1B-2CEB403D4DE7}"/>
               </a:ext>
             </a:extLst>
           </p:cNvPr>
@@ -3929,7 +3929,7 @@
         </p:nvPicPr>
         <p:blipFill>
           <a:blip r:embed="rId5"/>
-          <a:srcRect t="3265" b="3265"/>
+          <a:srcRect t="3361" b="3361"/>
           <a:stretch>
             <a:fillRect/>
           </a:stretch>
@@ -3951,7 +3951,7 @@
           <p:cNvPr id="6" name="Rectangle: Rounded Corners 5">
             <a:extLst>
               <a:ext uri="{FF2B5EF4-FFF2-40B4-BE49-F238E27FC236}">
-                <a16:creationId xmlns:a16="http://schemas.microsoft.com/office/drawing/2014/main" id="{BD88E9BD-0A1A-40AE-AE5C-2200CF54D573}"/>
+                <a16:creationId xmlns:a16="http://schemas.microsoft.com/office/drawing/2014/main" id="{43EFBB60-67E9-4650-AC6A-683BC30D4E04}"/>
               </a:ext>
             </a:extLst>
           </p:cNvPr>
@@ -3984,7 +3984,7 @@
           <p:cNvPr id="7" name="Oval 6">
             <a:extLst>
               <a:ext uri="{FF2B5EF4-FFF2-40B4-BE49-F238E27FC236}">
-                <a16:creationId xmlns:a16="http://schemas.microsoft.com/office/drawing/2014/main" id="{B4AD0A06-6BA6-4883-8BAD-22B38A067F55}"/>
+                <a16:creationId xmlns:a16="http://schemas.microsoft.com/office/drawing/2014/main" id="{9690429E-FA07-440B-A32B-2ABE123F1A12}"/>
               </a:ext>
             </a:extLst>
           </p:cNvPr>
@@ -4015,7 +4015,7 @@
           <p:cNvPr id="8" name="Rectangle 7">
             <a:extLst>
               <a:ext uri="{FF2B5EF4-FFF2-40B4-BE49-F238E27FC236}">
-                <a16:creationId xmlns:a16="http://schemas.microsoft.com/office/drawing/2014/main" id="{11BB834B-1FBF-4EB0-AA56-F35991546D39}"/>
+                <a16:creationId xmlns:a16="http://schemas.microsoft.com/office/drawing/2014/main" id="{33369B50-77F6-4B24-B9D3-25E171906B3D}"/>
               </a:ext>
             </a:extLst>
           </p:cNvPr>
@@ -4077,7 +4077,7 @@
           <p:cNvPr id="9" name="Rectangle: Rounded Corners 8">
             <a:extLst>
               <a:ext uri="{FF2B5EF4-FFF2-40B4-BE49-F238E27FC236}">
-                <a16:creationId xmlns:a16="http://schemas.microsoft.com/office/drawing/2014/main" id="{C5695599-7990-4702-98C3-77ADD9E76D24}"/>
+                <a16:creationId xmlns:a16="http://schemas.microsoft.com/office/drawing/2014/main" id="{D7CD7814-C20D-404F-9CD0-6D62C0B34043}"/>
               </a:ext>
             </a:extLst>
           </p:cNvPr>
@@ -4112,7 +4112,7 @@
           <p:cNvPr id="10" name="Rectangle 9">
             <a:extLst>
               <a:ext uri="{FF2B5EF4-FFF2-40B4-BE49-F238E27FC236}">
-                <a16:creationId xmlns:a16="http://schemas.microsoft.com/office/drawing/2014/main" id="{0837F9A0-0F20-4180-B860-A9EDCD2F4725}"/>
+                <a16:creationId xmlns:a16="http://schemas.microsoft.com/office/drawing/2014/main" id="{02237E8C-7E39-4229-A9E2-B57B060324E1}"/>
               </a:ext>
             </a:extLst>
           </p:cNvPr>
@@ -4174,7 +4174,7 @@
           <p:cNvPr id="11" name="Oval 10">
             <a:extLst>
               <a:ext uri="{FF2B5EF4-FFF2-40B4-BE49-F238E27FC236}">
-                <a16:creationId xmlns:a16="http://schemas.microsoft.com/office/drawing/2014/main" id="{A9722C18-74FD-45EC-9F57-9BB02CCD9CBA}"/>
+                <a16:creationId xmlns:a16="http://schemas.microsoft.com/office/drawing/2014/main" id="{EF5FD3D3-FFBB-4CCE-9EB7-35F0D21282E0}"/>
               </a:ext>
             </a:extLst>
           </p:cNvPr>
@@ -4205,7 +4205,7 @@
           <p:cNvPr id="12" name="Rectangle 11">
             <a:extLst>
               <a:ext uri="{FF2B5EF4-FFF2-40B4-BE49-F238E27FC236}">
-                <a16:creationId xmlns:a16="http://schemas.microsoft.com/office/drawing/2014/main" id="{70A85321-8B10-4E8D-9E33-34856083E6C2}"/>
+                <a16:creationId xmlns:a16="http://schemas.microsoft.com/office/drawing/2014/main" id="{3FB02A5F-D451-459D-80F4-4E297903BE5E}"/>
               </a:ext>
             </a:extLst>
           </p:cNvPr>
@@ -4267,7 +4267,7 @@
           <p:cNvPr id="13" name="Rectangle: Rounded Corners 12">
             <a:extLst>
               <a:ext uri="{FF2B5EF4-FFF2-40B4-BE49-F238E27FC236}">
-                <a16:creationId xmlns:a16="http://schemas.microsoft.com/office/drawing/2014/main" id="{C95D1BD7-3E7E-4C86-B2D8-96552D817068}"/>
+                <a16:creationId xmlns:a16="http://schemas.microsoft.com/office/drawing/2014/main" id="{E384D906-A0B7-4F95-ADD0-EC1C57AFD8F6}"/>
               </a:ext>
             </a:extLst>
           </p:cNvPr>
@@ -4302,7 +4302,7 @@
           <p:cNvPr id="14" name="Rectangle 13">
             <a:extLst>
               <a:ext uri="{FF2B5EF4-FFF2-40B4-BE49-F238E27FC236}">
-                <a16:creationId xmlns:a16="http://schemas.microsoft.com/office/drawing/2014/main" id="{76AD974E-A35F-4A26-BCE5-2330C2C2B79B}"/>
+                <a16:creationId xmlns:a16="http://schemas.microsoft.com/office/drawing/2014/main" id="{ED29B790-DDD4-4204-8012-2BBAD0B974EE}"/>
               </a:ext>
             </a:extLst>
           </p:cNvPr>
@@ -4364,7 +4364,7 @@
           <p:cNvPr id="15" name="Oval 14">
             <a:extLst>
               <a:ext uri="{FF2B5EF4-FFF2-40B4-BE49-F238E27FC236}">
-                <a16:creationId xmlns:a16="http://schemas.microsoft.com/office/drawing/2014/main" id="{4F3ADAF8-E362-41BD-A815-1D6699C897F3}"/>
+                <a16:creationId xmlns:a16="http://schemas.microsoft.com/office/drawing/2014/main" id="{7B5C492E-3B32-4F4A-B093-4F610BCB88F9}"/>
               </a:ext>
             </a:extLst>
           </p:cNvPr>
@@ -4395,7 +4395,7 @@
           <p:cNvPr id="16" name="Rectangle 15">
             <a:extLst>
               <a:ext uri="{FF2B5EF4-FFF2-40B4-BE49-F238E27FC236}">
-                <a16:creationId xmlns:a16="http://schemas.microsoft.com/office/drawing/2014/main" id="{CAF48F41-C826-4773-98E3-3B58B5B3AA77}"/>
+                <a16:creationId xmlns:a16="http://schemas.microsoft.com/office/drawing/2014/main" id="{94B7D9A3-CF5C-4C3B-8E78-1E6905253701}"/>
               </a:ext>
             </a:extLst>
           </p:cNvPr>
@@ -4457,7 +4457,7 @@
           <p:cNvPr id="17" name="Rectangle: Rounded Corners 16">
             <a:extLst>
               <a:ext uri="{FF2B5EF4-FFF2-40B4-BE49-F238E27FC236}">
-                <a16:creationId xmlns:a16="http://schemas.microsoft.com/office/drawing/2014/main" id="{F08C14C2-A6D3-435A-B7DB-1AB2FA0B18CA}"/>
+                <a16:creationId xmlns:a16="http://schemas.microsoft.com/office/drawing/2014/main" id="{AC220318-1C9D-4FF0-AE4D-2F797F894CF1}"/>
               </a:ext>
             </a:extLst>
           </p:cNvPr>
@@ -4492,7 +4492,7 @@
           <p:cNvPr id="18" name="Rectangle 17">
             <a:extLst>
               <a:ext uri="{FF2B5EF4-FFF2-40B4-BE49-F238E27FC236}">
-                <a16:creationId xmlns:a16="http://schemas.microsoft.com/office/drawing/2014/main" id="{6CC8FFA3-D853-4D4A-A056-FCEEA417F502}"/>
+                <a16:creationId xmlns:a16="http://schemas.microsoft.com/office/drawing/2014/main" id="{4FD2C045-B9AD-45B9-96C2-DE62604B909E}"/>
               </a:ext>
             </a:extLst>
           </p:cNvPr>
@@ -4554,7 +4554,7 @@
           <p:cNvPr id="19" name="Rectangle 18">
             <a:extLst>
               <a:ext uri="{FF2B5EF4-FFF2-40B4-BE49-F238E27FC236}">
-                <a16:creationId xmlns:a16="http://schemas.microsoft.com/office/drawing/2014/main" id="{1E6BC39B-E0A1-4111-A7AD-A6385EF6209B}"/>
+                <a16:creationId xmlns:a16="http://schemas.microsoft.com/office/drawing/2014/main" id="{3FE6FEEE-4D4C-40BF-9E84-476B31EDE323}"/>
               </a:ext>
             </a:extLst>
           </p:cNvPr>
@@ -4585,7 +4585,7 @@
           <p:cNvPr id="20" name="Rectangle 19">
             <a:extLst>
               <a:ext uri="{FF2B5EF4-FFF2-40B4-BE49-F238E27FC236}">
-                <a16:creationId xmlns:a16="http://schemas.microsoft.com/office/drawing/2014/main" id="{8A048FDA-7C51-40C2-B836-B05608A3CC51}"/>
+                <a16:creationId xmlns:a16="http://schemas.microsoft.com/office/drawing/2014/main" id="{F7C619B0-B6A0-48E0-B9FB-0B91FC7B5022}"/>
               </a:ext>
             </a:extLst>
           </p:cNvPr>
@@ -4647,7 +4647,7 @@
           <p:cNvPr id="21" name="Rectangle 20">
             <a:extLst>
               <a:ext uri="{FF2B5EF4-FFF2-40B4-BE49-F238E27FC236}">
-                <a16:creationId xmlns:a16="http://schemas.microsoft.com/office/drawing/2014/main" id="{0EACE78D-5095-4AAE-B22C-C5EF21AA4E16}"/>
+                <a16:creationId xmlns:a16="http://schemas.microsoft.com/office/drawing/2014/main" id="{DEBCDB36-8375-4673-A9D2-614E959B23D6}"/>
               </a:ext>
             </a:extLst>
           </p:cNvPr>
@@ -4707,7 +4707,7 @@
     </p:spTree>
     <p:extLst>
       <p:ext uri="{BB962C8B-B14F-4D97-AF65-F5344CB8AC3E}">
-        <p14:creationId xmlns:p14="http://schemas.microsoft.com/office/powerpoint/2010/main" val="1310718391"/>
+        <p14:creationId xmlns:p14="http://schemas.microsoft.com/office/powerpoint/2010/main" val="86225550"/>
       </p:ext>
     </p:extLst>
   </p:cSld>
@@ -4748,7 +4748,7 @@
             <a:hlinkClick r:id="rId3"/>
             <a:extLst>
               <a:ext uri="{FF2B5EF4-FFF2-40B4-BE49-F238E27FC236}">
-                <a16:creationId xmlns:a16="http://schemas.microsoft.com/office/drawing/2014/main" id="{C2670786-A1F3-42A5-BA45-BB192BBA6A4A}"/>
+                <a16:creationId xmlns:a16="http://schemas.microsoft.com/office/drawing/2014/main" id="{CF2D6680-5CBE-49C1-9D51-EFD5C4D0B9A1}"/>
               </a:ext>
             </a:extLst>
           </p:cNvPr>
@@ -4823,7 +4823,7 @@
             <a:hlinkClick r:id="rId4"/>
             <a:extLst>
               <a:ext uri="{FF2B5EF4-FFF2-40B4-BE49-F238E27FC236}">
-                <a16:creationId xmlns:a16="http://schemas.microsoft.com/office/drawing/2014/main" id="{718322BB-CC49-4D66-9D97-0098259A8844}"/>
+                <a16:creationId xmlns:a16="http://schemas.microsoft.com/office/drawing/2014/main" id="{24E0DED8-85A5-4B31-AE88-2C834FD5535C}"/>
               </a:ext>
             </a:extLst>
           </p:cNvPr>
@@ -4897,7 +4897,7 @@
           <p:cNvPr id="3" name="Rectangle 2">
             <a:extLst>
               <a:ext uri="{FF2B5EF4-FFF2-40B4-BE49-F238E27FC236}">
-                <a16:creationId xmlns:a16="http://schemas.microsoft.com/office/drawing/2014/main" id="{D61BB36B-2E1C-41FE-A966-7605CF53DAA3}"/>
+                <a16:creationId xmlns:a16="http://schemas.microsoft.com/office/drawing/2014/main" id="{15A88A26-DE00-4E08-A4DF-2099919C52A0}"/>
               </a:ext>
             </a:extLst>
           </p:cNvPr>
@@ -4959,7 +4959,7 @@
           <p:cNvPr id="4" name="Rectangle 3">
             <a:extLst>
               <a:ext uri="{FF2B5EF4-FFF2-40B4-BE49-F238E27FC236}">
-                <a16:creationId xmlns:a16="http://schemas.microsoft.com/office/drawing/2014/main" id="{4953CFC2-D963-406E-BF87-A8B64431734F}"/>
+                <a16:creationId xmlns:a16="http://schemas.microsoft.com/office/drawing/2014/main" id="{4B23D46D-B206-4C26-A6C8-D91634990C63}"/>
               </a:ext>
             </a:extLst>
           </p:cNvPr>
@@ -5026,7 +5026,7 @@
         </p:nvPicPr>
         <p:blipFill>
           <a:blip r:embed="rId5"/>
-          <a:srcRect t="27645" b="27645"/>
+          <a:srcRect t="15586" b="15586"/>
           <a:stretch>
             <a:fillRect/>
           </a:stretch>
@@ -5048,7 +5048,7 @@
           <p:cNvPr id="6" name="Rectangle: Rounded Corners 5">
             <a:extLst>
               <a:ext uri="{FF2B5EF4-FFF2-40B4-BE49-F238E27FC236}">
-                <a16:creationId xmlns:a16="http://schemas.microsoft.com/office/drawing/2014/main" id="{ECD31F14-2B65-463C-A5B0-25AED07531A8}"/>
+                <a16:creationId xmlns:a16="http://schemas.microsoft.com/office/drawing/2014/main" id="{5FA980F1-8776-45A9-A14A-92F160954A03}"/>
               </a:ext>
             </a:extLst>
           </p:cNvPr>
@@ -5081,7 +5081,7 @@
           <p:cNvPr id="7" name="Oval 6">
             <a:extLst>
               <a:ext uri="{FF2B5EF4-FFF2-40B4-BE49-F238E27FC236}">
-                <a16:creationId xmlns:a16="http://schemas.microsoft.com/office/drawing/2014/main" id="{3D8296B4-CDA9-4BFC-9E71-9718FD1861D5}"/>
+                <a16:creationId xmlns:a16="http://schemas.microsoft.com/office/drawing/2014/main" id="{E4C2624A-A04D-4F21-97C8-09D4C921179A}"/>
               </a:ext>
             </a:extLst>
           </p:cNvPr>
@@ -5112,7 +5112,7 @@
           <p:cNvPr id="8" name="Rectangle 7">
             <a:extLst>
               <a:ext uri="{FF2B5EF4-FFF2-40B4-BE49-F238E27FC236}">
-                <a16:creationId xmlns:a16="http://schemas.microsoft.com/office/drawing/2014/main" id="{C7CC72B9-D83A-46F5-985B-7BA7F4158294}"/>
+                <a16:creationId xmlns:a16="http://schemas.microsoft.com/office/drawing/2014/main" id="{3B5EE290-0C59-4193-B517-E9946D04183B}"/>
               </a:ext>
             </a:extLst>
           </p:cNvPr>
@@ -5174,7 +5174,7 @@
           <p:cNvPr id="9" name="Rectangle: Rounded Corners 8">
             <a:extLst>
               <a:ext uri="{FF2B5EF4-FFF2-40B4-BE49-F238E27FC236}">
-                <a16:creationId xmlns:a16="http://schemas.microsoft.com/office/drawing/2014/main" id="{9612F33A-579B-43BF-BB3B-FC12FA064CDB}"/>
+                <a16:creationId xmlns:a16="http://schemas.microsoft.com/office/drawing/2014/main" id="{40694A5E-0BC6-47DE-963D-5A6AB29F3A77}"/>
               </a:ext>
             </a:extLst>
           </p:cNvPr>
@@ -5209,7 +5209,7 @@
           <p:cNvPr id="10" name="Rectangle 9">
             <a:extLst>
               <a:ext uri="{FF2B5EF4-FFF2-40B4-BE49-F238E27FC236}">
-                <a16:creationId xmlns:a16="http://schemas.microsoft.com/office/drawing/2014/main" id="{495F5359-00AE-4DED-B307-B781EDE86A7D}"/>
+                <a16:creationId xmlns:a16="http://schemas.microsoft.com/office/drawing/2014/main" id="{EF73031A-9370-4B60-BDCF-8628283B3B97}"/>
               </a:ext>
             </a:extLst>
           </p:cNvPr>
@@ -5271,7 +5271,7 @@
           <p:cNvPr id="11" name="Oval 10">
             <a:extLst>
               <a:ext uri="{FF2B5EF4-FFF2-40B4-BE49-F238E27FC236}">
-                <a16:creationId xmlns:a16="http://schemas.microsoft.com/office/drawing/2014/main" id="{D8AFBE8B-90CE-4258-81E6-446CA945C413}"/>
+                <a16:creationId xmlns:a16="http://schemas.microsoft.com/office/drawing/2014/main" id="{2F8ED8A0-2E67-45F4-9112-CD685F750E9B}"/>
               </a:ext>
             </a:extLst>
           </p:cNvPr>
@@ -5302,7 +5302,7 @@
           <p:cNvPr id="12" name="Rectangle 11">
             <a:extLst>
               <a:ext uri="{FF2B5EF4-FFF2-40B4-BE49-F238E27FC236}">
-                <a16:creationId xmlns:a16="http://schemas.microsoft.com/office/drawing/2014/main" id="{42069D5F-D601-4CE6-845F-ED3967CAE43B}"/>
+                <a16:creationId xmlns:a16="http://schemas.microsoft.com/office/drawing/2014/main" id="{D71E5195-BDF1-4F95-8060-1C052F86BFD5}"/>
               </a:ext>
             </a:extLst>
           </p:cNvPr>
@@ -5364,7 +5364,7 @@
           <p:cNvPr id="13" name="Rectangle: Rounded Corners 12">
             <a:extLst>
               <a:ext uri="{FF2B5EF4-FFF2-40B4-BE49-F238E27FC236}">
-                <a16:creationId xmlns:a16="http://schemas.microsoft.com/office/drawing/2014/main" id="{1AAE96F6-AE91-4C07-B61D-011A8BDC5016}"/>
+                <a16:creationId xmlns:a16="http://schemas.microsoft.com/office/drawing/2014/main" id="{978DECF1-DBB4-4714-9356-E7C774C2FBCC}"/>
               </a:ext>
             </a:extLst>
           </p:cNvPr>
@@ -5399,7 +5399,7 @@
           <p:cNvPr id="14" name="Rectangle 13">
             <a:extLst>
               <a:ext uri="{FF2B5EF4-FFF2-40B4-BE49-F238E27FC236}">
-                <a16:creationId xmlns:a16="http://schemas.microsoft.com/office/drawing/2014/main" id="{B6B8E0EE-7A0C-4C8B-B42C-FB3E657A9D40}"/>
+                <a16:creationId xmlns:a16="http://schemas.microsoft.com/office/drawing/2014/main" id="{5992EACD-529C-4584-A9A9-BB0980E90803}"/>
               </a:ext>
             </a:extLst>
           </p:cNvPr>
@@ -5461,7 +5461,7 @@
           <p:cNvPr id="15" name="Oval 14">
             <a:extLst>
               <a:ext uri="{FF2B5EF4-FFF2-40B4-BE49-F238E27FC236}">
-                <a16:creationId xmlns:a16="http://schemas.microsoft.com/office/drawing/2014/main" id="{CE0156C9-6DEA-45EF-9074-16B31ECD6AF7}"/>
+                <a16:creationId xmlns:a16="http://schemas.microsoft.com/office/drawing/2014/main" id="{DEAA4764-7AC0-4AAE-9489-6C7231040C1A}"/>
               </a:ext>
             </a:extLst>
           </p:cNvPr>
@@ -5492,7 +5492,7 @@
           <p:cNvPr id="16" name="Rectangle 15">
             <a:extLst>
               <a:ext uri="{FF2B5EF4-FFF2-40B4-BE49-F238E27FC236}">
-                <a16:creationId xmlns:a16="http://schemas.microsoft.com/office/drawing/2014/main" id="{41D936C0-CFB7-4949-B9C0-3C0EB7774471}"/>
+                <a16:creationId xmlns:a16="http://schemas.microsoft.com/office/drawing/2014/main" id="{69835C9B-A579-4130-8391-8D13FB2FF554}"/>
               </a:ext>
             </a:extLst>
           </p:cNvPr>
@@ -5554,7 +5554,7 @@
           <p:cNvPr id="17" name="Rectangle: Rounded Corners 16">
             <a:extLst>
               <a:ext uri="{FF2B5EF4-FFF2-40B4-BE49-F238E27FC236}">
-                <a16:creationId xmlns:a16="http://schemas.microsoft.com/office/drawing/2014/main" id="{C771C200-A306-4555-BA67-42B0DA21D996}"/>
+                <a16:creationId xmlns:a16="http://schemas.microsoft.com/office/drawing/2014/main" id="{285FF8E8-15F2-4DDC-BAEA-D75D4CBFE06A}"/>
               </a:ext>
             </a:extLst>
           </p:cNvPr>
@@ -5589,7 +5589,7 @@
           <p:cNvPr id="18" name="Rectangle 17">
             <a:extLst>
               <a:ext uri="{FF2B5EF4-FFF2-40B4-BE49-F238E27FC236}">
-                <a16:creationId xmlns:a16="http://schemas.microsoft.com/office/drawing/2014/main" id="{2A505177-F252-409C-8F89-5955FEA86592}"/>
+                <a16:creationId xmlns:a16="http://schemas.microsoft.com/office/drawing/2014/main" id="{D99251A3-7245-48E8-876D-112A1E497C61}"/>
               </a:ext>
             </a:extLst>
           </p:cNvPr>
@@ -5651,7 +5651,7 @@
           <p:cNvPr id="19" name="Rectangle 18">
             <a:extLst>
               <a:ext uri="{FF2B5EF4-FFF2-40B4-BE49-F238E27FC236}">
-                <a16:creationId xmlns:a16="http://schemas.microsoft.com/office/drawing/2014/main" id="{6B1C4CCE-8F97-4DC7-B259-E9BA56F1ED2C}"/>
+                <a16:creationId xmlns:a16="http://schemas.microsoft.com/office/drawing/2014/main" id="{22D2C59D-FD2A-4A78-BE94-7AEBBA183A44}"/>
               </a:ext>
             </a:extLst>
           </p:cNvPr>
@@ -5682,7 +5682,7 @@
           <p:cNvPr id="20" name="Rectangle 19">
             <a:extLst>
               <a:ext uri="{FF2B5EF4-FFF2-40B4-BE49-F238E27FC236}">
-                <a16:creationId xmlns:a16="http://schemas.microsoft.com/office/drawing/2014/main" id="{E1643EA7-9A9D-45D1-8C0B-A9920E0CB7BB}"/>
+                <a16:creationId xmlns:a16="http://schemas.microsoft.com/office/drawing/2014/main" id="{BBD3D1C3-3E36-4FB3-8224-74E19453ED58}"/>
               </a:ext>
             </a:extLst>
           </p:cNvPr>
@@ -5744,7 +5744,7 @@
           <p:cNvPr id="21" name="Rectangle 20">
             <a:extLst>
               <a:ext uri="{FF2B5EF4-FFF2-40B4-BE49-F238E27FC236}">
-                <a16:creationId xmlns:a16="http://schemas.microsoft.com/office/drawing/2014/main" id="{A2D24820-008A-4B42-9258-BF21EF419F0E}"/>
+                <a16:creationId xmlns:a16="http://schemas.microsoft.com/office/drawing/2014/main" id="{67207976-735F-4B63-9111-1F30048A2617}"/>
               </a:ext>
             </a:extLst>
           </p:cNvPr>
@@ -5804,7 +5804,7 @@
     </p:spTree>
     <p:extLst>
       <p:ext uri="{BB962C8B-B14F-4D97-AF65-F5344CB8AC3E}">
-        <p14:creationId xmlns:p14="http://schemas.microsoft.com/office/powerpoint/2010/main" val="1773460078"/>
+        <p14:creationId xmlns:p14="http://schemas.microsoft.com/office/powerpoint/2010/main" val="1719115139"/>
       </p:ext>
     </p:extLst>
   </p:cSld>
@@ -5845,7 +5845,7 @@
             <a:hlinkClick r:id="rId3"/>
             <a:extLst>
               <a:ext uri="{FF2B5EF4-FFF2-40B4-BE49-F238E27FC236}">
-                <a16:creationId xmlns:a16="http://schemas.microsoft.com/office/drawing/2014/main" id="{8A3E6AB5-97CE-4CD5-AE9E-F42EE1F5DB37}"/>
+                <a16:creationId xmlns:a16="http://schemas.microsoft.com/office/drawing/2014/main" id="{E1539F57-F36A-4847-B72B-17C47DEC5556}"/>
               </a:ext>
             </a:extLst>
           </p:cNvPr>
@@ -5920,7 +5920,7 @@
             <a:hlinkClick r:id="rId4"/>
             <a:extLst>
               <a:ext uri="{FF2B5EF4-FFF2-40B4-BE49-F238E27FC236}">
-                <a16:creationId xmlns:a16="http://schemas.microsoft.com/office/drawing/2014/main" id="{162CDFAE-1295-494A-B425-A86DC75B90BD}"/>
+                <a16:creationId xmlns:a16="http://schemas.microsoft.com/office/drawing/2014/main" id="{AACC5AA6-6776-43D6-B59F-82EF855929D5}"/>
               </a:ext>
             </a:extLst>
           </p:cNvPr>
@@ -5994,7 +5994,7 @@
           <p:cNvPr id="3" name="Rectangle 2">
             <a:extLst>
               <a:ext uri="{FF2B5EF4-FFF2-40B4-BE49-F238E27FC236}">
-                <a16:creationId xmlns:a16="http://schemas.microsoft.com/office/drawing/2014/main" id="{EE8D8398-2957-4731-9AC3-4893D710C126}"/>
+                <a16:creationId xmlns:a16="http://schemas.microsoft.com/office/drawing/2014/main" id="{787728EA-ADC7-4065-906C-8FF8C745871C}"/>
               </a:ext>
             </a:extLst>
           </p:cNvPr>
@@ -6056,7 +6056,7 @@
           <p:cNvPr id="4" name="Rectangle 3">
             <a:extLst>
               <a:ext uri="{FF2B5EF4-FFF2-40B4-BE49-F238E27FC236}">
-                <a16:creationId xmlns:a16="http://schemas.microsoft.com/office/drawing/2014/main" id="{EA3A6D2F-D188-4861-B2C7-1BB5626B52A3}"/>
+                <a16:creationId xmlns:a16="http://schemas.microsoft.com/office/drawing/2014/main" id="{2265E948-EB86-4E66-A9D4-71A5DEB63B7F}"/>
               </a:ext>
             </a:extLst>
           </p:cNvPr>
@@ -6123,7 +6123,7 @@
         </p:nvPicPr>
         <p:blipFill>
           <a:blip r:embed="rId5"/>
-          <a:srcRect l="10162" r="10162"/>
+          <a:srcRect l="10231" r="10231"/>
           <a:stretch>
             <a:fillRect/>
           </a:stretch>
@@ -6145,7 +6145,7 @@
           <p:cNvPr id="6" name="Rectangle: Rounded Corners 5">
             <a:extLst>
               <a:ext uri="{FF2B5EF4-FFF2-40B4-BE49-F238E27FC236}">
-                <a16:creationId xmlns:a16="http://schemas.microsoft.com/office/drawing/2014/main" id="{394934C8-D72E-4FDE-9EB2-B5954977E4AE}"/>
+                <a16:creationId xmlns:a16="http://schemas.microsoft.com/office/drawing/2014/main" id="{3FE03666-E8E7-4404-9FC4-031ADCF450A6}"/>
               </a:ext>
             </a:extLst>
           </p:cNvPr>
@@ -6178,7 +6178,7 @@
           <p:cNvPr id="7" name="Rectangle 6">
             <a:extLst>
               <a:ext uri="{FF2B5EF4-FFF2-40B4-BE49-F238E27FC236}">
-                <a16:creationId xmlns:a16="http://schemas.microsoft.com/office/drawing/2014/main" id="{EB6042C3-9B78-4635-AB6A-528DD87EEE9E}"/>
+                <a16:creationId xmlns:a16="http://schemas.microsoft.com/office/drawing/2014/main" id="{89071F57-08B0-4A77-87D2-70B8BAFFB987}"/>
               </a:ext>
             </a:extLst>
           </p:cNvPr>
@@ -6240,7 +6240,7 @@
           <p:cNvPr id="8" name="Rectangle 7">
             <a:extLst>
               <a:ext uri="{FF2B5EF4-FFF2-40B4-BE49-F238E27FC236}">
-                <a16:creationId xmlns:a16="http://schemas.microsoft.com/office/drawing/2014/main" id="{C88C4B52-A6CC-48D2-AB73-204FED7A1A56}"/>
+                <a16:creationId xmlns:a16="http://schemas.microsoft.com/office/drawing/2014/main" id="{FA865F4B-3309-4F4D-9A9F-08E8D40C0F5A}"/>
               </a:ext>
             </a:extLst>
           </p:cNvPr>
@@ -6302,7 +6302,7 @@
           <p:cNvPr id="9" name="Rectangle 8">
             <a:extLst>
               <a:ext uri="{FF2B5EF4-FFF2-40B4-BE49-F238E27FC236}">
-                <a16:creationId xmlns:a16="http://schemas.microsoft.com/office/drawing/2014/main" id="{E91A802D-B637-4976-ACD7-4946F655B608}"/>
+                <a16:creationId xmlns:a16="http://schemas.microsoft.com/office/drawing/2014/main" id="{E28689C0-046D-4BDD-81F4-669AD3E232B1}"/>
               </a:ext>
             </a:extLst>
           </p:cNvPr>
@@ -6364,7 +6364,7 @@
           <p:cNvPr id="10" name="Rectangle 9">
             <a:extLst>
               <a:ext uri="{FF2B5EF4-FFF2-40B4-BE49-F238E27FC236}">
-                <a16:creationId xmlns:a16="http://schemas.microsoft.com/office/drawing/2014/main" id="{DAFDAA98-2976-4317-9BE4-6588B9CD32C5}"/>
+                <a16:creationId xmlns:a16="http://schemas.microsoft.com/office/drawing/2014/main" id="{E9F1804B-46F4-486D-B45D-1C5F56B82452}"/>
               </a:ext>
             </a:extLst>
           </p:cNvPr>
@@ -6426,7 +6426,7 @@
           <p:cNvPr id="11" name="Rectangle 10">
             <a:extLst>
               <a:ext uri="{FF2B5EF4-FFF2-40B4-BE49-F238E27FC236}">
-                <a16:creationId xmlns:a16="http://schemas.microsoft.com/office/drawing/2014/main" id="{3E3D4AD1-D171-487F-840D-71A8BBD05FC3}"/>
+                <a16:creationId xmlns:a16="http://schemas.microsoft.com/office/drawing/2014/main" id="{A5094559-8222-481B-AC12-CD471BC21B1E}"/>
               </a:ext>
             </a:extLst>
           </p:cNvPr>
@@ -6488,7 +6488,7 @@
           <p:cNvPr id="12" name="Rectangle: Rounded Corners 11">
             <a:extLst>
               <a:ext uri="{FF2B5EF4-FFF2-40B4-BE49-F238E27FC236}">
-                <a16:creationId xmlns:a16="http://schemas.microsoft.com/office/drawing/2014/main" id="{6E2D2508-0923-4166-9036-27645CC60BE5}"/>
+                <a16:creationId xmlns:a16="http://schemas.microsoft.com/office/drawing/2014/main" id="{7A47A1E2-3647-46C0-918E-516185C6D5DE}"/>
               </a:ext>
             </a:extLst>
           </p:cNvPr>
@@ -6523,7 +6523,7 @@
           <p:cNvPr id="13" name="Rectangle 12">
             <a:extLst>
               <a:ext uri="{FF2B5EF4-FFF2-40B4-BE49-F238E27FC236}">
-                <a16:creationId xmlns:a16="http://schemas.microsoft.com/office/drawing/2014/main" id="{88E202AB-1F5D-4560-9F7D-DC2DB8C7401B}"/>
+                <a16:creationId xmlns:a16="http://schemas.microsoft.com/office/drawing/2014/main" id="{42A3AAA4-492B-4066-969F-0AF56DEFEEF6}"/>
               </a:ext>
             </a:extLst>
           </p:cNvPr>
@@ -6585,7 +6585,7 @@
           <p:cNvPr id="14" name="Rectangle 13">
             <a:extLst>
               <a:ext uri="{FF2B5EF4-FFF2-40B4-BE49-F238E27FC236}">
-                <a16:creationId xmlns:a16="http://schemas.microsoft.com/office/drawing/2014/main" id="{5FB09369-9FC8-4FF8-A936-2A18FDCCFC39}"/>
+                <a16:creationId xmlns:a16="http://schemas.microsoft.com/office/drawing/2014/main" id="{89132BAF-D900-4FC3-BFF6-BE111CC24894}"/>
               </a:ext>
             </a:extLst>
           </p:cNvPr>
@@ -6647,7 +6647,7 @@
           <p:cNvPr id="15" name="Rectangle 14">
             <a:extLst>
               <a:ext uri="{FF2B5EF4-FFF2-40B4-BE49-F238E27FC236}">
-                <a16:creationId xmlns:a16="http://schemas.microsoft.com/office/drawing/2014/main" id="{09C86D2E-D4C2-41B9-9AE9-9BF727CCF70A}"/>
+                <a16:creationId xmlns:a16="http://schemas.microsoft.com/office/drawing/2014/main" id="{034BCE20-75E0-42AE-AC1C-62A2C2C161DC}"/>
               </a:ext>
             </a:extLst>
           </p:cNvPr>
@@ -6709,7 +6709,7 @@
           <p:cNvPr id="16" name="Rectangle 15">
             <a:extLst>
               <a:ext uri="{FF2B5EF4-FFF2-40B4-BE49-F238E27FC236}">
-                <a16:creationId xmlns:a16="http://schemas.microsoft.com/office/drawing/2014/main" id="{41D3B78A-B188-400D-8760-4E3D1E34F204}"/>
+                <a16:creationId xmlns:a16="http://schemas.microsoft.com/office/drawing/2014/main" id="{39EB64E5-552B-4A73-BD20-F157F1B21DB6}"/>
               </a:ext>
             </a:extLst>
           </p:cNvPr>
@@ -6771,7 +6771,7 @@
           <p:cNvPr id="17" name="Rectangle 16">
             <a:extLst>
               <a:ext uri="{FF2B5EF4-FFF2-40B4-BE49-F238E27FC236}">
-                <a16:creationId xmlns:a16="http://schemas.microsoft.com/office/drawing/2014/main" id="{0AB672F3-268B-450A-9112-7E8AD52A19D0}"/>
+                <a16:creationId xmlns:a16="http://schemas.microsoft.com/office/drawing/2014/main" id="{D47CA950-C56F-4082-B292-65AB42808E6E}"/>
               </a:ext>
             </a:extLst>
           </p:cNvPr>
@@ -6833,7 +6833,7 @@
           <p:cNvPr id="18" name="Rectangle 17">
             <a:extLst>
               <a:ext uri="{FF2B5EF4-FFF2-40B4-BE49-F238E27FC236}">
-                <a16:creationId xmlns:a16="http://schemas.microsoft.com/office/drawing/2014/main" id="{C6EC6A94-5D9E-4AD1-9E7C-72981782CAC5}"/>
+                <a16:creationId xmlns:a16="http://schemas.microsoft.com/office/drawing/2014/main" id="{1E8C5D8F-5536-45D6-B4B5-4118C0D180C2}"/>
               </a:ext>
             </a:extLst>
           </p:cNvPr>
@@ -6895,7 +6895,7 @@
           <p:cNvPr id="19" name="Rectangle: Rounded Corners 18">
             <a:extLst>
               <a:ext uri="{FF2B5EF4-FFF2-40B4-BE49-F238E27FC236}">
-                <a16:creationId xmlns:a16="http://schemas.microsoft.com/office/drawing/2014/main" id="{C164DFA0-B2B0-40A0-8DE8-6562B5412E4F}"/>
+                <a16:creationId xmlns:a16="http://schemas.microsoft.com/office/drawing/2014/main" id="{4FEF37B8-4637-475D-A796-90CA649A2589}"/>
               </a:ext>
             </a:extLst>
           </p:cNvPr>
@@ -6930,7 +6930,7 @@
           <p:cNvPr id="20" name="Rectangle 19">
             <a:extLst>
               <a:ext uri="{FF2B5EF4-FFF2-40B4-BE49-F238E27FC236}">
-                <a16:creationId xmlns:a16="http://schemas.microsoft.com/office/drawing/2014/main" id="{9523547F-08FC-4D13-8432-51529A9A93CE}"/>
+                <a16:creationId xmlns:a16="http://schemas.microsoft.com/office/drawing/2014/main" id="{B04549CF-9FBD-4B3B-9D7D-916BAC15EFE7}"/>
               </a:ext>
             </a:extLst>
           </p:cNvPr>
@@ -6992,7 +6992,7 @@
           <p:cNvPr id="21" name="Rectangle 20">
             <a:extLst>
               <a:ext uri="{FF2B5EF4-FFF2-40B4-BE49-F238E27FC236}">
-                <a16:creationId xmlns:a16="http://schemas.microsoft.com/office/drawing/2014/main" id="{6510F82D-5FDF-4BF2-9D1A-D75B2215A6CD}"/>
+                <a16:creationId xmlns:a16="http://schemas.microsoft.com/office/drawing/2014/main" id="{8F00DB56-D782-4788-9509-E02E6802FE81}"/>
               </a:ext>
             </a:extLst>
           </p:cNvPr>
@@ -7023,7 +7023,7 @@
           <p:cNvPr id="22" name="Rectangle 21">
             <a:extLst>
               <a:ext uri="{FF2B5EF4-FFF2-40B4-BE49-F238E27FC236}">
-                <a16:creationId xmlns:a16="http://schemas.microsoft.com/office/drawing/2014/main" id="{C0147D6C-221A-46E8-B740-D962465BAA21}"/>
+                <a16:creationId xmlns:a16="http://schemas.microsoft.com/office/drawing/2014/main" id="{FC760951-7EB9-43DD-9DCB-1774B03C3A83}"/>
               </a:ext>
             </a:extLst>
           </p:cNvPr>
@@ -7085,7 +7085,7 @@
           <p:cNvPr id="23" name="Rectangle 22">
             <a:extLst>
               <a:ext uri="{FF2B5EF4-FFF2-40B4-BE49-F238E27FC236}">
-                <a16:creationId xmlns:a16="http://schemas.microsoft.com/office/drawing/2014/main" id="{5C8CC502-B37F-4E3C-A78C-C421DE515379}"/>
+                <a16:creationId xmlns:a16="http://schemas.microsoft.com/office/drawing/2014/main" id="{468DAF2B-B692-40BA-B490-922B79A9A550}"/>
               </a:ext>
             </a:extLst>
           </p:cNvPr>
@@ -7145,7 +7145,7 @@
     </p:spTree>
     <p:extLst>
       <p:ext uri="{BB962C8B-B14F-4D97-AF65-F5344CB8AC3E}">
-        <p14:creationId xmlns:p14="http://schemas.microsoft.com/office/powerpoint/2010/main" val="665951743"/>
+        <p14:creationId xmlns:p14="http://schemas.microsoft.com/office/powerpoint/2010/main" val="567718276"/>
       </p:ext>
     </p:extLst>
   </p:cSld>
@@ -7186,7 +7186,7 @@
             <a:hlinkClick r:id="rId3"/>
             <a:extLst>
               <a:ext uri="{FF2B5EF4-FFF2-40B4-BE49-F238E27FC236}">
-                <a16:creationId xmlns:a16="http://schemas.microsoft.com/office/drawing/2014/main" id="{AFF55512-C6A8-4318-B084-8B1320555145}"/>
+                <a16:creationId xmlns:a16="http://schemas.microsoft.com/office/drawing/2014/main" id="{12EE98C3-2B32-402E-AFFB-E9BB96C428ED}"/>
               </a:ext>
             </a:extLst>
           </p:cNvPr>
@@ -7261,7 +7261,7 @@
             <a:hlinkClick r:id="rId4"/>
             <a:extLst>
               <a:ext uri="{FF2B5EF4-FFF2-40B4-BE49-F238E27FC236}">
-                <a16:creationId xmlns:a16="http://schemas.microsoft.com/office/drawing/2014/main" id="{EEC43B04-079E-48BD-94A2-6E6E5E54169A}"/>
+                <a16:creationId xmlns:a16="http://schemas.microsoft.com/office/drawing/2014/main" id="{D9B0EBC2-7D07-4B85-A31F-DD15E515969D}"/>
               </a:ext>
             </a:extLst>
           </p:cNvPr>
@@ -7335,7 +7335,7 @@
           <p:cNvPr id="3" name="Rectangle 2">
             <a:extLst>
               <a:ext uri="{FF2B5EF4-FFF2-40B4-BE49-F238E27FC236}">
-                <a16:creationId xmlns:a16="http://schemas.microsoft.com/office/drawing/2014/main" id="{9754EC1B-F327-4EAA-B803-AC1F81775938}"/>
+                <a16:creationId xmlns:a16="http://schemas.microsoft.com/office/drawing/2014/main" id="{A375854B-A546-4AD2-9D48-C8B4BD3A2959}"/>
               </a:ext>
             </a:extLst>
           </p:cNvPr>
@@ -7397,7 +7397,7 @@
           <p:cNvPr id="4" name="Rectangle 3">
             <a:extLst>
               <a:ext uri="{FF2B5EF4-FFF2-40B4-BE49-F238E27FC236}">
-                <a16:creationId xmlns:a16="http://schemas.microsoft.com/office/drawing/2014/main" id="{3BFC7988-98B0-4092-9DFA-34F26049BFB7}"/>
+                <a16:creationId xmlns:a16="http://schemas.microsoft.com/office/drawing/2014/main" id="{10CA6C7F-7508-4195-B4E5-60059C40E6FE}"/>
               </a:ext>
             </a:extLst>
           </p:cNvPr>
@@ -7486,7 +7486,7 @@
           <p:cNvPr id="6" name="Rectangle: Rounded Corners 5">
             <a:extLst>
               <a:ext uri="{FF2B5EF4-FFF2-40B4-BE49-F238E27FC236}">
-                <a16:creationId xmlns:a16="http://schemas.microsoft.com/office/drawing/2014/main" id="{AF967250-F50B-4F3B-BB34-F93451278F17}"/>
+                <a16:creationId xmlns:a16="http://schemas.microsoft.com/office/drawing/2014/main" id="{910C27D3-A746-4B6F-B69E-EBB852870954}"/>
               </a:ext>
             </a:extLst>
           </p:cNvPr>
@@ -7519,7 +7519,7 @@
           <p:cNvPr id="7" name="Oval 6">
             <a:extLst>
               <a:ext uri="{FF2B5EF4-FFF2-40B4-BE49-F238E27FC236}">
-                <a16:creationId xmlns:a16="http://schemas.microsoft.com/office/drawing/2014/main" id="{3F3A2DB6-9621-4E56-BFA7-4BF653FAA621}"/>
+                <a16:creationId xmlns:a16="http://schemas.microsoft.com/office/drawing/2014/main" id="{62057308-6F58-4068-B359-C0D9824BA39B}"/>
               </a:ext>
             </a:extLst>
           </p:cNvPr>
@@ -7550,7 +7550,7 @@
           <p:cNvPr id="8" name="Rectangle 7">
             <a:extLst>
               <a:ext uri="{FF2B5EF4-FFF2-40B4-BE49-F238E27FC236}">
-                <a16:creationId xmlns:a16="http://schemas.microsoft.com/office/drawing/2014/main" id="{8C29C49B-9612-4A7E-A80E-67477F9661C6}"/>
+                <a16:creationId xmlns:a16="http://schemas.microsoft.com/office/drawing/2014/main" id="{9A249D15-23B2-40D7-973B-D935898F1EDE}"/>
               </a:ext>
             </a:extLst>
           </p:cNvPr>
@@ -7612,7 +7612,7 @@
           <p:cNvPr id="9" name="Rectangle: Rounded Corners 8">
             <a:extLst>
               <a:ext uri="{FF2B5EF4-FFF2-40B4-BE49-F238E27FC236}">
-                <a16:creationId xmlns:a16="http://schemas.microsoft.com/office/drawing/2014/main" id="{D42279D7-F825-47EC-8F67-9C5F4C48E63F}"/>
+                <a16:creationId xmlns:a16="http://schemas.microsoft.com/office/drawing/2014/main" id="{9CBF298D-11F9-46D2-ABA0-70DBF8ED5B37}"/>
               </a:ext>
             </a:extLst>
           </p:cNvPr>
@@ -7647,7 +7647,7 @@
           <p:cNvPr id="10" name="Rectangle 9">
             <a:extLst>
               <a:ext uri="{FF2B5EF4-FFF2-40B4-BE49-F238E27FC236}">
-                <a16:creationId xmlns:a16="http://schemas.microsoft.com/office/drawing/2014/main" id="{13E51911-AAF0-455C-A9C2-384966F2F7DF}"/>
+                <a16:creationId xmlns:a16="http://schemas.microsoft.com/office/drawing/2014/main" id="{223C48D6-DCA1-41F6-87EE-4DE98171636F}"/>
               </a:ext>
             </a:extLst>
           </p:cNvPr>
@@ -7709,7 +7709,7 @@
           <p:cNvPr id="11" name="Oval 10">
             <a:extLst>
               <a:ext uri="{FF2B5EF4-FFF2-40B4-BE49-F238E27FC236}">
-                <a16:creationId xmlns:a16="http://schemas.microsoft.com/office/drawing/2014/main" id="{FF10668F-AA1E-44A7-9B89-A6D6F2A730C1}"/>
+                <a16:creationId xmlns:a16="http://schemas.microsoft.com/office/drawing/2014/main" id="{27DFA09E-83F1-4322-B750-C99B1B2BF4B4}"/>
               </a:ext>
             </a:extLst>
           </p:cNvPr>
@@ -7740,7 +7740,7 @@
           <p:cNvPr id="12" name="Rectangle 11">
             <a:extLst>
               <a:ext uri="{FF2B5EF4-FFF2-40B4-BE49-F238E27FC236}">
-                <a16:creationId xmlns:a16="http://schemas.microsoft.com/office/drawing/2014/main" id="{28F8F462-AB5B-42FC-B387-35B0939A61A2}"/>
+                <a16:creationId xmlns:a16="http://schemas.microsoft.com/office/drawing/2014/main" id="{DA5FC74B-D023-4F7D-896D-3EA235BA375C}"/>
               </a:ext>
             </a:extLst>
           </p:cNvPr>
@@ -7802,7 +7802,7 @@
           <p:cNvPr id="13" name="Rectangle: Rounded Corners 12">
             <a:extLst>
               <a:ext uri="{FF2B5EF4-FFF2-40B4-BE49-F238E27FC236}">
-                <a16:creationId xmlns:a16="http://schemas.microsoft.com/office/drawing/2014/main" id="{0DD792DA-4EA5-484F-BE6E-B79D2D6BCBC5}"/>
+                <a16:creationId xmlns:a16="http://schemas.microsoft.com/office/drawing/2014/main" id="{0B296806-BDCE-4B6A-A87D-ED220EBB2090}"/>
               </a:ext>
             </a:extLst>
           </p:cNvPr>
@@ -7837,7 +7837,7 @@
           <p:cNvPr id="14" name="Rectangle 13">
             <a:extLst>
               <a:ext uri="{FF2B5EF4-FFF2-40B4-BE49-F238E27FC236}">
-                <a16:creationId xmlns:a16="http://schemas.microsoft.com/office/drawing/2014/main" id="{B63A8C12-4246-40C0-A035-DD8B9F0B66BA}"/>
+                <a16:creationId xmlns:a16="http://schemas.microsoft.com/office/drawing/2014/main" id="{70B465E3-284A-4B0D-A270-3E9EB02FA63B}"/>
               </a:ext>
             </a:extLst>
           </p:cNvPr>
@@ -7899,7 +7899,7 @@
           <p:cNvPr id="15" name="Oval 14">
             <a:extLst>
               <a:ext uri="{FF2B5EF4-FFF2-40B4-BE49-F238E27FC236}">
-                <a16:creationId xmlns:a16="http://schemas.microsoft.com/office/drawing/2014/main" id="{80FC0C7D-F994-4DF7-98DE-3B2EDA53EE69}"/>
+                <a16:creationId xmlns:a16="http://schemas.microsoft.com/office/drawing/2014/main" id="{9A8BFFCB-FC5E-4BE8-8D26-7872EBFD9CA0}"/>
               </a:ext>
             </a:extLst>
           </p:cNvPr>
@@ -7930,7 +7930,7 @@
           <p:cNvPr id="16" name="Rectangle 15">
             <a:extLst>
               <a:ext uri="{FF2B5EF4-FFF2-40B4-BE49-F238E27FC236}">
-                <a16:creationId xmlns:a16="http://schemas.microsoft.com/office/drawing/2014/main" id="{92D18C43-69A5-4006-A284-073F7A5B5C5B}"/>
+                <a16:creationId xmlns:a16="http://schemas.microsoft.com/office/drawing/2014/main" id="{EE2FCF2B-362D-49B7-86A7-8736EC962E6B}"/>
               </a:ext>
             </a:extLst>
           </p:cNvPr>
@@ -7992,7 +7992,7 @@
           <p:cNvPr id="17" name="Rectangle: Rounded Corners 16">
             <a:extLst>
               <a:ext uri="{FF2B5EF4-FFF2-40B4-BE49-F238E27FC236}">
-                <a16:creationId xmlns:a16="http://schemas.microsoft.com/office/drawing/2014/main" id="{B82DC5AD-1E38-44EB-889F-16C8E7A6A1F7}"/>
+                <a16:creationId xmlns:a16="http://schemas.microsoft.com/office/drawing/2014/main" id="{958159D9-0A52-44CF-A4AC-7B44F835F851}"/>
               </a:ext>
             </a:extLst>
           </p:cNvPr>
@@ -8027,7 +8027,7 @@
           <p:cNvPr id="18" name="Rectangle 17">
             <a:extLst>
               <a:ext uri="{FF2B5EF4-FFF2-40B4-BE49-F238E27FC236}">
-                <a16:creationId xmlns:a16="http://schemas.microsoft.com/office/drawing/2014/main" id="{AC610D74-29F9-474B-95F3-89539FA1151C}"/>
+                <a16:creationId xmlns:a16="http://schemas.microsoft.com/office/drawing/2014/main" id="{A6B78516-C38D-4669-9145-A321A28DCA4F}"/>
               </a:ext>
             </a:extLst>
           </p:cNvPr>
@@ -8089,7 +8089,7 @@
           <p:cNvPr id="19" name="Rectangle 18">
             <a:extLst>
               <a:ext uri="{FF2B5EF4-FFF2-40B4-BE49-F238E27FC236}">
-                <a16:creationId xmlns:a16="http://schemas.microsoft.com/office/drawing/2014/main" id="{BD29A887-E746-4C8C-98A0-EFC5E9EC731E}"/>
+                <a16:creationId xmlns:a16="http://schemas.microsoft.com/office/drawing/2014/main" id="{A6AF09C0-9D59-40A7-8B93-8B88E71B41A3}"/>
               </a:ext>
             </a:extLst>
           </p:cNvPr>
@@ -8120,7 +8120,7 @@
           <p:cNvPr id="20" name="Rectangle 19">
             <a:extLst>
               <a:ext uri="{FF2B5EF4-FFF2-40B4-BE49-F238E27FC236}">
-                <a16:creationId xmlns:a16="http://schemas.microsoft.com/office/drawing/2014/main" id="{4B7DC793-12BF-4195-9BF2-27F219AB5C56}"/>
+                <a16:creationId xmlns:a16="http://schemas.microsoft.com/office/drawing/2014/main" id="{A1A2F9C6-EED8-4114-81AF-F244ED49BF29}"/>
               </a:ext>
             </a:extLst>
           </p:cNvPr>
@@ -8182,7 +8182,7 @@
           <p:cNvPr id="21" name="Rectangle 20">
             <a:extLst>
               <a:ext uri="{FF2B5EF4-FFF2-40B4-BE49-F238E27FC236}">
-                <a16:creationId xmlns:a16="http://schemas.microsoft.com/office/drawing/2014/main" id="{C9AE14F7-759F-4E83-81E0-F97B0DA4238D}"/>
+                <a16:creationId xmlns:a16="http://schemas.microsoft.com/office/drawing/2014/main" id="{B5C39E03-B341-483E-91B7-5ECC82BA6B79}"/>
               </a:ext>
             </a:extLst>
           </p:cNvPr>
@@ -8242,7 +8242,7 @@
     </p:spTree>
     <p:extLst>
       <p:ext uri="{BB962C8B-B14F-4D97-AF65-F5344CB8AC3E}">
-        <p14:creationId xmlns:p14="http://schemas.microsoft.com/office/powerpoint/2010/main" val="1319460352"/>
+        <p14:creationId xmlns:p14="http://schemas.microsoft.com/office/powerpoint/2010/main" val="1665897545"/>
       </p:ext>
     </p:extLst>
   </p:cSld>
@@ -8283,7 +8283,7 @@
             <a:hlinkClick r:id="rId3"/>
             <a:extLst>
               <a:ext uri="{FF2B5EF4-FFF2-40B4-BE49-F238E27FC236}">
-                <a16:creationId xmlns:a16="http://schemas.microsoft.com/office/drawing/2014/main" id="{7166A0BE-2575-4284-ABC7-92E523EC265C}"/>
+                <a16:creationId xmlns:a16="http://schemas.microsoft.com/office/drawing/2014/main" id="{47853F5E-EA51-4F5D-A2AC-DE69A4EF387D}"/>
               </a:ext>
             </a:extLst>
           </p:cNvPr>
@@ -8358,7 +8358,7 @@
             <a:hlinkClick r:id="rId4"/>
             <a:extLst>
               <a:ext uri="{FF2B5EF4-FFF2-40B4-BE49-F238E27FC236}">
-                <a16:creationId xmlns:a16="http://schemas.microsoft.com/office/drawing/2014/main" id="{129B336A-5880-45F4-A97E-3DD62FE4B1F6}"/>
+                <a16:creationId xmlns:a16="http://schemas.microsoft.com/office/drawing/2014/main" id="{47C11889-C538-4377-97F8-D3BE5C00C1C4}"/>
               </a:ext>
             </a:extLst>
           </p:cNvPr>
@@ -8432,7 +8432,7 @@
           <p:cNvPr id="3" name="Rectangle 2">
             <a:extLst>
               <a:ext uri="{FF2B5EF4-FFF2-40B4-BE49-F238E27FC236}">
-                <a16:creationId xmlns:a16="http://schemas.microsoft.com/office/drawing/2014/main" id="{C14437B7-EDDA-4056-AAD2-82171013CF48}"/>
+                <a16:creationId xmlns:a16="http://schemas.microsoft.com/office/drawing/2014/main" id="{0D80CCE6-C7B9-4E00-B492-9B5EAC0BB1A8}"/>
               </a:ext>
             </a:extLst>
           </p:cNvPr>
@@ -8494,7 +8494,7 @@
           <p:cNvPr id="4" name="Rectangle 3">
             <a:extLst>
               <a:ext uri="{FF2B5EF4-FFF2-40B4-BE49-F238E27FC236}">
-                <a16:creationId xmlns:a16="http://schemas.microsoft.com/office/drawing/2014/main" id="{1522680E-E5B4-4095-B073-3109118306EA}"/>
+                <a16:creationId xmlns:a16="http://schemas.microsoft.com/office/drawing/2014/main" id="{5757271C-73A7-463C-8734-C4B027E09676}"/>
               </a:ext>
             </a:extLst>
           </p:cNvPr>
@@ -8561,7 +8561,7 @@
         </p:nvPicPr>
         <p:blipFill>
           <a:blip r:embed="rId5"/>
-          <a:srcRect t="10907" b="10907"/>
+          <a:srcRect t="10840" b="10840"/>
           <a:stretch>
             <a:fillRect/>
           </a:stretch>
@@ -8583,7 +8583,7 @@
           <p:cNvPr id="6" name="Rectangle: Rounded Corners 5">
             <a:extLst>
               <a:ext uri="{FF2B5EF4-FFF2-40B4-BE49-F238E27FC236}">
-                <a16:creationId xmlns:a16="http://schemas.microsoft.com/office/drawing/2014/main" id="{F08C6D8A-CD98-48A0-9ACD-EA058DA53A77}"/>
+                <a16:creationId xmlns:a16="http://schemas.microsoft.com/office/drawing/2014/main" id="{E914C5BB-A147-4B59-88AB-F2DB1924AFF6}"/>
               </a:ext>
             </a:extLst>
           </p:cNvPr>
@@ -8616,7 +8616,7 @@
           <p:cNvPr id="7" name="Oval 6">
             <a:extLst>
               <a:ext uri="{FF2B5EF4-FFF2-40B4-BE49-F238E27FC236}">
-                <a16:creationId xmlns:a16="http://schemas.microsoft.com/office/drawing/2014/main" id="{7431DE11-319F-4DE4-B144-3DA5B18F63CD}"/>
+                <a16:creationId xmlns:a16="http://schemas.microsoft.com/office/drawing/2014/main" id="{94B734CE-AD73-4041-9DBC-B676229F460E}"/>
               </a:ext>
             </a:extLst>
           </p:cNvPr>
@@ -8647,7 +8647,7 @@
           <p:cNvPr id="8" name="Rectangle 7">
             <a:extLst>
               <a:ext uri="{FF2B5EF4-FFF2-40B4-BE49-F238E27FC236}">
-                <a16:creationId xmlns:a16="http://schemas.microsoft.com/office/drawing/2014/main" id="{3CAD6D61-4A3C-440C-8263-E42E39CA9CFD}"/>
+                <a16:creationId xmlns:a16="http://schemas.microsoft.com/office/drawing/2014/main" id="{B1C4CB62-14E3-4981-82BC-1A0F75E88233}"/>
               </a:ext>
             </a:extLst>
           </p:cNvPr>
@@ -8709,7 +8709,7 @@
           <p:cNvPr id="9" name="Rectangle: Rounded Corners 8">
             <a:extLst>
               <a:ext uri="{FF2B5EF4-FFF2-40B4-BE49-F238E27FC236}">
-                <a16:creationId xmlns:a16="http://schemas.microsoft.com/office/drawing/2014/main" id="{0D0BA73F-EC12-4C78-9FC7-2B9B36D83D14}"/>
+                <a16:creationId xmlns:a16="http://schemas.microsoft.com/office/drawing/2014/main" id="{A8D84D8D-C7D8-4EFE-A9CD-79CB27BC04F5}"/>
               </a:ext>
             </a:extLst>
           </p:cNvPr>
@@ -8744,7 +8744,7 @@
           <p:cNvPr id="10" name="Rectangle 9">
             <a:extLst>
               <a:ext uri="{FF2B5EF4-FFF2-40B4-BE49-F238E27FC236}">
-                <a16:creationId xmlns:a16="http://schemas.microsoft.com/office/drawing/2014/main" id="{A226B049-A319-4327-9DA1-4E2279C40D49}"/>
+                <a16:creationId xmlns:a16="http://schemas.microsoft.com/office/drawing/2014/main" id="{8CC9638E-77DB-4511-B0D2-8B84CF6668D6}"/>
               </a:ext>
             </a:extLst>
           </p:cNvPr>
@@ -8806,7 +8806,7 @@
           <p:cNvPr id="11" name="Oval 10">
             <a:extLst>
               <a:ext uri="{FF2B5EF4-FFF2-40B4-BE49-F238E27FC236}">
-                <a16:creationId xmlns:a16="http://schemas.microsoft.com/office/drawing/2014/main" id="{436C4A52-E059-4DE5-AA4A-4A378AF9541E}"/>
+                <a16:creationId xmlns:a16="http://schemas.microsoft.com/office/drawing/2014/main" id="{C891CF3A-0A81-4CB3-9D99-D6CB2F91C168}"/>
               </a:ext>
             </a:extLst>
           </p:cNvPr>
@@ -8837,7 +8837,7 @@
           <p:cNvPr id="12" name="Rectangle 11">
             <a:extLst>
               <a:ext uri="{FF2B5EF4-FFF2-40B4-BE49-F238E27FC236}">
-                <a16:creationId xmlns:a16="http://schemas.microsoft.com/office/drawing/2014/main" id="{22258B77-1B16-4BD4-A361-505F60C49EB7}"/>
+                <a16:creationId xmlns:a16="http://schemas.microsoft.com/office/drawing/2014/main" id="{2A950D2F-8A1D-4FC7-A658-79B9B12798AF}"/>
               </a:ext>
             </a:extLst>
           </p:cNvPr>
@@ -8899,7 +8899,7 @@
           <p:cNvPr id="13" name="Rectangle: Rounded Corners 12">
             <a:extLst>
               <a:ext uri="{FF2B5EF4-FFF2-40B4-BE49-F238E27FC236}">
-                <a16:creationId xmlns:a16="http://schemas.microsoft.com/office/drawing/2014/main" id="{D4F92E99-314A-4610-93AD-FC0CC0E35C74}"/>
+                <a16:creationId xmlns:a16="http://schemas.microsoft.com/office/drawing/2014/main" id="{FB59B21B-77A3-4545-85B7-43D76A1D2047}"/>
               </a:ext>
             </a:extLst>
           </p:cNvPr>
@@ -8934,7 +8934,7 @@
           <p:cNvPr id="14" name="Rectangle 13">
             <a:extLst>
               <a:ext uri="{FF2B5EF4-FFF2-40B4-BE49-F238E27FC236}">
-                <a16:creationId xmlns:a16="http://schemas.microsoft.com/office/drawing/2014/main" id="{24D46D96-1D4B-4688-9AA6-ADFA6BFC270D}"/>
+                <a16:creationId xmlns:a16="http://schemas.microsoft.com/office/drawing/2014/main" id="{978E4BFA-B5F8-4B4B-B31B-303BC94CD753}"/>
               </a:ext>
             </a:extLst>
           </p:cNvPr>
@@ -8996,7 +8996,7 @@
           <p:cNvPr id="15" name="Oval 14">
             <a:extLst>
               <a:ext uri="{FF2B5EF4-FFF2-40B4-BE49-F238E27FC236}">
-                <a16:creationId xmlns:a16="http://schemas.microsoft.com/office/drawing/2014/main" id="{4148297D-8A72-4C8E-8BB6-1D8041F8CF61}"/>
+                <a16:creationId xmlns:a16="http://schemas.microsoft.com/office/drawing/2014/main" id="{83A14F1D-A74A-4F9D-ADAC-46D2A1DC4B36}"/>
               </a:ext>
             </a:extLst>
           </p:cNvPr>
@@ -9027,7 +9027,7 @@
           <p:cNvPr id="16" name="Rectangle 15">
             <a:extLst>
               <a:ext uri="{FF2B5EF4-FFF2-40B4-BE49-F238E27FC236}">
-                <a16:creationId xmlns:a16="http://schemas.microsoft.com/office/drawing/2014/main" id="{E25989E1-20EF-4B00-99D8-6694C31EEF7A}"/>
+                <a16:creationId xmlns:a16="http://schemas.microsoft.com/office/drawing/2014/main" id="{A3E7942E-399B-4656-8487-B3198E919195}"/>
               </a:ext>
             </a:extLst>
           </p:cNvPr>
@@ -9089,7 +9089,7 @@
           <p:cNvPr id="17" name="Rectangle: Rounded Corners 16">
             <a:extLst>
               <a:ext uri="{FF2B5EF4-FFF2-40B4-BE49-F238E27FC236}">
-                <a16:creationId xmlns:a16="http://schemas.microsoft.com/office/drawing/2014/main" id="{24927E8F-87DE-4418-8107-59665AD5EA83}"/>
+                <a16:creationId xmlns:a16="http://schemas.microsoft.com/office/drawing/2014/main" id="{332C1188-2CC2-4DF9-8982-249DE2118C39}"/>
               </a:ext>
             </a:extLst>
           </p:cNvPr>
@@ -9124,7 +9124,7 @@
           <p:cNvPr id="18" name="Rectangle 17">
             <a:extLst>
               <a:ext uri="{FF2B5EF4-FFF2-40B4-BE49-F238E27FC236}">
-                <a16:creationId xmlns:a16="http://schemas.microsoft.com/office/drawing/2014/main" id="{AA1DE7A1-7957-4C67-AB2F-8C8F0857E477}"/>
+                <a16:creationId xmlns:a16="http://schemas.microsoft.com/office/drawing/2014/main" id="{8BE1041F-7C8E-4C0D-AA50-5D52E0D536C4}"/>
               </a:ext>
             </a:extLst>
           </p:cNvPr>
@@ -9186,7 +9186,7 @@
           <p:cNvPr id="19" name="Rectangle 18">
             <a:extLst>
               <a:ext uri="{FF2B5EF4-FFF2-40B4-BE49-F238E27FC236}">
-                <a16:creationId xmlns:a16="http://schemas.microsoft.com/office/drawing/2014/main" id="{884A935E-8EE1-4751-A2F5-DEC648A8895C}"/>
+                <a16:creationId xmlns:a16="http://schemas.microsoft.com/office/drawing/2014/main" id="{F08F3E63-B774-46FC-912B-FB21391E7312}"/>
               </a:ext>
             </a:extLst>
           </p:cNvPr>
@@ -9217,7 +9217,7 @@
           <p:cNvPr id="20" name="Rectangle 19">
             <a:extLst>
               <a:ext uri="{FF2B5EF4-FFF2-40B4-BE49-F238E27FC236}">
-                <a16:creationId xmlns:a16="http://schemas.microsoft.com/office/drawing/2014/main" id="{3E011167-446E-4AD7-8E6F-E22BC0466377}"/>
+                <a16:creationId xmlns:a16="http://schemas.microsoft.com/office/drawing/2014/main" id="{8BB729B0-F728-4500-B25E-03656DB1F426}"/>
               </a:ext>
             </a:extLst>
           </p:cNvPr>
@@ -9279,7 +9279,7 @@
           <p:cNvPr id="21" name="Rectangle 20">
             <a:extLst>
               <a:ext uri="{FF2B5EF4-FFF2-40B4-BE49-F238E27FC236}">
-                <a16:creationId xmlns:a16="http://schemas.microsoft.com/office/drawing/2014/main" id="{64BE1775-ED56-4931-B238-79183C287E85}"/>
+                <a16:creationId xmlns:a16="http://schemas.microsoft.com/office/drawing/2014/main" id="{F3E7709E-72AD-469B-B90E-01A94F2B9B47}"/>
               </a:ext>
             </a:extLst>
           </p:cNvPr>
@@ -9339,7 +9339,7 @@
     </p:spTree>
     <p:extLst>
       <p:ext uri="{BB962C8B-B14F-4D97-AF65-F5344CB8AC3E}">
-        <p14:creationId xmlns:p14="http://schemas.microsoft.com/office/powerpoint/2010/main" val="1868565004"/>
+        <p14:creationId xmlns:p14="http://schemas.microsoft.com/office/powerpoint/2010/main" val="1295295518"/>
       </p:ext>
     </p:extLst>
   </p:cSld>
@@ -9380,7 +9380,7 @@
             <a:hlinkClick r:id="rId3"/>
             <a:extLst>
               <a:ext uri="{FF2B5EF4-FFF2-40B4-BE49-F238E27FC236}">
-                <a16:creationId xmlns:a16="http://schemas.microsoft.com/office/drawing/2014/main" id="{BFB6AB7E-F20E-4EA7-BC72-ADD7E6ADAB9D}"/>
+                <a16:creationId xmlns:a16="http://schemas.microsoft.com/office/drawing/2014/main" id="{D75CAAE8-845E-4235-98BC-4885965A967A}"/>
               </a:ext>
             </a:extLst>
           </p:cNvPr>
@@ -9455,7 +9455,7 @@
             <a:hlinkClick r:id="rId4"/>
             <a:extLst>
               <a:ext uri="{FF2B5EF4-FFF2-40B4-BE49-F238E27FC236}">
-                <a16:creationId xmlns:a16="http://schemas.microsoft.com/office/drawing/2014/main" id="{879DB936-5ACD-4CA3-A7A8-5DC8EAEC8F3F}"/>
+                <a16:creationId xmlns:a16="http://schemas.microsoft.com/office/drawing/2014/main" id="{8587582E-786A-45B7-BC40-92C25DA83E5C}"/>
               </a:ext>
             </a:extLst>
           </p:cNvPr>
@@ -9529,7 +9529,7 @@
           <p:cNvPr id="3" name="Rectangle 2">
             <a:extLst>
               <a:ext uri="{FF2B5EF4-FFF2-40B4-BE49-F238E27FC236}">
-                <a16:creationId xmlns:a16="http://schemas.microsoft.com/office/drawing/2014/main" id="{BC6B6EF0-C019-4B61-8288-B6160EE78D8D}"/>
+                <a16:creationId xmlns:a16="http://schemas.microsoft.com/office/drawing/2014/main" id="{14F599C1-1AAC-41A5-BA4F-EDF2D29EB928}"/>
               </a:ext>
             </a:extLst>
           </p:cNvPr>
@@ -9591,7 +9591,7 @@
           <p:cNvPr id="4" name="Rectangle 3">
             <a:extLst>
               <a:ext uri="{FF2B5EF4-FFF2-40B4-BE49-F238E27FC236}">
-                <a16:creationId xmlns:a16="http://schemas.microsoft.com/office/drawing/2014/main" id="{9D222C5C-CFEB-44A5-B0B7-CEF3DADB72FC}"/>
+                <a16:creationId xmlns:a16="http://schemas.microsoft.com/office/drawing/2014/main" id="{65C0D65F-87CC-4B65-8C88-0AEDC44CC6B0}"/>
               </a:ext>
             </a:extLst>
           </p:cNvPr>
@@ -9680,7 +9680,7 @@
           <p:cNvPr id="6" name="Rectangle: Rounded Corners 5">
             <a:extLst>
               <a:ext uri="{FF2B5EF4-FFF2-40B4-BE49-F238E27FC236}">
-                <a16:creationId xmlns:a16="http://schemas.microsoft.com/office/drawing/2014/main" id="{359F6A1D-AB46-45A6-8B2E-6770FE267B90}"/>
+                <a16:creationId xmlns:a16="http://schemas.microsoft.com/office/drawing/2014/main" id="{7711E1A5-224D-49AF-96BA-F5ACD97B4EC1}"/>
               </a:ext>
             </a:extLst>
           </p:cNvPr>
@@ -9713,7 +9713,7 @@
           <p:cNvPr id="7" name="Oval 6">
             <a:extLst>
               <a:ext uri="{FF2B5EF4-FFF2-40B4-BE49-F238E27FC236}">
-                <a16:creationId xmlns:a16="http://schemas.microsoft.com/office/drawing/2014/main" id="{B7F93CB8-1F05-440F-8812-1D8FE5274685}"/>
+                <a16:creationId xmlns:a16="http://schemas.microsoft.com/office/drawing/2014/main" id="{CBD770F6-4788-47EA-81F1-DADC12C2B728}"/>
               </a:ext>
             </a:extLst>
           </p:cNvPr>
@@ -9744,7 +9744,7 @@
           <p:cNvPr id="8" name="Rectangle 7">
             <a:extLst>
               <a:ext uri="{FF2B5EF4-FFF2-40B4-BE49-F238E27FC236}">
-                <a16:creationId xmlns:a16="http://schemas.microsoft.com/office/drawing/2014/main" id="{43AE438F-25DC-4B06-91B3-CB2D55B10321}"/>
+                <a16:creationId xmlns:a16="http://schemas.microsoft.com/office/drawing/2014/main" id="{A2B05C49-224A-43B0-8384-E736B109321E}"/>
               </a:ext>
             </a:extLst>
           </p:cNvPr>
@@ -9806,7 +9806,7 @@
           <p:cNvPr id="9" name="Rectangle: Rounded Corners 8">
             <a:extLst>
               <a:ext uri="{FF2B5EF4-FFF2-40B4-BE49-F238E27FC236}">
-                <a16:creationId xmlns:a16="http://schemas.microsoft.com/office/drawing/2014/main" id="{6FBB4713-5491-4FB9-BD6D-33AB2E8121E3}"/>
+                <a16:creationId xmlns:a16="http://schemas.microsoft.com/office/drawing/2014/main" id="{2819E1ED-A25D-4EB9-AF35-55CFF79E0511}"/>
               </a:ext>
             </a:extLst>
           </p:cNvPr>
@@ -9841,7 +9841,7 @@
           <p:cNvPr id="10" name="Rectangle 9">
             <a:extLst>
               <a:ext uri="{FF2B5EF4-FFF2-40B4-BE49-F238E27FC236}">
-                <a16:creationId xmlns:a16="http://schemas.microsoft.com/office/drawing/2014/main" id="{C59D2F48-6561-4DA0-B539-EF4072FBC1DD}"/>
+                <a16:creationId xmlns:a16="http://schemas.microsoft.com/office/drawing/2014/main" id="{5A0861EB-1382-463B-B93A-C1BDCE8EB251}"/>
               </a:ext>
             </a:extLst>
           </p:cNvPr>
@@ -9903,7 +9903,7 @@
           <p:cNvPr id="11" name="Oval 10">
             <a:extLst>
               <a:ext uri="{FF2B5EF4-FFF2-40B4-BE49-F238E27FC236}">
-                <a16:creationId xmlns:a16="http://schemas.microsoft.com/office/drawing/2014/main" id="{789CC24F-031A-46EE-B8B0-D92406173ED1}"/>
+                <a16:creationId xmlns:a16="http://schemas.microsoft.com/office/drawing/2014/main" id="{F5E7FFCB-4D67-4D4A-8E9B-933B81B14B53}"/>
               </a:ext>
             </a:extLst>
           </p:cNvPr>
@@ -9934,7 +9934,7 @@
           <p:cNvPr id="12" name="Rectangle 11">
             <a:extLst>
               <a:ext uri="{FF2B5EF4-FFF2-40B4-BE49-F238E27FC236}">
-                <a16:creationId xmlns:a16="http://schemas.microsoft.com/office/drawing/2014/main" id="{9AC09C3D-9942-474B-BEBD-4D553CFD1D80}"/>
+                <a16:creationId xmlns:a16="http://schemas.microsoft.com/office/drawing/2014/main" id="{42536664-D7E8-4716-AD1B-87EC73A9033D}"/>
               </a:ext>
             </a:extLst>
           </p:cNvPr>
@@ -9996,7 +9996,7 @@
           <p:cNvPr id="13" name="Rectangle: Rounded Corners 12">
             <a:extLst>
               <a:ext uri="{FF2B5EF4-FFF2-40B4-BE49-F238E27FC236}">
-                <a16:creationId xmlns:a16="http://schemas.microsoft.com/office/drawing/2014/main" id="{4105503B-0823-4922-8C17-27D50DF2E305}"/>
+                <a16:creationId xmlns:a16="http://schemas.microsoft.com/office/drawing/2014/main" id="{E65D8B24-48D7-4DDC-AE63-D5F150EA2314}"/>
               </a:ext>
             </a:extLst>
           </p:cNvPr>
@@ -10031,7 +10031,7 @@
           <p:cNvPr id="14" name="Rectangle 13">
             <a:extLst>
               <a:ext uri="{FF2B5EF4-FFF2-40B4-BE49-F238E27FC236}">
-                <a16:creationId xmlns:a16="http://schemas.microsoft.com/office/drawing/2014/main" id="{0D9D3971-C372-46D4-9418-5B88DFFF65CC}"/>
+                <a16:creationId xmlns:a16="http://schemas.microsoft.com/office/drawing/2014/main" id="{2C5C1E4B-140B-4A70-AAA5-50F6FC42DD1E}"/>
               </a:ext>
             </a:extLst>
           </p:cNvPr>
@@ -10093,7 +10093,7 @@
           <p:cNvPr id="15" name="Oval 14">
             <a:extLst>
               <a:ext uri="{FF2B5EF4-FFF2-40B4-BE49-F238E27FC236}">
-                <a16:creationId xmlns:a16="http://schemas.microsoft.com/office/drawing/2014/main" id="{1434975C-48EB-4517-9B46-C7E8E2178625}"/>
+                <a16:creationId xmlns:a16="http://schemas.microsoft.com/office/drawing/2014/main" id="{3B2EB6E6-3CB5-4023-A8C4-58A847A1F792}"/>
               </a:ext>
             </a:extLst>
           </p:cNvPr>
@@ -10124,7 +10124,7 @@
           <p:cNvPr id="16" name="Rectangle 15">
             <a:extLst>
               <a:ext uri="{FF2B5EF4-FFF2-40B4-BE49-F238E27FC236}">
-                <a16:creationId xmlns:a16="http://schemas.microsoft.com/office/drawing/2014/main" id="{5CB4FDA8-670D-4C00-A035-51B50FF097AC}"/>
+                <a16:creationId xmlns:a16="http://schemas.microsoft.com/office/drawing/2014/main" id="{4FD6FFD0-9539-4E0D-807C-B891578A7B80}"/>
               </a:ext>
             </a:extLst>
           </p:cNvPr>
@@ -10186,7 +10186,7 @@
           <p:cNvPr id="17" name="Rectangle: Rounded Corners 16">
             <a:extLst>
               <a:ext uri="{FF2B5EF4-FFF2-40B4-BE49-F238E27FC236}">
-                <a16:creationId xmlns:a16="http://schemas.microsoft.com/office/drawing/2014/main" id="{ECACC00A-6ACC-4A5C-8B64-A9D4F28C3B23}"/>
+                <a16:creationId xmlns:a16="http://schemas.microsoft.com/office/drawing/2014/main" id="{E44EFBD1-0107-40F0-8128-2673EADC5359}"/>
               </a:ext>
             </a:extLst>
           </p:cNvPr>
@@ -10221,7 +10221,7 @@
           <p:cNvPr id="18" name="Rectangle 17">
             <a:extLst>
               <a:ext uri="{FF2B5EF4-FFF2-40B4-BE49-F238E27FC236}">
-                <a16:creationId xmlns:a16="http://schemas.microsoft.com/office/drawing/2014/main" id="{26959CF4-9917-43CF-92FA-374BBE1F274C}"/>
+                <a16:creationId xmlns:a16="http://schemas.microsoft.com/office/drawing/2014/main" id="{79FFD718-0164-44D6-AE1D-4BE3D01CDF6D}"/>
               </a:ext>
             </a:extLst>
           </p:cNvPr>
@@ -10283,7 +10283,7 @@
           <p:cNvPr id="19" name="Rectangle 18">
             <a:extLst>
               <a:ext uri="{FF2B5EF4-FFF2-40B4-BE49-F238E27FC236}">
-                <a16:creationId xmlns:a16="http://schemas.microsoft.com/office/drawing/2014/main" id="{D86A4372-0462-4DC3-B885-BEC17AF9A565}"/>
+                <a16:creationId xmlns:a16="http://schemas.microsoft.com/office/drawing/2014/main" id="{784FE03B-2644-4189-9BB8-5EE549C203D2}"/>
               </a:ext>
             </a:extLst>
           </p:cNvPr>
@@ -10314,7 +10314,7 @@
           <p:cNvPr id="20" name="Rectangle 19">
             <a:extLst>
               <a:ext uri="{FF2B5EF4-FFF2-40B4-BE49-F238E27FC236}">
-                <a16:creationId xmlns:a16="http://schemas.microsoft.com/office/drawing/2014/main" id="{5FB62129-47DE-4937-A73A-0E35AB8A7873}"/>
+                <a16:creationId xmlns:a16="http://schemas.microsoft.com/office/drawing/2014/main" id="{206AFC67-900A-44C7-BACD-D7DAF718C944}"/>
               </a:ext>
             </a:extLst>
           </p:cNvPr>
@@ -10376,7 +10376,7 @@
           <p:cNvPr id="21" name="Rectangle 20">
             <a:extLst>
               <a:ext uri="{FF2B5EF4-FFF2-40B4-BE49-F238E27FC236}">
-                <a16:creationId xmlns:a16="http://schemas.microsoft.com/office/drawing/2014/main" id="{E62280DE-86E3-4CF1-B333-23C3F150FC9F}"/>
+                <a16:creationId xmlns:a16="http://schemas.microsoft.com/office/drawing/2014/main" id="{EC87AAC3-7F8C-4071-8341-6597242834AE}"/>
               </a:ext>
             </a:extLst>
           </p:cNvPr>
@@ -10436,7 +10436,7 @@
     </p:spTree>
     <p:extLst>
       <p:ext uri="{BB962C8B-B14F-4D97-AF65-F5344CB8AC3E}">
-        <p14:creationId xmlns:p14="http://schemas.microsoft.com/office/powerpoint/2010/main" val="424942448"/>
+        <p14:creationId xmlns:p14="http://schemas.microsoft.com/office/powerpoint/2010/main" val="323909242"/>
       </p:ext>
     </p:extLst>
   </p:cSld>
@@ -10477,7 +10477,7 @@
             <a:hlinkClick r:id="rId3"/>
             <a:extLst>
               <a:ext uri="{FF2B5EF4-FFF2-40B4-BE49-F238E27FC236}">
-                <a16:creationId xmlns:a16="http://schemas.microsoft.com/office/drawing/2014/main" id="{C5546542-4E25-4009-A984-EB30A58D0427}"/>
+                <a16:creationId xmlns:a16="http://schemas.microsoft.com/office/drawing/2014/main" id="{BA0D5680-7E89-4352-8C04-64C11CEC4BB8}"/>
               </a:ext>
             </a:extLst>
           </p:cNvPr>
@@ -10552,7 +10552,7 @@
             <a:hlinkClick r:id="rId4"/>
             <a:extLst>
               <a:ext uri="{FF2B5EF4-FFF2-40B4-BE49-F238E27FC236}">
-                <a16:creationId xmlns:a16="http://schemas.microsoft.com/office/drawing/2014/main" id="{ACD05B51-BF93-44C3-844F-D0EF7B1DB321}"/>
+                <a16:creationId xmlns:a16="http://schemas.microsoft.com/office/drawing/2014/main" id="{747C0F4F-C365-4777-B864-DE315E633721}"/>
               </a:ext>
             </a:extLst>
           </p:cNvPr>
@@ -10626,7 +10626,7 @@
           <p:cNvPr id="3" name="Rectangle 2">
             <a:extLst>
               <a:ext uri="{FF2B5EF4-FFF2-40B4-BE49-F238E27FC236}">
-                <a16:creationId xmlns:a16="http://schemas.microsoft.com/office/drawing/2014/main" id="{A41AE07D-839A-416D-A244-8163C5419718}"/>
+                <a16:creationId xmlns:a16="http://schemas.microsoft.com/office/drawing/2014/main" id="{3C3376D0-D267-4113-A9A9-8C427F90FEE5}"/>
               </a:ext>
             </a:extLst>
           </p:cNvPr>
@@ -10688,7 +10688,7 @@
           <p:cNvPr id="4" name="Rectangle 3">
             <a:extLst>
               <a:ext uri="{FF2B5EF4-FFF2-40B4-BE49-F238E27FC236}">
-                <a16:creationId xmlns:a16="http://schemas.microsoft.com/office/drawing/2014/main" id="{EC0C8D03-6BEA-49B7-B225-FE77416B436B}"/>
+                <a16:creationId xmlns:a16="http://schemas.microsoft.com/office/drawing/2014/main" id="{E2C6E94F-3648-4F6E-9A30-7A05C6DCA02B}"/>
               </a:ext>
             </a:extLst>
           </p:cNvPr>
@@ -10777,7 +10777,7 @@
           <p:cNvPr id="6" name="Rectangle: Rounded Corners 5">
             <a:extLst>
               <a:ext uri="{FF2B5EF4-FFF2-40B4-BE49-F238E27FC236}">
-                <a16:creationId xmlns:a16="http://schemas.microsoft.com/office/drawing/2014/main" id="{F0C18CBF-E7B3-4DE7-AC5F-9DB7CCD3226C}"/>
+                <a16:creationId xmlns:a16="http://schemas.microsoft.com/office/drawing/2014/main" id="{089DA5B6-DC69-40E6-B3AE-F8A5E32C4D2F}"/>
               </a:ext>
             </a:extLst>
           </p:cNvPr>
@@ -10810,7 +10810,7 @@
           <p:cNvPr id="7" name="Oval 6">
             <a:extLst>
               <a:ext uri="{FF2B5EF4-FFF2-40B4-BE49-F238E27FC236}">
-                <a16:creationId xmlns:a16="http://schemas.microsoft.com/office/drawing/2014/main" id="{F011F17F-E42A-4083-AB68-9BD3BDD0F254}"/>
+                <a16:creationId xmlns:a16="http://schemas.microsoft.com/office/drawing/2014/main" id="{A8DE1B61-6D94-4C6F-9523-D428143B40AC}"/>
               </a:ext>
             </a:extLst>
           </p:cNvPr>
@@ -10841,7 +10841,7 @@
           <p:cNvPr id="8" name="Rectangle 7">
             <a:extLst>
               <a:ext uri="{FF2B5EF4-FFF2-40B4-BE49-F238E27FC236}">
-                <a16:creationId xmlns:a16="http://schemas.microsoft.com/office/drawing/2014/main" id="{F1E2CEF4-A29A-41FE-A778-73EBA1A769A3}"/>
+                <a16:creationId xmlns:a16="http://schemas.microsoft.com/office/drawing/2014/main" id="{9E3C0449-9F5F-4142-9FE4-955B084234EF}"/>
               </a:ext>
             </a:extLst>
           </p:cNvPr>
@@ -10903,7 +10903,7 @@
           <p:cNvPr id="9" name="Rectangle: Rounded Corners 8">
             <a:extLst>
               <a:ext uri="{FF2B5EF4-FFF2-40B4-BE49-F238E27FC236}">
-                <a16:creationId xmlns:a16="http://schemas.microsoft.com/office/drawing/2014/main" id="{4FAF12DD-1487-4DD9-AC3D-DE0211A1A19D}"/>
+                <a16:creationId xmlns:a16="http://schemas.microsoft.com/office/drawing/2014/main" id="{93743600-A73E-463B-ACB4-0DF3BD15D0CB}"/>
               </a:ext>
             </a:extLst>
           </p:cNvPr>
@@ -10938,7 +10938,7 @@
           <p:cNvPr id="10" name="Rectangle 9">
             <a:extLst>
               <a:ext uri="{FF2B5EF4-FFF2-40B4-BE49-F238E27FC236}">
-                <a16:creationId xmlns:a16="http://schemas.microsoft.com/office/drawing/2014/main" id="{1090A945-04FF-4630-8D1D-2028126CC86F}"/>
+                <a16:creationId xmlns:a16="http://schemas.microsoft.com/office/drawing/2014/main" id="{243A3C42-E7F7-475B-9506-42905A5C475E}"/>
               </a:ext>
             </a:extLst>
           </p:cNvPr>
@@ -11000,7 +11000,7 @@
           <p:cNvPr id="11" name="Oval 10">
             <a:extLst>
               <a:ext uri="{FF2B5EF4-FFF2-40B4-BE49-F238E27FC236}">
-                <a16:creationId xmlns:a16="http://schemas.microsoft.com/office/drawing/2014/main" id="{07E90388-7CDC-43AF-913F-386A7F8A0C50}"/>
+                <a16:creationId xmlns:a16="http://schemas.microsoft.com/office/drawing/2014/main" id="{CB1DFB33-BCDC-4863-8460-3C328985ABB0}"/>
               </a:ext>
             </a:extLst>
           </p:cNvPr>
@@ -11031,7 +11031,7 @@
           <p:cNvPr id="12" name="Rectangle 11">
             <a:extLst>
               <a:ext uri="{FF2B5EF4-FFF2-40B4-BE49-F238E27FC236}">
-                <a16:creationId xmlns:a16="http://schemas.microsoft.com/office/drawing/2014/main" id="{87CCE25B-E090-4BD8-AE2F-A47C103AECF4}"/>
+                <a16:creationId xmlns:a16="http://schemas.microsoft.com/office/drawing/2014/main" id="{1A1BC7D9-CB6A-4182-A709-9EB3C7E6FBD0}"/>
               </a:ext>
             </a:extLst>
           </p:cNvPr>
@@ -11093,7 +11093,7 @@
           <p:cNvPr id="13" name="Rectangle: Rounded Corners 12">
             <a:extLst>
               <a:ext uri="{FF2B5EF4-FFF2-40B4-BE49-F238E27FC236}">
-                <a16:creationId xmlns:a16="http://schemas.microsoft.com/office/drawing/2014/main" id="{A165B028-1B88-443A-98A3-7319932D2372}"/>
+                <a16:creationId xmlns:a16="http://schemas.microsoft.com/office/drawing/2014/main" id="{D2F8A8FA-A6EF-48BB-B4C6-1C5685803855}"/>
               </a:ext>
             </a:extLst>
           </p:cNvPr>
@@ -11128,7 +11128,7 @@
           <p:cNvPr id="14" name="Rectangle 13">
             <a:extLst>
               <a:ext uri="{FF2B5EF4-FFF2-40B4-BE49-F238E27FC236}">
-                <a16:creationId xmlns:a16="http://schemas.microsoft.com/office/drawing/2014/main" id="{BA2BB67E-B995-43CD-B3C5-AD577AB8E547}"/>
+                <a16:creationId xmlns:a16="http://schemas.microsoft.com/office/drawing/2014/main" id="{E8C9A394-C066-4F01-AD5B-B0C59047492E}"/>
               </a:ext>
             </a:extLst>
           </p:cNvPr>
@@ -11190,7 +11190,7 @@
           <p:cNvPr id="15" name="Oval 14">
             <a:extLst>
               <a:ext uri="{FF2B5EF4-FFF2-40B4-BE49-F238E27FC236}">
-                <a16:creationId xmlns:a16="http://schemas.microsoft.com/office/drawing/2014/main" id="{AF8011FB-2D2D-4466-86A8-88CD95C8678B}"/>
+                <a16:creationId xmlns:a16="http://schemas.microsoft.com/office/drawing/2014/main" id="{B3949C80-F304-4739-8A47-8A24AC5DD828}"/>
               </a:ext>
             </a:extLst>
           </p:cNvPr>
@@ -11221,7 +11221,7 @@
           <p:cNvPr id="16" name="Rectangle 15">
             <a:extLst>
               <a:ext uri="{FF2B5EF4-FFF2-40B4-BE49-F238E27FC236}">
-                <a16:creationId xmlns:a16="http://schemas.microsoft.com/office/drawing/2014/main" id="{FC2714F2-A9E2-45F9-9A56-BD03C733B4E5}"/>
+                <a16:creationId xmlns:a16="http://schemas.microsoft.com/office/drawing/2014/main" id="{BCD13074-58A6-4727-8061-1C6922BDCE5D}"/>
               </a:ext>
             </a:extLst>
           </p:cNvPr>
@@ -11283,7 +11283,7 @@
           <p:cNvPr id="17" name="Rectangle: Rounded Corners 16">
             <a:extLst>
               <a:ext uri="{FF2B5EF4-FFF2-40B4-BE49-F238E27FC236}">
-                <a16:creationId xmlns:a16="http://schemas.microsoft.com/office/drawing/2014/main" id="{6062E744-B631-4330-81A3-AC32B02E5993}"/>
+                <a16:creationId xmlns:a16="http://schemas.microsoft.com/office/drawing/2014/main" id="{744D5D16-43CC-48B4-B8CC-75288B9C7E4C}"/>
               </a:ext>
             </a:extLst>
           </p:cNvPr>
@@ -11318,7 +11318,7 @@
           <p:cNvPr id="18" name="Rectangle 17">
             <a:extLst>
               <a:ext uri="{FF2B5EF4-FFF2-40B4-BE49-F238E27FC236}">
-                <a16:creationId xmlns:a16="http://schemas.microsoft.com/office/drawing/2014/main" id="{A845F822-23AB-4A61-991F-49C6BB54063E}"/>
+                <a16:creationId xmlns:a16="http://schemas.microsoft.com/office/drawing/2014/main" id="{8747D22B-D3DB-4EEC-A758-DF0EB9B8E1F8}"/>
               </a:ext>
             </a:extLst>
           </p:cNvPr>
@@ -11380,7 +11380,7 @@
           <p:cNvPr id="19" name="Rectangle 18">
             <a:extLst>
               <a:ext uri="{FF2B5EF4-FFF2-40B4-BE49-F238E27FC236}">
-                <a16:creationId xmlns:a16="http://schemas.microsoft.com/office/drawing/2014/main" id="{06010ADA-964C-4D84-A3EC-0E951418D782}"/>
+                <a16:creationId xmlns:a16="http://schemas.microsoft.com/office/drawing/2014/main" id="{6CF1FA4A-6AA2-4FDF-AF0D-0021F37B0B55}"/>
               </a:ext>
             </a:extLst>
           </p:cNvPr>
@@ -11411,7 +11411,7 @@
           <p:cNvPr id="20" name="Rectangle 19">
             <a:extLst>
               <a:ext uri="{FF2B5EF4-FFF2-40B4-BE49-F238E27FC236}">
-                <a16:creationId xmlns:a16="http://schemas.microsoft.com/office/drawing/2014/main" id="{3068C8C3-8991-45B7-9530-F350457E2D6F}"/>
+                <a16:creationId xmlns:a16="http://schemas.microsoft.com/office/drawing/2014/main" id="{A67397D1-4D50-43BF-A75D-45BC51B53E1A}"/>
               </a:ext>
             </a:extLst>
           </p:cNvPr>
@@ -11473,7 +11473,7 @@
           <p:cNvPr id="21" name="Rectangle 20">
             <a:extLst>
               <a:ext uri="{FF2B5EF4-FFF2-40B4-BE49-F238E27FC236}">
-                <a16:creationId xmlns:a16="http://schemas.microsoft.com/office/drawing/2014/main" id="{141644EA-0A48-46D8-A436-E67CA935E6C9}"/>
+                <a16:creationId xmlns:a16="http://schemas.microsoft.com/office/drawing/2014/main" id="{6DA486B0-F1D6-4A7B-9E19-3DE8F0DF7CD0}"/>
               </a:ext>
             </a:extLst>
           </p:cNvPr>
@@ -11533,7 +11533,7 @@
     </p:spTree>
     <p:extLst>
       <p:ext uri="{BB962C8B-B14F-4D97-AF65-F5344CB8AC3E}">
-        <p14:creationId xmlns:p14="http://schemas.microsoft.com/office/powerpoint/2010/main" val="1213362300"/>
+        <p14:creationId xmlns:p14="http://schemas.microsoft.com/office/powerpoint/2010/main" val="1190942000"/>
       </p:ext>
     </p:extLst>
   </p:cSld>
@@ -11574,7 +11574,7 @@
             <a:hlinkClick r:id="rId3"/>
             <a:extLst>
               <a:ext uri="{FF2B5EF4-FFF2-40B4-BE49-F238E27FC236}">
-                <a16:creationId xmlns:a16="http://schemas.microsoft.com/office/drawing/2014/main" id="{1AFA6C53-32D1-4280-A22B-3539A011A35B}"/>
+                <a16:creationId xmlns:a16="http://schemas.microsoft.com/office/drawing/2014/main" id="{0E7D5B14-25DB-4381-A27B-5437F28235FD}"/>
               </a:ext>
             </a:extLst>
           </p:cNvPr>
@@ -11649,7 +11649,7 @@
             <a:hlinkClick r:id="rId4"/>
             <a:extLst>
               <a:ext uri="{FF2B5EF4-FFF2-40B4-BE49-F238E27FC236}">
-                <a16:creationId xmlns:a16="http://schemas.microsoft.com/office/drawing/2014/main" id="{2D02A667-349E-4067-AF69-1F66DED2E00D}"/>
+                <a16:creationId xmlns:a16="http://schemas.microsoft.com/office/drawing/2014/main" id="{05B47CCF-879F-45EC-A6B6-BE607DFDD05E}"/>
               </a:ext>
             </a:extLst>
           </p:cNvPr>
@@ -11723,7 +11723,7 @@
           <p:cNvPr id="3" name="Rectangle 2">
             <a:extLst>
               <a:ext uri="{FF2B5EF4-FFF2-40B4-BE49-F238E27FC236}">
-                <a16:creationId xmlns:a16="http://schemas.microsoft.com/office/drawing/2014/main" id="{F53AEB06-2366-4E83-86FD-C3A67D16BCA2}"/>
+                <a16:creationId xmlns:a16="http://schemas.microsoft.com/office/drawing/2014/main" id="{A6B4EED8-8C87-4B92-BABF-A67602D1B984}"/>
               </a:ext>
             </a:extLst>
           </p:cNvPr>
@@ -11785,7 +11785,7 @@
           <p:cNvPr id="4" name="Rectangle 3">
             <a:extLst>
               <a:ext uri="{FF2B5EF4-FFF2-40B4-BE49-F238E27FC236}">
-                <a16:creationId xmlns:a16="http://schemas.microsoft.com/office/drawing/2014/main" id="{18DD419C-E268-4C6D-B0CD-9B412B968B48}"/>
+                <a16:creationId xmlns:a16="http://schemas.microsoft.com/office/drawing/2014/main" id="{5231B501-3B22-483D-B736-C448979A3814}"/>
               </a:ext>
             </a:extLst>
           </p:cNvPr>
@@ -11874,7 +11874,7 @@
           <p:cNvPr id="6" name="Rectangle: Rounded Corners 5">
             <a:extLst>
               <a:ext uri="{FF2B5EF4-FFF2-40B4-BE49-F238E27FC236}">
-                <a16:creationId xmlns:a16="http://schemas.microsoft.com/office/drawing/2014/main" id="{1130DFDA-683D-4002-AFC9-022F579ABCAD}"/>
+                <a16:creationId xmlns:a16="http://schemas.microsoft.com/office/drawing/2014/main" id="{1B6C3F70-A670-4632-A123-29A16CD09A99}"/>
               </a:ext>
             </a:extLst>
           </p:cNvPr>
@@ -11907,7 +11907,7 @@
           <p:cNvPr id="7" name="Oval 6">
             <a:extLst>
               <a:ext uri="{FF2B5EF4-FFF2-40B4-BE49-F238E27FC236}">
-                <a16:creationId xmlns:a16="http://schemas.microsoft.com/office/drawing/2014/main" id="{7E46898B-235E-452B-A64B-A5C84D998F1E}"/>
+                <a16:creationId xmlns:a16="http://schemas.microsoft.com/office/drawing/2014/main" id="{A101E30D-9225-4376-A85C-EA23B3035D0F}"/>
               </a:ext>
             </a:extLst>
           </p:cNvPr>
@@ -11938,7 +11938,7 @@
           <p:cNvPr id="8" name="Rectangle 7">
             <a:extLst>
               <a:ext uri="{FF2B5EF4-FFF2-40B4-BE49-F238E27FC236}">
-                <a16:creationId xmlns:a16="http://schemas.microsoft.com/office/drawing/2014/main" id="{EC888C22-1C21-4387-BDA5-2F70D895A8C9}"/>
+                <a16:creationId xmlns:a16="http://schemas.microsoft.com/office/drawing/2014/main" id="{ABA5F203-1DCA-4BF4-BE28-1830FD55EE5A}"/>
               </a:ext>
             </a:extLst>
           </p:cNvPr>
@@ -12000,7 +12000,7 @@
           <p:cNvPr id="9" name="Rectangle: Rounded Corners 8">
             <a:extLst>
               <a:ext uri="{FF2B5EF4-FFF2-40B4-BE49-F238E27FC236}">
-                <a16:creationId xmlns:a16="http://schemas.microsoft.com/office/drawing/2014/main" id="{78D76D45-9E99-4FBA-98B9-4CB4BE31A15E}"/>
+                <a16:creationId xmlns:a16="http://schemas.microsoft.com/office/drawing/2014/main" id="{6D0504DC-4843-42BE-89A5-F21B40DC77F9}"/>
               </a:ext>
             </a:extLst>
           </p:cNvPr>
@@ -12035,7 +12035,7 @@
           <p:cNvPr id="10" name="Rectangle 9">
             <a:extLst>
               <a:ext uri="{FF2B5EF4-FFF2-40B4-BE49-F238E27FC236}">
-                <a16:creationId xmlns:a16="http://schemas.microsoft.com/office/drawing/2014/main" id="{5CFC32A7-1A23-4F90-8399-614A0E8AF154}"/>
+                <a16:creationId xmlns:a16="http://schemas.microsoft.com/office/drawing/2014/main" id="{43526787-A678-4C80-92BA-9B7E3D456AE3}"/>
               </a:ext>
             </a:extLst>
           </p:cNvPr>
@@ -12097,7 +12097,7 @@
           <p:cNvPr id="11" name="Oval 10">
             <a:extLst>
               <a:ext uri="{FF2B5EF4-FFF2-40B4-BE49-F238E27FC236}">
-                <a16:creationId xmlns:a16="http://schemas.microsoft.com/office/drawing/2014/main" id="{8E6CA8DB-1BBB-446B-B7C8-809BFDAAE47E}"/>
+                <a16:creationId xmlns:a16="http://schemas.microsoft.com/office/drawing/2014/main" id="{4DD4094D-36EC-4C83-AB0D-944809549EAD}"/>
               </a:ext>
             </a:extLst>
           </p:cNvPr>
@@ -12128,7 +12128,7 @@
           <p:cNvPr id="12" name="Rectangle 11">
             <a:extLst>
               <a:ext uri="{FF2B5EF4-FFF2-40B4-BE49-F238E27FC236}">
-                <a16:creationId xmlns:a16="http://schemas.microsoft.com/office/drawing/2014/main" id="{E7DEF86C-68FF-462E-AFCB-FEEE042699BF}"/>
+                <a16:creationId xmlns:a16="http://schemas.microsoft.com/office/drawing/2014/main" id="{00A1C11F-8DCC-4F2F-999A-7965CD93DCFD}"/>
               </a:ext>
             </a:extLst>
           </p:cNvPr>
@@ -12190,7 +12190,7 @@
           <p:cNvPr id="13" name="Rectangle: Rounded Corners 12">
             <a:extLst>
               <a:ext uri="{FF2B5EF4-FFF2-40B4-BE49-F238E27FC236}">
-                <a16:creationId xmlns:a16="http://schemas.microsoft.com/office/drawing/2014/main" id="{66D89EEB-C0FC-4E25-BEAE-6A7854C1B1D8}"/>
+                <a16:creationId xmlns:a16="http://schemas.microsoft.com/office/drawing/2014/main" id="{F7F23701-362B-4B54-93AC-0810E76E8A78}"/>
               </a:ext>
             </a:extLst>
           </p:cNvPr>
@@ -12225,7 +12225,7 @@
           <p:cNvPr id="14" name="Rectangle 13">
             <a:extLst>
               <a:ext uri="{FF2B5EF4-FFF2-40B4-BE49-F238E27FC236}">
-                <a16:creationId xmlns:a16="http://schemas.microsoft.com/office/drawing/2014/main" id="{890F6EC0-307A-4E4E-A61C-9A79134C3AC2}"/>
+                <a16:creationId xmlns:a16="http://schemas.microsoft.com/office/drawing/2014/main" id="{D569314D-6C5C-470E-A3B5-50AB208A6FDF}"/>
               </a:ext>
             </a:extLst>
           </p:cNvPr>
@@ -12287,7 +12287,7 @@
           <p:cNvPr id="15" name="Oval 14">
             <a:extLst>
               <a:ext uri="{FF2B5EF4-FFF2-40B4-BE49-F238E27FC236}">
-                <a16:creationId xmlns:a16="http://schemas.microsoft.com/office/drawing/2014/main" id="{F06BE7D6-DD4E-4294-9A08-3E20940DDB0F}"/>
+                <a16:creationId xmlns:a16="http://schemas.microsoft.com/office/drawing/2014/main" id="{0D09138B-7C3E-4F8C-8283-32E608227776}"/>
               </a:ext>
             </a:extLst>
           </p:cNvPr>
@@ -12318,7 +12318,7 @@
           <p:cNvPr id="16" name="Rectangle 15">
             <a:extLst>
               <a:ext uri="{FF2B5EF4-FFF2-40B4-BE49-F238E27FC236}">
-                <a16:creationId xmlns:a16="http://schemas.microsoft.com/office/drawing/2014/main" id="{6B3579D1-46BA-47B9-86FF-6ED6A8900C55}"/>
+                <a16:creationId xmlns:a16="http://schemas.microsoft.com/office/drawing/2014/main" id="{8C6E70B6-0FF7-424C-A95A-BD7EBEE640DE}"/>
               </a:ext>
             </a:extLst>
           </p:cNvPr>
@@ -12380,7 +12380,7 @@
           <p:cNvPr id="17" name="Rectangle: Rounded Corners 16">
             <a:extLst>
               <a:ext uri="{FF2B5EF4-FFF2-40B4-BE49-F238E27FC236}">
-                <a16:creationId xmlns:a16="http://schemas.microsoft.com/office/drawing/2014/main" id="{EF937C92-4AA4-4C27-80AD-1816F97351DB}"/>
+                <a16:creationId xmlns:a16="http://schemas.microsoft.com/office/drawing/2014/main" id="{80F15D90-25DD-4D36-9FF3-00968A91AB58}"/>
               </a:ext>
             </a:extLst>
           </p:cNvPr>
@@ -12415,7 +12415,7 @@
           <p:cNvPr id="18" name="Rectangle 17">
             <a:extLst>
               <a:ext uri="{FF2B5EF4-FFF2-40B4-BE49-F238E27FC236}">
-                <a16:creationId xmlns:a16="http://schemas.microsoft.com/office/drawing/2014/main" id="{C4A2FB81-855B-4522-BE7B-199CE61415DE}"/>
+                <a16:creationId xmlns:a16="http://schemas.microsoft.com/office/drawing/2014/main" id="{89AB816F-440C-42CF-9632-E819C7942FF5}"/>
               </a:ext>
             </a:extLst>
           </p:cNvPr>
@@ -12467,7 +12467,7 @@
                 <a:ea typeface="Arial"/>
                 <a:cs typeface="Arial"/>
               </a:rPr>
-              <a:t>Scenario + source + fallback status</a:t>
+              <a:t>Scenario + source + provider status</a:t>
             </a:r>
           </a:p>
         </p:txBody>
@@ -12477,7 +12477,7 @@
           <p:cNvPr id="19" name="Rectangle 18">
             <a:extLst>
               <a:ext uri="{FF2B5EF4-FFF2-40B4-BE49-F238E27FC236}">
-                <a16:creationId xmlns:a16="http://schemas.microsoft.com/office/drawing/2014/main" id="{AF1D9B95-12BD-4A50-91A3-24E6C6222302}"/>
+                <a16:creationId xmlns:a16="http://schemas.microsoft.com/office/drawing/2014/main" id="{602749FC-3C9D-4C00-95C6-35CD83BA2CB2}"/>
               </a:ext>
             </a:extLst>
           </p:cNvPr>
@@ -12508,7 +12508,7 @@
           <p:cNvPr id="20" name="Rectangle 19">
             <a:extLst>
               <a:ext uri="{FF2B5EF4-FFF2-40B4-BE49-F238E27FC236}">
-                <a16:creationId xmlns:a16="http://schemas.microsoft.com/office/drawing/2014/main" id="{3EB30432-C887-4ACD-8C4E-8FB55716919C}"/>
+                <a16:creationId xmlns:a16="http://schemas.microsoft.com/office/drawing/2014/main" id="{65FF7AD0-B2BD-492F-8144-69E127466E74}"/>
               </a:ext>
             </a:extLst>
           </p:cNvPr>
@@ -12570,7 +12570,7 @@
           <p:cNvPr id="21" name="Rectangle 20">
             <a:extLst>
               <a:ext uri="{FF2B5EF4-FFF2-40B4-BE49-F238E27FC236}">
-                <a16:creationId xmlns:a16="http://schemas.microsoft.com/office/drawing/2014/main" id="{E6C90D60-51DD-4F61-BA17-7F521E1B0540}"/>
+                <a16:creationId xmlns:a16="http://schemas.microsoft.com/office/drawing/2014/main" id="{BFCA8CE7-68A1-4178-973B-37B857B2F1F9}"/>
               </a:ext>
             </a:extLst>
           </p:cNvPr>
@@ -12630,7 +12630,7 @@
     </p:spTree>
     <p:extLst>
       <p:ext uri="{BB962C8B-B14F-4D97-AF65-F5344CB8AC3E}">
-        <p14:creationId xmlns:p14="http://schemas.microsoft.com/office/powerpoint/2010/main" val="1335316284"/>
+        <p14:creationId xmlns:p14="http://schemas.microsoft.com/office/powerpoint/2010/main" val="186251965"/>
       </p:ext>
     </p:extLst>
   </p:cSld>
@@ -12671,7 +12671,7 @@
             <a:hlinkClick r:id="rId3"/>
             <a:extLst>
               <a:ext uri="{FF2B5EF4-FFF2-40B4-BE49-F238E27FC236}">
-                <a16:creationId xmlns:a16="http://schemas.microsoft.com/office/drawing/2014/main" id="{241F40F7-B125-456D-868A-80CC4CF2D064}"/>
+                <a16:creationId xmlns:a16="http://schemas.microsoft.com/office/drawing/2014/main" id="{C8E0CC9D-51FD-485B-828B-51091D1CEDFD}"/>
               </a:ext>
             </a:extLst>
           </p:cNvPr>
@@ -12746,7 +12746,7 @@
             <a:hlinkClick r:id="rId4"/>
             <a:extLst>
               <a:ext uri="{FF2B5EF4-FFF2-40B4-BE49-F238E27FC236}">
-                <a16:creationId xmlns:a16="http://schemas.microsoft.com/office/drawing/2014/main" id="{70FF511A-4281-4258-B346-181670605343}"/>
+                <a16:creationId xmlns:a16="http://schemas.microsoft.com/office/drawing/2014/main" id="{C27B4274-F798-4852-9322-3121E506F245}"/>
               </a:ext>
             </a:extLst>
           </p:cNvPr>
@@ -12820,7 +12820,7 @@
           <p:cNvPr id="3" name="Rectangle 2">
             <a:extLst>
               <a:ext uri="{FF2B5EF4-FFF2-40B4-BE49-F238E27FC236}">
-                <a16:creationId xmlns:a16="http://schemas.microsoft.com/office/drawing/2014/main" id="{01AEA93C-5D63-4ED0-9484-E3A9CFDA07A9}"/>
+                <a16:creationId xmlns:a16="http://schemas.microsoft.com/office/drawing/2014/main" id="{76E8BEE2-6CD5-4457-9D16-15CCFE6FD160}"/>
               </a:ext>
             </a:extLst>
           </p:cNvPr>
@@ -12882,7 +12882,7 @@
           <p:cNvPr id="4" name="Rectangle 3">
             <a:extLst>
               <a:ext uri="{FF2B5EF4-FFF2-40B4-BE49-F238E27FC236}">
-                <a16:creationId xmlns:a16="http://schemas.microsoft.com/office/drawing/2014/main" id="{CBF79FD4-4DC3-401A-A63D-2EE50A33FC89}"/>
+                <a16:creationId xmlns:a16="http://schemas.microsoft.com/office/drawing/2014/main" id="{774DE99B-1C17-4D16-AE41-A44C7BCC64C3}"/>
               </a:ext>
             </a:extLst>
           </p:cNvPr>
@@ -12949,7 +12949,7 @@
         </p:nvPicPr>
         <p:blipFill>
           <a:blip r:embed="rId5"/>
-          <a:srcRect t="8995" b="8995"/>
+          <a:srcRect t="16963" b="16963"/>
           <a:stretch>
             <a:fillRect/>
           </a:stretch>
@@ -12971,7 +12971,7 @@
           <p:cNvPr id="6" name="Rectangle: Rounded Corners 5">
             <a:extLst>
               <a:ext uri="{FF2B5EF4-FFF2-40B4-BE49-F238E27FC236}">
-                <a16:creationId xmlns:a16="http://schemas.microsoft.com/office/drawing/2014/main" id="{0FD56803-4E0F-4B1E-B7AB-83D4C849DE1C}"/>
+                <a16:creationId xmlns:a16="http://schemas.microsoft.com/office/drawing/2014/main" id="{008940CC-98BC-4699-804D-56399C4D3D80}"/>
               </a:ext>
             </a:extLst>
           </p:cNvPr>
@@ -13004,7 +13004,7 @@
           <p:cNvPr id="7" name="Rectangle 6">
             <a:extLst>
               <a:ext uri="{FF2B5EF4-FFF2-40B4-BE49-F238E27FC236}">
-                <a16:creationId xmlns:a16="http://schemas.microsoft.com/office/drawing/2014/main" id="{9755BFDF-4413-4027-8D6A-D4D680ED9D71}"/>
+                <a16:creationId xmlns:a16="http://schemas.microsoft.com/office/drawing/2014/main" id="{9BDB8225-1605-49A0-9F5B-B7D173047B19}"/>
               </a:ext>
             </a:extLst>
           </p:cNvPr>
@@ -13066,7 +13066,7 @@
           <p:cNvPr id="8" name="Rectangle 7">
             <a:extLst>
               <a:ext uri="{FF2B5EF4-FFF2-40B4-BE49-F238E27FC236}">
-                <a16:creationId xmlns:a16="http://schemas.microsoft.com/office/drawing/2014/main" id="{B2674B70-2C08-442A-9759-0AD8A6FE52F1}"/>
+                <a16:creationId xmlns:a16="http://schemas.microsoft.com/office/drawing/2014/main" id="{20B85D1E-23E9-4778-AB02-70F388634C2D}"/>
               </a:ext>
             </a:extLst>
           </p:cNvPr>
@@ -13128,7 +13128,7 @@
           <p:cNvPr id="9" name="Rectangle 8">
             <a:extLst>
               <a:ext uri="{FF2B5EF4-FFF2-40B4-BE49-F238E27FC236}">
-                <a16:creationId xmlns:a16="http://schemas.microsoft.com/office/drawing/2014/main" id="{5E628A79-AE87-44C0-9B69-83E10DA9B8B2}"/>
+                <a16:creationId xmlns:a16="http://schemas.microsoft.com/office/drawing/2014/main" id="{A6BD7281-04FC-4270-9B3F-BAEBE9AAF899}"/>
               </a:ext>
             </a:extLst>
           </p:cNvPr>
@@ -13159,7 +13159,7 @@
           <p:cNvPr id="10" name="Rectangle 9">
             <a:extLst>
               <a:ext uri="{FF2B5EF4-FFF2-40B4-BE49-F238E27FC236}">
-                <a16:creationId xmlns:a16="http://schemas.microsoft.com/office/drawing/2014/main" id="{EBFC5CAE-B45E-4DC3-92F1-08EF63BA5124}"/>
+                <a16:creationId xmlns:a16="http://schemas.microsoft.com/office/drawing/2014/main" id="{1473A129-8542-47C8-9038-BCF90C5CDDCF}"/>
               </a:ext>
             </a:extLst>
           </p:cNvPr>
@@ -13221,7 +13221,7 @@
           <p:cNvPr id="11" name="Rectangle 10">
             <a:extLst>
               <a:ext uri="{FF2B5EF4-FFF2-40B4-BE49-F238E27FC236}">
-                <a16:creationId xmlns:a16="http://schemas.microsoft.com/office/drawing/2014/main" id="{50C5AA4F-E392-47BE-A384-7D4B0E8FC67D}"/>
+                <a16:creationId xmlns:a16="http://schemas.microsoft.com/office/drawing/2014/main" id="{E79CB2CD-1DD0-4E96-813C-E61EF1935A1D}"/>
               </a:ext>
             </a:extLst>
           </p:cNvPr>
@@ -13283,7 +13283,7 @@
           <p:cNvPr id="12" name="Rectangle 11">
             <a:extLst>
               <a:ext uri="{FF2B5EF4-FFF2-40B4-BE49-F238E27FC236}">
-                <a16:creationId xmlns:a16="http://schemas.microsoft.com/office/drawing/2014/main" id="{BB4F8173-757A-4469-88C3-E363E18D0B4A}"/>
+                <a16:creationId xmlns:a16="http://schemas.microsoft.com/office/drawing/2014/main" id="{0A957F65-35C8-4CDB-AEF3-E80DB835F5DE}"/>
               </a:ext>
             </a:extLst>
           </p:cNvPr>
@@ -13314,7 +13314,7 @@
           <p:cNvPr id="13" name="Rectangle 12">
             <a:extLst>
               <a:ext uri="{FF2B5EF4-FFF2-40B4-BE49-F238E27FC236}">
-                <a16:creationId xmlns:a16="http://schemas.microsoft.com/office/drawing/2014/main" id="{A75DB1D7-6A45-4A10-9990-9B3E9B27AEEC}"/>
+                <a16:creationId xmlns:a16="http://schemas.microsoft.com/office/drawing/2014/main" id="{D788BB2E-0623-4600-BEBE-28EBA4884E54}"/>
               </a:ext>
             </a:extLst>
           </p:cNvPr>
@@ -13376,7 +13376,7 @@
           <p:cNvPr id="14" name="Rectangle 13">
             <a:extLst>
               <a:ext uri="{FF2B5EF4-FFF2-40B4-BE49-F238E27FC236}">
-                <a16:creationId xmlns:a16="http://schemas.microsoft.com/office/drawing/2014/main" id="{2522A5C6-F7F5-4CD4-A82C-3881AC92884A}"/>
+                <a16:creationId xmlns:a16="http://schemas.microsoft.com/office/drawing/2014/main" id="{20C6D06C-D715-4F82-85C3-F3BD6C3C9434}"/>
               </a:ext>
             </a:extLst>
           </p:cNvPr>
@@ -13438,7 +13438,7 @@
           <p:cNvPr id="15" name="Rectangle 14">
             <a:extLst>
               <a:ext uri="{FF2B5EF4-FFF2-40B4-BE49-F238E27FC236}">
-                <a16:creationId xmlns:a16="http://schemas.microsoft.com/office/drawing/2014/main" id="{20C9619F-FF86-463D-A9F6-B57712F53553}"/>
+                <a16:creationId xmlns:a16="http://schemas.microsoft.com/office/drawing/2014/main" id="{0AA9106F-AFEB-405E-879A-06CF9C9E4E89}"/>
               </a:ext>
             </a:extLst>
           </p:cNvPr>
@@ -13469,7 +13469,7 @@
           <p:cNvPr id="16" name="Rectangle 15">
             <a:extLst>
               <a:ext uri="{FF2B5EF4-FFF2-40B4-BE49-F238E27FC236}">
-                <a16:creationId xmlns:a16="http://schemas.microsoft.com/office/drawing/2014/main" id="{6CA7DE7C-A4B3-45EE-8BCF-90E5D935C528}"/>
+                <a16:creationId xmlns:a16="http://schemas.microsoft.com/office/drawing/2014/main" id="{A0C8EE31-2962-4512-AF0D-355E02666B93}"/>
               </a:ext>
             </a:extLst>
           </p:cNvPr>
@@ -13531,7 +13531,7 @@
           <p:cNvPr id="17" name="Rectangle 16">
             <a:extLst>
               <a:ext uri="{FF2B5EF4-FFF2-40B4-BE49-F238E27FC236}">
-                <a16:creationId xmlns:a16="http://schemas.microsoft.com/office/drawing/2014/main" id="{E1484F63-775B-41FC-B2AA-A0F7DFBD226D}"/>
+                <a16:creationId xmlns:a16="http://schemas.microsoft.com/office/drawing/2014/main" id="{75912A08-BC1F-4977-88B6-B4F280DF7CA5}"/>
               </a:ext>
             </a:extLst>
           </p:cNvPr>
@@ -13593,7 +13593,7 @@
           <p:cNvPr id="18" name="Rectangle 17">
             <a:extLst>
               <a:ext uri="{FF2B5EF4-FFF2-40B4-BE49-F238E27FC236}">
-                <a16:creationId xmlns:a16="http://schemas.microsoft.com/office/drawing/2014/main" id="{6526A822-27AE-4CA6-852B-0DDD382C3BA7}"/>
+                <a16:creationId xmlns:a16="http://schemas.microsoft.com/office/drawing/2014/main" id="{B87DA9A3-0593-41E2-8A2B-A423038BBD24}"/>
               </a:ext>
             </a:extLst>
           </p:cNvPr>
@@ -13624,7 +13624,7 @@
           <p:cNvPr id="19" name="Rectangle 18">
             <a:extLst>
               <a:ext uri="{FF2B5EF4-FFF2-40B4-BE49-F238E27FC236}">
-                <a16:creationId xmlns:a16="http://schemas.microsoft.com/office/drawing/2014/main" id="{2C14B5EC-0600-428D-B5FA-AD7B6FF7109E}"/>
+                <a16:creationId xmlns:a16="http://schemas.microsoft.com/office/drawing/2014/main" id="{FA8848E0-71D3-4C2D-BAE2-5B8AC73376F0}"/>
               </a:ext>
             </a:extLst>
           </p:cNvPr>
@@ -13676,7 +13676,7 @@
                 <a:ea typeface="Arial"/>
                 <a:cs typeface="Arial"/>
               </a:rPr>
-              <a:t>FALLBACK</a:t>
+              <a:t>TOUR VOICE</a:t>
             </a:r>
           </a:p>
         </p:txBody>
@@ -13686,7 +13686,7 @@
           <p:cNvPr id="20" name="Rectangle 19">
             <a:extLst>
               <a:ext uri="{FF2B5EF4-FFF2-40B4-BE49-F238E27FC236}">
-                <a16:creationId xmlns:a16="http://schemas.microsoft.com/office/drawing/2014/main" id="{33D54621-EF80-48AE-B05D-265AF9030A3D}"/>
+                <a16:creationId xmlns:a16="http://schemas.microsoft.com/office/drawing/2014/main" id="{B9B1FF0B-9165-48F8-BF11-ACAF1BA456FA}"/>
               </a:ext>
             </a:extLst>
           </p:cNvPr>
@@ -13738,7 +13738,7 @@
                 <a:ea typeface="Arial"/>
                 <a:cs typeface="Arial"/>
               </a:rPr>
-              <a:t>AI-disabled deterministic path</a:t>
+              <a:t>14 recorded MP3 · 1 live response</a:t>
             </a:r>
           </a:p>
         </p:txBody>
@@ -13748,7 +13748,7 @@
           <p:cNvPr id="21" name="Rectangle 20">
             <a:extLst>
               <a:ext uri="{FF2B5EF4-FFF2-40B4-BE49-F238E27FC236}">
-                <a16:creationId xmlns:a16="http://schemas.microsoft.com/office/drawing/2014/main" id="{61E9BC41-E357-4B76-8FF1-08D93C54A9A7}"/>
+                <a16:creationId xmlns:a16="http://schemas.microsoft.com/office/drawing/2014/main" id="{B37D00B0-A846-400B-9B10-0E8D19A80532}"/>
               </a:ext>
             </a:extLst>
           </p:cNvPr>
@@ -13779,7 +13779,7 @@
           <p:cNvPr id="22" name="Rectangle 21">
             <a:extLst>
               <a:ext uri="{FF2B5EF4-FFF2-40B4-BE49-F238E27FC236}">
-                <a16:creationId xmlns:a16="http://schemas.microsoft.com/office/drawing/2014/main" id="{6605C627-2068-49D9-B368-0D1204B94EA5}"/>
+                <a16:creationId xmlns:a16="http://schemas.microsoft.com/office/drawing/2014/main" id="{14A203E0-3B60-410B-85F0-C15342D944EC}"/>
               </a:ext>
             </a:extLst>
           </p:cNvPr>
@@ -13841,7 +13841,7 @@
           <p:cNvPr id="23" name="Rectangle 22">
             <a:extLst>
               <a:ext uri="{FF2B5EF4-FFF2-40B4-BE49-F238E27FC236}">
-                <a16:creationId xmlns:a16="http://schemas.microsoft.com/office/drawing/2014/main" id="{C10B270D-24D2-4881-AC4B-E5B6BE8CB85F}"/>
+                <a16:creationId xmlns:a16="http://schemas.microsoft.com/office/drawing/2014/main" id="{1239121F-DF6A-4525-98BD-941962054404}"/>
               </a:ext>
             </a:extLst>
           </p:cNvPr>
@@ -13893,7 +13893,7 @@
                 <a:ea typeface="Arial"/>
                 <a:cs typeface="Arial"/>
               </a:rPr>
-              <a:t>pipeline · contracts · Netlify build</a:t>
+              <a:t>pipeline · freshness · Netlify build</a:t>
             </a:r>
           </a:p>
         </p:txBody>
@@ -13903,7 +13903,7 @@
           <p:cNvPr id="24" name="Rectangle 23">
             <a:extLst>
               <a:ext uri="{FF2B5EF4-FFF2-40B4-BE49-F238E27FC236}">
-                <a16:creationId xmlns:a16="http://schemas.microsoft.com/office/drawing/2014/main" id="{6E7B4035-DEFF-4977-99E7-85A8E9F11312}"/>
+                <a16:creationId xmlns:a16="http://schemas.microsoft.com/office/drawing/2014/main" id="{D014A104-1F65-4368-ABBC-60B1EBF20F20}"/>
               </a:ext>
             </a:extLst>
           </p:cNvPr>
@@ -13934,7 +13934,7 @@
           <p:cNvPr id="25" name="Rectangle 24">
             <a:extLst>
               <a:ext uri="{FF2B5EF4-FFF2-40B4-BE49-F238E27FC236}">
-                <a16:creationId xmlns:a16="http://schemas.microsoft.com/office/drawing/2014/main" id="{D4726237-3BDE-4C72-9ECB-3F1E7AE3290B}"/>
+                <a16:creationId xmlns:a16="http://schemas.microsoft.com/office/drawing/2014/main" id="{80782507-F2E4-4D4F-9A84-C2624825A5F7}"/>
               </a:ext>
             </a:extLst>
           </p:cNvPr>
@@ -13996,7 +13996,7 @@
           <p:cNvPr id="26" name="Rectangle 25">
             <a:extLst>
               <a:ext uri="{FF2B5EF4-FFF2-40B4-BE49-F238E27FC236}">
-                <a16:creationId xmlns:a16="http://schemas.microsoft.com/office/drawing/2014/main" id="{8CDEC17D-1035-4597-B06B-8948D8C1CB7A}"/>
+                <a16:creationId xmlns:a16="http://schemas.microsoft.com/office/drawing/2014/main" id="{7EC26D36-1D24-4395-A339-2C0302F0FB9D}"/>
               </a:ext>
             </a:extLst>
           </p:cNvPr>
@@ -14048,7 +14048,7 @@
                 <a:ea typeface="Arial"/>
                 <a:cs typeface="Arial"/>
               </a:rPr>
-              <a:t>TRISTIAN JAMES CABALAR · JOHN MICHAEL PALAGANAS · Carl Nueva · JOSEPH CLARENCE PARAYAOAN</a:t>
+              <a:t>Joaquin Sarmiento · Prince Marl Mirasol · Carl Nueva · JOSEPH CLARENCE PARAYAOAN</a:t>
             </a:r>
           </a:p>
         </p:txBody>
@@ -14058,7 +14058,7 @@
           <p:cNvPr id="27" name="Rectangle 26">
             <a:extLst>
               <a:ext uri="{FF2B5EF4-FFF2-40B4-BE49-F238E27FC236}">
-                <a16:creationId xmlns:a16="http://schemas.microsoft.com/office/drawing/2014/main" id="{B2CC98E2-0477-471B-AB22-C5602B513FFB}"/>
+                <a16:creationId xmlns:a16="http://schemas.microsoft.com/office/drawing/2014/main" id="{095400AE-46FC-4C89-B7E2-969B40DCFAFE}"/>
               </a:ext>
             </a:extLst>
           </p:cNvPr>
@@ -14120,7 +14120,7 @@
           <p:cNvPr id="28" name="Rectangle 27">
             <a:extLst>
               <a:ext uri="{FF2B5EF4-FFF2-40B4-BE49-F238E27FC236}">
-                <a16:creationId xmlns:a16="http://schemas.microsoft.com/office/drawing/2014/main" id="{DF4AE3AF-3EB4-44A2-8166-54AC1F92C49F}"/>
+                <a16:creationId xmlns:a16="http://schemas.microsoft.com/office/drawing/2014/main" id="{FAF9E20B-E503-46A4-B846-E7CCAAFC791F}"/>
               </a:ext>
             </a:extLst>
           </p:cNvPr>
@@ -14182,7 +14182,7 @@
           <p:cNvPr id="29" name="Rectangle 28">
             <a:extLst>
               <a:ext uri="{FF2B5EF4-FFF2-40B4-BE49-F238E27FC236}">
-                <a16:creationId xmlns:a16="http://schemas.microsoft.com/office/drawing/2014/main" id="{69384CA8-C321-4C9A-BF06-A0440C21D3D3}"/>
+                <a16:creationId xmlns:a16="http://schemas.microsoft.com/office/drawing/2014/main" id="{B64F7444-F103-417E-BE1A-7CA888F1BBE2}"/>
               </a:ext>
             </a:extLst>
           </p:cNvPr>
@@ -14213,7 +14213,7 @@
           <p:cNvPr id="30" name="Rectangle 29">
             <a:extLst>
               <a:ext uri="{FF2B5EF4-FFF2-40B4-BE49-F238E27FC236}">
-                <a16:creationId xmlns:a16="http://schemas.microsoft.com/office/drawing/2014/main" id="{4CB3ADF2-9BE7-4E26-A4E6-4837918B75AD}"/>
+                <a16:creationId xmlns:a16="http://schemas.microsoft.com/office/drawing/2014/main" id="{A963F72F-32CF-41C1-9B39-2C101E66113E}"/>
               </a:ext>
             </a:extLst>
           </p:cNvPr>
@@ -14275,7 +14275,7 @@
           <p:cNvPr id="31" name="Rectangle 30">
             <a:extLst>
               <a:ext uri="{FF2B5EF4-FFF2-40B4-BE49-F238E27FC236}">
-                <a16:creationId xmlns:a16="http://schemas.microsoft.com/office/drawing/2014/main" id="{FE63984C-E7F7-4597-9A01-D016347A2224}"/>
+                <a16:creationId xmlns:a16="http://schemas.microsoft.com/office/drawing/2014/main" id="{8CAAB21E-BF02-4FF1-A3D0-31E5E368E4AF}"/>
               </a:ext>
             </a:extLst>
           </p:cNvPr>
@@ -14335,7 +14335,7 @@
     </p:spTree>
     <p:extLst>
       <p:ext uri="{BB962C8B-B14F-4D97-AF65-F5344CB8AC3E}">
-        <p14:creationId xmlns:p14="http://schemas.microsoft.com/office/powerpoint/2010/main" val="1621495758"/>
+        <p14:creationId xmlns:p14="http://schemas.microsoft.com/office/powerpoint/2010/main" val="2056991342"/>
       </p:ext>
     </p:extLst>
   </p:cSld>
@@ -14376,7 +14376,7 @@
             <a:hlinkClick r:id="rId3"/>
             <a:extLst>
               <a:ext uri="{FF2B5EF4-FFF2-40B4-BE49-F238E27FC236}">
-                <a16:creationId xmlns:a16="http://schemas.microsoft.com/office/drawing/2014/main" id="{08CB269D-32B5-40C1-8058-1E0AF393F23B}"/>
+                <a16:creationId xmlns:a16="http://schemas.microsoft.com/office/drawing/2014/main" id="{32DEEEDD-DD76-45C0-AE17-40DFC132D686}"/>
               </a:ext>
             </a:extLst>
           </p:cNvPr>
@@ -14451,7 +14451,7 @@
             <a:hlinkClick r:id="rId4"/>
             <a:extLst>
               <a:ext uri="{FF2B5EF4-FFF2-40B4-BE49-F238E27FC236}">
-                <a16:creationId xmlns:a16="http://schemas.microsoft.com/office/drawing/2014/main" id="{ED452A77-B4AF-4211-B249-B121ACC5D86D}"/>
+                <a16:creationId xmlns:a16="http://schemas.microsoft.com/office/drawing/2014/main" id="{7264FA1E-8417-4195-A8E2-E2F043EE2336}"/>
               </a:ext>
             </a:extLst>
           </p:cNvPr>
@@ -14525,7 +14525,7 @@
           <p:cNvPr id="3" name="Rectangle 2">
             <a:extLst>
               <a:ext uri="{FF2B5EF4-FFF2-40B4-BE49-F238E27FC236}">
-                <a16:creationId xmlns:a16="http://schemas.microsoft.com/office/drawing/2014/main" id="{B2F7D632-D910-43E4-9A43-02AADFCCC954}"/>
+                <a16:creationId xmlns:a16="http://schemas.microsoft.com/office/drawing/2014/main" id="{89D57A21-11EC-41D4-87DC-A4F55E4AB178}"/>
               </a:ext>
             </a:extLst>
           </p:cNvPr>
@@ -14587,7 +14587,7 @@
           <p:cNvPr id="4" name="Rectangle 3">
             <a:extLst>
               <a:ext uri="{FF2B5EF4-FFF2-40B4-BE49-F238E27FC236}">
-                <a16:creationId xmlns:a16="http://schemas.microsoft.com/office/drawing/2014/main" id="{5E8C501D-B91F-4974-A24E-DD1D2FEC66CD}"/>
+                <a16:creationId xmlns:a16="http://schemas.microsoft.com/office/drawing/2014/main" id="{9EA78022-6BAC-4B71-B6DA-2E0DC3684A86}"/>
               </a:ext>
             </a:extLst>
           </p:cNvPr>
@@ -14649,7 +14649,7 @@
           <p:cNvPr id="5" name="Rectangle 4">
             <a:extLst>
               <a:ext uri="{FF2B5EF4-FFF2-40B4-BE49-F238E27FC236}">
-                <a16:creationId xmlns:a16="http://schemas.microsoft.com/office/drawing/2014/main" id="{32208C46-4CC6-4DF8-9421-D4C3377FBEEF}"/>
+                <a16:creationId xmlns:a16="http://schemas.microsoft.com/office/drawing/2014/main" id="{4D644831-6B6D-4253-9111-CF4BA4362D2E}"/>
               </a:ext>
             </a:extLst>
           </p:cNvPr>
@@ -14711,7 +14711,7 @@
           <p:cNvPr id="6" name="Oval 5">
             <a:extLst>
               <a:ext uri="{FF2B5EF4-FFF2-40B4-BE49-F238E27FC236}">
-                <a16:creationId xmlns:a16="http://schemas.microsoft.com/office/drawing/2014/main" id="{87AE2982-963D-485F-8029-CCD1C8C9E351}"/>
+                <a16:creationId xmlns:a16="http://schemas.microsoft.com/office/drawing/2014/main" id="{BCDE92D7-6A37-43F4-9C04-423C3F73A014}"/>
               </a:ext>
             </a:extLst>
           </p:cNvPr>
@@ -14742,7 +14742,7 @@
           <p:cNvPr id="7" name="Rectangle 6">
             <a:extLst>
               <a:ext uri="{FF2B5EF4-FFF2-40B4-BE49-F238E27FC236}">
-                <a16:creationId xmlns:a16="http://schemas.microsoft.com/office/drawing/2014/main" id="{63AD9E1D-96DB-4012-8559-9EF946678979}"/>
+                <a16:creationId xmlns:a16="http://schemas.microsoft.com/office/drawing/2014/main" id="{B507AE46-FDBF-4EC9-AC45-F9B620EBDA61}"/>
               </a:ext>
             </a:extLst>
           </p:cNvPr>
@@ -14804,7 +14804,7 @@
           <p:cNvPr id="8" name="Rectangle 7">
             <a:extLst>
               <a:ext uri="{FF2B5EF4-FFF2-40B4-BE49-F238E27FC236}">
-                <a16:creationId xmlns:a16="http://schemas.microsoft.com/office/drawing/2014/main" id="{D830B9D9-6148-46E6-BFF8-A0E9B2964B79}"/>
+                <a16:creationId xmlns:a16="http://schemas.microsoft.com/office/drawing/2014/main" id="{73CDD6A7-F850-4BC0-B1A7-3D08B7DCC3BE}"/>
               </a:ext>
             </a:extLst>
           </p:cNvPr>
@@ -14835,7 +14835,7 @@
           <p:cNvPr id="9" name="Rectangle 8">
             <a:extLst>
               <a:ext uri="{FF2B5EF4-FFF2-40B4-BE49-F238E27FC236}">
-                <a16:creationId xmlns:a16="http://schemas.microsoft.com/office/drawing/2014/main" id="{498D2C90-4D8B-4716-8C20-FC55960B9687}"/>
+                <a16:creationId xmlns:a16="http://schemas.microsoft.com/office/drawing/2014/main" id="{5BFFA6B8-4AF4-4D25-8480-2A20B35879CB}"/>
               </a:ext>
             </a:extLst>
           </p:cNvPr>
@@ -14897,7 +14897,7 @@
           <p:cNvPr id="10" name="Oval 9">
             <a:extLst>
               <a:ext uri="{FF2B5EF4-FFF2-40B4-BE49-F238E27FC236}">
-                <a16:creationId xmlns:a16="http://schemas.microsoft.com/office/drawing/2014/main" id="{251DBE69-2551-49CA-BA97-C87F4924DE8B}"/>
+                <a16:creationId xmlns:a16="http://schemas.microsoft.com/office/drawing/2014/main" id="{DFCF1413-90F2-4A77-9684-37E15B87BD01}"/>
               </a:ext>
             </a:extLst>
           </p:cNvPr>
@@ -14928,7 +14928,7 @@
           <p:cNvPr id="11" name="Rectangle 10">
             <a:extLst>
               <a:ext uri="{FF2B5EF4-FFF2-40B4-BE49-F238E27FC236}">
-                <a16:creationId xmlns:a16="http://schemas.microsoft.com/office/drawing/2014/main" id="{1279D365-5CBF-46BA-8796-9A6847BB38FF}"/>
+                <a16:creationId xmlns:a16="http://schemas.microsoft.com/office/drawing/2014/main" id="{0ABB2F9E-F57B-400B-ACFF-4D725C07CCDE}"/>
               </a:ext>
             </a:extLst>
           </p:cNvPr>
@@ -14990,7 +14990,7 @@
           <p:cNvPr id="12" name="Rectangle 11">
             <a:extLst>
               <a:ext uri="{FF2B5EF4-FFF2-40B4-BE49-F238E27FC236}">
-                <a16:creationId xmlns:a16="http://schemas.microsoft.com/office/drawing/2014/main" id="{6FC5C454-B884-46B8-8771-1968B9D5DCB0}"/>
+                <a16:creationId xmlns:a16="http://schemas.microsoft.com/office/drawing/2014/main" id="{DC6C4333-7D78-4510-A493-2BA777A69F87}"/>
               </a:ext>
             </a:extLst>
           </p:cNvPr>
@@ -15021,7 +15021,7 @@
           <p:cNvPr id="13" name="Rectangle 12">
             <a:extLst>
               <a:ext uri="{FF2B5EF4-FFF2-40B4-BE49-F238E27FC236}">
-                <a16:creationId xmlns:a16="http://schemas.microsoft.com/office/drawing/2014/main" id="{93034D16-9732-44EF-9BAF-990044DADA7E}"/>
+                <a16:creationId xmlns:a16="http://schemas.microsoft.com/office/drawing/2014/main" id="{81182E96-BF49-434C-A675-AD290F8B4D3F}"/>
               </a:ext>
             </a:extLst>
           </p:cNvPr>
@@ -15083,7 +15083,7 @@
           <p:cNvPr id="14" name="Oval 13">
             <a:extLst>
               <a:ext uri="{FF2B5EF4-FFF2-40B4-BE49-F238E27FC236}">
-                <a16:creationId xmlns:a16="http://schemas.microsoft.com/office/drawing/2014/main" id="{62543840-3EB7-425D-B268-9CDBA3CBFA23}"/>
+                <a16:creationId xmlns:a16="http://schemas.microsoft.com/office/drawing/2014/main" id="{67B5B097-9EDF-4003-9581-2C3D1B55971C}"/>
               </a:ext>
             </a:extLst>
           </p:cNvPr>
@@ -15114,7 +15114,7 @@
           <p:cNvPr id="15" name="Rectangle 14">
             <a:extLst>
               <a:ext uri="{FF2B5EF4-FFF2-40B4-BE49-F238E27FC236}">
-                <a16:creationId xmlns:a16="http://schemas.microsoft.com/office/drawing/2014/main" id="{BC2729BF-CFDF-43AE-AB8E-CA16ECC1CFA4}"/>
+                <a16:creationId xmlns:a16="http://schemas.microsoft.com/office/drawing/2014/main" id="{84D5FF00-2C3F-441D-85AB-41F9C5D40976}"/>
               </a:ext>
             </a:extLst>
           </p:cNvPr>
@@ -15176,7 +15176,7 @@
           <p:cNvPr id="16" name="Rectangle 15">
             <a:extLst>
               <a:ext uri="{FF2B5EF4-FFF2-40B4-BE49-F238E27FC236}">
-                <a16:creationId xmlns:a16="http://schemas.microsoft.com/office/drawing/2014/main" id="{44658ED2-18A3-4F1E-9FC7-7D905C618D5F}"/>
+                <a16:creationId xmlns:a16="http://schemas.microsoft.com/office/drawing/2014/main" id="{BC08ECD9-ADEF-406C-AFB3-2D85DDC0FDF0}"/>
               </a:ext>
             </a:extLst>
           </p:cNvPr>
@@ -15207,7 +15207,7 @@
           <p:cNvPr id="17" name="Rectangle 16">
             <a:extLst>
               <a:ext uri="{FF2B5EF4-FFF2-40B4-BE49-F238E27FC236}">
-                <a16:creationId xmlns:a16="http://schemas.microsoft.com/office/drawing/2014/main" id="{B08CE82C-D5B6-4BC1-84F1-79C08AEE2C3F}"/>
+                <a16:creationId xmlns:a16="http://schemas.microsoft.com/office/drawing/2014/main" id="{F0A525BA-650D-400B-B3E8-9E6AFE5DC582}"/>
               </a:ext>
             </a:extLst>
           </p:cNvPr>
@@ -15269,7 +15269,7 @@
           <p:cNvPr id="18" name="Oval 17">
             <a:extLst>
               <a:ext uri="{FF2B5EF4-FFF2-40B4-BE49-F238E27FC236}">
-                <a16:creationId xmlns:a16="http://schemas.microsoft.com/office/drawing/2014/main" id="{A7BCF1B4-910E-4BDD-BE06-9FB48BC4E0EE}"/>
+                <a16:creationId xmlns:a16="http://schemas.microsoft.com/office/drawing/2014/main" id="{E0BF008A-2EFD-43B6-A0D5-6ED9C168FFF5}"/>
               </a:ext>
             </a:extLst>
           </p:cNvPr>
@@ -15300,7 +15300,7 @@
           <p:cNvPr id="19" name="Rectangle 18">
             <a:extLst>
               <a:ext uri="{FF2B5EF4-FFF2-40B4-BE49-F238E27FC236}">
-                <a16:creationId xmlns:a16="http://schemas.microsoft.com/office/drawing/2014/main" id="{CE74E3DB-5689-41C4-AFEF-46932BB3CF20}"/>
+                <a16:creationId xmlns:a16="http://schemas.microsoft.com/office/drawing/2014/main" id="{A328A5D4-C3C4-41CF-B25C-33003D92DF13}"/>
               </a:ext>
             </a:extLst>
           </p:cNvPr>
@@ -15362,7 +15362,7 @@
           <p:cNvPr id="20" name="Rectangle 19">
             <a:extLst>
               <a:ext uri="{FF2B5EF4-FFF2-40B4-BE49-F238E27FC236}">
-                <a16:creationId xmlns:a16="http://schemas.microsoft.com/office/drawing/2014/main" id="{93BA4629-5EFE-4C33-83E8-97DC5268462E}"/>
+                <a16:creationId xmlns:a16="http://schemas.microsoft.com/office/drawing/2014/main" id="{7B01C8F5-0BF3-4479-8B8D-DF5DF234BEE1}"/>
               </a:ext>
             </a:extLst>
           </p:cNvPr>
@@ -15393,7 +15393,7 @@
           <p:cNvPr id="21" name="Rectangle 20">
             <a:extLst>
               <a:ext uri="{FF2B5EF4-FFF2-40B4-BE49-F238E27FC236}">
-                <a16:creationId xmlns:a16="http://schemas.microsoft.com/office/drawing/2014/main" id="{348D50C5-9770-4EC3-B0EA-067F39E90648}"/>
+                <a16:creationId xmlns:a16="http://schemas.microsoft.com/office/drawing/2014/main" id="{EE2D2FB7-D6EF-42EB-8D12-A1A6F69E6AAB}"/>
               </a:ext>
             </a:extLst>
           </p:cNvPr>
@@ -15455,7 +15455,7 @@
           <p:cNvPr id="22" name="Oval 21">
             <a:extLst>
               <a:ext uri="{FF2B5EF4-FFF2-40B4-BE49-F238E27FC236}">
-                <a16:creationId xmlns:a16="http://schemas.microsoft.com/office/drawing/2014/main" id="{98A7A4CF-26FD-4DEB-B944-5B5B9F34EA90}"/>
+                <a16:creationId xmlns:a16="http://schemas.microsoft.com/office/drawing/2014/main" id="{F6CCC68C-A297-43E2-A8EA-C722B5156215}"/>
               </a:ext>
             </a:extLst>
           </p:cNvPr>
@@ -15486,7 +15486,7 @@
           <p:cNvPr id="23" name="Rectangle 22">
             <a:extLst>
               <a:ext uri="{FF2B5EF4-FFF2-40B4-BE49-F238E27FC236}">
-                <a16:creationId xmlns:a16="http://schemas.microsoft.com/office/drawing/2014/main" id="{4629C6E4-198D-43F0-81FC-CF4947CD0F9A}"/>
+                <a16:creationId xmlns:a16="http://schemas.microsoft.com/office/drawing/2014/main" id="{BCCF152B-4008-40E2-A8D9-35153A0023BC}"/>
               </a:ext>
             </a:extLst>
           </p:cNvPr>
@@ -15548,7 +15548,7 @@
           <p:cNvPr id="24" name="Rectangle 23">
             <a:extLst>
               <a:ext uri="{FF2B5EF4-FFF2-40B4-BE49-F238E27FC236}">
-                <a16:creationId xmlns:a16="http://schemas.microsoft.com/office/drawing/2014/main" id="{91297A33-4B4B-44F4-BA0A-0A415C68E4BB}"/>
+                <a16:creationId xmlns:a16="http://schemas.microsoft.com/office/drawing/2014/main" id="{7699A5F0-9596-42F6-8E59-EC5586D91C6F}"/>
               </a:ext>
             </a:extLst>
           </p:cNvPr>
@@ -15579,7 +15579,7 @@
           <p:cNvPr id="25" name="Rectangle 24">
             <a:extLst>
               <a:ext uri="{FF2B5EF4-FFF2-40B4-BE49-F238E27FC236}">
-                <a16:creationId xmlns:a16="http://schemas.microsoft.com/office/drawing/2014/main" id="{54F6AE50-1F18-4AFF-A812-54670AA034EF}"/>
+                <a16:creationId xmlns:a16="http://schemas.microsoft.com/office/drawing/2014/main" id="{BDC9E810-937D-4EC8-B707-7C352D6EB93D}"/>
               </a:ext>
             </a:extLst>
           </p:cNvPr>
@@ -15641,7 +15641,7 @@
           <p:cNvPr id="26" name="Oval 25">
             <a:extLst>
               <a:ext uri="{FF2B5EF4-FFF2-40B4-BE49-F238E27FC236}">
-                <a16:creationId xmlns:a16="http://schemas.microsoft.com/office/drawing/2014/main" id="{B7C0BB03-4F53-48ED-9679-3868447A0A15}"/>
+                <a16:creationId xmlns:a16="http://schemas.microsoft.com/office/drawing/2014/main" id="{B22AFC82-EF8E-4D4F-A4E1-F24979832691}"/>
               </a:ext>
             </a:extLst>
           </p:cNvPr>
@@ -15672,7 +15672,7 @@
           <p:cNvPr id="27" name="Rectangle 26">
             <a:extLst>
               <a:ext uri="{FF2B5EF4-FFF2-40B4-BE49-F238E27FC236}">
-                <a16:creationId xmlns:a16="http://schemas.microsoft.com/office/drawing/2014/main" id="{EF1C2A99-F6F4-4368-A634-3A38A32BEA74}"/>
+                <a16:creationId xmlns:a16="http://schemas.microsoft.com/office/drawing/2014/main" id="{78F68147-F047-44D6-8C2F-9F5D60759FF8}"/>
               </a:ext>
             </a:extLst>
           </p:cNvPr>
@@ -15734,7 +15734,7 @@
           <p:cNvPr id="28" name="Rectangle 27">
             <a:extLst>
               <a:ext uri="{FF2B5EF4-FFF2-40B4-BE49-F238E27FC236}">
-                <a16:creationId xmlns:a16="http://schemas.microsoft.com/office/drawing/2014/main" id="{0F26BBA4-0794-4079-85F5-4134E5B1308D}"/>
+                <a16:creationId xmlns:a16="http://schemas.microsoft.com/office/drawing/2014/main" id="{CD1DFFAE-B652-40DC-A0F7-C86AB15066B6}"/>
               </a:ext>
             </a:extLst>
           </p:cNvPr>
@@ -15765,7 +15765,7 @@
           <p:cNvPr id="29" name="Rectangle 28">
             <a:extLst>
               <a:ext uri="{FF2B5EF4-FFF2-40B4-BE49-F238E27FC236}">
-                <a16:creationId xmlns:a16="http://schemas.microsoft.com/office/drawing/2014/main" id="{F3E90D26-889F-4C75-A6B2-4705CA6C9356}"/>
+                <a16:creationId xmlns:a16="http://schemas.microsoft.com/office/drawing/2014/main" id="{E2EDD034-C485-4D6E-8038-A97FE6D7B61A}"/>
               </a:ext>
             </a:extLst>
           </p:cNvPr>
@@ -15827,7 +15827,7 @@
           <p:cNvPr id="30" name="Oval 29">
             <a:extLst>
               <a:ext uri="{FF2B5EF4-FFF2-40B4-BE49-F238E27FC236}">
-                <a16:creationId xmlns:a16="http://schemas.microsoft.com/office/drawing/2014/main" id="{BE4877ED-E2A8-4971-9EE6-4D487F37AD16}"/>
+                <a16:creationId xmlns:a16="http://schemas.microsoft.com/office/drawing/2014/main" id="{11BD0F02-BB83-4498-9BC2-DF95140B1E5F}"/>
               </a:ext>
             </a:extLst>
           </p:cNvPr>
@@ -15858,7 +15858,7 @@
           <p:cNvPr id="31" name="Rectangle 30">
             <a:extLst>
               <a:ext uri="{FF2B5EF4-FFF2-40B4-BE49-F238E27FC236}">
-                <a16:creationId xmlns:a16="http://schemas.microsoft.com/office/drawing/2014/main" id="{FD69B469-36F0-4847-99DB-5269D4EA5470}"/>
+                <a16:creationId xmlns:a16="http://schemas.microsoft.com/office/drawing/2014/main" id="{8F8DC668-5D3F-4B38-953F-B6B5DEFE4947}"/>
               </a:ext>
             </a:extLst>
           </p:cNvPr>
@@ -15920,7 +15920,7 @@
           <p:cNvPr id="32" name="Rectangle 31">
             <a:extLst>
               <a:ext uri="{FF2B5EF4-FFF2-40B4-BE49-F238E27FC236}">
-                <a16:creationId xmlns:a16="http://schemas.microsoft.com/office/drawing/2014/main" id="{B16A1A2F-50CA-4C8D-B34B-D07C502FE9C4}"/>
+                <a16:creationId xmlns:a16="http://schemas.microsoft.com/office/drawing/2014/main" id="{E7EE3479-1F4E-49E4-AA69-4F2767E33612}"/>
               </a:ext>
             </a:extLst>
           </p:cNvPr>
@@ -15982,7 +15982,7 @@
           <p:cNvPr id="33" name="Rectangle: Rounded Corners 32">
             <a:extLst>
               <a:ext uri="{FF2B5EF4-FFF2-40B4-BE49-F238E27FC236}">
-                <a16:creationId xmlns:a16="http://schemas.microsoft.com/office/drawing/2014/main" id="{F864757B-A281-4A43-A31C-3258E54EDC3A}"/>
+                <a16:creationId xmlns:a16="http://schemas.microsoft.com/office/drawing/2014/main" id="{033E1764-2A9D-48A5-BCCA-C0E2E2417348}"/>
               </a:ext>
             </a:extLst>
           </p:cNvPr>
@@ -16015,7 +16015,7 @@
           <p:cNvPr id="34" name="Rectangle 33">
             <a:extLst>
               <a:ext uri="{FF2B5EF4-FFF2-40B4-BE49-F238E27FC236}">
-                <a16:creationId xmlns:a16="http://schemas.microsoft.com/office/drawing/2014/main" id="{B98F31BE-F6B0-417D-931D-74624360A282}"/>
+                <a16:creationId xmlns:a16="http://schemas.microsoft.com/office/drawing/2014/main" id="{D268731A-00D5-4761-8AC1-F31666BA3035}"/>
               </a:ext>
             </a:extLst>
           </p:cNvPr>
@@ -16077,7 +16077,7 @@
           <p:cNvPr id="35" name="Rectangle 34">
             <a:extLst>
               <a:ext uri="{FF2B5EF4-FFF2-40B4-BE49-F238E27FC236}">
-                <a16:creationId xmlns:a16="http://schemas.microsoft.com/office/drawing/2014/main" id="{CCE76F6D-C341-442E-8CAE-897D741CC709}"/>
+                <a16:creationId xmlns:a16="http://schemas.microsoft.com/office/drawing/2014/main" id="{B53654DC-8981-48A6-8BB5-A51C397854F8}"/>
               </a:ext>
             </a:extLst>
           </p:cNvPr>
@@ -16108,7 +16108,7 @@
           <p:cNvPr id="36" name="Rectangle 35">
             <a:extLst>
               <a:ext uri="{FF2B5EF4-FFF2-40B4-BE49-F238E27FC236}">
-                <a16:creationId xmlns:a16="http://schemas.microsoft.com/office/drawing/2014/main" id="{B5C6DF11-F34D-4671-87DC-41E60D12351A}"/>
+                <a16:creationId xmlns:a16="http://schemas.microsoft.com/office/drawing/2014/main" id="{466461E5-1A63-494B-BE47-7629228EB843}"/>
               </a:ext>
             </a:extLst>
           </p:cNvPr>
@@ -16170,7 +16170,7 @@
           <p:cNvPr id="37" name="Rectangle 36">
             <a:extLst>
               <a:ext uri="{FF2B5EF4-FFF2-40B4-BE49-F238E27FC236}">
-                <a16:creationId xmlns:a16="http://schemas.microsoft.com/office/drawing/2014/main" id="{7FD19055-F51F-43F9-B50C-8EDE380FA02A}"/>
+                <a16:creationId xmlns:a16="http://schemas.microsoft.com/office/drawing/2014/main" id="{A007F414-1577-4569-B8CA-DBD6823422E0}"/>
               </a:ext>
             </a:extLst>
           </p:cNvPr>
@@ -16230,7 +16230,7 @@
     </p:spTree>
     <p:extLst>
       <p:ext uri="{BB962C8B-B14F-4D97-AF65-F5344CB8AC3E}">
-        <p14:creationId xmlns:p14="http://schemas.microsoft.com/office/powerpoint/2010/main" val="1914620211"/>
+        <p14:creationId xmlns:p14="http://schemas.microsoft.com/office/powerpoint/2010/main" val="1029667254"/>
       </p:ext>
     </p:extLst>
   </p:cSld>
@@ -16271,7 +16271,7 @@
             <a:hlinkClick r:id="rId3"/>
             <a:extLst>
               <a:ext uri="{FF2B5EF4-FFF2-40B4-BE49-F238E27FC236}">
-                <a16:creationId xmlns:a16="http://schemas.microsoft.com/office/drawing/2014/main" id="{8E1F9429-8CD5-4B70-84E3-EDA20622E42F}"/>
+                <a16:creationId xmlns:a16="http://schemas.microsoft.com/office/drawing/2014/main" id="{F3E85F55-0B28-4EEF-9918-8D8ED48AC6C5}"/>
               </a:ext>
             </a:extLst>
           </p:cNvPr>
@@ -16346,7 +16346,7 @@
             <a:hlinkClick r:id="rId4"/>
             <a:extLst>
               <a:ext uri="{FF2B5EF4-FFF2-40B4-BE49-F238E27FC236}">
-                <a16:creationId xmlns:a16="http://schemas.microsoft.com/office/drawing/2014/main" id="{760CD901-CF1B-48ED-B6D7-CF4CF19D64D4}"/>
+                <a16:creationId xmlns:a16="http://schemas.microsoft.com/office/drawing/2014/main" id="{0CF5AF90-986E-43A4-B473-C02DCC48A98E}"/>
               </a:ext>
             </a:extLst>
           </p:cNvPr>
@@ -16420,7 +16420,7 @@
           <p:cNvPr id="3" name="Rectangle 2">
             <a:extLst>
               <a:ext uri="{FF2B5EF4-FFF2-40B4-BE49-F238E27FC236}">
-                <a16:creationId xmlns:a16="http://schemas.microsoft.com/office/drawing/2014/main" id="{49B4895C-4AC4-4912-98BD-15B09F6EB2BA}"/>
+                <a16:creationId xmlns:a16="http://schemas.microsoft.com/office/drawing/2014/main" id="{0CC367DF-CD7E-48E6-B5D5-98CBFB4ED20A}"/>
               </a:ext>
             </a:extLst>
           </p:cNvPr>
@@ -16482,7 +16482,7 @@
           <p:cNvPr id="4" name="Rectangle 3">
             <a:extLst>
               <a:ext uri="{FF2B5EF4-FFF2-40B4-BE49-F238E27FC236}">
-                <a16:creationId xmlns:a16="http://schemas.microsoft.com/office/drawing/2014/main" id="{72A4EA27-C282-45D9-AF29-1C6115F8A744}"/>
+                <a16:creationId xmlns:a16="http://schemas.microsoft.com/office/drawing/2014/main" id="{B20C5AF0-1294-4AAA-AAC7-053C7ECF7532}"/>
               </a:ext>
             </a:extLst>
           </p:cNvPr>
@@ -16571,7 +16571,7 @@
           <p:cNvPr id="6" name="Rectangle: Rounded Corners 5">
             <a:extLst>
               <a:ext uri="{FF2B5EF4-FFF2-40B4-BE49-F238E27FC236}">
-                <a16:creationId xmlns:a16="http://schemas.microsoft.com/office/drawing/2014/main" id="{3579E3BD-9450-46A5-BE00-170939247A28}"/>
+                <a16:creationId xmlns:a16="http://schemas.microsoft.com/office/drawing/2014/main" id="{EB537D81-F5D3-413A-83DE-D5B4CAEB5025}"/>
               </a:ext>
             </a:extLst>
           </p:cNvPr>
@@ -16604,7 +16604,7 @@
           <p:cNvPr id="7" name="Oval 6">
             <a:extLst>
               <a:ext uri="{FF2B5EF4-FFF2-40B4-BE49-F238E27FC236}">
-                <a16:creationId xmlns:a16="http://schemas.microsoft.com/office/drawing/2014/main" id="{0D8AFF09-CA13-42A8-B3CE-9D37DC2841E7}"/>
+                <a16:creationId xmlns:a16="http://schemas.microsoft.com/office/drawing/2014/main" id="{2796837C-D756-4EC2-B5DD-105E83109EB9}"/>
               </a:ext>
             </a:extLst>
           </p:cNvPr>
@@ -16635,7 +16635,7 @@
           <p:cNvPr id="8" name="Rectangle 7">
             <a:extLst>
               <a:ext uri="{FF2B5EF4-FFF2-40B4-BE49-F238E27FC236}">
-                <a16:creationId xmlns:a16="http://schemas.microsoft.com/office/drawing/2014/main" id="{18A10892-B590-47A3-A767-F132F372848D}"/>
+                <a16:creationId xmlns:a16="http://schemas.microsoft.com/office/drawing/2014/main" id="{E0931A67-0DB7-4A10-AF1A-7DAA45D00932}"/>
               </a:ext>
             </a:extLst>
           </p:cNvPr>
@@ -16697,7 +16697,7 @@
           <p:cNvPr id="9" name="Rectangle: Rounded Corners 8">
             <a:extLst>
               <a:ext uri="{FF2B5EF4-FFF2-40B4-BE49-F238E27FC236}">
-                <a16:creationId xmlns:a16="http://schemas.microsoft.com/office/drawing/2014/main" id="{1C576AA9-148F-4918-AE6F-363BEFC4B694}"/>
+                <a16:creationId xmlns:a16="http://schemas.microsoft.com/office/drawing/2014/main" id="{77311258-2580-4599-9DAF-C9E55E51C3D8}"/>
               </a:ext>
             </a:extLst>
           </p:cNvPr>
@@ -16732,7 +16732,7 @@
           <p:cNvPr id="10" name="Rectangle 9">
             <a:extLst>
               <a:ext uri="{FF2B5EF4-FFF2-40B4-BE49-F238E27FC236}">
-                <a16:creationId xmlns:a16="http://schemas.microsoft.com/office/drawing/2014/main" id="{446CF7E6-1C35-4D89-A490-884FF6889901}"/>
+                <a16:creationId xmlns:a16="http://schemas.microsoft.com/office/drawing/2014/main" id="{7E97C88C-7D36-4637-AA8D-36B56D2DA22D}"/>
               </a:ext>
             </a:extLst>
           </p:cNvPr>
@@ -16794,7 +16794,7 @@
           <p:cNvPr id="11" name="Oval 10">
             <a:extLst>
               <a:ext uri="{FF2B5EF4-FFF2-40B4-BE49-F238E27FC236}">
-                <a16:creationId xmlns:a16="http://schemas.microsoft.com/office/drawing/2014/main" id="{63D59DBF-3F86-4ADB-8590-7570951898FA}"/>
+                <a16:creationId xmlns:a16="http://schemas.microsoft.com/office/drawing/2014/main" id="{6E0DA7B2-F18E-49C6-9FF7-DAAD62D1B19C}"/>
               </a:ext>
             </a:extLst>
           </p:cNvPr>
@@ -16825,7 +16825,7 @@
           <p:cNvPr id="12" name="Rectangle 11">
             <a:extLst>
               <a:ext uri="{FF2B5EF4-FFF2-40B4-BE49-F238E27FC236}">
-                <a16:creationId xmlns:a16="http://schemas.microsoft.com/office/drawing/2014/main" id="{A521AB5D-6EFB-4F48-BD5B-E05DDD0A3B65}"/>
+                <a16:creationId xmlns:a16="http://schemas.microsoft.com/office/drawing/2014/main" id="{738F35F1-C8B5-4DAE-931B-27E02A02194B}"/>
               </a:ext>
             </a:extLst>
           </p:cNvPr>
@@ -16887,7 +16887,7 @@
           <p:cNvPr id="13" name="Rectangle: Rounded Corners 12">
             <a:extLst>
               <a:ext uri="{FF2B5EF4-FFF2-40B4-BE49-F238E27FC236}">
-                <a16:creationId xmlns:a16="http://schemas.microsoft.com/office/drawing/2014/main" id="{DA8FD093-D54D-491D-9E2A-BE73F5C4BBB9}"/>
+                <a16:creationId xmlns:a16="http://schemas.microsoft.com/office/drawing/2014/main" id="{D0534737-683C-4E15-A3A2-4352A5C0B449}"/>
               </a:ext>
             </a:extLst>
           </p:cNvPr>
@@ -16922,7 +16922,7 @@
           <p:cNvPr id="14" name="Rectangle 13">
             <a:extLst>
               <a:ext uri="{FF2B5EF4-FFF2-40B4-BE49-F238E27FC236}">
-                <a16:creationId xmlns:a16="http://schemas.microsoft.com/office/drawing/2014/main" id="{8BAB6207-BFBB-477D-AB76-5B946A3247CD}"/>
+                <a16:creationId xmlns:a16="http://schemas.microsoft.com/office/drawing/2014/main" id="{672C4490-C78E-4C55-8492-72B50A7A3833}"/>
               </a:ext>
             </a:extLst>
           </p:cNvPr>
@@ -16984,7 +16984,7 @@
           <p:cNvPr id="15" name="Oval 14">
             <a:extLst>
               <a:ext uri="{FF2B5EF4-FFF2-40B4-BE49-F238E27FC236}">
-                <a16:creationId xmlns:a16="http://schemas.microsoft.com/office/drawing/2014/main" id="{A84A80DD-281D-4D91-957B-739E1D6ADBA7}"/>
+                <a16:creationId xmlns:a16="http://schemas.microsoft.com/office/drawing/2014/main" id="{CA456EBD-F11B-4A76-A3FC-539AE4B50057}"/>
               </a:ext>
             </a:extLst>
           </p:cNvPr>
@@ -17015,7 +17015,7 @@
           <p:cNvPr id="16" name="Rectangle 15">
             <a:extLst>
               <a:ext uri="{FF2B5EF4-FFF2-40B4-BE49-F238E27FC236}">
-                <a16:creationId xmlns:a16="http://schemas.microsoft.com/office/drawing/2014/main" id="{2BFE3154-141B-4CFC-9195-EF5D3B552DCB}"/>
+                <a16:creationId xmlns:a16="http://schemas.microsoft.com/office/drawing/2014/main" id="{DB3B0D93-A350-4636-9E73-F28AF50D7E92}"/>
               </a:ext>
             </a:extLst>
           </p:cNvPr>
@@ -17077,7 +17077,7 @@
           <p:cNvPr id="17" name="Rectangle: Rounded Corners 16">
             <a:extLst>
               <a:ext uri="{FF2B5EF4-FFF2-40B4-BE49-F238E27FC236}">
-                <a16:creationId xmlns:a16="http://schemas.microsoft.com/office/drawing/2014/main" id="{933A734F-2792-4A3E-8933-3FD7E49A0438}"/>
+                <a16:creationId xmlns:a16="http://schemas.microsoft.com/office/drawing/2014/main" id="{5E68F09F-963A-4653-AFF1-2F8DCD1DDC97}"/>
               </a:ext>
             </a:extLst>
           </p:cNvPr>
@@ -17112,7 +17112,7 @@
           <p:cNvPr id="18" name="Rectangle 17">
             <a:extLst>
               <a:ext uri="{FF2B5EF4-FFF2-40B4-BE49-F238E27FC236}">
-                <a16:creationId xmlns:a16="http://schemas.microsoft.com/office/drawing/2014/main" id="{7018F164-9023-4645-A187-D6F72E5FB94D}"/>
+                <a16:creationId xmlns:a16="http://schemas.microsoft.com/office/drawing/2014/main" id="{999C28CB-18B7-4E55-A70E-7D983C41E856}"/>
               </a:ext>
             </a:extLst>
           </p:cNvPr>
@@ -17174,7 +17174,7 @@
           <p:cNvPr id="19" name="Rectangle 18">
             <a:extLst>
               <a:ext uri="{FF2B5EF4-FFF2-40B4-BE49-F238E27FC236}">
-                <a16:creationId xmlns:a16="http://schemas.microsoft.com/office/drawing/2014/main" id="{A73F2554-2191-4A6D-BF25-16672AF84125}"/>
+                <a16:creationId xmlns:a16="http://schemas.microsoft.com/office/drawing/2014/main" id="{89EEE755-5F1A-4259-AA9A-C9C9AEE882C1}"/>
               </a:ext>
             </a:extLst>
           </p:cNvPr>
@@ -17205,7 +17205,7 @@
           <p:cNvPr id="20" name="Rectangle 19">
             <a:extLst>
               <a:ext uri="{FF2B5EF4-FFF2-40B4-BE49-F238E27FC236}">
-                <a16:creationId xmlns:a16="http://schemas.microsoft.com/office/drawing/2014/main" id="{CD7DC0EC-FC53-4AE5-96D3-DA3B47BC7A38}"/>
+                <a16:creationId xmlns:a16="http://schemas.microsoft.com/office/drawing/2014/main" id="{3BA7237A-A5B2-424B-B6B1-50F3FCA6601E}"/>
               </a:ext>
             </a:extLst>
           </p:cNvPr>
@@ -17267,7 +17267,7 @@
           <p:cNvPr id="21" name="Rectangle 20">
             <a:extLst>
               <a:ext uri="{FF2B5EF4-FFF2-40B4-BE49-F238E27FC236}">
-                <a16:creationId xmlns:a16="http://schemas.microsoft.com/office/drawing/2014/main" id="{DBC98DD9-0EB6-4199-9D11-698D52C42EE5}"/>
+                <a16:creationId xmlns:a16="http://schemas.microsoft.com/office/drawing/2014/main" id="{A1317FA9-CECA-4CCD-93A2-36EF516424A0}"/>
               </a:ext>
             </a:extLst>
           </p:cNvPr>
@@ -17327,7 +17327,7 @@
     </p:spTree>
     <p:extLst>
       <p:ext uri="{BB962C8B-B14F-4D97-AF65-F5344CB8AC3E}">
-        <p14:creationId xmlns:p14="http://schemas.microsoft.com/office/powerpoint/2010/main" val="92785600"/>
+        <p14:creationId xmlns:p14="http://schemas.microsoft.com/office/powerpoint/2010/main" val="267746532"/>
       </p:ext>
     </p:extLst>
   </p:cSld>
@@ -17368,7 +17368,7 @@
             <a:hlinkClick r:id="rId3"/>
             <a:extLst>
               <a:ext uri="{FF2B5EF4-FFF2-40B4-BE49-F238E27FC236}">
-                <a16:creationId xmlns:a16="http://schemas.microsoft.com/office/drawing/2014/main" id="{E3BA4FD7-F99B-4DAE-9762-2864E9AB63FC}"/>
+                <a16:creationId xmlns:a16="http://schemas.microsoft.com/office/drawing/2014/main" id="{F3F15D96-4F79-4E68-A6BC-6B8FDEFF256B}"/>
               </a:ext>
             </a:extLst>
           </p:cNvPr>
@@ -17443,7 +17443,7 @@
             <a:hlinkClick r:id="rId4"/>
             <a:extLst>
               <a:ext uri="{FF2B5EF4-FFF2-40B4-BE49-F238E27FC236}">
-                <a16:creationId xmlns:a16="http://schemas.microsoft.com/office/drawing/2014/main" id="{3570772F-25F5-4DF2-B9B5-E50FA20FE5A2}"/>
+                <a16:creationId xmlns:a16="http://schemas.microsoft.com/office/drawing/2014/main" id="{B0184771-4927-4758-AFCB-B510C9784092}"/>
               </a:ext>
             </a:extLst>
           </p:cNvPr>
@@ -17517,7 +17517,7 @@
           <p:cNvPr id="3" name="Rectangle 2">
             <a:extLst>
               <a:ext uri="{FF2B5EF4-FFF2-40B4-BE49-F238E27FC236}">
-                <a16:creationId xmlns:a16="http://schemas.microsoft.com/office/drawing/2014/main" id="{B2404B8A-0D58-4551-9B25-BEE44136A727}"/>
+                <a16:creationId xmlns:a16="http://schemas.microsoft.com/office/drawing/2014/main" id="{7D8B76F6-FA21-4B74-B1C6-C3FD1C0F7F32}"/>
               </a:ext>
             </a:extLst>
           </p:cNvPr>
@@ -17569,7 +17569,7 @@
                 <a:ea typeface="Arial"/>
                 <a:cs typeface="Arial"/>
               </a:rPr>
-              <a:t>CURRENT-EVIDENCE VALIDATION</a:t>
+              <a:t>DATED EXTERNAL MAP RECORD</a:t>
             </a:r>
           </a:p>
         </p:txBody>
@@ -17579,7 +17579,7 @@
           <p:cNvPr id="4" name="Rectangle 3">
             <a:extLst>
               <a:ext uri="{FF2B5EF4-FFF2-40B4-BE49-F238E27FC236}">
-                <a16:creationId xmlns:a16="http://schemas.microsoft.com/office/drawing/2014/main" id="{2545F457-F04D-433A-B668-5577426E3313}"/>
+                <a16:creationId xmlns:a16="http://schemas.microsoft.com/office/drawing/2014/main" id="{9668F030-9182-4885-956F-B680EDB1BD2D}"/>
               </a:ext>
             </a:extLst>
           </p:cNvPr>
@@ -17631,7 +17631,7 @@
                 <a:ea typeface="Arial"/>
                 <a:cs typeface="Arial"/>
               </a:rPr>
-              <a:t>A validated corridor shows its source, review date, and observed geometry.</a:t>
+              <a:t>A dated map record shows its source, review date, and observed geometry.</a:t>
             </a:r>
           </a:p>
         </p:txBody>
@@ -17646,7 +17646,7 @@
         </p:nvPicPr>
         <p:blipFill>
           <a:blip r:embed="rId5"/>
-          <a:srcRect t="29371" b="29371"/>
+          <a:srcRect t="33730" b="33730"/>
           <a:stretch>
             <a:fillRect/>
           </a:stretch>
@@ -17668,7 +17668,7 @@
           <p:cNvPr id="6" name="Rectangle: Rounded Corners 5">
             <a:extLst>
               <a:ext uri="{FF2B5EF4-FFF2-40B4-BE49-F238E27FC236}">
-                <a16:creationId xmlns:a16="http://schemas.microsoft.com/office/drawing/2014/main" id="{F5F5F6A7-FC54-4F1A-8C4E-FD85B40BB973}"/>
+                <a16:creationId xmlns:a16="http://schemas.microsoft.com/office/drawing/2014/main" id="{9F3EF0DD-7B60-49D3-B341-FA0E7CCE99F1}"/>
               </a:ext>
             </a:extLst>
           </p:cNvPr>
@@ -17701,7 +17701,7 @@
           <p:cNvPr id="7" name="Oval 6">
             <a:extLst>
               <a:ext uri="{FF2B5EF4-FFF2-40B4-BE49-F238E27FC236}">
-                <a16:creationId xmlns:a16="http://schemas.microsoft.com/office/drawing/2014/main" id="{2DC2A57D-33D5-4613-B24A-8615C9A7CBCA}"/>
+                <a16:creationId xmlns:a16="http://schemas.microsoft.com/office/drawing/2014/main" id="{8636660F-EDC3-4D08-8EA1-1BB6C9E2B357}"/>
               </a:ext>
             </a:extLst>
           </p:cNvPr>
@@ -17732,7 +17732,7 @@
           <p:cNvPr id="8" name="Rectangle 7">
             <a:extLst>
               <a:ext uri="{FF2B5EF4-FFF2-40B4-BE49-F238E27FC236}">
-                <a16:creationId xmlns:a16="http://schemas.microsoft.com/office/drawing/2014/main" id="{91C09FF4-91A7-4D34-95AF-1F8B5C8C8E74}"/>
+                <a16:creationId xmlns:a16="http://schemas.microsoft.com/office/drawing/2014/main" id="{5DFAB6AC-6E8A-4CD9-A8C8-660541879C76}"/>
               </a:ext>
             </a:extLst>
           </p:cNvPr>
@@ -17794,7 +17794,7 @@
           <p:cNvPr id="9" name="Rectangle: Rounded Corners 8">
             <a:extLst>
               <a:ext uri="{FF2B5EF4-FFF2-40B4-BE49-F238E27FC236}">
-                <a16:creationId xmlns:a16="http://schemas.microsoft.com/office/drawing/2014/main" id="{965530B8-29D3-46D5-A5B5-858AB47710E7}"/>
+                <a16:creationId xmlns:a16="http://schemas.microsoft.com/office/drawing/2014/main" id="{845206FB-EF39-4642-B31F-9EE98A83C629}"/>
               </a:ext>
             </a:extLst>
           </p:cNvPr>
@@ -17829,7 +17829,7 @@
           <p:cNvPr id="10" name="Rectangle 9">
             <a:extLst>
               <a:ext uri="{FF2B5EF4-FFF2-40B4-BE49-F238E27FC236}">
-                <a16:creationId xmlns:a16="http://schemas.microsoft.com/office/drawing/2014/main" id="{BC977C0E-6068-4281-A939-79A03516CB3F}"/>
+                <a16:creationId xmlns:a16="http://schemas.microsoft.com/office/drawing/2014/main" id="{BC68B510-33E8-454D-8263-2CAF8A894BAA}"/>
               </a:ext>
             </a:extLst>
           </p:cNvPr>
@@ -17881,7 +17881,7 @@
                 <a:ea typeface="Arial"/>
                 <a:cs typeface="Arial"/>
               </a:rPr>
-              <a:t>OBSERVED field badges</a:t>
+              <a:t>OBSERVED map and geometry claim</a:t>
             </a:r>
           </a:p>
         </p:txBody>
@@ -17891,7 +17891,7 @@
           <p:cNvPr id="11" name="Oval 10">
             <a:extLst>
               <a:ext uri="{FF2B5EF4-FFF2-40B4-BE49-F238E27FC236}">
-                <a16:creationId xmlns:a16="http://schemas.microsoft.com/office/drawing/2014/main" id="{3CA547B5-ECBA-426E-87A1-FBBBF848467E}"/>
+                <a16:creationId xmlns:a16="http://schemas.microsoft.com/office/drawing/2014/main" id="{CF30EEFE-01BA-4514-8F1A-60F61CAC3521}"/>
               </a:ext>
             </a:extLst>
           </p:cNvPr>
@@ -17922,7 +17922,7 @@
           <p:cNvPr id="12" name="Rectangle 11">
             <a:extLst>
               <a:ext uri="{FF2B5EF4-FFF2-40B4-BE49-F238E27FC236}">
-                <a16:creationId xmlns:a16="http://schemas.microsoft.com/office/drawing/2014/main" id="{223B0428-95D4-4F81-8433-898D2A1F85CE}"/>
+                <a16:creationId xmlns:a16="http://schemas.microsoft.com/office/drawing/2014/main" id="{9E1AE6DB-4A12-44E3-B104-F480C6F87E82}"/>
               </a:ext>
             </a:extLst>
           </p:cNvPr>
@@ -17984,7 +17984,7 @@
           <p:cNvPr id="13" name="Rectangle: Rounded Corners 12">
             <a:extLst>
               <a:ext uri="{FF2B5EF4-FFF2-40B4-BE49-F238E27FC236}">
-                <a16:creationId xmlns:a16="http://schemas.microsoft.com/office/drawing/2014/main" id="{98BCB48F-58D3-4AB4-B17F-2DF354853965}"/>
+                <a16:creationId xmlns:a16="http://schemas.microsoft.com/office/drawing/2014/main" id="{079C4437-5FE6-4897-8ECF-614337B3941A}"/>
               </a:ext>
             </a:extLst>
           </p:cNvPr>
@@ -18019,7 +18019,7 @@
           <p:cNvPr id="14" name="Rectangle 13">
             <a:extLst>
               <a:ext uri="{FF2B5EF4-FFF2-40B4-BE49-F238E27FC236}">
-                <a16:creationId xmlns:a16="http://schemas.microsoft.com/office/drawing/2014/main" id="{16BEFE70-8525-4F6A-8C5D-F90EFAB0BB67}"/>
+                <a16:creationId xmlns:a16="http://schemas.microsoft.com/office/drawing/2014/main" id="{D46F94C2-2B09-4FA1-9006-5B12DB72D423}"/>
               </a:ext>
             </a:extLst>
           </p:cNvPr>
@@ -18081,7 +18081,7 @@
           <p:cNvPr id="15" name="Oval 14">
             <a:extLst>
               <a:ext uri="{FF2B5EF4-FFF2-40B4-BE49-F238E27FC236}">
-                <a16:creationId xmlns:a16="http://schemas.microsoft.com/office/drawing/2014/main" id="{3881175F-7A4A-4218-9840-6B614635DFE6}"/>
+                <a16:creationId xmlns:a16="http://schemas.microsoft.com/office/drawing/2014/main" id="{1C2D32ED-BCD6-413F-BDDF-1D82653F0C59}"/>
               </a:ext>
             </a:extLst>
           </p:cNvPr>
@@ -18112,7 +18112,7 @@
           <p:cNvPr id="16" name="Rectangle 15">
             <a:extLst>
               <a:ext uri="{FF2B5EF4-FFF2-40B4-BE49-F238E27FC236}">
-                <a16:creationId xmlns:a16="http://schemas.microsoft.com/office/drawing/2014/main" id="{F0D40025-3A82-4F50-84DF-2B3C8BBFCAD7}"/>
+                <a16:creationId xmlns:a16="http://schemas.microsoft.com/office/drawing/2014/main" id="{44267B69-A958-4E11-A9CD-E925C20F61D4}"/>
               </a:ext>
             </a:extLst>
           </p:cNvPr>
@@ -18174,7 +18174,7 @@
           <p:cNvPr id="17" name="Rectangle: Rounded Corners 16">
             <a:extLst>
               <a:ext uri="{FF2B5EF4-FFF2-40B4-BE49-F238E27FC236}">
-                <a16:creationId xmlns:a16="http://schemas.microsoft.com/office/drawing/2014/main" id="{BAB7F09F-A452-48E3-B2EA-B31ED95016FF}"/>
+                <a16:creationId xmlns:a16="http://schemas.microsoft.com/office/drawing/2014/main" id="{AF6DA9EE-B7FB-43F8-8AE2-42FD96D726F9}"/>
               </a:ext>
             </a:extLst>
           </p:cNvPr>
@@ -18209,7 +18209,7 @@
           <p:cNvPr id="18" name="Rectangle 17">
             <a:extLst>
               <a:ext uri="{FF2B5EF4-FFF2-40B4-BE49-F238E27FC236}">
-                <a16:creationId xmlns:a16="http://schemas.microsoft.com/office/drawing/2014/main" id="{BC522444-3C2A-40AC-890D-C51D7C13EBD8}"/>
+                <a16:creationId xmlns:a16="http://schemas.microsoft.com/office/drawing/2014/main" id="{D9FFA410-F4C6-4E54-BA1A-31867C766413}"/>
               </a:ext>
             </a:extLst>
           </p:cNvPr>
@@ -18271,7 +18271,7 @@
           <p:cNvPr id="19" name="Rectangle 18">
             <a:extLst>
               <a:ext uri="{FF2B5EF4-FFF2-40B4-BE49-F238E27FC236}">
-                <a16:creationId xmlns:a16="http://schemas.microsoft.com/office/drawing/2014/main" id="{90825220-19E8-426E-A939-C3D86A343724}"/>
+                <a16:creationId xmlns:a16="http://schemas.microsoft.com/office/drawing/2014/main" id="{C08CF11A-A1C1-4C4F-A339-6828E1513663}"/>
               </a:ext>
             </a:extLst>
           </p:cNvPr>
@@ -18302,7 +18302,7 @@
           <p:cNvPr id="20" name="Rectangle 19">
             <a:extLst>
               <a:ext uri="{FF2B5EF4-FFF2-40B4-BE49-F238E27FC236}">
-                <a16:creationId xmlns:a16="http://schemas.microsoft.com/office/drawing/2014/main" id="{01A26E61-435A-4063-A427-91703E17893C}"/>
+                <a16:creationId xmlns:a16="http://schemas.microsoft.com/office/drawing/2014/main" id="{5A5296E5-0532-4A89-8C85-EB7917805ABC}"/>
               </a:ext>
             </a:extLst>
           </p:cNvPr>
@@ -18364,7 +18364,7 @@
           <p:cNvPr id="21" name="Rectangle 20">
             <a:extLst>
               <a:ext uri="{FF2B5EF4-FFF2-40B4-BE49-F238E27FC236}">
-                <a16:creationId xmlns:a16="http://schemas.microsoft.com/office/drawing/2014/main" id="{85BC40C4-EA4A-49B6-8003-76AF21C7C8E8}"/>
+                <a16:creationId xmlns:a16="http://schemas.microsoft.com/office/drawing/2014/main" id="{C1056A2A-5274-40EC-8FD6-FE42848E3EE4}"/>
               </a:ext>
             </a:extLst>
           </p:cNvPr>
@@ -18424,7 +18424,7 @@
     </p:spTree>
     <p:extLst>
       <p:ext uri="{BB962C8B-B14F-4D97-AF65-F5344CB8AC3E}">
-        <p14:creationId xmlns:p14="http://schemas.microsoft.com/office/powerpoint/2010/main" val="1521238105"/>
+        <p14:creationId xmlns:p14="http://schemas.microsoft.com/office/powerpoint/2010/main" val="483070044"/>
       </p:ext>
     </p:extLst>
   </p:cSld>
@@ -18465,7 +18465,7 @@
             <a:hlinkClick r:id="rId3"/>
             <a:extLst>
               <a:ext uri="{FF2B5EF4-FFF2-40B4-BE49-F238E27FC236}">
-                <a16:creationId xmlns:a16="http://schemas.microsoft.com/office/drawing/2014/main" id="{893929FD-23AA-4664-84A6-C2BDB421CA4B}"/>
+                <a16:creationId xmlns:a16="http://schemas.microsoft.com/office/drawing/2014/main" id="{E71D383A-E0CE-4589-B5E2-95695A17240E}"/>
               </a:ext>
             </a:extLst>
           </p:cNvPr>
@@ -18540,7 +18540,7 @@
             <a:hlinkClick r:id="rId4"/>
             <a:extLst>
               <a:ext uri="{FF2B5EF4-FFF2-40B4-BE49-F238E27FC236}">
-                <a16:creationId xmlns:a16="http://schemas.microsoft.com/office/drawing/2014/main" id="{A8F05B5C-33A2-4D59-9C42-DEB7F7342DD6}"/>
+                <a16:creationId xmlns:a16="http://schemas.microsoft.com/office/drawing/2014/main" id="{8709EB3A-CE87-4252-9CBA-0C2D3C79E7FC}"/>
               </a:ext>
             </a:extLst>
           </p:cNvPr>
@@ -18614,7 +18614,7 @@
           <p:cNvPr id="3" name="Rectangle 2">
             <a:extLst>
               <a:ext uri="{FF2B5EF4-FFF2-40B4-BE49-F238E27FC236}">
-                <a16:creationId xmlns:a16="http://schemas.microsoft.com/office/drawing/2014/main" id="{3165FFF0-6FF7-4D92-AB0A-10649FE03FF3}"/>
+                <a16:creationId xmlns:a16="http://schemas.microsoft.com/office/drawing/2014/main" id="{EEBB864C-F1F8-49A8-985B-60E9640F7E6D}"/>
               </a:ext>
             </a:extLst>
           </p:cNvPr>
@@ -18676,7 +18676,7 @@
           <p:cNvPr id="4" name="Rectangle 3">
             <a:extLst>
               <a:ext uri="{FF2B5EF4-FFF2-40B4-BE49-F238E27FC236}">
-                <a16:creationId xmlns:a16="http://schemas.microsoft.com/office/drawing/2014/main" id="{53C7053C-B463-40C6-B251-318C236D4D3A}"/>
+                <a16:creationId xmlns:a16="http://schemas.microsoft.com/office/drawing/2014/main" id="{0D9E8EC8-4F06-4C01-8C05-0012E15F618F}"/>
               </a:ext>
             </a:extLst>
           </p:cNvPr>
@@ -18743,7 +18743,7 @@
         </p:nvPicPr>
         <p:blipFill>
           <a:blip r:embed="rId5"/>
-          <a:srcRect t="27645" b="27645"/>
+          <a:srcRect t="15586" b="15586"/>
           <a:stretch>
             <a:fillRect/>
           </a:stretch>
@@ -18765,7 +18765,7 @@
           <p:cNvPr id="6" name="Rectangle: Rounded Corners 5">
             <a:extLst>
               <a:ext uri="{FF2B5EF4-FFF2-40B4-BE49-F238E27FC236}">
-                <a16:creationId xmlns:a16="http://schemas.microsoft.com/office/drawing/2014/main" id="{0EB408AD-2859-4F18-A1B9-E3A9E222224D}"/>
+                <a16:creationId xmlns:a16="http://schemas.microsoft.com/office/drawing/2014/main" id="{6CBF0E6E-F1E5-4287-AD7F-E6F812C56970}"/>
               </a:ext>
             </a:extLst>
           </p:cNvPr>
@@ -18798,7 +18798,7 @@
           <p:cNvPr id="7" name="Oval 6">
             <a:extLst>
               <a:ext uri="{FF2B5EF4-FFF2-40B4-BE49-F238E27FC236}">
-                <a16:creationId xmlns:a16="http://schemas.microsoft.com/office/drawing/2014/main" id="{487A79F0-C01D-4A63-9C17-3803BD36E019}"/>
+                <a16:creationId xmlns:a16="http://schemas.microsoft.com/office/drawing/2014/main" id="{07EE46C4-3A6D-47AF-98FB-53036F6FEE54}"/>
               </a:ext>
             </a:extLst>
           </p:cNvPr>
@@ -18829,7 +18829,7 @@
           <p:cNvPr id="8" name="Rectangle 7">
             <a:extLst>
               <a:ext uri="{FF2B5EF4-FFF2-40B4-BE49-F238E27FC236}">
-                <a16:creationId xmlns:a16="http://schemas.microsoft.com/office/drawing/2014/main" id="{7805968F-5ADF-4DF7-B41B-5F848C0D0F73}"/>
+                <a16:creationId xmlns:a16="http://schemas.microsoft.com/office/drawing/2014/main" id="{B1AC4D29-A9B3-4EC1-803A-8FA03B4B36A2}"/>
               </a:ext>
             </a:extLst>
           </p:cNvPr>
@@ -18891,7 +18891,7 @@
           <p:cNvPr id="9" name="Rectangle: Rounded Corners 8">
             <a:extLst>
               <a:ext uri="{FF2B5EF4-FFF2-40B4-BE49-F238E27FC236}">
-                <a16:creationId xmlns:a16="http://schemas.microsoft.com/office/drawing/2014/main" id="{9FF271C1-BA71-446E-BA6D-9C3371D6266D}"/>
+                <a16:creationId xmlns:a16="http://schemas.microsoft.com/office/drawing/2014/main" id="{60C0BCD1-7AF0-4CFC-A119-65330F9F2865}"/>
               </a:ext>
             </a:extLst>
           </p:cNvPr>
@@ -18926,7 +18926,7 @@
           <p:cNvPr id="10" name="Rectangle 9">
             <a:extLst>
               <a:ext uri="{FF2B5EF4-FFF2-40B4-BE49-F238E27FC236}">
-                <a16:creationId xmlns:a16="http://schemas.microsoft.com/office/drawing/2014/main" id="{B9FF830E-A0F6-4E22-8589-9EC7F6DCFF01}"/>
+                <a16:creationId xmlns:a16="http://schemas.microsoft.com/office/drawing/2014/main" id="{28D6E99C-D290-4149-B6D7-D1D9C6F9D299}"/>
               </a:ext>
             </a:extLst>
           </p:cNvPr>
@@ -18978,7 +18978,7 @@
                 <a:ea typeface="Arial"/>
                 <a:cs typeface="Arial"/>
               </a:rPr>
-              <a:t>Priority, evidence, stability</a:t>
+              <a:t>Validation rank</a:t>
             </a:r>
           </a:p>
         </p:txBody>
@@ -18988,7 +18988,7 @@
           <p:cNvPr id="11" name="Oval 10">
             <a:extLst>
               <a:ext uri="{FF2B5EF4-FFF2-40B4-BE49-F238E27FC236}">
-                <a16:creationId xmlns:a16="http://schemas.microsoft.com/office/drawing/2014/main" id="{DA591217-86E2-43B5-8E73-C786576BBCCC}"/>
+                <a16:creationId xmlns:a16="http://schemas.microsoft.com/office/drawing/2014/main" id="{87A60282-F8E9-466C-B706-4E1A50E0E3EA}"/>
               </a:ext>
             </a:extLst>
           </p:cNvPr>
@@ -19019,7 +19019,7 @@
           <p:cNvPr id="12" name="Rectangle 11">
             <a:extLst>
               <a:ext uri="{FF2B5EF4-FFF2-40B4-BE49-F238E27FC236}">
-                <a16:creationId xmlns:a16="http://schemas.microsoft.com/office/drawing/2014/main" id="{4EBB151D-51B9-4CBC-9A80-24F2D848C7BC}"/>
+                <a16:creationId xmlns:a16="http://schemas.microsoft.com/office/drawing/2014/main" id="{73755B59-6C5F-4719-A461-F36D108DF6B2}"/>
               </a:ext>
             </a:extLst>
           </p:cNvPr>
@@ -19081,7 +19081,7 @@
           <p:cNvPr id="13" name="Rectangle: Rounded Corners 12">
             <a:extLst>
               <a:ext uri="{FF2B5EF4-FFF2-40B4-BE49-F238E27FC236}">
-                <a16:creationId xmlns:a16="http://schemas.microsoft.com/office/drawing/2014/main" id="{D9714F7A-5439-4709-AF74-8472407DFA3A}"/>
+                <a16:creationId xmlns:a16="http://schemas.microsoft.com/office/drawing/2014/main" id="{CF9C0DBF-D931-4493-916A-97E286F9BC6E}"/>
               </a:ext>
             </a:extLst>
           </p:cNvPr>
@@ -19116,7 +19116,7 @@
           <p:cNvPr id="14" name="Rectangle 13">
             <a:extLst>
               <a:ext uri="{FF2B5EF4-FFF2-40B4-BE49-F238E27FC236}">
-                <a16:creationId xmlns:a16="http://schemas.microsoft.com/office/drawing/2014/main" id="{4F12C898-BEFF-4CE7-9E2B-F020C7195B36}"/>
+                <a16:creationId xmlns:a16="http://schemas.microsoft.com/office/drawing/2014/main" id="{1B1DDB75-412F-4C4F-9353-14C279580DE2}"/>
               </a:ext>
             </a:extLst>
           </p:cNvPr>
@@ -19168,7 +19168,7 @@
                 <a:ea typeface="Arial"/>
                 <a:cs typeface="Arial"/>
               </a:rPr>
-              <a:t>Eight field-status badges</a:t>
+              <a:t>Evidence confidence</a:t>
             </a:r>
           </a:p>
         </p:txBody>
@@ -19178,7 +19178,7 @@
           <p:cNvPr id="15" name="Oval 14">
             <a:extLst>
               <a:ext uri="{FF2B5EF4-FFF2-40B4-BE49-F238E27FC236}">
-                <a16:creationId xmlns:a16="http://schemas.microsoft.com/office/drawing/2014/main" id="{82C00146-AC3F-4E77-BE43-9F4F8D6F3F9C}"/>
+                <a16:creationId xmlns:a16="http://schemas.microsoft.com/office/drawing/2014/main" id="{1372F7DF-AB9B-421B-B9E1-B63A0A213C63}"/>
               </a:ext>
             </a:extLst>
           </p:cNvPr>
@@ -19209,7 +19209,7 @@
           <p:cNvPr id="16" name="Rectangle 15">
             <a:extLst>
               <a:ext uri="{FF2B5EF4-FFF2-40B4-BE49-F238E27FC236}">
-                <a16:creationId xmlns:a16="http://schemas.microsoft.com/office/drawing/2014/main" id="{A6076861-BFF7-4420-A365-E85B116EE99F}"/>
+                <a16:creationId xmlns:a16="http://schemas.microsoft.com/office/drawing/2014/main" id="{28EA6D74-3735-4316-8AD0-08711A4C12EF}"/>
               </a:ext>
             </a:extLst>
           </p:cNvPr>
@@ -19271,7 +19271,7 @@
           <p:cNvPr id="17" name="Rectangle: Rounded Corners 16">
             <a:extLst>
               <a:ext uri="{FF2B5EF4-FFF2-40B4-BE49-F238E27FC236}">
-                <a16:creationId xmlns:a16="http://schemas.microsoft.com/office/drawing/2014/main" id="{11C0D16A-5556-444B-8DD2-4557007C02E6}"/>
+                <a16:creationId xmlns:a16="http://schemas.microsoft.com/office/drawing/2014/main" id="{A3406500-A1DF-4B52-95D9-90F91E8078B9}"/>
               </a:ext>
             </a:extLst>
           </p:cNvPr>
@@ -19306,7 +19306,7 @@
           <p:cNvPr id="18" name="Rectangle 17">
             <a:extLst>
               <a:ext uri="{FF2B5EF4-FFF2-40B4-BE49-F238E27FC236}">
-                <a16:creationId xmlns:a16="http://schemas.microsoft.com/office/drawing/2014/main" id="{DA1CD70B-E79E-4F9D-A2F1-0E3C8A9CC685}"/>
+                <a16:creationId xmlns:a16="http://schemas.microsoft.com/office/drawing/2014/main" id="{44638F9A-8CF7-46F8-9529-8FDF6C6C1308}"/>
               </a:ext>
             </a:extLst>
           </p:cNvPr>
@@ -19358,7 +19358,7 @@
                 <a:ea typeface="Arial"/>
                 <a:cs typeface="Arial"/>
               </a:rPr>
-              <a:t>Climate and validation action</a:t>
+              <a:t>Validate next</a:t>
             </a:r>
           </a:p>
         </p:txBody>
@@ -19368,7 +19368,7 @@
           <p:cNvPr id="19" name="Rectangle 18">
             <a:extLst>
               <a:ext uri="{FF2B5EF4-FFF2-40B4-BE49-F238E27FC236}">
-                <a16:creationId xmlns:a16="http://schemas.microsoft.com/office/drawing/2014/main" id="{FA748C3C-F9E9-4416-B77E-5054B894E350}"/>
+                <a16:creationId xmlns:a16="http://schemas.microsoft.com/office/drawing/2014/main" id="{C3A4B490-90BE-4053-BD23-FB2E9FF657E0}"/>
               </a:ext>
             </a:extLst>
           </p:cNvPr>
@@ -19399,7 +19399,7 @@
           <p:cNvPr id="20" name="Rectangle 19">
             <a:extLst>
               <a:ext uri="{FF2B5EF4-FFF2-40B4-BE49-F238E27FC236}">
-                <a16:creationId xmlns:a16="http://schemas.microsoft.com/office/drawing/2014/main" id="{40590FF6-B555-4A37-9D90-BC30D131DB31}"/>
+                <a16:creationId xmlns:a16="http://schemas.microsoft.com/office/drawing/2014/main" id="{33DBE82B-E2BA-4BE8-BCE9-0FD793CAB1D6}"/>
               </a:ext>
             </a:extLst>
           </p:cNvPr>
@@ -19461,7 +19461,7 @@
           <p:cNvPr id="21" name="Rectangle 20">
             <a:extLst>
               <a:ext uri="{FF2B5EF4-FFF2-40B4-BE49-F238E27FC236}">
-                <a16:creationId xmlns:a16="http://schemas.microsoft.com/office/drawing/2014/main" id="{9AA99B01-B425-493B-8698-871828A0E5C3}"/>
+                <a16:creationId xmlns:a16="http://schemas.microsoft.com/office/drawing/2014/main" id="{1C8E2E54-58CC-4EBA-8697-7C0E4E3ED38E}"/>
               </a:ext>
             </a:extLst>
           </p:cNvPr>
@@ -19521,7 +19521,7 @@
     </p:spTree>
     <p:extLst>
       <p:ext uri="{BB962C8B-B14F-4D97-AF65-F5344CB8AC3E}">
-        <p14:creationId xmlns:p14="http://schemas.microsoft.com/office/powerpoint/2010/main" val="61586104"/>
+        <p14:creationId xmlns:p14="http://schemas.microsoft.com/office/powerpoint/2010/main" val="1468527240"/>
       </p:ext>
     </p:extLst>
   </p:cSld>
@@ -19562,7 +19562,7 @@
             <a:hlinkClick r:id="rId3"/>
             <a:extLst>
               <a:ext uri="{FF2B5EF4-FFF2-40B4-BE49-F238E27FC236}">
-                <a16:creationId xmlns:a16="http://schemas.microsoft.com/office/drawing/2014/main" id="{8DCE41BD-8120-405B-A7AB-DFC2927CA792}"/>
+                <a16:creationId xmlns:a16="http://schemas.microsoft.com/office/drawing/2014/main" id="{3F08B46F-7A7F-49B2-990B-98BC5AC1EDB4}"/>
               </a:ext>
             </a:extLst>
           </p:cNvPr>
@@ -19637,7 +19637,7 @@
             <a:hlinkClick r:id="rId4"/>
             <a:extLst>
               <a:ext uri="{FF2B5EF4-FFF2-40B4-BE49-F238E27FC236}">
-                <a16:creationId xmlns:a16="http://schemas.microsoft.com/office/drawing/2014/main" id="{EA2662FA-D6FF-4ED7-A608-5225A4EDE3D3}"/>
+                <a16:creationId xmlns:a16="http://schemas.microsoft.com/office/drawing/2014/main" id="{A0FA976A-9CF1-4992-87E0-6992A03729E2}"/>
               </a:ext>
             </a:extLst>
           </p:cNvPr>
@@ -19711,7 +19711,7 @@
           <p:cNvPr id="3" name="Rectangle 2">
             <a:extLst>
               <a:ext uri="{FF2B5EF4-FFF2-40B4-BE49-F238E27FC236}">
-                <a16:creationId xmlns:a16="http://schemas.microsoft.com/office/drawing/2014/main" id="{6F4D674F-8D95-41E6-BE61-8D7BC60630FE}"/>
+                <a16:creationId xmlns:a16="http://schemas.microsoft.com/office/drawing/2014/main" id="{718B5FF7-75FE-4546-BACA-017108A01DBA}"/>
               </a:ext>
             </a:extLst>
           </p:cNvPr>
@@ -19773,7 +19773,7 @@
           <p:cNvPr id="4" name="Rectangle 3">
             <a:extLst>
               <a:ext uri="{FF2B5EF4-FFF2-40B4-BE49-F238E27FC236}">
-                <a16:creationId xmlns:a16="http://schemas.microsoft.com/office/drawing/2014/main" id="{80315A0F-A6AB-4A42-84FE-86781C99D189}"/>
+                <a16:creationId xmlns:a16="http://schemas.microsoft.com/office/drawing/2014/main" id="{F0BA1FF5-468C-40ED-AEF1-972A2F050FD5}"/>
               </a:ext>
             </a:extLst>
           </p:cNvPr>
@@ -19840,7 +19840,7 @@
         </p:nvPicPr>
         <p:blipFill>
           <a:blip r:embed="rId5"/>
-          <a:srcRect t="13797" b="13797"/>
+          <a:srcRect l="5141" r="5141"/>
           <a:stretch>
             <a:fillRect/>
           </a:stretch>
@@ -19862,7 +19862,7 @@
           <p:cNvPr id="6" name="Rectangle: Rounded Corners 5">
             <a:extLst>
               <a:ext uri="{FF2B5EF4-FFF2-40B4-BE49-F238E27FC236}">
-                <a16:creationId xmlns:a16="http://schemas.microsoft.com/office/drawing/2014/main" id="{75761148-F221-49C5-B93A-ABC58DA99849}"/>
+                <a16:creationId xmlns:a16="http://schemas.microsoft.com/office/drawing/2014/main" id="{A946D82A-7083-4DE4-B008-A544C6B18EB8}"/>
               </a:ext>
             </a:extLst>
           </p:cNvPr>
@@ -19911,7 +19911,7 @@
           <p:cNvPr id="8" name="Rectangle 7">
             <a:extLst>
               <a:ext uri="{FF2B5EF4-FFF2-40B4-BE49-F238E27FC236}">
-                <a16:creationId xmlns:a16="http://schemas.microsoft.com/office/drawing/2014/main" id="{14E74962-32EF-4246-A411-91F9410ACC09}"/>
+                <a16:creationId xmlns:a16="http://schemas.microsoft.com/office/drawing/2014/main" id="{28703A27-A9FF-4701-82B0-0FFDD2F67356}"/>
               </a:ext>
             </a:extLst>
           </p:cNvPr>
@@ -19973,7 +19973,7 @@
           <p:cNvPr id="9" name="Rectangle 8">
             <a:extLst>
               <a:ext uri="{FF2B5EF4-FFF2-40B4-BE49-F238E27FC236}">
-                <a16:creationId xmlns:a16="http://schemas.microsoft.com/office/drawing/2014/main" id="{8F89ECF7-1274-49C2-B790-E8EA3D312348}"/>
+                <a16:creationId xmlns:a16="http://schemas.microsoft.com/office/drawing/2014/main" id="{631B4F34-D003-4EC2-A82D-8C2147E4895D}"/>
               </a:ext>
             </a:extLst>
           </p:cNvPr>
@@ -20035,7 +20035,7 @@
           <p:cNvPr id="10" name="Rectangle 9">
             <a:extLst>
               <a:ext uri="{FF2B5EF4-FFF2-40B4-BE49-F238E27FC236}">
-                <a16:creationId xmlns:a16="http://schemas.microsoft.com/office/drawing/2014/main" id="{457A2989-AADA-4457-AD57-D45525902B03}"/>
+                <a16:creationId xmlns:a16="http://schemas.microsoft.com/office/drawing/2014/main" id="{42547F0F-CFCE-49E9-AF84-6C3468414E3B}"/>
               </a:ext>
             </a:extLst>
           </p:cNvPr>
@@ -20097,7 +20097,7 @@
           <p:cNvPr id="11" name="Rectangle: Rounded Corners 10">
             <a:extLst>
               <a:ext uri="{FF2B5EF4-FFF2-40B4-BE49-F238E27FC236}">
-                <a16:creationId xmlns:a16="http://schemas.microsoft.com/office/drawing/2014/main" id="{0647304E-17C3-4815-8DD1-5CADB30F005F}"/>
+                <a16:creationId xmlns:a16="http://schemas.microsoft.com/office/drawing/2014/main" id="{D9BC59F5-FA1D-44FB-8BB4-DE1C22CDA1D4}"/>
               </a:ext>
             </a:extLst>
           </p:cNvPr>
@@ -20130,7 +20130,7 @@
           <p:cNvPr id="12" name="Rectangle 11">
             <a:extLst>
               <a:ext uri="{FF2B5EF4-FFF2-40B4-BE49-F238E27FC236}">
-                <a16:creationId xmlns:a16="http://schemas.microsoft.com/office/drawing/2014/main" id="{FDAC1532-7002-433B-AC19-0D361F44BDF7}"/>
+                <a16:creationId xmlns:a16="http://schemas.microsoft.com/office/drawing/2014/main" id="{E3A155C7-0CB8-4A2C-8125-1D464676D567}"/>
               </a:ext>
             </a:extLst>
           </p:cNvPr>
@@ -20192,7 +20192,7 @@
           <p:cNvPr id="13" name="Rectangle: Rounded Corners 12">
             <a:extLst>
               <a:ext uri="{FF2B5EF4-FFF2-40B4-BE49-F238E27FC236}">
-                <a16:creationId xmlns:a16="http://schemas.microsoft.com/office/drawing/2014/main" id="{5DCECD10-44CF-4530-BC89-92C6386A4EF7}"/>
+                <a16:creationId xmlns:a16="http://schemas.microsoft.com/office/drawing/2014/main" id="{9BA760BE-7409-4924-AEAB-DB4D563696BC}"/>
               </a:ext>
             </a:extLst>
           </p:cNvPr>
@@ -20225,7 +20225,7 @@
           <p:cNvPr id="14" name="Rectangle 13">
             <a:extLst>
               <a:ext uri="{FF2B5EF4-FFF2-40B4-BE49-F238E27FC236}">
-                <a16:creationId xmlns:a16="http://schemas.microsoft.com/office/drawing/2014/main" id="{53D1B079-E305-4B3C-94CE-E3E818D11966}"/>
+                <a16:creationId xmlns:a16="http://schemas.microsoft.com/office/drawing/2014/main" id="{28A4F1E2-5F67-4437-A48D-3534EC0C738E}"/>
               </a:ext>
             </a:extLst>
           </p:cNvPr>
@@ -20287,7 +20287,7 @@
           <p:cNvPr id="15" name="Rectangle 14">
             <a:extLst>
               <a:ext uri="{FF2B5EF4-FFF2-40B4-BE49-F238E27FC236}">
-                <a16:creationId xmlns:a16="http://schemas.microsoft.com/office/drawing/2014/main" id="{0D1B9924-F31C-462B-AFE5-DB5419190FB9}"/>
+                <a16:creationId xmlns:a16="http://schemas.microsoft.com/office/drawing/2014/main" id="{C87437DE-77EC-4694-A4E4-F6E317E37047}"/>
               </a:ext>
             </a:extLst>
           </p:cNvPr>
@@ -20318,7 +20318,7 @@
           <p:cNvPr id="16" name="Rectangle 15">
             <a:extLst>
               <a:ext uri="{FF2B5EF4-FFF2-40B4-BE49-F238E27FC236}">
-                <a16:creationId xmlns:a16="http://schemas.microsoft.com/office/drawing/2014/main" id="{BA80BC33-5FF4-4E1E-BBCC-1E06CB1FD306}"/>
+                <a16:creationId xmlns:a16="http://schemas.microsoft.com/office/drawing/2014/main" id="{A54B0F84-31F4-4662-B92F-79146DF4557C}"/>
               </a:ext>
             </a:extLst>
           </p:cNvPr>
@@ -20380,7 +20380,7 @@
           <p:cNvPr id="17" name="Rectangle 16">
             <a:extLst>
               <a:ext uri="{FF2B5EF4-FFF2-40B4-BE49-F238E27FC236}">
-                <a16:creationId xmlns:a16="http://schemas.microsoft.com/office/drawing/2014/main" id="{9E62DB4C-3D39-41AB-94C9-CFCADAC84360}"/>
+                <a16:creationId xmlns:a16="http://schemas.microsoft.com/office/drawing/2014/main" id="{9208DA0D-0457-486F-8504-BA8AD62E8B09}"/>
               </a:ext>
             </a:extLst>
           </p:cNvPr>
@@ -20440,7 +20440,7 @@
     </p:spTree>
     <p:extLst>
       <p:ext uri="{BB962C8B-B14F-4D97-AF65-F5344CB8AC3E}">
-        <p14:creationId xmlns:p14="http://schemas.microsoft.com/office/powerpoint/2010/main" val="771841773"/>
+        <p14:creationId xmlns:p14="http://schemas.microsoft.com/office/powerpoint/2010/main" val="1846655817"/>
       </p:ext>
     </p:extLst>
   </p:cSld>
@@ -20481,7 +20481,7 @@
             <a:hlinkClick r:id="rId3"/>
             <a:extLst>
               <a:ext uri="{FF2B5EF4-FFF2-40B4-BE49-F238E27FC236}">
-                <a16:creationId xmlns:a16="http://schemas.microsoft.com/office/drawing/2014/main" id="{8A409CFA-F2AB-4DE1-87BD-61ED936FDE80}"/>
+                <a16:creationId xmlns:a16="http://schemas.microsoft.com/office/drawing/2014/main" id="{1026C430-7B06-4D77-989C-20B8C32C624F}"/>
               </a:ext>
             </a:extLst>
           </p:cNvPr>
@@ -20556,7 +20556,7 @@
             <a:hlinkClick r:id="rId4"/>
             <a:extLst>
               <a:ext uri="{FF2B5EF4-FFF2-40B4-BE49-F238E27FC236}">
-                <a16:creationId xmlns:a16="http://schemas.microsoft.com/office/drawing/2014/main" id="{3386B24D-17FC-41FE-B34C-2EB36E33902A}"/>
+                <a16:creationId xmlns:a16="http://schemas.microsoft.com/office/drawing/2014/main" id="{7AFE2322-FAD6-436D-805C-B1C29AA3E1A7}"/>
               </a:ext>
             </a:extLst>
           </p:cNvPr>
@@ -20630,7 +20630,7 @@
           <p:cNvPr id="3" name="Rectangle 2">
             <a:extLst>
               <a:ext uri="{FF2B5EF4-FFF2-40B4-BE49-F238E27FC236}">
-                <a16:creationId xmlns:a16="http://schemas.microsoft.com/office/drawing/2014/main" id="{57920EF8-751C-4BE3-89EB-6A7FA696739A}"/>
+                <a16:creationId xmlns:a16="http://schemas.microsoft.com/office/drawing/2014/main" id="{EBAB6BB2-CD7D-42F5-A6AE-F5B6DCE06DC4}"/>
               </a:ext>
             </a:extLst>
           </p:cNvPr>
@@ -20692,7 +20692,7 @@
           <p:cNvPr id="4" name="Rectangle 3">
             <a:extLst>
               <a:ext uri="{FF2B5EF4-FFF2-40B4-BE49-F238E27FC236}">
-                <a16:creationId xmlns:a16="http://schemas.microsoft.com/office/drawing/2014/main" id="{675F130C-84FD-4133-A08D-59597C2A537E}"/>
+                <a16:creationId xmlns:a16="http://schemas.microsoft.com/office/drawing/2014/main" id="{7B210F30-8F16-4D28-8D31-D5EB0B5B9063}"/>
               </a:ext>
             </a:extLst>
           </p:cNvPr>
@@ -20744,7 +20744,7 @@
                 <a:ea typeface="Arial"/>
                 <a:cs typeface="Arial"/>
               </a:rPr>
-              <a:t>The selected route is compared against similar corridors.</a:t>
+              <a:t>Typology is a descriptive comparison aid, not a prediction.</a:t>
             </a:r>
           </a:p>
         </p:txBody>
@@ -20781,7 +20781,7 @@
           <p:cNvPr id="6" name="Rectangle: Rounded Corners 5">
             <a:extLst>
               <a:ext uri="{FF2B5EF4-FFF2-40B4-BE49-F238E27FC236}">
-                <a16:creationId xmlns:a16="http://schemas.microsoft.com/office/drawing/2014/main" id="{16E35A32-B702-4B26-AF6B-7E38E5914B6C}"/>
+                <a16:creationId xmlns:a16="http://schemas.microsoft.com/office/drawing/2014/main" id="{E12F7D06-D485-4CF2-8351-4E9BAE1F71CE}"/>
               </a:ext>
             </a:extLst>
           </p:cNvPr>
@@ -20814,7 +20814,7 @@
           <p:cNvPr id="7" name="Oval 6">
             <a:extLst>
               <a:ext uri="{FF2B5EF4-FFF2-40B4-BE49-F238E27FC236}">
-                <a16:creationId xmlns:a16="http://schemas.microsoft.com/office/drawing/2014/main" id="{6A4B977F-5DA4-4528-B703-4526FEAAFBAD}"/>
+                <a16:creationId xmlns:a16="http://schemas.microsoft.com/office/drawing/2014/main" id="{D39EF534-FC93-4920-AA9D-4BB8801B692F}"/>
               </a:ext>
             </a:extLst>
           </p:cNvPr>
@@ -20845,7 +20845,7 @@
           <p:cNvPr id="8" name="Rectangle 7">
             <a:extLst>
               <a:ext uri="{FF2B5EF4-FFF2-40B4-BE49-F238E27FC236}">
-                <a16:creationId xmlns:a16="http://schemas.microsoft.com/office/drawing/2014/main" id="{4FE60E65-65FC-46AD-8B63-68E6B17F8392}"/>
+                <a16:creationId xmlns:a16="http://schemas.microsoft.com/office/drawing/2014/main" id="{1C4A3F9C-E7BD-4121-B7EA-EE0631C6B898}"/>
               </a:ext>
             </a:extLst>
           </p:cNvPr>
@@ -20907,7 +20907,7 @@
           <p:cNvPr id="9" name="Rectangle: Rounded Corners 8">
             <a:extLst>
               <a:ext uri="{FF2B5EF4-FFF2-40B4-BE49-F238E27FC236}">
-                <a16:creationId xmlns:a16="http://schemas.microsoft.com/office/drawing/2014/main" id="{062D26C0-8EC6-40DE-9C29-4EC712C31D10}"/>
+                <a16:creationId xmlns:a16="http://schemas.microsoft.com/office/drawing/2014/main" id="{8FA05284-C2A3-4E3E-816E-E2B547CB717D}"/>
               </a:ext>
             </a:extLst>
           </p:cNvPr>
@@ -20942,7 +20942,7 @@
           <p:cNvPr id="10" name="Rectangle 9">
             <a:extLst>
               <a:ext uri="{FF2B5EF4-FFF2-40B4-BE49-F238E27FC236}">
-                <a16:creationId xmlns:a16="http://schemas.microsoft.com/office/drawing/2014/main" id="{77B38761-09B5-4B3A-8E24-6422DD13674E}"/>
+                <a16:creationId xmlns:a16="http://schemas.microsoft.com/office/drawing/2014/main" id="{C778456B-1969-41AF-B648-73C64842D8D5}"/>
               </a:ext>
             </a:extLst>
           </p:cNvPr>
@@ -21004,7 +21004,7 @@
           <p:cNvPr id="11" name="Oval 10">
             <a:extLst>
               <a:ext uri="{FF2B5EF4-FFF2-40B4-BE49-F238E27FC236}">
-                <a16:creationId xmlns:a16="http://schemas.microsoft.com/office/drawing/2014/main" id="{DE9D4142-B4F7-4E1B-AC88-95F11CFCF9E1}"/>
+                <a16:creationId xmlns:a16="http://schemas.microsoft.com/office/drawing/2014/main" id="{1FC1ECD4-A0FB-4B53-BAF4-B2A1684DD244}"/>
               </a:ext>
             </a:extLst>
           </p:cNvPr>
@@ -21035,7 +21035,7 @@
           <p:cNvPr id="12" name="Rectangle 11">
             <a:extLst>
               <a:ext uri="{FF2B5EF4-FFF2-40B4-BE49-F238E27FC236}">
-                <a16:creationId xmlns:a16="http://schemas.microsoft.com/office/drawing/2014/main" id="{8EA733FE-70BE-4A9C-84B3-92D427CB8629}"/>
+                <a16:creationId xmlns:a16="http://schemas.microsoft.com/office/drawing/2014/main" id="{2B3E733F-0E87-4038-9BB7-44F5632E60F5}"/>
               </a:ext>
             </a:extLst>
           </p:cNvPr>
@@ -21097,7 +21097,7 @@
           <p:cNvPr id="13" name="Rectangle: Rounded Corners 12">
             <a:extLst>
               <a:ext uri="{FF2B5EF4-FFF2-40B4-BE49-F238E27FC236}">
-                <a16:creationId xmlns:a16="http://schemas.microsoft.com/office/drawing/2014/main" id="{961B3F22-871A-4942-BB03-660EAD0AB134}"/>
+                <a16:creationId xmlns:a16="http://schemas.microsoft.com/office/drawing/2014/main" id="{A973B118-87B2-482E-843B-3FFBB8019725}"/>
               </a:ext>
             </a:extLst>
           </p:cNvPr>
@@ -21132,7 +21132,7 @@
           <p:cNvPr id="14" name="Rectangle 13">
             <a:extLst>
               <a:ext uri="{FF2B5EF4-FFF2-40B4-BE49-F238E27FC236}">
-                <a16:creationId xmlns:a16="http://schemas.microsoft.com/office/drawing/2014/main" id="{F8793059-217F-4FFC-AB28-4ABC64478D54}"/>
+                <a16:creationId xmlns:a16="http://schemas.microsoft.com/office/drawing/2014/main" id="{3C3DCC72-A1F3-460D-AA47-C0F47735F006}"/>
               </a:ext>
             </a:extLst>
           </p:cNvPr>
@@ -21184,7 +21184,7 @@
                 <a:ea typeface="Arial"/>
                 <a:cs typeface="Arial"/>
               </a:rPr>
-              <a:t>Three structural groups</a:t>
+              <a:t>Three overlapping groups</a:t>
             </a:r>
           </a:p>
         </p:txBody>
@@ -21194,7 +21194,7 @@
           <p:cNvPr id="15" name="Oval 14">
             <a:extLst>
               <a:ext uri="{FF2B5EF4-FFF2-40B4-BE49-F238E27FC236}">
-                <a16:creationId xmlns:a16="http://schemas.microsoft.com/office/drawing/2014/main" id="{8E5AE53B-83D2-471B-B8A9-F9063CDEEF9F}"/>
+                <a16:creationId xmlns:a16="http://schemas.microsoft.com/office/drawing/2014/main" id="{FE49B032-EC1B-4345-8725-A3FEBD1571D0}"/>
               </a:ext>
             </a:extLst>
           </p:cNvPr>
@@ -21225,7 +21225,7 @@
           <p:cNvPr id="16" name="Rectangle 15">
             <a:extLst>
               <a:ext uri="{FF2B5EF4-FFF2-40B4-BE49-F238E27FC236}">
-                <a16:creationId xmlns:a16="http://schemas.microsoft.com/office/drawing/2014/main" id="{AEB5E61F-647E-4244-BCA0-6292551F224C}"/>
+                <a16:creationId xmlns:a16="http://schemas.microsoft.com/office/drawing/2014/main" id="{2E6D6504-8C38-440D-A6C4-25BA11D4A69C}"/>
               </a:ext>
             </a:extLst>
           </p:cNvPr>
@@ -21287,7 +21287,7 @@
           <p:cNvPr id="17" name="Rectangle: Rounded Corners 16">
             <a:extLst>
               <a:ext uri="{FF2B5EF4-FFF2-40B4-BE49-F238E27FC236}">
-                <a16:creationId xmlns:a16="http://schemas.microsoft.com/office/drawing/2014/main" id="{439AB6EE-4B11-47BF-B247-601FF47ED959}"/>
+                <a16:creationId xmlns:a16="http://schemas.microsoft.com/office/drawing/2014/main" id="{DE9CEB84-BEA0-4103-9871-F463E37605C1}"/>
               </a:ext>
             </a:extLst>
           </p:cNvPr>
@@ -21322,7 +21322,7 @@
           <p:cNvPr id="18" name="Rectangle 17">
             <a:extLst>
               <a:ext uri="{FF2B5EF4-FFF2-40B4-BE49-F238E27FC236}">
-                <a16:creationId xmlns:a16="http://schemas.microsoft.com/office/drawing/2014/main" id="{27513FD7-5329-40A0-ADDF-484CCA24219A}"/>
+                <a16:creationId xmlns:a16="http://schemas.microsoft.com/office/drawing/2014/main" id="{C4EBB6E0-C65C-4E1F-8567-2BE03DDC9BE4}"/>
               </a:ext>
             </a:extLst>
           </p:cNvPr>
@@ -21384,7 +21384,7 @@
           <p:cNvPr id="19" name="Rectangle 18">
             <a:extLst>
               <a:ext uri="{FF2B5EF4-FFF2-40B4-BE49-F238E27FC236}">
-                <a16:creationId xmlns:a16="http://schemas.microsoft.com/office/drawing/2014/main" id="{D066709A-04C7-42E9-BFF9-FAC5D4E9F3C7}"/>
+                <a16:creationId xmlns:a16="http://schemas.microsoft.com/office/drawing/2014/main" id="{2691AF2D-621A-47BF-BDD0-DA092770BE5D}"/>
               </a:ext>
             </a:extLst>
           </p:cNvPr>
@@ -21415,7 +21415,7 @@
           <p:cNvPr id="20" name="Rectangle 19">
             <a:extLst>
               <a:ext uri="{FF2B5EF4-FFF2-40B4-BE49-F238E27FC236}">
-                <a16:creationId xmlns:a16="http://schemas.microsoft.com/office/drawing/2014/main" id="{880CE458-C6CF-4054-9471-298459FC367B}"/>
+                <a16:creationId xmlns:a16="http://schemas.microsoft.com/office/drawing/2014/main" id="{850FC014-896E-4108-924B-1A1B2916C8EB}"/>
               </a:ext>
             </a:extLst>
           </p:cNvPr>
@@ -21477,7 +21477,7 @@
           <p:cNvPr id="21" name="Rectangle 20">
             <a:extLst>
               <a:ext uri="{FF2B5EF4-FFF2-40B4-BE49-F238E27FC236}">
-                <a16:creationId xmlns:a16="http://schemas.microsoft.com/office/drawing/2014/main" id="{E265EC5A-37E0-4598-B7E5-5FD2AC062D40}"/>
+                <a16:creationId xmlns:a16="http://schemas.microsoft.com/office/drawing/2014/main" id="{1860FC59-66E3-4F08-B8A5-8F62BB4F6467}"/>
               </a:ext>
             </a:extLst>
           </p:cNvPr>
@@ -21537,7 +21537,7 @@
     </p:spTree>
     <p:extLst>
       <p:ext uri="{BB962C8B-B14F-4D97-AF65-F5344CB8AC3E}">
-        <p14:creationId xmlns:p14="http://schemas.microsoft.com/office/powerpoint/2010/main" val="779545863"/>
+        <p14:creationId xmlns:p14="http://schemas.microsoft.com/office/powerpoint/2010/main" val="716377381"/>
       </p:ext>
     </p:extLst>
   </p:cSld>
@@ -21578,7 +21578,7 @@
             <a:hlinkClick r:id="rId3"/>
             <a:extLst>
               <a:ext uri="{FF2B5EF4-FFF2-40B4-BE49-F238E27FC236}">
-                <a16:creationId xmlns:a16="http://schemas.microsoft.com/office/drawing/2014/main" id="{34471A89-45C8-47C7-85DD-477025CF0616}"/>
+                <a16:creationId xmlns:a16="http://schemas.microsoft.com/office/drawing/2014/main" id="{1AF6978E-4A73-4A89-B03D-B612477D5712}"/>
               </a:ext>
             </a:extLst>
           </p:cNvPr>
@@ -21653,7 +21653,7 @@
             <a:hlinkClick r:id="rId4"/>
             <a:extLst>
               <a:ext uri="{FF2B5EF4-FFF2-40B4-BE49-F238E27FC236}">
-                <a16:creationId xmlns:a16="http://schemas.microsoft.com/office/drawing/2014/main" id="{18BAD484-ECC4-4D9B-B4FD-42162B93211D}"/>
+                <a16:creationId xmlns:a16="http://schemas.microsoft.com/office/drawing/2014/main" id="{F54D3A77-9AFF-497F-A0A1-357CE2AD5C90}"/>
               </a:ext>
             </a:extLst>
           </p:cNvPr>
@@ -21727,7 +21727,7 @@
           <p:cNvPr id="3" name="Rectangle 2">
             <a:extLst>
               <a:ext uri="{FF2B5EF4-FFF2-40B4-BE49-F238E27FC236}">
-                <a16:creationId xmlns:a16="http://schemas.microsoft.com/office/drawing/2014/main" id="{3010D3BD-F7D6-4A1A-8022-CD8681E91F2C}"/>
+                <a16:creationId xmlns:a16="http://schemas.microsoft.com/office/drawing/2014/main" id="{F371AEEB-9A9B-4163-A218-6AD4BF3C920D}"/>
               </a:ext>
             </a:extLst>
           </p:cNvPr>
@@ -21789,7 +21789,7 @@
           <p:cNvPr id="4" name="Rectangle 3">
             <a:extLst>
               <a:ext uri="{FF2B5EF4-FFF2-40B4-BE49-F238E27FC236}">
-                <a16:creationId xmlns:a16="http://schemas.microsoft.com/office/drawing/2014/main" id="{5FBC1F33-61D2-4DC4-99E6-A83594179948}"/>
+                <a16:creationId xmlns:a16="http://schemas.microsoft.com/office/drawing/2014/main" id="{A3AFDF05-54EA-4A7F-B64F-3A417B0277B6}"/>
               </a:ext>
             </a:extLst>
           </p:cNvPr>
@@ -21841,7 +21841,7 @@
                 <a:ea typeface="Arial"/>
                 <a:cs typeface="Arial"/>
               </a:rPr>
-              <a:t>Lead with the base climate case; keep the bounded risk beside it.</a:t>
+              <a:t>Lead with the base climate case; keep the scenario range beside it.</a:t>
             </a:r>
           </a:p>
         </p:txBody>
@@ -21856,7 +21856,7 @@
         </p:nvPicPr>
         <p:blipFill>
           <a:blip r:embed="rId5"/>
-          <a:srcRect t="27645" b="27645"/>
+          <a:srcRect t="32420" b="32420"/>
           <a:stretch>
             <a:fillRect/>
           </a:stretch>
@@ -21878,7 +21878,7 @@
           <p:cNvPr id="6" name="Rectangle: Rounded Corners 5">
             <a:extLst>
               <a:ext uri="{FF2B5EF4-FFF2-40B4-BE49-F238E27FC236}">
-                <a16:creationId xmlns:a16="http://schemas.microsoft.com/office/drawing/2014/main" id="{699AAEE0-92CF-4B74-A1CF-B0F3105064A0}"/>
+                <a16:creationId xmlns:a16="http://schemas.microsoft.com/office/drawing/2014/main" id="{157DEE80-CCAE-422E-B087-88E6076C1529}"/>
               </a:ext>
             </a:extLst>
           </p:cNvPr>
@@ -21911,7 +21911,7 @@
           <p:cNvPr id="7" name="Oval 6">
             <a:extLst>
               <a:ext uri="{FF2B5EF4-FFF2-40B4-BE49-F238E27FC236}">
-                <a16:creationId xmlns:a16="http://schemas.microsoft.com/office/drawing/2014/main" id="{9CCB10D8-B6DB-4526-AED9-0404E0DA31F0}"/>
+                <a16:creationId xmlns:a16="http://schemas.microsoft.com/office/drawing/2014/main" id="{77F95A9C-3369-43AE-8D27-4608382D8E56}"/>
               </a:ext>
             </a:extLst>
           </p:cNvPr>
@@ -21942,7 +21942,7 @@
           <p:cNvPr id="8" name="Rectangle 7">
             <a:extLst>
               <a:ext uri="{FF2B5EF4-FFF2-40B4-BE49-F238E27FC236}">
-                <a16:creationId xmlns:a16="http://schemas.microsoft.com/office/drawing/2014/main" id="{72F67C1B-C972-40A6-9C4E-9EA075D20D85}"/>
+                <a16:creationId xmlns:a16="http://schemas.microsoft.com/office/drawing/2014/main" id="{2C61B3F8-D02A-4472-BD22-EF8547FC9437}"/>
               </a:ext>
             </a:extLst>
           </p:cNvPr>
@@ -22004,7 +22004,7 @@
           <p:cNvPr id="9" name="Rectangle: Rounded Corners 8">
             <a:extLst>
               <a:ext uri="{FF2B5EF4-FFF2-40B4-BE49-F238E27FC236}">
-                <a16:creationId xmlns:a16="http://schemas.microsoft.com/office/drawing/2014/main" id="{99B580D2-594C-4655-B1A8-686784BFE811}"/>
+                <a16:creationId xmlns:a16="http://schemas.microsoft.com/office/drawing/2014/main" id="{D45E4EE4-8BE6-4538-B041-5B05DB3CFADD}"/>
               </a:ext>
             </a:extLst>
           </p:cNvPr>
@@ -22039,7 +22039,7 @@
           <p:cNvPr id="10" name="Rectangle 9">
             <a:extLst>
               <a:ext uri="{FF2B5EF4-FFF2-40B4-BE49-F238E27FC236}">
-                <a16:creationId xmlns:a16="http://schemas.microsoft.com/office/drawing/2014/main" id="{24EEFAE2-B066-41A8-9C98-3AFFA88559E1}"/>
+                <a16:creationId xmlns:a16="http://schemas.microsoft.com/office/drawing/2014/main" id="{9F51FBB9-CB10-4A60-9422-26C8A5EA7CF4}"/>
               </a:ext>
             </a:extLst>
           </p:cNvPr>
@@ -22101,7 +22101,7 @@
           <p:cNvPr id="11" name="Oval 10">
             <a:extLst>
               <a:ext uri="{FF2B5EF4-FFF2-40B4-BE49-F238E27FC236}">
-                <a16:creationId xmlns:a16="http://schemas.microsoft.com/office/drawing/2014/main" id="{D750C6B9-574D-405D-9225-BF430C995F92}"/>
+                <a16:creationId xmlns:a16="http://schemas.microsoft.com/office/drawing/2014/main" id="{C0F4C74F-AB50-4662-8EF8-7658A80BB821}"/>
               </a:ext>
             </a:extLst>
           </p:cNvPr>
@@ -22132,7 +22132,7 @@
           <p:cNvPr id="12" name="Rectangle 11">
             <a:extLst>
               <a:ext uri="{FF2B5EF4-FFF2-40B4-BE49-F238E27FC236}">
-                <a16:creationId xmlns:a16="http://schemas.microsoft.com/office/drawing/2014/main" id="{B3E94AA8-8A73-4EC0-A2CD-476ECC0EB2B0}"/>
+                <a16:creationId xmlns:a16="http://schemas.microsoft.com/office/drawing/2014/main" id="{E742F82D-4855-4B4F-9691-6E1802BBE97F}"/>
               </a:ext>
             </a:extLst>
           </p:cNvPr>
@@ -22194,7 +22194,7 @@
           <p:cNvPr id="13" name="Rectangle: Rounded Corners 12">
             <a:extLst>
               <a:ext uri="{FF2B5EF4-FFF2-40B4-BE49-F238E27FC236}">
-                <a16:creationId xmlns:a16="http://schemas.microsoft.com/office/drawing/2014/main" id="{537C1B9C-D37A-47B1-9EF6-159D026A98EE}"/>
+                <a16:creationId xmlns:a16="http://schemas.microsoft.com/office/drawing/2014/main" id="{9B0E7E5A-B65F-4E23-B397-C26C0A8C2DAB}"/>
               </a:ext>
             </a:extLst>
           </p:cNvPr>
@@ -22229,7 +22229,7 @@
           <p:cNvPr id="14" name="Rectangle 13">
             <a:extLst>
               <a:ext uri="{FF2B5EF4-FFF2-40B4-BE49-F238E27FC236}">
-                <a16:creationId xmlns:a16="http://schemas.microsoft.com/office/drawing/2014/main" id="{EEAFFA69-5731-4563-8FF6-D6C80E7CB754}"/>
+                <a16:creationId xmlns:a16="http://schemas.microsoft.com/office/drawing/2014/main" id="{468ADB86-39CB-4A7F-A30E-C12AAD8C0C1A}"/>
               </a:ext>
             </a:extLst>
           </p:cNvPr>
@@ -22281,7 +22281,7 @@
                 <a:ea typeface="Arial"/>
                 <a:cs typeface="Arial"/>
               </a:rPr>
-              <a:t>Low–high shown beside it</a:t>
+              <a:t>Scenario range · not a CI</a:t>
             </a:r>
           </a:p>
         </p:txBody>
@@ -22291,7 +22291,7 @@
           <p:cNvPr id="15" name="Oval 14">
             <a:extLst>
               <a:ext uri="{FF2B5EF4-FFF2-40B4-BE49-F238E27FC236}">
-                <a16:creationId xmlns:a16="http://schemas.microsoft.com/office/drawing/2014/main" id="{E4AABF11-7FDE-42C5-99DA-A03D167F2D61}"/>
+                <a16:creationId xmlns:a16="http://schemas.microsoft.com/office/drawing/2014/main" id="{5B0D082F-4C87-44A1-896B-51F00B0C93FB}"/>
               </a:ext>
             </a:extLst>
           </p:cNvPr>
@@ -22322,7 +22322,7 @@
           <p:cNvPr id="16" name="Rectangle 15">
             <a:extLst>
               <a:ext uri="{FF2B5EF4-FFF2-40B4-BE49-F238E27FC236}">
-                <a16:creationId xmlns:a16="http://schemas.microsoft.com/office/drawing/2014/main" id="{36FA854E-B548-4ADE-A0A1-8899580AD639}"/>
+                <a16:creationId xmlns:a16="http://schemas.microsoft.com/office/drawing/2014/main" id="{F1AEBF66-687F-46EB-A619-8715CF5E9FF7}"/>
               </a:ext>
             </a:extLst>
           </p:cNvPr>
@@ -22384,7 +22384,7 @@
           <p:cNvPr id="17" name="Rectangle: Rounded Corners 16">
             <a:extLst>
               <a:ext uri="{FF2B5EF4-FFF2-40B4-BE49-F238E27FC236}">
-                <a16:creationId xmlns:a16="http://schemas.microsoft.com/office/drawing/2014/main" id="{03BC8E2F-BF36-48A1-9522-8373FB3A57BA}"/>
+                <a16:creationId xmlns:a16="http://schemas.microsoft.com/office/drawing/2014/main" id="{07E7D4A4-BDB8-44C8-926F-2D06A8E9EB61}"/>
               </a:ext>
             </a:extLst>
           </p:cNvPr>
@@ -22419,7 +22419,7 @@
           <p:cNvPr id="18" name="Rectangle 17">
             <a:extLst>
               <a:ext uri="{FF2B5EF4-FFF2-40B4-BE49-F238E27FC236}">
-                <a16:creationId xmlns:a16="http://schemas.microsoft.com/office/drawing/2014/main" id="{CD13365B-CDB7-4F1A-80CF-E2A05687D143}"/>
+                <a16:creationId xmlns:a16="http://schemas.microsoft.com/office/drawing/2014/main" id="{4A96214C-CDCA-4DC0-8E22-D3205F226420}"/>
               </a:ext>
             </a:extLst>
           </p:cNvPr>
@@ -22481,7 +22481,7 @@
           <p:cNvPr id="19" name="Rectangle 18">
             <a:extLst>
               <a:ext uri="{FF2B5EF4-FFF2-40B4-BE49-F238E27FC236}">
-                <a16:creationId xmlns:a16="http://schemas.microsoft.com/office/drawing/2014/main" id="{CE15A9F7-F91B-4C94-9C15-B6C0A281E0B2}"/>
+                <a16:creationId xmlns:a16="http://schemas.microsoft.com/office/drawing/2014/main" id="{FEB963F5-3C80-49CD-82B0-3E0D3E7661B0}"/>
               </a:ext>
             </a:extLst>
           </p:cNvPr>
@@ -22512,7 +22512,7 @@
           <p:cNvPr id="20" name="Rectangle 19">
             <a:extLst>
               <a:ext uri="{FF2B5EF4-FFF2-40B4-BE49-F238E27FC236}">
-                <a16:creationId xmlns:a16="http://schemas.microsoft.com/office/drawing/2014/main" id="{164DCC1F-9E2C-4D29-B695-E84C06647132}"/>
+                <a16:creationId xmlns:a16="http://schemas.microsoft.com/office/drawing/2014/main" id="{5B513227-A2C5-4496-8AD8-F5936ED7978E}"/>
               </a:ext>
             </a:extLst>
           </p:cNvPr>
@@ -22574,7 +22574,7 @@
           <p:cNvPr id="21" name="Rectangle 20">
             <a:extLst>
               <a:ext uri="{FF2B5EF4-FFF2-40B4-BE49-F238E27FC236}">
-                <a16:creationId xmlns:a16="http://schemas.microsoft.com/office/drawing/2014/main" id="{49639FC4-8BFE-4E97-8721-00A7EA2C3F0F}"/>
+                <a16:creationId xmlns:a16="http://schemas.microsoft.com/office/drawing/2014/main" id="{5BE63AE3-5313-462A-A17A-AF8480C87417}"/>
               </a:ext>
             </a:extLst>
           </p:cNvPr>
@@ -22634,7 +22634,7 @@
     </p:spTree>
     <p:extLst>
       <p:ext uri="{BB962C8B-B14F-4D97-AF65-F5344CB8AC3E}">
-        <p14:creationId xmlns:p14="http://schemas.microsoft.com/office/powerpoint/2010/main" val="47099653"/>
+        <p14:creationId xmlns:p14="http://schemas.microsoft.com/office/powerpoint/2010/main" val="1666022479"/>
       </p:ext>
     </p:extLst>
   </p:cSld>
@@ -22675,7 +22675,7 @@
             <a:hlinkClick r:id="rId3"/>
             <a:extLst>
               <a:ext uri="{FF2B5EF4-FFF2-40B4-BE49-F238E27FC236}">
-                <a16:creationId xmlns:a16="http://schemas.microsoft.com/office/drawing/2014/main" id="{5FF352F6-14D0-41A2-B51A-D8660DC06159}"/>
+                <a16:creationId xmlns:a16="http://schemas.microsoft.com/office/drawing/2014/main" id="{F827D46E-F855-4EEC-A20F-83145288E005}"/>
               </a:ext>
             </a:extLst>
           </p:cNvPr>
@@ -22750,7 +22750,7 @@
             <a:hlinkClick r:id="rId4"/>
             <a:extLst>
               <a:ext uri="{FF2B5EF4-FFF2-40B4-BE49-F238E27FC236}">
-                <a16:creationId xmlns:a16="http://schemas.microsoft.com/office/drawing/2014/main" id="{5B68588A-31CB-4EC4-94F1-1484EFEE049D}"/>
+                <a16:creationId xmlns:a16="http://schemas.microsoft.com/office/drawing/2014/main" id="{8BA47BD5-C76A-4881-A93C-702F22CC455F}"/>
               </a:ext>
             </a:extLst>
           </p:cNvPr>
@@ -22824,7 +22824,7 @@
           <p:cNvPr id="3" name="Rectangle 2">
             <a:extLst>
               <a:ext uri="{FF2B5EF4-FFF2-40B4-BE49-F238E27FC236}">
-                <a16:creationId xmlns:a16="http://schemas.microsoft.com/office/drawing/2014/main" id="{0A0039B8-A24B-4D58-BEC8-4544279B6886}"/>
+                <a16:creationId xmlns:a16="http://schemas.microsoft.com/office/drawing/2014/main" id="{7FF1E5C2-C0DF-4EE4-B784-29808BD0663F}"/>
               </a:ext>
             </a:extLst>
           </p:cNvPr>
@@ -22886,7 +22886,7 @@
           <p:cNvPr id="4" name="Rectangle 3">
             <a:extLst>
               <a:ext uri="{FF2B5EF4-FFF2-40B4-BE49-F238E27FC236}">
-                <a16:creationId xmlns:a16="http://schemas.microsoft.com/office/drawing/2014/main" id="{DE02AD0C-E212-4E06-98E3-F393544293F7}"/>
+                <a16:creationId xmlns:a16="http://schemas.microsoft.com/office/drawing/2014/main" id="{953CF906-AE09-4848-BE26-E2C3FB4441D6}"/>
               </a:ext>
             </a:extLst>
           </p:cNvPr>
@@ -22975,7 +22975,7 @@
           <p:cNvPr id="6" name="Rectangle: Rounded Corners 5">
             <a:extLst>
               <a:ext uri="{FF2B5EF4-FFF2-40B4-BE49-F238E27FC236}">
-                <a16:creationId xmlns:a16="http://schemas.microsoft.com/office/drawing/2014/main" id="{A2705EC5-85AE-45D2-88CC-0E2DC9C17588}"/>
+                <a16:creationId xmlns:a16="http://schemas.microsoft.com/office/drawing/2014/main" id="{B5BA5571-1E23-41FF-B819-28095378DFF6}"/>
               </a:ext>
             </a:extLst>
           </p:cNvPr>
@@ -23008,7 +23008,7 @@
           <p:cNvPr id="7" name="Oval 6">
             <a:extLst>
               <a:ext uri="{FF2B5EF4-FFF2-40B4-BE49-F238E27FC236}">
-                <a16:creationId xmlns:a16="http://schemas.microsoft.com/office/drawing/2014/main" id="{9AD6A40A-9B94-4F63-887C-7A84E584B13D}"/>
+                <a16:creationId xmlns:a16="http://schemas.microsoft.com/office/drawing/2014/main" id="{2C03573E-22BD-4778-9D06-2BA9DFD06BD4}"/>
               </a:ext>
             </a:extLst>
           </p:cNvPr>
@@ -23039,7 +23039,7 @@
           <p:cNvPr id="8" name="Rectangle 7">
             <a:extLst>
               <a:ext uri="{FF2B5EF4-FFF2-40B4-BE49-F238E27FC236}">
-                <a16:creationId xmlns:a16="http://schemas.microsoft.com/office/drawing/2014/main" id="{5E0E73F1-4EAA-4EAE-83E9-43F1FDCF50B3}"/>
+                <a16:creationId xmlns:a16="http://schemas.microsoft.com/office/drawing/2014/main" id="{440F1CA0-3E51-4C30-9FE1-5D8F009BC435}"/>
               </a:ext>
             </a:extLst>
           </p:cNvPr>
@@ -23101,7 +23101,7 @@
           <p:cNvPr id="9" name="Rectangle: Rounded Corners 8">
             <a:extLst>
               <a:ext uri="{FF2B5EF4-FFF2-40B4-BE49-F238E27FC236}">
-                <a16:creationId xmlns:a16="http://schemas.microsoft.com/office/drawing/2014/main" id="{7233F9C9-790B-40D1-91A5-6A5A952D526B}"/>
+                <a16:creationId xmlns:a16="http://schemas.microsoft.com/office/drawing/2014/main" id="{4D16B551-6230-4521-9129-49CEC6B59C1F}"/>
               </a:ext>
             </a:extLst>
           </p:cNvPr>
@@ -23136,7 +23136,7 @@
           <p:cNvPr id="10" name="Rectangle 9">
             <a:extLst>
               <a:ext uri="{FF2B5EF4-FFF2-40B4-BE49-F238E27FC236}">
-                <a16:creationId xmlns:a16="http://schemas.microsoft.com/office/drawing/2014/main" id="{FC00F02D-42A3-4A07-BDC7-B52EA262E991}"/>
+                <a16:creationId xmlns:a16="http://schemas.microsoft.com/office/drawing/2014/main" id="{AB8110F9-1ED4-46DF-9D5C-B2DF0BC6FA03}"/>
               </a:ext>
             </a:extLst>
           </p:cNvPr>
@@ -23198,7 +23198,7 @@
           <p:cNvPr id="11" name="Oval 10">
             <a:extLst>
               <a:ext uri="{FF2B5EF4-FFF2-40B4-BE49-F238E27FC236}">
-                <a16:creationId xmlns:a16="http://schemas.microsoft.com/office/drawing/2014/main" id="{FED5E43E-E266-4846-88F6-E21B34236C0B}"/>
+                <a16:creationId xmlns:a16="http://schemas.microsoft.com/office/drawing/2014/main" id="{619BF66F-7362-4B46-9824-C3A52CCC7AC9}"/>
               </a:ext>
             </a:extLst>
           </p:cNvPr>
@@ -23229,7 +23229,7 @@
           <p:cNvPr id="12" name="Rectangle 11">
             <a:extLst>
               <a:ext uri="{FF2B5EF4-FFF2-40B4-BE49-F238E27FC236}">
-                <a16:creationId xmlns:a16="http://schemas.microsoft.com/office/drawing/2014/main" id="{A080DA39-61C6-4C88-A501-DEC2A3D230BB}"/>
+                <a16:creationId xmlns:a16="http://schemas.microsoft.com/office/drawing/2014/main" id="{63AE1C60-8A5F-4242-A696-7E74A6E3F686}"/>
               </a:ext>
             </a:extLst>
           </p:cNvPr>
@@ -23291,7 +23291,7 @@
           <p:cNvPr id="13" name="Rectangle: Rounded Corners 12">
             <a:extLst>
               <a:ext uri="{FF2B5EF4-FFF2-40B4-BE49-F238E27FC236}">
-                <a16:creationId xmlns:a16="http://schemas.microsoft.com/office/drawing/2014/main" id="{9A0B81D4-175A-4A08-8A9C-118040D95822}"/>
+                <a16:creationId xmlns:a16="http://schemas.microsoft.com/office/drawing/2014/main" id="{AC60F3FF-F4B6-448F-8B93-62121E56EBFC}"/>
               </a:ext>
             </a:extLst>
           </p:cNvPr>
@@ -23326,7 +23326,7 @@
           <p:cNvPr id="14" name="Rectangle 13">
             <a:extLst>
               <a:ext uri="{FF2B5EF4-FFF2-40B4-BE49-F238E27FC236}">
-                <a16:creationId xmlns:a16="http://schemas.microsoft.com/office/drawing/2014/main" id="{4D21ACB1-41B0-452E-8E8D-910736D1FAA5}"/>
+                <a16:creationId xmlns:a16="http://schemas.microsoft.com/office/drawing/2014/main" id="{C5EEF6E0-C353-4F2A-BC4F-F8ED8EFAF7D2}"/>
               </a:ext>
             </a:extLst>
           </p:cNvPr>
@@ -23388,7 +23388,7 @@
           <p:cNvPr id="15" name="Oval 14">
             <a:extLst>
               <a:ext uri="{FF2B5EF4-FFF2-40B4-BE49-F238E27FC236}">
-                <a16:creationId xmlns:a16="http://schemas.microsoft.com/office/drawing/2014/main" id="{D1652C45-ECCC-460A-8396-2FBDAAE1B5B0}"/>
+                <a16:creationId xmlns:a16="http://schemas.microsoft.com/office/drawing/2014/main" id="{ADDB816E-A5C0-4858-9CDA-E31E54F234CE}"/>
               </a:ext>
             </a:extLst>
           </p:cNvPr>
@@ -23419,7 +23419,7 @@
           <p:cNvPr id="16" name="Rectangle 15">
             <a:extLst>
               <a:ext uri="{FF2B5EF4-FFF2-40B4-BE49-F238E27FC236}">
-                <a16:creationId xmlns:a16="http://schemas.microsoft.com/office/drawing/2014/main" id="{E3DEC9E4-27D6-4B36-8054-B1247FC57506}"/>
+                <a16:creationId xmlns:a16="http://schemas.microsoft.com/office/drawing/2014/main" id="{31E012FC-3D32-4AB9-952A-1EF16FAAF84A}"/>
               </a:ext>
             </a:extLst>
           </p:cNvPr>
@@ -23481,7 +23481,7 @@
           <p:cNvPr id="17" name="Rectangle: Rounded Corners 16">
             <a:extLst>
               <a:ext uri="{FF2B5EF4-FFF2-40B4-BE49-F238E27FC236}">
-                <a16:creationId xmlns:a16="http://schemas.microsoft.com/office/drawing/2014/main" id="{C7F60163-1ACB-4064-8DF4-E71697A6D25B}"/>
+                <a16:creationId xmlns:a16="http://schemas.microsoft.com/office/drawing/2014/main" id="{61C82E3C-56E3-4348-A719-4DE0E212759F}"/>
               </a:ext>
             </a:extLst>
           </p:cNvPr>
@@ -23516,7 +23516,7 @@
           <p:cNvPr id="18" name="Rectangle 17">
             <a:extLst>
               <a:ext uri="{FF2B5EF4-FFF2-40B4-BE49-F238E27FC236}">
-                <a16:creationId xmlns:a16="http://schemas.microsoft.com/office/drawing/2014/main" id="{B00A4D55-C33D-4B15-BFB2-704F9F7F4E33}"/>
+                <a16:creationId xmlns:a16="http://schemas.microsoft.com/office/drawing/2014/main" id="{F7F2831C-D3B9-4478-B70E-86CC6A5D5120}"/>
               </a:ext>
             </a:extLst>
           </p:cNvPr>
@@ -23578,7 +23578,7 @@
           <p:cNvPr id="19" name="Rectangle 18">
             <a:extLst>
               <a:ext uri="{FF2B5EF4-FFF2-40B4-BE49-F238E27FC236}">
-                <a16:creationId xmlns:a16="http://schemas.microsoft.com/office/drawing/2014/main" id="{DFF5CF71-6B97-4E92-8F51-CFA10780421E}"/>
+                <a16:creationId xmlns:a16="http://schemas.microsoft.com/office/drawing/2014/main" id="{7018A92E-4C82-4D21-A0AE-DD37B6580BAC}"/>
               </a:ext>
             </a:extLst>
           </p:cNvPr>
@@ -23609,7 +23609,7 @@
           <p:cNvPr id="20" name="Rectangle 19">
             <a:extLst>
               <a:ext uri="{FF2B5EF4-FFF2-40B4-BE49-F238E27FC236}">
-                <a16:creationId xmlns:a16="http://schemas.microsoft.com/office/drawing/2014/main" id="{AB3E6552-118B-4514-815E-2E085F347686}"/>
+                <a16:creationId xmlns:a16="http://schemas.microsoft.com/office/drawing/2014/main" id="{AA387BC5-737B-45E1-93A2-B0EC3395B332}"/>
               </a:ext>
             </a:extLst>
           </p:cNvPr>
@@ -23671,7 +23671,7 @@
           <p:cNvPr id="21" name="Rectangle 20">
             <a:extLst>
               <a:ext uri="{FF2B5EF4-FFF2-40B4-BE49-F238E27FC236}">
-                <a16:creationId xmlns:a16="http://schemas.microsoft.com/office/drawing/2014/main" id="{BCBAD78D-745D-4154-8C9F-0E5C7FFD935E}"/>
+                <a16:creationId xmlns:a16="http://schemas.microsoft.com/office/drawing/2014/main" id="{ADA69D37-F1F9-494C-A70C-B87BB87F0B71}"/>
               </a:ext>
             </a:extLst>
           </p:cNvPr>
@@ -23731,7 +23731,7 @@
     </p:spTree>
     <p:extLst>
       <p:ext uri="{BB962C8B-B14F-4D97-AF65-F5344CB8AC3E}">
-        <p14:creationId xmlns:p14="http://schemas.microsoft.com/office/powerpoint/2010/main" val="282154360"/>
+        <p14:creationId xmlns:p14="http://schemas.microsoft.com/office/powerpoint/2010/main" val="559458769"/>
       </p:ext>
     </p:extLst>
   </p:cSld>

</xml_diff>

<commit_message>
Rebuild corrected release and submission artifacts
</commit_message>
<xml_diff>
--- a/output/submission/Route2Zero_Prototype_Demonstration.pptx
+++ b/output/submission/Route2Zero_Prototype_Demonstration.pptx
@@ -164,7 +164,7 @@
             </c:spPr>
             <c:extLst>
               <c:ext xmlns:c16="http://schemas.microsoft.com/office/drawing/2014/chart" uri="{C3380CC4-5D6E-409C-BE32-E72D297353CC}">
-                <c16:uniqueId val="{00000001-03E8-4525-BD97-366997560345}"/>
+                <c16:uniqueId val="{00000001-7F49-43CF-8577-A32469015294}"/>
               </c:ext>
             </c:extLst>
           </c:dPt>
@@ -238,7 +238,7 @@
               </c14:invertSolidFillFmt>
             </c:ext>
             <c:ext xmlns:c16="http://schemas.microsoft.com/office/drawing/2014/chart" uri="{C3380CC4-5D6E-409C-BE32-E72D297353CC}">
-              <c16:uniqueId val="{00000002-03E8-4525-BD97-366997560345}"/>
+              <c16:uniqueId val="{00000002-7F49-43CF-8577-A32469015294}"/>
             </c:ext>
           </c:extLst>
         </c:ser>
@@ -1197,7 +1197,7 @@
           <a:lstStyle/>
           <a:p>
             <a:r>
-              <a:t>The optimizer changes four routes while selecting one route direction per normalized corridor.</a:t>
+              <a:t>The deterministic selector changes four routes while selecting one route direction per normalized corridor.</a:t>
             </a:r>
           </a:p>
           <a:p>
@@ -2493,7 +2493,7 @@
             <a:hlinkClick r:id="rId3"/>
             <a:extLst>
               <a:ext uri="{FF2B5EF4-FFF2-40B4-BE49-F238E27FC236}">
-                <a16:creationId xmlns:a16="http://schemas.microsoft.com/office/drawing/2014/main" id="{F5DE8121-0CCD-41A2-B4EB-F0EBA720F342}"/>
+                <a16:creationId xmlns:a16="http://schemas.microsoft.com/office/drawing/2014/main" id="{F0E1D0C4-4183-4EC0-B3F7-B5ECD437B985}"/>
               </a:ext>
             </a:extLst>
           </p:cNvPr>
@@ -2568,7 +2568,7 @@
             <a:hlinkClick r:id="rId4"/>
             <a:extLst>
               <a:ext uri="{FF2B5EF4-FFF2-40B4-BE49-F238E27FC236}">
-                <a16:creationId xmlns:a16="http://schemas.microsoft.com/office/drawing/2014/main" id="{B162E345-F350-4F02-9222-03213E6581A9}"/>
+                <a16:creationId xmlns:a16="http://schemas.microsoft.com/office/drawing/2014/main" id="{2FF8AB2D-3023-418C-92AE-DD2B4708CFF4}"/>
               </a:ext>
             </a:extLst>
           </p:cNvPr>
@@ -2667,7 +2667,7 @@
           <p:cNvPr id="4" name="Rectangle 3">
             <a:extLst>
               <a:ext uri="{FF2B5EF4-FFF2-40B4-BE49-F238E27FC236}">
-                <a16:creationId xmlns:a16="http://schemas.microsoft.com/office/drawing/2014/main" id="{17203677-BC37-413E-BC92-DC107A0BADB6}"/>
+                <a16:creationId xmlns:a16="http://schemas.microsoft.com/office/drawing/2014/main" id="{18D76A5E-478B-4BDB-9AC3-53C6C785BA4E}"/>
               </a:ext>
             </a:extLst>
           </p:cNvPr>
@@ -2713,7 +2713,7 @@
           <p:cNvPr id="5" name="Rectangle 4">
             <a:extLst>
               <a:ext uri="{FF2B5EF4-FFF2-40B4-BE49-F238E27FC236}">
-                <a16:creationId xmlns:a16="http://schemas.microsoft.com/office/drawing/2014/main" id="{869EEC55-5B81-4765-B109-FC01755196E1}"/>
+                <a16:creationId xmlns:a16="http://schemas.microsoft.com/office/drawing/2014/main" id="{5B60D913-3039-4348-A644-D171F3658173}"/>
               </a:ext>
             </a:extLst>
           </p:cNvPr>
@@ -2775,7 +2775,7 @@
           <p:cNvPr id="6" name="Rectangle 5">
             <a:extLst>
               <a:ext uri="{FF2B5EF4-FFF2-40B4-BE49-F238E27FC236}">
-                <a16:creationId xmlns:a16="http://schemas.microsoft.com/office/drawing/2014/main" id="{7B25C864-1E2C-4C8E-8EAF-B7A219E118E7}"/>
+                <a16:creationId xmlns:a16="http://schemas.microsoft.com/office/drawing/2014/main" id="{3EC2E27C-0ABD-4701-A03B-889611F5515C}"/>
               </a:ext>
             </a:extLst>
           </p:cNvPr>
@@ -2837,7 +2837,7 @@
           <p:cNvPr id="7" name="Rectangle 6">
             <a:extLst>
               <a:ext uri="{FF2B5EF4-FFF2-40B4-BE49-F238E27FC236}">
-                <a16:creationId xmlns:a16="http://schemas.microsoft.com/office/drawing/2014/main" id="{B8D699E7-64C7-4C10-8802-04FF575ADF90}"/>
+                <a16:creationId xmlns:a16="http://schemas.microsoft.com/office/drawing/2014/main" id="{10A5BC28-EC20-4FD3-924F-31FC0E6A2912}"/>
               </a:ext>
             </a:extLst>
           </p:cNvPr>
@@ -2899,7 +2899,7 @@
           <p:cNvPr id="8" name="Rectangle 7">
             <a:extLst>
               <a:ext uri="{FF2B5EF4-FFF2-40B4-BE49-F238E27FC236}">
-                <a16:creationId xmlns:a16="http://schemas.microsoft.com/office/drawing/2014/main" id="{3E92D9A1-4EA0-448E-8F4B-05034F3F87E6}"/>
+                <a16:creationId xmlns:a16="http://schemas.microsoft.com/office/drawing/2014/main" id="{16225DBE-E32F-4481-83BF-6BD0DF379BA2}"/>
               </a:ext>
             </a:extLst>
           </p:cNvPr>
@@ -2961,7 +2961,7 @@
           <p:cNvPr id="9" name="Rectangle 8">
             <a:extLst>
               <a:ext uri="{FF2B5EF4-FFF2-40B4-BE49-F238E27FC236}">
-                <a16:creationId xmlns:a16="http://schemas.microsoft.com/office/drawing/2014/main" id="{C3A15E6A-9BBB-4D47-83CE-9CAD9142477C}"/>
+                <a16:creationId xmlns:a16="http://schemas.microsoft.com/office/drawing/2014/main" id="{80C0980F-50E9-41C6-BB5D-12E1F8DB6724}"/>
               </a:ext>
             </a:extLst>
           </p:cNvPr>
@@ -3013,7 +3013,7 @@
                 <a:ea typeface="Arial"/>
                 <a:cs typeface="Arial"/>
               </a:rPr>
-              <a:t>r2z-d4c8d4cc709a</a:t>
+              <a:t>r2z-a7181752a17d</a:t>
             </a:r>
           </a:p>
         </p:txBody>
@@ -3023,7 +3023,7 @@
           <p:cNvPr id="10" name="Rectangle 9">
             <a:extLst>
               <a:ext uri="{FF2B5EF4-FFF2-40B4-BE49-F238E27FC236}">
-                <a16:creationId xmlns:a16="http://schemas.microsoft.com/office/drawing/2014/main" id="{6E543582-2BFC-4FDA-982D-7242D8012C1A}"/>
+                <a16:creationId xmlns:a16="http://schemas.microsoft.com/office/drawing/2014/main" id="{C72A1686-6F66-442F-86D9-05A456E20B1F}"/>
               </a:ext>
             </a:extLst>
           </p:cNvPr>
@@ -3085,7 +3085,7 @@
           <p:cNvPr id="11" name="Rectangle 10">
             <a:extLst>
               <a:ext uri="{FF2B5EF4-FFF2-40B4-BE49-F238E27FC236}">
-                <a16:creationId xmlns:a16="http://schemas.microsoft.com/office/drawing/2014/main" id="{52323C63-0256-4AA4-A15C-AB46CC603916}"/>
+                <a16:creationId xmlns:a16="http://schemas.microsoft.com/office/drawing/2014/main" id="{949E1AF1-D238-4CF9-BCBC-8CB62030A760}"/>
               </a:ext>
             </a:extLst>
           </p:cNvPr>
@@ -3147,7 +3147,7 @@
           <p:cNvPr id="12" name="Rectangle 11">
             <a:extLst>
               <a:ext uri="{FF2B5EF4-FFF2-40B4-BE49-F238E27FC236}">
-                <a16:creationId xmlns:a16="http://schemas.microsoft.com/office/drawing/2014/main" id="{FDD6847E-5CA9-4CDA-B779-772F22B855B7}"/>
+                <a16:creationId xmlns:a16="http://schemas.microsoft.com/office/drawing/2014/main" id="{F02E7139-8AC8-46D5-9669-BD0B4CB152A9}"/>
               </a:ext>
             </a:extLst>
           </p:cNvPr>
@@ -3209,7 +3209,7 @@
           <p:cNvPr id="13" name="Rectangle 12">
             <a:extLst>
               <a:ext uri="{FF2B5EF4-FFF2-40B4-BE49-F238E27FC236}">
-                <a16:creationId xmlns:a16="http://schemas.microsoft.com/office/drawing/2014/main" id="{8DF0F915-4024-454B-AB17-8AD3D5D68488}"/>
+                <a16:creationId xmlns:a16="http://schemas.microsoft.com/office/drawing/2014/main" id="{3023826C-29B0-4AA6-A417-122F15C2EE4E}"/>
               </a:ext>
             </a:extLst>
           </p:cNvPr>
@@ -3271,7 +3271,7 @@
           <p:cNvPr id="14" name="Rectangle 13">
             <a:extLst>
               <a:ext uri="{FF2B5EF4-FFF2-40B4-BE49-F238E27FC236}">
-                <a16:creationId xmlns:a16="http://schemas.microsoft.com/office/drawing/2014/main" id="{1E945F98-6D0C-4698-9470-45B9FC5DF6EB}"/>
+                <a16:creationId xmlns:a16="http://schemas.microsoft.com/office/drawing/2014/main" id="{1C9C54AB-6FCE-4112-8FDB-DE3FF451802C}"/>
               </a:ext>
             </a:extLst>
           </p:cNvPr>
@@ -3333,7 +3333,7 @@
           <p:cNvPr id="15" name="Rectangle 14">
             <a:extLst>
               <a:ext uri="{FF2B5EF4-FFF2-40B4-BE49-F238E27FC236}">
-                <a16:creationId xmlns:a16="http://schemas.microsoft.com/office/drawing/2014/main" id="{AF65BB97-FBFD-46AE-B027-57A1CA6C98F8}"/>
+                <a16:creationId xmlns:a16="http://schemas.microsoft.com/office/drawing/2014/main" id="{F3D3606F-47ED-45A5-8052-B4B07B77CDB4}"/>
               </a:ext>
             </a:extLst>
           </p:cNvPr>
@@ -3385,7 +3385,7 @@
                 <a:ea typeface="Arial"/>
                 <a:cs typeface="Arial"/>
               </a:rPr>
-              <a:t>24 Aug 2026 · 16:13 UTC</a:t>
+              <a:t>25 Aug 2026 · 01:00 UTC</a:t>
             </a:r>
           </a:p>
         </p:txBody>
@@ -3395,7 +3395,7 @@
           <p:cNvPr id="16" name="Rectangle 15">
             <a:extLst>
               <a:ext uri="{FF2B5EF4-FFF2-40B4-BE49-F238E27FC236}">
-                <a16:creationId xmlns:a16="http://schemas.microsoft.com/office/drawing/2014/main" id="{8F443C12-72CC-4EE2-9586-4F2662BE99B4}"/>
+                <a16:creationId xmlns:a16="http://schemas.microsoft.com/office/drawing/2014/main" id="{258A8DCE-52D4-4C68-9BB0-8748394B1E95}"/>
               </a:ext>
             </a:extLst>
           </p:cNvPr>
@@ -3457,7 +3457,7 @@
           <p:cNvPr id="17" name="Rectangle 16">
             <a:extLst>
               <a:ext uri="{FF2B5EF4-FFF2-40B4-BE49-F238E27FC236}">
-                <a16:creationId xmlns:a16="http://schemas.microsoft.com/office/drawing/2014/main" id="{83739915-A6E7-460E-AE1D-9EE098E6BC8A}"/>
+                <a16:creationId xmlns:a16="http://schemas.microsoft.com/office/drawing/2014/main" id="{B20F63DD-4823-4570-B54A-1E2C120AF960}"/>
               </a:ext>
             </a:extLst>
           </p:cNvPr>
@@ -3488,7 +3488,7 @@
           <p:cNvPr id="18" name="Rectangle 17">
             <a:extLst>
               <a:ext uri="{FF2B5EF4-FFF2-40B4-BE49-F238E27FC236}">
-                <a16:creationId xmlns:a16="http://schemas.microsoft.com/office/drawing/2014/main" id="{BCFB574D-4EE8-48ED-AA89-560D5E8BA9A5}"/>
+                <a16:creationId xmlns:a16="http://schemas.microsoft.com/office/drawing/2014/main" id="{04CB480E-E682-42CC-8BFF-970A15D95DCC}"/>
               </a:ext>
             </a:extLst>
           </p:cNvPr>
@@ -3540,7 +3540,7 @@
                 <a:ea typeface="Arial"/>
                 <a:cs typeface="Arial"/>
               </a:rPr>
-              <a:t>r2z-d4c8d4cc709a · scn-e0f12f397e · prt-fd6de9d793</a:t>
+              <a:t>r2z-a7181752a17d · scn-e0f12f397e · prt-fd6de9d793</a:t>
             </a:r>
           </a:p>
         </p:txBody>
@@ -3550,7 +3550,7 @@
           <p:cNvPr id="19" name="Rectangle 18">
             <a:extLst>
               <a:ext uri="{FF2B5EF4-FFF2-40B4-BE49-F238E27FC236}">
-                <a16:creationId xmlns:a16="http://schemas.microsoft.com/office/drawing/2014/main" id="{89AB4920-49D0-47D5-BBD5-7E2D3C43FFCA}"/>
+                <a16:creationId xmlns:a16="http://schemas.microsoft.com/office/drawing/2014/main" id="{D34016D3-F85C-498A-B6E0-37D8B281FD71}"/>
               </a:ext>
             </a:extLst>
           </p:cNvPr>
@@ -3610,7 +3610,7 @@
     </p:spTree>
     <p:extLst>
       <p:ext uri="{BB962C8B-B14F-4D97-AF65-F5344CB8AC3E}">
-        <p14:creationId xmlns:p14="http://schemas.microsoft.com/office/powerpoint/2010/main" val="1089284717"/>
+        <p14:creationId xmlns:p14="http://schemas.microsoft.com/office/powerpoint/2010/main" val="2037128199"/>
       </p:ext>
     </p:extLst>
   </p:cSld>
@@ -3651,7 +3651,7 @@
             <a:hlinkClick r:id="rId3"/>
             <a:extLst>
               <a:ext uri="{FF2B5EF4-FFF2-40B4-BE49-F238E27FC236}">
-                <a16:creationId xmlns:a16="http://schemas.microsoft.com/office/drawing/2014/main" id="{4B3D9B78-3222-4750-925A-A35C39DE1670}"/>
+                <a16:creationId xmlns:a16="http://schemas.microsoft.com/office/drawing/2014/main" id="{CBDAE414-F0FF-42E1-9E8F-4BD983CD2014}"/>
               </a:ext>
             </a:extLst>
           </p:cNvPr>
@@ -3726,7 +3726,7 @@
             <a:hlinkClick r:id="rId4"/>
             <a:extLst>
               <a:ext uri="{FF2B5EF4-FFF2-40B4-BE49-F238E27FC236}">
-                <a16:creationId xmlns:a16="http://schemas.microsoft.com/office/drawing/2014/main" id="{DF0BBE3C-C2C3-4B50-A378-FBE6CD68DD05}"/>
+                <a16:creationId xmlns:a16="http://schemas.microsoft.com/office/drawing/2014/main" id="{4AFC50FB-CBD4-4334-B235-C9C56822A1A3}"/>
               </a:ext>
             </a:extLst>
           </p:cNvPr>
@@ -3800,7 +3800,7 @@
           <p:cNvPr id="3" name="Rectangle 2">
             <a:extLst>
               <a:ext uri="{FF2B5EF4-FFF2-40B4-BE49-F238E27FC236}">
-                <a16:creationId xmlns:a16="http://schemas.microsoft.com/office/drawing/2014/main" id="{71BF3587-812B-494C-BE3C-D21A703E349E}"/>
+                <a16:creationId xmlns:a16="http://schemas.microsoft.com/office/drawing/2014/main" id="{2D0DC8C6-96BC-48C5-901D-1F4309C7099C}"/>
               </a:ext>
             </a:extLst>
           </p:cNvPr>
@@ -3862,7 +3862,7 @@
           <p:cNvPr id="4" name="Rectangle 3">
             <a:extLst>
               <a:ext uri="{FF2B5EF4-FFF2-40B4-BE49-F238E27FC236}">
-                <a16:creationId xmlns:a16="http://schemas.microsoft.com/office/drawing/2014/main" id="{E636017A-BC47-4A16-BC1B-2CEB403D4DE7}"/>
+                <a16:creationId xmlns:a16="http://schemas.microsoft.com/office/drawing/2014/main" id="{839FC786-F410-4B2B-9C0D-88823490693F}"/>
               </a:ext>
             </a:extLst>
           </p:cNvPr>
@@ -3951,7 +3951,7 @@
           <p:cNvPr id="6" name="Rectangle: Rounded Corners 5">
             <a:extLst>
               <a:ext uri="{FF2B5EF4-FFF2-40B4-BE49-F238E27FC236}">
-                <a16:creationId xmlns:a16="http://schemas.microsoft.com/office/drawing/2014/main" id="{43EFBB60-67E9-4650-AC6A-683BC30D4E04}"/>
+                <a16:creationId xmlns:a16="http://schemas.microsoft.com/office/drawing/2014/main" id="{8FB77B34-4423-4411-BDA0-EDE2E3F64C67}"/>
               </a:ext>
             </a:extLst>
           </p:cNvPr>
@@ -3984,7 +3984,7 @@
           <p:cNvPr id="7" name="Oval 6">
             <a:extLst>
               <a:ext uri="{FF2B5EF4-FFF2-40B4-BE49-F238E27FC236}">
-                <a16:creationId xmlns:a16="http://schemas.microsoft.com/office/drawing/2014/main" id="{9690429E-FA07-440B-A32B-2ABE123F1A12}"/>
+                <a16:creationId xmlns:a16="http://schemas.microsoft.com/office/drawing/2014/main" id="{91974BE5-E925-4622-ADFB-85B9362A9F18}"/>
               </a:ext>
             </a:extLst>
           </p:cNvPr>
@@ -4015,7 +4015,7 @@
           <p:cNvPr id="8" name="Rectangle 7">
             <a:extLst>
               <a:ext uri="{FF2B5EF4-FFF2-40B4-BE49-F238E27FC236}">
-                <a16:creationId xmlns:a16="http://schemas.microsoft.com/office/drawing/2014/main" id="{33369B50-77F6-4B24-B9D3-25E171906B3D}"/>
+                <a16:creationId xmlns:a16="http://schemas.microsoft.com/office/drawing/2014/main" id="{8AEF1CDC-90F2-45F7-A76D-59CB51EB40E1}"/>
               </a:ext>
             </a:extLst>
           </p:cNvPr>
@@ -4077,7 +4077,7 @@
           <p:cNvPr id="9" name="Rectangle: Rounded Corners 8">
             <a:extLst>
               <a:ext uri="{FF2B5EF4-FFF2-40B4-BE49-F238E27FC236}">
-                <a16:creationId xmlns:a16="http://schemas.microsoft.com/office/drawing/2014/main" id="{D7CD7814-C20D-404F-9CD0-6D62C0B34043}"/>
+                <a16:creationId xmlns:a16="http://schemas.microsoft.com/office/drawing/2014/main" id="{8C5C63E0-FBF2-4990-BE4F-A1945BCFDC83}"/>
               </a:ext>
             </a:extLst>
           </p:cNvPr>
@@ -4112,7 +4112,7 @@
           <p:cNvPr id="10" name="Rectangle 9">
             <a:extLst>
               <a:ext uri="{FF2B5EF4-FFF2-40B4-BE49-F238E27FC236}">
-                <a16:creationId xmlns:a16="http://schemas.microsoft.com/office/drawing/2014/main" id="{02237E8C-7E39-4229-A9E2-B57B060324E1}"/>
+                <a16:creationId xmlns:a16="http://schemas.microsoft.com/office/drawing/2014/main" id="{653F3059-66CA-4FAD-95DA-13C71114E103}"/>
               </a:ext>
             </a:extLst>
           </p:cNvPr>
@@ -4174,7 +4174,7 @@
           <p:cNvPr id="11" name="Oval 10">
             <a:extLst>
               <a:ext uri="{FF2B5EF4-FFF2-40B4-BE49-F238E27FC236}">
-                <a16:creationId xmlns:a16="http://schemas.microsoft.com/office/drawing/2014/main" id="{EF5FD3D3-FFBB-4CCE-9EB7-35F0D21282E0}"/>
+                <a16:creationId xmlns:a16="http://schemas.microsoft.com/office/drawing/2014/main" id="{2F800826-96D6-4AC6-95AD-051116CF779A}"/>
               </a:ext>
             </a:extLst>
           </p:cNvPr>
@@ -4205,7 +4205,7 @@
           <p:cNvPr id="12" name="Rectangle 11">
             <a:extLst>
               <a:ext uri="{FF2B5EF4-FFF2-40B4-BE49-F238E27FC236}">
-                <a16:creationId xmlns:a16="http://schemas.microsoft.com/office/drawing/2014/main" id="{3FB02A5F-D451-459D-80F4-4E297903BE5E}"/>
+                <a16:creationId xmlns:a16="http://schemas.microsoft.com/office/drawing/2014/main" id="{C46F417C-66F9-4B7A-88BB-658154276B8B}"/>
               </a:ext>
             </a:extLst>
           </p:cNvPr>
@@ -4267,7 +4267,7 @@
           <p:cNvPr id="13" name="Rectangle: Rounded Corners 12">
             <a:extLst>
               <a:ext uri="{FF2B5EF4-FFF2-40B4-BE49-F238E27FC236}">
-                <a16:creationId xmlns:a16="http://schemas.microsoft.com/office/drawing/2014/main" id="{E384D906-A0B7-4F95-ADD0-EC1C57AFD8F6}"/>
+                <a16:creationId xmlns:a16="http://schemas.microsoft.com/office/drawing/2014/main" id="{CCACAD47-693F-4CB6-AFFA-43ECDCDC7230}"/>
               </a:ext>
             </a:extLst>
           </p:cNvPr>
@@ -4302,7 +4302,7 @@
           <p:cNvPr id="14" name="Rectangle 13">
             <a:extLst>
               <a:ext uri="{FF2B5EF4-FFF2-40B4-BE49-F238E27FC236}">
-                <a16:creationId xmlns:a16="http://schemas.microsoft.com/office/drawing/2014/main" id="{ED29B790-DDD4-4204-8012-2BBAD0B974EE}"/>
+                <a16:creationId xmlns:a16="http://schemas.microsoft.com/office/drawing/2014/main" id="{7C66FD61-A5B6-485C-B12C-CF679FE6827F}"/>
               </a:ext>
             </a:extLst>
           </p:cNvPr>
@@ -4364,7 +4364,7 @@
           <p:cNvPr id="15" name="Oval 14">
             <a:extLst>
               <a:ext uri="{FF2B5EF4-FFF2-40B4-BE49-F238E27FC236}">
-                <a16:creationId xmlns:a16="http://schemas.microsoft.com/office/drawing/2014/main" id="{7B5C492E-3B32-4F4A-B093-4F610BCB88F9}"/>
+                <a16:creationId xmlns:a16="http://schemas.microsoft.com/office/drawing/2014/main" id="{42249C78-8AC7-4987-B5CB-E5F89DDF8676}"/>
               </a:ext>
             </a:extLst>
           </p:cNvPr>
@@ -4395,7 +4395,7 @@
           <p:cNvPr id="16" name="Rectangle 15">
             <a:extLst>
               <a:ext uri="{FF2B5EF4-FFF2-40B4-BE49-F238E27FC236}">
-                <a16:creationId xmlns:a16="http://schemas.microsoft.com/office/drawing/2014/main" id="{94B7D9A3-CF5C-4C3B-8E78-1E6905253701}"/>
+                <a16:creationId xmlns:a16="http://schemas.microsoft.com/office/drawing/2014/main" id="{E08F05D4-8831-4544-B20A-C6E03C507BFB}"/>
               </a:ext>
             </a:extLst>
           </p:cNvPr>
@@ -4457,7 +4457,7 @@
           <p:cNvPr id="17" name="Rectangle: Rounded Corners 16">
             <a:extLst>
               <a:ext uri="{FF2B5EF4-FFF2-40B4-BE49-F238E27FC236}">
-                <a16:creationId xmlns:a16="http://schemas.microsoft.com/office/drawing/2014/main" id="{AC220318-1C9D-4FF0-AE4D-2F797F894CF1}"/>
+                <a16:creationId xmlns:a16="http://schemas.microsoft.com/office/drawing/2014/main" id="{B15EF8A0-4D05-4C8B-A3B5-91635003A25A}"/>
               </a:ext>
             </a:extLst>
           </p:cNvPr>
@@ -4492,7 +4492,7 @@
           <p:cNvPr id="18" name="Rectangle 17">
             <a:extLst>
               <a:ext uri="{FF2B5EF4-FFF2-40B4-BE49-F238E27FC236}">
-                <a16:creationId xmlns:a16="http://schemas.microsoft.com/office/drawing/2014/main" id="{4FD2C045-B9AD-45B9-96C2-DE62604B909E}"/>
+                <a16:creationId xmlns:a16="http://schemas.microsoft.com/office/drawing/2014/main" id="{53DE3F61-62E2-4BE1-A00B-B27172014333}"/>
               </a:ext>
             </a:extLst>
           </p:cNvPr>
@@ -4554,7 +4554,7 @@
           <p:cNvPr id="19" name="Rectangle 18">
             <a:extLst>
               <a:ext uri="{FF2B5EF4-FFF2-40B4-BE49-F238E27FC236}">
-                <a16:creationId xmlns:a16="http://schemas.microsoft.com/office/drawing/2014/main" id="{3FE6FEEE-4D4C-40BF-9E84-476B31EDE323}"/>
+                <a16:creationId xmlns:a16="http://schemas.microsoft.com/office/drawing/2014/main" id="{10FBAF55-CBF4-460D-8BF0-8851D14431AE}"/>
               </a:ext>
             </a:extLst>
           </p:cNvPr>
@@ -4585,7 +4585,7 @@
           <p:cNvPr id="20" name="Rectangle 19">
             <a:extLst>
               <a:ext uri="{FF2B5EF4-FFF2-40B4-BE49-F238E27FC236}">
-                <a16:creationId xmlns:a16="http://schemas.microsoft.com/office/drawing/2014/main" id="{F7C619B0-B6A0-48E0-B9FB-0B91FC7B5022}"/>
+                <a16:creationId xmlns:a16="http://schemas.microsoft.com/office/drawing/2014/main" id="{36F52EEC-040D-4CB5-8C6B-2405FB1B0998}"/>
               </a:ext>
             </a:extLst>
           </p:cNvPr>
@@ -4637,7 +4637,7 @@
                 <a:ea typeface="Arial"/>
                 <a:cs typeface="Arial"/>
               </a:rPr>
-              <a:t>r2z-d4c8d4cc709a · scn-e0f12f397e · prt-fd6de9d793</a:t>
+              <a:t>r2z-a7181752a17d · scn-e0f12f397e · prt-fd6de9d793</a:t>
             </a:r>
           </a:p>
         </p:txBody>
@@ -4647,7 +4647,7 @@
           <p:cNvPr id="21" name="Rectangle 20">
             <a:extLst>
               <a:ext uri="{FF2B5EF4-FFF2-40B4-BE49-F238E27FC236}">
-                <a16:creationId xmlns:a16="http://schemas.microsoft.com/office/drawing/2014/main" id="{DEBCDB36-8375-4673-A9D2-614E959B23D6}"/>
+                <a16:creationId xmlns:a16="http://schemas.microsoft.com/office/drawing/2014/main" id="{9661E5D7-8551-4BD4-AB97-69EB67180593}"/>
               </a:ext>
             </a:extLst>
           </p:cNvPr>
@@ -4707,7 +4707,7 @@
     </p:spTree>
     <p:extLst>
       <p:ext uri="{BB962C8B-B14F-4D97-AF65-F5344CB8AC3E}">
-        <p14:creationId xmlns:p14="http://schemas.microsoft.com/office/powerpoint/2010/main" val="86225550"/>
+        <p14:creationId xmlns:p14="http://schemas.microsoft.com/office/powerpoint/2010/main" val="300639733"/>
       </p:ext>
     </p:extLst>
   </p:cSld>
@@ -4748,7 +4748,7 @@
             <a:hlinkClick r:id="rId3"/>
             <a:extLst>
               <a:ext uri="{FF2B5EF4-FFF2-40B4-BE49-F238E27FC236}">
-                <a16:creationId xmlns:a16="http://schemas.microsoft.com/office/drawing/2014/main" id="{CF2D6680-5CBE-49C1-9D51-EFD5C4D0B9A1}"/>
+                <a16:creationId xmlns:a16="http://schemas.microsoft.com/office/drawing/2014/main" id="{7DEACC65-2C9E-47C7-B5E8-816154407907}"/>
               </a:ext>
             </a:extLst>
           </p:cNvPr>
@@ -4823,7 +4823,7 @@
             <a:hlinkClick r:id="rId4"/>
             <a:extLst>
               <a:ext uri="{FF2B5EF4-FFF2-40B4-BE49-F238E27FC236}">
-                <a16:creationId xmlns:a16="http://schemas.microsoft.com/office/drawing/2014/main" id="{24E0DED8-85A5-4B31-AE88-2C834FD5535C}"/>
+                <a16:creationId xmlns:a16="http://schemas.microsoft.com/office/drawing/2014/main" id="{CD30F34B-7F66-43F4-8CE6-D515D2D5431D}"/>
               </a:ext>
             </a:extLst>
           </p:cNvPr>
@@ -4897,7 +4897,7 @@
           <p:cNvPr id="3" name="Rectangle 2">
             <a:extLst>
               <a:ext uri="{FF2B5EF4-FFF2-40B4-BE49-F238E27FC236}">
-                <a16:creationId xmlns:a16="http://schemas.microsoft.com/office/drawing/2014/main" id="{15A88A26-DE00-4E08-A4DF-2099919C52A0}"/>
+                <a16:creationId xmlns:a16="http://schemas.microsoft.com/office/drawing/2014/main" id="{19AA475A-DC51-4BE1-8214-452C1A4DC3E5}"/>
               </a:ext>
             </a:extLst>
           </p:cNvPr>
@@ -4959,7 +4959,7 @@
           <p:cNvPr id="4" name="Rectangle 3">
             <a:extLst>
               <a:ext uri="{FF2B5EF4-FFF2-40B4-BE49-F238E27FC236}">
-                <a16:creationId xmlns:a16="http://schemas.microsoft.com/office/drawing/2014/main" id="{4B23D46D-B206-4C26-A6C8-D91634990C63}"/>
+                <a16:creationId xmlns:a16="http://schemas.microsoft.com/office/drawing/2014/main" id="{40058786-E414-4E64-8A74-2BF2CF915403}"/>
               </a:ext>
             </a:extLst>
           </p:cNvPr>
@@ -5048,7 +5048,7 @@
           <p:cNvPr id="6" name="Rectangle: Rounded Corners 5">
             <a:extLst>
               <a:ext uri="{FF2B5EF4-FFF2-40B4-BE49-F238E27FC236}">
-                <a16:creationId xmlns:a16="http://schemas.microsoft.com/office/drawing/2014/main" id="{5FA980F1-8776-45A9-A14A-92F160954A03}"/>
+                <a16:creationId xmlns:a16="http://schemas.microsoft.com/office/drawing/2014/main" id="{773A7746-6C55-4E8C-8854-1A684C03A5FF}"/>
               </a:ext>
             </a:extLst>
           </p:cNvPr>
@@ -5081,7 +5081,7 @@
           <p:cNvPr id="7" name="Oval 6">
             <a:extLst>
               <a:ext uri="{FF2B5EF4-FFF2-40B4-BE49-F238E27FC236}">
-                <a16:creationId xmlns:a16="http://schemas.microsoft.com/office/drawing/2014/main" id="{E4C2624A-A04D-4F21-97C8-09D4C921179A}"/>
+                <a16:creationId xmlns:a16="http://schemas.microsoft.com/office/drawing/2014/main" id="{9E043F23-0756-4E10-B288-F4732E2F668B}"/>
               </a:ext>
             </a:extLst>
           </p:cNvPr>
@@ -5112,7 +5112,7 @@
           <p:cNvPr id="8" name="Rectangle 7">
             <a:extLst>
               <a:ext uri="{FF2B5EF4-FFF2-40B4-BE49-F238E27FC236}">
-                <a16:creationId xmlns:a16="http://schemas.microsoft.com/office/drawing/2014/main" id="{3B5EE290-0C59-4193-B517-E9946D04183B}"/>
+                <a16:creationId xmlns:a16="http://schemas.microsoft.com/office/drawing/2014/main" id="{B32B01F2-ED6F-4B00-BCFA-B0AE5BE72001}"/>
               </a:ext>
             </a:extLst>
           </p:cNvPr>
@@ -5174,7 +5174,7 @@
           <p:cNvPr id="9" name="Rectangle: Rounded Corners 8">
             <a:extLst>
               <a:ext uri="{FF2B5EF4-FFF2-40B4-BE49-F238E27FC236}">
-                <a16:creationId xmlns:a16="http://schemas.microsoft.com/office/drawing/2014/main" id="{40694A5E-0BC6-47DE-963D-5A6AB29F3A77}"/>
+                <a16:creationId xmlns:a16="http://schemas.microsoft.com/office/drawing/2014/main" id="{1DD212CE-6993-49D1-89B0-E7875EE136DE}"/>
               </a:ext>
             </a:extLst>
           </p:cNvPr>
@@ -5209,7 +5209,7 @@
           <p:cNvPr id="10" name="Rectangle 9">
             <a:extLst>
               <a:ext uri="{FF2B5EF4-FFF2-40B4-BE49-F238E27FC236}">
-                <a16:creationId xmlns:a16="http://schemas.microsoft.com/office/drawing/2014/main" id="{EF73031A-9370-4B60-BDCF-8628283B3B97}"/>
+                <a16:creationId xmlns:a16="http://schemas.microsoft.com/office/drawing/2014/main" id="{55C69E48-5345-4CCF-84F6-21C0A97DCE7F}"/>
               </a:ext>
             </a:extLst>
           </p:cNvPr>
@@ -5271,7 +5271,7 @@
           <p:cNvPr id="11" name="Oval 10">
             <a:extLst>
               <a:ext uri="{FF2B5EF4-FFF2-40B4-BE49-F238E27FC236}">
-                <a16:creationId xmlns:a16="http://schemas.microsoft.com/office/drawing/2014/main" id="{2F8ED8A0-2E67-45F4-9112-CD685F750E9B}"/>
+                <a16:creationId xmlns:a16="http://schemas.microsoft.com/office/drawing/2014/main" id="{2C8D8071-213B-4601-AAA6-870A27830929}"/>
               </a:ext>
             </a:extLst>
           </p:cNvPr>
@@ -5302,7 +5302,7 @@
           <p:cNvPr id="12" name="Rectangle 11">
             <a:extLst>
               <a:ext uri="{FF2B5EF4-FFF2-40B4-BE49-F238E27FC236}">
-                <a16:creationId xmlns:a16="http://schemas.microsoft.com/office/drawing/2014/main" id="{D71E5195-BDF1-4F95-8060-1C052F86BFD5}"/>
+                <a16:creationId xmlns:a16="http://schemas.microsoft.com/office/drawing/2014/main" id="{6D9C2641-80C0-4D03-B59A-969AA15E9B5C}"/>
               </a:ext>
             </a:extLst>
           </p:cNvPr>
@@ -5364,7 +5364,7 @@
           <p:cNvPr id="13" name="Rectangle: Rounded Corners 12">
             <a:extLst>
               <a:ext uri="{FF2B5EF4-FFF2-40B4-BE49-F238E27FC236}">
-                <a16:creationId xmlns:a16="http://schemas.microsoft.com/office/drawing/2014/main" id="{978DECF1-DBB4-4714-9356-E7C774C2FBCC}"/>
+                <a16:creationId xmlns:a16="http://schemas.microsoft.com/office/drawing/2014/main" id="{92B4776D-CEF7-4274-B249-0818F1B2B8F3}"/>
               </a:ext>
             </a:extLst>
           </p:cNvPr>
@@ -5399,7 +5399,7 @@
           <p:cNvPr id="14" name="Rectangle 13">
             <a:extLst>
               <a:ext uri="{FF2B5EF4-FFF2-40B4-BE49-F238E27FC236}">
-                <a16:creationId xmlns:a16="http://schemas.microsoft.com/office/drawing/2014/main" id="{5992EACD-529C-4584-A9A9-BB0980E90803}"/>
+                <a16:creationId xmlns:a16="http://schemas.microsoft.com/office/drawing/2014/main" id="{0CF2FB93-948B-4470-9EA5-9F09B2A0D35D}"/>
               </a:ext>
             </a:extLst>
           </p:cNvPr>
@@ -5461,7 +5461,7 @@
           <p:cNvPr id="15" name="Oval 14">
             <a:extLst>
               <a:ext uri="{FF2B5EF4-FFF2-40B4-BE49-F238E27FC236}">
-                <a16:creationId xmlns:a16="http://schemas.microsoft.com/office/drawing/2014/main" id="{DEAA4764-7AC0-4AAE-9489-6C7231040C1A}"/>
+                <a16:creationId xmlns:a16="http://schemas.microsoft.com/office/drawing/2014/main" id="{6B072E0E-81DD-4340-B50C-3E21569043B3}"/>
               </a:ext>
             </a:extLst>
           </p:cNvPr>
@@ -5492,7 +5492,7 @@
           <p:cNvPr id="16" name="Rectangle 15">
             <a:extLst>
               <a:ext uri="{FF2B5EF4-FFF2-40B4-BE49-F238E27FC236}">
-                <a16:creationId xmlns:a16="http://schemas.microsoft.com/office/drawing/2014/main" id="{69835C9B-A579-4130-8391-8D13FB2FF554}"/>
+                <a16:creationId xmlns:a16="http://schemas.microsoft.com/office/drawing/2014/main" id="{C4A24762-BE80-48DE-8BA4-58B20BC9A782}"/>
               </a:ext>
             </a:extLst>
           </p:cNvPr>
@@ -5554,7 +5554,7 @@
           <p:cNvPr id="17" name="Rectangle: Rounded Corners 16">
             <a:extLst>
               <a:ext uri="{FF2B5EF4-FFF2-40B4-BE49-F238E27FC236}">
-                <a16:creationId xmlns:a16="http://schemas.microsoft.com/office/drawing/2014/main" id="{285FF8E8-15F2-4DDC-BAEA-D75D4CBFE06A}"/>
+                <a16:creationId xmlns:a16="http://schemas.microsoft.com/office/drawing/2014/main" id="{FD434514-ECBD-4881-811B-CD39B9BCB3F7}"/>
               </a:ext>
             </a:extLst>
           </p:cNvPr>
@@ -5589,7 +5589,7 @@
           <p:cNvPr id="18" name="Rectangle 17">
             <a:extLst>
               <a:ext uri="{FF2B5EF4-FFF2-40B4-BE49-F238E27FC236}">
-                <a16:creationId xmlns:a16="http://schemas.microsoft.com/office/drawing/2014/main" id="{D99251A3-7245-48E8-876D-112A1E497C61}"/>
+                <a16:creationId xmlns:a16="http://schemas.microsoft.com/office/drawing/2014/main" id="{65D2E518-4B0A-49D2-9109-4E8AA5A35415}"/>
               </a:ext>
             </a:extLst>
           </p:cNvPr>
@@ -5651,7 +5651,7 @@
           <p:cNvPr id="19" name="Rectangle 18">
             <a:extLst>
               <a:ext uri="{FF2B5EF4-FFF2-40B4-BE49-F238E27FC236}">
-                <a16:creationId xmlns:a16="http://schemas.microsoft.com/office/drawing/2014/main" id="{22D2C59D-FD2A-4A78-BE94-7AEBBA183A44}"/>
+                <a16:creationId xmlns:a16="http://schemas.microsoft.com/office/drawing/2014/main" id="{27806147-326E-470F-B0D4-AD76E3841B37}"/>
               </a:ext>
             </a:extLst>
           </p:cNvPr>
@@ -5682,7 +5682,7 @@
           <p:cNvPr id="20" name="Rectangle 19">
             <a:extLst>
               <a:ext uri="{FF2B5EF4-FFF2-40B4-BE49-F238E27FC236}">
-                <a16:creationId xmlns:a16="http://schemas.microsoft.com/office/drawing/2014/main" id="{BBD3D1C3-3E36-4FB3-8224-74E19453ED58}"/>
+                <a16:creationId xmlns:a16="http://schemas.microsoft.com/office/drawing/2014/main" id="{ACCBD51E-A2C5-49D8-8294-73464BE28E68}"/>
               </a:ext>
             </a:extLst>
           </p:cNvPr>
@@ -5734,7 +5734,7 @@
                 <a:ea typeface="Arial"/>
                 <a:cs typeface="Arial"/>
               </a:rPr>
-              <a:t>r2z-d4c8d4cc709a · scn-e0f12f397e · prt-fd6de9d793</a:t>
+              <a:t>r2z-a7181752a17d · scn-e0f12f397e · prt-fd6de9d793</a:t>
             </a:r>
           </a:p>
         </p:txBody>
@@ -5744,7 +5744,7 @@
           <p:cNvPr id="21" name="Rectangle 20">
             <a:extLst>
               <a:ext uri="{FF2B5EF4-FFF2-40B4-BE49-F238E27FC236}">
-                <a16:creationId xmlns:a16="http://schemas.microsoft.com/office/drawing/2014/main" id="{67207976-735F-4B63-9111-1F30048A2617}"/>
+                <a16:creationId xmlns:a16="http://schemas.microsoft.com/office/drawing/2014/main" id="{CBF7B035-5566-4E06-8EC5-EDDC986A0222}"/>
               </a:ext>
             </a:extLst>
           </p:cNvPr>
@@ -5804,7 +5804,7 @@
     </p:spTree>
     <p:extLst>
       <p:ext uri="{BB962C8B-B14F-4D97-AF65-F5344CB8AC3E}">
-        <p14:creationId xmlns:p14="http://schemas.microsoft.com/office/powerpoint/2010/main" val="1719115139"/>
+        <p14:creationId xmlns:p14="http://schemas.microsoft.com/office/powerpoint/2010/main" val="272596171"/>
       </p:ext>
     </p:extLst>
   </p:cSld>
@@ -5845,7 +5845,7 @@
             <a:hlinkClick r:id="rId3"/>
             <a:extLst>
               <a:ext uri="{FF2B5EF4-FFF2-40B4-BE49-F238E27FC236}">
-                <a16:creationId xmlns:a16="http://schemas.microsoft.com/office/drawing/2014/main" id="{E1539F57-F36A-4847-B72B-17C47DEC5556}"/>
+                <a16:creationId xmlns:a16="http://schemas.microsoft.com/office/drawing/2014/main" id="{AB29BEF1-FB72-4988-ADA6-DD31BBAEA916}"/>
               </a:ext>
             </a:extLst>
           </p:cNvPr>
@@ -5920,7 +5920,7 @@
             <a:hlinkClick r:id="rId4"/>
             <a:extLst>
               <a:ext uri="{FF2B5EF4-FFF2-40B4-BE49-F238E27FC236}">
-                <a16:creationId xmlns:a16="http://schemas.microsoft.com/office/drawing/2014/main" id="{AACC5AA6-6776-43D6-B59F-82EF855929D5}"/>
+                <a16:creationId xmlns:a16="http://schemas.microsoft.com/office/drawing/2014/main" id="{BD1C73FD-F4E4-4554-A239-962AFA5889FC}"/>
               </a:ext>
             </a:extLst>
           </p:cNvPr>
@@ -5994,7 +5994,7 @@
           <p:cNvPr id="3" name="Rectangle 2">
             <a:extLst>
               <a:ext uri="{FF2B5EF4-FFF2-40B4-BE49-F238E27FC236}">
-                <a16:creationId xmlns:a16="http://schemas.microsoft.com/office/drawing/2014/main" id="{787728EA-ADC7-4065-906C-8FF8C745871C}"/>
+                <a16:creationId xmlns:a16="http://schemas.microsoft.com/office/drawing/2014/main" id="{5F2A5471-1BA2-4CBC-ADCC-A471AC5C360F}"/>
               </a:ext>
             </a:extLst>
           </p:cNvPr>
@@ -6056,7 +6056,7 @@
           <p:cNvPr id="4" name="Rectangle 3">
             <a:extLst>
               <a:ext uri="{FF2B5EF4-FFF2-40B4-BE49-F238E27FC236}">
-                <a16:creationId xmlns:a16="http://schemas.microsoft.com/office/drawing/2014/main" id="{2265E948-EB86-4E66-A9D4-71A5DEB63B7F}"/>
+                <a16:creationId xmlns:a16="http://schemas.microsoft.com/office/drawing/2014/main" id="{67E8FBAB-97EC-46C1-A7B6-8096B2A68E49}"/>
               </a:ext>
             </a:extLst>
           </p:cNvPr>
@@ -6145,7 +6145,7 @@
           <p:cNvPr id="6" name="Rectangle: Rounded Corners 5">
             <a:extLst>
               <a:ext uri="{FF2B5EF4-FFF2-40B4-BE49-F238E27FC236}">
-                <a16:creationId xmlns:a16="http://schemas.microsoft.com/office/drawing/2014/main" id="{3FE03666-E8E7-4404-9FC4-031ADCF450A6}"/>
+                <a16:creationId xmlns:a16="http://schemas.microsoft.com/office/drawing/2014/main" id="{57012999-B32A-4271-956C-4D7F4C6BE65E}"/>
               </a:ext>
             </a:extLst>
           </p:cNvPr>
@@ -6178,7 +6178,7 @@
           <p:cNvPr id="7" name="Rectangle 6">
             <a:extLst>
               <a:ext uri="{FF2B5EF4-FFF2-40B4-BE49-F238E27FC236}">
-                <a16:creationId xmlns:a16="http://schemas.microsoft.com/office/drawing/2014/main" id="{89071F57-08B0-4A77-87D2-70B8BAFFB987}"/>
+                <a16:creationId xmlns:a16="http://schemas.microsoft.com/office/drawing/2014/main" id="{AB55B088-17AA-4144-AF8A-DFD720075A1D}"/>
               </a:ext>
             </a:extLst>
           </p:cNvPr>
@@ -6240,7 +6240,7 @@
           <p:cNvPr id="8" name="Rectangle 7">
             <a:extLst>
               <a:ext uri="{FF2B5EF4-FFF2-40B4-BE49-F238E27FC236}">
-                <a16:creationId xmlns:a16="http://schemas.microsoft.com/office/drawing/2014/main" id="{FA865F4B-3309-4F4D-9A9F-08E8D40C0F5A}"/>
+                <a16:creationId xmlns:a16="http://schemas.microsoft.com/office/drawing/2014/main" id="{E3942EBE-3EF8-43B4-956D-89D8FF7AD186}"/>
               </a:ext>
             </a:extLst>
           </p:cNvPr>
@@ -6302,7 +6302,7 @@
           <p:cNvPr id="9" name="Rectangle 8">
             <a:extLst>
               <a:ext uri="{FF2B5EF4-FFF2-40B4-BE49-F238E27FC236}">
-                <a16:creationId xmlns:a16="http://schemas.microsoft.com/office/drawing/2014/main" id="{E28689C0-046D-4BDD-81F4-669AD3E232B1}"/>
+                <a16:creationId xmlns:a16="http://schemas.microsoft.com/office/drawing/2014/main" id="{BC007548-D012-402E-8C94-21ED3C365F5B}"/>
               </a:ext>
             </a:extLst>
           </p:cNvPr>
@@ -6364,7 +6364,7 @@
           <p:cNvPr id="10" name="Rectangle 9">
             <a:extLst>
               <a:ext uri="{FF2B5EF4-FFF2-40B4-BE49-F238E27FC236}">
-                <a16:creationId xmlns:a16="http://schemas.microsoft.com/office/drawing/2014/main" id="{E9F1804B-46F4-486D-B45D-1C5F56B82452}"/>
+                <a16:creationId xmlns:a16="http://schemas.microsoft.com/office/drawing/2014/main" id="{C093D0D0-71B4-4ED5-AE80-EE425C38D8D8}"/>
               </a:ext>
             </a:extLst>
           </p:cNvPr>
@@ -6426,7 +6426,7 @@
           <p:cNvPr id="11" name="Rectangle 10">
             <a:extLst>
               <a:ext uri="{FF2B5EF4-FFF2-40B4-BE49-F238E27FC236}">
-                <a16:creationId xmlns:a16="http://schemas.microsoft.com/office/drawing/2014/main" id="{A5094559-8222-481B-AC12-CD471BC21B1E}"/>
+                <a16:creationId xmlns:a16="http://schemas.microsoft.com/office/drawing/2014/main" id="{90DC2E8D-859C-4045-858F-2F722D89C265}"/>
               </a:ext>
             </a:extLst>
           </p:cNvPr>
@@ -6488,7 +6488,7 @@
           <p:cNvPr id="12" name="Rectangle: Rounded Corners 11">
             <a:extLst>
               <a:ext uri="{FF2B5EF4-FFF2-40B4-BE49-F238E27FC236}">
-                <a16:creationId xmlns:a16="http://schemas.microsoft.com/office/drawing/2014/main" id="{7A47A1E2-3647-46C0-918E-516185C6D5DE}"/>
+                <a16:creationId xmlns:a16="http://schemas.microsoft.com/office/drawing/2014/main" id="{2073D107-375D-4EE7-AF38-41548C046DC8}"/>
               </a:ext>
             </a:extLst>
           </p:cNvPr>
@@ -6523,7 +6523,7 @@
           <p:cNvPr id="13" name="Rectangle 12">
             <a:extLst>
               <a:ext uri="{FF2B5EF4-FFF2-40B4-BE49-F238E27FC236}">
-                <a16:creationId xmlns:a16="http://schemas.microsoft.com/office/drawing/2014/main" id="{42A3AAA4-492B-4066-969F-0AF56DEFEEF6}"/>
+                <a16:creationId xmlns:a16="http://schemas.microsoft.com/office/drawing/2014/main" id="{BF51868E-236D-49EF-9539-7658E1FBBF69}"/>
               </a:ext>
             </a:extLst>
           </p:cNvPr>
@@ -6585,7 +6585,7 @@
           <p:cNvPr id="14" name="Rectangle 13">
             <a:extLst>
               <a:ext uri="{FF2B5EF4-FFF2-40B4-BE49-F238E27FC236}">
-                <a16:creationId xmlns:a16="http://schemas.microsoft.com/office/drawing/2014/main" id="{89132BAF-D900-4FC3-BFF6-BE111CC24894}"/>
+                <a16:creationId xmlns:a16="http://schemas.microsoft.com/office/drawing/2014/main" id="{0A6A6489-0EC8-45A1-BE62-6C7E81A06D70}"/>
               </a:ext>
             </a:extLst>
           </p:cNvPr>
@@ -6647,7 +6647,7 @@
           <p:cNvPr id="15" name="Rectangle 14">
             <a:extLst>
               <a:ext uri="{FF2B5EF4-FFF2-40B4-BE49-F238E27FC236}">
-                <a16:creationId xmlns:a16="http://schemas.microsoft.com/office/drawing/2014/main" id="{034BCE20-75E0-42AE-AC1C-62A2C2C161DC}"/>
+                <a16:creationId xmlns:a16="http://schemas.microsoft.com/office/drawing/2014/main" id="{8ED153D5-AB6D-4EE5-8523-9B86196F22CC}"/>
               </a:ext>
             </a:extLst>
           </p:cNvPr>
@@ -6709,7 +6709,7 @@
           <p:cNvPr id="16" name="Rectangle 15">
             <a:extLst>
               <a:ext uri="{FF2B5EF4-FFF2-40B4-BE49-F238E27FC236}">
-                <a16:creationId xmlns:a16="http://schemas.microsoft.com/office/drawing/2014/main" id="{39EB64E5-552B-4A73-BD20-F157F1B21DB6}"/>
+                <a16:creationId xmlns:a16="http://schemas.microsoft.com/office/drawing/2014/main" id="{AB10401E-1D6C-4CA0-B510-1541C5AD390E}"/>
               </a:ext>
             </a:extLst>
           </p:cNvPr>
@@ -6771,7 +6771,7 @@
           <p:cNvPr id="17" name="Rectangle 16">
             <a:extLst>
               <a:ext uri="{FF2B5EF4-FFF2-40B4-BE49-F238E27FC236}">
-                <a16:creationId xmlns:a16="http://schemas.microsoft.com/office/drawing/2014/main" id="{D47CA950-C56F-4082-B292-65AB42808E6E}"/>
+                <a16:creationId xmlns:a16="http://schemas.microsoft.com/office/drawing/2014/main" id="{7A707660-2E3A-4CA6-A0CC-C65A25B28584}"/>
               </a:ext>
             </a:extLst>
           </p:cNvPr>
@@ -6833,7 +6833,7 @@
           <p:cNvPr id="18" name="Rectangle 17">
             <a:extLst>
               <a:ext uri="{FF2B5EF4-FFF2-40B4-BE49-F238E27FC236}">
-                <a16:creationId xmlns:a16="http://schemas.microsoft.com/office/drawing/2014/main" id="{1E8C5D8F-5536-45D6-B4B5-4118C0D180C2}"/>
+                <a16:creationId xmlns:a16="http://schemas.microsoft.com/office/drawing/2014/main" id="{6033505E-D45A-4D80-AF21-886C07216E68}"/>
               </a:ext>
             </a:extLst>
           </p:cNvPr>
@@ -6895,7 +6895,7 @@
           <p:cNvPr id="19" name="Rectangle: Rounded Corners 18">
             <a:extLst>
               <a:ext uri="{FF2B5EF4-FFF2-40B4-BE49-F238E27FC236}">
-                <a16:creationId xmlns:a16="http://schemas.microsoft.com/office/drawing/2014/main" id="{4FEF37B8-4637-475D-A796-90CA649A2589}"/>
+                <a16:creationId xmlns:a16="http://schemas.microsoft.com/office/drawing/2014/main" id="{0B188667-31D6-46C1-AC9B-DFD72B79E581}"/>
               </a:ext>
             </a:extLst>
           </p:cNvPr>
@@ -6930,7 +6930,7 @@
           <p:cNvPr id="20" name="Rectangle 19">
             <a:extLst>
               <a:ext uri="{FF2B5EF4-FFF2-40B4-BE49-F238E27FC236}">
-                <a16:creationId xmlns:a16="http://schemas.microsoft.com/office/drawing/2014/main" id="{B04549CF-9FBD-4B3B-9D7D-916BAC15EFE7}"/>
+                <a16:creationId xmlns:a16="http://schemas.microsoft.com/office/drawing/2014/main" id="{FA6686A5-DBA2-4C1D-9F73-D98EEF903541}"/>
               </a:ext>
             </a:extLst>
           </p:cNvPr>
@@ -6992,7 +6992,7 @@
           <p:cNvPr id="21" name="Rectangle 20">
             <a:extLst>
               <a:ext uri="{FF2B5EF4-FFF2-40B4-BE49-F238E27FC236}">
-                <a16:creationId xmlns:a16="http://schemas.microsoft.com/office/drawing/2014/main" id="{8F00DB56-D782-4788-9509-E02E6802FE81}"/>
+                <a16:creationId xmlns:a16="http://schemas.microsoft.com/office/drawing/2014/main" id="{38991D6A-6A02-4A33-825D-B8064E34610A}"/>
               </a:ext>
             </a:extLst>
           </p:cNvPr>
@@ -7023,7 +7023,7 @@
           <p:cNvPr id="22" name="Rectangle 21">
             <a:extLst>
               <a:ext uri="{FF2B5EF4-FFF2-40B4-BE49-F238E27FC236}">
-                <a16:creationId xmlns:a16="http://schemas.microsoft.com/office/drawing/2014/main" id="{FC760951-7EB9-43DD-9DCB-1774B03C3A83}"/>
+                <a16:creationId xmlns:a16="http://schemas.microsoft.com/office/drawing/2014/main" id="{3FE19EB3-B95C-44A0-8CBC-9160F8F7B00B}"/>
               </a:ext>
             </a:extLst>
           </p:cNvPr>
@@ -7075,7 +7075,7 @@
                 <a:ea typeface="Arial"/>
                 <a:cs typeface="Arial"/>
               </a:rPr>
-              <a:t>r2z-d4c8d4cc709a · scn-e0f12f397e · prt-fd6de9d793 · seed 20260820 · 5,000 simulations</a:t>
+              <a:t>r2z-a7181752a17d · scn-e0f12f397e · prt-fd6de9d793 · seed 20260820 · 5,000 simulations</a:t>
             </a:r>
           </a:p>
         </p:txBody>
@@ -7085,7 +7085,7 @@
           <p:cNvPr id="23" name="Rectangle 22">
             <a:extLst>
               <a:ext uri="{FF2B5EF4-FFF2-40B4-BE49-F238E27FC236}">
-                <a16:creationId xmlns:a16="http://schemas.microsoft.com/office/drawing/2014/main" id="{468DAF2B-B692-40BA-B490-922B79A9A550}"/>
+                <a16:creationId xmlns:a16="http://schemas.microsoft.com/office/drawing/2014/main" id="{35A89C83-8CCF-4314-BBB3-817D67B8CEDA}"/>
               </a:ext>
             </a:extLst>
           </p:cNvPr>
@@ -7145,7 +7145,7 @@
     </p:spTree>
     <p:extLst>
       <p:ext uri="{BB962C8B-B14F-4D97-AF65-F5344CB8AC3E}">
-        <p14:creationId xmlns:p14="http://schemas.microsoft.com/office/powerpoint/2010/main" val="567718276"/>
+        <p14:creationId xmlns:p14="http://schemas.microsoft.com/office/powerpoint/2010/main" val="961379952"/>
       </p:ext>
     </p:extLst>
   </p:cSld>
@@ -7186,7 +7186,7 @@
             <a:hlinkClick r:id="rId3"/>
             <a:extLst>
               <a:ext uri="{FF2B5EF4-FFF2-40B4-BE49-F238E27FC236}">
-                <a16:creationId xmlns:a16="http://schemas.microsoft.com/office/drawing/2014/main" id="{12EE98C3-2B32-402E-AFFB-E9BB96C428ED}"/>
+                <a16:creationId xmlns:a16="http://schemas.microsoft.com/office/drawing/2014/main" id="{FB275886-89CD-41E5-B6A8-FF729DA731B6}"/>
               </a:ext>
             </a:extLst>
           </p:cNvPr>
@@ -7261,7 +7261,7 @@
             <a:hlinkClick r:id="rId4"/>
             <a:extLst>
               <a:ext uri="{FF2B5EF4-FFF2-40B4-BE49-F238E27FC236}">
-                <a16:creationId xmlns:a16="http://schemas.microsoft.com/office/drawing/2014/main" id="{D9B0EBC2-7D07-4B85-A31F-DD15E515969D}"/>
+                <a16:creationId xmlns:a16="http://schemas.microsoft.com/office/drawing/2014/main" id="{157AD1EE-EBDC-4356-86F7-22E9E68F8835}"/>
               </a:ext>
             </a:extLst>
           </p:cNvPr>
@@ -7335,7 +7335,7 @@
           <p:cNvPr id="3" name="Rectangle 2">
             <a:extLst>
               <a:ext uri="{FF2B5EF4-FFF2-40B4-BE49-F238E27FC236}">
-                <a16:creationId xmlns:a16="http://schemas.microsoft.com/office/drawing/2014/main" id="{A375854B-A546-4AD2-9D48-C8B4BD3A2959}"/>
+                <a16:creationId xmlns:a16="http://schemas.microsoft.com/office/drawing/2014/main" id="{B3426931-91B0-4409-AF07-DC76F9BCD1C3}"/>
               </a:ext>
             </a:extLst>
           </p:cNvPr>
@@ -7397,7 +7397,7 @@
           <p:cNvPr id="4" name="Rectangle 3">
             <a:extLst>
               <a:ext uri="{FF2B5EF4-FFF2-40B4-BE49-F238E27FC236}">
-                <a16:creationId xmlns:a16="http://schemas.microsoft.com/office/drawing/2014/main" id="{10CA6C7F-7508-4195-B4E5-60059C40E6FE}"/>
+                <a16:creationId xmlns:a16="http://schemas.microsoft.com/office/drawing/2014/main" id="{31938100-C170-478E-AD68-E0E3C8C550AD}"/>
               </a:ext>
             </a:extLst>
           </p:cNvPr>
@@ -7486,7 +7486,7 @@
           <p:cNvPr id="6" name="Rectangle: Rounded Corners 5">
             <a:extLst>
               <a:ext uri="{FF2B5EF4-FFF2-40B4-BE49-F238E27FC236}">
-                <a16:creationId xmlns:a16="http://schemas.microsoft.com/office/drawing/2014/main" id="{910C27D3-A746-4B6F-B69E-EBB852870954}"/>
+                <a16:creationId xmlns:a16="http://schemas.microsoft.com/office/drawing/2014/main" id="{E5AFBC04-278C-4A4C-A01E-D4031AED0815}"/>
               </a:ext>
             </a:extLst>
           </p:cNvPr>
@@ -7519,7 +7519,7 @@
           <p:cNvPr id="7" name="Oval 6">
             <a:extLst>
               <a:ext uri="{FF2B5EF4-FFF2-40B4-BE49-F238E27FC236}">
-                <a16:creationId xmlns:a16="http://schemas.microsoft.com/office/drawing/2014/main" id="{62057308-6F58-4068-B359-C0D9824BA39B}"/>
+                <a16:creationId xmlns:a16="http://schemas.microsoft.com/office/drawing/2014/main" id="{BF09A862-3F94-4429-8F72-A0B31D1D7975}"/>
               </a:ext>
             </a:extLst>
           </p:cNvPr>
@@ -7550,7 +7550,7 @@
           <p:cNvPr id="8" name="Rectangle 7">
             <a:extLst>
               <a:ext uri="{FF2B5EF4-FFF2-40B4-BE49-F238E27FC236}">
-                <a16:creationId xmlns:a16="http://schemas.microsoft.com/office/drawing/2014/main" id="{9A249D15-23B2-40D7-973B-D935898F1EDE}"/>
+                <a16:creationId xmlns:a16="http://schemas.microsoft.com/office/drawing/2014/main" id="{3DA853EC-D2AF-4AD6-8E82-3CA4658D5E9A}"/>
               </a:ext>
             </a:extLst>
           </p:cNvPr>
@@ -7612,7 +7612,7 @@
           <p:cNvPr id="9" name="Rectangle: Rounded Corners 8">
             <a:extLst>
               <a:ext uri="{FF2B5EF4-FFF2-40B4-BE49-F238E27FC236}">
-                <a16:creationId xmlns:a16="http://schemas.microsoft.com/office/drawing/2014/main" id="{9CBF298D-11F9-46D2-ABA0-70DBF8ED5B37}"/>
+                <a16:creationId xmlns:a16="http://schemas.microsoft.com/office/drawing/2014/main" id="{9572FEE2-6CA0-460C-8595-C295B22663FA}"/>
               </a:ext>
             </a:extLst>
           </p:cNvPr>
@@ -7647,7 +7647,7 @@
           <p:cNvPr id="10" name="Rectangle 9">
             <a:extLst>
               <a:ext uri="{FF2B5EF4-FFF2-40B4-BE49-F238E27FC236}">
-                <a16:creationId xmlns:a16="http://schemas.microsoft.com/office/drawing/2014/main" id="{223C48D6-DCA1-41F6-87EE-4DE98171636F}"/>
+                <a16:creationId xmlns:a16="http://schemas.microsoft.com/office/drawing/2014/main" id="{8FB5E323-A1B2-467F-B15C-EFED34597003}"/>
               </a:ext>
             </a:extLst>
           </p:cNvPr>
@@ -7709,7 +7709,7 @@
           <p:cNvPr id="11" name="Oval 10">
             <a:extLst>
               <a:ext uri="{FF2B5EF4-FFF2-40B4-BE49-F238E27FC236}">
-                <a16:creationId xmlns:a16="http://schemas.microsoft.com/office/drawing/2014/main" id="{27DFA09E-83F1-4322-B750-C99B1B2BF4B4}"/>
+                <a16:creationId xmlns:a16="http://schemas.microsoft.com/office/drawing/2014/main" id="{12654BC6-B35E-4C3B-A5B5-0AF8AA94E550}"/>
               </a:ext>
             </a:extLst>
           </p:cNvPr>
@@ -7740,7 +7740,7 @@
           <p:cNvPr id="12" name="Rectangle 11">
             <a:extLst>
               <a:ext uri="{FF2B5EF4-FFF2-40B4-BE49-F238E27FC236}">
-                <a16:creationId xmlns:a16="http://schemas.microsoft.com/office/drawing/2014/main" id="{DA5FC74B-D023-4F7D-896D-3EA235BA375C}"/>
+                <a16:creationId xmlns:a16="http://schemas.microsoft.com/office/drawing/2014/main" id="{D961317A-BA60-4537-8A63-4C27A0673CF1}"/>
               </a:ext>
             </a:extLst>
           </p:cNvPr>
@@ -7802,7 +7802,7 @@
           <p:cNvPr id="13" name="Rectangle: Rounded Corners 12">
             <a:extLst>
               <a:ext uri="{FF2B5EF4-FFF2-40B4-BE49-F238E27FC236}">
-                <a16:creationId xmlns:a16="http://schemas.microsoft.com/office/drawing/2014/main" id="{0B296806-BDCE-4B6A-A87D-ED220EBB2090}"/>
+                <a16:creationId xmlns:a16="http://schemas.microsoft.com/office/drawing/2014/main" id="{409D5BF6-3562-4502-BB69-37768DA5E3CF}"/>
               </a:ext>
             </a:extLst>
           </p:cNvPr>
@@ -7837,7 +7837,7 @@
           <p:cNvPr id="14" name="Rectangle 13">
             <a:extLst>
               <a:ext uri="{FF2B5EF4-FFF2-40B4-BE49-F238E27FC236}">
-                <a16:creationId xmlns:a16="http://schemas.microsoft.com/office/drawing/2014/main" id="{70B465E3-284A-4B0D-A270-3E9EB02FA63B}"/>
+                <a16:creationId xmlns:a16="http://schemas.microsoft.com/office/drawing/2014/main" id="{FE12F624-E08B-4633-91A8-EF58ABB66BCA}"/>
               </a:ext>
             </a:extLst>
           </p:cNvPr>
@@ -7899,7 +7899,7 @@
           <p:cNvPr id="15" name="Oval 14">
             <a:extLst>
               <a:ext uri="{FF2B5EF4-FFF2-40B4-BE49-F238E27FC236}">
-                <a16:creationId xmlns:a16="http://schemas.microsoft.com/office/drawing/2014/main" id="{9A8BFFCB-FC5E-4BE8-8D26-7872EBFD9CA0}"/>
+                <a16:creationId xmlns:a16="http://schemas.microsoft.com/office/drawing/2014/main" id="{41C3EAA8-6BB2-4DBA-8822-DC7D721E4F05}"/>
               </a:ext>
             </a:extLst>
           </p:cNvPr>
@@ -7930,7 +7930,7 @@
           <p:cNvPr id="16" name="Rectangle 15">
             <a:extLst>
               <a:ext uri="{FF2B5EF4-FFF2-40B4-BE49-F238E27FC236}">
-                <a16:creationId xmlns:a16="http://schemas.microsoft.com/office/drawing/2014/main" id="{EE2FCF2B-362D-49B7-86A7-8736EC962E6B}"/>
+                <a16:creationId xmlns:a16="http://schemas.microsoft.com/office/drawing/2014/main" id="{9F255CB1-1B4C-47EC-95D6-4C0B48468CF0}"/>
               </a:ext>
             </a:extLst>
           </p:cNvPr>
@@ -7992,7 +7992,7 @@
           <p:cNvPr id="17" name="Rectangle: Rounded Corners 16">
             <a:extLst>
               <a:ext uri="{FF2B5EF4-FFF2-40B4-BE49-F238E27FC236}">
-                <a16:creationId xmlns:a16="http://schemas.microsoft.com/office/drawing/2014/main" id="{958159D9-0A52-44CF-A4AC-7B44F835F851}"/>
+                <a16:creationId xmlns:a16="http://schemas.microsoft.com/office/drawing/2014/main" id="{9222D8E0-C6FA-4E41-89AD-D582954FC3A1}"/>
               </a:ext>
             </a:extLst>
           </p:cNvPr>
@@ -8027,7 +8027,7 @@
           <p:cNvPr id="18" name="Rectangle 17">
             <a:extLst>
               <a:ext uri="{FF2B5EF4-FFF2-40B4-BE49-F238E27FC236}">
-                <a16:creationId xmlns:a16="http://schemas.microsoft.com/office/drawing/2014/main" id="{A6B78516-C38D-4669-9145-A321A28DCA4F}"/>
+                <a16:creationId xmlns:a16="http://schemas.microsoft.com/office/drawing/2014/main" id="{C0622880-E841-4618-8C47-AD08CF791E13}"/>
               </a:ext>
             </a:extLst>
           </p:cNvPr>
@@ -8089,7 +8089,7 @@
           <p:cNvPr id="19" name="Rectangle 18">
             <a:extLst>
               <a:ext uri="{FF2B5EF4-FFF2-40B4-BE49-F238E27FC236}">
-                <a16:creationId xmlns:a16="http://schemas.microsoft.com/office/drawing/2014/main" id="{A6AF09C0-9D59-40A7-8B93-8B88E71B41A3}"/>
+                <a16:creationId xmlns:a16="http://schemas.microsoft.com/office/drawing/2014/main" id="{F6A3B23C-0786-4CB5-A5CC-C6CD98B829F2}"/>
               </a:ext>
             </a:extLst>
           </p:cNvPr>
@@ -8120,7 +8120,7 @@
           <p:cNvPr id="20" name="Rectangle 19">
             <a:extLst>
               <a:ext uri="{FF2B5EF4-FFF2-40B4-BE49-F238E27FC236}">
-                <a16:creationId xmlns:a16="http://schemas.microsoft.com/office/drawing/2014/main" id="{A1A2F9C6-EED8-4114-81AF-F244ED49BF29}"/>
+                <a16:creationId xmlns:a16="http://schemas.microsoft.com/office/drawing/2014/main" id="{A2E797D1-93F5-4E73-AC2C-6863445DBCCA}"/>
               </a:ext>
             </a:extLst>
           </p:cNvPr>
@@ -8172,7 +8172,7 @@
                 <a:ea typeface="Arial"/>
                 <a:cs typeface="Arial"/>
               </a:rPr>
-              <a:t>r2z-d4c8d4cc709a · scn-e0f12f397e · prt-fd6de9d793</a:t>
+              <a:t>r2z-a7181752a17d · scn-e0f12f397e · prt-fd6de9d793</a:t>
             </a:r>
           </a:p>
         </p:txBody>
@@ -8182,7 +8182,7 @@
           <p:cNvPr id="21" name="Rectangle 20">
             <a:extLst>
               <a:ext uri="{FF2B5EF4-FFF2-40B4-BE49-F238E27FC236}">
-                <a16:creationId xmlns:a16="http://schemas.microsoft.com/office/drawing/2014/main" id="{B5C39E03-B341-483E-91B7-5ECC82BA6B79}"/>
+                <a16:creationId xmlns:a16="http://schemas.microsoft.com/office/drawing/2014/main" id="{E91DFA65-B3BF-452A-869C-966AE48FE9BE}"/>
               </a:ext>
             </a:extLst>
           </p:cNvPr>
@@ -8242,7 +8242,7 @@
     </p:spTree>
     <p:extLst>
       <p:ext uri="{BB962C8B-B14F-4D97-AF65-F5344CB8AC3E}">
-        <p14:creationId xmlns:p14="http://schemas.microsoft.com/office/powerpoint/2010/main" val="1665897545"/>
+        <p14:creationId xmlns:p14="http://schemas.microsoft.com/office/powerpoint/2010/main" val="567371025"/>
       </p:ext>
     </p:extLst>
   </p:cSld>
@@ -8283,7 +8283,7 @@
             <a:hlinkClick r:id="rId3"/>
             <a:extLst>
               <a:ext uri="{FF2B5EF4-FFF2-40B4-BE49-F238E27FC236}">
-                <a16:creationId xmlns:a16="http://schemas.microsoft.com/office/drawing/2014/main" id="{47853F5E-EA51-4F5D-A2AC-DE69A4EF387D}"/>
+                <a16:creationId xmlns:a16="http://schemas.microsoft.com/office/drawing/2014/main" id="{A84AD618-144C-42DA-ACA3-7CD0A6E61853}"/>
               </a:ext>
             </a:extLst>
           </p:cNvPr>
@@ -8358,7 +8358,7 @@
             <a:hlinkClick r:id="rId4"/>
             <a:extLst>
               <a:ext uri="{FF2B5EF4-FFF2-40B4-BE49-F238E27FC236}">
-                <a16:creationId xmlns:a16="http://schemas.microsoft.com/office/drawing/2014/main" id="{47C11889-C538-4377-97F8-D3BE5C00C1C4}"/>
+                <a16:creationId xmlns:a16="http://schemas.microsoft.com/office/drawing/2014/main" id="{A17186A3-2D6E-4313-9B19-18AE27372C0C}"/>
               </a:ext>
             </a:extLst>
           </p:cNvPr>
@@ -8432,7 +8432,7 @@
           <p:cNvPr id="3" name="Rectangle 2">
             <a:extLst>
               <a:ext uri="{FF2B5EF4-FFF2-40B4-BE49-F238E27FC236}">
-                <a16:creationId xmlns:a16="http://schemas.microsoft.com/office/drawing/2014/main" id="{0D80CCE6-C7B9-4E00-B492-9B5EAC0BB1A8}"/>
+                <a16:creationId xmlns:a16="http://schemas.microsoft.com/office/drawing/2014/main" id="{1DE28029-82DF-458E-A6F3-F0B058D72D17}"/>
               </a:ext>
             </a:extLst>
           </p:cNvPr>
@@ -8494,7 +8494,7 @@
           <p:cNvPr id="4" name="Rectangle 3">
             <a:extLst>
               <a:ext uri="{FF2B5EF4-FFF2-40B4-BE49-F238E27FC236}">
-                <a16:creationId xmlns:a16="http://schemas.microsoft.com/office/drawing/2014/main" id="{5757271C-73A7-463C-8734-C4B027E09676}"/>
+                <a16:creationId xmlns:a16="http://schemas.microsoft.com/office/drawing/2014/main" id="{1067BE1C-2DBA-4865-93FC-E4021286D1A9}"/>
               </a:ext>
             </a:extLst>
           </p:cNvPr>
@@ -8583,7 +8583,7 @@
           <p:cNvPr id="6" name="Rectangle: Rounded Corners 5">
             <a:extLst>
               <a:ext uri="{FF2B5EF4-FFF2-40B4-BE49-F238E27FC236}">
-                <a16:creationId xmlns:a16="http://schemas.microsoft.com/office/drawing/2014/main" id="{E914C5BB-A147-4B59-88AB-F2DB1924AFF6}"/>
+                <a16:creationId xmlns:a16="http://schemas.microsoft.com/office/drawing/2014/main" id="{698E724B-E012-432D-BACB-E38B78594391}"/>
               </a:ext>
             </a:extLst>
           </p:cNvPr>
@@ -8616,7 +8616,7 @@
           <p:cNvPr id="7" name="Oval 6">
             <a:extLst>
               <a:ext uri="{FF2B5EF4-FFF2-40B4-BE49-F238E27FC236}">
-                <a16:creationId xmlns:a16="http://schemas.microsoft.com/office/drawing/2014/main" id="{94B734CE-AD73-4041-9DBC-B676229F460E}"/>
+                <a16:creationId xmlns:a16="http://schemas.microsoft.com/office/drawing/2014/main" id="{82C16EB7-84A3-4D77-918B-85F2CF13269B}"/>
               </a:ext>
             </a:extLst>
           </p:cNvPr>
@@ -8647,7 +8647,7 @@
           <p:cNvPr id="8" name="Rectangle 7">
             <a:extLst>
               <a:ext uri="{FF2B5EF4-FFF2-40B4-BE49-F238E27FC236}">
-                <a16:creationId xmlns:a16="http://schemas.microsoft.com/office/drawing/2014/main" id="{B1C4CB62-14E3-4981-82BC-1A0F75E88233}"/>
+                <a16:creationId xmlns:a16="http://schemas.microsoft.com/office/drawing/2014/main" id="{8E6FECA8-C0BE-4907-8655-0D894121962A}"/>
               </a:ext>
             </a:extLst>
           </p:cNvPr>
@@ -8709,7 +8709,7 @@
           <p:cNvPr id="9" name="Rectangle: Rounded Corners 8">
             <a:extLst>
               <a:ext uri="{FF2B5EF4-FFF2-40B4-BE49-F238E27FC236}">
-                <a16:creationId xmlns:a16="http://schemas.microsoft.com/office/drawing/2014/main" id="{A8D84D8D-C7D8-4EFE-A9CD-79CB27BC04F5}"/>
+                <a16:creationId xmlns:a16="http://schemas.microsoft.com/office/drawing/2014/main" id="{E50FCBCD-0741-4F5E-8C1F-90C4F589FBA2}"/>
               </a:ext>
             </a:extLst>
           </p:cNvPr>
@@ -8744,7 +8744,7 @@
           <p:cNvPr id="10" name="Rectangle 9">
             <a:extLst>
               <a:ext uri="{FF2B5EF4-FFF2-40B4-BE49-F238E27FC236}">
-                <a16:creationId xmlns:a16="http://schemas.microsoft.com/office/drawing/2014/main" id="{8CC9638E-77DB-4511-B0D2-8B84CF6668D6}"/>
+                <a16:creationId xmlns:a16="http://schemas.microsoft.com/office/drawing/2014/main" id="{10B9B4EC-D817-4DF9-9CBC-DD7C0F0432AC}"/>
               </a:ext>
             </a:extLst>
           </p:cNvPr>
@@ -8806,7 +8806,7 @@
           <p:cNvPr id="11" name="Oval 10">
             <a:extLst>
               <a:ext uri="{FF2B5EF4-FFF2-40B4-BE49-F238E27FC236}">
-                <a16:creationId xmlns:a16="http://schemas.microsoft.com/office/drawing/2014/main" id="{C891CF3A-0A81-4CB3-9D99-D6CB2F91C168}"/>
+                <a16:creationId xmlns:a16="http://schemas.microsoft.com/office/drawing/2014/main" id="{66F61874-6B7F-4994-89CA-D055619A324A}"/>
               </a:ext>
             </a:extLst>
           </p:cNvPr>
@@ -8837,7 +8837,7 @@
           <p:cNvPr id="12" name="Rectangle 11">
             <a:extLst>
               <a:ext uri="{FF2B5EF4-FFF2-40B4-BE49-F238E27FC236}">
-                <a16:creationId xmlns:a16="http://schemas.microsoft.com/office/drawing/2014/main" id="{2A950D2F-8A1D-4FC7-A658-79B9B12798AF}"/>
+                <a16:creationId xmlns:a16="http://schemas.microsoft.com/office/drawing/2014/main" id="{E72F10CF-3F15-4E0E-867D-5C3ACF72C6A4}"/>
               </a:ext>
             </a:extLst>
           </p:cNvPr>
@@ -8899,7 +8899,7 @@
           <p:cNvPr id="13" name="Rectangle: Rounded Corners 12">
             <a:extLst>
               <a:ext uri="{FF2B5EF4-FFF2-40B4-BE49-F238E27FC236}">
-                <a16:creationId xmlns:a16="http://schemas.microsoft.com/office/drawing/2014/main" id="{FB59B21B-77A3-4545-85B7-43D76A1D2047}"/>
+                <a16:creationId xmlns:a16="http://schemas.microsoft.com/office/drawing/2014/main" id="{C87DC077-4D5D-4835-9042-DF178989687B}"/>
               </a:ext>
             </a:extLst>
           </p:cNvPr>
@@ -8934,7 +8934,7 @@
           <p:cNvPr id="14" name="Rectangle 13">
             <a:extLst>
               <a:ext uri="{FF2B5EF4-FFF2-40B4-BE49-F238E27FC236}">
-                <a16:creationId xmlns:a16="http://schemas.microsoft.com/office/drawing/2014/main" id="{978E4BFA-B5F8-4B4B-B31B-303BC94CD753}"/>
+                <a16:creationId xmlns:a16="http://schemas.microsoft.com/office/drawing/2014/main" id="{11F3C959-EEDE-4BF7-8770-7B15FE5D40A6}"/>
               </a:ext>
             </a:extLst>
           </p:cNvPr>
@@ -8996,7 +8996,7 @@
           <p:cNvPr id="15" name="Oval 14">
             <a:extLst>
               <a:ext uri="{FF2B5EF4-FFF2-40B4-BE49-F238E27FC236}">
-                <a16:creationId xmlns:a16="http://schemas.microsoft.com/office/drawing/2014/main" id="{83A14F1D-A74A-4F9D-ADAC-46D2A1DC4B36}"/>
+                <a16:creationId xmlns:a16="http://schemas.microsoft.com/office/drawing/2014/main" id="{A508E0EB-C9EA-42BC-A6F9-8B8337339CD6}"/>
               </a:ext>
             </a:extLst>
           </p:cNvPr>
@@ -9027,7 +9027,7 @@
           <p:cNvPr id="16" name="Rectangle 15">
             <a:extLst>
               <a:ext uri="{FF2B5EF4-FFF2-40B4-BE49-F238E27FC236}">
-                <a16:creationId xmlns:a16="http://schemas.microsoft.com/office/drawing/2014/main" id="{A3E7942E-399B-4656-8487-B3198E919195}"/>
+                <a16:creationId xmlns:a16="http://schemas.microsoft.com/office/drawing/2014/main" id="{4BE6024C-0A5D-4162-8BFA-9EF82626AA48}"/>
               </a:ext>
             </a:extLst>
           </p:cNvPr>
@@ -9089,7 +9089,7 @@
           <p:cNvPr id="17" name="Rectangle: Rounded Corners 16">
             <a:extLst>
               <a:ext uri="{FF2B5EF4-FFF2-40B4-BE49-F238E27FC236}">
-                <a16:creationId xmlns:a16="http://schemas.microsoft.com/office/drawing/2014/main" id="{332C1188-2CC2-4DF9-8982-249DE2118C39}"/>
+                <a16:creationId xmlns:a16="http://schemas.microsoft.com/office/drawing/2014/main" id="{D3D2C091-214A-4874-91A1-A269278EDA10}"/>
               </a:ext>
             </a:extLst>
           </p:cNvPr>
@@ -9124,7 +9124,7 @@
           <p:cNvPr id="18" name="Rectangle 17">
             <a:extLst>
               <a:ext uri="{FF2B5EF4-FFF2-40B4-BE49-F238E27FC236}">
-                <a16:creationId xmlns:a16="http://schemas.microsoft.com/office/drawing/2014/main" id="{8BE1041F-7C8E-4C0D-AA50-5D52E0D536C4}"/>
+                <a16:creationId xmlns:a16="http://schemas.microsoft.com/office/drawing/2014/main" id="{96F115ED-3620-4564-8173-485CC6A856DF}"/>
               </a:ext>
             </a:extLst>
           </p:cNvPr>
@@ -9186,7 +9186,7 @@
           <p:cNvPr id="19" name="Rectangle 18">
             <a:extLst>
               <a:ext uri="{FF2B5EF4-FFF2-40B4-BE49-F238E27FC236}">
-                <a16:creationId xmlns:a16="http://schemas.microsoft.com/office/drawing/2014/main" id="{F08F3E63-B774-46FC-912B-FB21391E7312}"/>
+                <a16:creationId xmlns:a16="http://schemas.microsoft.com/office/drawing/2014/main" id="{B05FF79B-9BBA-4B3A-A9C5-64BF388CE0AD}"/>
               </a:ext>
             </a:extLst>
           </p:cNvPr>
@@ -9217,7 +9217,7 @@
           <p:cNvPr id="20" name="Rectangle 19">
             <a:extLst>
               <a:ext uri="{FF2B5EF4-FFF2-40B4-BE49-F238E27FC236}">
-                <a16:creationId xmlns:a16="http://schemas.microsoft.com/office/drawing/2014/main" id="{8BB729B0-F728-4500-B25E-03656DB1F426}"/>
+                <a16:creationId xmlns:a16="http://schemas.microsoft.com/office/drawing/2014/main" id="{EAE3DA58-C8CB-4984-A678-375856DC460E}"/>
               </a:ext>
             </a:extLst>
           </p:cNvPr>
@@ -9269,7 +9269,7 @@
                 <a:ea typeface="Arial"/>
                 <a:cs typeface="Arial"/>
               </a:rPr>
-              <a:t>r2z-d4c8d4cc709a · scn-e0f12f397e · prt-fd6de9d793</a:t>
+              <a:t>r2z-a7181752a17d · scn-e0f12f397e · prt-fd6de9d793</a:t>
             </a:r>
           </a:p>
         </p:txBody>
@@ -9279,7 +9279,7 @@
           <p:cNvPr id="21" name="Rectangle 20">
             <a:extLst>
               <a:ext uri="{FF2B5EF4-FFF2-40B4-BE49-F238E27FC236}">
-                <a16:creationId xmlns:a16="http://schemas.microsoft.com/office/drawing/2014/main" id="{F3E7709E-72AD-469B-B90E-01A94F2B9B47}"/>
+                <a16:creationId xmlns:a16="http://schemas.microsoft.com/office/drawing/2014/main" id="{9CF5B123-E87E-4448-8580-1492863FD79B}"/>
               </a:ext>
             </a:extLst>
           </p:cNvPr>
@@ -9339,7 +9339,7 @@
     </p:spTree>
     <p:extLst>
       <p:ext uri="{BB962C8B-B14F-4D97-AF65-F5344CB8AC3E}">
-        <p14:creationId xmlns:p14="http://schemas.microsoft.com/office/powerpoint/2010/main" val="1295295518"/>
+        <p14:creationId xmlns:p14="http://schemas.microsoft.com/office/powerpoint/2010/main" val="1160488634"/>
       </p:ext>
     </p:extLst>
   </p:cSld>
@@ -9380,7 +9380,7 @@
             <a:hlinkClick r:id="rId3"/>
             <a:extLst>
               <a:ext uri="{FF2B5EF4-FFF2-40B4-BE49-F238E27FC236}">
-                <a16:creationId xmlns:a16="http://schemas.microsoft.com/office/drawing/2014/main" id="{D75CAAE8-845E-4235-98BC-4885965A967A}"/>
+                <a16:creationId xmlns:a16="http://schemas.microsoft.com/office/drawing/2014/main" id="{E98306C6-4611-4749-8DA3-99DA27AED4E1}"/>
               </a:ext>
             </a:extLst>
           </p:cNvPr>
@@ -9455,7 +9455,7 @@
             <a:hlinkClick r:id="rId4"/>
             <a:extLst>
               <a:ext uri="{FF2B5EF4-FFF2-40B4-BE49-F238E27FC236}">
-                <a16:creationId xmlns:a16="http://schemas.microsoft.com/office/drawing/2014/main" id="{8587582E-786A-45B7-BC40-92C25DA83E5C}"/>
+                <a16:creationId xmlns:a16="http://schemas.microsoft.com/office/drawing/2014/main" id="{2F91A9A5-2B1C-4084-967F-26293B61B326}"/>
               </a:ext>
             </a:extLst>
           </p:cNvPr>
@@ -9529,7 +9529,7 @@
           <p:cNvPr id="3" name="Rectangle 2">
             <a:extLst>
               <a:ext uri="{FF2B5EF4-FFF2-40B4-BE49-F238E27FC236}">
-                <a16:creationId xmlns:a16="http://schemas.microsoft.com/office/drawing/2014/main" id="{14F599C1-1AAC-41A5-BA4F-EDF2D29EB928}"/>
+                <a16:creationId xmlns:a16="http://schemas.microsoft.com/office/drawing/2014/main" id="{C71EA69A-2D92-4283-8D42-937FBAAEDBFA}"/>
               </a:ext>
             </a:extLst>
           </p:cNvPr>
@@ -9591,7 +9591,7 @@
           <p:cNvPr id="4" name="Rectangle 3">
             <a:extLst>
               <a:ext uri="{FF2B5EF4-FFF2-40B4-BE49-F238E27FC236}">
-                <a16:creationId xmlns:a16="http://schemas.microsoft.com/office/drawing/2014/main" id="{65C0D65F-87CC-4B65-8C88-0AEDC44CC6B0}"/>
+                <a16:creationId xmlns:a16="http://schemas.microsoft.com/office/drawing/2014/main" id="{5B480C06-27B0-4E07-90EC-C8816BC500F1}"/>
               </a:ext>
             </a:extLst>
           </p:cNvPr>
@@ -9680,7 +9680,7 @@
           <p:cNvPr id="6" name="Rectangle: Rounded Corners 5">
             <a:extLst>
               <a:ext uri="{FF2B5EF4-FFF2-40B4-BE49-F238E27FC236}">
-                <a16:creationId xmlns:a16="http://schemas.microsoft.com/office/drawing/2014/main" id="{7711E1A5-224D-49AF-96BA-F5ACD97B4EC1}"/>
+                <a16:creationId xmlns:a16="http://schemas.microsoft.com/office/drawing/2014/main" id="{7DA30EBE-8FA1-4AAF-823A-00BCE48C73FA}"/>
               </a:ext>
             </a:extLst>
           </p:cNvPr>
@@ -9713,7 +9713,7 @@
           <p:cNvPr id="7" name="Oval 6">
             <a:extLst>
               <a:ext uri="{FF2B5EF4-FFF2-40B4-BE49-F238E27FC236}">
-                <a16:creationId xmlns:a16="http://schemas.microsoft.com/office/drawing/2014/main" id="{CBD770F6-4788-47EA-81F1-DADC12C2B728}"/>
+                <a16:creationId xmlns:a16="http://schemas.microsoft.com/office/drawing/2014/main" id="{46487E3E-6748-47C0-8327-1F755447D487}"/>
               </a:ext>
             </a:extLst>
           </p:cNvPr>
@@ -9744,7 +9744,7 @@
           <p:cNvPr id="8" name="Rectangle 7">
             <a:extLst>
               <a:ext uri="{FF2B5EF4-FFF2-40B4-BE49-F238E27FC236}">
-                <a16:creationId xmlns:a16="http://schemas.microsoft.com/office/drawing/2014/main" id="{A2B05C49-224A-43B0-8384-E736B109321E}"/>
+                <a16:creationId xmlns:a16="http://schemas.microsoft.com/office/drawing/2014/main" id="{ECF9B0DA-4BA8-4320-8489-F162864167E0}"/>
               </a:ext>
             </a:extLst>
           </p:cNvPr>
@@ -9806,7 +9806,7 @@
           <p:cNvPr id="9" name="Rectangle: Rounded Corners 8">
             <a:extLst>
               <a:ext uri="{FF2B5EF4-FFF2-40B4-BE49-F238E27FC236}">
-                <a16:creationId xmlns:a16="http://schemas.microsoft.com/office/drawing/2014/main" id="{2819E1ED-A25D-4EB9-AF35-55CFF79E0511}"/>
+                <a16:creationId xmlns:a16="http://schemas.microsoft.com/office/drawing/2014/main" id="{775696DB-14EB-4559-89A1-69EBF50CFA0B}"/>
               </a:ext>
             </a:extLst>
           </p:cNvPr>
@@ -9841,7 +9841,7 @@
           <p:cNvPr id="10" name="Rectangle 9">
             <a:extLst>
               <a:ext uri="{FF2B5EF4-FFF2-40B4-BE49-F238E27FC236}">
-                <a16:creationId xmlns:a16="http://schemas.microsoft.com/office/drawing/2014/main" id="{5A0861EB-1382-463B-B93A-C1BDCE8EB251}"/>
+                <a16:creationId xmlns:a16="http://schemas.microsoft.com/office/drawing/2014/main" id="{2576AB35-8CE8-404D-9553-6E25C4090AAD}"/>
               </a:ext>
             </a:extLst>
           </p:cNvPr>
@@ -9903,7 +9903,7 @@
           <p:cNvPr id="11" name="Oval 10">
             <a:extLst>
               <a:ext uri="{FF2B5EF4-FFF2-40B4-BE49-F238E27FC236}">
-                <a16:creationId xmlns:a16="http://schemas.microsoft.com/office/drawing/2014/main" id="{F5E7FFCB-4D67-4D4A-8E9B-933B81B14B53}"/>
+                <a16:creationId xmlns:a16="http://schemas.microsoft.com/office/drawing/2014/main" id="{689ED3CC-3E3B-4D71-9A7A-B45D11CE0E05}"/>
               </a:ext>
             </a:extLst>
           </p:cNvPr>
@@ -9934,7 +9934,7 @@
           <p:cNvPr id="12" name="Rectangle 11">
             <a:extLst>
               <a:ext uri="{FF2B5EF4-FFF2-40B4-BE49-F238E27FC236}">
-                <a16:creationId xmlns:a16="http://schemas.microsoft.com/office/drawing/2014/main" id="{42536664-D7E8-4716-AD1B-87EC73A9033D}"/>
+                <a16:creationId xmlns:a16="http://schemas.microsoft.com/office/drawing/2014/main" id="{AB668E32-C947-4D96-84EA-E5084EA76F85}"/>
               </a:ext>
             </a:extLst>
           </p:cNvPr>
@@ -9996,7 +9996,7 @@
           <p:cNvPr id="13" name="Rectangle: Rounded Corners 12">
             <a:extLst>
               <a:ext uri="{FF2B5EF4-FFF2-40B4-BE49-F238E27FC236}">
-                <a16:creationId xmlns:a16="http://schemas.microsoft.com/office/drawing/2014/main" id="{E65D8B24-48D7-4DDC-AE63-D5F150EA2314}"/>
+                <a16:creationId xmlns:a16="http://schemas.microsoft.com/office/drawing/2014/main" id="{A921DC83-5BBC-46BC-8DAB-5A1BF1A83103}"/>
               </a:ext>
             </a:extLst>
           </p:cNvPr>
@@ -10031,7 +10031,7 @@
           <p:cNvPr id="14" name="Rectangle 13">
             <a:extLst>
               <a:ext uri="{FF2B5EF4-FFF2-40B4-BE49-F238E27FC236}">
-                <a16:creationId xmlns:a16="http://schemas.microsoft.com/office/drawing/2014/main" id="{2C5C1E4B-140B-4A70-AAA5-50F6FC42DD1E}"/>
+                <a16:creationId xmlns:a16="http://schemas.microsoft.com/office/drawing/2014/main" id="{8E502610-48FA-4BBC-8E24-B3D3558C06AB}"/>
               </a:ext>
             </a:extLst>
           </p:cNvPr>
@@ -10093,7 +10093,7 @@
           <p:cNvPr id="15" name="Oval 14">
             <a:extLst>
               <a:ext uri="{FF2B5EF4-FFF2-40B4-BE49-F238E27FC236}">
-                <a16:creationId xmlns:a16="http://schemas.microsoft.com/office/drawing/2014/main" id="{3B2EB6E6-3CB5-4023-A8C4-58A847A1F792}"/>
+                <a16:creationId xmlns:a16="http://schemas.microsoft.com/office/drawing/2014/main" id="{5BA75019-22DF-4EE1-89BD-B572E172C03C}"/>
               </a:ext>
             </a:extLst>
           </p:cNvPr>
@@ -10124,7 +10124,7 @@
           <p:cNvPr id="16" name="Rectangle 15">
             <a:extLst>
               <a:ext uri="{FF2B5EF4-FFF2-40B4-BE49-F238E27FC236}">
-                <a16:creationId xmlns:a16="http://schemas.microsoft.com/office/drawing/2014/main" id="{4FD6FFD0-9539-4E0D-807C-B891578A7B80}"/>
+                <a16:creationId xmlns:a16="http://schemas.microsoft.com/office/drawing/2014/main" id="{087DA251-3878-4729-859D-E1819A1180F5}"/>
               </a:ext>
             </a:extLst>
           </p:cNvPr>
@@ -10186,7 +10186,7 @@
           <p:cNvPr id="17" name="Rectangle: Rounded Corners 16">
             <a:extLst>
               <a:ext uri="{FF2B5EF4-FFF2-40B4-BE49-F238E27FC236}">
-                <a16:creationId xmlns:a16="http://schemas.microsoft.com/office/drawing/2014/main" id="{E44EFBD1-0107-40F0-8128-2673EADC5359}"/>
+                <a16:creationId xmlns:a16="http://schemas.microsoft.com/office/drawing/2014/main" id="{E6A4AA7D-30DF-4CAC-9B6B-AE6A8693FFC1}"/>
               </a:ext>
             </a:extLst>
           </p:cNvPr>
@@ -10221,7 +10221,7 @@
           <p:cNvPr id="18" name="Rectangle 17">
             <a:extLst>
               <a:ext uri="{FF2B5EF4-FFF2-40B4-BE49-F238E27FC236}">
-                <a16:creationId xmlns:a16="http://schemas.microsoft.com/office/drawing/2014/main" id="{79FFD718-0164-44D6-AE1D-4BE3D01CDF6D}"/>
+                <a16:creationId xmlns:a16="http://schemas.microsoft.com/office/drawing/2014/main" id="{F9C2B21F-1207-4422-AA6C-4281174C75ED}"/>
               </a:ext>
             </a:extLst>
           </p:cNvPr>
@@ -10283,7 +10283,7 @@
           <p:cNvPr id="19" name="Rectangle 18">
             <a:extLst>
               <a:ext uri="{FF2B5EF4-FFF2-40B4-BE49-F238E27FC236}">
-                <a16:creationId xmlns:a16="http://schemas.microsoft.com/office/drawing/2014/main" id="{784FE03B-2644-4189-9BB8-5EE549C203D2}"/>
+                <a16:creationId xmlns:a16="http://schemas.microsoft.com/office/drawing/2014/main" id="{2F57FE58-294A-4A1D-BDC8-3672196BFC35}"/>
               </a:ext>
             </a:extLst>
           </p:cNvPr>
@@ -10314,7 +10314,7 @@
           <p:cNvPr id="20" name="Rectangle 19">
             <a:extLst>
               <a:ext uri="{FF2B5EF4-FFF2-40B4-BE49-F238E27FC236}">
-                <a16:creationId xmlns:a16="http://schemas.microsoft.com/office/drawing/2014/main" id="{206AFC67-900A-44C7-BACD-D7DAF718C944}"/>
+                <a16:creationId xmlns:a16="http://schemas.microsoft.com/office/drawing/2014/main" id="{D71EE1C8-483B-4491-B3A4-298594EA6892}"/>
               </a:ext>
             </a:extLst>
           </p:cNvPr>
@@ -10366,7 +10366,7 @@
                 <a:ea typeface="Arial"/>
                 <a:cs typeface="Arial"/>
               </a:rPr>
-              <a:t>r2z-d4c8d4cc709a · scn-e0f12f397e · prt-fd6de9d793</a:t>
+              <a:t>r2z-a7181752a17d · scn-e0f12f397e · prt-fd6de9d793</a:t>
             </a:r>
           </a:p>
         </p:txBody>
@@ -10376,7 +10376,7 @@
           <p:cNvPr id="21" name="Rectangle 20">
             <a:extLst>
               <a:ext uri="{FF2B5EF4-FFF2-40B4-BE49-F238E27FC236}">
-                <a16:creationId xmlns:a16="http://schemas.microsoft.com/office/drawing/2014/main" id="{EC87AAC3-7F8C-4071-8341-6597242834AE}"/>
+                <a16:creationId xmlns:a16="http://schemas.microsoft.com/office/drawing/2014/main" id="{EA4250B3-E3F8-472E-AC34-28B1C743120B}"/>
               </a:ext>
             </a:extLst>
           </p:cNvPr>
@@ -10436,7 +10436,7 @@
     </p:spTree>
     <p:extLst>
       <p:ext uri="{BB962C8B-B14F-4D97-AF65-F5344CB8AC3E}">
-        <p14:creationId xmlns:p14="http://schemas.microsoft.com/office/powerpoint/2010/main" val="323909242"/>
+        <p14:creationId xmlns:p14="http://schemas.microsoft.com/office/powerpoint/2010/main" val="1813067280"/>
       </p:ext>
     </p:extLst>
   </p:cSld>
@@ -10477,7 +10477,7 @@
             <a:hlinkClick r:id="rId3"/>
             <a:extLst>
               <a:ext uri="{FF2B5EF4-FFF2-40B4-BE49-F238E27FC236}">
-                <a16:creationId xmlns:a16="http://schemas.microsoft.com/office/drawing/2014/main" id="{BA0D5680-7E89-4352-8C04-64C11CEC4BB8}"/>
+                <a16:creationId xmlns:a16="http://schemas.microsoft.com/office/drawing/2014/main" id="{F4017751-9031-4D0D-A54F-0C484AD2162E}"/>
               </a:ext>
             </a:extLst>
           </p:cNvPr>
@@ -10552,7 +10552,7 @@
             <a:hlinkClick r:id="rId4"/>
             <a:extLst>
               <a:ext uri="{FF2B5EF4-FFF2-40B4-BE49-F238E27FC236}">
-                <a16:creationId xmlns:a16="http://schemas.microsoft.com/office/drawing/2014/main" id="{747C0F4F-C365-4777-B864-DE315E633721}"/>
+                <a16:creationId xmlns:a16="http://schemas.microsoft.com/office/drawing/2014/main" id="{33390E86-6CBC-463F-8C91-1554365DA257}"/>
               </a:ext>
             </a:extLst>
           </p:cNvPr>
@@ -10626,7 +10626,7 @@
           <p:cNvPr id="3" name="Rectangle 2">
             <a:extLst>
               <a:ext uri="{FF2B5EF4-FFF2-40B4-BE49-F238E27FC236}">
-                <a16:creationId xmlns:a16="http://schemas.microsoft.com/office/drawing/2014/main" id="{3C3376D0-D267-4113-A9A9-8C427F90FEE5}"/>
+                <a16:creationId xmlns:a16="http://schemas.microsoft.com/office/drawing/2014/main" id="{9BB68474-712F-49D2-8A22-BB1C4C633575}"/>
               </a:ext>
             </a:extLst>
           </p:cNvPr>
@@ -10678,7 +10678,7 @@
                 <a:ea typeface="Arial"/>
                 <a:cs typeface="Arial"/>
               </a:rPr>
-              <a:t>OPTIMIZED RESULT</a:t>
+              <a:t>CONSTRAINED RESULT</a:t>
             </a:r>
           </a:p>
         </p:txBody>
@@ -10688,7 +10688,7 @@
           <p:cNvPr id="4" name="Rectangle 3">
             <a:extLst>
               <a:ext uri="{FF2B5EF4-FFF2-40B4-BE49-F238E27FC236}">
-                <a16:creationId xmlns:a16="http://schemas.microsoft.com/office/drawing/2014/main" id="{E2C6E94F-3648-4F6E-9A30-7A05C6DCA02B}"/>
+                <a16:creationId xmlns:a16="http://schemas.microsoft.com/office/drawing/2014/main" id="{6B3C6A32-D9FB-4057-9C37-74A8B25E003F}"/>
               </a:ext>
             </a:extLst>
           </p:cNvPr>
@@ -10740,7 +10740,7 @@
                 <a:ea typeface="Arial"/>
                 <a:cs typeface="Arial"/>
               </a:rPr>
-              <a:t>The optimized portfolio is not simply the top eight routes.</a:t>
+              <a:t>The constrained portfolio is not simply the top eight routes.</a:t>
             </a:r>
           </a:p>
         </p:txBody>
@@ -10777,7 +10777,7 @@
           <p:cNvPr id="6" name="Rectangle: Rounded Corners 5">
             <a:extLst>
               <a:ext uri="{FF2B5EF4-FFF2-40B4-BE49-F238E27FC236}">
-                <a16:creationId xmlns:a16="http://schemas.microsoft.com/office/drawing/2014/main" id="{089DA5B6-DC69-40E6-B3AE-F8A5E32C4D2F}"/>
+                <a16:creationId xmlns:a16="http://schemas.microsoft.com/office/drawing/2014/main" id="{5A8B652F-4DB6-492B-8158-B892FBA88152}"/>
               </a:ext>
             </a:extLst>
           </p:cNvPr>
@@ -10810,7 +10810,7 @@
           <p:cNvPr id="7" name="Oval 6">
             <a:extLst>
               <a:ext uri="{FF2B5EF4-FFF2-40B4-BE49-F238E27FC236}">
-                <a16:creationId xmlns:a16="http://schemas.microsoft.com/office/drawing/2014/main" id="{A8DE1B61-6D94-4C6F-9523-D428143B40AC}"/>
+                <a16:creationId xmlns:a16="http://schemas.microsoft.com/office/drawing/2014/main" id="{0F4F3CE7-AFC0-401E-8480-D4A25874FC90}"/>
               </a:ext>
             </a:extLst>
           </p:cNvPr>
@@ -10841,7 +10841,7 @@
           <p:cNvPr id="8" name="Rectangle 7">
             <a:extLst>
               <a:ext uri="{FF2B5EF4-FFF2-40B4-BE49-F238E27FC236}">
-                <a16:creationId xmlns:a16="http://schemas.microsoft.com/office/drawing/2014/main" id="{9E3C0449-9F5F-4142-9FE4-955B084234EF}"/>
+                <a16:creationId xmlns:a16="http://schemas.microsoft.com/office/drawing/2014/main" id="{EBA34DE4-B4CA-4771-8287-B7A21C29CDBD}"/>
               </a:ext>
             </a:extLst>
           </p:cNvPr>
@@ -10903,7 +10903,7 @@
           <p:cNvPr id="9" name="Rectangle: Rounded Corners 8">
             <a:extLst>
               <a:ext uri="{FF2B5EF4-FFF2-40B4-BE49-F238E27FC236}">
-                <a16:creationId xmlns:a16="http://schemas.microsoft.com/office/drawing/2014/main" id="{93743600-A73E-463B-ACB4-0DF3BD15D0CB}"/>
+                <a16:creationId xmlns:a16="http://schemas.microsoft.com/office/drawing/2014/main" id="{D5B09EB2-8B6E-4575-BA1B-FB09B817D87B}"/>
               </a:ext>
             </a:extLst>
           </p:cNvPr>
@@ -10938,7 +10938,7 @@
           <p:cNvPr id="10" name="Rectangle 9">
             <a:extLst>
               <a:ext uri="{FF2B5EF4-FFF2-40B4-BE49-F238E27FC236}">
-                <a16:creationId xmlns:a16="http://schemas.microsoft.com/office/drawing/2014/main" id="{243A3C42-E7F7-475B-9506-42905A5C475E}"/>
+                <a16:creationId xmlns:a16="http://schemas.microsoft.com/office/drawing/2014/main" id="{0A003D06-5AF4-4865-99B1-C26DEEEF7AC1}"/>
               </a:ext>
             </a:extLst>
           </p:cNvPr>
@@ -11000,7 +11000,7 @@
           <p:cNvPr id="11" name="Oval 10">
             <a:extLst>
               <a:ext uri="{FF2B5EF4-FFF2-40B4-BE49-F238E27FC236}">
-                <a16:creationId xmlns:a16="http://schemas.microsoft.com/office/drawing/2014/main" id="{CB1DFB33-BCDC-4863-8460-3C328985ABB0}"/>
+                <a16:creationId xmlns:a16="http://schemas.microsoft.com/office/drawing/2014/main" id="{21D13BAD-67C8-404D-8E33-B5CEB5B677B3}"/>
               </a:ext>
             </a:extLst>
           </p:cNvPr>
@@ -11031,7 +11031,7 @@
           <p:cNvPr id="12" name="Rectangle 11">
             <a:extLst>
               <a:ext uri="{FF2B5EF4-FFF2-40B4-BE49-F238E27FC236}">
-                <a16:creationId xmlns:a16="http://schemas.microsoft.com/office/drawing/2014/main" id="{1A1BC7D9-CB6A-4182-A709-9EB3C7E6FBD0}"/>
+                <a16:creationId xmlns:a16="http://schemas.microsoft.com/office/drawing/2014/main" id="{0FF48764-D93B-4431-99F5-9C833684D109}"/>
               </a:ext>
             </a:extLst>
           </p:cNvPr>
@@ -11093,7 +11093,7 @@
           <p:cNvPr id="13" name="Rectangle: Rounded Corners 12">
             <a:extLst>
               <a:ext uri="{FF2B5EF4-FFF2-40B4-BE49-F238E27FC236}">
-                <a16:creationId xmlns:a16="http://schemas.microsoft.com/office/drawing/2014/main" id="{D2F8A8FA-A6EF-48BB-B4C6-1C5685803855}"/>
+                <a16:creationId xmlns:a16="http://schemas.microsoft.com/office/drawing/2014/main" id="{73A58167-D111-4CB0-A663-9CCE6C7E228C}"/>
               </a:ext>
             </a:extLst>
           </p:cNvPr>
@@ -11128,7 +11128,7 @@
           <p:cNvPr id="14" name="Rectangle 13">
             <a:extLst>
               <a:ext uri="{FF2B5EF4-FFF2-40B4-BE49-F238E27FC236}">
-                <a16:creationId xmlns:a16="http://schemas.microsoft.com/office/drawing/2014/main" id="{E8C9A394-C066-4F01-AD5B-B0C59047492E}"/>
+                <a16:creationId xmlns:a16="http://schemas.microsoft.com/office/drawing/2014/main" id="{2F89CA1A-5F9C-4748-8A12-82D7ACA9DB5C}"/>
               </a:ext>
             </a:extLst>
           </p:cNvPr>
@@ -11190,7 +11190,7 @@
           <p:cNvPr id="15" name="Oval 14">
             <a:extLst>
               <a:ext uri="{FF2B5EF4-FFF2-40B4-BE49-F238E27FC236}">
-                <a16:creationId xmlns:a16="http://schemas.microsoft.com/office/drawing/2014/main" id="{B3949C80-F304-4739-8A47-8A24AC5DD828}"/>
+                <a16:creationId xmlns:a16="http://schemas.microsoft.com/office/drawing/2014/main" id="{EC2D2483-D963-4896-BA03-F0D5181F4C56}"/>
               </a:ext>
             </a:extLst>
           </p:cNvPr>
@@ -11221,7 +11221,7 @@
           <p:cNvPr id="16" name="Rectangle 15">
             <a:extLst>
               <a:ext uri="{FF2B5EF4-FFF2-40B4-BE49-F238E27FC236}">
-                <a16:creationId xmlns:a16="http://schemas.microsoft.com/office/drawing/2014/main" id="{BCD13074-58A6-4727-8061-1C6922BDCE5D}"/>
+                <a16:creationId xmlns:a16="http://schemas.microsoft.com/office/drawing/2014/main" id="{BC6252A6-50E8-4973-A2AC-28242D2B5C48}"/>
               </a:ext>
             </a:extLst>
           </p:cNvPr>
@@ -11283,7 +11283,7 @@
           <p:cNvPr id="17" name="Rectangle: Rounded Corners 16">
             <a:extLst>
               <a:ext uri="{FF2B5EF4-FFF2-40B4-BE49-F238E27FC236}">
-                <a16:creationId xmlns:a16="http://schemas.microsoft.com/office/drawing/2014/main" id="{744D5D16-43CC-48B4-B8CC-75288B9C7E4C}"/>
+                <a16:creationId xmlns:a16="http://schemas.microsoft.com/office/drawing/2014/main" id="{C9F6E139-1684-4EDE-8C4F-EC44712CC83A}"/>
               </a:ext>
             </a:extLst>
           </p:cNvPr>
@@ -11318,7 +11318,7 @@
           <p:cNvPr id="18" name="Rectangle 17">
             <a:extLst>
               <a:ext uri="{FF2B5EF4-FFF2-40B4-BE49-F238E27FC236}">
-                <a16:creationId xmlns:a16="http://schemas.microsoft.com/office/drawing/2014/main" id="{8747D22B-D3DB-4EEC-A758-DF0EB9B8E1F8}"/>
+                <a16:creationId xmlns:a16="http://schemas.microsoft.com/office/drawing/2014/main" id="{7B50C306-D2FA-4440-8B89-524021E59B4E}"/>
               </a:ext>
             </a:extLst>
           </p:cNvPr>
@@ -11380,7 +11380,7 @@
           <p:cNvPr id="19" name="Rectangle 18">
             <a:extLst>
               <a:ext uri="{FF2B5EF4-FFF2-40B4-BE49-F238E27FC236}">
-                <a16:creationId xmlns:a16="http://schemas.microsoft.com/office/drawing/2014/main" id="{6CF1FA4A-6AA2-4FDF-AF0D-0021F37B0B55}"/>
+                <a16:creationId xmlns:a16="http://schemas.microsoft.com/office/drawing/2014/main" id="{E678A96F-D572-4D5A-85F7-083A32E9712A}"/>
               </a:ext>
             </a:extLst>
           </p:cNvPr>
@@ -11411,7 +11411,7 @@
           <p:cNvPr id="20" name="Rectangle 19">
             <a:extLst>
               <a:ext uri="{FF2B5EF4-FFF2-40B4-BE49-F238E27FC236}">
-                <a16:creationId xmlns:a16="http://schemas.microsoft.com/office/drawing/2014/main" id="{A67397D1-4D50-43BF-A75D-45BC51B53E1A}"/>
+                <a16:creationId xmlns:a16="http://schemas.microsoft.com/office/drawing/2014/main" id="{A5DEB390-FC17-4CFE-AA2B-3BF6352D88E5}"/>
               </a:ext>
             </a:extLst>
           </p:cNvPr>
@@ -11463,7 +11463,7 @@
                 <a:ea typeface="Arial"/>
                 <a:cs typeface="Arial"/>
               </a:rPr>
-              <a:t>r2z-d4c8d4cc709a · scn-e0f12f397e · prt-fd6de9d793</a:t>
+              <a:t>r2z-a7181752a17d · scn-e0f12f397e · prt-fd6de9d793</a:t>
             </a:r>
           </a:p>
         </p:txBody>
@@ -11473,7 +11473,7 @@
           <p:cNvPr id="21" name="Rectangle 20">
             <a:extLst>
               <a:ext uri="{FF2B5EF4-FFF2-40B4-BE49-F238E27FC236}">
-                <a16:creationId xmlns:a16="http://schemas.microsoft.com/office/drawing/2014/main" id="{6DA486B0-F1D6-4A7B-9E19-3DE8F0DF7CD0}"/>
+                <a16:creationId xmlns:a16="http://schemas.microsoft.com/office/drawing/2014/main" id="{ABB23E0F-CD23-4DFD-A5EA-5AA896AEC5EE}"/>
               </a:ext>
             </a:extLst>
           </p:cNvPr>
@@ -11533,7 +11533,7 @@
     </p:spTree>
     <p:extLst>
       <p:ext uri="{BB962C8B-B14F-4D97-AF65-F5344CB8AC3E}">
-        <p14:creationId xmlns:p14="http://schemas.microsoft.com/office/powerpoint/2010/main" val="1190942000"/>
+        <p14:creationId xmlns:p14="http://schemas.microsoft.com/office/powerpoint/2010/main" val="1692016538"/>
       </p:ext>
     </p:extLst>
   </p:cSld>
@@ -11574,7 +11574,7 @@
             <a:hlinkClick r:id="rId3"/>
             <a:extLst>
               <a:ext uri="{FF2B5EF4-FFF2-40B4-BE49-F238E27FC236}">
-                <a16:creationId xmlns:a16="http://schemas.microsoft.com/office/drawing/2014/main" id="{0E7D5B14-25DB-4381-A27B-5437F28235FD}"/>
+                <a16:creationId xmlns:a16="http://schemas.microsoft.com/office/drawing/2014/main" id="{BFC1F2EC-4250-4314-9240-EB143A4DBDFF}"/>
               </a:ext>
             </a:extLst>
           </p:cNvPr>
@@ -11649,7 +11649,7 @@
             <a:hlinkClick r:id="rId4"/>
             <a:extLst>
               <a:ext uri="{FF2B5EF4-FFF2-40B4-BE49-F238E27FC236}">
-                <a16:creationId xmlns:a16="http://schemas.microsoft.com/office/drawing/2014/main" id="{05B47CCF-879F-45EC-A6B6-BE607DFDD05E}"/>
+                <a16:creationId xmlns:a16="http://schemas.microsoft.com/office/drawing/2014/main" id="{F166CA96-81A4-461A-842E-EED7EB80729F}"/>
               </a:ext>
             </a:extLst>
           </p:cNvPr>
@@ -11723,7 +11723,7 @@
           <p:cNvPr id="3" name="Rectangle 2">
             <a:extLst>
               <a:ext uri="{FF2B5EF4-FFF2-40B4-BE49-F238E27FC236}">
-                <a16:creationId xmlns:a16="http://schemas.microsoft.com/office/drawing/2014/main" id="{A6B4EED8-8C87-4B92-BABF-A67602D1B984}"/>
+                <a16:creationId xmlns:a16="http://schemas.microsoft.com/office/drawing/2014/main" id="{CB2A0787-2912-4123-98FD-502FE935BE85}"/>
               </a:ext>
             </a:extLst>
           </p:cNvPr>
@@ -11785,7 +11785,7 @@
           <p:cNvPr id="4" name="Rectangle 3">
             <a:extLst>
               <a:ext uri="{FF2B5EF4-FFF2-40B4-BE49-F238E27FC236}">
-                <a16:creationId xmlns:a16="http://schemas.microsoft.com/office/drawing/2014/main" id="{5231B501-3B22-483D-B736-C448979A3814}"/>
+                <a16:creationId xmlns:a16="http://schemas.microsoft.com/office/drawing/2014/main" id="{E7F3AFF3-D71D-41D3-BEE8-5534F0903CF0}"/>
               </a:ext>
             </a:extLst>
           </p:cNvPr>
@@ -11874,7 +11874,7 @@
           <p:cNvPr id="6" name="Rectangle: Rounded Corners 5">
             <a:extLst>
               <a:ext uri="{FF2B5EF4-FFF2-40B4-BE49-F238E27FC236}">
-                <a16:creationId xmlns:a16="http://schemas.microsoft.com/office/drawing/2014/main" id="{1B6C3F70-A670-4632-A123-29A16CD09A99}"/>
+                <a16:creationId xmlns:a16="http://schemas.microsoft.com/office/drawing/2014/main" id="{C1D8E55A-FF59-4499-99E0-365BD6E7AC5F}"/>
               </a:ext>
             </a:extLst>
           </p:cNvPr>
@@ -11907,7 +11907,7 @@
           <p:cNvPr id="7" name="Oval 6">
             <a:extLst>
               <a:ext uri="{FF2B5EF4-FFF2-40B4-BE49-F238E27FC236}">
-                <a16:creationId xmlns:a16="http://schemas.microsoft.com/office/drawing/2014/main" id="{A101E30D-9225-4376-A85C-EA23B3035D0F}"/>
+                <a16:creationId xmlns:a16="http://schemas.microsoft.com/office/drawing/2014/main" id="{DC861761-8B76-434E-B4DD-C2AEE0527E0B}"/>
               </a:ext>
             </a:extLst>
           </p:cNvPr>
@@ -11938,7 +11938,7 @@
           <p:cNvPr id="8" name="Rectangle 7">
             <a:extLst>
               <a:ext uri="{FF2B5EF4-FFF2-40B4-BE49-F238E27FC236}">
-                <a16:creationId xmlns:a16="http://schemas.microsoft.com/office/drawing/2014/main" id="{ABA5F203-1DCA-4BF4-BE28-1830FD55EE5A}"/>
+                <a16:creationId xmlns:a16="http://schemas.microsoft.com/office/drawing/2014/main" id="{264FD981-86F0-48EC-B4D9-57623F304F00}"/>
               </a:ext>
             </a:extLst>
           </p:cNvPr>
@@ -12000,7 +12000,7 @@
           <p:cNvPr id="9" name="Rectangle: Rounded Corners 8">
             <a:extLst>
               <a:ext uri="{FF2B5EF4-FFF2-40B4-BE49-F238E27FC236}">
-                <a16:creationId xmlns:a16="http://schemas.microsoft.com/office/drawing/2014/main" id="{6D0504DC-4843-42BE-89A5-F21B40DC77F9}"/>
+                <a16:creationId xmlns:a16="http://schemas.microsoft.com/office/drawing/2014/main" id="{747A679A-5344-4EAB-80D4-41CCF50ECA6E}"/>
               </a:ext>
             </a:extLst>
           </p:cNvPr>
@@ -12035,7 +12035,7 @@
           <p:cNvPr id="10" name="Rectangle 9">
             <a:extLst>
               <a:ext uri="{FF2B5EF4-FFF2-40B4-BE49-F238E27FC236}">
-                <a16:creationId xmlns:a16="http://schemas.microsoft.com/office/drawing/2014/main" id="{43526787-A678-4C80-92BA-9B7E3D456AE3}"/>
+                <a16:creationId xmlns:a16="http://schemas.microsoft.com/office/drawing/2014/main" id="{A4C974C3-C5C9-49C3-A967-E774AAD40D72}"/>
               </a:ext>
             </a:extLst>
           </p:cNvPr>
@@ -12097,7 +12097,7 @@
           <p:cNvPr id="11" name="Oval 10">
             <a:extLst>
               <a:ext uri="{FF2B5EF4-FFF2-40B4-BE49-F238E27FC236}">
-                <a16:creationId xmlns:a16="http://schemas.microsoft.com/office/drawing/2014/main" id="{4DD4094D-36EC-4C83-AB0D-944809549EAD}"/>
+                <a16:creationId xmlns:a16="http://schemas.microsoft.com/office/drawing/2014/main" id="{C33E3336-33AB-46A9-8CBC-C22199CDA529}"/>
               </a:ext>
             </a:extLst>
           </p:cNvPr>
@@ -12128,7 +12128,7 @@
           <p:cNvPr id="12" name="Rectangle 11">
             <a:extLst>
               <a:ext uri="{FF2B5EF4-FFF2-40B4-BE49-F238E27FC236}">
-                <a16:creationId xmlns:a16="http://schemas.microsoft.com/office/drawing/2014/main" id="{00A1C11F-8DCC-4F2F-999A-7965CD93DCFD}"/>
+                <a16:creationId xmlns:a16="http://schemas.microsoft.com/office/drawing/2014/main" id="{657209CD-7603-4F61-9A72-565BB7F54420}"/>
               </a:ext>
             </a:extLst>
           </p:cNvPr>
@@ -12190,7 +12190,7 @@
           <p:cNvPr id="13" name="Rectangle: Rounded Corners 12">
             <a:extLst>
               <a:ext uri="{FF2B5EF4-FFF2-40B4-BE49-F238E27FC236}">
-                <a16:creationId xmlns:a16="http://schemas.microsoft.com/office/drawing/2014/main" id="{F7F23701-362B-4B54-93AC-0810E76E8A78}"/>
+                <a16:creationId xmlns:a16="http://schemas.microsoft.com/office/drawing/2014/main" id="{890C577E-1FDB-41AB-B77D-767B3B54284D}"/>
               </a:ext>
             </a:extLst>
           </p:cNvPr>
@@ -12225,7 +12225,7 @@
           <p:cNvPr id="14" name="Rectangle 13">
             <a:extLst>
               <a:ext uri="{FF2B5EF4-FFF2-40B4-BE49-F238E27FC236}">
-                <a16:creationId xmlns:a16="http://schemas.microsoft.com/office/drawing/2014/main" id="{D569314D-6C5C-470E-A3B5-50AB208A6FDF}"/>
+                <a16:creationId xmlns:a16="http://schemas.microsoft.com/office/drawing/2014/main" id="{AD4393AF-942F-4C17-BA02-0A4A3D8E0E01}"/>
               </a:ext>
             </a:extLst>
           </p:cNvPr>
@@ -12287,7 +12287,7 @@
           <p:cNvPr id="15" name="Oval 14">
             <a:extLst>
               <a:ext uri="{FF2B5EF4-FFF2-40B4-BE49-F238E27FC236}">
-                <a16:creationId xmlns:a16="http://schemas.microsoft.com/office/drawing/2014/main" id="{0D09138B-7C3E-4F8C-8283-32E608227776}"/>
+                <a16:creationId xmlns:a16="http://schemas.microsoft.com/office/drawing/2014/main" id="{93494F3B-DA78-4039-9046-8B6A0A94B821}"/>
               </a:ext>
             </a:extLst>
           </p:cNvPr>
@@ -12318,7 +12318,7 @@
           <p:cNvPr id="16" name="Rectangle 15">
             <a:extLst>
               <a:ext uri="{FF2B5EF4-FFF2-40B4-BE49-F238E27FC236}">
-                <a16:creationId xmlns:a16="http://schemas.microsoft.com/office/drawing/2014/main" id="{8C6E70B6-0FF7-424C-A95A-BD7EBEE640DE}"/>
+                <a16:creationId xmlns:a16="http://schemas.microsoft.com/office/drawing/2014/main" id="{18E64C0C-2592-4722-AA6A-C9EECF9DFC5C}"/>
               </a:ext>
             </a:extLst>
           </p:cNvPr>
@@ -12380,7 +12380,7 @@
           <p:cNvPr id="17" name="Rectangle: Rounded Corners 16">
             <a:extLst>
               <a:ext uri="{FF2B5EF4-FFF2-40B4-BE49-F238E27FC236}">
-                <a16:creationId xmlns:a16="http://schemas.microsoft.com/office/drawing/2014/main" id="{80F15D90-25DD-4D36-9FF3-00968A91AB58}"/>
+                <a16:creationId xmlns:a16="http://schemas.microsoft.com/office/drawing/2014/main" id="{2421CE48-B85F-4903-855B-75C695D44F63}"/>
               </a:ext>
             </a:extLst>
           </p:cNvPr>
@@ -12415,7 +12415,7 @@
           <p:cNvPr id="18" name="Rectangle 17">
             <a:extLst>
               <a:ext uri="{FF2B5EF4-FFF2-40B4-BE49-F238E27FC236}">
-                <a16:creationId xmlns:a16="http://schemas.microsoft.com/office/drawing/2014/main" id="{89AB816F-440C-42CF-9632-E819C7942FF5}"/>
+                <a16:creationId xmlns:a16="http://schemas.microsoft.com/office/drawing/2014/main" id="{CCBE15C6-39C7-4F20-8AD4-9953DFD127D3}"/>
               </a:ext>
             </a:extLst>
           </p:cNvPr>
@@ -12477,7 +12477,7 @@
           <p:cNvPr id="19" name="Rectangle 18">
             <a:extLst>
               <a:ext uri="{FF2B5EF4-FFF2-40B4-BE49-F238E27FC236}">
-                <a16:creationId xmlns:a16="http://schemas.microsoft.com/office/drawing/2014/main" id="{602749FC-3C9D-4C00-95C6-35CD83BA2CB2}"/>
+                <a16:creationId xmlns:a16="http://schemas.microsoft.com/office/drawing/2014/main" id="{8FEB9E8C-3DC1-475A-9700-6C6830733DA7}"/>
               </a:ext>
             </a:extLst>
           </p:cNvPr>
@@ -12508,7 +12508,7 @@
           <p:cNvPr id="20" name="Rectangle 19">
             <a:extLst>
               <a:ext uri="{FF2B5EF4-FFF2-40B4-BE49-F238E27FC236}">
-                <a16:creationId xmlns:a16="http://schemas.microsoft.com/office/drawing/2014/main" id="{65FF7AD0-B2BD-492F-8144-69E127466E74}"/>
+                <a16:creationId xmlns:a16="http://schemas.microsoft.com/office/drawing/2014/main" id="{87BDBF13-4CBA-4E3A-A393-714511BD1633}"/>
               </a:ext>
             </a:extLst>
           </p:cNvPr>
@@ -12560,7 +12560,7 @@
                 <a:ea typeface="Arial"/>
                 <a:cs typeface="Arial"/>
               </a:rPr>
-              <a:t>r2z-d4c8d4cc709a · scn-e0f12f397e · prt-fd6de9d793</a:t>
+              <a:t>r2z-a7181752a17d · scn-e0f12f397e · prt-fd6de9d793</a:t>
             </a:r>
           </a:p>
         </p:txBody>
@@ -12570,7 +12570,7 @@
           <p:cNvPr id="21" name="Rectangle 20">
             <a:extLst>
               <a:ext uri="{FF2B5EF4-FFF2-40B4-BE49-F238E27FC236}">
-                <a16:creationId xmlns:a16="http://schemas.microsoft.com/office/drawing/2014/main" id="{BFCA8CE7-68A1-4178-973B-37B857B2F1F9}"/>
+                <a16:creationId xmlns:a16="http://schemas.microsoft.com/office/drawing/2014/main" id="{200B4DFD-2C9A-4FB8-A2E5-EC55424ECB36}"/>
               </a:ext>
             </a:extLst>
           </p:cNvPr>
@@ -12630,7 +12630,7 @@
     </p:spTree>
     <p:extLst>
       <p:ext uri="{BB962C8B-B14F-4D97-AF65-F5344CB8AC3E}">
-        <p14:creationId xmlns:p14="http://schemas.microsoft.com/office/powerpoint/2010/main" val="186251965"/>
+        <p14:creationId xmlns:p14="http://schemas.microsoft.com/office/powerpoint/2010/main" val="1821183943"/>
       </p:ext>
     </p:extLst>
   </p:cSld>
@@ -12671,7 +12671,7 @@
             <a:hlinkClick r:id="rId3"/>
             <a:extLst>
               <a:ext uri="{FF2B5EF4-FFF2-40B4-BE49-F238E27FC236}">
-                <a16:creationId xmlns:a16="http://schemas.microsoft.com/office/drawing/2014/main" id="{C8E0CC9D-51FD-485B-828B-51091D1CEDFD}"/>
+                <a16:creationId xmlns:a16="http://schemas.microsoft.com/office/drawing/2014/main" id="{37A8C7FE-DD3B-4DB5-9FAB-787BE605FEC0}"/>
               </a:ext>
             </a:extLst>
           </p:cNvPr>
@@ -12746,7 +12746,7 @@
             <a:hlinkClick r:id="rId4"/>
             <a:extLst>
               <a:ext uri="{FF2B5EF4-FFF2-40B4-BE49-F238E27FC236}">
-                <a16:creationId xmlns:a16="http://schemas.microsoft.com/office/drawing/2014/main" id="{C27B4274-F798-4852-9322-3121E506F245}"/>
+                <a16:creationId xmlns:a16="http://schemas.microsoft.com/office/drawing/2014/main" id="{F91A5BE8-5D67-484E-9F57-FCAF6A715ACB}"/>
               </a:ext>
             </a:extLst>
           </p:cNvPr>
@@ -12820,7 +12820,7 @@
           <p:cNvPr id="3" name="Rectangle 2">
             <a:extLst>
               <a:ext uri="{FF2B5EF4-FFF2-40B4-BE49-F238E27FC236}">
-                <a16:creationId xmlns:a16="http://schemas.microsoft.com/office/drawing/2014/main" id="{76E8BEE2-6CD5-4457-9D16-15CCFE6FD160}"/>
+                <a16:creationId xmlns:a16="http://schemas.microsoft.com/office/drawing/2014/main" id="{7FC4D5FB-6FF6-4707-96F4-D5E10C073549}"/>
               </a:ext>
             </a:extLst>
           </p:cNvPr>
@@ -12882,7 +12882,7 @@
           <p:cNvPr id="4" name="Rectangle 3">
             <a:extLst>
               <a:ext uri="{FF2B5EF4-FFF2-40B4-BE49-F238E27FC236}">
-                <a16:creationId xmlns:a16="http://schemas.microsoft.com/office/drawing/2014/main" id="{774DE99B-1C17-4D16-AE41-A44C7BCC64C3}"/>
+                <a16:creationId xmlns:a16="http://schemas.microsoft.com/office/drawing/2014/main" id="{E4200596-585C-4D1E-93C5-D901457AADEA}"/>
               </a:ext>
             </a:extLst>
           </p:cNvPr>
@@ -12971,7 +12971,7 @@
           <p:cNvPr id="6" name="Rectangle: Rounded Corners 5">
             <a:extLst>
               <a:ext uri="{FF2B5EF4-FFF2-40B4-BE49-F238E27FC236}">
-                <a16:creationId xmlns:a16="http://schemas.microsoft.com/office/drawing/2014/main" id="{008940CC-98BC-4699-804D-56399C4D3D80}"/>
+                <a16:creationId xmlns:a16="http://schemas.microsoft.com/office/drawing/2014/main" id="{B7B93B09-ECB3-4B16-82F3-468BE79F95F5}"/>
               </a:ext>
             </a:extLst>
           </p:cNvPr>
@@ -13004,7 +13004,7 @@
           <p:cNvPr id="7" name="Rectangle 6">
             <a:extLst>
               <a:ext uri="{FF2B5EF4-FFF2-40B4-BE49-F238E27FC236}">
-                <a16:creationId xmlns:a16="http://schemas.microsoft.com/office/drawing/2014/main" id="{9BDB8225-1605-49A0-9F5B-B7D173047B19}"/>
+                <a16:creationId xmlns:a16="http://schemas.microsoft.com/office/drawing/2014/main" id="{6BAC45D4-0F37-408C-95A4-F1B59B099D48}"/>
               </a:ext>
             </a:extLst>
           </p:cNvPr>
@@ -13066,7 +13066,7 @@
           <p:cNvPr id="8" name="Rectangle 7">
             <a:extLst>
               <a:ext uri="{FF2B5EF4-FFF2-40B4-BE49-F238E27FC236}">
-                <a16:creationId xmlns:a16="http://schemas.microsoft.com/office/drawing/2014/main" id="{20B85D1E-23E9-4778-AB02-70F388634C2D}"/>
+                <a16:creationId xmlns:a16="http://schemas.microsoft.com/office/drawing/2014/main" id="{D6240FE8-827F-4F0C-A78D-7E743EBB747B}"/>
               </a:ext>
             </a:extLst>
           </p:cNvPr>
@@ -13118,7 +13118,7 @@
                 <a:ea typeface="Arial"/>
                 <a:cs typeface="Arial"/>
               </a:rPr>
-              <a:t>r2z-d4c8d4cc709a</a:t>
+              <a:t>r2z-a7181752a17d</a:t>
             </a:r>
           </a:p>
         </p:txBody>
@@ -13128,7 +13128,7 @@
           <p:cNvPr id="9" name="Rectangle 8">
             <a:extLst>
               <a:ext uri="{FF2B5EF4-FFF2-40B4-BE49-F238E27FC236}">
-                <a16:creationId xmlns:a16="http://schemas.microsoft.com/office/drawing/2014/main" id="{A6BD7281-04FC-4270-9B3F-BAEBE9AAF899}"/>
+                <a16:creationId xmlns:a16="http://schemas.microsoft.com/office/drawing/2014/main" id="{AB86C431-7431-4003-9819-C9B28FA6D399}"/>
               </a:ext>
             </a:extLst>
           </p:cNvPr>
@@ -13159,7 +13159,7 @@
           <p:cNvPr id="10" name="Rectangle 9">
             <a:extLst>
               <a:ext uri="{FF2B5EF4-FFF2-40B4-BE49-F238E27FC236}">
-                <a16:creationId xmlns:a16="http://schemas.microsoft.com/office/drawing/2014/main" id="{1473A129-8542-47C8-9038-BCF90C5CDDCF}"/>
+                <a16:creationId xmlns:a16="http://schemas.microsoft.com/office/drawing/2014/main" id="{013A37E1-C286-4520-AC37-26CFC5D38E35}"/>
               </a:ext>
             </a:extLst>
           </p:cNvPr>
@@ -13221,7 +13221,7 @@
           <p:cNvPr id="11" name="Rectangle 10">
             <a:extLst>
               <a:ext uri="{FF2B5EF4-FFF2-40B4-BE49-F238E27FC236}">
-                <a16:creationId xmlns:a16="http://schemas.microsoft.com/office/drawing/2014/main" id="{E79CB2CD-1DD0-4E96-813C-E61EF1935A1D}"/>
+                <a16:creationId xmlns:a16="http://schemas.microsoft.com/office/drawing/2014/main" id="{84788F21-35EB-43F6-8475-EB4DFF282FFE}"/>
               </a:ext>
             </a:extLst>
           </p:cNvPr>
@@ -13283,7 +13283,7 @@
           <p:cNvPr id="12" name="Rectangle 11">
             <a:extLst>
               <a:ext uri="{FF2B5EF4-FFF2-40B4-BE49-F238E27FC236}">
-                <a16:creationId xmlns:a16="http://schemas.microsoft.com/office/drawing/2014/main" id="{0A957F65-35C8-4CDB-AEF3-E80DB835F5DE}"/>
+                <a16:creationId xmlns:a16="http://schemas.microsoft.com/office/drawing/2014/main" id="{85ED0063-DBA6-4533-BA49-584B7A86DD0C}"/>
               </a:ext>
             </a:extLst>
           </p:cNvPr>
@@ -13314,7 +13314,7 @@
           <p:cNvPr id="13" name="Rectangle 12">
             <a:extLst>
               <a:ext uri="{FF2B5EF4-FFF2-40B4-BE49-F238E27FC236}">
-                <a16:creationId xmlns:a16="http://schemas.microsoft.com/office/drawing/2014/main" id="{D788BB2E-0623-4600-BEBE-28EBA4884E54}"/>
+                <a16:creationId xmlns:a16="http://schemas.microsoft.com/office/drawing/2014/main" id="{62125295-3061-48EF-B654-381881C66413}"/>
               </a:ext>
             </a:extLst>
           </p:cNvPr>
@@ -13376,7 +13376,7 @@
           <p:cNvPr id="14" name="Rectangle 13">
             <a:extLst>
               <a:ext uri="{FF2B5EF4-FFF2-40B4-BE49-F238E27FC236}">
-                <a16:creationId xmlns:a16="http://schemas.microsoft.com/office/drawing/2014/main" id="{20C6D06C-D715-4F82-85C3-F3BD6C3C9434}"/>
+                <a16:creationId xmlns:a16="http://schemas.microsoft.com/office/drawing/2014/main" id="{1FF958A9-DA6C-400E-BC5A-0874BB22DF66}"/>
               </a:ext>
             </a:extLst>
           </p:cNvPr>
@@ -13438,7 +13438,7 @@
           <p:cNvPr id="15" name="Rectangle 14">
             <a:extLst>
               <a:ext uri="{FF2B5EF4-FFF2-40B4-BE49-F238E27FC236}">
-                <a16:creationId xmlns:a16="http://schemas.microsoft.com/office/drawing/2014/main" id="{0AA9106F-AFEB-405E-879A-06CF9C9E4E89}"/>
+                <a16:creationId xmlns:a16="http://schemas.microsoft.com/office/drawing/2014/main" id="{753FBC7E-2CBC-4398-AD7F-8A37C3695987}"/>
               </a:ext>
             </a:extLst>
           </p:cNvPr>
@@ -13469,7 +13469,7 @@
           <p:cNvPr id="16" name="Rectangle 15">
             <a:extLst>
               <a:ext uri="{FF2B5EF4-FFF2-40B4-BE49-F238E27FC236}">
-                <a16:creationId xmlns:a16="http://schemas.microsoft.com/office/drawing/2014/main" id="{A0C8EE31-2962-4512-AF0D-355E02666B93}"/>
+                <a16:creationId xmlns:a16="http://schemas.microsoft.com/office/drawing/2014/main" id="{741D5484-7FAB-4493-9179-8906DD0204FE}"/>
               </a:ext>
             </a:extLst>
           </p:cNvPr>
@@ -13531,7 +13531,7 @@
           <p:cNvPr id="17" name="Rectangle 16">
             <a:extLst>
               <a:ext uri="{FF2B5EF4-FFF2-40B4-BE49-F238E27FC236}">
-                <a16:creationId xmlns:a16="http://schemas.microsoft.com/office/drawing/2014/main" id="{75912A08-BC1F-4977-88B6-B4F280DF7CA5}"/>
+                <a16:creationId xmlns:a16="http://schemas.microsoft.com/office/drawing/2014/main" id="{0FBA89F6-811E-443B-8D41-BBE8183A92EB}"/>
               </a:ext>
             </a:extLst>
           </p:cNvPr>
@@ -13593,7 +13593,7 @@
           <p:cNvPr id="18" name="Rectangle 17">
             <a:extLst>
               <a:ext uri="{FF2B5EF4-FFF2-40B4-BE49-F238E27FC236}">
-                <a16:creationId xmlns:a16="http://schemas.microsoft.com/office/drawing/2014/main" id="{B87DA9A3-0593-41E2-8A2B-A423038BBD24}"/>
+                <a16:creationId xmlns:a16="http://schemas.microsoft.com/office/drawing/2014/main" id="{F4224446-5812-4FDB-9F96-0D28B62A45BB}"/>
               </a:ext>
             </a:extLst>
           </p:cNvPr>
@@ -13624,7 +13624,7 @@
           <p:cNvPr id="19" name="Rectangle 18">
             <a:extLst>
               <a:ext uri="{FF2B5EF4-FFF2-40B4-BE49-F238E27FC236}">
-                <a16:creationId xmlns:a16="http://schemas.microsoft.com/office/drawing/2014/main" id="{FA8848E0-71D3-4C2D-BAE2-5B8AC73376F0}"/>
+                <a16:creationId xmlns:a16="http://schemas.microsoft.com/office/drawing/2014/main" id="{DED400F7-4945-4079-95FF-0195DAF9E5DF}"/>
               </a:ext>
             </a:extLst>
           </p:cNvPr>
@@ -13686,7 +13686,7 @@
           <p:cNvPr id="20" name="Rectangle 19">
             <a:extLst>
               <a:ext uri="{FF2B5EF4-FFF2-40B4-BE49-F238E27FC236}">
-                <a16:creationId xmlns:a16="http://schemas.microsoft.com/office/drawing/2014/main" id="{B9B1FF0B-9165-48F8-BF11-ACAF1BA456FA}"/>
+                <a16:creationId xmlns:a16="http://schemas.microsoft.com/office/drawing/2014/main" id="{ACA4F870-0365-4911-8492-EBCB3E2474BE}"/>
               </a:ext>
             </a:extLst>
           </p:cNvPr>
@@ -13748,7 +13748,7 @@
           <p:cNvPr id="21" name="Rectangle 20">
             <a:extLst>
               <a:ext uri="{FF2B5EF4-FFF2-40B4-BE49-F238E27FC236}">
-                <a16:creationId xmlns:a16="http://schemas.microsoft.com/office/drawing/2014/main" id="{B37D00B0-A846-400B-9B10-0E8D19A80532}"/>
+                <a16:creationId xmlns:a16="http://schemas.microsoft.com/office/drawing/2014/main" id="{6F3A1689-3713-413A-9717-E805E0D52099}"/>
               </a:ext>
             </a:extLst>
           </p:cNvPr>
@@ -13779,7 +13779,7 @@
           <p:cNvPr id="22" name="Rectangle 21">
             <a:extLst>
               <a:ext uri="{FF2B5EF4-FFF2-40B4-BE49-F238E27FC236}">
-                <a16:creationId xmlns:a16="http://schemas.microsoft.com/office/drawing/2014/main" id="{14A203E0-3B60-410B-85F0-C15342D944EC}"/>
+                <a16:creationId xmlns:a16="http://schemas.microsoft.com/office/drawing/2014/main" id="{C187F792-8D8E-4C02-B580-6CA2DD27179D}"/>
               </a:ext>
             </a:extLst>
           </p:cNvPr>
@@ -13841,7 +13841,7 @@
           <p:cNvPr id="23" name="Rectangle 22">
             <a:extLst>
               <a:ext uri="{FF2B5EF4-FFF2-40B4-BE49-F238E27FC236}">
-                <a16:creationId xmlns:a16="http://schemas.microsoft.com/office/drawing/2014/main" id="{1239121F-DF6A-4525-98BD-941962054404}"/>
+                <a16:creationId xmlns:a16="http://schemas.microsoft.com/office/drawing/2014/main" id="{C9AE05D6-3299-454E-AC18-22CF67B7C8C9}"/>
               </a:ext>
             </a:extLst>
           </p:cNvPr>
@@ -13903,7 +13903,7 @@
           <p:cNvPr id="24" name="Rectangle 23">
             <a:extLst>
               <a:ext uri="{FF2B5EF4-FFF2-40B4-BE49-F238E27FC236}">
-                <a16:creationId xmlns:a16="http://schemas.microsoft.com/office/drawing/2014/main" id="{D014A104-1F65-4368-ABBC-60B1EBF20F20}"/>
+                <a16:creationId xmlns:a16="http://schemas.microsoft.com/office/drawing/2014/main" id="{9D6186C8-C443-4C2B-A6F3-7516EDEFF5BB}"/>
               </a:ext>
             </a:extLst>
           </p:cNvPr>
@@ -13934,7 +13934,7 @@
           <p:cNvPr id="25" name="Rectangle 24">
             <a:extLst>
               <a:ext uri="{FF2B5EF4-FFF2-40B4-BE49-F238E27FC236}">
-                <a16:creationId xmlns:a16="http://schemas.microsoft.com/office/drawing/2014/main" id="{80782507-F2E4-4D4F-9A84-C2624825A5F7}"/>
+                <a16:creationId xmlns:a16="http://schemas.microsoft.com/office/drawing/2014/main" id="{A129BAC4-F617-4589-A96E-D8D36DB24ED0}"/>
               </a:ext>
             </a:extLst>
           </p:cNvPr>
@@ -13996,7 +13996,7 @@
           <p:cNvPr id="26" name="Rectangle 25">
             <a:extLst>
               <a:ext uri="{FF2B5EF4-FFF2-40B4-BE49-F238E27FC236}">
-                <a16:creationId xmlns:a16="http://schemas.microsoft.com/office/drawing/2014/main" id="{7EC26D36-1D24-4395-A339-2C0302F0FB9D}"/>
+                <a16:creationId xmlns:a16="http://schemas.microsoft.com/office/drawing/2014/main" id="{2927E41B-8489-4A07-9AC2-A99BBD9911BA}"/>
               </a:ext>
             </a:extLst>
           </p:cNvPr>
@@ -14058,7 +14058,7 @@
           <p:cNvPr id="27" name="Rectangle 26">
             <a:extLst>
               <a:ext uri="{FF2B5EF4-FFF2-40B4-BE49-F238E27FC236}">
-                <a16:creationId xmlns:a16="http://schemas.microsoft.com/office/drawing/2014/main" id="{095400AE-46FC-4C89-B7E2-969B40DCFAFE}"/>
+                <a16:creationId xmlns:a16="http://schemas.microsoft.com/office/drawing/2014/main" id="{43A1F776-4476-4F85-A7FE-8104538EFFFE}"/>
               </a:ext>
             </a:extLst>
           </p:cNvPr>
@@ -14120,7 +14120,7 @@
           <p:cNvPr id="28" name="Rectangle 27">
             <a:extLst>
               <a:ext uri="{FF2B5EF4-FFF2-40B4-BE49-F238E27FC236}">
-                <a16:creationId xmlns:a16="http://schemas.microsoft.com/office/drawing/2014/main" id="{FAF9E20B-E503-46A4-B846-E7CCAAFC791F}"/>
+                <a16:creationId xmlns:a16="http://schemas.microsoft.com/office/drawing/2014/main" id="{F0052B75-C522-47B1-B741-6E6829006F95}"/>
               </a:ext>
             </a:extLst>
           </p:cNvPr>
@@ -14182,7 +14182,7 @@
           <p:cNvPr id="29" name="Rectangle 28">
             <a:extLst>
               <a:ext uri="{FF2B5EF4-FFF2-40B4-BE49-F238E27FC236}">
-                <a16:creationId xmlns:a16="http://schemas.microsoft.com/office/drawing/2014/main" id="{B64F7444-F103-417E-BE1A-7CA888F1BBE2}"/>
+                <a16:creationId xmlns:a16="http://schemas.microsoft.com/office/drawing/2014/main" id="{E40C8895-3CA2-46AE-A69D-2F894CEA8018}"/>
               </a:ext>
             </a:extLst>
           </p:cNvPr>
@@ -14213,7 +14213,7 @@
           <p:cNvPr id="30" name="Rectangle 29">
             <a:extLst>
               <a:ext uri="{FF2B5EF4-FFF2-40B4-BE49-F238E27FC236}">
-                <a16:creationId xmlns:a16="http://schemas.microsoft.com/office/drawing/2014/main" id="{A963F72F-32CF-41C1-9B39-2C101E66113E}"/>
+                <a16:creationId xmlns:a16="http://schemas.microsoft.com/office/drawing/2014/main" id="{8EA3EDE0-0BDC-4111-8FA0-E497FA37A262}"/>
               </a:ext>
             </a:extLst>
           </p:cNvPr>
@@ -14265,7 +14265,7 @@
                 <a:ea typeface="Arial"/>
                 <a:cs typeface="Arial"/>
               </a:rPr>
-              <a:t>r2z-d4c8d4cc709a · scn-e0f12f397e · prt-fd6de9d793</a:t>
+              <a:t>r2z-a7181752a17d · scn-e0f12f397e · prt-fd6de9d793</a:t>
             </a:r>
           </a:p>
         </p:txBody>
@@ -14275,7 +14275,7 @@
           <p:cNvPr id="31" name="Rectangle 30">
             <a:extLst>
               <a:ext uri="{FF2B5EF4-FFF2-40B4-BE49-F238E27FC236}">
-                <a16:creationId xmlns:a16="http://schemas.microsoft.com/office/drawing/2014/main" id="{8CAAB21E-BF02-4FF1-A3D0-31E5E368E4AF}"/>
+                <a16:creationId xmlns:a16="http://schemas.microsoft.com/office/drawing/2014/main" id="{94EFFD28-CCB6-46E0-860B-A652D9C08225}"/>
               </a:ext>
             </a:extLst>
           </p:cNvPr>
@@ -14335,7 +14335,7 @@
     </p:spTree>
     <p:extLst>
       <p:ext uri="{BB962C8B-B14F-4D97-AF65-F5344CB8AC3E}">
-        <p14:creationId xmlns:p14="http://schemas.microsoft.com/office/powerpoint/2010/main" val="2056991342"/>
+        <p14:creationId xmlns:p14="http://schemas.microsoft.com/office/powerpoint/2010/main" val="2100262121"/>
       </p:ext>
     </p:extLst>
   </p:cSld>
@@ -14376,7 +14376,7 @@
             <a:hlinkClick r:id="rId3"/>
             <a:extLst>
               <a:ext uri="{FF2B5EF4-FFF2-40B4-BE49-F238E27FC236}">
-                <a16:creationId xmlns:a16="http://schemas.microsoft.com/office/drawing/2014/main" id="{32DEEEDD-DD76-45C0-AE17-40DFC132D686}"/>
+                <a16:creationId xmlns:a16="http://schemas.microsoft.com/office/drawing/2014/main" id="{E21DA6D9-E769-47BD-9083-DECA5F3AE7D4}"/>
               </a:ext>
             </a:extLst>
           </p:cNvPr>
@@ -14451,7 +14451,7 @@
             <a:hlinkClick r:id="rId4"/>
             <a:extLst>
               <a:ext uri="{FF2B5EF4-FFF2-40B4-BE49-F238E27FC236}">
-                <a16:creationId xmlns:a16="http://schemas.microsoft.com/office/drawing/2014/main" id="{7264FA1E-8417-4195-A8E2-E2F043EE2336}"/>
+                <a16:creationId xmlns:a16="http://schemas.microsoft.com/office/drawing/2014/main" id="{CC7C10AB-422F-464A-A454-CA6115D3749F}"/>
               </a:ext>
             </a:extLst>
           </p:cNvPr>
@@ -14525,7 +14525,7 @@
           <p:cNvPr id="3" name="Rectangle 2">
             <a:extLst>
               <a:ext uri="{FF2B5EF4-FFF2-40B4-BE49-F238E27FC236}">
-                <a16:creationId xmlns:a16="http://schemas.microsoft.com/office/drawing/2014/main" id="{89D57A21-11EC-41D4-87DC-A4F55E4AB178}"/>
+                <a16:creationId xmlns:a16="http://schemas.microsoft.com/office/drawing/2014/main" id="{88403451-C193-48C0-9A49-B0B6C76C9977}"/>
               </a:ext>
             </a:extLst>
           </p:cNvPr>
@@ -14587,7 +14587,7 @@
           <p:cNvPr id="4" name="Rectangle 3">
             <a:extLst>
               <a:ext uri="{FF2B5EF4-FFF2-40B4-BE49-F238E27FC236}">
-                <a16:creationId xmlns:a16="http://schemas.microsoft.com/office/drawing/2014/main" id="{9EA78022-6BAC-4B71-B6DA-2E0DC3684A86}"/>
+                <a16:creationId xmlns:a16="http://schemas.microsoft.com/office/drawing/2014/main" id="{36B5108A-BE9D-4914-9D53-E9AD4E175A5D}"/>
               </a:ext>
             </a:extLst>
           </p:cNvPr>
@@ -14649,7 +14649,7 @@
           <p:cNvPr id="5" name="Rectangle 4">
             <a:extLst>
               <a:ext uri="{FF2B5EF4-FFF2-40B4-BE49-F238E27FC236}">
-                <a16:creationId xmlns:a16="http://schemas.microsoft.com/office/drawing/2014/main" id="{4D644831-6B6D-4253-9111-CF4BA4362D2E}"/>
+                <a16:creationId xmlns:a16="http://schemas.microsoft.com/office/drawing/2014/main" id="{7E44C40A-D55B-405F-9042-5AA887241929}"/>
               </a:ext>
             </a:extLst>
           </p:cNvPr>
@@ -14711,7 +14711,7 @@
           <p:cNvPr id="6" name="Oval 5">
             <a:extLst>
               <a:ext uri="{FF2B5EF4-FFF2-40B4-BE49-F238E27FC236}">
-                <a16:creationId xmlns:a16="http://schemas.microsoft.com/office/drawing/2014/main" id="{BCDE92D7-6A37-43F4-9C04-423C3F73A014}"/>
+                <a16:creationId xmlns:a16="http://schemas.microsoft.com/office/drawing/2014/main" id="{DC626D73-0D86-4FCC-9C64-5533AC7432B2}"/>
               </a:ext>
             </a:extLst>
           </p:cNvPr>
@@ -14742,7 +14742,7 @@
           <p:cNvPr id="7" name="Rectangle 6">
             <a:extLst>
               <a:ext uri="{FF2B5EF4-FFF2-40B4-BE49-F238E27FC236}">
-                <a16:creationId xmlns:a16="http://schemas.microsoft.com/office/drawing/2014/main" id="{B507AE46-FDBF-4EC9-AC45-F9B620EBDA61}"/>
+                <a16:creationId xmlns:a16="http://schemas.microsoft.com/office/drawing/2014/main" id="{1C47F356-C82D-4725-8B6E-191195C35078}"/>
               </a:ext>
             </a:extLst>
           </p:cNvPr>
@@ -14804,7 +14804,7 @@
           <p:cNvPr id="8" name="Rectangle 7">
             <a:extLst>
               <a:ext uri="{FF2B5EF4-FFF2-40B4-BE49-F238E27FC236}">
-                <a16:creationId xmlns:a16="http://schemas.microsoft.com/office/drawing/2014/main" id="{73CDD6A7-F850-4BC0-B1A7-3D08B7DCC3BE}"/>
+                <a16:creationId xmlns:a16="http://schemas.microsoft.com/office/drawing/2014/main" id="{464E822D-E3E7-4690-B995-BEEFD670D239}"/>
               </a:ext>
             </a:extLst>
           </p:cNvPr>
@@ -14835,7 +14835,7 @@
           <p:cNvPr id="9" name="Rectangle 8">
             <a:extLst>
               <a:ext uri="{FF2B5EF4-FFF2-40B4-BE49-F238E27FC236}">
-                <a16:creationId xmlns:a16="http://schemas.microsoft.com/office/drawing/2014/main" id="{5BFFA6B8-4AF4-4D25-8480-2A20B35879CB}"/>
+                <a16:creationId xmlns:a16="http://schemas.microsoft.com/office/drawing/2014/main" id="{D35F0140-AA61-4DB6-BEED-DAF9CB429527}"/>
               </a:ext>
             </a:extLst>
           </p:cNvPr>
@@ -14897,7 +14897,7 @@
           <p:cNvPr id="10" name="Oval 9">
             <a:extLst>
               <a:ext uri="{FF2B5EF4-FFF2-40B4-BE49-F238E27FC236}">
-                <a16:creationId xmlns:a16="http://schemas.microsoft.com/office/drawing/2014/main" id="{DFCF1413-90F2-4A77-9684-37E15B87BD01}"/>
+                <a16:creationId xmlns:a16="http://schemas.microsoft.com/office/drawing/2014/main" id="{8DBFA306-8D6A-4080-A314-B3439F0C6F8E}"/>
               </a:ext>
             </a:extLst>
           </p:cNvPr>
@@ -14928,7 +14928,7 @@
           <p:cNvPr id="11" name="Rectangle 10">
             <a:extLst>
               <a:ext uri="{FF2B5EF4-FFF2-40B4-BE49-F238E27FC236}">
-                <a16:creationId xmlns:a16="http://schemas.microsoft.com/office/drawing/2014/main" id="{0ABB2F9E-F57B-400B-ACFF-4D725C07CCDE}"/>
+                <a16:creationId xmlns:a16="http://schemas.microsoft.com/office/drawing/2014/main" id="{45C58831-E675-4540-832E-5CFFC307C7D5}"/>
               </a:ext>
             </a:extLst>
           </p:cNvPr>
@@ -14990,7 +14990,7 @@
           <p:cNvPr id="12" name="Rectangle 11">
             <a:extLst>
               <a:ext uri="{FF2B5EF4-FFF2-40B4-BE49-F238E27FC236}">
-                <a16:creationId xmlns:a16="http://schemas.microsoft.com/office/drawing/2014/main" id="{DC6C4333-7D78-4510-A493-2BA777A69F87}"/>
+                <a16:creationId xmlns:a16="http://schemas.microsoft.com/office/drawing/2014/main" id="{A53E921C-64BE-455B-BBA0-FF461CDA9ADE}"/>
               </a:ext>
             </a:extLst>
           </p:cNvPr>
@@ -15021,7 +15021,7 @@
           <p:cNvPr id="13" name="Rectangle 12">
             <a:extLst>
               <a:ext uri="{FF2B5EF4-FFF2-40B4-BE49-F238E27FC236}">
-                <a16:creationId xmlns:a16="http://schemas.microsoft.com/office/drawing/2014/main" id="{81182E96-BF49-434C-A675-AD290F8B4D3F}"/>
+                <a16:creationId xmlns:a16="http://schemas.microsoft.com/office/drawing/2014/main" id="{9D15FD93-15C5-4269-BC2C-D3BD4954AA68}"/>
               </a:ext>
             </a:extLst>
           </p:cNvPr>
@@ -15083,7 +15083,7 @@
           <p:cNvPr id="14" name="Oval 13">
             <a:extLst>
               <a:ext uri="{FF2B5EF4-FFF2-40B4-BE49-F238E27FC236}">
-                <a16:creationId xmlns:a16="http://schemas.microsoft.com/office/drawing/2014/main" id="{67B5B097-9EDF-4003-9581-2C3D1B55971C}"/>
+                <a16:creationId xmlns:a16="http://schemas.microsoft.com/office/drawing/2014/main" id="{7E02A5C4-D227-4297-846C-9E7BFBD45893}"/>
               </a:ext>
             </a:extLst>
           </p:cNvPr>
@@ -15114,7 +15114,7 @@
           <p:cNvPr id="15" name="Rectangle 14">
             <a:extLst>
               <a:ext uri="{FF2B5EF4-FFF2-40B4-BE49-F238E27FC236}">
-                <a16:creationId xmlns:a16="http://schemas.microsoft.com/office/drawing/2014/main" id="{84D5FF00-2C3F-441D-85AB-41F9C5D40976}"/>
+                <a16:creationId xmlns:a16="http://schemas.microsoft.com/office/drawing/2014/main" id="{D518BBCD-4651-438F-8C09-7F7F2D297E34}"/>
               </a:ext>
             </a:extLst>
           </p:cNvPr>
@@ -15176,7 +15176,7 @@
           <p:cNvPr id="16" name="Rectangle 15">
             <a:extLst>
               <a:ext uri="{FF2B5EF4-FFF2-40B4-BE49-F238E27FC236}">
-                <a16:creationId xmlns:a16="http://schemas.microsoft.com/office/drawing/2014/main" id="{BC08ECD9-ADEF-406C-AFB3-2D85DDC0FDF0}"/>
+                <a16:creationId xmlns:a16="http://schemas.microsoft.com/office/drawing/2014/main" id="{3254B77E-C447-4D45-A06C-B2EC56D2CFCB}"/>
               </a:ext>
             </a:extLst>
           </p:cNvPr>
@@ -15207,7 +15207,7 @@
           <p:cNvPr id="17" name="Rectangle 16">
             <a:extLst>
               <a:ext uri="{FF2B5EF4-FFF2-40B4-BE49-F238E27FC236}">
-                <a16:creationId xmlns:a16="http://schemas.microsoft.com/office/drawing/2014/main" id="{F0A525BA-650D-400B-B3E8-9E6AFE5DC582}"/>
+                <a16:creationId xmlns:a16="http://schemas.microsoft.com/office/drawing/2014/main" id="{4582BF9D-9E96-4EB4-B0C0-9B54FF87F1CF}"/>
               </a:ext>
             </a:extLst>
           </p:cNvPr>
@@ -15269,7 +15269,7 @@
           <p:cNvPr id="18" name="Oval 17">
             <a:extLst>
               <a:ext uri="{FF2B5EF4-FFF2-40B4-BE49-F238E27FC236}">
-                <a16:creationId xmlns:a16="http://schemas.microsoft.com/office/drawing/2014/main" id="{E0BF008A-2EFD-43B6-A0D5-6ED9C168FFF5}"/>
+                <a16:creationId xmlns:a16="http://schemas.microsoft.com/office/drawing/2014/main" id="{50EA1F11-EF50-4D0F-BF37-34B61E18C620}"/>
               </a:ext>
             </a:extLst>
           </p:cNvPr>
@@ -15300,7 +15300,7 @@
           <p:cNvPr id="19" name="Rectangle 18">
             <a:extLst>
               <a:ext uri="{FF2B5EF4-FFF2-40B4-BE49-F238E27FC236}">
-                <a16:creationId xmlns:a16="http://schemas.microsoft.com/office/drawing/2014/main" id="{A328A5D4-C3C4-41CF-B25C-33003D92DF13}"/>
+                <a16:creationId xmlns:a16="http://schemas.microsoft.com/office/drawing/2014/main" id="{E4B3A1B5-E3FB-463E-9DF2-F70D309DA961}"/>
               </a:ext>
             </a:extLst>
           </p:cNvPr>
@@ -15362,7 +15362,7 @@
           <p:cNvPr id="20" name="Rectangle 19">
             <a:extLst>
               <a:ext uri="{FF2B5EF4-FFF2-40B4-BE49-F238E27FC236}">
-                <a16:creationId xmlns:a16="http://schemas.microsoft.com/office/drawing/2014/main" id="{7B01C8F5-0BF3-4479-8B8D-DF5DF234BEE1}"/>
+                <a16:creationId xmlns:a16="http://schemas.microsoft.com/office/drawing/2014/main" id="{53A77983-2454-49D7-A488-C03032E98965}"/>
               </a:ext>
             </a:extLst>
           </p:cNvPr>
@@ -15393,7 +15393,7 @@
           <p:cNvPr id="21" name="Rectangle 20">
             <a:extLst>
               <a:ext uri="{FF2B5EF4-FFF2-40B4-BE49-F238E27FC236}">
-                <a16:creationId xmlns:a16="http://schemas.microsoft.com/office/drawing/2014/main" id="{EE2D2FB7-D6EF-42EB-8D12-A1A6F69E6AAB}"/>
+                <a16:creationId xmlns:a16="http://schemas.microsoft.com/office/drawing/2014/main" id="{9D59358E-8B61-4332-8012-ED21B580697A}"/>
               </a:ext>
             </a:extLst>
           </p:cNvPr>
@@ -15455,7 +15455,7 @@
           <p:cNvPr id="22" name="Oval 21">
             <a:extLst>
               <a:ext uri="{FF2B5EF4-FFF2-40B4-BE49-F238E27FC236}">
-                <a16:creationId xmlns:a16="http://schemas.microsoft.com/office/drawing/2014/main" id="{F6CCC68C-A297-43E2-A8EA-C722B5156215}"/>
+                <a16:creationId xmlns:a16="http://schemas.microsoft.com/office/drawing/2014/main" id="{CF87685F-C90F-4FA4-9E8F-F3CADB297D59}"/>
               </a:ext>
             </a:extLst>
           </p:cNvPr>
@@ -15486,7 +15486,7 @@
           <p:cNvPr id="23" name="Rectangle 22">
             <a:extLst>
               <a:ext uri="{FF2B5EF4-FFF2-40B4-BE49-F238E27FC236}">
-                <a16:creationId xmlns:a16="http://schemas.microsoft.com/office/drawing/2014/main" id="{BCCF152B-4008-40E2-A8D9-35153A0023BC}"/>
+                <a16:creationId xmlns:a16="http://schemas.microsoft.com/office/drawing/2014/main" id="{FEA8A117-E97E-4A8E-AB76-8F2358D2BAB1}"/>
               </a:ext>
             </a:extLst>
           </p:cNvPr>
@@ -15548,7 +15548,7 @@
           <p:cNvPr id="24" name="Rectangle 23">
             <a:extLst>
               <a:ext uri="{FF2B5EF4-FFF2-40B4-BE49-F238E27FC236}">
-                <a16:creationId xmlns:a16="http://schemas.microsoft.com/office/drawing/2014/main" id="{7699A5F0-9596-42F6-8E59-EC5586D91C6F}"/>
+                <a16:creationId xmlns:a16="http://schemas.microsoft.com/office/drawing/2014/main" id="{84A3CF3C-6FE4-4BAF-959F-1F94E9E4C6AA}"/>
               </a:ext>
             </a:extLst>
           </p:cNvPr>
@@ -15579,7 +15579,7 @@
           <p:cNvPr id="25" name="Rectangle 24">
             <a:extLst>
               <a:ext uri="{FF2B5EF4-FFF2-40B4-BE49-F238E27FC236}">
-                <a16:creationId xmlns:a16="http://schemas.microsoft.com/office/drawing/2014/main" id="{BDC9E810-937D-4EC8-B707-7C352D6EB93D}"/>
+                <a16:creationId xmlns:a16="http://schemas.microsoft.com/office/drawing/2014/main" id="{35965364-DF55-440E-AA63-78252FA498A7}"/>
               </a:ext>
             </a:extLst>
           </p:cNvPr>
@@ -15641,7 +15641,7 @@
           <p:cNvPr id="26" name="Oval 25">
             <a:extLst>
               <a:ext uri="{FF2B5EF4-FFF2-40B4-BE49-F238E27FC236}">
-                <a16:creationId xmlns:a16="http://schemas.microsoft.com/office/drawing/2014/main" id="{B22AFC82-EF8E-4D4F-A4E1-F24979832691}"/>
+                <a16:creationId xmlns:a16="http://schemas.microsoft.com/office/drawing/2014/main" id="{0A27061F-F091-44C0-B2F1-0660AE489CBB}"/>
               </a:ext>
             </a:extLst>
           </p:cNvPr>
@@ -15672,7 +15672,7 @@
           <p:cNvPr id="27" name="Rectangle 26">
             <a:extLst>
               <a:ext uri="{FF2B5EF4-FFF2-40B4-BE49-F238E27FC236}">
-                <a16:creationId xmlns:a16="http://schemas.microsoft.com/office/drawing/2014/main" id="{78F68147-F047-44D6-8C2F-9F5D60759FF8}"/>
+                <a16:creationId xmlns:a16="http://schemas.microsoft.com/office/drawing/2014/main" id="{B64DC102-8BA3-49DC-BEBE-9D92BF4E19FE}"/>
               </a:ext>
             </a:extLst>
           </p:cNvPr>
@@ -15734,7 +15734,7 @@
           <p:cNvPr id="28" name="Rectangle 27">
             <a:extLst>
               <a:ext uri="{FF2B5EF4-FFF2-40B4-BE49-F238E27FC236}">
-                <a16:creationId xmlns:a16="http://schemas.microsoft.com/office/drawing/2014/main" id="{CD1DFFAE-B652-40DC-A0F7-C86AB15066B6}"/>
+                <a16:creationId xmlns:a16="http://schemas.microsoft.com/office/drawing/2014/main" id="{7CFE4443-5937-4655-BC1C-5FB484680C83}"/>
               </a:ext>
             </a:extLst>
           </p:cNvPr>
@@ -15765,7 +15765,7 @@
           <p:cNvPr id="29" name="Rectangle 28">
             <a:extLst>
               <a:ext uri="{FF2B5EF4-FFF2-40B4-BE49-F238E27FC236}">
-                <a16:creationId xmlns:a16="http://schemas.microsoft.com/office/drawing/2014/main" id="{E2EDD034-C485-4D6E-8038-A97FE6D7B61A}"/>
+                <a16:creationId xmlns:a16="http://schemas.microsoft.com/office/drawing/2014/main" id="{DFDE0B9C-25E3-4AE2-9914-8CF5B75652FA}"/>
               </a:ext>
             </a:extLst>
           </p:cNvPr>
@@ -15827,7 +15827,7 @@
           <p:cNvPr id="30" name="Oval 29">
             <a:extLst>
               <a:ext uri="{FF2B5EF4-FFF2-40B4-BE49-F238E27FC236}">
-                <a16:creationId xmlns:a16="http://schemas.microsoft.com/office/drawing/2014/main" id="{11BD0F02-BB83-4498-9BC2-DF95140B1E5F}"/>
+                <a16:creationId xmlns:a16="http://schemas.microsoft.com/office/drawing/2014/main" id="{40FB49FD-ABAE-470E-B45C-ADE01A3654C9}"/>
               </a:ext>
             </a:extLst>
           </p:cNvPr>
@@ -15858,7 +15858,7 @@
           <p:cNvPr id="31" name="Rectangle 30">
             <a:extLst>
               <a:ext uri="{FF2B5EF4-FFF2-40B4-BE49-F238E27FC236}">
-                <a16:creationId xmlns:a16="http://schemas.microsoft.com/office/drawing/2014/main" id="{8F8DC668-5D3F-4B38-953F-B6B5DEFE4947}"/>
+                <a16:creationId xmlns:a16="http://schemas.microsoft.com/office/drawing/2014/main" id="{C03158DF-2B97-4C5E-BC30-A9F174AB8F0F}"/>
               </a:ext>
             </a:extLst>
           </p:cNvPr>
@@ -15920,7 +15920,7 @@
           <p:cNvPr id="32" name="Rectangle 31">
             <a:extLst>
               <a:ext uri="{FF2B5EF4-FFF2-40B4-BE49-F238E27FC236}">
-                <a16:creationId xmlns:a16="http://schemas.microsoft.com/office/drawing/2014/main" id="{E7EE3479-1F4E-49E4-AA69-4F2767E33612}"/>
+                <a16:creationId xmlns:a16="http://schemas.microsoft.com/office/drawing/2014/main" id="{2222C72D-B447-4C4D-84D2-9C17B9F4308F}"/>
               </a:ext>
             </a:extLst>
           </p:cNvPr>
@@ -15982,7 +15982,7 @@
           <p:cNvPr id="33" name="Rectangle: Rounded Corners 32">
             <a:extLst>
               <a:ext uri="{FF2B5EF4-FFF2-40B4-BE49-F238E27FC236}">
-                <a16:creationId xmlns:a16="http://schemas.microsoft.com/office/drawing/2014/main" id="{033E1764-2A9D-48A5-BCCA-C0E2E2417348}"/>
+                <a16:creationId xmlns:a16="http://schemas.microsoft.com/office/drawing/2014/main" id="{B77BE76F-2D2C-45C9-934C-6F79CA9E8CE4}"/>
               </a:ext>
             </a:extLst>
           </p:cNvPr>
@@ -16015,7 +16015,7 @@
           <p:cNvPr id="34" name="Rectangle 33">
             <a:extLst>
               <a:ext uri="{FF2B5EF4-FFF2-40B4-BE49-F238E27FC236}">
-                <a16:creationId xmlns:a16="http://schemas.microsoft.com/office/drawing/2014/main" id="{D268731A-00D5-4761-8AC1-F31666BA3035}"/>
+                <a16:creationId xmlns:a16="http://schemas.microsoft.com/office/drawing/2014/main" id="{B09E6BEC-027A-4F2E-835B-B9467C83EE02}"/>
               </a:ext>
             </a:extLst>
           </p:cNvPr>
@@ -16077,7 +16077,7 @@
           <p:cNvPr id="35" name="Rectangle 34">
             <a:extLst>
               <a:ext uri="{FF2B5EF4-FFF2-40B4-BE49-F238E27FC236}">
-                <a16:creationId xmlns:a16="http://schemas.microsoft.com/office/drawing/2014/main" id="{B53654DC-8981-48A6-8BB5-A51C397854F8}"/>
+                <a16:creationId xmlns:a16="http://schemas.microsoft.com/office/drawing/2014/main" id="{8E3A6F3C-4999-4E22-95E2-A359909834EB}"/>
               </a:ext>
             </a:extLst>
           </p:cNvPr>
@@ -16108,7 +16108,7 @@
           <p:cNvPr id="36" name="Rectangle 35">
             <a:extLst>
               <a:ext uri="{FF2B5EF4-FFF2-40B4-BE49-F238E27FC236}">
-                <a16:creationId xmlns:a16="http://schemas.microsoft.com/office/drawing/2014/main" id="{466461E5-1A63-494B-BE47-7629228EB843}"/>
+                <a16:creationId xmlns:a16="http://schemas.microsoft.com/office/drawing/2014/main" id="{4A42629C-4505-46E4-A37F-98967EC281C9}"/>
               </a:ext>
             </a:extLst>
           </p:cNvPr>
@@ -16160,7 +16160,7 @@
                 <a:ea typeface="Arial"/>
                 <a:cs typeface="Arial"/>
               </a:rPr>
-              <a:t>r2z-d4c8d4cc709a · scn-e0f12f397e · prt-fd6de9d793</a:t>
+              <a:t>r2z-a7181752a17d · scn-e0f12f397e · prt-fd6de9d793</a:t>
             </a:r>
           </a:p>
         </p:txBody>
@@ -16170,7 +16170,7 @@
           <p:cNvPr id="37" name="Rectangle 36">
             <a:extLst>
               <a:ext uri="{FF2B5EF4-FFF2-40B4-BE49-F238E27FC236}">
-                <a16:creationId xmlns:a16="http://schemas.microsoft.com/office/drawing/2014/main" id="{A007F414-1577-4569-B8CA-DBD6823422E0}"/>
+                <a16:creationId xmlns:a16="http://schemas.microsoft.com/office/drawing/2014/main" id="{5AAAEB7C-8CF4-459A-AB30-0C14F1E608A2}"/>
               </a:ext>
             </a:extLst>
           </p:cNvPr>
@@ -16230,7 +16230,7 @@
     </p:spTree>
     <p:extLst>
       <p:ext uri="{BB962C8B-B14F-4D97-AF65-F5344CB8AC3E}">
-        <p14:creationId xmlns:p14="http://schemas.microsoft.com/office/powerpoint/2010/main" val="1029667254"/>
+        <p14:creationId xmlns:p14="http://schemas.microsoft.com/office/powerpoint/2010/main" val="1551240838"/>
       </p:ext>
     </p:extLst>
   </p:cSld>
@@ -16271,7 +16271,7 @@
             <a:hlinkClick r:id="rId3"/>
             <a:extLst>
               <a:ext uri="{FF2B5EF4-FFF2-40B4-BE49-F238E27FC236}">
-                <a16:creationId xmlns:a16="http://schemas.microsoft.com/office/drawing/2014/main" id="{F3E85F55-0B28-4EEF-9918-8D8ED48AC6C5}"/>
+                <a16:creationId xmlns:a16="http://schemas.microsoft.com/office/drawing/2014/main" id="{7C2385E2-190D-4478-A9A6-328A3B200F8A}"/>
               </a:ext>
             </a:extLst>
           </p:cNvPr>
@@ -16346,7 +16346,7 @@
             <a:hlinkClick r:id="rId4"/>
             <a:extLst>
               <a:ext uri="{FF2B5EF4-FFF2-40B4-BE49-F238E27FC236}">
-                <a16:creationId xmlns:a16="http://schemas.microsoft.com/office/drawing/2014/main" id="{0CF5AF90-986E-43A4-B473-C02DCC48A98E}"/>
+                <a16:creationId xmlns:a16="http://schemas.microsoft.com/office/drawing/2014/main" id="{1359600E-AD7F-4079-831E-992AD41AB1BB}"/>
               </a:ext>
             </a:extLst>
           </p:cNvPr>
@@ -16420,7 +16420,7 @@
           <p:cNvPr id="3" name="Rectangle 2">
             <a:extLst>
               <a:ext uri="{FF2B5EF4-FFF2-40B4-BE49-F238E27FC236}">
-                <a16:creationId xmlns:a16="http://schemas.microsoft.com/office/drawing/2014/main" id="{0CC367DF-CD7E-48E6-B5D5-98CBFB4ED20A}"/>
+                <a16:creationId xmlns:a16="http://schemas.microsoft.com/office/drawing/2014/main" id="{D319CFAA-BC90-4AE3-AE0D-5CE55CCC5559}"/>
               </a:ext>
             </a:extLst>
           </p:cNvPr>
@@ -16482,7 +16482,7 @@
           <p:cNvPr id="4" name="Rectangle 3">
             <a:extLst>
               <a:ext uri="{FF2B5EF4-FFF2-40B4-BE49-F238E27FC236}">
-                <a16:creationId xmlns:a16="http://schemas.microsoft.com/office/drawing/2014/main" id="{B20C5AF0-1294-4AAA-AAC7-053C7ECF7532}"/>
+                <a16:creationId xmlns:a16="http://schemas.microsoft.com/office/drawing/2014/main" id="{BA72CFE5-50C6-485B-9FA7-221AC6CCAB2D}"/>
               </a:ext>
             </a:extLst>
           </p:cNvPr>
@@ -16571,7 +16571,7 @@
           <p:cNvPr id="6" name="Rectangle: Rounded Corners 5">
             <a:extLst>
               <a:ext uri="{FF2B5EF4-FFF2-40B4-BE49-F238E27FC236}">
-                <a16:creationId xmlns:a16="http://schemas.microsoft.com/office/drawing/2014/main" id="{EB537D81-F5D3-413A-83DE-D5B4CAEB5025}"/>
+                <a16:creationId xmlns:a16="http://schemas.microsoft.com/office/drawing/2014/main" id="{DC665DFB-3A0D-464C-B3EA-05F3445BC288}"/>
               </a:ext>
             </a:extLst>
           </p:cNvPr>
@@ -16604,7 +16604,7 @@
           <p:cNvPr id="7" name="Oval 6">
             <a:extLst>
               <a:ext uri="{FF2B5EF4-FFF2-40B4-BE49-F238E27FC236}">
-                <a16:creationId xmlns:a16="http://schemas.microsoft.com/office/drawing/2014/main" id="{2796837C-D756-4EC2-B5DD-105E83109EB9}"/>
+                <a16:creationId xmlns:a16="http://schemas.microsoft.com/office/drawing/2014/main" id="{06487AA7-7BCF-4302-B81F-A11EF6309E96}"/>
               </a:ext>
             </a:extLst>
           </p:cNvPr>
@@ -16635,7 +16635,7 @@
           <p:cNvPr id="8" name="Rectangle 7">
             <a:extLst>
               <a:ext uri="{FF2B5EF4-FFF2-40B4-BE49-F238E27FC236}">
-                <a16:creationId xmlns:a16="http://schemas.microsoft.com/office/drawing/2014/main" id="{E0931A67-0DB7-4A10-AF1A-7DAA45D00932}"/>
+                <a16:creationId xmlns:a16="http://schemas.microsoft.com/office/drawing/2014/main" id="{6A6D36A9-1E3D-45BB-B8EE-35847B159758}"/>
               </a:ext>
             </a:extLst>
           </p:cNvPr>
@@ -16697,7 +16697,7 @@
           <p:cNvPr id="9" name="Rectangle: Rounded Corners 8">
             <a:extLst>
               <a:ext uri="{FF2B5EF4-FFF2-40B4-BE49-F238E27FC236}">
-                <a16:creationId xmlns:a16="http://schemas.microsoft.com/office/drawing/2014/main" id="{77311258-2580-4599-9DAF-C9E55E51C3D8}"/>
+                <a16:creationId xmlns:a16="http://schemas.microsoft.com/office/drawing/2014/main" id="{05B668AC-EAF9-4E02-88C3-54484461CCA0}"/>
               </a:ext>
             </a:extLst>
           </p:cNvPr>
@@ -16732,7 +16732,7 @@
           <p:cNvPr id="10" name="Rectangle 9">
             <a:extLst>
               <a:ext uri="{FF2B5EF4-FFF2-40B4-BE49-F238E27FC236}">
-                <a16:creationId xmlns:a16="http://schemas.microsoft.com/office/drawing/2014/main" id="{7E97C88C-7D36-4637-AA8D-36B56D2DA22D}"/>
+                <a16:creationId xmlns:a16="http://schemas.microsoft.com/office/drawing/2014/main" id="{554E19B6-FCE8-45DE-B84F-1A67C4BF8AB7}"/>
               </a:ext>
             </a:extLst>
           </p:cNvPr>
@@ -16794,7 +16794,7 @@
           <p:cNvPr id="11" name="Oval 10">
             <a:extLst>
               <a:ext uri="{FF2B5EF4-FFF2-40B4-BE49-F238E27FC236}">
-                <a16:creationId xmlns:a16="http://schemas.microsoft.com/office/drawing/2014/main" id="{6E0DA7B2-F18E-49C6-9FF7-DAAD62D1B19C}"/>
+                <a16:creationId xmlns:a16="http://schemas.microsoft.com/office/drawing/2014/main" id="{4FD5515B-8C45-4411-8021-23622E757485}"/>
               </a:ext>
             </a:extLst>
           </p:cNvPr>
@@ -16825,7 +16825,7 @@
           <p:cNvPr id="12" name="Rectangle 11">
             <a:extLst>
               <a:ext uri="{FF2B5EF4-FFF2-40B4-BE49-F238E27FC236}">
-                <a16:creationId xmlns:a16="http://schemas.microsoft.com/office/drawing/2014/main" id="{738F35F1-C8B5-4DAE-931B-27E02A02194B}"/>
+                <a16:creationId xmlns:a16="http://schemas.microsoft.com/office/drawing/2014/main" id="{51FFA3F3-4C6F-4033-99AC-05BEB3C861F8}"/>
               </a:ext>
             </a:extLst>
           </p:cNvPr>
@@ -16887,7 +16887,7 @@
           <p:cNvPr id="13" name="Rectangle: Rounded Corners 12">
             <a:extLst>
               <a:ext uri="{FF2B5EF4-FFF2-40B4-BE49-F238E27FC236}">
-                <a16:creationId xmlns:a16="http://schemas.microsoft.com/office/drawing/2014/main" id="{D0534737-683C-4E15-A3A2-4352A5C0B449}"/>
+                <a16:creationId xmlns:a16="http://schemas.microsoft.com/office/drawing/2014/main" id="{CE03DAC6-570D-4C53-B407-14D1FAB7671E}"/>
               </a:ext>
             </a:extLst>
           </p:cNvPr>
@@ -16922,7 +16922,7 @@
           <p:cNvPr id="14" name="Rectangle 13">
             <a:extLst>
               <a:ext uri="{FF2B5EF4-FFF2-40B4-BE49-F238E27FC236}">
-                <a16:creationId xmlns:a16="http://schemas.microsoft.com/office/drawing/2014/main" id="{672C4490-C78E-4C55-8492-72B50A7A3833}"/>
+                <a16:creationId xmlns:a16="http://schemas.microsoft.com/office/drawing/2014/main" id="{F24516AA-DEC4-41B3-9F31-0B8617304972}"/>
               </a:ext>
             </a:extLst>
           </p:cNvPr>
@@ -16984,7 +16984,7 @@
           <p:cNvPr id="15" name="Oval 14">
             <a:extLst>
               <a:ext uri="{FF2B5EF4-FFF2-40B4-BE49-F238E27FC236}">
-                <a16:creationId xmlns:a16="http://schemas.microsoft.com/office/drawing/2014/main" id="{CA456EBD-F11B-4A76-A3FC-539AE4B50057}"/>
+                <a16:creationId xmlns:a16="http://schemas.microsoft.com/office/drawing/2014/main" id="{11F94F48-BDD1-460E-8B8F-E296E78B265E}"/>
               </a:ext>
             </a:extLst>
           </p:cNvPr>
@@ -17015,7 +17015,7 @@
           <p:cNvPr id="16" name="Rectangle 15">
             <a:extLst>
               <a:ext uri="{FF2B5EF4-FFF2-40B4-BE49-F238E27FC236}">
-                <a16:creationId xmlns:a16="http://schemas.microsoft.com/office/drawing/2014/main" id="{DB3B0D93-A350-4636-9E73-F28AF50D7E92}"/>
+                <a16:creationId xmlns:a16="http://schemas.microsoft.com/office/drawing/2014/main" id="{5A413985-5FBF-4B7C-9D99-D23C33F32B5A}"/>
               </a:ext>
             </a:extLst>
           </p:cNvPr>
@@ -17077,7 +17077,7 @@
           <p:cNvPr id="17" name="Rectangle: Rounded Corners 16">
             <a:extLst>
               <a:ext uri="{FF2B5EF4-FFF2-40B4-BE49-F238E27FC236}">
-                <a16:creationId xmlns:a16="http://schemas.microsoft.com/office/drawing/2014/main" id="{5E68F09F-963A-4653-AFF1-2F8DCD1DDC97}"/>
+                <a16:creationId xmlns:a16="http://schemas.microsoft.com/office/drawing/2014/main" id="{EFE867F9-AE87-40C9-95EB-1311F7D20F87}"/>
               </a:ext>
             </a:extLst>
           </p:cNvPr>
@@ -17112,7 +17112,7 @@
           <p:cNvPr id="18" name="Rectangle 17">
             <a:extLst>
               <a:ext uri="{FF2B5EF4-FFF2-40B4-BE49-F238E27FC236}">
-                <a16:creationId xmlns:a16="http://schemas.microsoft.com/office/drawing/2014/main" id="{999C28CB-18B7-4E55-A70E-7D983C41E856}"/>
+                <a16:creationId xmlns:a16="http://schemas.microsoft.com/office/drawing/2014/main" id="{83ADF858-F3CE-4F00-B3D6-2C70BCC26536}"/>
               </a:ext>
             </a:extLst>
           </p:cNvPr>
@@ -17174,7 +17174,7 @@
           <p:cNvPr id="19" name="Rectangle 18">
             <a:extLst>
               <a:ext uri="{FF2B5EF4-FFF2-40B4-BE49-F238E27FC236}">
-                <a16:creationId xmlns:a16="http://schemas.microsoft.com/office/drawing/2014/main" id="{89EEE755-5F1A-4259-AA9A-C9C9AEE882C1}"/>
+                <a16:creationId xmlns:a16="http://schemas.microsoft.com/office/drawing/2014/main" id="{D7BBFC28-2300-4376-805B-0C6385F53A56}"/>
               </a:ext>
             </a:extLst>
           </p:cNvPr>
@@ -17205,7 +17205,7 @@
           <p:cNvPr id="20" name="Rectangle 19">
             <a:extLst>
               <a:ext uri="{FF2B5EF4-FFF2-40B4-BE49-F238E27FC236}">
-                <a16:creationId xmlns:a16="http://schemas.microsoft.com/office/drawing/2014/main" id="{3BA7237A-A5B2-424B-B6B1-50F3FCA6601E}"/>
+                <a16:creationId xmlns:a16="http://schemas.microsoft.com/office/drawing/2014/main" id="{BC8FC81A-E37A-4B3F-AD0D-638AD0CF1822}"/>
               </a:ext>
             </a:extLst>
           </p:cNvPr>
@@ -17257,7 +17257,7 @@
                 <a:ea typeface="Arial"/>
                 <a:cs typeface="Arial"/>
               </a:rPr>
-              <a:t>r2z-d4c8d4cc709a · scn-e0f12f397e · prt-fd6de9d793</a:t>
+              <a:t>r2z-a7181752a17d · scn-e0f12f397e · prt-fd6de9d793</a:t>
             </a:r>
           </a:p>
         </p:txBody>
@@ -17267,7 +17267,7 @@
           <p:cNvPr id="21" name="Rectangle 20">
             <a:extLst>
               <a:ext uri="{FF2B5EF4-FFF2-40B4-BE49-F238E27FC236}">
-                <a16:creationId xmlns:a16="http://schemas.microsoft.com/office/drawing/2014/main" id="{A1317FA9-CECA-4CCD-93A2-36EF516424A0}"/>
+                <a16:creationId xmlns:a16="http://schemas.microsoft.com/office/drawing/2014/main" id="{1C38EBD9-3FA1-4DEE-9D0C-98BF1E269A37}"/>
               </a:ext>
             </a:extLst>
           </p:cNvPr>
@@ -17327,7 +17327,7 @@
     </p:spTree>
     <p:extLst>
       <p:ext uri="{BB962C8B-B14F-4D97-AF65-F5344CB8AC3E}">
-        <p14:creationId xmlns:p14="http://schemas.microsoft.com/office/powerpoint/2010/main" val="267746532"/>
+        <p14:creationId xmlns:p14="http://schemas.microsoft.com/office/powerpoint/2010/main" val="343166562"/>
       </p:ext>
     </p:extLst>
   </p:cSld>
@@ -17368,7 +17368,7 @@
             <a:hlinkClick r:id="rId3"/>
             <a:extLst>
               <a:ext uri="{FF2B5EF4-FFF2-40B4-BE49-F238E27FC236}">
-                <a16:creationId xmlns:a16="http://schemas.microsoft.com/office/drawing/2014/main" id="{F3F15D96-4F79-4E68-A6BC-6B8FDEFF256B}"/>
+                <a16:creationId xmlns:a16="http://schemas.microsoft.com/office/drawing/2014/main" id="{D2540317-7F5B-4C8F-AB98-920BD6A0E910}"/>
               </a:ext>
             </a:extLst>
           </p:cNvPr>
@@ -17443,7 +17443,7 @@
             <a:hlinkClick r:id="rId4"/>
             <a:extLst>
               <a:ext uri="{FF2B5EF4-FFF2-40B4-BE49-F238E27FC236}">
-                <a16:creationId xmlns:a16="http://schemas.microsoft.com/office/drawing/2014/main" id="{B0184771-4927-4758-AFCB-B510C9784092}"/>
+                <a16:creationId xmlns:a16="http://schemas.microsoft.com/office/drawing/2014/main" id="{72C27A9D-CBC6-4AA8-A721-648CFC412AAE}"/>
               </a:ext>
             </a:extLst>
           </p:cNvPr>
@@ -17517,7 +17517,7 @@
           <p:cNvPr id="3" name="Rectangle 2">
             <a:extLst>
               <a:ext uri="{FF2B5EF4-FFF2-40B4-BE49-F238E27FC236}">
-                <a16:creationId xmlns:a16="http://schemas.microsoft.com/office/drawing/2014/main" id="{7D8B76F6-FA21-4B74-B1C6-C3FD1C0F7F32}"/>
+                <a16:creationId xmlns:a16="http://schemas.microsoft.com/office/drawing/2014/main" id="{5574294A-8F5C-4809-B25A-B62916C18533}"/>
               </a:ext>
             </a:extLst>
           </p:cNvPr>
@@ -17579,7 +17579,7 @@
           <p:cNvPr id="4" name="Rectangle 3">
             <a:extLst>
               <a:ext uri="{FF2B5EF4-FFF2-40B4-BE49-F238E27FC236}">
-                <a16:creationId xmlns:a16="http://schemas.microsoft.com/office/drawing/2014/main" id="{9668F030-9182-4885-956F-B680EDB1BD2D}"/>
+                <a16:creationId xmlns:a16="http://schemas.microsoft.com/office/drawing/2014/main" id="{DA26E73D-54BE-43A4-B0CD-8CC400A440B7}"/>
               </a:ext>
             </a:extLst>
           </p:cNvPr>
@@ -17668,7 +17668,7 @@
           <p:cNvPr id="6" name="Rectangle: Rounded Corners 5">
             <a:extLst>
               <a:ext uri="{FF2B5EF4-FFF2-40B4-BE49-F238E27FC236}">
-                <a16:creationId xmlns:a16="http://schemas.microsoft.com/office/drawing/2014/main" id="{9F3EF0DD-7B60-49D3-B341-FA0E7CCE99F1}"/>
+                <a16:creationId xmlns:a16="http://schemas.microsoft.com/office/drawing/2014/main" id="{DC0610AC-CB72-4288-BC89-21FC0F806EE4}"/>
               </a:ext>
             </a:extLst>
           </p:cNvPr>
@@ -17701,7 +17701,7 @@
           <p:cNvPr id="7" name="Oval 6">
             <a:extLst>
               <a:ext uri="{FF2B5EF4-FFF2-40B4-BE49-F238E27FC236}">
-                <a16:creationId xmlns:a16="http://schemas.microsoft.com/office/drawing/2014/main" id="{8636660F-EDC3-4D08-8EA1-1BB6C9E2B357}"/>
+                <a16:creationId xmlns:a16="http://schemas.microsoft.com/office/drawing/2014/main" id="{79CCBEF6-0345-4BFE-8570-F06B20E8F4B6}"/>
               </a:ext>
             </a:extLst>
           </p:cNvPr>
@@ -17732,7 +17732,7 @@
           <p:cNvPr id="8" name="Rectangle 7">
             <a:extLst>
               <a:ext uri="{FF2B5EF4-FFF2-40B4-BE49-F238E27FC236}">
-                <a16:creationId xmlns:a16="http://schemas.microsoft.com/office/drawing/2014/main" id="{5DFAB6AC-6E8A-4CD9-A8C8-660541879C76}"/>
+                <a16:creationId xmlns:a16="http://schemas.microsoft.com/office/drawing/2014/main" id="{1C121F5E-CA98-4FDC-BC6D-32F9078A1051}"/>
               </a:ext>
             </a:extLst>
           </p:cNvPr>
@@ -17794,7 +17794,7 @@
           <p:cNvPr id="9" name="Rectangle: Rounded Corners 8">
             <a:extLst>
               <a:ext uri="{FF2B5EF4-FFF2-40B4-BE49-F238E27FC236}">
-                <a16:creationId xmlns:a16="http://schemas.microsoft.com/office/drawing/2014/main" id="{845206FB-EF39-4642-B31F-9EE98A83C629}"/>
+                <a16:creationId xmlns:a16="http://schemas.microsoft.com/office/drawing/2014/main" id="{86620C78-9230-43E7-A329-19CB3C799087}"/>
               </a:ext>
             </a:extLst>
           </p:cNvPr>
@@ -17829,7 +17829,7 @@
           <p:cNvPr id="10" name="Rectangle 9">
             <a:extLst>
               <a:ext uri="{FF2B5EF4-FFF2-40B4-BE49-F238E27FC236}">
-                <a16:creationId xmlns:a16="http://schemas.microsoft.com/office/drawing/2014/main" id="{BC68B510-33E8-454D-8263-2CAF8A894BAA}"/>
+                <a16:creationId xmlns:a16="http://schemas.microsoft.com/office/drawing/2014/main" id="{BAD656DA-6D43-4227-A584-E0F3D9F1F352}"/>
               </a:ext>
             </a:extLst>
           </p:cNvPr>
@@ -17891,7 +17891,7 @@
           <p:cNvPr id="11" name="Oval 10">
             <a:extLst>
               <a:ext uri="{FF2B5EF4-FFF2-40B4-BE49-F238E27FC236}">
-                <a16:creationId xmlns:a16="http://schemas.microsoft.com/office/drawing/2014/main" id="{CF30EEFE-01BA-4514-8F1A-60F61CAC3521}"/>
+                <a16:creationId xmlns:a16="http://schemas.microsoft.com/office/drawing/2014/main" id="{AEF0E351-03D5-4728-8A30-D18B0ACC5A89}"/>
               </a:ext>
             </a:extLst>
           </p:cNvPr>
@@ -17922,7 +17922,7 @@
           <p:cNvPr id="12" name="Rectangle 11">
             <a:extLst>
               <a:ext uri="{FF2B5EF4-FFF2-40B4-BE49-F238E27FC236}">
-                <a16:creationId xmlns:a16="http://schemas.microsoft.com/office/drawing/2014/main" id="{9E1AE6DB-4A12-44E3-B104-F480C6F87E82}"/>
+                <a16:creationId xmlns:a16="http://schemas.microsoft.com/office/drawing/2014/main" id="{7CFDF336-7E66-4959-A049-C5CF39C9A804}"/>
               </a:ext>
             </a:extLst>
           </p:cNvPr>
@@ -17984,7 +17984,7 @@
           <p:cNvPr id="13" name="Rectangle: Rounded Corners 12">
             <a:extLst>
               <a:ext uri="{FF2B5EF4-FFF2-40B4-BE49-F238E27FC236}">
-                <a16:creationId xmlns:a16="http://schemas.microsoft.com/office/drawing/2014/main" id="{079C4437-5FE6-4897-8ECF-614337B3941A}"/>
+                <a16:creationId xmlns:a16="http://schemas.microsoft.com/office/drawing/2014/main" id="{DCC70012-053C-4D10-BE8D-6225B6F3D139}"/>
               </a:ext>
             </a:extLst>
           </p:cNvPr>
@@ -18019,7 +18019,7 @@
           <p:cNvPr id="14" name="Rectangle 13">
             <a:extLst>
               <a:ext uri="{FF2B5EF4-FFF2-40B4-BE49-F238E27FC236}">
-                <a16:creationId xmlns:a16="http://schemas.microsoft.com/office/drawing/2014/main" id="{D46F94C2-2B09-4FA1-9006-5B12DB72D423}"/>
+                <a16:creationId xmlns:a16="http://schemas.microsoft.com/office/drawing/2014/main" id="{0EDAE898-9A20-429A-A5AA-01724F66F62D}"/>
               </a:ext>
             </a:extLst>
           </p:cNvPr>
@@ -18081,7 +18081,7 @@
           <p:cNvPr id="15" name="Oval 14">
             <a:extLst>
               <a:ext uri="{FF2B5EF4-FFF2-40B4-BE49-F238E27FC236}">
-                <a16:creationId xmlns:a16="http://schemas.microsoft.com/office/drawing/2014/main" id="{1C2D32ED-BCD6-413F-BDDF-1D82653F0C59}"/>
+                <a16:creationId xmlns:a16="http://schemas.microsoft.com/office/drawing/2014/main" id="{387F9981-36E2-4025-BEFF-5394CECDA7BE}"/>
               </a:ext>
             </a:extLst>
           </p:cNvPr>
@@ -18112,7 +18112,7 @@
           <p:cNvPr id="16" name="Rectangle 15">
             <a:extLst>
               <a:ext uri="{FF2B5EF4-FFF2-40B4-BE49-F238E27FC236}">
-                <a16:creationId xmlns:a16="http://schemas.microsoft.com/office/drawing/2014/main" id="{44267B69-A958-4E11-A9CD-E925C20F61D4}"/>
+                <a16:creationId xmlns:a16="http://schemas.microsoft.com/office/drawing/2014/main" id="{47AD6969-ABA3-404E-B519-B36B3AA573D7}"/>
               </a:ext>
             </a:extLst>
           </p:cNvPr>
@@ -18174,7 +18174,7 @@
           <p:cNvPr id="17" name="Rectangle: Rounded Corners 16">
             <a:extLst>
               <a:ext uri="{FF2B5EF4-FFF2-40B4-BE49-F238E27FC236}">
-                <a16:creationId xmlns:a16="http://schemas.microsoft.com/office/drawing/2014/main" id="{AF6DA9EE-B7FB-43F8-8AE2-42FD96D726F9}"/>
+                <a16:creationId xmlns:a16="http://schemas.microsoft.com/office/drawing/2014/main" id="{AE7A4D52-FA19-4604-B4F7-B3F920E68B73}"/>
               </a:ext>
             </a:extLst>
           </p:cNvPr>
@@ -18209,7 +18209,7 @@
           <p:cNvPr id="18" name="Rectangle 17">
             <a:extLst>
               <a:ext uri="{FF2B5EF4-FFF2-40B4-BE49-F238E27FC236}">
-                <a16:creationId xmlns:a16="http://schemas.microsoft.com/office/drawing/2014/main" id="{D9FFA410-F4C6-4E54-BA1A-31867C766413}"/>
+                <a16:creationId xmlns:a16="http://schemas.microsoft.com/office/drawing/2014/main" id="{3D6B457B-2E0D-4C2C-A764-D7B724502D9F}"/>
               </a:ext>
             </a:extLst>
           </p:cNvPr>
@@ -18271,7 +18271,7 @@
           <p:cNvPr id="19" name="Rectangle 18">
             <a:extLst>
               <a:ext uri="{FF2B5EF4-FFF2-40B4-BE49-F238E27FC236}">
-                <a16:creationId xmlns:a16="http://schemas.microsoft.com/office/drawing/2014/main" id="{C08CF11A-A1C1-4C4F-A339-6828E1513663}"/>
+                <a16:creationId xmlns:a16="http://schemas.microsoft.com/office/drawing/2014/main" id="{1B0BC8D6-5E19-43F5-A16B-C0390F303DDA}"/>
               </a:ext>
             </a:extLst>
           </p:cNvPr>
@@ -18302,7 +18302,7 @@
           <p:cNvPr id="20" name="Rectangle 19">
             <a:extLst>
               <a:ext uri="{FF2B5EF4-FFF2-40B4-BE49-F238E27FC236}">
-                <a16:creationId xmlns:a16="http://schemas.microsoft.com/office/drawing/2014/main" id="{5A5296E5-0532-4A89-8C85-EB7917805ABC}"/>
+                <a16:creationId xmlns:a16="http://schemas.microsoft.com/office/drawing/2014/main" id="{E9A21CCF-7111-4F5F-8CCC-FBB0BCDA150C}"/>
               </a:ext>
             </a:extLst>
           </p:cNvPr>
@@ -18354,7 +18354,7 @@
                 <a:ea typeface="Arial"/>
                 <a:cs typeface="Arial"/>
               </a:rPr>
-              <a:t>r2z-d4c8d4cc709a · scn-e0f12f397e · prt-fd6de9d793</a:t>
+              <a:t>r2z-a7181752a17d · scn-e0f12f397e · prt-fd6de9d793</a:t>
             </a:r>
           </a:p>
         </p:txBody>
@@ -18364,7 +18364,7 @@
           <p:cNvPr id="21" name="Rectangle 20">
             <a:extLst>
               <a:ext uri="{FF2B5EF4-FFF2-40B4-BE49-F238E27FC236}">
-                <a16:creationId xmlns:a16="http://schemas.microsoft.com/office/drawing/2014/main" id="{C1056A2A-5274-40EC-8FD6-FE42848E3EE4}"/>
+                <a16:creationId xmlns:a16="http://schemas.microsoft.com/office/drawing/2014/main" id="{BA0E1ABA-9A17-42DC-902C-D60E6B927A64}"/>
               </a:ext>
             </a:extLst>
           </p:cNvPr>
@@ -18424,7 +18424,7 @@
     </p:spTree>
     <p:extLst>
       <p:ext uri="{BB962C8B-B14F-4D97-AF65-F5344CB8AC3E}">
-        <p14:creationId xmlns:p14="http://schemas.microsoft.com/office/powerpoint/2010/main" val="483070044"/>
+        <p14:creationId xmlns:p14="http://schemas.microsoft.com/office/powerpoint/2010/main" val="978969316"/>
       </p:ext>
     </p:extLst>
   </p:cSld>
@@ -18465,7 +18465,7 @@
             <a:hlinkClick r:id="rId3"/>
             <a:extLst>
               <a:ext uri="{FF2B5EF4-FFF2-40B4-BE49-F238E27FC236}">
-                <a16:creationId xmlns:a16="http://schemas.microsoft.com/office/drawing/2014/main" id="{E71D383A-E0CE-4589-B5E2-95695A17240E}"/>
+                <a16:creationId xmlns:a16="http://schemas.microsoft.com/office/drawing/2014/main" id="{178B1607-8FD9-4928-AB60-C6BE41ADEA39}"/>
               </a:ext>
             </a:extLst>
           </p:cNvPr>
@@ -18540,7 +18540,7 @@
             <a:hlinkClick r:id="rId4"/>
             <a:extLst>
               <a:ext uri="{FF2B5EF4-FFF2-40B4-BE49-F238E27FC236}">
-                <a16:creationId xmlns:a16="http://schemas.microsoft.com/office/drawing/2014/main" id="{8709EB3A-CE87-4252-9CBA-0C2D3C79E7FC}"/>
+                <a16:creationId xmlns:a16="http://schemas.microsoft.com/office/drawing/2014/main" id="{F8079C95-6B5F-484B-A131-50430B6DA066}"/>
               </a:ext>
             </a:extLst>
           </p:cNvPr>
@@ -18614,7 +18614,7 @@
           <p:cNvPr id="3" name="Rectangle 2">
             <a:extLst>
               <a:ext uri="{FF2B5EF4-FFF2-40B4-BE49-F238E27FC236}">
-                <a16:creationId xmlns:a16="http://schemas.microsoft.com/office/drawing/2014/main" id="{EEBB864C-F1F8-49A8-985B-60E9640F7E6D}"/>
+                <a16:creationId xmlns:a16="http://schemas.microsoft.com/office/drawing/2014/main" id="{328EE187-3420-4BBB-B7C9-EAC051628896}"/>
               </a:ext>
             </a:extLst>
           </p:cNvPr>
@@ -18676,7 +18676,7 @@
           <p:cNvPr id="4" name="Rectangle 3">
             <a:extLst>
               <a:ext uri="{FF2B5EF4-FFF2-40B4-BE49-F238E27FC236}">
-                <a16:creationId xmlns:a16="http://schemas.microsoft.com/office/drawing/2014/main" id="{0D9E8EC8-4F06-4C01-8C05-0012E15F618F}"/>
+                <a16:creationId xmlns:a16="http://schemas.microsoft.com/office/drawing/2014/main" id="{A078A925-5113-477B-9B45-52EB6417FAFF}"/>
               </a:ext>
             </a:extLst>
           </p:cNvPr>
@@ -18765,7 +18765,7 @@
           <p:cNvPr id="6" name="Rectangle: Rounded Corners 5">
             <a:extLst>
               <a:ext uri="{FF2B5EF4-FFF2-40B4-BE49-F238E27FC236}">
-                <a16:creationId xmlns:a16="http://schemas.microsoft.com/office/drawing/2014/main" id="{6CBF0E6E-F1E5-4287-AD7F-E6F812C56970}"/>
+                <a16:creationId xmlns:a16="http://schemas.microsoft.com/office/drawing/2014/main" id="{AFA2B169-E78D-4EEB-8A6F-F1D270A65CF4}"/>
               </a:ext>
             </a:extLst>
           </p:cNvPr>
@@ -18798,7 +18798,7 @@
           <p:cNvPr id="7" name="Oval 6">
             <a:extLst>
               <a:ext uri="{FF2B5EF4-FFF2-40B4-BE49-F238E27FC236}">
-                <a16:creationId xmlns:a16="http://schemas.microsoft.com/office/drawing/2014/main" id="{07EE46C4-3A6D-47AF-98FB-53036F6FEE54}"/>
+                <a16:creationId xmlns:a16="http://schemas.microsoft.com/office/drawing/2014/main" id="{0AA6220C-CB43-410F-A21D-FBD1D0F51F20}"/>
               </a:ext>
             </a:extLst>
           </p:cNvPr>
@@ -18829,7 +18829,7 @@
           <p:cNvPr id="8" name="Rectangle 7">
             <a:extLst>
               <a:ext uri="{FF2B5EF4-FFF2-40B4-BE49-F238E27FC236}">
-                <a16:creationId xmlns:a16="http://schemas.microsoft.com/office/drawing/2014/main" id="{B1AC4D29-A9B3-4EC1-803A-8FA03B4B36A2}"/>
+                <a16:creationId xmlns:a16="http://schemas.microsoft.com/office/drawing/2014/main" id="{BBFE3D27-F263-40D4-A55A-64EFF5415AF6}"/>
               </a:ext>
             </a:extLst>
           </p:cNvPr>
@@ -18891,7 +18891,7 @@
           <p:cNvPr id="9" name="Rectangle: Rounded Corners 8">
             <a:extLst>
               <a:ext uri="{FF2B5EF4-FFF2-40B4-BE49-F238E27FC236}">
-                <a16:creationId xmlns:a16="http://schemas.microsoft.com/office/drawing/2014/main" id="{60C0BCD1-7AF0-4CFC-A119-65330F9F2865}"/>
+                <a16:creationId xmlns:a16="http://schemas.microsoft.com/office/drawing/2014/main" id="{218ACEF0-F1D8-494C-A167-E4E1B9CCD688}"/>
               </a:ext>
             </a:extLst>
           </p:cNvPr>
@@ -18926,7 +18926,7 @@
           <p:cNvPr id="10" name="Rectangle 9">
             <a:extLst>
               <a:ext uri="{FF2B5EF4-FFF2-40B4-BE49-F238E27FC236}">
-                <a16:creationId xmlns:a16="http://schemas.microsoft.com/office/drawing/2014/main" id="{28D6E99C-D290-4149-B6D7-D1D9C6F9D299}"/>
+                <a16:creationId xmlns:a16="http://schemas.microsoft.com/office/drawing/2014/main" id="{508543AC-6CB8-47E5-B5D8-6824183F47C5}"/>
               </a:ext>
             </a:extLst>
           </p:cNvPr>
@@ -18988,7 +18988,7 @@
           <p:cNvPr id="11" name="Oval 10">
             <a:extLst>
               <a:ext uri="{FF2B5EF4-FFF2-40B4-BE49-F238E27FC236}">
-                <a16:creationId xmlns:a16="http://schemas.microsoft.com/office/drawing/2014/main" id="{87A60282-F8E9-466C-B706-4E1A50E0E3EA}"/>
+                <a16:creationId xmlns:a16="http://schemas.microsoft.com/office/drawing/2014/main" id="{8BEA8B9E-ADAE-42FA-A4E1-623BB6D43765}"/>
               </a:ext>
             </a:extLst>
           </p:cNvPr>
@@ -19019,7 +19019,7 @@
           <p:cNvPr id="12" name="Rectangle 11">
             <a:extLst>
               <a:ext uri="{FF2B5EF4-FFF2-40B4-BE49-F238E27FC236}">
-                <a16:creationId xmlns:a16="http://schemas.microsoft.com/office/drawing/2014/main" id="{73755B59-6C5F-4719-A461-F36D108DF6B2}"/>
+                <a16:creationId xmlns:a16="http://schemas.microsoft.com/office/drawing/2014/main" id="{4F054936-9844-4BD7-B011-F0D6245AECC9}"/>
               </a:ext>
             </a:extLst>
           </p:cNvPr>
@@ -19081,7 +19081,7 @@
           <p:cNvPr id="13" name="Rectangle: Rounded Corners 12">
             <a:extLst>
               <a:ext uri="{FF2B5EF4-FFF2-40B4-BE49-F238E27FC236}">
-                <a16:creationId xmlns:a16="http://schemas.microsoft.com/office/drawing/2014/main" id="{CF9C0DBF-D931-4493-916A-97E286F9BC6E}"/>
+                <a16:creationId xmlns:a16="http://schemas.microsoft.com/office/drawing/2014/main" id="{974BE317-5156-4F7D-AB56-343DF0BA0593}"/>
               </a:ext>
             </a:extLst>
           </p:cNvPr>
@@ -19116,7 +19116,7 @@
           <p:cNvPr id="14" name="Rectangle 13">
             <a:extLst>
               <a:ext uri="{FF2B5EF4-FFF2-40B4-BE49-F238E27FC236}">
-                <a16:creationId xmlns:a16="http://schemas.microsoft.com/office/drawing/2014/main" id="{1B1DDB75-412F-4C4F-9353-14C279580DE2}"/>
+                <a16:creationId xmlns:a16="http://schemas.microsoft.com/office/drawing/2014/main" id="{1B3D3047-393A-4D1C-8E61-A7D0F094D48A}"/>
               </a:ext>
             </a:extLst>
           </p:cNvPr>
@@ -19178,7 +19178,7 @@
           <p:cNvPr id="15" name="Oval 14">
             <a:extLst>
               <a:ext uri="{FF2B5EF4-FFF2-40B4-BE49-F238E27FC236}">
-                <a16:creationId xmlns:a16="http://schemas.microsoft.com/office/drawing/2014/main" id="{1372F7DF-AB9B-421B-B9E1-B63A0A213C63}"/>
+                <a16:creationId xmlns:a16="http://schemas.microsoft.com/office/drawing/2014/main" id="{5565B0F3-D714-42C1-8823-675A2DD9A12C}"/>
               </a:ext>
             </a:extLst>
           </p:cNvPr>
@@ -19209,7 +19209,7 @@
           <p:cNvPr id="16" name="Rectangle 15">
             <a:extLst>
               <a:ext uri="{FF2B5EF4-FFF2-40B4-BE49-F238E27FC236}">
-                <a16:creationId xmlns:a16="http://schemas.microsoft.com/office/drawing/2014/main" id="{28EA6D74-3735-4316-8AD0-08711A4C12EF}"/>
+                <a16:creationId xmlns:a16="http://schemas.microsoft.com/office/drawing/2014/main" id="{991B13C6-8EE5-46D0-878F-E679CBD7EA23}"/>
               </a:ext>
             </a:extLst>
           </p:cNvPr>
@@ -19271,7 +19271,7 @@
           <p:cNvPr id="17" name="Rectangle: Rounded Corners 16">
             <a:extLst>
               <a:ext uri="{FF2B5EF4-FFF2-40B4-BE49-F238E27FC236}">
-                <a16:creationId xmlns:a16="http://schemas.microsoft.com/office/drawing/2014/main" id="{A3406500-A1DF-4B52-95D9-90F91E8078B9}"/>
+                <a16:creationId xmlns:a16="http://schemas.microsoft.com/office/drawing/2014/main" id="{0E085A36-8F44-4F03-8F1A-4B24D44D783A}"/>
               </a:ext>
             </a:extLst>
           </p:cNvPr>
@@ -19306,7 +19306,7 @@
           <p:cNvPr id="18" name="Rectangle 17">
             <a:extLst>
               <a:ext uri="{FF2B5EF4-FFF2-40B4-BE49-F238E27FC236}">
-                <a16:creationId xmlns:a16="http://schemas.microsoft.com/office/drawing/2014/main" id="{44638F9A-8CF7-46F8-9529-8FDF6C6C1308}"/>
+                <a16:creationId xmlns:a16="http://schemas.microsoft.com/office/drawing/2014/main" id="{6CEE93C8-8000-4AF3-86CD-1D2461ED0DCC}"/>
               </a:ext>
             </a:extLst>
           </p:cNvPr>
@@ -19368,7 +19368,7 @@
           <p:cNvPr id="19" name="Rectangle 18">
             <a:extLst>
               <a:ext uri="{FF2B5EF4-FFF2-40B4-BE49-F238E27FC236}">
-                <a16:creationId xmlns:a16="http://schemas.microsoft.com/office/drawing/2014/main" id="{C3A4B490-90BE-4053-BD23-FB2E9FF657E0}"/>
+                <a16:creationId xmlns:a16="http://schemas.microsoft.com/office/drawing/2014/main" id="{D1D555D9-4DED-41A1-8951-CFB8EB68FCAE}"/>
               </a:ext>
             </a:extLst>
           </p:cNvPr>
@@ -19399,7 +19399,7 @@
           <p:cNvPr id="20" name="Rectangle 19">
             <a:extLst>
               <a:ext uri="{FF2B5EF4-FFF2-40B4-BE49-F238E27FC236}">
-                <a16:creationId xmlns:a16="http://schemas.microsoft.com/office/drawing/2014/main" id="{33DBE82B-E2BA-4BE8-BCE9-0FD793CAB1D6}"/>
+                <a16:creationId xmlns:a16="http://schemas.microsoft.com/office/drawing/2014/main" id="{DF7C9D0A-F22E-4DA1-9FFB-35314A7C6F4B}"/>
               </a:ext>
             </a:extLst>
           </p:cNvPr>
@@ -19451,7 +19451,7 @@
                 <a:ea typeface="Arial"/>
                 <a:cs typeface="Arial"/>
               </a:rPr>
-              <a:t>r2z-d4c8d4cc709a · scn-e0f12f397e · prt-fd6de9d793</a:t>
+              <a:t>r2z-a7181752a17d · scn-e0f12f397e · prt-fd6de9d793</a:t>
             </a:r>
           </a:p>
         </p:txBody>
@@ -19461,7 +19461,7 @@
           <p:cNvPr id="21" name="Rectangle 20">
             <a:extLst>
               <a:ext uri="{FF2B5EF4-FFF2-40B4-BE49-F238E27FC236}">
-                <a16:creationId xmlns:a16="http://schemas.microsoft.com/office/drawing/2014/main" id="{1C8E2E54-58CC-4EBA-8697-7C0E4E3ED38E}"/>
+                <a16:creationId xmlns:a16="http://schemas.microsoft.com/office/drawing/2014/main" id="{E22E7B14-A615-454D-B494-B77184700A21}"/>
               </a:ext>
             </a:extLst>
           </p:cNvPr>
@@ -19521,7 +19521,7 @@
     </p:spTree>
     <p:extLst>
       <p:ext uri="{BB962C8B-B14F-4D97-AF65-F5344CB8AC3E}">
-        <p14:creationId xmlns:p14="http://schemas.microsoft.com/office/powerpoint/2010/main" val="1468527240"/>
+        <p14:creationId xmlns:p14="http://schemas.microsoft.com/office/powerpoint/2010/main" val="846153784"/>
       </p:ext>
     </p:extLst>
   </p:cSld>
@@ -19562,7 +19562,7 @@
             <a:hlinkClick r:id="rId3"/>
             <a:extLst>
               <a:ext uri="{FF2B5EF4-FFF2-40B4-BE49-F238E27FC236}">
-                <a16:creationId xmlns:a16="http://schemas.microsoft.com/office/drawing/2014/main" id="{3F08B46F-7A7F-49B2-990B-98BC5AC1EDB4}"/>
+                <a16:creationId xmlns:a16="http://schemas.microsoft.com/office/drawing/2014/main" id="{FFF1773E-0753-4DE4-8660-1D19A8D79301}"/>
               </a:ext>
             </a:extLst>
           </p:cNvPr>
@@ -19637,7 +19637,7 @@
             <a:hlinkClick r:id="rId4"/>
             <a:extLst>
               <a:ext uri="{FF2B5EF4-FFF2-40B4-BE49-F238E27FC236}">
-                <a16:creationId xmlns:a16="http://schemas.microsoft.com/office/drawing/2014/main" id="{A0FA976A-9CF1-4992-87E0-6992A03729E2}"/>
+                <a16:creationId xmlns:a16="http://schemas.microsoft.com/office/drawing/2014/main" id="{F83AC99E-E206-4977-B3CE-5BABB091DAF2}"/>
               </a:ext>
             </a:extLst>
           </p:cNvPr>
@@ -19711,7 +19711,7 @@
           <p:cNvPr id="3" name="Rectangle 2">
             <a:extLst>
               <a:ext uri="{FF2B5EF4-FFF2-40B4-BE49-F238E27FC236}">
-                <a16:creationId xmlns:a16="http://schemas.microsoft.com/office/drawing/2014/main" id="{718B5FF7-75FE-4546-BACA-017108A01DBA}"/>
+                <a16:creationId xmlns:a16="http://schemas.microsoft.com/office/drawing/2014/main" id="{B7F5DBE4-2928-4C42-AE34-8946416B6C14}"/>
               </a:ext>
             </a:extLst>
           </p:cNvPr>
@@ -19773,7 +19773,7 @@
           <p:cNvPr id="4" name="Rectangle 3">
             <a:extLst>
               <a:ext uri="{FF2B5EF4-FFF2-40B4-BE49-F238E27FC236}">
-                <a16:creationId xmlns:a16="http://schemas.microsoft.com/office/drawing/2014/main" id="{F0BA1FF5-468C-40ED-AEF1-972A2F050FD5}"/>
+                <a16:creationId xmlns:a16="http://schemas.microsoft.com/office/drawing/2014/main" id="{2BD4E3F6-081D-4211-9B5C-4B08F68153B5}"/>
               </a:ext>
             </a:extLst>
           </p:cNvPr>
@@ -19862,7 +19862,7 @@
           <p:cNvPr id="6" name="Rectangle: Rounded Corners 5">
             <a:extLst>
               <a:ext uri="{FF2B5EF4-FFF2-40B4-BE49-F238E27FC236}">
-                <a16:creationId xmlns:a16="http://schemas.microsoft.com/office/drawing/2014/main" id="{A946D82A-7083-4DE4-B008-A544C6B18EB8}"/>
+                <a16:creationId xmlns:a16="http://schemas.microsoft.com/office/drawing/2014/main" id="{EF5CC028-DB8E-4619-9FF7-DC7E5325D244}"/>
               </a:ext>
             </a:extLst>
           </p:cNvPr>
@@ -19911,7 +19911,7 @@
           <p:cNvPr id="8" name="Rectangle 7">
             <a:extLst>
               <a:ext uri="{FF2B5EF4-FFF2-40B4-BE49-F238E27FC236}">
-                <a16:creationId xmlns:a16="http://schemas.microsoft.com/office/drawing/2014/main" id="{28703A27-A9FF-4701-82B0-0FFDD2F67356}"/>
+                <a16:creationId xmlns:a16="http://schemas.microsoft.com/office/drawing/2014/main" id="{8CA18D47-154B-4173-B0D7-06C336F2174E}"/>
               </a:ext>
             </a:extLst>
           </p:cNvPr>
@@ -19973,7 +19973,7 @@
           <p:cNvPr id="9" name="Rectangle 8">
             <a:extLst>
               <a:ext uri="{FF2B5EF4-FFF2-40B4-BE49-F238E27FC236}">
-                <a16:creationId xmlns:a16="http://schemas.microsoft.com/office/drawing/2014/main" id="{631B4F34-D003-4EC2-A82D-8C2147E4895D}"/>
+                <a16:creationId xmlns:a16="http://schemas.microsoft.com/office/drawing/2014/main" id="{941A00C2-D54A-407B-9303-8EC6C167FF54}"/>
               </a:ext>
             </a:extLst>
           </p:cNvPr>
@@ -20035,7 +20035,7 @@
           <p:cNvPr id="10" name="Rectangle 9">
             <a:extLst>
               <a:ext uri="{FF2B5EF4-FFF2-40B4-BE49-F238E27FC236}">
-                <a16:creationId xmlns:a16="http://schemas.microsoft.com/office/drawing/2014/main" id="{42547F0F-CFCE-49E9-AF84-6C3468414E3B}"/>
+                <a16:creationId xmlns:a16="http://schemas.microsoft.com/office/drawing/2014/main" id="{94BB839C-16A0-437A-885A-602E9295D172}"/>
               </a:ext>
             </a:extLst>
           </p:cNvPr>
@@ -20097,7 +20097,7 @@
           <p:cNvPr id="11" name="Rectangle: Rounded Corners 10">
             <a:extLst>
               <a:ext uri="{FF2B5EF4-FFF2-40B4-BE49-F238E27FC236}">
-                <a16:creationId xmlns:a16="http://schemas.microsoft.com/office/drawing/2014/main" id="{D9BC59F5-FA1D-44FB-8BB4-DE1C22CDA1D4}"/>
+                <a16:creationId xmlns:a16="http://schemas.microsoft.com/office/drawing/2014/main" id="{1FCBD50D-55FA-406D-AFD4-00A135CCCDF5}"/>
               </a:ext>
             </a:extLst>
           </p:cNvPr>
@@ -20130,7 +20130,7 @@
           <p:cNvPr id="12" name="Rectangle 11">
             <a:extLst>
               <a:ext uri="{FF2B5EF4-FFF2-40B4-BE49-F238E27FC236}">
-                <a16:creationId xmlns:a16="http://schemas.microsoft.com/office/drawing/2014/main" id="{E3A155C7-0CB8-4A2C-8125-1D464676D567}"/>
+                <a16:creationId xmlns:a16="http://schemas.microsoft.com/office/drawing/2014/main" id="{FAF2739D-8B83-4BDB-BD82-85C9263A4D01}"/>
               </a:ext>
             </a:extLst>
           </p:cNvPr>
@@ -20192,7 +20192,7 @@
           <p:cNvPr id="13" name="Rectangle: Rounded Corners 12">
             <a:extLst>
               <a:ext uri="{FF2B5EF4-FFF2-40B4-BE49-F238E27FC236}">
-                <a16:creationId xmlns:a16="http://schemas.microsoft.com/office/drawing/2014/main" id="{9BA760BE-7409-4924-AEAB-DB4D563696BC}"/>
+                <a16:creationId xmlns:a16="http://schemas.microsoft.com/office/drawing/2014/main" id="{EB14AB06-CDF2-4FA2-906C-5642A712CA38}"/>
               </a:ext>
             </a:extLst>
           </p:cNvPr>
@@ -20225,7 +20225,7 @@
           <p:cNvPr id="14" name="Rectangle 13">
             <a:extLst>
               <a:ext uri="{FF2B5EF4-FFF2-40B4-BE49-F238E27FC236}">
-                <a16:creationId xmlns:a16="http://schemas.microsoft.com/office/drawing/2014/main" id="{28A4F1E2-5F67-4437-A48D-3534EC0C738E}"/>
+                <a16:creationId xmlns:a16="http://schemas.microsoft.com/office/drawing/2014/main" id="{8FA95B34-D32A-4930-A803-6AFBD04204CC}"/>
               </a:ext>
             </a:extLst>
           </p:cNvPr>
@@ -20287,7 +20287,7 @@
           <p:cNvPr id="15" name="Rectangle 14">
             <a:extLst>
               <a:ext uri="{FF2B5EF4-FFF2-40B4-BE49-F238E27FC236}">
-                <a16:creationId xmlns:a16="http://schemas.microsoft.com/office/drawing/2014/main" id="{C87437DE-77EC-4694-A4E4-F6E317E37047}"/>
+                <a16:creationId xmlns:a16="http://schemas.microsoft.com/office/drawing/2014/main" id="{317D688D-9C9A-4068-B332-CC8B399F660D}"/>
               </a:ext>
             </a:extLst>
           </p:cNvPr>
@@ -20318,7 +20318,7 @@
           <p:cNvPr id="16" name="Rectangle 15">
             <a:extLst>
               <a:ext uri="{FF2B5EF4-FFF2-40B4-BE49-F238E27FC236}">
-                <a16:creationId xmlns:a16="http://schemas.microsoft.com/office/drawing/2014/main" id="{A54B0F84-31F4-4662-B92F-79146DF4557C}"/>
+                <a16:creationId xmlns:a16="http://schemas.microsoft.com/office/drawing/2014/main" id="{E3266DE2-3EB3-4FB0-A3CD-4A6BDA78BA0A}"/>
               </a:ext>
             </a:extLst>
           </p:cNvPr>
@@ -20370,7 +20370,7 @@
                 <a:ea typeface="Arial"/>
                 <a:cs typeface="Arial"/>
               </a:rPr>
-              <a:t>r2z-d4c8d4cc709a · scn-e0f12f397e · prt-fd6de9d793 · service-v1-266e0b1d</a:t>
+              <a:t>r2z-a7181752a17d · scn-e0f12f397e · prt-fd6de9d793 · service-v1-266e0b1d</a:t>
             </a:r>
           </a:p>
         </p:txBody>
@@ -20380,7 +20380,7 @@
           <p:cNvPr id="17" name="Rectangle 16">
             <a:extLst>
               <a:ext uri="{FF2B5EF4-FFF2-40B4-BE49-F238E27FC236}">
-                <a16:creationId xmlns:a16="http://schemas.microsoft.com/office/drawing/2014/main" id="{9208DA0D-0457-486F-8504-BA8AD62E8B09}"/>
+                <a16:creationId xmlns:a16="http://schemas.microsoft.com/office/drawing/2014/main" id="{3CDCFD9A-33EF-4D92-AE64-E9AA77E51BD9}"/>
               </a:ext>
             </a:extLst>
           </p:cNvPr>
@@ -20440,7 +20440,7 @@
     </p:spTree>
     <p:extLst>
       <p:ext uri="{BB962C8B-B14F-4D97-AF65-F5344CB8AC3E}">
-        <p14:creationId xmlns:p14="http://schemas.microsoft.com/office/powerpoint/2010/main" val="1846655817"/>
+        <p14:creationId xmlns:p14="http://schemas.microsoft.com/office/powerpoint/2010/main" val="1079132304"/>
       </p:ext>
     </p:extLst>
   </p:cSld>
@@ -20481,7 +20481,7 @@
             <a:hlinkClick r:id="rId3"/>
             <a:extLst>
               <a:ext uri="{FF2B5EF4-FFF2-40B4-BE49-F238E27FC236}">
-                <a16:creationId xmlns:a16="http://schemas.microsoft.com/office/drawing/2014/main" id="{1026C430-7B06-4D77-989C-20B8C32C624F}"/>
+                <a16:creationId xmlns:a16="http://schemas.microsoft.com/office/drawing/2014/main" id="{38BABFF3-A994-4F4F-A6F9-1FAA6DF7BC23}"/>
               </a:ext>
             </a:extLst>
           </p:cNvPr>
@@ -20556,7 +20556,7 @@
             <a:hlinkClick r:id="rId4"/>
             <a:extLst>
               <a:ext uri="{FF2B5EF4-FFF2-40B4-BE49-F238E27FC236}">
-                <a16:creationId xmlns:a16="http://schemas.microsoft.com/office/drawing/2014/main" id="{7AFE2322-FAD6-436D-805C-B1C29AA3E1A7}"/>
+                <a16:creationId xmlns:a16="http://schemas.microsoft.com/office/drawing/2014/main" id="{169415CB-0650-4E30-964C-BCA0F85F6E75}"/>
               </a:ext>
             </a:extLst>
           </p:cNvPr>
@@ -20630,7 +20630,7 @@
           <p:cNvPr id="3" name="Rectangle 2">
             <a:extLst>
               <a:ext uri="{FF2B5EF4-FFF2-40B4-BE49-F238E27FC236}">
-                <a16:creationId xmlns:a16="http://schemas.microsoft.com/office/drawing/2014/main" id="{EBAB6BB2-CD7D-42F5-A6AE-F5B6DCE06DC4}"/>
+                <a16:creationId xmlns:a16="http://schemas.microsoft.com/office/drawing/2014/main" id="{31B80862-83E5-4E3B-997B-F1B442D983CB}"/>
               </a:ext>
             </a:extLst>
           </p:cNvPr>
@@ -20692,7 +20692,7 @@
           <p:cNvPr id="4" name="Rectangle 3">
             <a:extLst>
               <a:ext uri="{FF2B5EF4-FFF2-40B4-BE49-F238E27FC236}">
-                <a16:creationId xmlns:a16="http://schemas.microsoft.com/office/drawing/2014/main" id="{7B210F30-8F16-4D28-8D31-D5EB0B5B9063}"/>
+                <a16:creationId xmlns:a16="http://schemas.microsoft.com/office/drawing/2014/main" id="{5FB99DA5-9A06-4C9B-B769-3C39BFD56A78}"/>
               </a:ext>
             </a:extLst>
           </p:cNvPr>
@@ -20781,7 +20781,7 @@
           <p:cNvPr id="6" name="Rectangle: Rounded Corners 5">
             <a:extLst>
               <a:ext uri="{FF2B5EF4-FFF2-40B4-BE49-F238E27FC236}">
-                <a16:creationId xmlns:a16="http://schemas.microsoft.com/office/drawing/2014/main" id="{E12F7D06-D485-4CF2-8351-4E9BAE1F71CE}"/>
+                <a16:creationId xmlns:a16="http://schemas.microsoft.com/office/drawing/2014/main" id="{5B98ED65-4B53-447D-BF67-BB8C7263C151}"/>
               </a:ext>
             </a:extLst>
           </p:cNvPr>
@@ -20814,7 +20814,7 @@
           <p:cNvPr id="7" name="Oval 6">
             <a:extLst>
               <a:ext uri="{FF2B5EF4-FFF2-40B4-BE49-F238E27FC236}">
-                <a16:creationId xmlns:a16="http://schemas.microsoft.com/office/drawing/2014/main" id="{D39EF534-FC93-4920-AA9D-4BB8801B692F}"/>
+                <a16:creationId xmlns:a16="http://schemas.microsoft.com/office/drawing/2014/main" id="{4AEF9CC4-034A-4475-BB40-7835C1A369B4}"/>
               </a:ext>
             </a:extLst>
           </p:cNvPr>
@@ -20845,7 +20845,7 @@
           <p:cNvPr id="8" name="Rectangle 7">
             <a:extLst>
               <a:ext uri="{FF2B5EF4-FFF2-40B4-BE49-F238E27FC236}">
-                <a16:creationId xmlns:a16="http://schemas.microsoft.com/office/drawing/2014/main" id="{1C4A3F9C-E7BD-4121-B7EA-EE0631C6B898}"/>
+                <a16:creationId xmlns:a16="http://schemas.microsoft.com/office/drawing/2014/main" id="{D63F53D2-3F94-42CC-B4DE-E11C2B47117B}"/>
               </a:ext>
             </a:extLst>
           </p:cNvPr>
@@ -20907,7 +20907,7 @@
           <p:cNvPr id="9" name="Rectangle: Rounded Corners 8">
             <a:extLst>
               <a:ext uri="{FF2B5EF4-FFF2-40B4-BE49-F238E27FC236}">
-                <a16:creationId xmlns:a16="http://schemas.microsoft.com/office/drawing/2014/main" id="{8FA05284-C2A3-4E3E-816E-E2B547CB717D}"/>
+                <a16:creationId xmlns:a16="http://schemas.microsoft.com/office/drawing/2014/main" id="{49A36368-E4A9-478F-A389-2D3D3019AD80}"/>
               </a:ext>
             </a:extLst>
           </p:cNvPr>
@@ -20942,7 +20942,7 @@
           <p:cNvPr id="10" name="Rectangle 9">
             <a:extLst>
               <a:ext uri="{FF2B5EF4-FFF2-40B4-BE49-F238E27FC236}">
-                <a16:creationId xmlns:a16="http://schemas.microsoft.com/office/drawing/2014/main" id="{C778456B-1969-41AF-B648-73C64842D8D5}"/>
+                <a16:creationId xmlns:a16="http://schemas.microsoft.com/office/drawing/2014/main" id="{9FBE394F-072F-4D57-8A2A-2734DE639E19}"/>
               </a:ext>
             </a:extLst>
           </p:cNvPr>
@@ -21004,7 +21004,7 @@
           <p:cNvPr id="11" name="Oval 10">
             <a:extLst>
               <a:ext uri="{FF2B5EF4-FFF2-40B4-BE49-F238E27FC236}">
-                <a16:creationId xmlns:a16="http://schemas.microsoft.com/office/drawing/2014/main" id="{1FC1ECD4-A0FB-4B53-BAF4-B2A1684DD244}"/>
+                <a16:creationId xmlns:a16="http://schemas.microsoft.com/office/drawing/2014/main" id="{7CDD498B-9BBE-4B10-9BDD-989447BEE229}"/>
               </a:ext>
             </a:extLst>
           </p:cNvPr>
@@ -21035,7 +21035,7 @@
           <p:cNvPr id="12" name="Rectangle 11">
             <a:extLst>
               <a:ext uri="{FF2B5EF4-FFF2-40B4-BE49-F238E27FC236}">
-                <a16:creationId xmlns:a16="http://schemas.microsoft.com/office/drawing/2014/main" id="{2B3E733F-0E87-4038-9BB7-44F5632E60F5}"/>
+                <a16:creationId xmlns:a16="http://schemas.microsoft.com/office/drawing/2014/main" id="{B15E1D81-6204-4011-8843-3CB5269A61B9}"/>
               </a:ext>
             </a:extLst>
           </p:cNvPr>
@@ -21097,7 +21097,7 @@
           <p:cNvPr id="13" name="Rectangle: Rounded Corners 12">
             <a:extLst>
               <a:ext uri="{FF2B5EF4-FFF2-40B4-BE49-F238E27FC236}">
-                <a16:creationId xmlns:a16="http://schemas.microsoft.com/office/drawing/2014/main" id="{A973B118-87B2-482E-843B-3FFBB8019725}"/>
+                <a16:creationId xmlns:a16="http://schemas.microsoft.com/office/drawing/2014/main" id="{05E1C841-71E1-4ECC-87A9-744E1BC26E4A}"/>
               </a:ext>
             </a:extLst>
           </p:cNvPr>
@@ -21132,7 +21132,7 @@
           <p:cNvPr id="14" name="Rectangle 13">
             <a:extLst>
               <a:ext uri="{FF2B5EF4-FFF2-40B4-BE49-F238E27FC236}">
-                <a16:creationId xmlns:a16="http://schemas.microsoft.com/office/drawing/2014/main" id="{3C3DCC72-A1F3-460D-AA47-C0F47735F006}"/>
+                <a16:creationId xmlns:a16="http://schemas.microsoft.com/office/drawing/2014/main" id="{A2458FCB-ADD8-4FCB-A7B2-A58A29F3DC34}"/>
               </a:ext>
             </a:extLst>
           </p:cNvPr>
@@ -21194,7 +21194,7 @@
           <p:cNvPr id="15" name="Oval 14">
             <a:extLst>
               <a:ext uri="{FF2B5EF4-FFF2-40B4-BE49-F238E27FC236}">
-                <a16:creationId xmlns:a16="http://schemas.microsoft.com/office/drawing/2014/main" id="{FE49B032-EC1B-4345-8725-A3FEBD1571D0}"/>
+                <a16:creationId xmlns:a16="http://schemas.microsoft.com/office/drawing/2014/main" id="{9682BA76-001E-48A5-9C7F-3538E4BBE972}"/>
               </a:ext>
             </a:extLst>
           </p:cNvPr>
@@ -21225,7 +21225,7 @@
           <p:cNvPr id="16" name="Rectangle 15">
             <a:extLst>
               <a:ext uri="{FF2B5EF4-FFF2-40B4-BE49-F238E27FC236}">
-                <a16:creationId xmlns:a16="http://schemas.microsoft.com/office/drawing/2014/main" id="{2E6D6504-8C38-440D-A6C4-25BA11D4A69C}"/>
+                <a16:creationId xmlns:a16="http://schemas.microsoft.com/office/drawing/2014/main" id="{457CB69D-F6D9-4AE8-A7FC-453B3ECD74FB}"/>
               </a:ext>
             </a:extLst>
           </p:cNvPr>
@@ -21287,7 +21287,7 @@
           <p:cNvPr id="17" name="Rectangle: Rounded Corners 16">
             <a:extLst>
               <a:ext uri="{FF2B5EF4-FFF2-40B4-BE49-F238E27FC236}">
-                <a16:creationId xmlns:a16="http://schemas.microsoft.com/office/drawing/2014/main" id="{DE9CEB84-BEA0-4103-9871-F463E37605C1}"/>
+                <a16:creationId xmlns:a16="http://schemas.microsoft.com/office/drawing/2014/main" id="{293094AA-6F64-4348-997C-F1FF53A1F6B1}"/>
               </a:ext>
             </a:extLst>
           </p:cNvPr>
@@ -21322,7 +21322,7 @@
           <p:cNvPr id="18" name="Rectangle 17">
             <a:extLst>
               <a:ext uri="{FF2B5EF4-FFF2-40B4-BE49-F238E27FC236}">
-                <a16:creationId xmlns:a16="http://schemas.microsoft.com/office/drawing/2014/main" id="{C4EBB6E0-C65C-4E1F-8567-2BE03DDC9BE4}"/>
+                <a16:creationId xmlns:a16="http://schemas.microsoft.com/office/drawing/2014/main" id="{E5109702-C54A-4ADC-8E6C-47B3813B52A4}"/>
               </a:ext>
             </a:extLst>
           </p:cNvPr>
@@ -21384,7 +21384,7 @@
           <p:cNvPr id="19" name="Rectangle 18">
             <a:extLst>
               <a:ext uri="{FF2B5EF4-FFF2-40B4-BE49-F238E27FC236}">
-                <a16:creationId xmlns:a16="http://schemas.microsoft.com/office/drawing/2014/main" id="{2691AF2D-621A-47BF-BDD0-DA092770BE5D}"/>
+                <a16:creationId xmlns:a16="http://schemas.microsoft.com/office/drawing/2014/main" id="{E93BC0DB-85BB-4D3C-948C-92701E5DBD9A}"/>
               </a:ext>
             </a:extLst>
           </p:cNvPr>
@@ -21415,7 +21415,7 @@
           <p:cNvPr id="20" name="Rectangle 19">
             <a:extLst>
               <a:ext uri="{FF2B5EF4-FFF2-40B4-BE49-F238E27FC236}">
-                <a16:creationId xmlns:a16="http://schemas.microsoft.com/office/drawing/2014/main" id="{850FC014-896E-4108-924B-1A1B2916C8EB}"/>
+                <a16:creationId xmlns:a16="http://schemas.microsoft.com/office/drawing/2014/main" id="{D56FE17B-934D-43FB-A1FE-4475F2D96AA9}"/>
               </a:ext>
             </a:extLst>
           </p:cNvPr>
@@ -21467,7 +21467,7 @@
                 <a:ea typeface="Arial"/>
                 <a:cs typeface="Arial"/>
               </a:rPr>
-              <a:t>r2z-d4c8d4cc709a · scn-e0f12f397e · prt-fd6de9d793</a:t>
+              <a:t>r2z-a7181752a17d · scn-e0f12f397e · prt-fd6de9d793</a:t>
             </a:r>
           </a:p>
         </p:txBody>
@@ -21477,7 +21477,7 @@
           <p:cNvPr id="21" name="Rectangle 20">
             <a:extLst>
               <a:ext uri="{FF2B5EF4-FFF2-40B4-BE49-F238E27FC236}">
-                <a16:creationId xmlns:a16="http://schemas.microsoft.com/office/drawing/2014/main" id="{1860FC59-66E3-4F08-B8A5-8F62BB4F6467}"/>
+                <a16:creationId xmlns:a16="http://schemas.microsoft.com/office/drawing/2014/main" id="{EF05A0DE-50B3-44DE-9868-988EAD9415AA}"/>
               </a:ext>
             </a:extLst>
           </p:cNvPr>
@@ -21537,7 +21537,7 @@
     </p:spTree>
     <p:extLst>
       <p:ext uri="{BB962C8B-B14F-4D97-AF65-F5344CB8AC3E}">
-        <p14:creationId xmlns:p14="http://schemas.microsoft.com/office/powerpoint/2010/main" val="716377381"/>
+        <p14:creationId xmlns:p14="http://schemas.microsoft.com/office/powerpoint/2010/main" val="244821497"/>
       </p:ext>
     </p:extLst>
   </p:cSld>
@@ -21578,7 +21578,7 @@
             <a:hlinkClick r:id="rId3"/>
             <a:extLst>
               <a:ext uri="{FF2B5EF4-FFF2-40B4-BE49-F238E27FC236}">
-                <a16:creationId xmlns:a16="http://schemas.microsoft.com/office/drawing/2014/main" id="{1AF6978E-4A73-4A89-B03D-B612477D5712}"/>
+                <a16:creationId xmlns:a16="http://schemas.microsoft.com/office/drawing/2014/main" id="{0751D279-D8F1-457F-8B93-BB582149CD97}"/>
               </a:ext>
             </a:extLst>
           </p:cNvPr>
@@ -21653,7 +21653,7 @@
             <a:hlinkClick r:id="rId4"/>
             <a:extLst>
               <a:ext uri="{FF2B5EF4-FFF2-40B4-BE49-F238E27FC236}">
-                <a16:creationId xmlns:a16="http://schemas.microsoft.com/office/drawing/2014/main" id="{F54D3A77-9AFF-497F-A0A1-357CE2AD5C90}"/>
+                <a16:creationId xmlns:a16="http://schemas.microsoft.com/office/drawing/2014/main" id="{E17A73C8-17E5-45F4-9E77-7B30A5D0934E}"/>
               </a:ext>
             </a:extLst>
           </p:cNvPr>
@@ -21727,7 +21727,7 @@
           <p:cNvPr id="3" name="Rectangle 2">
             <a:extLst>
               <a:ext uri="{FF2B5EF4-FFF2-40B4-BE49-F238E27FC236}">
-                <a16:creationId xmlns:a16="http://schemas.microsoft.com/office/drawing/2014/main" id="{F371AEEB-9A9B-4163-A218-6AD4BF3C920D}"/>
+                <a16:creationId xmlns:a16="http://schemas.microsoft.com/office/drawing/2014/main" id="{A0C4D59E-BD73-4FDF-BEDC-0F05D8B70272}"/>
               </a:ext>
             </a:extLst>
           </p:cNvPr>
@@ -21789,7 +21789,7 @@
           <p:cNvPr id="4" name="Rectangle 3">
             <a:extLst>
               <a:ext uri="{FF2B5EF4-FFF2-40B4-BE49-F238E27FC236}">
-                <a16:creationId xmlns:a16="http://schemas.microsoft.com/office/drawing/2014/main" id="{A3AFDF05-54EA-4A7F-B64F-3A417B0277B6}"/>
+                <a16:creationId xmlns:a16="http://schemas.microsoft.com/office/drawing/2014/main" id="{C48D26A9-4A4F-42C1-B429-9241D06E7C1B}"/>
               </a:ext>
             </a:extLst>
           </p:cNvPr>
@@ -21878,7 +21878,7 @@
           <p:cNvPr id="6" name="Rectangle: Rounded Corners 5">
             <a:extLst>
               <a:ext uri="{FF2B5EF4-FFF2-40B4-BE49-F238E27FC236}">
-                <a16:creationId xmlns:a16="http://schemas.microsoft.com/office/drawing/2014/main" id="{157DEE80-CCAE-422E-B087-88E6076C1529}"/>
+                <a16:creationId xmlns:a16="http://schemas.microsoft.com/office/drawing/2014/main" id="{FA88E6F0-BE76-412E-B0B9-994A7F573D4F}"/>
               </a:ext>
             </a:extLst>
           </p:cNvPr>
@@ -21911,7 +21911,7 @@
           <p:cNvPr id="7" name="Oval 6">
             <a:extLst>
               <a:ext uri="{FF2B5EF4-FFF2-40B4-BE49-F238E27FC236}">
-                <a16:creationId xmlns:a16="http://schemas.microsoft.com/office/drawing/2014/main" id="{77F95A9C-3369-43AE-8D27-4608382D8E56}"/>
+                <a16:creationId xmlns:a16="http://schemas.microsoft.com/office/drawing/2014/main" id="{D03424B4-E8E3-4BA3-AC61-18FD2E6F09BC}"/>
               </a:ext>
             </a:extLst>
           </p:cNvPr>
@@ -21942,7 +21942,7 @@
           <p:cNvPr id="8" name="Rectangle 7">
             <a:extLst>
               <a:ext uri="{FF2B5EF4-FFF2-40B4-BE49-F238E27FC236}">
-                <a16:creationId xmlns:a16="http://schemas.microsoft.com/office/drawing/2014/main" id="{2C61B3F8-D02A-4472-BD22-EF8547FC9437}"/>
+                <a16:creationId xmlns:a16="http://schemas.microsoft.com/office/drawing/2014/main" id="{9D64D563-2FCC-4595-AA51-B60BB9101EFB}"/>
               </a:ext>
             </a:extLst>
           </p:cNvPr>
@@ -22004,7 +22004,7 @@
           <p:cNvPr id="9" name="Rectangle: Rounded Corners 8">
             <a:extLst>
               <a:ext uri="{FF2B5EF4-FFF2-40B4-BE49-F238E27FC236}">
-                <a16:creationId xmlns:a16="http://schemas.microsoft.com/office/drawing/2014/main" id="{D45E4EE4-8BE6-4538-B041-5B05DB3CFADD}"/>
+                <a16:creationId xmlns:a16="http://schemas.microsoft.com/office/drawing/2014/main" id="{27BD67A7-AA35-42FD-85E9-7044C861BA47}"/>
               </a:ext>
             </a:extLst>
           </p:cNvPr>
@@ -22039,7 +22039,7 @@
           <p:cNvPr id="10" name="Rectangle 9">
             <a:extLst>
               <a:ext uri="{FF2B5EF4-FFF2-40B4-BE49-F238E27FC236}">
-                <a16:creationId xmlns:a16="http://schemas.microsoft.com/office/drawing/2014/main" id="{9F51FBB9-CB10-4A60-9422-26C8A5EA7CF4}"/>
+                <a16:creationId xmlns:a16="http://schemas.microsoft.com/office/drawing/2014/main" id="{140BAC12-1375-4FAC-BB72-817752A655DB}"/>
               </a:ext>
             </a:extLst>
           </p:cNvPr>
@@ -22101,7 +22101,7 @@
           <p:cNvPr id="11" name="Oval 10">
             <a:extLst>
               <a:ext uri="{FF2B5EF4-FFF2-40B4-BE49-F238E27FC236}">
-                <a16:creationId xmlns:a16="http://schemas.microsoft.com/office/drawing/2014/main" id="{C0F4C74F-AB50-4662-8EF8-7658A80BB821}"/>
+                <a16:creationId xmlns:a16="http://schemas.microsoft.com/office/drawing/2014/main" id="{1BAC6BFF-76B3-47A7-8BCF-4B1383EDD216}"/>
               </a:ext>
             </a:extLst>
           </p:cNvPr>
@@ -22132,7 +22132,7 @@
           <p:cNvPr id="12" name="Rectangle 11">
             <a:extLst>
               <a:ext uri="{FF2B5EF4-FFF2-40B4-BE49-F238E27FC236}">
-                <a16:creationId xmlns:a16="http://schemas.microsoft.com/office/drawing/2014/main" id="{E742F82D-4855-4B4F-9691-6E1802BBE97F}"/>
+                <a16:creationId xmlns:a16="http://schemas.microsoft.com/office/drawing/2014/main" id="{B483E1CA-9B82-48B1-998E-01BF86C1F666}"/>
               </a:ext>
             </a:extLst>
           </p:cNvPr>
@@ -22194,7 +22194,7 @@
           <p:cNvPr id="13" name="Rectangle: Rounded Corners 12">
             <a:extLst>
               <a:ext uri="{FF2B5EF4-FFF2-40B4-BE49-F238E27FC236}">
-                <a16:creationId xmlns:a16="http://schemas.microsoft.com/office/drawing/2014/main" id="{9B0E7E5A-B65F-4E23-B397-C26C0A8C2DAB}"/>
+                <a16:creationId xmlns:a16="http://schemas.microsoft.com/office/drawing/2014/main" id="{CD97D84B-9B81-4CA8-BA6A-4BC41B48A696}"/>
               </a:ext>
             </a:extLst>
           </p:cNvPr>
@@ -22229,7 +22229,7 @@
           <p:cNvPr id="14" name="Rectangle 13">
             <a:extLst>
               <a:ext uri="{FF2B5EF4-FFF2-40B4-BE49-F238E27FC236}">
-                <a16:creationId xmlns:a16="http://schemas.microsoft.com/office/drawing/2014/main" id="{468ADB86-39CB-4A7F-A30E-C12AAD8C0C1A}"/>
+                <a16:creationId xmlns:a16="http://schemas.microsoft.com/office/drawing/2014/main" id="{60308633-8ECD-4ABF-925B-390F638E2614}"/>
               </a:ext>
             </a:extLst>
           </p:cNvPr>
@@ -22291,7 +22291,7 @@
           <p:cNvPr id="15" name="Oval 14">
             <a:extLst>
               <a:ext uri="{FF2B5EF4-FFF2-40B4-BE49-F238E27FC236}">
-                <a16:creationId xmlns:a16="http://schemas.microsoft.com/office/drawing/2014/main" id="{5B0D082F-4C87-44A1-896B-51F00B0C93FB}"/>
+                <a16:creationId xmlns:a16="http://schemas.microsoft.com/office/drawing/2014/main" id="{F4E867D7-87CD-4934-814D-AD8D53C0F806}"/>
               </a:ext>
             </a:extLst>
           </p:cNvPr>
@@ -22322,7 +22322,7 @@
           <p:cNvPr id="16" name="Rectangle 15">
             <a:extLst>
               <a:ext uri="{FF2B5EF4-FFF2-40B4-BE49-F238E27FC236}">
-                <a16:creationId xmlns:a16="http://schemas.microsoft.com/office/drawing/2014/main" id="{F1AEBF66-687F-46EB-A619-8715CF5E9FF7}"/>
+                <a16:creationId xmlns:a16="http://schemas.microsoft.com/office/drawing/2014/main" id="{34F95559-88D5-478F-908C-01F4868B4A6E}"/>
               </a:ext>
             </a:extLst>
           </p:cNvPr>
@@ -22384,7 +22384,7 @@
           <p:cNvPr id="17" name="Rectangle: Rounded Corners 16">
             <a:extLst>
               <a:ext uri="{FF2B5EF4-FFF2-40B4-BE49-F238E27FC236}">
-                <a16:creationId xmlns:a16="http://schemas.microsoft.com/office/drawing/2014/main" id="{07E7D4A4-BDB8-44C8-926F-2D06A8E9EB61}"/>
+                <a16:creationId xmlns:a16="http://schemas.microsoft.com/office/drawing/2014/main" id="{CF7C8369-1517-4091-A4F1-EA3D25FB8F6D}"/>
               </a:ext>
             </a:extLst>
           </p:cNvPr>
@@ -22419,7 +22419,7 @@
           <p:cNvPr id="18" name="Rectangle 17">
             <a:extLst>
               <a:ext uri="{FF2B5EF4-FFF2-40B4-BE49-F238E27FC236}">
-                <a16:creationId xmlns:a16="http://schemas.microsoft.com/office/drawing/2014/main" id="{4A96214C-CDCA-4DC0-8E22-D3205F226420}"/>
+                <a16:creationId xmlns:a16="http://schemas.microsoft.com/office/drawing/2014/main" id="{4CF1D388-46F2-47BC-972F-B00EA5AC4210}"/>
               </a:ext>
             </a:extLst>
           </p:cNvPr>
@@ -22481,7 +22481,7 @@
           <p:cNvPr id="19" name="Rectangle 18">
             <a:extLst>
               <a:ext uri="{FF2B5EF4-FFF2-40B4-BE49-F238E27FC236}">
-                <a16:creationId xmlns:a16="http://schemas.microsoft.com/office/drawing/2014/main" id="{FEB963F5-3C80-49CD-82B0-3E0D3E7661B0}"/>
+                <a16:creationId xmlns:a16="http://schemas.microsoft.com/office/drawing/2014/main" id="{27B55C50-4C5C-4466-8D71-584BDE4099F7}"/>
               </a:ext>
             </a:extLst>
           </p:cNvPr>
@@ -22512,7 +22512,7 @@
           <p:cNvPr id="20" name="Rectangle 19">
             <a:extLst>
               <a:ext uri="{FF2B5EF4-FFF2-40B4-BE49-F238E27FC236}">
-                <a16:creationId xmlns:a16="http://schemas.microsoft.com/office/drawing/2014/main" id="{5B513227-A2C5-4496-8AD8-F5936ED7978E}"/>
+                <a16:creationId xmlns:a16="http://schemas.microsoft.com/office/drawing/2014/main" id="{84DA0336-1FDD-4471-BE3F-57E4AA36FC9F}"/>
               </a:ext>
             </a:extLst>
           </p:cNvPr>
@@ -22564,7 +22564,7 @@
                 <a:ea typeface="Arial"/>
                 <a:cs typeface="Arial"/>
               </a:rPr>
-              <a:t>r2z-d4c8d4cc709a · scn-e0f12f397e · prt-fd6de9d793</a:t>
+              <a:t>r2z-a7181752a17d · scn-e0f12f397e · prt-fd6de9d793</a:t>
             </a:r>
           </a:p>
         </p:txBody>
@@ -22574,7 +22574,7 @@
           <p:cNvPr id="21" name="Rectangle 20">
             <a:extLst>
               <a:ext uri="{FF2B5EF4-FFF2-40B4-BE49-F238E27FC236}">
-                <a16:creationId xmlns:a16="http://schemas.microsoft.com/office/drawing/2014/main" id="{5BE63AE3-5313-462A-A17A-AF8480C87417}"/>
+                <a16:creationId xmlns:a16="http://schemas.microsoft.com/office/drawing/2014/main" id="{1F194D82-54C5-43C7-B42A-F319583125A2}"/>
               </a:ext>
             </a:extLst>
           </p:cNvPr>
@@ -22634,7 +22634,7 @@
     </p:spTree>
     <p:extLst>
       <p:ext uri="{BB962C8B-B14F-4D97-AF65-F5344CB8AC3E}">
-        <p14:creationId xmlns:p14="http://schemas.microsoft.com/office/powerpoint/2010/main" val="1666022479"/>
+        <p14:creationId xmlns:p14="http://schemas.microsoft.com/office/powerpoint/2010/main" val="216960900"/>
       </p:ext>
     </p:extLst>
   </p:cSld>
@@ -22675,7 +22675,7 @@
             <a:hlinkClick r:id="rId3"/>
             <a:extLst>
               <a:ext uri="{FF2B5EF4-FFF2-40B4-BE49-F238E27FC236}">
-                <a16:creationId xmlns:a16="http://schemas.microsoft.com/office/drawing/2014/main" id="{F827D46E-F855-4EEC-A20F-83145288E005}"/>
+                <a16:creationId xmlns:a16="http://schemas.microsoft.com/office/drawing/2014/main" id="{F5AA322F-C90B-4A7C-8833-5EC58C0AFC50}"/>
               </a:ext>
             </a:extLst>
           </p:cNvPr>
@@ -22750,7 +22750,7 @@
             <a:hlinkClick r:id="rId4"/>
             <a:extLst>
               <a:ext uri="{FF2B5EF4-FFF2-40B4-BE49-F238E27FC236}">
-                <a16:creationId xmlns:a16="http://schemas.microsoft.com/office/drawing/2014/main" id="{8BA47BD5-C76A-4881-A93C-702F22CC455F}"/>
+                <a16:creationId xmlns:a16="http://schemas.microsoft.com/office/drawing/2014/main" id="{E86DAEF7-4FEE-4713-B2FD-45252A36DAC2}"/>
               </a:ext>
             </a:extLst>
           </p:cNvPr>
@@ -22824,7 +22824,7 @@
           <p:cNvPr id="3" name="Rectangle 2">
             <a:extLst>
               <a:ext uri="{FF2B5EF4-FFF2-40B4-BE49-F238E27FC236}">
-                <a16:creationId xmlns:a16="http://schemas.microsoft.com/office/drawing/2014/main" id="{7FF1E5C2-C0DF-4EE4-B784-29808BD0663F}"/>
+                <a16:creationId xmlns:a16="http://schemas.microsoft.com/office/drawing/2014/main" id="{75E24CCC-A23A-4641-965B-CFEB8E3D5393}"/>
               </a:ext>
             </a:extLst>
           </p:cNvPr>
@@ -22886,7 +22886,7 @@
           <p:cNvPr id="4" name="Rectangle 3">
             <a:extLst>
               <a:ext uri="{FF2B5EF4-FFF2-40B4-BE49-F238E27FC236}">
-                <a16:creationId xmlns:a16="http://schemas.microsoft.com/office/drawing/2014/main" id="{953CF906-AE09-4848-BE26-E2C3FB4441D6}"/>
+                <a16:creationId xmlns:a16="http://schemas.microsoft.com/office/drawing/2014/main" id="{7C3C3EF0-1CD8-46A3-9E22-1F2CBC098819}"/>
               </a:ext>
             </a:extLst>
           </p:cNvPr>
@@ -22975,7 +22975,7 @@
           <p:cNvPr id="6" name="Rectangle: Rounded Corners 5">
             <a:extLst>
               <a:ext uri="{FF2B5EF4-FFF2-40B4-BE49-F238E27FC236}">
-                <a16:creationId xmlns:a16="http://schemas.microsoft.com/office/drawing/2014/main" id="{B5BA5571-1E23-41FF-B819-28095378DFF6}"/>
+                <a16:creationId xmlns:a16="http://schemas.microsoft.com/office/drawing/2014/main" id="{08A3EFFC-4B1C-428F-8B8A-7AA9B0388EB6}"/>
               </a:ext>
             </a:extLst>
           </p:cNvPr>
@@ -23008,7 +23008,7 @@
           <p:cNvPr id="7" name="Oval 6">
             <a:extLst>
               <a:ext uri="{FF2B5EF4-FFF2-40B4-BE49-F238E27FC236}">
-                <a16:creationId xmlns:a16="http://schemas.microsoft.com/office/drawing/2014/main" id="{2C03573E-22BD-4778-9D06-2BA9DFD06BD4}"/>
+                <a16:creationId xmlns:a16="http://schemas.microsoft.com/office/drawing/2014/main" id="{CC275937-E2CD-4663-B1C0-43DA227896DB}"/>
               </a:ext>
             </a:extLst>
           </p:cNvPr>
@@ -23039,7 +23039,7 @@
           <p:cNvPr id="8" name="Rectangle 7">
             <a:extLst>
               <a:ext uri="{FF2B5EF4-FFF2-40B4-BE49-F238E27FC236}">
-                <a16:creationId xmlns:a16="http://schemas.microsoft.com/office/drawing/2014/main" id="{440F1CA0-3E51-4C30-9FE1-5D8F009BC435}"/>
+                <a16:creationId xmlns:a16="http://schemas.microsoft.com/office/drawing/2014/main" id="{8FF69CCC-CFA6-4F37-8978-C05215903AA1}"/>
               </a:ext>
             </a:extLst>
           </p:cNvPr>
@@ -23101,7 +23101,7 @@
           <p:cNvPr id="9" name="Rectangle: Rounded Corners 8">
             <a:extLst>
               <a:ext uri="{FF2B5EF4-FFF2-40B4-BE49-F238E27FC236}">
-                <a16:creationId xmlns:a16="http://schemas.microsoft.com/office/drawing/2014/main" id="{4D16B551-6230-4521-9129-49CEC6B59C1F}"/>
+                <a16:creationId xmlns:a16="http://schemas.microsoft.com/office/drawing/2014/main" id="{5A1FE333-1DC4-4152-92DE-79CE16D1207F}"/>
               </a:ext>
             </a:extLst>
           </p:cNvPr>
@@ -23136,7 +23136,7 @@
           <p:cNvPr id="10" name="Rectangle 9">
             <a:extLst>
               <a:ext uri="{FF2B5EF4-FFF2-40B4-BE49-F238E27FC236}">
-                <a16:creationId xmlns:a16="http://schemas.microsoft.com/office/drawing/2014/main" id="{AB8110F9-1ED4-46DF-9D5C-B2DF0BC6FA03}"/>
+                <a16:creationId xmlns:a16="http://schemas.microsoft.com/office/drawing/2014/main" id="{AD205E9D-CCA7-4798-8408-171452789BAE}"/>
               </a:ext>
             </a:extLst>
           </p:cNvPr>
@@ -23198,7 +23198,7 @@
           <p:cNvPr id="11" name="Oval 10">
             <a:extLst>
               <a:ext uri="{FF2B5EF4-FFF2-40B4-BE49-F238E27FC236}">
-                <a16:creationId xmlns:a16="http://schemas.microsoft.com/office/drawing/2014/main" id="{619BF66F-7362-4B46-9824-C3A52CCC7AC9}"/>
+                <a16:creationId xmlns:a16="http://schemas.microsoft.com/office/drawing/2014/main" id="{6A492D1B-E3B3-4422-928A-C8F966379AD4}"/>
               </a:ext>
             </a:extLst>
           </p:cNvPr>
@@ -23229,7 +23229,7 @@
           <p:cNvPr id="12" name="Rectangle 11">
             <a:extLst>
               <a:ext uri="{FF2B5EF4-FFF2-40B4-BE49-F238E27FC236}">
-                <a16:creationId xmlns:a16="http://schemas.microsoft.com/office/drawing/2014/main" id="{63AE1C60-8A5F-4242-A696-7E74A6E3F686}"/>
+                <a16:creationId xmlns:a16="http://schemas.microsoft.com/office/drawing/2014/main" id="{2AE3A833-3275-40A2-A27B-AADC57983909}"/>
               </a:ext>
             </a:extLst>
           </p:cNvPr>
@@ -23291,7 +23291,7 @@
           <p:cNvPr id="13" name="Rectangle: Rounded Corners 12">
             <a:extLst>
               <a:ext uri="{FF2B5EF4-FFF2-40B4-BE49-F238E27FC236}">
-                <a16:creationId xmlns:a16="http://schemas.microsoft.com/office/drawing/2014/main" id="{AC60F3FF-F4B6-448F-8B93-62121E56EBFC}"/>
+                <a16:creationId xmlns:a16="http://schemas.microsoft.com/office/drawing/2014/main" id="{17CECDB2-181D-4BB4-B779-396E50C9CFB8}"/>
               </a:ext>
             </a:extLst>
           </p:cNvPr>
@@ -23326,7 +23326,7 @@
           <p:cNvPr id="14" name="Rectangle 13">
             <a:extLst>
               <a:ext uri="{FF2B5EF4-FFF2-40B4-BE49-F238E27FC236}">
-                <a16:creationId xmlns:a16="http://schemas.microsoft.com/office/drawing/2014/main" id="{C5EEF6E0-C353-4F2A-BC4F-F8ED8EFAF7D2}"/>
+                <a16:creationId xmlns:a16="http://schemas.microsoft.com/office/drawing/2014/main" id="{45309562-3181-47B7-A879-AE3FCF34B44A}"/>
               </a:ext>
             </a:extLst>
           </p:cNvPr>
@@ -23388,7 +23388,7 @@
           <p:cNvPr id="15" name="Oval 14">
             <a:extLst>
               <a:ext uri="{FF2B5EF4-FFF2-40B4-BE49-F238E27FC236}">
-                <a16:creationId xmlns:a16="http://schemas.microsoft.com/office/drawing/2014/main" id="{ADDB816E-A5C0-4858-9CDA-E31E54F234CE}"/>
+                <a16:creationId xmlns:a16="http://schemas.microsoft.com/office/drawing/2014/main" id="{8D86912F-9F39-4E1D-A324-E8EE0BE5D997}"/>
               </a:ext>
             </a:extLst>
           </p:cNvPr>
@@ -23419,7 +23419,7 @@
           <p:cNvPr id="16" name="Rectangle 15">
             <a:extLst>
               <a:ext uri="{FF2B5EF4-FFF2-40B4-BE49-F238E27FC236}">
-                <a16:creationId xmlns:a16="http://schemas.microsoft.com/office/drawing/2014/main" id="{31E012FC-3D32-4AB9-952A-1EF16FAAF84A}"/>
+                <a16:creationId xmlns:a16="http://schemas.microsoft.com/office/drawing/2014/main" id="{BD8B92A3-C5ED-4146-8290-2CB166F06607}"/>
               </a:ext>
             </a:extLst>
           </p:cNvPr>
@@ -23481,7 +23481,7 @@
           <p:cNvPr id="17" name="Rectangle: Rounded Corners 16">
             <a:extLst>
               <a:ext uri="{FF2B5EF4-FFF2-40B4-BE49-F238E27FC236}">
-                <a16:creationId xmlns:a16="http://schemas.microsoft.com/office/drawing/2014/main" id="{61C82E3C-56E3-4348-A719-4DE0E212759F}"/>
+                <a16:creationId xmlns:a16="http://schemas.microsoft.com/office/drawing/2014/main" id="{F840C937-D642-498F-8B6F-9F67F0159B42}"/>
               </a:ext>
             </a:extLst>
           </p:cNvPr>
@@ -23516,7 +23516,7 @@
           <p:cNvPr id="18" name="Rectangle 17">
             <a:extLst>
               <a:ext uri="{FF2B5EF4-FFF2-40B4-BE49-F238E27FC236}">
-                <a16:creationId xmlns:a16="http://schemas.microsoft.com/office/drawing/2014/main" id="{F7F2831C-D3B9-4478-B70E-86CC6A5D5120}"/>
+                <a16:creationId xmlns:a16="http://schemas.microsoft.com/office/drawing/2014/main" id="{87BF1082-93FD-47DF-97C4-D9B7324E8FAD}"/>
               </a:ext>
             </a:extLst>
           </p:cNvPr>
@@ -23578,7 +23578,7 @@
           <p:cNvPr id="19" name="Rectangle 18">
             <a:extLst>
               <a:ext uri="{FF2B5EF4-FFF2-40B4-BE49-F238E27FC236}">
-                <a16:creationId xmlns:a16="http://schemas.microsoft.com/office/drawing/2014/main" id="{7018A92E-4C82-4D21-A0AE-DD37B6580BAC}"/>
+                <a16:creationId xmlns:a16="http://schemas.microsoft.com/office/drawing/2014/main" id="{4DD8652C-686B-4A1E-AFAE-B3E2796F30CA}"/>
               </a:ext>
             </a:extLst>
           </p:cNvPr>
@@ -23609,7 +23609,7 @@
           <p:cNvPr id="20" name="Rectangle 19">
             <a:extLst>
               <a:ext uri="{FF2B5EF4-FFF2-40B4-BE49-F238E27FC236}">
-                <a16:creationId xmlns:a16="http://schemas.microsoft.com/office/drawing/2014/main" id="{AA387BC5-737B-45E1-93A2-B0EC3395B332}"/>
+                <a16:creationId xmlns:a16="http://schemas.microsoft.com/office/drawing/2014/main" id="{7B46BBC5-5A48-4C98-BA6A-A0D84B8C78FF}"/>
               </a:ext>
             </a:extLst>
           </p:cNvPr>
@@ -23661,7 +23661,7 @@
                 <a:ea typeface="Arial"/>
                 <a:cs typeface="Arial"/>
               </a:rPr>
-              <a:t>r2z-d4c8d4cc709a · scn-e0f12f397e · prt-fd6de9d793</a:t>
+              <a:t>r2z-a7181752a17d · scn-e0f12f397e · prt-fd6de9d793</a:t>
             </a:r>
           </a:p>
         </p:txBody>
@@ -23671,7 +23671,7 @@
           <p:cNvPr id="21" name="Rectangle 20">
             <a:extLst>
               <a:ext uri="{FF2B5EF4-FFF2-40B4-BE49-F238E27FC236}">
-                <a16:creationId xmlns:a16="http://schemas.microsoft.com/office/drawing/2014/main" id="{ADA69D37-F1F9-494C-A70C-B87BB87F0B71}"/>
+                <a16:creationId xmlns:a16="http://schemas.microsoft.com/office/drawing/2014/main" id="{75238E1C-3751-45DE-9465-14C056F40BC3}"/>
               </a:ext>
             </a:extLst>
           </p:cNvPr>
@@ -23731,7 +23731,7 @@
     </p:spTree>
     <p:extLst>
       <p:ext uri="{BB962C8B-B14F-4D97-AF65-F5344CB8AC3E}">
-        <p14:creationId xmlns:p14="http://schemas.microsoft.com/office/powerpoint/2010/main" val="559458769"/>
+        <p14:creationId xmlns:p14="http://schemas.microsoft.com/office/powerpoint/2010/main" val="1741773770"/>
       </p:ext>
     </p:extLst>
   </p:cSld>

</xml_diff>

<commit_message>
Clarify climate evidence and anchor tour invite
</commit_message>
<xml_diff>
--- a/output/submission/Route2Zero_Prototype_Demonstration.pptx
+++ b/output/submission/Route2Zero_Prototype_Demonstration.pptx
@@ -164,7 +164,7 @@
             </c:spPr>
             <c:extLst>
               <c:ext xmlns:c16="http://schemas.microsoft.com/office/drawing/2014/chart" uri="{C3380CC4-5D6E-409C-BE32-E72D297353CC}">
-                <c16:uniqueId val="{00000001-7F49-43CF-8577-A32469015294}"/>
+                <c16:uniqueId val="{00000001-292D-4C58-BF0D-6F378E036E4D}"/>
               </c:ext>
             </c:extLst>
           </c:dPt>
@@ -238,7 +238,7 @@
               </c14:invertSolidFillFmt>
             </c:ext>
             <c:ext xmlns:c16="http://schemas.microsoft.com/office/drawing/2014/chart" uri="{C3380CC4-5D6E-409C-BE32-E72D297353CC}">
-              <c16:uniqueId val="{00000002-7F49-43CF-8577-A32469015294}"/>
+              <c16:uniqueId val="{00000002-292D-4C58-BF0D-6F378E036E4D}"/>
             </c:ext>
           </c:extLst>
         </c:ser>
@@ -2493,7 +2493,7 @@
             <a:hlinkClick r:id="rId3"/>
             <a:extLst>
               <a:ext uri="{FF2B5EF4-FFF2-40B4-BE49-F238E27FC236}">
-                <a16:creationId xmlns:a16="http://schemas.microsoft.com/office/drawing/2014/main" id="{F0E1D0C4-4183-4EC0-B3F7-B5ECD437B985}"/>
+                <a16:creationId xmlns:a16="http://schemas.microsoft.com/office/drawing/2014/main" id="{2AA94FC1-7318-4F53-A5AE-75DF995873EF}"/>
               </a:ext>
             </a:extLst>
           </p:cNvPr>
@@ -2568,7 +2568,7 @@
             <a:hlinkClick r:id="rId4"/>
             <a:extLst>
               <a:ext uri="{FF2B5EF4-FFF2-40B4-BE49-F238E27FC236}">
-                <a16:creationId xmlns:a16="http://schemas.microsoft.com/office/drawing/2014/main" id="{2FF8AB2D-3023-418C-92AE-DD2B4708CFF4}"/>
+                <a16:creationId xmlns:a16="http://schemas.microsoft.com/office/drawing/2014/main" id="{39229063-61BC-4143-980A-BA679F7FE83D}"/>
               </a:ext>
             </a:extLst>
           </p:cNvPr>
@@ -2667,7 +2667,7 @@
           <p:cNvPr id="4" name="Rectangle 3">
             <a:extLst>
               <a:ext uri="{FF2B5EF4-FFF2-40B4-BE49-F238E27FC236}">
-                <a16:creationId xmlns:a16="http://schemas.microsoft.com/office/drawing/2014/main" id="{18D76A5E-478B-4BDB-9AC3-53C6C785BA4E}"/>
+                <a16:creationId xmlns:a16="http://schemas.microsoft.com/office/drawing/2014/main" id="{D23B3E0A-2142-4822-9E2D-7E14B586F847}"/>
               </a:ext>
             </a:extLst>
           </p:cNvPr>
@@ -2713,7 +2713,7 @@
           <p:cNvPr id="5" name="Rectangle 4">
             <a:extLst>
               <a:ext uri="{FF2B5EF4-FFF2-40B4-BE49-F238E27FC236}">
-                <a16:creationId xmlns:a16="http://schemas.microsoft.com/office/drawing/2014/main" id="{5B60D913-3039-4348-A644-D171F3658173}"/>
+                <a16:creationId xmlns:a16="http://schemas.microsoft.com/office/drawing/2014/main" id="{47C120AE-84AE-4124-9178-A2D111013578}"/>
               </a:ext>
             </a:extLst>
           </p:cNvPr>
@@ -2775,7 +2775,7 @@
           <p:cNvPr id="6" name="Rectangle 5">
             <a:extLst>
               <a:ext uri="{FF2B5EF4-FFF2-40B4-BE49-F238E27FC236}">
-                <a16:creationId xmlns:a16="http://schemas.microsoft.com/office/drawing/2014/main" id="{3EC2E27C-0ABD-4701-A03B-889611F5515C}"/>
+                <a16:creationId xmlns:a16="http://schemas.microsoft.com/office/drawing/2014/main" id="{69897D07-3521-4AFB-9DBE-4AE5B235456F}"/>
               </a:ext>
             </a:extLst>
           </p:cNvPr>
@@ -2837,7 +2837,7 @@
           <p:cNvPr id="7" name="Rectangle 6">
             <a:extLst>
               <a:ext uri="{FF2B5EF4-FFF2-40B4-BE49-F238E27FC236}">
-                <a16:creationId xmlns:a16="http://schemas.microsoft.com/office/drawing/2014/main" id="{10A5BC28-EC20-4FD3-924F-31FC0E6A2912}"/>
+                <a16:creationId xmlns:a16="http://schemas.microsoft.com/office/drawing/2014/main" id="{C74B56C6-72C7-4458-84C9-041286902AA3}"/>
               </a:ext>
             </a:extLst>
           </p:cNvPr>
@@ -2899,7 +2899,7 @@
           <p:cNvPr id="8" name="Rectangle 7">
             <a:extLst>
               <a:ext uri="{FF2B5EF4-FFF2-40B4-BE49-F238E27FC236}">
-                <a16:creationId xmlns:a16="http://schemas.microsoft.com/office/drawing/2014/main" id="{16225DBE-E32F-4481-83BF-6BD0DF379BA2}"/>
+                <a16:creationId xmlns:a16="http://schemas.microsoft.com/office/drawing/2014/main" id="{A8B0978E-798E-4FC4-A37D-2278F83A2EA0}"/>
               </a:ext>
             </a:extLst>
           </p:cNvPr>
@@ -2961,7 +2961,7 @@
           <p:cNvPr id="9" name="Rectangle 8">
             <a:extLst>
               <a:ext uri="{FF2B5EF4-FFF2-40B4-BE49-F238E27FC236}">
-                <a16:creationId xmlns:a16="http://schemas.microsoft.com/office/drawing/2014/main" id="{80C0980F-50E9-41C6-BB5D-12E1F8DB6724}"/>
+                <a16:creationId xmlns:a16="http://schemas.microsoft.com/office/drawing/2014/main" id="{1F7831B7-595B-45D3-A4C5-70B27ACB1877}"/>
               </a:ext>
             </a:extLst>
           </p:cNvPr>
@@ -3023,7 +3023,7 @@
           <p:cNvPr id="10" name="Rectangle 9">
             <a:extLst>
               <a:ext uri="{FF2B5EF4-FFF2-40B4-BE49-F238E27FC236}">
-                <a16:creationId xmlns:a16="http://schemas.microsoft.com/office/drawing/2014/main" id="{C72A1686-6F66-442F-86D9-05A456E20B1F}"/>
+                <a16:creationId xmlns:a16="http://schemas.microsoft.com/office/drawing/2014/main" id="{31545AF7-BBF7-4101-A59A-BF33E10EFB6A}"/>
               </a:ext>
             </a:extLst>
           </p:cNvPr>
@@ -3085,7 +3085,7 @@
           <p:cNvPr id="11" name="Rectangle 10">
             <a:extLst>
               <a:ext uri="{FF2B5EF4-FFF2-40B4-BE49-F238E27FC236}">
-                <a16:creationId xmlns:a16="http://schemas.microsoft.com/office/drawing/2014/main" id="{949E1AF1-D238-4CF9-BCBC-8CB62030A760}"/>
+                <a16:creationId xmlns:a16="http://schemas.microsoft.com/office/drawing/2014/main" id="{7BE6EAAC-913B-493E-8D53-6C546A06B4BC}"/>
               </a:ext>
             </a:extLst>
           </p:cNvPr>
@@ -3147,7 +3147,7 @@
           <p:cNvPr id="12" name="Rectangle 11">
             <a:extLst>
               <a:ext uri="{FF2B5EF4-FFF2-40B4-BE49-F238E27FC236}">
-                <a16:creationId xmlns:a16="http://schemas.microsoft.com/office/drawing/2014/main" id="{F02E7139-8AC8-46D5-9669-BD0B4CB152A9}"/>
+                <a16:creationId xmlns:a16="http://schemas.microsoft.com/office/drawing/2014/main" id="{1595578B-23FB-458A-9A41-1DA89C6B0EAF}"/>
               </a:ext>
             </a:extLst>
           </p:cNvPr>
@@ -3209,7 +3209,7 @@
           <p:cNvPr id="13" name="Rectangle 12">
             <a:extLst>
               <a:ext uri="{FF2B5EF4-FFF2-40B4-BE49-F238E27FC236}">
-                <a16:creationId xmlns:a16="http://schemas.microsoft.com/office/drawing/2014/main" id="{3023826C-29B0-4AA6-A417-122F15C2EE4E}"/>
+                <a16:creationId xmlns:a16="http://schemas.microsoft.com/office/drawing/2014/main" id="{B0D57768-8C00-442E-AEAE-270D3415EA93}"/>
               </a:ext>
             </a:extLst>
           </p:cNvPr>
@@ -3271,7 +3271,7 @@
           <p:cNvPr id="14" name="Rectangle 13">
             <a:extLst>
               <a:ext uri="{FF2B5EF4-FFF2-40B4-BE49-F238E27FC236}">
-                <a16:creationId xmlns:a16="http://schemas.microsoft.com/office/drawing/2014/main" id="{1C9C54AB-6FCE-4112-8FDB-DE3FF451802C}"/>
+                <a16:creationId xmlns:a16="http://schemas.microsoft.com/office/drawing/2014/main" id="{72B734C4-07F0-41C8-ABDD-3A5284F5A1E9}"/>
               </a:ext>
             </a:extLst>
           </p:cNvPr>
@@ -3333,7 +3333,7 @@
           <p:cNvPr id="15" name="Rectangle 14">
             <a:extLst>
               <a:ext uri="{FF2B5EF4-FFF2-40B4-BE49-F238E27FC236}">
-                <a16:creationId xmlns:a16="http://schemas.microsoft.com/office/drawing/2014/main" id="{F3D3606F-47ED-45A5-8052-B4B07B77CDB4}"/>
+                <a16:creationId xmlns:a16="http://schemas.microsoft.com/office/drawing/2014/main" id="{67652E46-DFD7-4FFB-BB86-897879D38218}"/>
               </a:ext>
             </a:extLst>
           </p:cNvPr>
@@ -3395,7 +3395,7 @@
           <p:cNvPr id="16" name="Rectangle 15">
             <a:extLst>
               <a:ext uri="{FF2B5EF4-FFF2-40B4-BE49-F238E27FC236}">
-                <a16:creationId xmlns:a16="http://schemas.microsoft.com/office/drawing/2014/main" id="{258A8DCE-52D4-4C68-9BB0-8748394B1E95}"/>
+                <a16:creationId xmlns:a16="http://schemas.microsoft.com/office/drawing/2014/main" id="{B100B896-2B92-4422-A851-0C3400A059F6}"/>
               </a:ext>
             </a:extLst>
           </p:cNvPr>
@@ -3457,7 +3457,7 @@
           <p:cNvPr id="17" name="Rectangle 16">
             <a:extLst>
               <a:ext uri="{FF2B5EF4-FFF2-40B4-BE49-F238E27FC236}">
-                <a16:creationId xmlns:a16="http://schemas.microsoft.com/office/drawing/2014/main" id="{B20F63DD-4823-4570-B54A-1E2C120AF960}"/>
+                <a16:creationId xmlns:a16="http://schemas.microsoft.com/office/drawing/2014/main" id="{77E62172-CC8A-4760-8237-EC00069AF486}"/>
               </a:ext>
             </a:extLst>
           </p:cNvPr>
@@ -3488,7 +3488,7 @@
           <p:cNvPr id="18" name="Rectangle 17">
             <a:extLst>
               <a:ext uri="{FF2B5EF4-FFF2-40B4-BE49-F238E27FC236}">
-                <a16:creationId xmlns:a16="http://schemas.microsoft.com/office/drawing/2014/main" id="{04CB480E-E682-42CC-8BFF-970A15D95DCC}"/>
+                <a16:creationId xmlns:a16="http://schemas.microsoft.com/office/drawing/2014/main" id="{07DF88FF-CD9A-4A66-A2A1-5542692BB34F}"/>
               </a:ext>
             </a:extLst>
           </p:cNvPr>
@@ -3550,7 +3550,7 @@
           <p:cNvPr id="19" name="Rectangle 18">
             <a:extLst>
               <a:ext uri="{FF2B5EF4-FFF2-40B4-BE49-F238E27FC236}">
-                <a16:creationId xmlns:a16="http://schemas.microsoft.com/office/drawing/2014/main" id="{D34016D3-F85C-498A-B6E0-37D8B281FD71}"/>
+                <a16:creationId xmlns:a16="http://schemas.microsoft.com/office/drawing/2014/main" id="{692D7D2C-84A7-4117-A14B-3B99DFFB0E5A}"/>
               </a:ext>
             </a:extLst>
           </p:cNvPr>
@@ -3610,7 +3610,7 @@
     </p:spTree>
     <p:extLst>
       <p:ext uri="{BB962C8B-B14F-4D97-AF65-F5344CB8AC3E}">
-        <p14:creationId xmlns:p14="http://schemas.microsoft.com/office/powerpoint/2010/main" val="2037128199"/>
+        <p14:creationId xmlns:p14="http://schemas.microsoft.com/office/powerpoint/2010/main" val="739732705"/>
       </p:ext>
     </p:extLst>
   </p:cSld>
@@ -3651,7 +3651,7 @@
             <a:hlinkClick r:id="rId3"/>
             <a:extLst>
               <a:ext uri="{FF2B5EF4-FFF2-40B4-BE49-F238E27FC236}">
-                <a16:creationId xmlns:a16="http://schemas.microsoft.com/office/drawing/2014/main" id="{CBDAE414-F0FF-42E1-9E8F-4BD983CD2014}"/>
+                <a16:creationId xmlns:a16="http://schemas.microsoft.com/office/drawing/2014/main" id="{C7688956-BBDD-4166-BABA-956C5BEADF46}"/>
               </a:ext>
             </a:extLst>
           </p:cNvPr>
@@ -3726,7 +3726,7 @@
             <a:hlinkClick r:id="rId4"/>
             <a:extLst>
               <a:ext uri="{FF2B5EF4-FFF2-40B4-BE49-F238E27FC236}">
-                <a16:creationId xmlns:a16="http://schemas.microsoft.com/office/drawing/2014/main" id="{4AFC50FB-CBD4-4334-B235-C9C56822A1A3}"/>
+                <a16:creationId xmlns:a16="http://schemas.microsoft.com/office/drawing/2014/main" id="{56B91E51-124C-45EC-BB7A-63AAB9A45BB8}"/>
               </a:ext>
             </a:extLst>
           </p:cNvPr>
@@ -3800,7 +3800,7 @@
           <p:cNvPr id="3" name="Rectangle 2">
             <a:extLst>
               <a:ext uri="{FF2B5EF4-FFF2-40B4-BE49-F238E27FC236}">
-                <a16:creationId xmlns:a16="http://schemas.microsoft.com/office/drawing/2014/main" id="{2D0DC8C6-96BC-48C5-901D-1F4309C7099C}"/>
+                <a16:creationId xmlns:a16="http://schemas.microsoft.com/office/drawing/2014/main" id="{10F7FEE1-E98E-4558-8BE7-F57E2D512768}"/>
               </a:ext>
             </a:extLst>
           </p:cNvPr>
@@ -3862,7 +3862,7 @@
           <p:cNvPr id="4" name="Rectangle 3">
             <a:extLst>
               <a:ext uri="{FF2B5EF4-FFF2-40B4-BE49-F238E27FC236}">
-                <a16:creationId xmlns:a16="http://schemas.microsoft.com/office/drawing/2014/main" id="{839FC786-F410-4B2B-9C0D-88823490693F}"/>
+                <a16:creationId xmlns:a16="http://schemas.microsoft.com/office/drawing/2014/main" id="{D516309D-49FE-47EC-B893-0BA8A70572AA}"/>
               </a:ext>
             </a:extLst>
           </p:cNvPr>
@@ -3951,7 +3951,7 @@
           <p:cNvPr id="6" name="Rectangle: Rounded Corners 5">
             <a:extLst>
               <a:ext uri="{FF2B5EF4-FFF2-40B4-BE49-F238E27FC236}">
-                <a16:creationId xmlns:a16="http://schemas.microsoft.com/office/drawing/2014/main" id="{8FB77B34-4423-4411-BDA0-EDE2E3F64C67}"/>
+                <a16:creationId xmlns:a16="http://schemas.microsoft.com/office/drawing/2014/main" id="{E4957C38-5321-409F-93AA-68C8599A65D2}"/>
               </a:ext>
             </a:extLst>
           </p:cNvPr>
@@ -3984,7 +3984,7 @@
           <p:cNvPr id="7" name="Oval 6">
             <a:extLst>
               <a:ext uri="{FF2B5EF4-FFF2-40B4-BE49-F238E27FC236}">
-                <a16:creationId xmlns:a16="http://schemas.microsoft.com/office/drawing/2014/main" id="{91974BE5-E925-4622-ADFB-85B9362A9F18}"/>
+                <a16:creationId xmlns:a16="http://schemas.microsoft.com/office/drawing/2014/main" id="{CD9826E3-C553-43B2-8E6B-66043C16983C}"/>
               </a:ext>
             </a:extLst>
           </p:cNvPr>
@@ -4015,7 +4015,7 @@
           <p:cNvPr id="8" name="Rectangle 7">
             <a:extLst>
               <a:ext uri="{FF2B5EF4-FFF2-40B4-BE49-F238E27FC236}">
-                <a16:creationId xmlns:a16="http://schemas.microsoft.com/office/drawing/2014/main" id="{8AEF1CDC-90F2-45F7-A76D-59CB51EB40E1}"/>
+                <a16:creationId xmlns:a16="http://schemas.microsoft.com/office/drawing/2014/main" id="{6534D77B-727C-4CA2-A677-BC7EF9FD7BBC}"/>
               </a:ext>
             </a:extLst>
           </p:cNvPr>
@@ -4077,7 +4077,7 @@
           <p:cNvPr id="9" name="Rectangle: Rounded Corners 8">
             <a:extLst>
               <a:ext uri="{FF2B5EF4-FFF2-40B4-BE49-F238E27FC236}">
-                <a16:creationId xmlns:a16="http://schemas.microsoft.com/office/drawing/2014/main" id="{8C5C63E0-FBF2-4990-BE4F-A1945BCFDC83}"/>
+                <a16:creationId xmlns:a16="http://schemas.microsoft.com/office/drawing/2014/main" id="{8A643435-3612-4CC5-9EE0-E6BF9C1A12DB}"/>
               </a:ext>
             </a:extLst>
           </p:cNvPr>
@@ -4112,7 +4112,7 @@
           <p:cNvPr id="10" name="Rectangle 9">
             <a:extLst>
               <a:ext uri="{FF2B5EF4-FFF2-40B4-BE49-F238E27FC236}">
-                <a16:creationId xmlns:a16="http://schemas.microsoft.com/office/drawing/2014/main" id="{653F3059-66CA-4FAD-95DA-13C71114E103}"/>
+                <a16:creationId xmlns:a16="http://schemas.microsoft.com/office/drawing/2014/main" id="{E59A3828-530F-4B8A-AB61-440DCCDE860E}"/>
               </a:ext>
             </a:extLst>
           </p:cNvPr>
@@ -4174,7 +4174,7 @@
           <p:cNvPr id="11" name="Oval 10">
             <a:extLst>
               <a:ext uri="{FF2B5EF4-FFF2-40B4-BE49-F238E27FC236}">
-                <a16:creationId xmlns:a16="http://schemas.microsoft.com/office/drawing/2014/main" id="{2F800826-96D6-4AC6-95AD-051116CF779A}"/>
+                <a16:creationId xmlns:a16="http://schemas.microsoft.com/office/drawing/2014/main" id="{BF4D6988-F3D2-48E2-B9F8-68BF4B48FFB2}"/>
               </a:ext>
             </a:extLst>
           </p:cNvPr>
@@ -4205,7 +4205,7 @@
           <p:cNvPr id="12" name="Rectangle 11">
             <a:extLst>
               <a:ext uri="{FF2B5EF4-FFF2-40B4-BE49-F238E27FC236}">
-                <a16:creationId xmlns:a16="http://schemas.microsoft.com/office/drawing/2014/main" id="{C46F417C-66F9-4B7A-88BB-658154276B8B}"/>
+                <a16:creationId xmlns:a16="http://schemas.microsoft.com/office/drawing/2014/main" id="{93408542-9795-4158-AC5B-5B633392961E}"/>
               </a:ext>
             </a:extLst>
           </p:cNvPr>
@@ -4267,7 +4267,7 @@
           <p:cNvPr id="13" name="Rectangle: Rounded Corners 12">
             <a:extLst>
               <a:ext uri="{FF2B5EF4-FFF2-40B4-BE49-F238E27FC236}">
-                <a16:creationId xmlns:a16="http://schemas.microsoft.com/office/drawing/2014/main" id="{CCACAD47-693F-4CB6-AFFA-43ECDCDC7230}"/>
+                <a16:creationId xmlns:a16="http://schemas.microsoft.com/office/drawing/2014/main" id="{83DED060-0AED-4E54-9E16-05AB117A0BCF}"/>
               </a:ext>
             </a:extLst>
           </p:cNvPr>
@@ -4302,7 +4302,7 @@
           <p:cNvPr id="14" name="Rectangle 13">
             <a:extLst>
               <a:ext uri="{FF2B5EF4-FFF2-40B4-BE49-F238E27FC236}">
-                <a16:creationId xmlns:a16="http://schemas.microsoft.com/office/drawing/2014/main" id="{7C66FD61-A5B6-485C-B12C-CF679FE6827F}"/>
+                <a16:creationId xmlns:a16="http://schemas.microsoft.com/office/drawing/2014/main" id="{2BF43D15-FE30-446A-9D07-3FBD15F90574}"/>
               </a:ext>
             </a:extLst>
           </p:cNvPr>
@@ -4364,7 +4364,7 @@
           <p:cNvPr id="15" name="Oval 14">
             <a:extLst>
               <a:ext uri="{FF2B5EF4-FFF2-40B4-BE49-F238E27FC236}">
-                <a16:creationId xmlns:a16="http://schemas.microsoft.com/office/drawing/2014/main" id="{42249C78-8AC7-4987-B5CB-E5F89DDF8676}"/>
+                <a16:creationId xmlns:a16="http://schemas.microsoft.com/office/drawing/2014/main" id="{AE172B06-E1B0-45BB-B220-E7378E6CEFC8}"/>
               </a:ext>
             </a:extLst>
           </p:cNvPr>
@@ -4395,7 +4395,7 @@
           <p:cNvPr id="16" name="Rectangle 15">
             <a:extLst>
               <a:ext uri="{FF2B5EF4-FFF2-40B4-BE49-F238E27FC236}">
-                <a16:creationId xmlns:a16="http://schemas.microsoft.com/office/drawing/2014/main" id="{E08F05D4-8831-4544-B20A-C6E03C507BFB}"/>
+                <a16:creationId xmlns:a16="http://schemas.microsoft.com/office/drawing/2014/main" id="{6E55D8BD-D017-4595-8F0E-D28331AD758D}"/>
               </a:ext>
             </a:extLst>
           </p:cNvPr>
@@ -4457,7 +4457,7 @@
           <p:cNvPr id="17" name="Rectangle: Rounded Corners 16">
             <a:extLst>
               <a:ext uri="{FF2B5EF4-FFF2-40B4-BE49-F238E27FC236}">
-                <a16:creationId xmlns:a16="http://schemas.microsoft.com/office/drawing/2014/main" id="{B15EF8A0-4D05-4C8B-A3B5-91635003A25A}"/>
+                <a16:creationId xmlns:a16="http://schemas.microsoft.com/office/drawing/2014/main" id="{AFF08E19-9548-4A0C-B31C-9603AF0CC0FC}"/>
               </a:ext>
             </a:extLst>
           </p:cNvPr>
@@ -4492,7 +4492,7 @@
           <p:cNvPr id="18" name="Rectangle 17">
             <a:extLst>
               <a:ext uri="{FF2B5EF4-FFF2-40B4-BE49-F238E27FC236}">
-                <a16:creationId xmlns:a16="http://schemas.microsoft.com/office/drawing/2014/main" id="{53DE3F61-62E2-4BE1-A00B-B27172014333}"/>
+                <a16:creationId xmlns:a16="http://schemas.microsoft.com/office/drawing/2014/main" id="{1686D884-44A3-4BF5-B3E7-46353A3AFAEE}"/>
               </a:ext>
             </a:extLst>
           </p:cNvPr>
@@ -4554,7 +4554,7 @@
           <p:cNvPr id="19" name="Rectangle 18">
             <a:extLst>
               <a:ext uri="{FF2B5EF4-FFF2-40B4-BE49-F238E27FC236}">
-                <a16:creationId xmlns:a16="http://schemas.microsoft.com/office/drawing/2014/main" id="{10FBAF55-CBF4-460D-8BF0-8851D14431AE}"/>
+                <a16:creationId xmlns:a16="http://schemas.microsoft.com/office/drawing/2014/main" id="{CB84AD6D-648E-43EB-887C-ED9AE68640D7}"/>
               </a:ext>
             </a:extLst>
           </p:cNvPr>
@@ -4585,7 +4585,7 @@
           <p:cNvPr id="20" name="Rectangle 19">
             <a:extLst>
               <a:ext uri="{FF2B5EF4-FFF2-40B4-BE49-F238E27FC236}">
-                <a16:creationId xmlns:a16="http://schemas.microsoft.com/office/drawing/2014/main" id="{36F52EEC-040D-4CB5-8C6B-2405FB1B0998}"/>
+                <a16:creationId xmlns:a16="http://schemas.microsoft.com/office/drawing/2014/main" id="{9667132A-19A8-4CC8-B2C9-AFA8634FB4E9}"/>
               </a:ext>
             </a:extLst>
           </p:cNvPr>
@@ -4647,7 +4647,7 @@
           <p:cNvPr id="21" name="Rectangle 20">
             <a:extLst>
               <a:ext uri="{FF2B5EF4-FFF2-40B4-BE49-F238E27FC236}">
-                <a16:creationId xmlns:a16="http://schemas.microsoft.com/office/drawing/2014/main" id="{9661E5D7-8551-4BD4-AB97-69EB67180593}"/>
+                <a16:creationId xmlns:a16="http://schemas.microsoft.com/office/drawing/2014/main" id="{951504DE-8D77-40BD-9C5C-E29F60BF2F6B}"/>
               </a:ext>
             </a:extLst>
           </p:cNvPr>
@@ -4707,7 +4707,7 @@
     </p:spTree>
     <p:extLst>
       <p:ext uri="{BB962C8B-B14F-4D97-AF65-F5344CB8AC3E}">
-        <p14:creationId xmlns:p14="http://schemas.microsoft.com/office/powerpoint/2010/main" val="300639733"/>
+        <p14:creationId xmlns:p14="http://schemas.microsoft.com/office/powerpoint/2010/main" val="65447936"/>
       </p:ext>
     </p:extLst>
   </p:cSld>
@@ -4748,7 +4748,7 @@
             <a:hlinkClick r:id="rId3"/>
             <a:extLst>
               <a:ext uri="{FF2B5EF4-FFF2-40B4-BE49-F238E27FC236}">
-                <a16:creationId xmlns:a16="http://schemas.microsoft.com/office/drawing/2014/main" id="{7DEACC65-2C9E-47C7-B5E8-816154407907}"/>
+                <a16:creationId xmlns:a16="http://schemas.microsoft.com/office/drawing/2014/main" id="{0B66CA20-0B22-4EBD-B0AE-A6093AAC6FF1}"/>
               </a:ext>
             </a:extLst>
           </p:cNvPr>
@@ -4823,7 +4823,7 @@
             <a:hlinkClick r:id="rId4"/>
             <a:extLst>
               <a:ext uri="{FF2B5EF4-FFF2-40B4-BE49-F238E27FC236}">
-                <a16:creationId xmlns:a16="http://schemas.microsoft.com/office/drawing/2014/main" id="{CD30F34B-7F66-43F4-8CE6-D515D2D5431D}"/>
+                <a16:creationId xmlns:a16="http://schemas.microsoft.com/office/drawing/2014/main" id="{98A58379-FDBC-4339-ABA4-E63431186229}"/>
               </a:ext>
             </a:extLst>
           </p:cNvPr>
@@ -4897,7 +4897,7 @@
           <p:cNvPr id="3" name="Rectangle 2">
             <a:extLst>
               <a:ext uri="{FF2B5EF4-FFF2-40B4-BE49-F238E27FC236}">
-                <a16:creationId xmlns:a16="http://schemas.microsoft.com/office/drawing/2014/main" id="{19AA475A-DC51-4BE1-8214-452C1A4DC3E5}"/>
+                <a16:creationId xmlns:a16="http://schemas.microsoft.com/office/drawing/2014/main" id="{DBF0CC26-2BEB-43D2-9B7F-4649B94EF920}"/>
               </a:ext>
             </a:extLst>
           </p:cNvPr>
@@ -4959,7 +4959,7 @@
           <p:cNvPr id="4" name="Rectangle 3">
             <a:extLst>
               <a:ext uri="{FF2B5EF4-FFF2-40B4-BE49-F238E27FC236}">
-                <a16:creationId xmlns:a16="http://schemas.microsoft.com/office/drawing/2014/main" id="{40058786-E414-4E64-8A74-2BF2CF915403}"/>
+                <a16:creationId xmlns:a16="http://schemas.microsoft.com/office/drawing/2014/main" id="{2B7D69CF-B8FD-40ED-A040-E9E7828A7848}"/>
               </a:ext>
             </a:extLst>
           </p:cNvPr>
@@ -5048,7 +5048,7 @@
           <p:cNvPr id="6" name="Rectangle: Rounded Corners 5">
             <a:extLst>
               <a:ext uri="{FF2B5EF4-FFF2-40B4-BE49-F238E27FC236}">
-                <a16:creationId xmlns:a16="http://schemas.microsoft.com/office/drawing/2014/main" id="{773A7746-6C55-4E8C-8854-1A684C03A5FF}"/>
+                <a16:creationId xmlns:a16="http://schemas.microsoft.com/office/drawing/2014/main" id="{DF1CFACD-332A-4214-8A64-4556915875ED}"/>
               </a:ext>
             </a:extLst>
           </p:cNvPr>
@@ -5081,7 +5081,7 @@
           <p:cNvPr id="7" name="Oval 6">
             <a:extLst>
               <a:ext uri="{FF2B5EF4-FFF2-40B4-BE49-F238E27FC236}">
-                <a16:creationId xmlns:a16="http://schemas.microsoft.com/office/drawing/2014/main" id="{9E043F23-0756-4E10-B288-F4732E2F668B}"/>
+                <a16:creationId xmlns:a16="http://schemas.microsoft.com/office/drawing/2014/main" id="{4685A5C0-438F-47E6-AE33-A0839D237907}"/>
               </a:ext>
             </a:extLst>
           </p:cNvPr>
@@ -5112,7 +5112,7 @@
           <p:cNvPr id="8" name="Rectangle 7">
             <a:extLst>
               <a:ext uri="{FF2B5EF4-FFF2-40B4-BE49-F238E27FC236}">
-                <a16:creationId xmlns:a16="http://schemas.microsoft.com/office/drawing/2014/main" id="{B32B01F2-ED6F-4B00-BCFA-B0AE5BE72001}"/>
+                <a16:creationId xmlns:a16="http://schemas.microsoft.com/office/drawing/2014/main" id="{A20A5F99-A9B3-474A-956F-E96DEBFFB775}"/>
               </a:ext>
             </a:extLst>
           </p:cNvPr>
@@ -5174,7 +5174,7 @@
           <p:cNvPr id="9" name="Rectangle: Rounded Corners 8">
             <a:extLst>
               <a:ext uri="{FF2B5EF4-FFF2-40B4-BE49-F238E27FC236}">
-                <a16:creationId xmlns:a16="http://schemas.microsoft.com/office/drawing/2014/main" id="{1DD212CE-6993-49D1-89B0-E7875EE136DE}"/>
+                <a16:creationId xmlns:a16="http://schemas.microsoft.com/office/drawing/2014/main" id="{2A6BCA4B-C576-4357-9539-06277B3BAC0D}"/>
               </a:ext>
             </a:extLst>
           </p:cNvPr>
@@ -5209,7 +5209,7 @@
           <p:cNvPr id="10" name="Rectangle 9">
             <a:extLst>
               <a:ext uri="{FF2B5EF4-FFF2-40B4-BE49-F238E27FC236}">
-                <a16:creationId xmlns:a16="http://schemas.microsoft.com/office/drawing/2014/main" id="{55C69E48-5345-4CCF-84F6-21C0A97DCE7F}"/>
+                <a16:creationId xmlns:a16="http://schemas.microsoft.com/office/drawing/2014/main" id="{36790C7E-81CB-4141-B457-3970FAD2AC44}"/>
               </a:ext>
             </a:extLst>
           </p:cNvPr>
@@ -5271,7 +5271,7 @@
           <p:cNvPr id="11" name="Oval 10">
             <a:extLst>
               <a:ext uri="{FF2B5EF4-FFF2-40B4-BE49-F238E27FC236}">
-                <a16:creationId xmlns:a16="http://schemas.microsoft.com/office/drawing/2014/main" id="{2C8D8071-213B-4601-AAA6-870A27830929}"/>
+                <a16:creationId xmlns:a16="http://schemas.microsoft.com/office/drawing/2014/main" id="{EFC5662F-BF58-41A9-8A4B-0B2EA4FDA3DB}"/>
               </a:ext>
             </a:extLst>
           </p:cNvPr>
@@ -5302,7 +5302,7 @@
           <p:cNvPr id="12" name="Rectangle 11">
             <a:extLst>
               <a:ext uri="{FF2B5EF4-FFF2-40B4-BE49-F238E27FC236}">
-                <a16:creationId xmlns:a16="http://schemas.microsoft.com/office/drawing/2014/main" id="{6D9C2641-80C0-4D03-B59A-969AA15E9B5C}"/>
+                <a16:creationId xmlns:a16="http://schemas.microsoft.com/office/drawing/2014/main" id="{8586BEDF-BBDB-45B5-AC7A-D61C38095FEB}"/>
               </a:ext>
             </a:extLst>
           </p:cNvPr>
@@ -5364,7 +5364,7 @@
           <p:cNvPr id="13" name="Rectangle: Rounded Corners 12">
             <a:extLst>
               <a:ext uri="{FF2B5EF4-FFF2-40B4-BE49-F238E27FC236}">
-                <a16:creationId xmlns:a16="http://schemas.microsoft.com/office/drawing/2014/main" id="{92B4776D-CEF7-4274-B249-0818F1B2B8F3}"/>
+                <a16:creationId xmlns:a16="http://schemas.microsoft.com/office/drawing/2014/main" id="{91FF710A-7708-4106-80A5-D2EBA1BD4E7D}"/>
               </a:ext>
             </a:extLst>
           </p:cNvPr>
@@ -5399,7 +5399,7 @@
           <p:cNvPr id="14" name="Rectangle 13">
             <a:extLst>
               <a:ext uri="{FF2B5EF4-FFF2-40B4-BE49-F238E27FC236}">
-                <a16:creationId xmlns:a16="http://schemas.microsoft.com/office/drawing/2014/main" id="{0CF2FB93-948B-4470-9EA5-9F09B2A0D35D}"/>
+                <a16:creationId xmlns:a16="http://schemas.microsoft.com/office/drawing/2014/main" id="{C24B8568-D539-4F2E-86BB-CD65DA38280F}"/>
               </a:ext>
             </a:extLst>
           </p:cNvPr>
@@ -5461,7 +5461,7 @@
           <p:cNvPr id="15" name="Oval 14">
             <a:extLst>
               <a:ext uri="{FF2B5EF4-FFF2-40B4-BE49-F238E27FC236}">
-                <a16:creationId xmlns:a16="http://schemas.microsoft.com/office/drawing/2014/main" id="{6B072E0E-81DD-4340-B50C-3E21569043B3}"/>
+                <a16:creationId xmlns:a16="http://schemas.microsoft.com/office/drawing/2014/main" id="{3B07EBDB-A022-41A4-A804-5C5D25AD03D5}"/>
               </a:ext>
             </a:extLst>
           </p:cNvPr>
@@ -5492,7 +5492,7 @@
           <p:cNvPr id="16" name="Rectangle 15">
             <a:extLst>
               <a:ext uri="{FF2B5EF4-FFF2-40B4-BE49-F238E27FC236}">
-                <a16:creationId xmlns:a16="http://schemas.microsoft.com/office/drawing/2014/main" id="{C4A24762-BE80-48DE-8BA4-58B20BC9A782}"/>
+                <a16:creationId xmlns:a16="http://schemas.microsoft.com/office/drawing/2014/main" id="{9D5E2084-657F-4661-A40C-503C9892EBD0}"/>
               </a:ext>
             </a:extLst>
           </p:cNvPr>
@@ -5554,7 +5554,7 @@
           <p:cNvPr id="17" name="Rectangle: Rounded Corners 16">
             <a:extLst>
               <a:ext uri="{FF2B5EF4-FFF2-40B4-BE49-F238E27FC236}">
-                <a16:creationId xmlns:a16="http://schemas.microsoft.com/office/drawing/2014/main" id="{FD434514-ECBD-4881-811B-CD39B9BCB3F7}"/>
+                <a16:creationId xmlns:a16="http://schemas.microsoft.com/office/drawing/2014/main" id="{4734EF62-B5EC-46F1-B67A-E2901574F390}"/>
               </a:ext>
             </a:extLst>
           </p:cNvPr>
@@ -5589,7 +5589,7 @@
           <p:cNvPr id="18" name="Rectangle 17">
             <a:extLst>
               <a:ext uri="{FF2B5EF4-FFF2-40B4-BE49-F238E27FC236}">
-                <a16:creationId xmlns:a16="http://schemas.microsoft.com/office/drawing/2014/main" id="{65D2E518-4B0A-49D2-9109-4E8AA5A35415}"/>
+                <a16:creationId xmlns:a16="http://schemas.microsoft.com/office/drawing/2014/main" id="{0300A705-ED34-46BF-9871-D8388FD601C8}"/>
               </a:ext>
             </a:extLst>
           </p:cNvPr>
@@ -5651,7 +5651,7 @@
           <p:cNvPr id="19" name="Rectangle 18">
             <a:extLst>
               <a:ext uri="{FF2B5EF4-FFF2-40B4-BE49-F238E27FC236}">
-                <a16:creationId xmlns:a16="http://schemas.microsoft.com/office/drawing/2014/main" id="{27806147-326E-470F-B0D4-AD76E3841B37}"/>
+                <a16:creationId xmlns:a16="http://schemas.microsoft.com/office/drawing/2014/main" id="{AA557766-7517-4663-89D0-DF499917891C}"/>
               </a:ext>
             </a:extLst>
           </p:cNvPr>
@@ -5682,7 +5682,7 @@
           <p:cNvPr id="20" name="Rectangle 19">
             <a:extLst>
               <a:ext uri="{FF2B5EF4-FFF2-40B4-BE49-F238E27FC236}">
-                <a16:creationId xmlns:a16="http://schemas.microsoft.com/office/drawing/2014/main" id="{ACCBD51E-A2C5-49D8-8294-73464BE28E68}"/>
+                <a16:creationId xmlns:a16="http://schemas.microsoft.com/office/drawing/2014/main" id="{F945B8BE-C645-4A1F-B6D7-FF14E2779333}"/>
               </a:ext>
             </a:extLst>
           </p:cNvPr>
@@ -5744,7 +5744,7 @@
           <p:cNvPr id="21" name="Rectangle 20">
             <a:extLst>
               <a:ext uri="{FF2B5EF4-FFF2-40B4-BE49-F238E27FC236}">
-                <a16:creationId xmlns:a16="http://schemas.microsoft.com/office/drawing/2014/main" id="{CBF7B035-5566-4E06-8EC5-EDDC986A0222}"/>
+                <a16:creationId xmlns:a16="http://schemas.microsoft.com/office/drawing/2014/main" id="{06913903-90CF-4041-9437-C57701D4283C}"/>
               </a:ext>
             </a:extLst>
           </p:cNvPr>
@@ -5804,7 +5804,7 @@
     </p:spTree>
     <p:extLst>
       <p:ext uri="{BB962C8B-B14F-4D97-AF65-F5344CB8AC3E}">
-        <p14:creationId xmlns:p14="http://schemas.microsoft.com/office/powerpoint/2010/main" val="272596171"/>
+        <p14:creationId xmlns:p14="http://schemas.microsoft.com/office/powerpoint/2010/main" val="1467970247"/>
       </p:ext>
     </p:extLst>
   </p:cSld>
@@ -5845,7 +5845,7 @@
             <a:hlinkClick r:id="rId3"/>
             <a:extLst>
               <a:ext uri="{FF2B5EF4-FFF2-40B4-BE49-F238E27FC236}">
-                <a16:creationId xmlns:a16="http://schemas.microsoft.com/office/drawing/2014/main" id="{AB29BEF1-FB72-4988-ADA6-DD31BBAEA916}"/>
+                <a16:creationId xmlns:a16="http://schemas.microsoft.com/office/drawing/2014/main" id="{A62CBCD0-2953-4AA0-84D0-28E7F5359E69}"/>
               </a:ext>
             </a:extLst>
           </p:cNvPr>
@@ -5920,7 +5920,7 @@
             <a:hlinkClick r:id="rId4"/>
             <a:extLst>
               <a:ext uri="{FF2B5EF4-FFF2-40B4-BE49-F238E27FC236}">
-                <a16:creationId xmlns:a16="http://schemas.microsoft.com/office/drawing/2014/main" id="{BD1C73FD-F4E4-4554-A239-962AFA5889FC}"/>
+                <a16:creationId xmlns:a16="http://schemas.microsoft.com/office/drawing/2014/main" id="{9EE94DFB-541B-4F60-8DD7-0B1BC76ED012}"/>
               </a:ext>
             </a:extLst>
           </p:cNvPr>
@@ -5994,7 +5994,7 @@
           <p:cNvPr id="3" name="Rectangle 2">
             <a:extLst>
               <a:ext uri="{FF2B5EF4-FFF2-40B4-BE49-F238E27FC236}">
-                <a16:creationId xmlns:a16="http://schemas.microsoft.com/office/drawing/2014/main" id="{5F2A5471-1BA2-4CBC-ADCC-A471AC5C360F}"/>
+                <a16:creationId xmlns:a16="http://schemas.microsoft.com/office/drawing/2014/main" id="{D8DE84CC-476E-4EA5-956C-FFD92AA7EF13}"/>
               </a:ext>
             </a:extLst>
           </p:cNvPr>
@@ -6056,7 +6056,7 @@
           <p:cNvPr id="4" name="Rectangle 3">
             <a:extLst>
               <a:ext uri="{FF2B5EF4-FFF2-40B4-BE49-F238E27FC236}">
-                <a16:creationId xmlns:a16="http://schemas.microsoft.com/office/drawing/2014/main" id="{67E8FBAB-97EC-46C1-A7B6-8096B2A68E49}"/>
+                <a16:creationId xmlns:a16="http://schemas.microsoft.com/office/drawing/2014/main" id="{564E9750-5B9C-4AFD-A1E5-CB55F9ADA94A}"/>
               </a:ext>
             </a:extLst>
           </p:cNvPr>
@@ -6145,7 +6145,7 @@
           <p:cNvPr id="6" name="Rectangle: Rounded Corners 5">
             <a:extLst>
               <a:ext uri="{FF2B5EF4-FFF2-40B4-BE49-F238E27FC236}">
-                <a16:creationId xmlns:a16="http://schemas.microsoft.com/office/drawing/2014/main" id="{57012999-B32A-4271-956C-4D7F4C6BE65E}"/>
+                <a16:creationId xmlns:a16="http://schemas.microsoft.com/office/drawing/2014/main" id="{D5E48A51-6574-4B09-ACD9-26918E900A4A}"/>
               </a:ext>
             </a:extLst>
           </p:cNvPr>
@@ -6178,7 +6178,7 @@
           <p:cNvPr id="7" name="Rectangle 6">
             <a:extLst>
               <a:ext uri="{FF2B5EF4-FFF2-40B4-BE49-F238E27FC236}">
-                <a16:creationId xmlns:a16="http://schemas.microsoft.com/office/drawing/2014/main" id="{AB55B088-17AA-4144-AF8A-DFD720075A1D}"/>
+                <a16:creationId xmlns:a16="http://schemas.microsoft.com/office/drawing/2014/main" id="{1E7497CA-496C-457C-B097-81637CE0F3DD}"/>
               </a:ext>
             </a:extLst>
           </p:cNvPr>
@@ -6240,7 +6240,7 @@
           <p:cNvPr id="8" name="Rectangle 7">
             <a:extLst>
               <a:ext uri="{FF2B5EF4-FFF2-40B4-BE49-F238E27FC236}">
-                <a16:creationId xmlns:a16="http://schemas.microsoft.com/office/drawing/2014/main" id="{E3942EBE-3EF8-43B4-956D-89D8FF7AD186}"/>
+                <a16:creationId xmlns:a16="http://schemas.microsoft.com/office/drawing/2014/main" id="{BF6C9D7F-E91C-4E67-878E-16FA5BC610EF}"/>
               </a:ext>
             </a:extLst>
           </p:cNvPr>
@@ -6302,7 +6302,7 @@
           <p:cNvPr id="9" name="Rectangle 8">
             <a:extLst>
               <a:ext uri="{FF2B5EF4-FFF2-40B4-BE49-F238E27FC236}">
-                <a16:creationId xmlns:a16="http://schemas.microsoft.com/office/drawing/2014/main" id="{BC007548-D012-402E-8C94-21ED3C365F5B}"/>
+                <a16:creationId xmlns:a16="http://schemas.microsoft.com/office/drawing/2014/main" id="{CEC03795-8605-4EB5-9349-ADBE8DBF1F3F}"/>
               </a:ext>
             </a:extLst>
           </p:cNvPr>
@@ -6364,7 +6364,7 @@
           <p:cNvPr id="10" name="Rectangle 9">
             <a:extLst>
               <a:ext uri="{FF2B5EF4-FFF2-40B4-BE49-F238E27FC236}">
-                <a16:creationId xmlns:a16="http://schemas.microsoft.com/office/drawing/2014/main" id="{C093D0D0-71B4-4ED5-AE80-EE425C38D8D8}"/>
+                <a16:creationId xmlns:a16="http://schemas.microsoft.com/office/drawing/2014/main" id="{7F3C31BF-2321-4BAA-A960-E43483745D21}"/>
               </a:ext>
             </a:extLst>
           </p:cNvPr>
@@ -6426,7 +6426,7 @@
           <p:cNvPr id="11" name="Rectangle 10">
             <a:extLst>
               <a:ext uri="{FF2B5EF4-FFF2-40B4-BE49-F238E27FC236}">
-                <a16:creationId xmlns:a16="http://schemas.microsoft.com/office/drawing/2014/main" id="{90DC2E8D-859C-4045-858F-2F722D89C265}"/>
+                <a16:creationId xmlns:a16="http://schemas.microsoft.com/office/drawing/2014/main" id="{9AFB6E39-D8CE-4AF7-8075-E55C3825235A}"/>
               </a:ext>
             </a:extLst>
           </p:cNvPr>
@@ -6488,7 +6488,7 @@
           <p:cNvPr id="12" name="Rectangle: Rounded Corners 11">
             <a:extLst>
               <a:ext uri="{FF2B5EF4-FFF2-40B4-BE49-F238E27FC236}">
-                <a16:creationId xmlns:a16="http://schemas.microsoft.com/office/drawing/2014/main" id="{2073D107-375D-4EE7-AF38-41548C046DC8}"/>
+                <a16:creationId xmlns:a16="http://schemas.microsoft.com/office/drawing/2014/main" id="{DC0F23C3-9739-403C-B2D9-015633D6DB04}"/>
               </a:ext>
             </a:extLst>
           </p:cNvPr>
@@ -6523,7 +6523,7 @@
           <p:cNvPr id="13" name="Rectangle 12">
             <a:extLst>
               <a:ext uri="{FF2B5EF4-FFF2-40B4-BE49-F238E27FC236}">
-                <a16:creationId xmlns:a16="http://schemas.microsoft.com/office/drawing/2014/main" id="{BF51868E-236D-49EF-9539-7658E1FBBF69}"/>
+                <a16:creationId xmlns:a16="http://schemas.microsoft.com/office/drawing/2014/main" id="{DF1F94A1-79A9-4EDE-A194-628BDE9BF76C}"/>
               </a:ext>
             </a:extLst>
           </p:cNvPr>
@@ -6585,7 +6585,7 @@
           <p:cNvPr id="14" name="Rectangle 13">
             <a:extLst>
               <a:ext uri="{FF2B5EF4-FFF2-40B4-BE49-F238E27FC236}">
-                <a16:creationId xmlns:a16="http://schemas.microsoft.com/office/drawing/2014/main" id="{0A6A6489-0EC8-45A1-BE62-6C7E81A06D70}"/>
+                <a16:creationId xmlns:a16="http://schemas.microsoft.com/office/drawing/2014/main" id="{E58DF48B-DDC2-4A85-BE0A-621289805343}"/>
               </a:ext>
             </a:extLst>
           </p:cNvPr>
@@ -6647,7 +6647,7 @@
           <p:cNvPr id="15" name="Rectangle 14">
             <a:extLst>
               <a:ext uri="{FF2B5EF4-FFF2-40B4-BE49-F238E27FC236}">
-                <a16:creationId xmlns:a16="http://schemas.microsoft.com/office/drawing/2014/main" id="{8ED153D5-AB6D-4EE5-8523-9B86196F22CC}"/>
+                <a16:creationId xmlns:a16="http://schemas.microsoft.com/office/drawing/2014/main" id="{5B4455AA-74DA-4DF6-92D5-7801B087CAC7}"/>
               </a:ext>
             </a:extLst>
           </p:cNvPr>
@@ -6709,7 +6709,7 @@
           <p:cNvPr id="16" name="Rectangle 15">
             <a:extLst>
               <a:ext uri="{FF2B5EF4-FFF2-40B4-BE49-F238E27FC236}">
-                <a16:creationId xmlns:a16="http://schemas.microsoft.com/office/drawing/2014/main" id="{AB10401E-1D6C-4CA0-B510-1541C5AD390E}"/>
+                <a16:creationId xmlns:a16="http://schemas.microsoft.com/office/drawing/2014/main" id="{73E4ED8A-1155-4D07-A555-B2FADEBD21E2}"/>
               </a:ext>
             </a:extLst>
           </p:cNvPr>
@@ -6771,7 +6771,7 @@
           <p:cNvPr id="17" name="Rectangle 16">
             <a:extLst>
               <a:ext uri="{FF2B5EF4-FFF2-40B4-BE49-F238E27FC236}">
-                <a16:creationId xmlns:a16="http://schemas.microsoft.com/office/drawing/2014/main" id="{7A707660-2E3A-4CA6-A0CC-C65A25B28584}"/>
+                <a16:creationId xmlns:a16="http://schemas.microsoft.com/office/drawing/2014/main" id="{1BF618CA-B506-4246-BEDE-D05829DAF271}"/>
               </a:ext>
             </a:extLst>
           </p:cNvPr>
@@ -6833,7 +6833,7 @@
           <p:cNvPr id="18" name="Rectangle 17">
             <a:extLst>
               <a:ext uri="{FF2B5EF4-FFF2-40B4-BE49-F238E27FC236}">
-                <a16:creationId xmlns:a16="http://schemas.microsoft.com/office/drawing/2014/main" id="{6033505E-D45A-4D80-AF21-886C07216E68}"/>
+                <a16:creationId xmlns:a16="http://schemas.microsoft.com/office/drawing/2014/main" id="{64503DFD-B36A-43B7-B28F-D12E721D2A2A}"/>
               </a:ext>
             </a:extLst>
           </p:cNvPr>
@@ -6895,7 +6895,7 @@
           <p:cNvPr id="19" name="Rectangle: Rounded Corners 18">
             <a:extLst>
               <a:ext uri="{FF2B5EF4-FFF2-40B4-BE49-F238E27FC236}">
-                <a16:creationId xmlns:a16="http://schemas.microsoft.com/office/drawing/2014/main" id="{0B188667-31D6-46C1-AC9B-DFD72B79E581}"/>
+                <a16:creationId xmlns:a16="http://schemas.microsoft.com/office/drawing/2014/main" id="{52DEA613-606E-4150-9C11-140A2F2BD3CA}"/>
               </a:ext>
             </a:extLst>
           </p:cNvPr>
@@ -6930,7 +6930,7 @@
           <p:cNvPr id="20" name="Rectangle 19">
             <a:extLst>
               <a:ext uri="{FF2B5EF4-FFF2-40B4-BE49-F238E27FC236}">
-                <a16:creationId xmlns:a16="http://schemas.microsoft.com/office/drawing/2014/main" id="{FA6686A5-DBA2-4C1D-9F73-D98EEF903541}"/>
+                <a16:creationId xmlns:a16="http://schemas.microsoft.com/office/drawing/2014/main" id="{4D734EAE-A1E3-413B-9541-838EEE1EF097}"/>
               </a:ext>
             </a:extLst>
           </p:cNvPr>
@@ -6992,7 +6992,7 @@
           <p:cNvPr id="21" name="Rectangle 20">
             <a:extLst>
               <a:ext uri="{FF2B5EF4-FFF2-40B4-BE49-F238E27FC236}">
-                <a16:creationId xmlns:a16="http://schemas.microsoft.com/office/drawing/2014/main" id="{38991D6A-6A02-4A33-825D-B8064E34610A}"/>
+                <a16:creationId xmlns:a16="http://schemas.microsoft.com/office/drawing/2014/main" id="{E6CD331F-F526-4B27-92DA-7B91D177C3EB}"/>
               </a:ext>
             </a:extLst>
           </p:cNvPr>
@@ -7023,7 +7023,7 @@
           <p:cNvPr id="22" name="Rectangle 21">
             <a:extLst>
               <a:ext uri="{FF2B5EF4-FFF2-40B4-BE49-F238E27FC236}">
-                <a16:creationId xmlns:a16="http://schemas.microsoft.com/office/drawing/2014/main" id="{3FE19EB3-B95C-44A0-8CBC-9160F8F7B00B}"/>
+                <a16:creationId xmlns:a16="http://schemas.microsoft.com/office/drawing/2014/main" id="{1B6001A9-A203-45E5-BF48-A97C768946A2}"/>
               </a:ext>
             </a:extLst>
           </p:cNvPr>
@@ -7085,7 +7085,7 @@
           <p:cNvPr id="23" name="Rectangle 22">
             <a:extLst>
               <a:ext uri="{FF2B5EF4-FFF2-40B4-BE49-F238E27FC236}">
-                <a16:creationId xmlns:a16="http://schemas.microsoft.com/office/drawing/2014/main" id="{35A89C83-8CCF-4314-BBB3-817D67B8CEDA}"/>
+                <a16:creationId xmlns:a16="http://schemas.microsoft.com/office/drawing/2014/main" id="{9A422C57-F1FE-4149-A9EB-218FC4018BA1}"/>
               </a:ext>
             </a:extLst>
           </p:cNvPr>
@@ -7145,7 +7145,7 @@
     </p:spTree>
     <p:extLst>
       <p:ext uri="{BB962C8B-B14F-4D97-AF65-F5344CB8AC3E}">
-        <p14:creationId xmlns:p14="http://schemas.microsoft.com/office/powerpoint/2010/main" val="961379952"/>
+        <p14:creationId xmlns:p14="http://schemas.microsoft.com/office/powerpoint/2010/main" val="618271968"/>
       </p:ext>
     </p:extLst>
   </p:cSld>
@@ -7186,7 +7186,7 @@
             <a:hlinkClick r:id="rId3"/>
             <a:extLst>
               <a:ext uri="{FF2B5EF4-FFF2-40B4-BE49-F238E27FC236}">
-                <a16:creationId xmlns:a16="http://schemas.microsoft.com/office/drawing/2014/main" id="{FB275886-89CD-41E5-B6A8-FF729DA731B6}"/>
+                <a16:creationId xmlns:a16="http://schemas.microsoft.com/office/drawing/2014/main" id="{099B5F0F-C08D-4F70-9CBB-401470823C6A}"/>
               </a:ext>
             </a:extLst>
           </p:cNvPr>
@@ -7261,7 +7261,7 @@
             <a:hlinkClick r:id="rId4"/>
             <a:extLst>
               <a:ext uri="{FF2B5EF4-FFF2-40B4-BE49-F238E27FC236}">
-                <a16:creationId xmlns:a16="http://schemas.microsoft.com/office/drawing/2014/main" id="{157AD1EE-EBDC-4356-86F7-22E9E68F8835}"/>
+                <a16:creationId xmlns:a16="http://schemas.microsoft.com/office/drawing/2014/main" id="{1CE02679-A317-440C-96CE-E9BB70C49C43}"/>
               </a:ext>
             </a:extLst>
           </p:cNvPr>
@@ -7335,7 +7335,7 @@
           <p:cNvPr id="3" name="Rectangle 2">
             <a:extLst>
               <a:ext uri="{FF2B5EF4-FFF2-40B4-BE49-F238E27FC236}">
-                <a16:creationId xmlns:a16="http://schemas.microsoft.com/office/drawing/2014/main" id="{B3426931-91B0-4409-AF07-DC76F9BCD1C3}"/>
+                <a16:creationId xmlns:a16="http://schemas.microsoft.com/office/drawing/2014/main" id="{81D1FC6F-9804-4FE1-BCCC-E7144BFA5ADC}"/>
               </a:ext>
             </a:extLst>
           </p:cNvPr>
@@ -7397,7 +7397,7 @@
           <p:cNvPr id="4" name="Rectangle 3">
             <a:extLst>
               <a:ext uri="{FF2B5EF4-FFF2-40B4-BE49-F238E27FC236}">
-                <a16:creationId xmlns:a16="http://schemas.microsoft.com/office/drawing/2014/main" id="{31938100-C170-478E-AD68-E0E3C8C550AD}"/>
+                <a16:creationId xmlns:a16="http://schemas.microsoft.com/office/drawing/2014/main" id="{A8622196-7604-4CC3-ABBD-CCAAD5317513}"/>
               </a:ext>
             </a:extLst>
           </p:cNvPr>
@@ -7486,7 +7486,7 @@
           <p:cNvPr id="6" name="Rectangle: Rounded Corners 5">
             <a:extLst>
               <a:ext uri="{FF2B5EF4-FFF2-40B4-BE49-F238E27FC236}">
-                <a16:creationId xmlns:a16="http://schemas.microsoft.com/office/drawing/2014/main" id="{E5AFBC04-278C-4A4C-A01E-D4031AED0815}"/>
+                <a16:creationId xmlns:a16="http://schemas.microsoft.com/office/drawing/2014/main" id="{5AF6714E-BEFB-4896-B177-2755411A31D9}"/>
               </a:ext>
             </a:extLst>
           </p:cNvPr>
@@ -7519,7 +7519,7 @@
           <p:cNvPr id="7" name="Oval 6">
             <a:extLst>
               <a:ext uri="{FF2B5EF4-FFF2-40B4-BE49-F238E27FC236}">
-                <a16:creationId xmlns:a16="http://schemas.microsoft.com/office/drawing/2014/main" id="{BF09A862-3F94-4429-8F72-A0B31D1D7975}"/>
+                <a16:creationId xmlns:a16="http://schemas.microsoft.com/office/drawing/2014/main" id="{FBD74002-7533-4F78-AB57-270C1EAC00E1}"/>
               </a:ext>
             </a:extLst>
           </p:cNvPr>
@@ -7550,7 +7550,7 @@
           <p:cNvPr id="8" name="Rectangle 7">
             <a:extLst>
               <a:ext uri="{FF2B5EF4-FFF2-40B4-BE49-F238E27FC236}">
-                <a16:creationId xmlns:a16="http://schemas.microsoft.com/office/drawing/2014/main" id="{3DA853EC-D2AF-4AD6-8E82-3CA4658D5E9A}"/>
+                <a16:creationId xmlns:a16="http://schemas.microsoft.com/office/drawing/2014/main" id="{A21F1C30-C810-44E4-B179-74BC1FB5614A}"/>
               </a:ext>
             </a:extLst>
           </p:cNvPr>
@@ -7612,7 +7612,7 @@
           <p:cNvPr id="9" name="Rectangle: Rounded Corners 8">
             <a:extLst>
               <a:ext uri="{FF2B5EF4-FFF2-40B4-BE49-F238E27FC236}">
-                <a16:creationId xmlns:a16="http://schemas.microsoft.com/office/drawing/2014/main" id="{9572FEE2-6CA0-460C-8595-C295B22663FA}"/>
+                <a16:creationId xmlns:a16="http://schemas.microsoft.com/office/drawing/2014/main" id="{4C3BDCEC-6EDC-4466-ABCE-D75C2F0DF373}"/>
               </a:ext>
             </a:extLst>
           </p:cNvPr>
@@ -7647,7 +7647,7 @@
           <p:cNvPr id="10" name="Rectangle 9">
             <a:extLst>
               <a:ext uri="{FF2B5EF4-FFF2-40B4-BE49-F238E27FC236}">
-                <a16:creationId xmlns:a16="http://schemas.microsoft.com/office/drawing/2014/main" id="{8FB5E323-A1B2-467F-B15C-EFED34597003}"/>
+                <a16:creationId xmlns:a16="http://schemas.microsoft.com/office/drawing/2014/main" id="{EA37EC6A-EFA0-4D43-8E42-455A886C8A65}"/>
               </a:ext>
             </a:extLst>
           </p:cNvPr>
@@ -7709,7 +7709,7 @@
           <p:cNvPr id="11" name="Oval 10">
             <a:extLst>
               <a:ext uri="{FF2B5EF4-FFF2-40B4-BE49-F238E27FC236}">
-                <a16:creationId xmlns:a16="http://schemas.microsoft.com/office/drawing/2014/main" id="{12654BC6-B35E-4C3B-A5B5-0AF8AA94E550}"/>
+                <a16:creationId xmlns:a16="http://schemas.microsoft.com/office/drawing/2014/main" id="{2192653A-B884-4F55-A0EE-D7CEEA3B95C0}"/>
               </a:ext>
             </a:extLst>
           </p:cNvPr>
@@ -7740,7 +7740,7 @@
           <p:cNvPr id="12" name="Rectangle 11">
             <a:extLst>
               <a:ext uri="{FF2B5EF4-FFF2-40B4-BE49-F238E27FC236}">
-                <a16:creationId xmlns:a16="http://schemas.microsoft.com/office/drawing/2014/main" id="{D961317A-BA60-4537-8A63-4C27A0673CF1}"/>
+                <a16:creationId xmlns:a16="http://schemas.microsoft.com/office/drawing/2014/main" id="{87831E37-1AA6-4B77-8A2A-878FD4F584A1}"/>
               </a:ext>
             </a:extLst>
           </p:cNvPr>
@@ -7802,7 +7802,7 @@
           <p:cNvPr id="13" name="Rectangle: Rounded Corners 12">
             <a:extLst>
               <a:ext uri="{FF2B5EF4-FFF2-40B4-BE49-F238E27FC236}">
-                <a16:creationId xmlns:a16="http://schemas.microsoft.com/office/drawing/2014/main" id="{409D5BF6-3562-4502-BB69-37768DA5E3CF}"/>
+                <a16:creationId xmlns:a16="http://schemas.microsoft.com/office/drawing/2014/main" id="{C733435B-ECE6-45AA-9B7E-9931D8D655A3}"/>
               </a:ext>
             </a:extLst>
           </p:cNvPr>
@@ -7837,7 +7837,7 @@
           <p:cNvPr id="14" name="Rectangle 13">
             <a:extLst>
               <a:ext uri="{FF2B5EF4-FFF2-40B4-BE49-F238E27FC236}">
-                <a16:creationId xmlns:a16="http://schemas.microsoft.com/office/drawing/2014/main" id="{FE12F624-E08B-4633-91A8-EF58ABB66BCA}"/>
+                <a16:creationId xmlns:a16="http://schemas.microsoft.com/office/drawing/2014/main" id="{4F1CC180-F81D-4DC1-935F-C65C74199A1D}"/>
               </a:ext>
             </a:extLst>
           </p:cNvPr>
@@ -7899,7 +7899,7 @@
           <p:cNvPr id="15" name="Oval 14">
             <a:extLst>
               <a:ext uri="{FF2B5EF4-FFF2-40B4-BE49-F238E27FC236}">
-                <a16:creationId xmlns:a16="http://schemas.microsoft.com/office/drawing/2014/main" id="{41C3EAA8-6BB2-4DBA-8822-DC7D721E4F05}"/>
+                <a16:creationId xmlns:a16="http://schemas.microsoft.com/office/drawing/2014/main" id="{686F34C6-D763-4AAE-8030-2FAA2A341740}"/>
               </a:ext>
             </a:extLst>
           </p:cNvPr>
@@ -7930,7 +7930,7 @@
           <p:cNvPr id="16" name="Rectangle 15">
             <a:extLst>
               <a:ext uri="{FF2B5EF4-FFF2-40B4-BE49-F238E27FC236}">
-                <a16:creationId xmlns:a16="http://schemas.microsoft.com/office/drawing/2014/main" id="{9F255CB1-1B4C-47EC-95D6-4C0B48468CF0}"/>
+                <a16:creationId xmlns:a16="http://schemas.microsoft.com/office/drawing/2014/main" id="{CC651E63-132D-4DD6-8CD2-367F1FC12B5E}"/>
               </a:ext>
             </a:extLst>
           </p:cNvPr>
@@ -7992,7 +7992,7 @@
           <p:cNvPr id="17" name="Rectangle: Rounded Corners 16">
             <a:extLst>
               <a:ext uri="{FF2B5EF4-FFF2-40B4-BE49-F238E27FC236}">
-                <a16:creationId xmlns:a16="http://schemas.microsoft.com/office/drawing/2014/main" id="{9222D8E0-C6FA-4E41-89AD-D582954FC3A1}"/>
+                <a16:creationId xmlns:a16="http://schemas.microsoft.com/office/drawing/2014/main" id="{04BB09A3-6AC6-4786-B061-60B9344BDF38}"/>
               </a:ext>
             </a:extLst>
           </p:cNvPr>
@@ -8027,7 +8027,7 @@
           <p:cNvPr id="18" name="Rectangle 17">
             <a:extLst>
               <a:ext uri="{FF2B5EF4-FFF2-40B4-BE49-F238E27FC236}">
-                <a16:creationId xmlns:a16="http://schemas.microsoft.com/office/drawing/2014/main" id="{C0622880-E841-4618-8C47-AD08CF791E13}"/>
+                <a16:creationId xmlns:a16="http://schemas.microsoft.com/office/drawing/2014/main" id="{D662BB2A-545D-4D26-9433-6CC2B9FC2D7D}"/>
               </a:ext>
             </a:extLst>
           </p:cNvPr>
@@ -8089,7 +8089,7 @@
           <p:cNvPr id="19" name="Rectangle 18">
             <a:extLst>
               <a:ext uri="{FF2B5EF4-FFF2-40B4-BE49-F238E27FC236}">
-                <a16:creationId xmlns:a16="http://schemas.microsoft.com/office/drawing/2014/main" id="{F6A3B23C-0786-4CB5-A5CC-C6CD98B829F2}"/>
+                <a16:creationId xmlns:a16="http://schemas.microsoft.com/office/drawing/2014/main" id="{634A87EF-0CE5-436D-A8FE-C15072E09409}"/>
               </a:ext>
             </a:extLst>
           </p:cNvPr>
@@ -8120,7 +8120,7 @@
           <p:cNvPr id="20" name="Rectangle 19">
             <a:extLst>
               <a:ext uri="{FF2B5EF4-FFF2-40B4-BE49-F238E27FC236}">
-                <a16:creationId xmlns:a16="http://schemas.microsoft.com/office/drawing/2014/main" id="{A2E797D1-93F5-4E73-AC2C-6863445DBCCA}"/>
+                <a16:creationId xmlns:a16="http://schemas.microsoft.com/office/drawing/2014/main" id="{79CDF01A-E735-438D-AD01-22DE5DF960D1}"/>
               </a:ext>
             </a:extLst>
           </p:cNvPr>
@@ -8182,7 +8182,7 @@
           <p:cNvPr id="21" name="Rectangle 20">
             <a:extLst>
               <a:ext uri="{FF2B5EF4-FFF2-40B4-BE49-F238E27FC236}">
-                <a16:creationId xmlns:a16="http://schemas.microsoft.com/office/drawing/2014/main" id="{E91DFA65-B3BF-452A-869C-966AE48FE9BE}"/>
+                <a16:creationId xmlns:a16="http://schemas.microsoft.com/office/drawing/2014/main" id="{FC453084-FE6A-4AC2-A6B4-26FF5D2DEFE7}"/>
               </a:ext>
             </a:extLst>
           </p:cNvPr>
@@ -8242,7 +8242,7 @@
     </p:spTree>
     <p:extLst>
       <p:ext uri="{BB962C8B-B14F-4D97-AF65-F5344CB8AC3E}">
-        <p14:creationId xmlns:p14="http://schemas.microsoft.com/office/powerpoint/2010/main" val="567371025"/>
+        <p14:creationId xmlns:p14="http://schemas.microsoft.com/office/powerpoint/2010/main" val="1492641365"/>
       </p:ext>
     </p:extLst>
   </p:cSld>
@@ -8283,7 +8283,7 @@
             <a:hlinkClick r:id="rId3"/>
             <a:extLst>
               <a:ext uri="{FF2B5EF4-FFF2-40B4-BE49-F238E27FC236}">
-                <a16:creationId xmlns:a16="http://schemas.microsoft.com/office/drawing/2014/main" id="{A84AD618-144C-42DA-ACA3-7CD0A6E61853}"/>
+                <a16:creationId xmlns:a16="http://schemas.microsoft.com/office/drawing/2014/main" id="{CD93EB77-2F31-45B5-AA56-B5CD7D34A5D5}"/>
               </a:ext>
             </a:extLst>
           </p:cNvPr>
@@ -8358,7 +8358,7 @@
             <a:hlinkClick r:id="rId4"/>
             <a:extLst>
               <a:ext uri="{FF2B5EF4-FFF2-40B4-BE49-F238E27FC236}">
-                <a16:creationId xmlns:a16="http://schemas.microsoft.com/office/drawing/2014/main" id="{A17186A3-2D6E-4313-9B19-18AE27372C0C}"/>
+                <a16:creationId xmlns:a16="http://schemas.microsoft.com/office/drawing/2014/main" id="{2A20A8AB-BBAC-4E6B-9DA6-3DBF19273B92}"/>
               </a:ext>
             </a:extLst>
           </p:cNvPr>
@@ -8432,7 +8432,7 @@
           <p:cNvPr id="3" name="Rectangle 2">
             <a:extLst>
               <a:ext uri="{FF2B5EF4-FFF2-40B4-BE49-F238E27FC236}">
-                <a16:creationId xmlns:a16="http://schemas.microsoft.com/office/drawing/2014/main" id="{1DE28029-82DF-458E-A6F3-F0B058D72D17}"/>
+                <a16:creationId xmlns:a16="http://schemas.microsoft.com/office/drawing/2014/main" id="{DC11112C-8B9B-46A9-A5EE-C5C07A16FEB8}"/>
               </a:ext>
             </a:extLst>
           </p:cNvPr>
@@ -8494,7 +8494,7 @@
           <p:cNvPr id="4" name="Rectangle 3">
             <a:extLst>
               <a:ext uri="{FF2B5EF4-FFF2-40B4-BE49-F238E27FC236}">
-                <a16:creationId xmlns:a16="http://schemas.microsoft.com/office/drawing/2014/main" id="{1067BE1C-2DBA-4865-93FC-E4021286D1A9}"/>
+                <a16:creationId xmlns:a16="http://schemas.microsoft.com/office/drawing/2014/main" id="{187ECEBC-D20D-468F-B328-F89C8FAB0E19}"/>
               </a:ext>
             </a:extLst>
           </p:cNvPr>
@@ -8583,7 +8583,7 @@
           <p:cNvPr id="6" name="Rectangle: Rounded Corners 5">
             <a:extLst>
               <a:ext uri="{FF2B5EF4-FFF2-40B4-BE49-F238E27FC236}">
-                <a16:creationId xmlns:a16="http://schemas.microsoft.com/office/drawing/2014/main" id="{698E724B-E012-432D-BACB-E38B78594391}"/>
+                <a16:creationId xmlns:a16="http://schemas.microsoft.com/office/drawing/2014/main" id="{F73AB2B9-1E46-4051-BFBB-A73D948CDEAE}"/>
               </a:ext>
             </a:extLst>
           </p:cNvPr>
@@ -8616,7 +8616,7 @@
           <p:cNvPr id="7" name="Oval 6">
             <a:extLst>
               <a:ext uri="{FF2B5EF4-FFF2-40B4-BE49-F238E27FC236}">
-                <a16:creationId xmlns:a16="http://schemas.microsoft.com/office/drawing/2014/main" id="{82C16EB7-84A3-4D77-918B-85F2CF13269B}"/>
+                <a16:creationId xmlns:a16="http://schemas.microsoft.com/office/drawing/2014/main" id="{ED0DADCA-8C19-4C15-95DE-92398F2EC1CC}"/>
               </a:ext>
             </a:extLst>
           </p:cNvPr>
@@ -8647,7 +8647,7 @@
           <p:cNvPr id="8" name="Rectangle 7">
             <a:extLst>
               <a:ext uri="{FF2B5EF4-FFF2-40B4-BE49-F238E27FC236}">
-                <a16:creationId xmlns:a16="http://schemas.microsoft.com/office/drawing/2014/main" id="{8E6FECA8-C0BE-4907-8655-0D894121962A}"/>
+                <a16:creationId xmlns:a16="http://schemas.microsoft.com/office/drawing/2014/main" id="{D9591F68-9D06-4785-B892-E5F9AF0925DE}"/>
               </a:ext>
             </a:extLst>
           </p:cNvPr>
@@ -8709,7 +8709,7 @@
           <p:cNvPr id="9" name="Rectangle: Rounded Corners 8">
             <a:extLst>
               <a:ext uri="{FF2B5EF4-FFF2-40B4-BE49-F238E27FC236}">
-                <a16:creationId xmlns:a16="http://schemas.microsoft.com/office/drawing/2014/main" id="{E50FCBCD-0741-4F5E-8C1F-90C4F589FBA2}"/>
+                <a16:creationId xmlns:a16="http://schemas.microsoft.com/office/drawing/2014/main" id="{CB9801EC-A451-499E-A0C9-C06031088D7A}"/>
               </a:ext>
             </a:extLst>
           </p:cNvPr>
@@ -8744,7 +8744,7 @@
           <p:cNvPr id="10" name="Rectangle 9">
             <a:extLst>
               <a:ext uri="{FF2B5EF4-FFF2-40B4-BE49-F238E27FC236}">
-                <a16:creationId xmlns:a16="http://schemas.microsoft.com/office/drawing/2014/main" id="{10B9B4EC-D817-4DF9-9CBC-DD7C0F0432AC}"/>
+                <a16:creationId xmlns:a16="http://schemas.microsoft.com/office/drawing/2014/main" id="{67FAB63C-AD94-47D2-974D-DA7AAB586137}"/>
               </a:ext>
             </a:extLst>
           </p:cNvPr>
@@ -8806,7 +8806,7 @@
           <p:cNvPr id="11" name="Oval 10">
             <a:extLst>
               <a:ext uri="{FF2B5EF4-FFF2-40B4-BE49-F238E27FC236}">
-                <a16:creationId xmlns:a16="http://schemas.microsoft.com/office/drawing/2014/main" id="{66F61874-6B7F-4994-89CA-D055619A324A}"/>
+                <a16:creationId xmlns:a16="http://schemas.microsoft.com/office/drawing/2014/main" id="{57F23106-53A5-4871-99C0-364400274757}"/>
               </a:ext>
             </a:extLst>
           </p:cNvPr>
@@ -8837,7 +8837,7 @@
           <p:cNvPr id="12" name="Rectangle 11">
             <a:extLst>
               <a:ext uri="{FF2B5EF4-FFF2-40B4-BE49-F238E27FC236}">
-                <a16:creationId xmlns:a16="http://schemas.microsoft.com/office/drawing/2014/main" id="{E72F10CF-3F15-4E0E-867D-5C3ACF72C6A4}"/>
+                <a16:creationId xmlns:a16="http://schemas.microsoft.com/office/drawing/2014/main" id="{5B7BB9F2-C379-40E9-AE28-63C8D0A3C3B6}"/>
               </a:ext>
             </a:extLst>
           </p:cNvPr>
@@ -8899,7 +8899,7 @@
           <p:cNvPr id="13" name="Rectangle: Rounded Corners 12">
             <a:extLst>
               <a:ext uri="{FF2B5EF4-FFF2-40B4-BE49-F238E27FC236}">
-                <a16:creationId xmlns:a16="http://schemas.microsoft.com/office/drawing/2014/main" id="{C87DC077-4D5D-4835-9042-DF178989687B}"/>
+                <a16:creationId xmlns:a16="http://schemas.microsoft.com/office/drawing/2014/main" id="{64D8305C-FD6A-40ED-9C1F-E4C6E13E38B6}"/>
               </a:ext>
             </a:extLst>
           </p:cNvPr>
@@ -8934,7 +8934,7 @@
           <p:cNvPr id="14" name="Rectangle 13">
             <a:extLst>
               <a:ext uri="{FF2B5EF4-FFF2-40B4-BE49-F238E27FC236}">
-                <a16:creationId xmlns:a16="http://schemas.microsoft.com/office/drawing/2014/main" id="{11F3C959-EEDE-4BF7-8770-7B15FE5D40A6}"/>
+                <a16:creationId xmlns:a16="http://schemas.microsoft.com/office/drawing/2014/main" id="{767E9CA1-7877-448F-9442-BA7FC9390DE2}"/>
               </a:ext>
             </a:extLst>
           </p:cNvPr>
@@ -8996,7 +8996,7 @@
           <p:cNvPr id="15" name="Oval 14">
             <a:extLst>
               <a:ext uri="{FF2B5EF4-FFF2-40B4-BE49-F238E27FC236}">
-                <a16:creationId xmlns:a16="http://schemas.microsoft.com/office/drawing/2014/main" id="{A508E0EB-C9EA-42BC-A6F9-8B8337339CD6}"/>
+                <a16:creationId xmlns:a16="http://schemas.microsoft.com/office/drawing/2014/main" id="{41F17569-E014-4C76-8E67-4B150BB1F20E}"/>
               </a:ext>
             </a:extLst>
           </p:cNvPr>
@@ -9027,7 +9027,7 @@
           <p:cNvPr id="16" name="Rectangle 15">
             <a:extLst>
               <a:ext uri="{FF2B5EF4-FFF2-40B4-BE49-F238E27FC236}">
-                <a16:creationId xmlns:a16="http://schemas.microsoft.com/office/drawing/2014/main" id="{4BE6024C-0A5D-4162-8BFA-9EF82626AA48}"/>
+                <a16:creationId xmlns:a16="http://schemas.microsoft.com/office/drawing/2014/main" id="{B72A2AE5-711C-49F1-8471-79FBD38DA645}"/>
               </a:ext>
             </a:extLst>
           </p:cNvPr>
@@ -9089,7 +9089,7 @@
           <p:cNvPr id="17" name="Rectangle: Rounded Corners 16">
             <a:extLst>
               <a:ext uri="{FF2B5EF4-FFF2-40B4-BE49-F238E27FC236}">
-                <a16:creationId xmlns:a16="http://schemas.microsoft.com/office/drawing/2014/main" id="{D3D2C091-214A-4874-91A1-A269278EDA10}"/>
+                <a16:creationId xmlns:a16="http://schemas.microsoft.com/office/drawing/2014/main" id="{6841F073-2054-413A-8E37-662A531EDAA6}"/>
               </a:ext>
             </a:extLst>
           </p:cNvPr>
@@ -9124,7 +9124,7 @@
           <p:cNvPr id="18" name="Rectangle 17">
             <a:extLst>
               <a:ext uri="{FF2B5EF4-FFF2-40B4-BE49-F238E27FC236}">
-                <a16:creationId xmlns:a16="http://schemas.microsoft.com/office/drawing/2014/main" id="{96F115ED-3620-4564-8173-485CC6A856DF}"/>
+                <a16:creationId xmlns:a16="http://schemas.microsoft.com/office/drawing/2014/main" id="{03C47F1A-97EB-4B00-84A1-C2DFB3C55A03}"/>
               </a:ext>
             </a:extLst>
           </p:cNvPr>
@@ -9186,7 +9186,7 @@
           <p:cNvPr id="19" name="Rectangle 18">
             <a:extLst>
               <a:ext uri="{FF2B5EF4-FFF2-40B4-BE49-F238E27FC236}">
-                <a16:creationId xmlns:a16="http://schemas.microsoft.com/office/drawing/2014/main" id="{B05FF79B-9BBA-4B3A-A9C5-64BF388CE0AD}"/>
+                <a16:creationId xmlns:a16="http://schemas.microsoft.com/office/drawing/2014/main" id="{4A6AF8D2-600B-4DA6-A31A-6ED23AC29E9E}"/>
               </a:ext>
             </a:extLst>
           </p:cNvPr>
@@ -9217,7 +9217,7 @@
           <p:cNvPr id="20" name="Rectangle 19">
             <a:extLst>
               <a:ext uri="{FF2B5EF4-FFF2-40B4-BE49-F238E27FC236}">
-                <a16:creationId xmlns:a16="http://schemas.microsoft.com/office/drawing/2014/main" id="{EAE3DA58-C8CB-4984-A678-375856DC460E}"/>
+                <a16:creationId xmlns:a16="http://schemas.microsoft.com/office/drawing/2014/main" id="{E6B7AD34-EA16-420D-9203-DA3D32B6D606}"/>
               </a:ext>
             </a:extLst>
           </p:cNvPr>
@@ -9279,7 +9279,7 @@
           <p:cNvPr id="21" name="Rectangle 20">
             <a:extLst>
               <a:ext uri="{FF2B5EF4-FFF2-40B4-BE49-F238E27FC236}">
-                <a16:creationId xmlns:a16="http://schemas.microsoft.com/office/drawing/2014/main" id="{9CF5B123-E87E-4448-8580-1492863FD79B}"/>
+                <a16:creationId xmlns:a16="http://schemas.microsoft.com/office/drawing/2014/main" id="{41D4B073-CBB7-4492-8FD8-FB48BE2433FC}"/>
               </a:ext>
             </a:extLst>
           </p:cNvPr>
@@ -9339,7 +9339,7 @@
     </p:spTree>
     <p:extLst>
       <p:ext uri="{BB962C8B-B14F-4D97-AF65-F5344CB8AC3E}">
-        <p14:creationId xmlns:p14="http://schemas.microsoft.com/office/powerpoint/2010/main" val="1160488634"/>
+        <p14:creationId xmlns:p14="http://schemas.microsoft.com/office/powerpoint/2010/main" val="1998766101"/>
       </p:ext>
     </p:extLst>
   </p:cSld>
@@ -9380,7 +9380,7 @@
             <a:hlinkClick r:id="rId3"/>
             <a:extLst>
               <a:ext uri="{FF2B5EF4-FFF2-40B4-BE49-F238E27FC236}">
-                <a16:creationId xmlns:a16="http://schemas.microsoft.com/office/drawing/2014/main" id="{E98306C6-4611-4749-8DA3-99DA27AED4E1}"/>
+                <a16:creationId xmlns:a16="http://schemas.microsoft.com/office/drawing/2014/main" id="{39245AC8-36FF-4D78-86FD-A15B0E8C7B02}"/>
               </a:ext>
             </a:extLst>
           </p:cNvPr>
@@ -9455,7 +9455,7 @@
             <a:hlinkClick r:id="rId4"/>
             <a:extLst>
               <a:ext uri="{FF2B5EF4-FFF2-40B4-BE49-F238E27FC236}">
-                <a16:creationId xmlns:a16="http://schemas.microsoft.com/office/drawing/2014/main" id="{2F91A9A5-2B1C-4084-967F-26293B61B326}"/>
+                <a16:creationId xmlns:a16="http://schemas.microsoft.com/office/drawing/2014/main" id="{DD65B017-B41B-4127-AAF0-88A5E594E7D7}"/>
               </a:ext>
             </a:extLst>
           </p:cNvPr>
@@ -9529,7 +9529,7 @@
           <p:cNvPr id="3" name="Rectangle 2">
             <a:extLst>
               <a:ext uri="{FF2B5EF4-FFF2-40B4-BE49-F238E27FC236}">
-                <a16:creationId xmlns:a16="http://schemas.microsoft.com/office/drawing/2014/main" id="{C71EA69A-2D92-4283-8D42-937FBAAEDBFA}"/>
+                <a16:creationId xmlns:a16="http://schemas.microsoft.com/office/drawing/2014/main" id="{2756BBD6-9785-4C8C-9BBC-41BD8B825B43}"/>
               </a:ext>
             </a:extLst>
           </p:cNvPr>
@@ -9591,7 +9591,7 @@
           <p:cNvPr id="4" name="Rectangle 3">
             <a:extLst>
               <a:ext uri="{FF2B5EF4-FFF2-40B4-BE49-F238E27FC236}">
-                <a16:creationId xmlns:a16="http://schemas.microsoft.com/office/drawing/2014/main" id="{5B480C06-27B0-4E07-90EC-C8816BC500F1}"/>
+                <a16:creationId xmlns:a16="http://schemas.microsoft.com/office/drawing/2014/main" id="{0354E15D-5C5F-4761-9522-38562AE57231}"/>
               </a:ext>
             </a:extLst>
           </p:cNvPr>
@@ -9680,7 +9680,7 @@
           <p:cNvPr id="6" name="Rectangle: Rounded Corners 5">
             <a:extLst>
               <a:ext uri="{FF2B5EF4-FFF2-40B4-BE49-F238E27FC236}">
-                <a16:creationId xmlns:a16="http://schemas.microsoft.com/office/drawing/2014/main" id="{7DA30EBE-8FA1-4AAF-823A-00BCE48C73FA}"/>
+                <a16:creationId xmlns:a16="http://schemas.microsoft.com/office/drawing/2014/main" id="{D2D3E388-1593-4619-9D16-578AD3D0A71B}"/>
               </a:ext>
             </a:extLst>
           </p:cNvPr>
@@ -9713,7 +9713,7 @@
           <p:cNvPr id="7" name="Oval 6">
             <a:extLst>
               <a:ext uri="{FF2B5EF4-FFF2-40B4-BE49-F238E27FC236}">
-                <a16:creationId xmlns:a16="http://schemas.microsoft.com/office/drawing/2014/main" id="{46487E3E-6748-47C0-8327-1F755447D487}"/>
+                <a16:creationId xmlns:a16="http://schemas.microsoft.com/office/drawing/2014/main" id="{EB2B90B5-723B-4AB4-96B4-0524FDF6223C}"/>
               </a:ext>
             </a:extLst>
           </p:cNvPr>
@@ -9744,7 +9744,7 @@
           <p:cNvPr id="8" name="Rectangle 7">
             <a:extLst>
               <a:ext uri="{FF2B5EF4-FFF2-40B4-BE49-F238E27FC236}">
-                <a16:creationId xmlns:a16="http://schemas.microsoft.com/office/drawing/2014/main" id="{ECF9B0DA-4BA8-4320-8489-F162864167E0}"/>
+                <a16:creationId xmlns:a16="http://schemas.microsoft.com/office/drawing/2014/main" id="{3B92C872-2775-4F90-BF3D-57D64B48EC71}"/>
               </a:ext>
             </a:extLst>
           </p:cNvPr>
@@ -9806,7 +9806,7 @@
           <p:cNvPr id="9" name="Rectangle: Rounded Corners 8">
             <a:extLst>
               <a:ext uri="{FF2B5EF4-FFF2-40B4-BE49-F238E27FC236}">
-                <a16:creationId xmlns:a16="http://schemas.microsoft.com/office/drawing/2014/main" id="{775696DB-14EB-4559-89A1-69EBF50CFA0B}"/>
+                <a16:creationId xmlns:a16="http://schemas.microsoft.com/office/drawing/2014/main" id="{9D81D162-75E1-41BC-9224-C6455845ABC8}"/>
               </a:ext>
             </a:extLst>
           </p:cNvPr>
@@ -9841,7 +9841,7 @@
           <p:cNvPr id="10" name="Rectangle 9">
             <a:extLst>
               <a:ext uri="{FF2B5EF4-FFF2-40B4-BE49-F238E27FC236}">
-                <a16:creationId xmlns:a16="http://schemas.microsoft.com/office/drawing/2014/main" id="{2576AB35-8CE8-404D-9553-6E25C4090AAD}"/>
+                <a16:creationId xmlns:a16="http://schemas.microsoft.com/office/drawing/2014/main" id="{01D4D6AF-1116-4171-B2FD-D864EEA207B7}"/>
               </a:ext>
             </a:extLst>
           </p:cNvPr>
@@ -9903,7 +9903,7 @@
           <p:cNvPr id="11" name="Oval 10">
             <a:extLst>
               <a:ext uri="{FF2B5EF4-FFF2-40B4-BE49-F238E27FC236}">
-                <a16:creationId xmlns:a16="http://schemas.microsoft.com/office/drawing/2014/main" id="{689ED3CC-3E3B-4D71-9A7A-B45D11CE0E05}"/>
+                <a16:creationId xmlns:a16="http://schemas.microsoft.com/office/drawing/2014/main" id="{E9154E0E-AE4D-4EF6-8370-8134B063DDFF}"/>
               </a:ext>
             </a:extLst>
           </p:cNvPr>
@@ -9934,7 +9934,7 @@
           <p:cNvPr id="12" name="Rectangle 11">
             <a:extLst>
               <a:ext uri="{FF2B5EF4-FFF2-40B4-BE49-F238E27FC236}">
-                <a16:creationId xmlns:a16="http://schemas.microsoft.com/office/drawing/2014/main" id="{AB668E32-C947-4D96-84EA-E5084EA76F85}"/>
+                <a16:creationId xmlns:a16="http://schemas.microsoft.com/office/drawing/2014/main" id="{01E8BF56-410D-4FA6-91B1-F77183C38899}"/>
               </a:ext>
             </a:extLst>
           </p:cNvPr>
@@ -9996,7 +9996,7 @@
           <p:cNvPr id="13" name="Rectangle: Rounded Corners 12">
             <a:extLst>
               <a:ext uri="{FF2B5EF4-FFF2-40B4-BE49-F238E27FC236}">
-                <a16:creationId xmlns:a16="http://schemas.microsoft.com/office/drawing/2014/main" id="{A921DC83-5BBC-46BC-8DAB-5A1BF1A83103}"/>
+                <a16:creationId xmlns:a16="http://schemas.microsoft.com/office/drawing/2014/main" id="{C5BE4D60-39EC-495A-8DBC-CA36E7E9D2EB}"/>
               </a:ext>
             </a:extLst>
           </p:cNvPr>
@@ -10031,7 +10031,7 @@
           <p:cNvPr id="14" name="Rectangle 13">
             <a:extLst>
               <a:ext uri="{FF2B5EF4-FFF2-40B4-BE49-F238E27FC236}">
-                <a16:creationId xmlns:a16="http://schemas.microsoft.com/office/drawing/2014/main" id="{8E502610-48FA-4BBC-8E24-B3D3558C06AB}"/>
+                <a16:creationId xmlns:a16="http://schemas.microsoft.com/office/drawing/2014/main" id="{7033613D-F9E6-432B-A597-988CD608A354}"/>
               </a:ext>
             </a:extLst>
           </p:cNvPr>
@@ -10093,7 +10093,7 @@
           <p:cNvPr id="15" name="Oval 14">
             <a:extLst>
               <a:ext uri="{FF2B5EF4-FFF2-40B4-BE49-F238E27FC236}">
-                <a16:creationId xmlns:a16="http://schemas.microsoft.com/office/drawing/2014/main" id="{5BA75019-22DF-4EE1-89BD-B572E172C03C}"/>
+                <a16:creationId xmlns:a16="http://schemas.microsoft.com/office/drawing/2014/main" id="{6C5E20D3-8454-405E-99D5-848D738B293D}"/>
               </a:ext>
             </a:extLst>
           </p:cNvPr>
@@ -10124,7 +10124,7 @@
           <p:cNvPr id="16" name="Rectangle 15">
             <a:extLst>
               <a:ext uri="{FF2B5EF4-FFF2-40B4-BE49-F238E27FC236}">
-                <a16:creationId xmlns:a16="http://schemas.microsoft.com/office/drawing/2014/main" id="{087DA251-3878-4729-859D-E1819A1180F5}"/>
+                <a16:creationId xmlns:a16="http://schemas.microsoft.com/office/drawing/2014/main" id="{B7AC7035-E656-460F-9C1B-7E6ABE7039C9}"/>
               </a:ext>
             </a:extLst>
           </p:cNvPr>
@@ -10186,7 +10186,7 @@
           <p:cNvPr id="17" name="Rectangle: Rounded Corners 16">
             <a:extLst>
               <a:ext uri="{FF2B5EF4-FFF2-40B4-BE49-F238E27FC236}">
-                <a16:creationId xmlns:a16="http://schemas.microsoft.com/office/drawing/2014/main" id="{E6A4AA7D-30DF-4CAC-9B6B-AE6A8693FFC1}"/>
+                <a16:creationId xmlns:a16="http://schemas.microsoft.com/office/drawing/2014/main" id="{D97F1837-1990-4DA9-BF1C-71079BB98643}"/>
               </a:ext>
             </a:extLst>
           </p:cNvPr>
@@ -10221,7 +10221,7 @@
           <p:cNvPr id="18" name="Rectangle 17">
             <a:extLst>
               <a:ext uri="{FF2B5EF4-FFF2-40B4-BE49-F238E27FC236}">
-                <a16:creationId xmlns:a16="http://schemas.microsoft.com/office/drawing/2014/main" id="{F9C2B21F-1207-4422-AA6C-4281174C75ED}"/>
+                <a16:creationId xmlns:a16="http://schemas.microsoft.com/office/drawing/2014/main" id="{B56F0D64-69D1-45FF-AA63-0480133C42DF}"/>
               </a:ext>
             </a:extLst>
           </p:cNvPr>
@@ -10283,7 +10283,7 @@
           <p:cNvPr id="19" name="Rectangle 18">
             <a:extLst>
               <a:ext uri="{FF2B5EF4-FFF2-40B4-BE49-F238E27FC236}">
-                <a16:creationId xmlns:a16="http://schemas.microsoft.com/office/drawing/2014/main" id="{2F57FE58-294A-4A1D-BDC8-3672196BFC35}"/>
+                <a16:creationId xmlns:a16="http://schemas.microsoft.com/office/drawing/2014/main" id="{6F82CD89-5425-4D29-BBFD-41557C153485}"/>
               </a:ext>
             </a:extLst>
           </p:cNvPr>
@@ -10314,7 +10314,7 @@
           <p:cNvPr id="20" name="Rectangle 19">
             <a:extLst>
               <a:ext uri="{FF2B5EF4-FFF2-40B4-BE49-F238E27FC236}">
-                <a16:creationId xmlns:a16="http://schemas.microsoft.com/office/drawing/2014/main" id="{D71EE1C8-483B-4491-B3A4-298594EA6892}"/>
+                <a16:creationId xmlns:a16="http://schemas.microsoft.com/office/drawing/2014/main" id="{89C875EE-72D3-47F8-8B7D-A2DAA70491C7}"/>
               </a:ext>
             </a:extLst>
           </p:cNvPr>
@@ -10376,7 +10376,7 @@
           <p:cNvPr id="21" name="Rectangle 20">
             <a:extLst>
               <a:ext uri="{FF2B5EF4-FFF2-40B4-BE49-F238E27FC236}">
-                <a16:creationId xmlns:a16="http://schemas.microsoft.com/office/drawing/2014/main" id="{EA4250B3-E3F8-472E-AC34-28B1C743120B}"/>
+                <a16:creationId xmlns:a16="http://schemas.microsoft.com/office/drawing/2014/main" id="{CA9D1746-E1B2-4F08-9ECE-594C979B2081}"/>
               </a:ext>
             </a:extLst>
           </p:cNvPr>
@@ -10436,7 +10436,7 @@
     </p:spTree>
     <p:extLst>
       <p:ext uri="{BB962C8B-B14F-4D97-AF65-F5344CB8AC3E}">
-        <p14:creationId xmlns:p14="http://schemas.microsoft.com/office/powerpoint/2010/main" val="1813067280"/>
+        <p14:creationId xmlns:p14="http://schemas.microsoft.com/office/powerpoint/2010/main" val="225251653"/>
       </p:ext>
     </p:extLst>
   </p:cSld>
@@ -10477,7 +10477,7 @@
             <a:hlinkClick r:id="rId3"/>
             <a:extLst>
               <a:ext uri="{FF2B5EF4-FFF2-40B4-BE49-F238E27FC236}">
-                <a16:creationId xmlns:a16="http://schemas.microsoft.com/office/drawing/2014/main" id="{F4017751-9031-4D0D-A54F-0C484AD2162E}"/>
+                <a16:creationId xmlns:a16="http://schemas.microsoft.com/office/drawing/2014/main" id="{F8610FDA-265B-420F-A479-A0487B51B076}"/>
               </a:ext>
             </a:extLst>
           </p:cNvPr>
@@ -10552,7 +10552,7 @@
             <a:hlinkClick r:id="rId4"/>
             <a:extLst>
               <a:ext uri="{FF2B5EF4-FFF2-40B4-BE49-F238E27FC236}">
-                <a16:creationId xmlns:a16="http://schemas.microsoft.com/office/drawing/2014/main" id="{33390E86-6CBC-463F-8C91-1554365DA257}"/>
+                <a16:creationId xmlns:a16="http://schemas.microsoft.com/office/drawing/2014/main" id="{E1DB85AE-FA56-475C-A9EF-D6EB0A5A3BA7}"/>
               </a:ext>
             </a:extLst>
           </p:cNvPr>
@@ -10626,7 +10626,7 @@
           <p:cNvPr id="3" name="Rectangle 2">
             <a:extLst>
               <a:ext uri="{FF2B5EF4-FFF2-40B4-BE49-F238E27FC236}">
-                <a16:creationId xmlns:a16="http://schemas.microsoft.com/office/drawing/2014/main" id="{9BB68474-712F-49D2-8A22-BB1C4C633575}"/>
+                <a16:creationId xmlns:a16="http://schemas.microsoft.com/office/drawing/2014/main" id="{E980F288-4736-4F48-800A-7848F5E98FE6}"/>
               </a:ext>
             </a:extLst>
           </p:cNvPr>
@@ -10688,7 +10688,7 @@
           <p:cNvPr id="4" name="Rectangle 3">
             <a:extLst>
               <a:ext uri="{FF2B5EF4-FFF2-40B4-BE49-F238E27FC236}">
-                <a16:creationId xmlns:a16="http://schemas.microsoft.com/office/drawing/2014/main" id="{6B3C6A32-D9FB-4057-9C37-74A8B25E003F}"/>
+                <a16:creationId xmlns:a16="http://schemas.microsoft.com/office/drawing/2014/main" id="{15DEE359-24B9-414F-B7CB-9BB8D6EA394D}"/>
               </a:ext>
             </a:extLst>
           </p:cNvPr>
@@ -10777,7 +10777,7 @@
           <p:cNvPr id="6" name="Rectangle: Rounded Corners 5">
             <a:extLst>
               <a:ext uri="{FF2B5EF4-FFF2-40B4-BE49-F238E27FC236}">
-                <a16:creationId xmlns:a16="http://schemas.microsoft.com/office/drawing/2014/main" id="{5A8B652F-4DB6-492B-8158-B892FBA88152}"/>
+                <a16:creationId xmlns:a16="http://schemas.microsoft.com/office/drawing/2014/main" id="{26113011-C42D-4ED5-BE8A-8993FDD58A98}"/>
               </a:ext>
             </a:extLst>
           </p:cNvPr>
@@ -10810,7 +10810,7 @@
           <p:cNvPr id="7" name="Oval 6">
             <a:extLst>
               <a:ext uri="{FF2B5EF4-FFF2-40B4-BE49-F238E27FC236}">
-                <a16:creationId xmlns:a16="http://schemas.microsoft.com/office/drawing/2014/main" id="{0F4F3CE7-AFC0-401E-8480-D4A25874FC90}"/>
+                <a16:creationId xmlns:a16="http://schemas.microsoft.com/office/drawing/2014/main" id="{263B55F6-7276-4F71-BCE3-E66A0C7DABDF}"/>
               </a:ext>
             </a:extLst>
           </p:cNvPr>
@@ -10841,7 +10841,7 @@
           <p:cNvPr id="8" name="Rectangle 7">
             <a:extLst>
               <a:ext uri="{FF2B5EF4-FFF2-40B4-BE49-F238E27FC236}">
-                <a16:creationId xmlns:a16="http://schemas.microsoft.com/office/drawing/2014/main" id="{EBA34DE4-B4CA-4771-8287-B7A21C29CDBD}"/>
+                <a16:creationId xmlns:a16="http://schemas.microsoft.com/office/drawing/2014/main" id="{5DADB939-D703-48A8-BF56-E6ABCF0D2E81}"/>
               </a:ext>
             </a:extLst>
           </p:cNvPr>
@@ -10903,7 +10903,7 @@
           <p:cNvPr id="9" name="Rectangle: Rounded Corners 8">
             <a:extLst>
               <a:ext uri="{FF2B5EF4-FFF2-40B4-BE49-F238E27FC236}">
-                <a16:creationId xmlns:a16="http://schemas.microsoft.com/office/drawing/2014/main" id="{D5B09EB2-8B6E-4575-BA1B-FB09B817D87B}"/>
+                <a16:creationId xmlns:a16="http://schemas.microsoft.com/office/drawing/2014/main" id="{4F28233E-F56F-4CC3-B1A0-E0E3F7723552}"/>
               </a:ext>
             </a:extLst>
           </p:cNvPr>
@@ -10938,7 +10938,7 @@
           <p:cNvPr id="10" name="Rectangle 9">
             <a:extLst>
               <a:ext uri="{FF2B5EF4-FFF2-40B4-BE49-F238E27FC236}">
-                <a16:creationId xmlns:a16="http://schemas.microsoft.com/office/drawing/2014/main" id="{0A003D06-5AF4-4865-99B1-C26DEEEF7AC1}"/>
+                <a16:creationId xmlns:a16="http://schemas.microsoft.com/office/drawing/2014/main" id="{D2057439-06B3-4B16-99F5-0BC8800317D6}"/>
               </a:ext>
             </a:extLst>
           </p:cNvPr>
@@ -11000,7 +11000,7 @@
           <p:cNvPr id="11" name="Oval 10">
             <a:extLst>
               <a:ext uri="{FF2B5EF4-FFF2-40B4-BE49-F238E27FC236}">
-                <a16:creationId xmlns:a16="http://schemas.microsoft.com/office/drawing/2014/main" id="{21D13BAD-67C8-404D-8E33-B5CEB5B677B3}"/>
+                <a16:creationId xmlns:a16="http://schemas.microsoft.com/office/drawing/2014/main" id="{80305FAE-47BB-4A4F-A9D5-1DF804B68F07}"/>
               </a:ext>
             </a:extLst>
           </p:cNvPr>
@@ -11031,7 +11031,7 @@
           <p:cNvPr id="12" name="Rectangle 11">
             <a:extLst>
               <a:ext uri="{FF2B5EF4-FFF2-40B4-BE49-F238E27FC236}">
-                <a16:creationId xmlns:a16="http://schemas.microsoft.com/office/drawing/2014/main" id="{0FF48764-D93B-4431-99F5-9C833684D109}"/>
+                <a16:creationId xmlns:a16="http://schemas.microsoft.com/office/drawing/2014/main" id="{DD32F45F-F2E9-4EEA-9EBF-05FA1C1A5460}"/>
               </a:ext>
             </a:extLst>
           </p:cNvPr>
@@ -11093,7 +11093,7 @@
           <p:cNvPr id="13" name="Rectangle: Rounded Corners 12">
             <a:extLst>
               <a:ext uri="{FF2B5EF4-FFF2-40B4-BE49-F238E27FC236}">
-                <a16:creationId xmlns:a16="http://schemas.microsoft.com/office/drawing/2014/main" id="{73A58167-D111-4CB0-A663-9CCE6C7E228C}"/>
+                <a16:creationId xmlns:a16="http://schemas.microsoft.com/office/drawing/2014/main" id="{813739C1-E22D-40EE-9914-119FC8281B5A}"/>
               </a:ext>
             </a:extLst>
           </p:cNvPr>
@@ -11128,7 +11128,7 @@
           <p:cNvPr id="14" name="Rectangle 13">
             <a:extLst>
               <a:ext uri="{FF2B5EF4-FFF2-40B4-BE49-F238E27FC236}">
-                <a16:creationId xmlns:a16="http://schemas.microsoft.com/office/drawing/2014/main" id="{2F89CA1A-5F9C-4748-8A12-82D7ACA9DB5C}"/>
+                <a16:creationId xmlns:a16="http://schemas.microsoft.com/office/drawing/2014/main" id="{177C5637-7C6C-40D1-82EB-6BF01FDDB5B1}"/>
               </a:ext>
             </a:extLst>
           </p:cNvPr>
@@ -11190,7 +11190,7 @@
           <p:cNvPr id="15" name="Oval 14">
             <a:extLst>
               <a:ext uri="{FF2B5EF4-FFF2-40B4-BE49-F238E27FC236}">
-                <a16:creationId xmlns:a16="http://schemas.microsoft.com/office/drawing/2014/main" id="{EC2D2483-D963-4896-BA03-F0D5181F4C56}"/>
+                <a16:creationId xmlns:a16="http://schemas.microsoft.com/office/drawing/2014/main" id="{A4B8387D-816C-48C8-8EE3-6ED175815424}"/>
               </a:ext>
             </a:extLst>
           </p:cNvPr>
@@ -11221,7 +11221,7 @@
           <p:cNvPr id="16" name="Rectangle 15">
             <a:extLst>
               <a:ext uri="{FF2B5EF4-FFF2-40B4-BE49-F238E27FC236}">
-                <a16:creationId xmlns:a16="http://schemas.microsoft.com/office/drawing/2014/main" id="{BC6252A6-50E8-4973-A2AC-28242D2B5C48}"/>
+                <a16:creationId xmlns:a16="http://schemas.microsoft.com/office/drawing/2014/main" id="{734C8210-B1FB-48CE-9964-86CAA4C3C741}"/>
               </a:ext>
             </a:extLst>
           </p:cNvPr>
@@ -11283,7 +11283,7 @@
           <p:cNvPr id="17" name="Rectangle: Rounded Corners 16">
             <a:extLst>
               <a:ext uri="{FF2B5EF4-FFF2-40B4-BE49-F238E27FC236}">
-                <a16:creationId xmlns:a16="http://schemas.microsoft.com/office/drawing/2014/main" id="{C9F6E139-1684-4EDE-8C4F-EC44712CC83A}"/>
+                <a16:creationId xmlns:a16="http://schemas.microsoft.com/office/drawing/2014/main" id="{6F05D3F0-9D04-4550-BF78-C75ADD05FD60}"/>
               </a:ext>
             </a:extLst>
           </p:cNvPr>
@@ -11318,7 +11318,7 @@
           <p:cNvPr id="18" name="Rectangle 17">
             <a:extLst>
               <a:ext uri="{FF2B5EF4-FFF2-40B4-BE49-F238E27FC236}">
-                <a16:creationId xmlns:a16="http://schemas.microsoft.com/office/drawing/2014/main" id="{7B50C306-D2FA-4440-8B89-524021E59B4E}"/>
+                <a16:creationId xmlns:a16="http://schemas.microsoft.com/office/drawing/2014/main" id="{D6B2E0D9-F4E4-49FD-81B2-49B6FB9E8661}"/>
               </a:ext>
             </a:extLst>
           </p:cNvPr>
@@ -11380,7 +11380,7 @@
           <p:cNvPr id="19" name="Rectangle 18">
             <a:extLst>
               <a:ext uri="{FF2B5EF4-FFF2-40B4-BE49-F238E27FC236}">
-                <a16:creationId xmlns:a16="http://schemas.microsoft.com/office/drawing/2014/main" id="{E678A96F-D572-4D5A-85F7-083A32E9712A}"/>
+                <a16:creationId xmlns:a16="http://schemas.microsoft.com/office/drawing/2014/main" id="{9039CA7E-DD65-4459-A4D4-9959CE8A4413}"/>
               </a:ext>
             </a:extLst>
           </p:cNvPr>
@@ -11411,7 +11411,7 @@
           <p:cNvPr id="20" name="Rectangle 19">
             <a:extLst>
               <a:ext uri="{FF2B5EF4-FFF2-40B4-BE49-F238E27FC236}">
-                <a16:creationId xmlns:a16="http://schemas.microsoft.com/office/drawing/2014/main" id="{A5DEB390-FC17-4CFE-AA2B-3BF6352D88E5}"/>
+                <a16:creationId xmlns:a16="http://schemas.microsoft.com/office/drawing/2014/main" id="{2C73DC48-9BA3-4B5A-9CD0-5A153467A6B3}"/>
               </a:ext>
             </a:extLst>
           </p:cNvPr>
@@ -11473,7 +11473,7 @@
           <p:cNvPr id="21" name="Rectangle 20">
             <a:extLst>
               <a:ext uri="{FF2B5EF4-FFF2-40B4-BE49-F238E27FC236}">
-                <a16:creationId xmlns:a16="http://schemas.microsoft.com/office/drawing/2014/main" id="{ABB23E0F-CD23-4DFD-A5EA-5AA896AEC5EE}"/>
+                <a16:creationId xmlns:a16="http://schemas.microsoft.com/office/drawing/2014/main" id="{1A6AA2B2-FFE2-4D6D-8C99-B369C6D052E7}"/>
               </a:ext>
             </a:extLst>
           </p:cNvPr>
@@ -11533,7 +11533,7 @@
     </p:spTree>
     <p:extLst>
       <p:ext uri="{BB962C8B-B14F-4D97-AF65-F5344CB8AC3E}">
-        <p14:creationId xmlns:p14="http://schemas.microsoft.com/office/powerpoint/2010/main" val="1692016538"/>
+        <p14:creationId xmlns:p14="http://schemas.microsoft.com/office/powerpoint/2010/main" val="77840381"/>
       </p:ext>
     </p:extLst>
   </p:cSld>
@@ -11574,7 +11574,7 @@
             <a:hlinkClick r:id="rId3"/>
             <a:extLst>
               <a:ext uri="{FF2B5EF4-FFF2-40B4-BE49-F238E27FC236}">
-                <a16:creationId xmlns:a16="http://schemas.microsoft.com/office/drawing/2014/main" id="{BFC1F2EC-4250-4314-9240-EB143A4DBDFF}"/>
+                <a16:creationId xmlns:a16="http://schemas.microsoft.com/office/drawing/2014/main" id="{BD95A840-AA3D-44F4-8A55-D154976ED589}"/>
               </a:ext>
             </a:extLst>
           </p:cNvPr>
@@ -11649,7 +11649,7 @@
             <a:hlinkClick r:id="rId4"/>
             <a:extLst>
               <a:ext uri="{FF2B5EF4-FFF2-40B4-BE49-F238E27FC236}">
-                <a16:creationId xmlns:a16="http://schemas.microsoft.com/office/drawing/2014/main" id="{F166CA96-81A4-461A-842E-EED7EB80729F}"/>
+                <a16:creationId xmlns:a16="http://schemas.microsoft.com/office/drawing/2014/main" id="{33100D7A-A2BA-4227-9839-0ECF353371B8}"/>
               </a:ext>
             </a:extLst>
           </p:cNvPr>
@@ -11723,7 +11723,7 @@
           <p:cNvPr id="3" name="Rectangle 2">
             <a:extLst>
               <a:ext uri="{FF2B5EF4-FFF2-40B4-BE49-F238E27FC236}">
-                <a16:creationId xmlns:a16="http://schemas.microsoft.com/office/drawing/2014/main" id="{CB2A0787-2912-4123-98FD-502FE935BE85}"/>
+                <a16:creationId xmlns:a16="http://schemas.microsoft.com/office/drawing/2014/main" id="{1721E1E8-3F80-4CE8-97D8-CFF0BB132821}"/>
               </a:ext>
             </a:extLst>
           </p:cNvPr>
@@ -11785,7 +11785,7 @@
           <p:cNvPr id="4" name="Rectangle 3">
             <a:extLst>
               <a:ext uri="{FF2B5EF4-FFF2-40B4-BE49-F238E27FC236}">
-                <a16:creationId xmlns:a16="http://schemas.microsoft.com/office/drawing/2014/main" id="{E7F3AFF3-D71D-41D3-BEE8-5534F0903CF0}"/>
+                <a16:creationId xmlns:a16="http://schemas.microsoft.com/office/drawing/2014/main" id="{775891CE-9398-4974-878E-55F433FBF8E6}"/>
               </a:ext>
             </a:extLst>
           </p:cNvPr>
@@ -11874,7 +11874,7 @@
           <p:cNvPr id="6" name="Rectangle: Rounded Corners 5">
             <a:extLst>
               <a:ext uri="{FF2B5EF4-FFF2-40B4-BE49-F238E27FC236}">
-                <a16:creationId xmlns:a16="http://schemas.microsoft.com/office/drawing/2014/main" id="{C1D8E55A-FF59-4499-99E0-365BD6E7AC5F}"/>
+                <a16:creationId xmlns:a16="http://schemas.microsoft.com/office/drawing/2014/main" id="{00DFF589-AF2F-4B21-BE86-9A2A5A29014C}"/>
               </a:ext>
             </a:extLst>
           </p:cNvPr>
@@ -11907,7 +11907,7 @@
           <p:cNvPr id="7" name="Oval 6">
             <a:extLst>
               <a:ext uri="{FF2B5EF4-FFF2-40B4-BE49-F238E27FC236}">
-                <a16:creationId xmlns:a16="http://schemas.microsoft.com/office/drawing/2014/main" id="{DC861761-8B76-434E-B4DD-C2AEE0527E0B}"/>
+                <a16:creationId xmlns:a16="http://schemas.microsoft.com/office/drawing/2014/main" id="{2EE03590-F123-46DE-A0C6-05A5F5918CFB}"/>
               </a:ext>
             </a:extLst>
           </p:cNvPr>
@@ -11938,7 +11938,7 @@
           <p:cNvPr id="8" name="Rectangle 7">
             <a:extLst>
               <a:ext uri="{FF2B5EF4-FFF2-40B4-BE49-F238E27FC236}">
-                <a16:creationId xmlns:a16="http://schemas.microsoft.com/office/drawing/2014/main" id="{264FD981-86F0-48EC-B4D9-57623F304F00}"/>
+                <a16:creationId xmlns:a16="http://schemas.microsoft.com/office/drawing/2014/main" id="{E7DB9654-C2A9-4DDA-9129-6ABCF6198B95}"/>
               </a:ext>
             </a:extLst>
           </p:cNvPr>
@@ -12000,7 +12000,7 @@
           <p:cNvPr id="9" name="Rectangle: Rounded Corners 8">
             <a:extLst>
               <a:ext uri="{FF2B5EF4-FFF2-40B4-BE49-F238E27FC236}">
-                <a16:creationId xmlns:a16="http://schemas.microsoft.com/office/drawing/2014/main" id="{747A679A-5344-4EAB-80D4-41CCF50ECA6E}"/>
+                <a16:creationId xmlns:a16="http://schemas.microsoft.com/office/drawing/2014/main" id="{E3D4A1D1-FB93-43B2-9F75-C9DB7ED5A334}"/>
               </a:ext>
             </a:extLst>
           </p:cNvPr>
@@ -12035,7 +12035,7 @@
           <p:cNvPr id="10" name="Rectangle 9">
             <a:extLst>
               <a:ext uri="{FF2B5EF4-FFF2-40B4-BE49-F238E27FC236}">
-                <a16:creationId xmlns:a16="http://schemas.microsoft.com/office/drawing/2014/main" id="{A4C974C3-C5C9-49C3-A967-E774AAD40D72}"/>
+                <a16:creationId xmlns:a16="http://schemas.microsoft.com/office/drawing/2014/main" id="{66F85469-9D0C-4DE1-BBAC-966244DA98B6}"/>
               </a:ext>
             </a:extLst>
           </p:cNvPr>
@@ -12097,7 +12097,7 @@
           <p:cNvPr id="11" name="Oval 10">
             <a:extLst>
               <a:ext uri="{FF2B5EF4-FFF2-40B4-BE49-F238E27FC236}">
-                <a16:creationId xmlns:a16="http://schemas.microsoft.com/office/drawing/2014/main" id="{C33E3336-33AB-46A9-8CBC-C22199CDA529}"/>
+                <a16:creationId xmlns:a16="http://schemas.microsoft.com/office/drawing/2014/main" id="{E4D349DE-6784-416B-BF42-C617A088F827}"/>
               </a:ext>
             </a:extLst>
           </p:cNvPr>
@@ -12128,7 +12128,7 @@
           <p:cNvPr id="12" name="Rectangle 11">
             <a:extLst>
               <a:ext uri="{FF2B5EF4-FFF2-40B4-BE49-F238E27FC236}">
-                <a16:creationId xmlns:a16="http://schemas.microsoft.com/office/drawing/2014/main" id="{657209CD-7603-4F61-9A72-565BB7F54420}"/>
+                <a16:creationId xmlns:a16="http://schemas.microsoft.com/office/drawing/2014/main" id="{2627C3B2-2E9F-488B-88EB-00D4EBEAB868}"/>
               </a:ext>
             </a:extLst>
           </p:cNvPr>
@@ -12190,7 +12190,7 @@
           <p:cNvPr id="13" name="Rectangle: Rounded Corners 12">
             <a:extLst>
               <a:ext uri="{FF2B5EF4-FFF2-40B4-BE49-F238E27FC236}">
-                <a16:creationId xmlns:a16="http://schemas.microsoft.com/office/drawing/2014/main" id="{890C577E-1FDB-41AB-B77D-767B3B54284D}"/>
+                <a16:creationId xmlns:a16="http://schemas.microsoft.com/office/drawing/2014/main" id="{8A8D41B5-C009-4D2B-AB90-A8BB4F25C3B8}"/>
               </a:ext>
             </a:extLst>
           </p:cNvPr>
@@ -12225,7 +12225,7 @@
           <p:cNvPr id="14" name="Rectangle 13">
             <a:extLst>
               <a:ext uri="{FF2B5EF4-FFF2-40B4-BE49-F238E27FC236}">
-                <a16:creationId xmlns:a16="http://schemas.microsoft.com/office/drawing/2014/main" id="{AD4393AF-942F-4C17-BA02-0A4A3D8E0E01}"/>
+                <a16:creationId xmlns:a16="http://schemas.microsoft.com/office/drawing/2014/main" id="{050E7759-279B-4F79-9B18-41CE50435F00}"/>
               </a:ext>
             </a:extLst>
           </p:cNvPr>
@@ -12287,7 +12287,7 @@
           <p:cNvPr id="15" name="Oval 14">
             <a:extLst>
               <a:ext uri="{FF2B5EF4-FFF2-40B4-BE49-F238E27FC236}">
-                <a16:creationId xmlns:a16="http://schemas.microsoft.com/office/drawing/2014/main" id="{93494F3B-DA78-4039-9046-8B6A0A94B821}"/>
+                <a16:creationId xmlns:a16="http://schemas.microsoft.com/office/drawing/2014/main" id="{0985FAB6-FF69-418F-8B0F-A032C741857A}"/>
               </a:ext>
             </a:extLst>
           </p:cNvPr>
@@ -12318,7 +12318,7 @@
           <p:cNvPr id="16" name="Rectangle 15">
             <a:extLst>
               <a:ext uri="{FF2B5EF4-FFF2-40B4-BE49-F238E27FC236}">
-                <a16:creationId xmlns:a16="http://schemas.microsoft.com/office/drawing/2014/main" id="{18E64C0C-2592-4722-AA6A-C9EECF9DFC5C}"/>
+                <a16:creationId xmlns:a16="http://schemas.microsoft.com/office/drawing/2014/main" id="{0B9BD606-0440-42AA-8F31-6DD50F37D946}"/>
               </a:ext>
             </a:extLst>
           </p:cNvPr>
@@ -12380,7 +12380,7 @@
           <p:cNvPr id="17" name="Rectangle: Rounded Corners 16">
             <a:extLst>
               <a:ext uri="{FF2B5EF4-FFF2-40B4-BE49-F238E27FC236}">
-                <a16:creationId xmlns:a16="http://schemas.microsoft.com/office/drawing/2014/main" id="{2421CE48-B85F-4903-855B-75C695D44F63}"/>
+                <a16:creationId xmlns:a16="http://schemas.microsoft.com/office/drawing/2014/main" id="{1A481D28-0394-4B3F-87BC-BED17AA5E0CF}"/>
               </a:ext>
             </a:extLst>
           </p:cNvPr>
@@ -12415,7 +12415,7 @@
           <p:cNvPr id="18" name="Rectangle 17">
             <a:extLst>
               <a:ext uri="{FF2B5EF4-FFF2-40B4-BE49-F238E27FC236}">
-                <a16:creationId xmlns:a16="http://schemas.microsoft.com/office/drawing/2014/main" id="{CCBE15C6-39C7-4F20-8AD4-9953DFD127D3}"/>
+                <a16:creationId xmlns:a16="http://schemas.microsoft.com/office/drawing/2014/main" id="{98226004-6143-4EED-A165-B61304A2EC53}"/>
               </a:ext>
             </a:extLst>
           </p:cNvPr>
@@ -12477,7 +12477,7 @@
           <p:cNvPr id="19" name="Rectangle 18">
             <a:extLst>
               <a:ext uri="{FF2B5EF4-FFF2-40B4-BE49-F238E27FC236}">
-                <a16:creationId xmlns:a16="http://schemas.microsoft.com/office/drawing/2014/main" id="{8FEB9E8C-3DC1-475A-9700-6C6830733DA7}"/>
+                <a16:creationId xmlns:a16="http://schemas.microsoft.com/office/drawing/2014/main" id="{AA77F701-8841-4354-B6D4-3DE369FAC462}"/>
               </a:ext>
             </a:extLst>
           </p:cNvPr>
@@ -12508,7 +12508,7 @@
           <p:cNvPr id="20" name="Rectangle 19">
             <a:extLst>
               <a:ext uri="{FF2B5EF4-FFF2-40B4-BE49-F238E27FC236}">
-                <a16:creationId xmlns:a16="http://schemas.microsoft.com/office/drawing/2014/main" id="{87BDBF13-4CBA-4E3A-A393-714511BD1633}"/>
+                <a16:creationId xmlns:a16="http://schemas.microsoft.com/office/drawing/2014/main" id="{CD970278-35A4-48D5-BB14-5884C29D6F39}"/>
               </a:ext>
             </a:extLst>
           </p:cNvPr>
@@ -12570,7 +12570,7 @@
           <p:cNvPr id="21" name="Rectangle 20">
             <a:extLst>
               <a:ext uri="{FF2B5EF4-FFF2-40B4-BE49-F238E27FC236}">
-                <a16:creationId xmlns:a16="http://schemas.microsoft.com/office/drawing/2014/main" id="{200B4DFD-2C9A-4FB8-A2E5-EC55424ECB36}"/>
+                <a16:creationId xmlns:a16="http://schemas.microsoft.com/office/drawing/2014/main" id="{CEFACB2F-252C-4034-BCD9-8B39EFE152BB}"/>
               </a:ext>
             </a:extLst>
           </p:cNvPr>
@@ -12630,7 +12630,7 @@
     </p:spTree>
     <p:extLst>
       <p:ext uri="{BB962C8B-B14F-4D97-AF65-F5344CB8AC3E}">
-        <p14:creationId xmlns:p14="http://schemas.microsoft.com/office/powerpoint/2010/main" val="1821183943"/>
+        <p14:creationId xmlns:p14="http://schemas.microsoft.com/office/powerpoint/2010/main" val="1067260268"/>
       </p:ext>
     </p:extLst>
   </p:cSld>
@@ -12671,7 +12671,7 @@
             <a:hlinkClick r:id="rId3"/>
             <a:extLst>
               <a:ext uri="{FF2B5EF4-FFF2-40B4-BE49-F238E27FC236}">
-                <a16:creationId xmlns:a16="http://schemas.microsoft.com/office/drawing/2014/main" id="{37A8C7FE-DD3B-4DB5-9FAB-787BE605FEC0}"/>
+                <a16:creationId xmlns:a16="http://schemas.microsoft.com/office/drawing/2014/main" id="{F224F522-C4C8-45AA-971E-CD374236C2BB}"/>
               </a:ext>
             </a:extLst>
           </p:cNvPr>
@@ -12746,7 +12746,7 @@
             <a:hlinkClick r:id="rId4"/>
             <a:extLst>
               <a:ext uri="{FF2B5EF4-FFF2-40B4-BE49-F238E27FC236}">
-                <a16:creationId xmlns:a16="http://schemas.microsoft.com/office/drawing/2014/main" id="{F91A5BE8-5D67-484E-9F57-FCAF6A715ACB}"/>
+                <a16:creationId xmlns:a16="http://schemas.microsoft.com/office/drawing/2014/main" id="{740C0EA2-F777-4795-959E-818732980380}"/>
               </a:ext>
             </a:extLst>
           </p:cNvPr>
@@ -12820,7 +12820,7 @@
           <p:cNvPr id="3" name="Rectangle 2">
             <a:extLst>
               <a:ext uri="{FF2B5EF4-FFF2-40B4-BE49-F238E27FC236}">
-                <a16:creationId xmlns:a16="http://schemas.microsoft.com/office/drawing/2014/main" id="{7FC4D5FB-6FF6-4707-96F4-D5E10C073549}"/>
+                <a16:creationId xmlns:a16="http://schemas.microsoft.com/office/drawing/2014/main" id="{F44D46A8-5BEB-4885-B491-17335C43019A}"/>
               </a:ext>
             </a:extLst>
           </p:cNvPr>
@@ -12882,7 +12882,7 @@
           <p:cNvPr id="4" name="Rectangle 3">
             <a:extLst>
               <a:ext uri="{FF2B5EF4-FFF2-40B4-BE49-F238E27FC236}">
-                <a16:creationId xmlns:a16="http://schemas.microsoft.com/office/drawing/2014/main" id="{E4200596-585C-4D1E-93C5-D901457AADEA}"/>
+                <a16:creationId xmlns:a16="http://schemas.microsoft.com/office/drawing/2014/main" id="{4FD4C62A-4B2C-4DD3-A526-30606668A27E}"/>
               </a:ext>
             </a:extLst>
           </p:cNvPr>
@@ -12971,7 +12971,7 @@
           <p:cNvPr id="6" name="Rectangle: Rounded Corners 5">
             <a:extLst>
               <a:ext uri="{FF2B5EF4-FFF2-40B4-BE49-F238E27FC236}">
-                <a16:creationId xmlns:a16="http://schemas.microsoft.com/office/drawing/2014/main" id="{B7B93B09-ECB3-4B16-82F3-468BE79F95F5}"/>
+                <a16:creationId xmlns:a16="http://schemas.microsoft.com/office/drawing/2014/main" id="{94EFA726-9C4D-4D77-A802-E5E839F7D8B9}"/>
               </a:ext>
             </a:extLst>
           </p:cNvPr>
@@ -13004,7 +13004,7 @@
           <p:cNvPr id="7" name="Rectangle 6">
             <a:extLst>
               <a:ext uri="{FF2B5EF4-FFF2-40B4-BE49-F238E27FC236}">
-                <a16:creationId xmlns:a16="http://schemas.microsoft.com/office/drawing/2014/main" id="{6BAC45D4-0F37-408C-95A4-F1B59B099D48}"/>
+                <a16:creationId xmlns:a16="http://schemas.microsoft.com/office/drawing/2014/main" id="{B3F2A17A-9C97-4282-8F5A-3DFDEA767830}"/>
               </a:ext>
             </a:extLst>
           </p:cNvPr>
@@ -13066,7 +13066,7 @@
           <p:cNvPr id="8" name="Rectangle 7">
             <a:extLst>
               <a:ext uri="{FF2B5EF4-FFF2-40B4-BE49-F238E27FC236}">
-                <a16:creationId xmlns:a16="http://schemas.microsoft.com/office/drawing/2014/main" id="{D6240FE8-827F-4F0C-A78D-7E743EBB747B}"/>
+                <a16:creationId xmlns:a16="http://schemas.microsoft.com/office/drawing/2014/main" id="{E524CA82-B4A7-475B-8CD5-6EA9D63B45B9}"/>
               </a:ext>
             </a:extLst>
           </p:cNvPr>
@@ -13128,7 +13128,7 @@
           <p:cNvPr id="9" name="Rectangle 8">
             <a:extLst>
               <a:ext uri="{FF2B5EF4-FFF2-40B4-BE49-F238E27FC236}">
-                <a16:creationId xmlns:a16="http://schemas.microsoft.com/office/drawing/2014/main" id="{AB86C431-7431-4003-9819-C9B28FA6D399}"/>
+                <a16:creationId xmlns:a16="http://schemas.microsoft.com/office/drawing/2014/main" id="{CD124E91-70AE-440F-A9D4-28FB9F3B29D0}"/>
               </a:ext>
             </a:extLst>
           </p:cNvPr>
@@ -13159,7 +13159,7 @@
           <p:cNvPr id="10" name="Rectangle 9">
             <a:extLst>
               <a:ext uri="{FF2B5EF4-FFF2-40B4-BE49-F238E27FC236}">
-                <a16:creationId xmlns:a16="http://schemas.microsoft.com/office/drawing/2014/main" id="{013A37E1-C286-4520-AC37-26CFC5D38E35}"/>
+                <a16:creationId xmlns:a16="http://schemas.microsoft.com/office/drawing/2014/main" id="{383E69ED-0D46-4B3B-92E5-D09928588BE0}"/>
               </a:ext>
             </a:extLst>
           </p:cNvPr>
@@ -13221,7 +13221,7 @@
           <p:cNvPr id="11" name="Rectangle 10">
             <a:extLst>
               <a:ext uri="{FF2B5EF4-FFF2-40B4-BE49-F238E27FC236}">
-                <a16:creationId xmlns:a16="http://schemas.microsoft.com/office/drawing/2014/main" id="{84788F21-35EB-43F6-8475-EB4DFF282FFE}"/>
+                <a16:creationId xmlns:a16="http://schemas.microsoft.com/office/drawing/2014/main" id="{4BE3F303-B92E-41C3-BB16-A9702F17FFB7}"/>
               </a:ext>
             </a:extLst>
           </p:cNvPr>
@@ -13283,7 +13283,7 @@
           <p:cNvPr id="12" name="Rectangle 11">
             <a:extLst>
               <a:ext uri="{FF2B5EF4-FFF2-40B4-BE49-F238E27FC236}">
-                <a16:creationId xmlns:a16="http://schemas.microsoft.com/office/drawing/2014/main" id="{85ED0063-DBA6-4533-BA49-584B7A86DD0C}"/>
+                <a16:creationId xmlns:a16="http://schemas.microsoft.com/office/drawing/2014/main" id="{1270E089-E9F3-426E-BC8D-7494876D2BBA}"/>
               </a:ext>
             </a:extLst>
           </p:cNvPr>
@@ -13314,7 +13314,7 @@
           <p:cNvPr id="13" name="Rectangle 12">
             <a:extLst>
               <a:ext uri="{FF2B5EF4-FFF2-40B4-BE49-F238E27FC236}">
-                <a16:creationId xmlns:a16="http://schemas.microsoft.com/office/drawing/2014/main" id="{62125295-3061-48EF-B654-381881C66413}"/>
+                <a16:creationId xmlns:a16="http://schemas.microsoft.com/office/drawing/2014/main" id="{2CD888CC-ACE8-40BB-988C-8BD0F327A231}"/>
               </a:ext>
             </a:extLst>
           </p:cNvPr>
@@ -13376,7 +13376,7 @@
           <p:cNvPr id="14" name="Rectangle 13">
             <a:extLst>
               <a:ext uri="{FF2B5EF4-FFF2-40B4-BE49-F238E27FC236}">
-                <a16:creationId xmlns:a16="http://schemas.microsoft.com/office/drawing/2014/main" id="{1FF958A9-DA6C-400E-BC5A-0874BB22DF66}"/>
+                <a16:creationId xmlns:a16="http://schemas.microsoft.com/office/drawing/2014/main" id="{8CF68CD2-9B94-4E4B-AB2D-ECD7DDF3B658}"/>
               </a:ext>
             </a:extLst>
           </p:cNvPr>
@@ -13438,7 +13438,7 @@
           <p:cNvPr id="15" name="Rectangle 14">
             <a:extLst>
               <a:ext uri="{FF2B5EF4-FFF2-40B4-BE49-F238E27FC236}">
-                <a16:creationId xmlns:a16="http://schemas.microsoft.com/office/drawing/2014/main" id="{753FBC7E-2CBC-4398-AD7F-8A37C3695987}"/>
+                <a16:creationId xmlns:a16="http://schemas.microsoft.com/office/drawing/2014/main" id="{5886395A-52FA-4022-BDF5-C87181695469}"/>
               </a:ext>
             </a:extLst>
           </p:cNvPr>
@@ -13469,7 +13469,7 @@
           <p:cNvPr id="16" name="Rectangle 15">
             <a:extLst>
               <a:ext uri="{FF2B5EF4-FFF2-40B4-BE49-F238E27FC236}">
-                <a16:creationId xmlns:a16="http://schemas.microsoft.com/office/drawing/2014/main" id="{741D5484-7FAB-4493-9179-8906DD0204FE}"/>
+                <a16:creationId xmlns:a16="http://schemas.microsoft.com/office/drawing/2014/main" id="{9A8C4970-4A43-4D98-90D2-CC0935E958AA}"/>
               </a:ext>
             </a:extLst>
           </p:cNvPr>
@@ -13531,7 +13531,7 @@
           <p:cNvPr id="17" name="Rectangle 16">
             <a:extLst>
               <a:ext uri="{FF2B5EF4-FFF2-40B4-BE49-F238E27FC236}">
-                <a16:creationId xmlns:a16="http://schemas.microsoft.com/office/drawing/2014/main" id="{0FBA89F6-811E-443B-8D41-BBE8183A92EB}"/>
+                <a16:creationId xmlns:a16="http://schemas.microsoft.com/office/drawing/2014/main" id="{91F2DD92-BF52-4A10-B399-A91F88EA8776}"/>
               </a:ext>
             </a:extLst>
           </p:cNvPr>
@@ -13593,7 +13593,7 @@
           <p:cNvPr id="18" name="Rectangle 17">
             <a:extLst>
               <a:ext uri="{FF2B5EF4-FFF2-40B4-BE49-F238E27FC236}">
-                <a16:creationId xmlns:a16="http://schemas.microsoft.com/office/drawing/2014/main" id="{F4224446-5812-4FDB-9F96-0D28B62A45BB}"/>
+                <a16:creationId xmlns:a16="http://schemas.microsoft.com/office/drawing/2014/main" id="{E451FD07-B46B-4B82-9958-2AF2D2188689}"/>
               </a:ext>
             </a:extLst>
           </p:cNvPr>
@@ -13624,7 +13624,7 @@
           <p:cNvPr id="19" name="Rectangle 18">
             <a:extLst>
               <a:ext uri="{FF2B5EF4-FFF2-40B4-BE49-F238E27FC236}">
-                <a16:creationId xmlns:a16="http://schemas.microsoft.com/office/drawing/2014/main" id="{DED400F7-4945-4079-95FF-0195DAF9E5DF}"/>
+                <a16:creationId xmlns:a16="http://schemas.microsoft.com/office/drawing/2014/main" id="{DF547ECF-53AB-4AAE-AA4C-0528C627BCF8}"/>
               </a:ext>
             </a:extLst>
           </p:cNvPr>
@@ -13686,7 +13686,7 @@
           <p:cNvPr id="20" name="Rectangle 19">
             <a:extLst>
               <a:ext uri="{FF2B5EF4-FFF2-40B4-BE49-F238E27FC236}">
-                <a16:creationId xmlns:a16="http://schemas.microsoft.com/office/drawing/2014/main" id="{ACA4F870-0365-4911-8492-EBCB3E2474BE}"/>
+                <a16:creationId xmlns:a16="http://schemas.microsoft.com/office/drawing/2014/main" id="{137A160E-E7B9-41CE-BC22-2B58D840F28A}"/>
               </a:ext>
             </a:extLst>
           </p:cNvPr>
@@ -13748,7 +13748,7 @@
           <p:cNvPr id="21" name="Rectangle 20">
             <a:extLst>
               <a:ext uri="{FF2B5EF4-FFF2-40B4-BE49-F238E27FC236}">
-                <a16:creationId xmlns:a16="http://schemas.microsoft.com/office/drawing/2014/main" id="{6F3A1689-3713-413A-9717-E805E0D52099}"/>
+                <a16:creationId xmlns:a16="http://schemas.microsoft.com/office/drawing/2014/main" id="{3B63CDCB-5850-4708-8EB0-6613ADF8DAF8}"/>
               </a:ext>
             </a:extLst>
           </p:cNvPr>
@@ -13779,7 +13779,7 @@
           <p:cNvPr id="22" name="Rectangle 21">
             <a:extLst>
               <a:ext uri="{FF2B5EF4-FFF2-40B4-BE49-F238E27FC236}">
-                <a16:creationId xmlns:a16="http://schemas.microsoft.com/office/drawing/2014/main" id="{C187F792-8D8E-4C02-B580-6CA2DD27179D}"/>
+                <a16:creationId xmlns:a16="http://schemas.microsoft.com/office/drawing/2014/main" id="{36FCA2A9-3B8D-4DD3-BAA7-D570ECF1B0FA}"/>
               </a:ext>
             </a:extLst>
           </p:cNvPr>
@@ -13841,7 +13841,7 @@
           <p:cNvPr id="23" name="Rectangle 22">
             <a:extLst>
               <a:ext uri="{FF2B5EF4-FFF2-40B4-BE49-F238E27FC236}">
-                <a16:creationId xmlns:a16="http://schemas.microsoft.com/office/drawing/2014/main" id="{C9AE05D6-3299-454E-AC18-22CF67B7C8C9}"/>
+                <a16:creationId xmlns:a16="http://schemas.microsoft.com/office/drawing/2014/main" id="{CA2E1D00-C7F5-464B-99BD-A77C30AECC87}"/>
               </a:ext>
             </a:extLst>
           </p:cNvPr>
@@ -13903,7 +13903,7 @@
           <p:cNvPr id="24" name="Rectangle 23">
             <a:extLst>
               <a:ext uri="{FF2B5EF4-FFF2-40B4-BE49-F238E27FC236}">
-                <a16:creationId xmlns:a16="http://schemas.microsoft.com/office/drawing/2014/main" id="{9D6186C8-C443-4C2B-A6F3-7516EDEFF5BB}"/>
+                <a16:creationId xmlns:a16="http://schemas.microsoft.com/office/drawing/2014/main" id="{A764333A-136F-4897-B269-13B43D6D2D43}"/>
               </a:ext>
             </a:extLst>
           </p:cNvPr>
@@ -13934,7 +13934,7 @@
           <p:cNvPr id="25" name="Rectangle 24">
             <a:extLst>
               <a:ext uri="{FF2B5EF4-FFF2-40B4-BE49-F238E27FC236}">
-                <a16:creationId xmlns:a16="http://schemas.microsoft.com/office/drawing/2014/main" id="{A129BAC4-F617-4589-A96E-D8D36DB24ED0}"/>
+                <a16:creationId xmlns:a16="http://schemas.microsoft.com/office/drawing/2014/main" id="{BC4A7B59-92A0-4A8A-A7C0-61D16ACECF81}"/>
               </a:ext>
             </a:extLst>
           </p:cNvPr>
@@ -13996,7 +13996,7 @@
           <p:cNvPr id="26" name="Rectangle 25">
             <a:extLst>
               <a:ext uri="{FF2B5EF4-FFF2-40B4-BE49-F238E27FC236}">
-                <a16:creationId xmlns:a16="http://schemas.microsoft.com/office/drawing/2014/main" id="{2927E41B-8489-4A07-9AC2-A99BBD9911BA}"/>
+                <a16:creationId xmlns:a16="http://schemas.microsoft.com/office/drawing/2014/main" id="{0BBCEFFD-B345-4847-97E8-7FA58D40E5CC}"/>
               </a:ext>
             </a:extLst>
           </p:cNvPr>
@@ -14058,7 +14058,7 @@
           <p:cNvPr id="27" name="Rectangle 26">
             <a:extLst>
               <a:ext uri="{FF2B5EF4-FFF2-40B4-BE49-F238E27FC236}">
-                <a16:creationId xmlns:a16="http://schemas.microsoft.com/office/drawing/2014/main" id="{43A1F776-4476-4F85-A7FE-8104538EFFFE}"/>
+                <a16:creationId xmlns:a16="http://schemas.microsoft.com/office/drawing/2014/main" id="{B32A58C4-BF3E-4D66-B745-7D9CA5001395}"/>
               </a:ext>
             </a:extLst>
           </p:cNvPr>
@@ -14120,7 +14120,7 @@
           <p:cNvPr id="28" name="Rectangle 27">
             <a:extLst>
               <a:ext uri="{FF2B5EF4-FFF2-40B4-BE49-F238E27FC236}">
-                <a16:creationId xmlns:a16="http://schemas.microsoft.com/office/drawing/2014/main" id="{F0052B75-C522-47B1-B741-6E6829006F95}"/>
+                <a16:creationId xmlns:a16="http://schemas.microsoft.com/office/drawing/2014/main" id="{1347A8BA-759A-4FC0-BD66-E8FE0C94B938}"/>
               </a:ext>
             </a:extLst>
           </p:cNvPr>
@@ -14182,7 +14182,7 @@
           <p:cNvPr id="29" name="Rectangle 28">
             <a:extLst>
               <a:ext uri="{FF2B5EF4-FFF2-40B4-BE49-F238E27FC236}">
-                <a16:creationId xmlns:a16="http://schemas.microsoft.com/office/drawing/2014/main" id="{E40C8895-3CA2-46AE-A69D-2F894CEA8018}"/>
+                <a16:creationId xmlns:a16="http://schemas.microsoft.com/office/drawing/2014/main" id="{50DC9368-C921-4B8F-8627-0E3D3864500D}"/>
               </a:ext>
             </a:extLst>
           </p:cNvPr>
@@ -14213,7 +14213,7 @@
           <p:cNvPr id="30" name="Rectangle 29">
             <a:extLst>
               <a:ext uri="{FF2B5EF4-FFF2-40B4-BE49-F238E27FC236}">
-                <a16:creationId xmlns:a16="http://schemas.microsoft.com/office/drawing/2014/main" id="{8EA3EDE0-0BDC-4111-8FA0-E497FA37A262}"/>
+                <a16:creationId xmlns:a16="http://schemas.microsoft.com/office/drawing/2014/main" id="{79884A95-4C44-424A-8247-7D2939D23D12}"/>
               </a:ext>
             </a:extLst>
           </p:cNvPr>
@@ -14275,7 +14275,7 @@
           <p:cNvPr id="31" name="Rectangle 30">
             <a:extLst>
               <a:ext uri="{FF2B5EF4-FFF2-40B4-BE49-F238E27FC236}">
-                <a16:creationId xmlns:a16="http://schemas.microsoft.com/office/drawing/2014/main" id="{94EFFD28-CCB6-46E0-860B-A652D9C08225}"/>
+                <a16:creationId xmlns:a16="http://schemas.microsoft.com/office/drawing/2014/main" id="{B79FD8C7-1DC5-4406-8B9F-777F2236163B}"/>
               </a:ext>
             </a:extLst>
           </p:cNvPr>
@@ -14335,7 +14335,7 @@
     </p:spTree>
     <p:extLst>
       <p:ext uri="{BB962C8B-B14F-4D97-AF65-F5344CB8AC3E}">
-        <p14:creationId xmlns:p14="http://schemas.microsoft.com/office/powerpoint/2010/main" val="2100262121"/>
+        <p14:creationId xmlns:p14="http://schemas.microsoft.com/office/powerpoint/2010/main" val="1233279204"/>
       </p:ext>
     </p:extLst>
   </p:cSld>
@@ -14376,7 +14376,7 @@
             <a:hlinkClick r:id="rId3"/>
             <a:extLst>
               <a:ext uri="{FF2B5EF4-FFF2-40B4-BE49-F238E27FC236}">
-                <a16:creationId xmlns:a16="http://schemas.microsoft.com/office/drawing/2014/main" id="{E21DA6D9-E769-47BD-9083-DECA5F3AE7D4}"/>
+                <a16:creationId xmlns:a16="http://schemas.microsoft.com/office/drawing/2014/main" id="{8897D838-09FF-498C-BFDE-1B42537152A4}"/>
               </a:ext>
             </a:extLst>
           </p:cNvPr>
@@ -14451,7 +14451,7 @@
             <a:hlinkClick r:id="rId4"/>
             <a:extLst>
               <a:ext uri="{FF2B5EF4-FFF2-40B4-BE49-F238E27FC236}">
-                <a16:creationId xmlns:a16="http://schemas.microsoft.com/office/drawing/2014/main" id="{CC7C10AB-422F-464A-A454-CA6115D3749F}"/>
+                <a16:creationId xmlns:a16="http://schemas.microsoft.com/office/drawing/2014/main" id="{FACDF09A-CAD0-408B-9926-EF76EAA190E7}"/>
               </a:ext>
             </a:extLst>
           </p:cNvPr>
@@ -14525,7 +14525,7 @@
           <p:cNvPr id="3" name="Rectangle 2">
             <a:extLst>
               <a:ext uri="{FF2B5EF4-FFF2-40B4-BE49-F238E27FC236}">
-                <a16:creationId xmlns:a16="http://schemas.microsoft.com/office/drawing/2014/main" id="{88403451-C193-48C0-9A49-B0B6C76C9977}"/>
+                <a16:creationId xmlns:a16="http://schemas.microsoft.com/office/drawing/2014/main" id="{2F884268-428C-48D3-A087-6C561602B34A}"/>
               </a:ext>
             </a:extLst>
           </p:cNvPr>
@@ -14587,7 +14587,7 @@
           <p:cNvPr id="4" name="Rectangle 3">
             <a:extLst>
               <a:ext uri="{FF2B5EF4-FFF2-40B4-BE49-F238E27FC236}">
-                <a16:creationId xmlns:a16="http://schemas.microsoft.com/office/drawing/2014/main" id="{36B5108A-BE9D-4914-9D53-E9AD4E175A5D}"/>
+                <a16:creationId xmlns:a16="http://schemas.microsoft.com/office/drawing/2014/main" id="{35FFEDCF-E3E6-4B77-A04E-B0F6437844EE}"/>
               </a:ext>
             </a:extLst>
           </p:cNvPr>
@@ -14649,7 +14649,7 @@
           <p:cNvPr id="5" name="Rectangle 4">
             <a:extLst>
               <a:ext uri="{FF2B5EF4-FFF2-40B4-BE49-F238E27FC236}">
-                <a16:creationId xmlns:a16="http://schemas.microsoft.com/office/drawing/2014/main" id="{7E44C40A-D55B-405F-9042-5AA887241929}"/>
+                <a16:creationId xmlns:a16="http://schemas.microsoft.com/office/drawing/2014/main" id="{964EE941-F6EE-4A2E-87E6-B9FBF5AEEA2B}"/>
               </a:ext>
             </a:extLst>
           </p:cNvPr>
@@ -14711,7 +14711,7 @@
           <p:cNvPr id="6" name="Oval 5">
             <a:extLst>
               <a:ext uri="{FF2B5EF4-FFF2-40B4-BE49-F238E27FC236}">
-                <a16:creationId xmlns:a16="http://schemas.microsoft.com/office/drawing/2014/main" id="{DC626D73-0D86-4FCC-9C64-5533AC7432B2}"/>
+                <a16:creationId xmlns:a16="http://schemas.microsoft.com/office/drawing/2014/main" id="{B9EC9822-5379-4F74-B031-A35B4FBD3CCB}"/>
               </a:ext>
             </a:extLst>
           </p:cNvPr>
@@ -14742,7 +14742,7 @@
           <p:cNvPr id="7" name="Rectangle 6">
             <a:extLst>
               <a:ext uri="{FF2B5EF4-FFF2-40B4-BE49-F238E27FC236}">
-                <a16:creationId xmlns:a16="http://schemas.microsoft.com/office/drawing/2014/main" id="{1C47F356-C82D-4725-8B6E-191195C35078}"/>
+                <a16:creationId xmlns:a16="http://schemas.microsoft.com/office/drawing/2014/main" id="{9F643597-5D0C-467A-B9AE-6A0FAE597E06}"/>
               </a:ext>
             </a:extLst>
           </p:cNvPr>
@@ -14804,7 +14804,7 @@
           <p:cNvPr id="8" name="Rectangle 7">
             <a:extLst>
               <a:ext uri="{FF2B5EF4-FFF2-40B4-BE49-F238E27FC236}">
-                <a16:creationId xmlns:a16="http://schemas.microsoft.com/office/drawing/2014/main" id="{464E822D-E3E7-4690-B995-BEEFD670D239}"/>
+                <a16:creationId xmlns:a16="http://schemas.microsoft.com/office/drawing/2014/main" id="{9BC7E429-C0B2-47C2-838D-04529DC45B64}"/>
               </a:ext>
             </a:extLst>
           </p:cNvPr>
@@ -14835,7 +14835,7 @@
           <p:cNvPr id="9" name="Rectangle 8">
             <a:extLst>
               <a:ext uri="{FF2B5EF4-FFF2-40B4-BE49-F238E27FC236}">
-                <a16:creationId xmlns:a16="http://schemas.microsoft.com/office/drawing/2014/main" id="{D35F0140-AA61-4DB6-BEED-DAF9CB429527}"/>
+                <a16:creationId xmlns:a16="http://schemas.microsoft.com/office/drawing/2014/main" id="{0F18E4FB-AB36-486A-BFCC-E62DE4762AF5}"/>
               </a:ext>
             </a:extLst>
           </p:cNvPr>
@@ -14897,7 +14897,7 @@
           <p:cNvPr id="10" name="Oval 9">
             <a:extLst>
               <a:ext uri="{FF2B5EF4-FFF2-40B4-BE49-F238E27FC236}">
-                <a16:creationId xmlns:a16="http://schemas.microsoft.com/office/drawing/2014/main" id="{8DBFA306-8D6A-4080-A314-B3439F0C6F8E}"/>
+                <a16:creationId xmlns:a16="http://schemas.microsoft.com/office/drawing/2014/main" id="{9F3F4737-B5DF-4D99-BACF-F184CC1129E0}"/>
               </a:ext>
             </a:extLst>
           </p:cNvPr>
@@ -14928,7 +14928,7 @@
           <p:cNvPr id="11" name="Rectangle 10">
             <a:extLst>
               <a:ext uri="{FF2B5EF4-FFF2-40B4-BE49-F238E27FC236}">
-                <a16:creationId xmlns:a16="http://schemas.microsoft.com/office/drawing/2014/main" id="{45C58831-E675-4540-832E-5CFFC307C7D5}"/>
+                <a16:creationId xmlns:a16="http://schemas.microsoft.com/office/drawing/2014/main" id="{901F370A-556F-43B9-A9A4-D2A7F279073F}"/>
               </a:ext>
             </a:extLst>
           </p:cNvPr>
@@ -14990,7 +14990,7 @@
           <p:cNvPr id="12" name="Rectangle 11">
             <a:extLst>
               <a:ext uri="{FF2B5EF4-FFF2-40B4-BE49-F238E27FC236}">
-                <a16:creationId xmlns:a16="http://schemas.microsoft.com/office/drawing/2014/main" id="{A53E921C-64BE-455B-BBA0-FF461CDA9ADE}"/>
+                <a16:creationId xmlns:a16="http://schemas.microsoft.com/office/drawing/2014/main" id="{83730FFE-CF75-4AB0-B06E-20D851E72C08}"/>
               </a:ext>
             </a:extLst>
           </p:cNvPr>
@@ -15021,7 +15021,7 @@
           <p:cNvPr id="13" name="Rectangle 12">
             <a:extLst>
               <a:ext uri="{FF2B5EF4-FFF2-40B4-BE49-F238E27FC236}">
-                <a16:creationId xmlns:a16="http://schemas.microsoft.com/office/drawing/2014/main" id="{9D15FD93-15C5-4269-BC2C-D3BD4954AA68}"/>
+                <a16:creationId xmlns:a16="http://schemas.microsoft.com/office/drawing/2014/main" id="{970A78A5-13B1-4F24-AE0A-64DBB977661F}"/>
               </a:ext>
             </a:extLst>
           </p:cNvPr>
@@ -15083,7 +15083,7 @@
           <p:cNvPr id="14" name="Oval 13">
             <a:extLst>
               <a:ext uri="{FF2B5EF4-FFF2-40B4-BE49-F238E27FC236}">
-                <a16:creationId xmlns:a16="http://schemas.microsoft.com/office/drawing/2014/main" id="{7E02A5C4-D227-4297-846C-9E7BFBD45893}"/>
+                <a16:creationId xmlns:a16="http://schemas.microsoft.com/office/drawing/2014/main" id="{EE8DD207-2A1D-4E97-9CA2-D508C4BA4C40}"/>
               </a:ext>
             </a:extLst>
           </p:cNvPr>
@@ -15114,7 +15114,7 @@
           <p:cNvPr id="15" name="Rectangle 14">
             <a:extLst>
               <a:ext uri="{FF2B5EF4-FFF2-40B4-BE49-F238E27FC236}">
-                <a16:creationId xmlns:a16="http://schemas.microsoft.com/office/drawing/2014/main" id="{D518BBCD-4651-438F-8C09-7F7F2D297E34}"/>
+                <a16:creationId xmlns:a16="http://schemas.microsoft.com/office/drawing/2014/main" id="{49DA2B4E-A647-44E7-8CDF-EE315B1E515D}"/>
               </a:ext>
             </a:extLst>
           </p:cNvPr>
@@ -15176,7 +15176,7 @@
           <p:cNvPr id="16" name="Rectangle 15">
             <a:extLst>
               <a:ext uri="{FF2B5EF4-FFF2-40B4-BE49-F238E27FC236}">
-                <a16:creationId xmlns:a16="http://schemas.microsoft.com/office/drawing/2014/main" id="{3254B77E-C447-4D45-A06C-B2EC56D2CFCB}"/>
+                <a16:creationId xmlns:a16="http://schemas.microsoft.com/office/drawing/2014/main" id="{44EA6B80-8895-4684-9654-B69386C23FF5}"/>
               </a:ext>
             </a:extLst>
           </p:cNvPr>
@@ -15207,7 +15207,7 @@
           <p:cNvPr id="17" name="Rectangle 16">
             <a:extLst>
               <a:ext uri="{FF2B5EF4-FFF2-40B4-BE49-F238E27FC236}">
-                <a16:creationId xmlns:a16="http://schemas.microsoft.com/office/drawing/2014/main" id="{4582BF9D-9E96-4EB4-B0C0-9B54FF87F1CF}"/>
+                <a16:creationId xmlns:a16="http://schemas.microsoft.com/office/drawing/2014/main" id="{FE2456B0-19E2-421A-BB4A-AA1B654B1B39}"/>
               </a:ext>
             </a:extLst>
           </p:cNvPr>
@@ -15269,7 +15269,7 @@
           <p:cNvPr id="18" name="Oval 17">
             <a:extLst>
               <a:ext uri="{FF2B5EF4-FFF2-40B4-BE49-F238E27FC236}">
-                <a16:creationId xmlns:a16="http://schemas.microsoft.com/office/drawing/2014/main" id="{50EA1F11-EF50-4D0F-BF37-34B61E18C620}"/>
+                <a16:creationId xmlns:a16="http://schemas.microsoft.com/office/drawing/2014/main" id="{DA61A27C-4055-4B6A-AAAC-EE1E983784B1}"/>
               </a:ext>
             </a:extLst>
           </p:cNvPr>
@@ -15300,7 +15300,7 @@
           <p:cNvPr id="19" name="Rectangle 18">
             <a:extLst>
               <a:ext uri="{FF2B5EF4-FFF2-40B4-BE49-F238E27FC236}">
-                <a16:creationId xmlns:a16="http://schemas.microsoft.com/office/drawing/2014/main" id="{E4B3A1B5-E3FB-463E-9DF2-F70D309DA961}"/>
+                <a16:creationId xmlns:a16="http://schemas.microsoft.com/office/drawing/2014/main" id="{A4049C9A-09F3-4B26-98B8-D23D77EF2BC3}"/>
               </a:ext>
             </a:extLst>
           </p:cNvPr>
@@ -15362,7 +15362,7 @@
           <p:cNvPr id="20" name="Rectangle 19">
             <a:extLst>
               <a:ext uri="{FF2B5EF4-FFF2-40B4-BE49-F238E27FC236}">
-                <a16:creationId xmlns:a16="http://schemas.microsoft.com/office/drawing/2014/main" id="{53A77983-2454-49D7-A488-C03032E98965}"/>
+                <a16:creationId xmlns:a16="http://schemas.microsoft.com/office/drawing/2014/main" id="{FBE9215A-F0CA-4E9D-8E63-4A579C639523}"/>
               </a:ext>
             </a:extLst>
           </p:cNvPr>
@@ -15393,7 +15393,7 @@
           <p:cNvPr id="21" name="Rectangle 20">
             <a:extLst>
               <a:ext uri="{FF2B5EF4-FFF2-40B4-BE49-F238E27FC236}">
-                <a16:creationId xmlns:a16="http://schemas.microsoft.com/office/drawing/2014/main" id="{9D59358E-8B61-4332-8012-ED21B580697A}"/>
+                <a16:creationId xmlns:a16="http://schemas.microsoft.com/office/drawing/2014/main" id="{680878BB-AAA3-4661-B5EC-1315A972C5A2}"/>
               </a:ext>
             </a:extLst>
           </p:cNvPr>
@@ -15455,7 +15455,7 @@
           <p:cNvPr id="22" name="Oval 21">
             <a:extLst>
               <a:ext uri="{FF2B5EF4-FFF2-40B4-BE49-F238E27FC236}">
-                <a16:creationId xmlns:a16="http://schemas.microsoft.com/office/drawing/2014/main" id="{CF87685F-C90F-4FA4-9E8F-F3CADB297D59}"/>
+                <a16:creationId xmlns:a16="http://schemas.microsoft.com/office/drawing/2014/main" id="{CDA11A28-6349-4520-8DAE-7858C6786C38}"/>
               </a:ext>
             </a:extLst>
           </p:cNvPr>
@@ -15486,7 +15486,7 @@
           <p:cNvPr id="23" name="Rectangle 22">
             <a:extLst>
               <a:ext uri="{FF2B5EF4-FFF2-40B4-BE49-F238E27FC236}">
-                <a16:creationId xmlns:a16="http://schemas.microsoft.com/office/drawing/2014/main" id="{FEA8A117-E97E-4A8E-AB76-8F2358D2BAB1}"/>
+                <a16:creationId xmlns:a16="http://schemas.microsoft.com/office/drawing/2014/main" id="{DD9F52B4-1529-48C4-A89F-84739735B06D}"/>
               </a:ext>
             </a:extLst>
           </p:cNvPr>
@@ -15548,7 +15548,7 @@
           <p:cNvPr id="24" name="Rectangle 23">
             <a:extLst>
               <a:ext uri="{FF2B5EF4-FFF2-40B4-BE49-F238E27FC236}">
-                <a16:creationId xmlns:a16="http://schemas.microsoft.com/office/drawing/2014/main" id="{84A3CF3C-6FE4-4BAF-959F-1F94E9E4C6AA}"/>
+                <a16:creationId xmlns:a16="http://schemas.microsoft.com/office/drawing/2014/main" id="{CC257654-93BC-4A15-A1D1-28CAB1F44074}"/>
               </a:ext>
             </a:extLst>
           </p:cNvPr>
@@ -15579,7 +15579,7 @@
           <p:cNvPr id="25" name="Rectangle 24">
             <a:extLst>
               <a:ext uri="{FF2B5EF4-FFF2-40B4-BE49-F238E27FC236}">
-                <a16:creationId xmlns:a16="http://schemas.microsoft.com/office/drawing/2014/main" id="{35965364-DF55-440E-AA63-78252FA498A7}"/>
+                <a16:creationId xmlns:a16="http://schemas.microsoft.com/office/drawing/2014/main" id="{7CFA31EE-63BE-4F3E-9C8F-89A42570BDD4}"/>
               </a:ext>
             </a:extLst>
           </p:cNvPr>
@@ -15641,7 +15641,7 @@
           <p:cNvPr id="26" name="Oval 25">
             <a:extLst>
               <a:ext uri="{FF2B5EF4-FFF2-40B4-BE49-F238E27FC236}">
-                <a16:creationId xmlns:a16="http://schemas.microsoft.com/office/drawing/2014/main" id="{0A27061F-F091-44C0-B2F1-0660AE489CBB}"/>
+                <a16:creationId xmlns:a16="http://schemas.microsoft.com/office/drawing/2014/main" id="{A55E688A-4A94-48A4-B51C-29CCD19D7D54}"/>
               </a:ext>
             </a:extLst>
           </p:cNvPr>
@@ -15672,7 +15672,7 @@
           <p:cNvPr id="27" name="Rectangle 26">
             <a:extLst>
               <a:ext uri="{FF2B5EF4-FFF2-40B4-BE49-F238E27FC236}">
-                <a16:creationId xmlns:a16="http://schemas.microsoft.com/office/drawing/2014/main" id="{B64DC102-8BA3-49DC-BEBE-9D92BF4E19FE}"/>
+                <a16:creationId xmlns:a16="http://schemas.microsoft.com/office/drawing/2014/main" id="{9A847EE5-C611-4B31-AEA1-FA8F149770F9}"/>
               </a:ext>
             </a:extLst>
           </p:cNvPr>
@@ -15734,7 +15734,7 @@
           <p:cNvPr id="28" name="Rectangle 27">
             <a:extLst>
               <a:ext uri="{FF2B5EF4-FFF2-40B4-BE49-F238E27FC236}">
-                <a16:creationId xmlns:a16="http://schemas.microsoft.com/office/drawing/2014/main" id="{7CFE4443-5937-4655-BC1C-5FB484680C83}"/>
+                <a16:creationId xmlns:a16="http://schemas.microsoft.com/office/drawing/2014/main" id="{D748C40C-FAD1-47B7-B4CC-B4A67C73AD42}"/>
               </a:ext>
             </a:extLst>
           </p:cNvPr>
@@ -15765,7 +15765,7 @@
           <p:cNvPr id="29" name="Rectangle 28">
             <a:extLst>
               <a:ext uri="{FF2B5EF4-FFF2-40B4-BE49-F238E27FC236}">
-                <a16:creationId xmlns:a16="http://schemas.microsoft.com/office/drawing/2014/main" id="{DFDE0B9C-25E3-4AE2-9914-8CF5B75652FA}"/>
+                <a16:creationId xmlns:a16="http://schemas.microsoft.com/office/drawing/2014/main" id="{AC56567F-E47C-4F14-8039-C30565564DAE}"/>
               </a:ext>
             </a:extLst>
           </p:cNvPr>
@@ -15827,7 +15827,7 @@
           <p:cNvPr id="30" name="Oval 29">
             <a:extLst>
               <a:ext uri="{FF2B5EF4-FFF2-40B4-BE49-F238E27FC236}">
-                <a16:creationId xmlns:a16="http://schemas.microsoft.com/office/drawing/2014/main" id="{40FB49FD-ABAE-470E-B45C-ADE01A3654C9}"/>
+                <a16:creationId xmlns:a16="http://schemas.microsoft.com/office/drawing/2014/main" id="{CFA90B9D-5D8B-4209-9A55-CD4EEFFC8DE9}"/>
               </a:ext>
             </a:extLst>
           </p:cNvPr>
@@ -15858,7 +15858,7 @@
           <p:cNvPr id="31" name="Rectangle 30">
             <a:extLst>
               <a:ext uri="{FF2B5EF4-FFF2-40B4-BE49-F238E27FC236}">
-                <a16:creationId xmlns:a16="http://schemas.microsoft.com/office/drawing/2014/main" id="{C03158DF-2B97-4C5E-BC30-A9F174AB8F0F}"/>
+                <a16:creationId xmlns:a16="http://schemas.microsoft.com/office/drawing/2014/main" id="{A4F0F6F9-822C-4D44-8D73-0C49E3561333}"/>
               </a:ext>
             </a:extLst>
           </p:cNvPr>
@@ -15920,7 +15920,7 @@
           <p:cNvPr id="32" name="Rectangle 31">
             <a:extLst>
               <a:ext uri="{FF2B5EF4-FFF2-40B4-BE49-F238E27FC236}">
-                <a16:creationId xmlns:a16="http://schemas.microsoft.com/office/drawing/2014/main" id="{2222C72D-B447-4C4D-84D2-9C17B9F4308F}"/>
+                <a16:creationId xmlns:a16="http://schemas.microsoft.com/office/drawing/2014/main" id="{D64A1855-BEC1-4179-AA5B-683F0ED0D383}"/>
               </a:ext>
             </a:extLst>
           </p:cNvPr>
@@ -15982,7 +15982,7 @@
           <p:cNvPr id="33" name="Rectangle: Rounded Corners 32">
             <a:extLst>
               <a:ext uri="{FF2B5EF4-FFF2-40B4-BE49-F238E27FC236}">
-                <a16:creationId xmlns:a16="http://schemas.microsoft.com/office/drawing/2014/main" id="{B77BE76F-2D2C-45C9-934C-6F79CA9E8CE4}"/>
+                <a16:creationId xmlns:a16="http://schemas.microsoft.com/office/drawing/2014/main" id="{B4F586C9-4BC8-4B13-963C-77EE479F86CC}"/>
               </a:ext>
             </a:extLst>
           </p:cNvPr>
@@ -16015,7 +16015,7 @@
           <p:cNvPr id="34" name="Rectangle 33">
             <a:extLst>
               <a:ext uri="{FF2B5EF4-FFF2-40B4-BE49-F238E27FC236}">
-                <a16:creationId xmlns:a16="http://schemas.microsoft.com/office/drawing/2014/main" id="{B09E6BEC-027A-4F2E-835B-B9467C83EE02}"/>
+                <a16:creationId xmlns:a16="http://schemas.microsoft.com/office/drawing/2014/main" id="{B6407C31-1357-4E4C-B1F9-3EE9344D03BC}"/>
               </a:ext>
             </a:extLst>
           </p:cNvPr>
@@ -16077,7 +16077,7 @@
           <p:cNvPr id="35" name="Rectangle 34">
             <a:extLst>
               <a:ext uri="{FF2B5EF4-FFF2-40B4-BE49-F238E27FC236}">
-                <a16:creationId xmlns:a16="http://schemas.microsoft.com/office/drawing/2014/main" id="{8E3A6F3C-4999-4E22-95E2-A359909834EB}"/>
+                <a16:creationId xmlns:a16="http://schemas.microsoft.com/office/drawing/2014/main" id="{DE0BFC11-7F8D-446E-B67A-98B03282E81E}"/>
               </a:ext>
             </a:extLst>
           </p:cNvPr>
@@ -16108,7 +16108,7 @@
           <p:cNvPr id="36" name="Rectangle 35">
             <a:extLst>
               <a:ext uri="{FF2B5EF4-FFF2-40B4-BE49-F238E27FC236}">
-                <a16:creationId xmlns:a16="http://schemas.microsoft.com/office/drawing/2014/main" id="{4A42629C-4505-46E4-A37F-98967EC281C9}"/>
+                <a16:creationId xmlns:a16="http://schemas.microsoft.com/office/drawing/2014/main" id="{0D502DB2-2A75-46C7-980B-6975E38807B2}"/>
               </a:ext>
             </a:extLst>
           </p:cNvPr>
@@ -16170,7 +16170,7 @@
           <p:cNvPr id="37" name="Rectangle 36">
             <a:extLst>
               <a:ext uri="{FF2B5EF4-FFF2-40B4-BE49-F238E27FC236}">
-                <a16:creationId xmlns:a16="http://schemas.microsoft.com/office/drawing/2014/main" id="{5AAAEB7C-8CF4-459A-AB30-0C14F1E608A2}"/>
+                <a16:creationId xmlns:a16="http://schemas.microsoft.com/office/drawing/2014/main" id="{5723BA15-5416-4D9C-A09D-DB2C70E81801}"/>
               </a:ext>
             </a:extLst>
           </p:cNvPr>
@@ -16230,7 +16230,7 @@
     </p:spTree>
     <p:extLst>
       <p:ext uri="{BB962C8B-B14F-4D97-AF65-F5344CB8AC3E}">
-        <p14:creationId xmlns:p14="http://schemas.microsoft.com/office/powerpoint/2010/main" val="1551240838"/>
+        <p14:creationId xmlns:p14="http://schemas.microsoft.com/office/powerpoint/2010/main" val="1067523060"/>
       </p:ext>
     </p:extLst>
   </p:cSld>
@@ -16271,7 +16271,7 @@
             <a:hlinkClick r:id="rId3"/>
             <a:extLst>
               <a:ext uri="{FF2B5EF4-FFF2-40B4-BE49-F238E27FC236}">
-                <a16:creationId xmlns:a16="http://schemas.microsoft.com/office/drawing/2014/main" id="{7C2385E2-190D-4478-A9A6-328A3B200F8A}"/>
+                <a16:creationId xmlns:a16="http://schemas.microsoft.com/office/drawing/2014/main" id="{FF1CFABC-3315-4E0C-87D4-63ABF85FA375}"/>
               </a:ext>
             </a:extLst>
           </p:cNvPr>
@@ -16346,7 +16346,7 @@
             <a:hlinkClick r:id="rId4"/>
             <a:extLst>
               <a:ext uri="{FF2B5EF4-FFF2-40B4-BE49-F238E27FC236}">
-                <a16:creationId xmlns:a16="http://schemas.microsoft.com/office/drawing/2014/main" id="{1359600E-AD7F-4079-831E-992AD41AB1BB}"/>
+                <a16:creationId xmlns:a16="http://schemas.microsoft.com/office/drawing/2014/main" id="{87B7B932-EBF8-4205-90A9-19D3EC74F7ED}"/>
               </a:ext>
             </a:extLst>
           </p:cNvPr>
@@ -16420,7 +16420,7 @@
           <p:cNvPr id="3" name="Rectangle 2">
             <a:extLst>
               <a:ext uri="{FF2B5EF4-FFF2-40B4-BE49-F238E27FC236}">
-                <a16:creationId xmlns:a16="http://schemas.microsoft.com/office/drawing/2014/main" id="{D319CFAA-BC90-4AE3-AE0D-5CE55CCC5559}"/>
+                <a16:creationId xmlns:a16="http://schemas.microsoft.com/office/drawing/2014/main" id="{ADFB10E6-934A-455E-B507-CA7A637CC044}"/>
               </a:ext>
             </a:extLst>
           </p:cNvPr>
@@ -16482,7 +16482,7 @@
           <p:cNvPr id="4" name="Rectangle 3">
             <a:extLst>
               <a:ext uri="{FF2B5EF4-FFF2-40B4-BE49-F238E27FC236}">
-                <a16:creationId xmlns:a16="http://schemas.microsoft.com/office/drawing/2014/main" id="{BA72CFE5-50C6-485B-9FA7-221AC6CCAB2D}"/>
+                <a16:creationId xmlns:a16="http://schemas.microsoft.com/office/drawing/2014/main" id="{E34DBECB-1A34-48D5-8845-F78637D9EA6C}"/>
               </a:ext>
             </a:extLst>
           </p:cNvPr>
@@ -16571,7 +16571,7 @@
           <p:cNvPr id="6" name="Rectangle: Rounded Corners 5">
             <a:extLst>
               <a:ext uri="{FF2B5EF4-FFF2-40B4-BE49-F238E27FC236}">
-                <a16:creationId xmlns:a16="http://schemas.microsoft.com/office/drawing/2014/main" id="{DC665DFB-3A0D-464C-B3EA-05F3445BC288}"/>
+                <a16:creationId xmlns:a16="http://schemas.microsoft.com/office/drawing/2014/main" id="{2E13EFD2-D082-497F-8167-835E153BFB19}"/>
               </a:ext>
             </a:extLst>
           </p:cNvPr>
@@ -16604,7 +16604,7 @@
           <p:cNvPr id="7" name="Oval 6">
             <a:extLst>
               <a:ext uri="{FF2B5EF4-FFF2-40B4-BE49-F238E27FC236}">
-                <a16:creationId xmlns:a16="http://schemas.microsoft.com/office/drawing/2014/main" id="{06487AA7-7BCF-4302-B81F-A11EF6309E96}"/>
+                <a16:creationId xmlns:a16="http://schemas.microsoft.com/office/drawing/2014/main" id="{BC46A9CE-4E19-47A2-94CA-3575ADD991F2}"/>
               </a:ext>
             </a:extLst>
           </p:cNvPr>
@@ -16635,7 +16635,7 @@
           <p:cNvPr id="8" name="Rectangle 7">
             <a:extLst>
               <a:ext uri="{FF2B5EF4-FFF2-40B4-BE49-F238E27FC236}">
-                <a16:creationId xmlns:a16="http://schemas.microsoft.com/office/drawing/2014/main" id="{6A6D36A9-1E3D-45BB-B8EE-35847B159758}"/>
+                <a16:creationId xmlns:a16="http://schemas.microsoft.com/office/drawing/2014/main" id="{004B47DD-04AA-4FDF-BC25-A0760AB82A8C}"/>
               </a:ext>
             </a:extLst>
           </p:cNvPr>
@@ -16697,7 +16697,7 @@
           <p:cNvPr id="9" name="Rectangle: Rounded Corners 8">
             <a:extLst>
               <a:ext uri="{FF2B5EF4-FFF2-40B4-BE49-F238E27FC236}">
-                <a16:creationId xmlns:a16="http://schemas.microsoft.com/office/drawing/2014/main" id="{05B668AC-EAF9-4E02-88C3-54484461CCA0}"/>
+                <a16:creationId xmlns:a16="http://schemas.microsoft.com/office/drawing/2014/main" id="{7210FB46-D7CD-489F-9841-FD9EC040EA92}"/>
               </a:ext>
             </a:extLst>
           </p:cNvPr>
@@ -16732,7 +16732,7 @@
           <p:cNvPr id="10" name="Rectangle 9">
             <a:extLst>
               <a:ext uri="{FF2B5EF4-FFF2-40B4-BE49-F238E27FC236}">
-                <a16:creationId xmlns:a16="http://schemas.microsoft.com/office/drawing/2014/main" id="{554E19B6-FCE8-45DE-B84F-1A67C4BF8AB7}"/>
+                <a16:creationId xmlns:a16="http://schemas.microsoft.com/office/drawing/2014/main" id="{EDF5ACE1-65BA-4F1D-8289-A91E987398B7}"/>
               </a:ext>
             </a:extLst>
           </p:cNvPr>
@@ -16794,7 +16794,7 @@
           <p:cNvPr id="11" name="Oval 10">
             <a:extLst>
               <a:ext uri="{FF2B5EF4-FFF2-40B4-BE49-F238E27FC236}">
-                <a16:creationId xmlns:a16="http://schemas.microsoft.com/office/drawing/2014/main" id="{4FD5515B-8C45-4411-8021-23622E757485}"/>
+                <a16:creationId xmlns:a16="http://schemas.microsoft.com/office/drawing/2014/main" id="{49073D29-0122-4D36-A058-03B2AD600D3C}"/>
               </a:ext>
             </a:extLst>
           </p:cNvPr>
@@ -16825,7 +16825,7 @@
           <p:cNvPr id="12" name="Rectangle 11">
             <a:extLst>
               <a:ext uri="{FF2B5EF4-FFF2-40B4-BE49-F238E27FC236}">
-                <a16:creationId xmlns:a16="http://schemas.microsoft.com/office/drawing/2014/main" id="{51FFA3F3-4C6F-4033-99AC-05BEB3C861F8}"/>
+                <a16:creationId xmlns:a16="http://schemas.microsoft.com/office/drawing/2014/main" id="{94E530BC-A9AA-4738-8BBF-BB35282A4CED}"/>
               </a:ext>
             </a:extLst>
           </p:cNvPr>
@@ -16887,7 +16887,7 @@
           <p:cNvPr id="13" name="Rectangle: Rounded Corners 12">
             <a:extLst>
               <a:ext uri="{FF2B5EF4-FFF2-40B4-BE49-F238E27FC236}">
-                <a16:creationId xmlns:a16="http://schemas.microsoft.com/office/drawing/2014/main" id="{CE03DAC6-570D-4C53-B407-14D1FAB7671E}"/>
+                <a16:creationId xmlns:a16="http://schemas.microsoft.com/office/drawing/2014/main" id="{B4DBF5E5-0336-4B60-BA32-D020E03DE5AB}"/>
               </a:ext>
             </a:extLst>
           </p:cNvPr>
@@ -16922,7 +16922,7 @@
           <p:cNvPr id="14" name="Rectangle 13">
             <a:extLst>
               <a:ext uri="{FF2B5EF4-FFF2-40B4-BE49-F238E27FC236}">
-                <a16:creationId xmlns:a16="http://schemas.microsoft.com/office/drawing/2014/main" id="{F24516AA-DEC4-41B3-9F31-0B8617304972}"/>
+                <a16:creationId xmlns:a16="http://schemas.microsoft.com/office/drawing/2014/main" id="{620DDE46-C6C4-4327-8919-E8CBA948B69B}"/>
               </a:ext>
             </a:extLst>
           </p:cNvPr>
@@ -16984,7 +16984,7 @@
           <p:cNvPr id="15" name="Oval 14">
             <a:extLst>
               <a:ext uri="{FF2B5EF4-FFF2-40B4-BE49-F238E27FC236}">
-                <a16:creationId xmlns:a16="http://schemas.microsoft.com/office/drawing/2014/main" id="{11F94F48-BDD1-460E-8B8F-E296E78B265E}"/>
+                <a16:creationId xmlns:a16="http://schemas.microsoft.com/office/drawing/2014/main" id="{8036630E-A831-48E0-B3D4-A4464B66FDEE}"/>
               </a:ext>
             </a:extLst>
           </p:cNvPr>
@@ -17015,7 +17015,7 @@
           <p:cNvPr id="16" name="Rectangle 15">
             <a:extLst>
               <a:ext uri="{FF2B5EF4-FFF2-40B4-BE49-F238E27FC236}">
-                <a16:creationId xmlns:a16="http://schemas.microsoft.com/office/drawing/2014/main" id="{5A413985-5FBF-4B7C-9D99-D23C33F32B5A}"/>
+                <a16:creationId xmlns:a16="http://schemas.microsoft.com/office/drawing/2014/main" id="{2525F30D-A817-4B74-A1AA-E40695D6D733}"/>
               </a:ext>
             </a:extLst>
           </p:cNvPr>
@@ -17077,7 +17077,7 @@
           <p:cNvPr id="17" name="Rectangle: Rounded Corners 16">
             <a:extLst>
               <a:ext uri="{FF2B5EF4-FFF2-40B4-BE49-F238E27FC236}">
-                <a16:creationId xmlns:a16="http://schemas.microsoft.com/office/drawing/2014/main" id="{EFE867F9-AE87-40C9-95EB-1311F7D20F87}"/>
+                <a16:creationId xmlns:a16="http://schemas.microsoft.com/office/drawing/2014/main" id="{2A562CB2-5DD8-404A-B82E-4AB4F0706CEE}"/>
               </a:ext>
             </a:extLst>
           </p:cNvPr>
@@ -17112,7 +17112,7 @@
           <p:cNvPr id="18" name="Rectangle 17">
             <a:extLst>
               <a:ext uri="{FF2B5EF4-FFF2-40B4-BE49-F238E27FC236}">
-                <a16:creationId xmlns:a16="http://schemas.microsoft.com/office/drawing/2014/main" id="{83ADF858-F3CE-4F00-B3D6-2C70BCC26536}"/>
+                <a16:creationId xmlns:a16="http://schemas.microsoft.com/office/drawing/2014/main" id="{38F5BDD9-0D5B-4891-868F-D9D236BC9E39}"/>
               </a:ext>
             </a:extLst>
           </p:cNvPr>
@@ -17174,7 +17174,7 @@
           <p:cNvPr id="19" name="Rectangle 18">
             <a:extLst>
               <a:ext uri="{FF2B5EF4-FFF2-40B4-BE49-F238E27FC236}">
-                <a16:creationId xmlns:a16="http://schemas.microsoft.com/office/drawing/2014/main" id="{D7BBFC28-2300-4376-805B-0C6385F53A56}"/>
+                <a16:creationId xmlns:a16="http://schemas.microsoft.com/office/drawing/2014/main" id="{DB12B809-FEED-45BA-A7B5-56AE43777BB7}"/>
               </a:ext>
             </a:extLst>
           </p:cNvPr>
@@ -17205,7 +17205,7 @@
           <p:cNvPr id="20" name="Rectangle 19">
             <a:extLst>
               <a:ext uri="{FF2B5EF4-FFF2-40B4-BE49-F238E27FC236}">
-                <a16:creationId xmlns:a16="http://schemas.microsoft.com/office/drawing/2014/main" id="{BC8FC81A-E37A-4B3F-AD0D-638AD0CF1822}"/>
+                <a16:creationId xmlns:a16="http://schemas.microsoft.com/office/drawing/2014/main" id="{1B681046-2561-40A5-A443-92A40A281AE7}"/>
               </a:ext>
             </a:extLst>
           </p:cNvPr>
@@ -17267,7 +17267,7 @@
           <p:cNvPr id="21" name="Rectangle 20">
             <a:extLst>
               <a:ext uri="{FF2B5EF4-FFF2-40B4-BE49-F238E27FC236}">
-                <a16:creationId xmlns:a16="http://schemas.microsoft.com/office/drawing/2014/main" id="{1C38EBD9-3FA1-4DEE-9D0C-98BF1E269A37}"/>
+                <a16:creationId xmlns:a16="http://schemas.microsoft.com/office/drawing/2014/main" id="{1698CE0A-A461-4B34-8AF3-F64871BFFC4D}"/>
               </a:ext>
             </a:extLst>
           </p:cNvPr>
@@ -17327,7 +17327,7 @@
     </p:spTree>
     <p:extLst>
       <p:ext uri="{BB962C8B-B14F-4D97-AF65-F5344CB8AC3E}">
-        <p14:creationId xmlns:p14="http://schemas.microsoft.com/office/powerpoint/2010/main" val="343166562"/>
+        <p14:creationId xmlns:p14="http://schemas.microsoft.com/office/powerpoint/2010/main" val="111049002"/>
       </p:ext>
     </p:extLst>
   </p:cSld>
@@ -17368,7 +17368,7 @@
             <a:hlinkClick r:id="rId3"/>
             <a:extLst>
               <a:ext uri="{FF2B5EF4-FFF2-40B4-BE49-F238E27FC236}">
-                <a16:creationId xmlns:a16="http://schemas.microsoft.com/office/drawing/2014/main" id="{D2540317-7F5B-4C8F-AB98-920BD6A0E910}"/>
+                <a16:creationId xmlns:a16="http://schemas.microsoft.com/office/drawing/2014/main" id="{2E2AE422-655E-42F2-BB40-71E533559158}"/>
               </a:ext>
             </a:extLst>
           </p:cNvPr>
@@ -17443,7 +17443,7 @@
             <a:hlinkClick r:id="rId4"/>
             <a:extLst>
               <a:ext uri="{FF2B5EF4-FFF2-40B4-BE49-F238E27FC236}">
-                <a16:creationId xmlns:a16="http://schemas.microsoft.com/office/drawing/2014/main" id="{72C27A9D-CBC6-4AA8-A721-648CFC412AAE}"/>
+                <a16:creationId xmlns:a16="http://schemas.microsoft.com/office/drawing/2014/main" id="{55370542-9FB1-4C87-A104-1AA36CFA91B4}"/>
               </a:ext>
             </a:extLst>
           </p:cNvPr>
@@ -17517,7 +17517,7 @@
           <p:cNvPr id="3" name="Rectangle 2">
             <a:extLst>
               <a:ext uri="{FF2B5EF4-FFF2-40B4-BE49-F238E27FC236}">
-                <a16:creationId xmlns:a16="http://schemas.microsoft.com/office/drawing/2014/main" id="{5574294A-8F5C-4809-B25A-B62916C18533}"/>
+                <a16:creationId xmlns:a16="http://schemas.microsoft.com/office/drawing/2014/main" id="{2B151A06-430E-4A2F-8969-84BCE612D5F2}"/>
               </a:ext>
             </a:extLst>
           </p:cNvPr>
@@ -17579,7 +17579,7 @@
           <p:cNvPr id="4" name="Rectangle 3">
             <a:extLst>
               <a:ext uri="{FF2B5EF4-FFF2-40B4-BE49-F238E27FC236}">
-                <a16:creationId xmlns:a16="http://schemas.microsoft.com/office/drawing/2014/main" id="{DA26E73D-54BE-43A4-B0CD-8CC400A440B7}"/>
+                <a16:creationId xmlns:a16="http://schemas.microsoft.com/office/drawing/2014/main" id="{CF425CE6-B268-484A-AAFD-83FEB6BAA63C}"/>
               </a:ext>
             </a:extLst>
           </p:cNvPr>
@@ -17668,7 +17668,7 @@
           <p:cNvPr id="6" name="Rectangle: Rounded Corners 5">
             <a:extLst>
               <a:ext uri="{FF2B5EF4-FFF2-40B4-BE49-F238E27FC236}">
-                <a16:creationId xmlns:a16="http://schemas.microsoft.com/office/drawing/2014/main" id="{DC0610AC-CB72-4288-BC89-21FC0F806EE4}"/>
+                <a16:creationId xmlns:a16="http://schemas.microsoft.com/office/drawing/2014/main" id="{CE6B656C-5D99-4B05-9A19-827EA8949589}"/>
               </a:ext>
             </a:extLst>
           </p:cNvPr>
@@ -17701,7 +17701,7 @@
           <p:cNvPr id="7" name="Oval 6">
             <a:extLst>
               <a:ext uri="{FF2B5EF4-FFF2-40B4-BE49-F238E27FC236}">
-                <a16:creationId xmlns:a16="http://schemas.microsoft.com/office/drawing/2014/main" id="{79CCBEF6-0345-4BFE-8570-F06B20E8F4B6}"/>
+                <a16:creationId xmlns:a16="http://schemas.microsoft.com/office/drawing/2014/main" id="{44FAB73E-DB84-45F4-8BC0-DA5A33FD9E7E}"/>
               </a:ext>
             </a:extLst>
           </p:cNvPr>
@@ -17732,7 +17732,7 @@
           <p:cNvPr id="8" name="Rectangle 7">
             <a:extLst>
               <a:ext uri="{FF2B5EF4-FFF2-40B4-BE49-F238E27FC236}">
-                <a16:creationId xmlns:a16="http://schemas.microsoft.com/office/drawing/2014/main" id="{1C121F5E-CA98-4FDC-BC6D-32F9078A1051}"/>
+                <a16:creationId xmlns:a16="http://schemas.microsoft.com/office/drawing/2014/main" id="{F77125C1-CB8C-4315-9915-B08FE34B3EE0}"/>
               </a:ext>
             </a:extLst>
           </p:cNvPr>
@@ -17794,7 +17794,7 @@
           <p:cNvPr id="9" name="Rectangle: Rounded Corners 8">
             <a:extLst>
               <a:ext uri="{FF2B5EF4-FFF2-40B4-BE49-F238E27FC236}">
-                <a16:creationId xmlns:a16="http://schemas.microsoft.com/office/drawing/2014/main" id="{86620C78-9230-43E7-A329-19CB3C799087}"/>
+                <a16:creationId xmlns:a16="http://schemas.microsoft.com/office/drawing/2014/main" id="{77FD52B6-E82C-49A8-907C-C310A8590D7F}"/>
               </a:ext>
             </a:extLst>
           </p:cNvPr>
@@ -17829,7 +17829,7 @@
           <p:cNvPr id="10" name="Rectangle 9">
             <a:extLst>
               <a:ext uri="{FF2B5EF4-FFF2-40B4-BE49-F238E27FC236}">
-                <a16:creationId xmlns:a16="http://schemas.microsoft.com/office/drawing/2014/main" id="{BAD656DA-6D43-4227-A584-E0F3D9F1F352}"/>
+                <a16:creationId xmlns:a16="http://schemas.microsoft.com/office/drawing/2014/main" id="{90B6D83F-3645-4A7F-811F-808391F707BF}"/>
               </a:ext>
             </a:extLst>
           </p:cNvPr>
@@ -17891,7 +17891,7 @@
           <p:cNvPr id="11" name="Oval 10">
             <a:extLst>
               <a:ext uri="{FF2B5EF4-FFF2-40B4-BE49-F238E27FC236}">
-                <a16:creationId xmlns:a16="http://schemas.microsoft.com/office/drawing/2014/main" id="{AEF0E351-03D5-4728-8A30-D18B0ACC5A89}"/>
+                <a16:creationId xmlns:a16="http://schemas.microsoft.com/office/drawing/2014/main" id="{3270D3C7-A187-427C-BCD2-03E59E41A5F0}"/>
               </a:ext>
             </a:extLst>
           </p:cNvPr>
@@ -17922,7 +17922,7 @@
           <p:cNvPr id="12" name="Rectangle 11">
             <a:extLst>
               <a:ext uri="{FF2B5EF4-FFF2-40B4-BE49-F238E27FC236}">
-                <a16:creationId xmlns:a16="http://schemas.microsoft.com/office/drawing/2014/main" id="{7CFDF336-7E66-4959-A049-C5CF39C9A804}"/>
+                <a16:creationId xmlns:a16="http://schemas.microsoft.com/office/drawing/2014/main" id="{2A41883F-3302-42E2-99BC-1D217E2893C2}"/>
               </a:ext>
             </a:extLst>
           </p:cNvPr>
@@ -17984,7 +17984,7 @@
           <p:cNvPr id="13" name="Rectangle: Rounded Corners 12">
             <a:extLst>
               <a:ext uri="{FF2B5EF4-FFF2-40B4-BE49-F238E27FC236}">
-                <a16:creationId xmlns:a16="http://schemas.microsoft.com/office/drawing/2014/main" id="{DCC70012-053C-4D10-BE8D-6225B6F3D139}"/>
+                <a16:creationId xmlns:a16="http://schemas.microsoft.com/office/drawing/2014/main" id="{2BC3D757-9A04-4D3B-B627-53007269C996}"/>
               </a:ext>
             </a:extLst>
           </p:cNvPr>
@@ -18019,7 +18019,7 @@
           <p:cNvPr id="14" name="Rectangle 13">
             <a:extLst>
               <a:ext uri="{FF2B5EF4-FFF2-40B4-BE49-F238E27FC236}">
-                <a16:creationId xmlns:a16="http://schemas.microsoft.com/office/drawing/2014/main" id="{0EDAE898-9A20-429A-A5AA-01724F66F62D}"/>
+                <a16:creationId xmlns:a16="http://schemas.microsoft.com/office/drawing/2014/main" id="{E9789976-0934-4F2D-BDE4-3FC057FA791C}"/>
               </a:ext>
             </a:extLst>
           </p:cNvPr>
@@ -18081,7 +18081,7 @@
           <p:cNvPr id="15" name="Oval 14">
             <a:extLst>
               <a:ext uri="{FF2B5EF4-FFF2-40B4-BE49-F238E27FC236}">
-                <a16:creationId xmlns:a16="http://schemas.microsoft.com/office/drawing/2014/main" id="{387F9981-36E2-4025-BEFF-5394CECDA7BE}"/>
+                <a16:creationId xmlns:a16="http://schemas.microsoft.com/office/drawing/2014/main" id="{2D679868-8C18-45B7-8424-A43D6FA7B39B}"/>
               </a:ext>
             </a:extLst>
           </p:cNvPr>
@@ -18112,7 +18112,7 @@
           <p:cNvPr id="16" name="Rectangle 15">
             <a:extLst>
               <a:ext uri="{FF2B5EF4-FFF2-40B4-BE49-F238E27FC236}">
-                <a16:creationId xmlns:a16="http://schemas.microsoft.com/office/drawing/2014/main" id="{47AD6969-ABA3-404E-B519-B36B3AA573D7}"/>
+                <a16:creationId xmlns:a16="http://schemas.microsoft.com/office/drawing/2014/main" id="{429EC8E3-01CE-4C3B-BE88-9911721C0D26}"/>
               </a:ext>
             </a:extLst>
           </p:cNvPr>
@@ -18174,7 +18174,7 @@
           <p:cNvPr id="17" name="Rectangle: Rounded Corners 16">
             <a:extLst>
               <a:ext uri="{FF2B5EF4-FFF2-40B4-BE49-F238E27FC236}">
-                <a16:creationId xmlns:a16="http://schemas.microsoft.com/office/drawing/2014/main" id="{AE7A4D52-FA19-4604-B4F7-B3F920E68B73}"/>
+                <a16:creationId xmlns:a16="http://schemas.microsoft.com/office/drawing/2014/main" id="{A3604E8A-6242-4375-9FA5-C896DD4EAEC4}"/>
               </a:ext>
             </a:extLst>
           </p:cNvPr>
@@ -18209,7 +18209,7 @@
           <p:cNvPr id="18" name="Rectangle 17">
             <a:extLst>
               <a:ext uri="{FF2B5EF4-FFF2-40B4-BE49-F238E27FC236}">
-                <a16:creationId xmlns:a16="http://schemas.microsoft.com/office/drawing/2014/main" id="{3D6B457B-2E0D-4C2C-A764-D7B724502D9F}"/>
+                <a16:creationId xmlns:a16="http://schemas.microsoft.com/office/drawing/2014/main" id="{36461EE4-0421-40E3-8B6D-8EFE2E31CFB7}"/>
               </a:ext>
             </a:extLst>
           </p:cNvPr>
@@ -18271,7 +18271,7 @@
           <p:cNvPr id="19" name="Rectangle 18">
             <a:extLst>
               <a:ext uri="{FF2B5EF4-FFF2-40B4-BE49-F238E27FC236}">
-                <a16:creationId xmlns:a16="http://schemas.microsoft.com/office/drawing/2014/main" id="{1B0BC8D6-5E19-43F5-A16B-C0390F303DDA}"/>
+                <a16:creationId xmlns:a16="http://schemas.microsoft.com/office/drawing/2014/main" id="{A314BC2E-CDA2-45E6-960A-500CFDD3931A}"/>
               </a:ext>
             </a:extLst>
           </p:cNvPr>
@@ -18302,7 +18302,7 @@
           <p:cNvPr id="20" name="Rectangle 19">
             <a:extLst>
               <a:ext uri="{FF2B5EF4-FFF2-40B4-BE49-F238E27FC236}">
-                <a16:creationId xmlns:a16="http://schemas.microsoft.com/office/drawing/2014/main" id="{E9A21CCF-7111-4F5F-8CCC-FBB0BCDA150C}"/>
+                <a16:creationId xmlns:a16="http://schemas.microsoft.com/office/drawing/2014/main" id="{F9C68A2A-2947-4977-8D95-8A2A234CCAE3}"/>
               </a:ext>
             </a:extLst>
           </p:cNvPr>
@@ -18364,7 +18364,7 @@
           <p:cNvPr id="21" name="Rectangle 20">
             <a:extLst>
               <a:ext uri="{FF2B5EF4-FFF2-40B4-BE49-F238E27FC236}">
-                <a16:creationId xmlns:a16="http://schemas.microsoft.com/office/drawing/2014/main" id="{BA0E1ABA-9A17-42DC-902C-D60E6B927A64}"/>
+                <a16:creationId xmlns:a16="http://schemas.microsoft.com/office/drawing/2014/main" id="{BEF24CBC-3642-43D7-96F9-71DF63861C16}"/>
               </a:ext>
             </a:extLst>
           </p:cNvPr>
@@ -18424,7 +18424,7 @@
     </p:spTree>
     <p:extLst>
       <p:ext uri="{BB962C8B-B14F-4D97-AF65-F5344CB8AC3E}">
-        <p14:creationId xmlns:p14="http://schemas.microsoft.com/office/powerpoint/2010/main" val="978969316"/>
+        <p14:creationId xmlns:p14="http://schemas.microsoft.com/office/powerpoint/2010/main" val="2131822731"/>
       </p:ext>
     </p:extLst>
   </p:cSld>
@@ -18465,7 +18465,7 @@
             <a:hlinkClick r:id="rId3"/>
             <a:extLst>
               <a:ext uri="{FF2B5EF4-FFF2-40B4-BE49-F238E27FC236}">
-                <a16:creationId xmlns:a16="http://schemas.microsoft.com/office/drawing/2014/main" id="{178B1607-8FD9-4928-AB60-C6BE41ADEA39}"/>
+                <a16:creationId xmlns:a16="http://schemas.microsoft.com/office/drawing/2014/main" id="{AD93CF68-F367-495B-A574-5175C59BA579}"/>
               </a:ext>
             </a:extLst>
           </p:cNvPr>
@@ -18540,7 +18540,7 @@
             <a:hlinkClick r:id="rId4"/>
             <a:extLst>
               <a:ext uri="{FF2B5EF4-FFF2-40B4-BE49-F238E27FC236}">
-                <a16:creationId xmlns:a16="http://schemas.microsoft.com/office/drawing/2014/main" id="{F8079C95-6B5F-484B-A131-50430B6DA066}"/>
+                <a16:creationId xmlns:a16="http://schemas.microsoft.com/office/drawing/2014/main" id="{1786CC6E-A0AC-4D58-A231-CB2830661108}"/>
               </a:ext>
             </a:extLst>
           </p:cNvPr>
@@ -18614,7 +18614,7 @@
           <p:cNvPr id="3" name="Rectangle 2">
             <a:extLst>
               <a:ext uri="{FF2B5EF4-FFF2-40B4-BE49-F238E27FC236}">
-                <a16:creationId xmlns:a16="http://schemas.microsoft.com/office/drawing/2014/main" id="{328EE187-3420-4BBB-B7C9-EAC051628896}"/>
+                <a16:creationId xmlns:a16="http://schemas.microsoft.com/office/drawing/2014/main" id="{A8B778BF-CDBA-4191-9865-5B2010EABF61}"/>
               </a:ext>
             </a:extLst>
           </p:cNvPr>
@@ -18676,7 +18676,7 @@
           <p:cNvPr id="4" name="Rectangle 3">
             <a:extLst>
               <a:ext uri="{FF2B5EF4-FFF2-40B4-BE49-F238E27FC236}">
-                <a16:creationId xmlns:a16="http://schemas.microsoft.com/office/drawing/2014/main" id="{A078A925-5113-477B-9B45-52EB6417FAFF}"/>
+                <a16:creationId xmlns:a16="http://schemas.microsoft.com/office/drawing/2014/main" id="{60505AFE-D8E3-423B-B150-420EDD12DBCF}"/>
               </a:ext>
             </a:extLst>
           </p:cNvPr>
@@ -18765,7 +18765,7 @@
           <p:cNvPr id="6" name="Rectangle: Rounded Corners 5">
             <a:extLst>
               <a:ext uri="{FF2B5EF4-FFF2-40B4-BE49-F238E27FC236}">
-                <a16:creationId xmlns:a16="http://schemas.microsoft.com/office/drawing/2014/main" id="{AFA2B169-E78D-4EEB-8A6F-F1D270A65CF4}"/>
+                <a16:creationId xmlns:a16="http://schemas.microsoft.com/office/drawing/2014/main" id="{66A6D08E-7319-4DB4-B799-664573C40E5B}"/>
               </a:ext>
             </a:extLst>
           </p:cNvPr>
@@ -18798,7 +18798,7 @@
           <p:cNvPr id="7" name="Oval 6">
             <a:extLst>
               <a:ext uri="{FF2B5EF4-FFF2-40B4-BE49-F238E27FC236}">
-                <a16:creationId xmlns:a16="http://schemas.microsoft.com/office/drawing/2014/main" id="{0AA6220C-CB43-410F-A21D-FBD1D0F51F20}"/>
+                <a16:creationId xmlns:a16="http://schemas.microsoft.com/office/drawing/2014/main" id="{AB7A38C5-D17E-4596-B2C8-0DBD3DB828BC}"/>
               </a:ext>
             </a:extLst>
           </p:cNvPr>
@@ -18829,7 +18829,7 @@
           <p:cNvPr id="8" name="Rectangle 7">
             <a:extLst>
               <a:ext uri="{FF2B5EF4-FFF2-40B4-BE49-F238E27FC236}">
-                <a16:creationId xmlns:a16="http://schemas.microsoft.com/office/drawing/2014/main" id="{BBFE3D27-F263-40D4-A55A-64EFF5415AF6}"/>
+                <a16:creationId xmlns:a16="http://schemas.microsoft.com/office/drawing/2014/main" id="{5C041C69-D9C0-4577-BD85-0DB14EA44965}"/>
               </a:ext>
             </a:extLst>
           </p:cNvPr>
@@ -18891,7 +18891,7 @@
           <p:cNvPr id="9" name="Rectangle: Rounded Corners 8">
             <a:extLst>
               <a:ext uri="{FF2B5EF4-FFF2-40B4-BE49-F238E27FC236}">
-                <a16:creationId xmlns:a16="http://schemas.microsoft.com/office/drawing/2014/main" id="{218ACEF0-F1D8-494C-A167-E4E1B9CCD688}"/>
+                <a16:creationId xmlns:a16="http://schemas.microsoft.com/office/drawing/2014/main" id="{0CA8F5DD-1800-4D1D-A5DE-362A6104DFC5}"/>
               </a:ext>
             </a:extLst>
           </p:cNvPr>
@@ -18926,7 +18926,7 @@
           <p:cNvPr id="10" name="Rectangle 9">
             <a:extLst>
               <a:ext uri="{FF2B5EF4-FFF2-40B4-BE49-F238E27FC236}">
-                <a16:creationId xmlns:a16="http://schemas.microsoft.com/office/drawing/2014/main" id="{508543AC-6CB8-47E5-B5D8-6824183F47C5}"/>
+                <a16:creationId xmlns:a16="http://schemas.microsoft.com/office/drawing/2014/main" id="{3FC45372-ED03-48FC-BCCF-9A883ED3F7F6}"/>
               </a:ext>
             </a:extLst>
           </p:cNvPr>
@@ -18988,7 +18988,7 @@
           <p:cNvPr id="11" name="Oval 10">
             <a:extLst>
               <a:ext uri="{FF2B5EF4-FFF2-40B4-BE49-F238E27FC236}">
-                <a16:creationId xmlns:a16="http://schemas.microsoft.com/office/drawing/2014/main" id="{8BEA8B9E-ADAE-42FA-A4E1-623BB6D43765}"/>
+                <a16:creationId xmlns:a16="http://schemas.microsoft.com/office/drawing/2014/main" id="{A6F90982-F48C-4E5C-A372-BC8EC9480EC8}"/>
               </a:ext>
             </a:extLst>
           </p:cNvPr>
@@ -19019,7 +19019,7 @@
           <p:cNvPr id="12" name="Rectangle 11">
             <a:extLst>
               <a:ext uri="{FF2B5EF4-FFF2-40B4-BE49-F238E27FC236}">
-                <a16:creationId xmlns:a16="http://schemas.microsoft.com/office/drawing/2014/main" id="{4F054936-9844-4BD7-B011-F0D6245AECC9}"/>
+                <a16:creationId xmlns:a16="http://schemas.microsoft.com/office/drawing/2014/main" id="{8F3C5361-A4E5-4EF9-A254-5C891FB06DF1}"/>
               </a:ext>
             </a:extLst>
           </p:cNvPr>
@@ -19081,7 +19081,7 @@
           <p:cNvPr id="13" name="Rectangle: Rounded Corners 12">
             <a:extLst>
               <a:ext uri="{FF2B5EF4-FFF2-40B4-BE49-F238E27FC236}">
-                <a16:creationId xmlns:a16="http://schemas.microsoft.com/office/drawing/2014/main" id="{974BE317-5156-4F7D-AB56-343DF0BA0593}"/>
+                <a16:creationId xmlns:a16="http://schemas.microsoft.com/office/drawing/2014/main" id="{78BCFAA0-D4F2-4826-88FC-A91B963671D4}"/>
               </a:ext>
             </a:extLst>
           </p:cNvPr>
@@ -19116,7 +19116,7 @@
           <p:cNvPr id="14" name="Rectangle 13">
             <a:extLst>
               <a:ext uri="{FF2B5EF4-FFF2-40B4-BE49-F238E27FC236}">
-                <a16:creationId xmlns:a16="http://schemas.microsoft.com/office/drawing/2014/main" id="{1B3D3047-393A-4D1C-8E61-A7D0F094D48A}"/>
+                <a16:creationId xmlns:a16="http://schemas.microsoft.com/office/drawing/2014/main" id="{1FF88707-119E-4297-925B-F6F8E65ACE5D}"/>
               </a:ext>
             </a:extLst>
           </p:cNvPr>
@@ -19178,7 +19178,7 @@
           <p:cNvPr id="15" name="Oval 14">
             <a:extLst>
               <a:ext uri="{FF2B5EF4-FFF2-40B4-BE49-F238E27FC236}">
-                <a16:creationId xmlns:a16="http://schemas.microsoft.com/office/drawing/2014/main" id="{5565B0F3-D714-42C1-8823-675A2DD9A12C}"/>
+                <a16:creationId xmlns:a16="http://schemas.microsoft.com/office/drawing/2014/main" id="{F9B1C262-819C-40F6-9450-8B55178A8397}"/>
               </a:ext>
             </a:extLst>
           </p:cNvPr>
@@ -19209,7 +19209,7 @@
           <p:cNvPr id="16" name="Rectangle 15">
             <a:extLst>
               <a:ext uri="{FF2B5EF4-FFF2-40B4-BE49-F238E27FC236}">
-                <a16:creationId xmlns:a16="http://schemas.microsoft.com/office/drawing/2014/main" id="{991B13C6-8EE5-46D0-878F-E679CBD7EA23}"/>
+                <a16:creationId xmlns:a16="http://schemas.microsoft.com/office/drawing/2014/main" id="{C57BBC21-9E78-4819-BF9C-0B63BA517660}"/>
               </a:ext>
             </a:extLst>
           </p:cNvPr>
@@ -19271,7 +19271,7 @@
           <p:cNvPr id="17" name="Rectangle: Rounded Corners 16">
             <a:extLst>
               <a:ext uri="{FF2B5EF4-FFF2-40B4-BE49-F238E27FC236}">
-                <a16:creationId xmlns:a16="http://schemas.microsoft.com/office/drawing/2014/main" id="{0E085A36-8F44-4F03-8F1A-4B24D44D783A}"/>
+                <a16:creationId xmlns:a16="http://schemas.microsoft.com/office/drawing/2014/main" id="{31DC4BD0-779D-4330-9F61-6367D5D765B3}"/>
               </a:ext>
             </a:extLst>
           </p:cNvPr>
@@ -19306,7 +19306,7 @@
           <p:cNvPr id="18" name="Rectangle 17">
             <a:extLst>
               <a:ext uri="{FF2B5EF4-FFF2-40B4-BE49-F238E27FC236}">
-                <a16:creationId xmlns:a16="http://schemas.microsoft.com/office/drawing/2014/main" id="{6CEE93C8-8000-4AF3-86CD-1D2461ED0DCC}"/>
+                <a16:creationId xmlns:a16="http://schemas.microsoft.com/office/drawing/2014/main" id="{39DBE098-92A2-4AE2-BB1D-D8ED04F9D348}"/>
               </a:ext>
             </a:extLst>
           </p:cNvPr>
@@ -19368,7 +19368,7 @@
           <p:cNvPr id="19" name="Rectangle 18">
             <a:extLst>
               <a:ext uri="{FF2B5EF4-FFF2-40B4-BE49-F238E27FC236}">
-                <a16:creationId xmlns:a16="http://schemas.microsoft.com/office/drawing/2014/main" id="{D1D555D9-4DED-41A1-8951-CFB8EB68FCAE}"/>
+                <a16:creationId xmlns:a16="http://schemas.microsoft.com/office/drawing/2014/main" id="{51837BAA-4769-465B-B3E8-AC02835E26FF}"/>
               </a:ext>
             </a:extLst>
           </p:cNvPr>
@@ -19399,7 +19399,7 @@
           <p:cNvPr id="20" name="Rectangle 19">
             <a:extLst>
               <a:ext uri="{FF2B5EF4-FFF2-40B4-BE49-F238E27FC236}">
-                <a16:creationId xmlns:a16="http://schemas.microsoft.com/office/drawing/2014/main" id="{DF7C9D0A-F22E-4DA1-9FFB-35314A7C6F4B}"/>
+                <a16:creationId xmlns:a16="http://schemas.microsoft.com/office/drawing/2014/main" id="{AF1D30A8-686B-4363-A11D-874F3E436B3D}"/>
               </a:ext>
             </a:extLst>
           </p:cNvPr>
@@ -19461,7 +19461,7 @@
           <p:cNvPr id="21" name="Rectangle 20">
             <a:extLst>
               <a:ext uri="{FF2B5EF4-FFF2-40B4-BE49-F238E27FC236}">
-                <a16:creationId xmlns:a16="http://schemas.microsoft.com/office/drawing/2014/main" id="{E22E7B14-A615-454D-B494-B77184700A21}"/>
+                <a16:creationId xmlns:a16="http://schemas.microsoft.com/office/drawing/2014/main" id="{1EC3DE20-B5EA-4DFA-ACA4-A51C23EF1825}"/>
               </a:ext>
             </a:extLst>
           </p:cNvPr>
@@ -19521,7 +19521,7 @@
     </p:spTree>
     <p:extLst>
       <p:ext uri="{BB962C8B-B14F-4D97-AF65-F5344CB8AC3E}">
-        <p14:creationId xmlns:p14="http://schemas.microsoft.com/office/powerpoint/2010/main" val="846153784"/>
+        <p14:creationId xmlns:p14="http://schemas.microsoft.com/office/powerpoint/2010/main" val="273523411"/>
       </p:ext>
     </p:extLst>
   </p:cSld>
@@ -19562,7 +19562,7 @@
             <a:hlinkClick r:id="rId3"/>
             <a:extLst>
               <a:ext uri="{FF2B5EF4-FFF2-40B4-BE49-F238E27FC236}">
-                <a16:creationId xmlns:a16="http://schemas.microsoft.com/office/drawing/2014/main" id="{FFF1773E-0753-4DE4-8660-1D19A8D79301}"/>
+                <a16:creationId xmlns:a16="http://schemas.microsoft.com/office/drawing/2014/main" id="{17F34523-A951-4A8D-92B3-660158D75E80}"/>
               </a:ext>
             </a:extLst>
           </p:cNvPr>
@@ -19637,7 +19637,7 @@
             <a:hlinkClick r:id="rId4"/>
             <a:extLst>
               <a:ext uri="{FF2B5EF4-FFF2-40B4-BE49-F238E27FC236}">
-                <a16:creationId xmlns:a16="http://schemas.microsoft.com/office/drawing/2014/main" id="{F83AC99E-E206-4977-B3CE-5BABB091DAF2}"/>
+                <a16:creationId xmlns:a16="http://schemas.microsoft.com/office/drawing/2014/main" id="{E303280B-4476-4525-B3DE-BC02CA2FCB7F}"/>
               </a:ext>
             </a:extLst>
           </p:cNvPr>
@@ -19711,7 +19711,7 @@
           <p:cNvPr id="3" name="Rectangle 2">
             <a:extLst>
               <a:ext uri="{FF2B5EF4-FFF2-40B4-BE49-F238E27FC236}">
-                <a16:creationId xmlns:a16="http://schemas.microsoft.com/office/drawing/2014/main" id="{B7F5DBE4-2928-4C42-AE34-8946416B6C14}"/>
+                <a16:creationId xmlns:a16="http://schemas.microsoft.com/office/drawing/2014/main" id="{6ADD9098-96D7-4D4E-82AB-5076095008B4}"/>
               </a:ext>
             </a:extLst>
           </p:cNvPr>
@@ -19773,7 +19773,7 @@
           <p:cNvPr id="4" name="Rectangle 3">
             <a:extLst>
               <a:ext uri="{FF2B5EF4-FFF2-40B4-BE49-F238E27FC236}">
-                <a16:creationId xmlns:a16="http://schemas.microsoft.com/office/drawing/2014/main" id="{2BD4E3F6-081D-4211-9B5C-4B08F68153B5}"/>
+                <a16:creationId xmlns:a16="http://schemas.microsoft.com/office/drawing/2014/main" id="{71A41DB7-1460-43A5-88B6-79A8F8893178}"/>
               </a:ext>
             </a:extLst>
           </p:cNvPr>
@@ -19862,7 +19862,7 @@
           <p:cNvPr id="6" name="Rectangle: Rounded Corners 5">
             <a:extLst>
               <a:ext uri="{FF2B5EF4-FFF2-40B4-BE49-F238E27FC236}">
-                <a16:creationId xmlns:a16="http://schemas.microsoft.com/office/drawing/2014/main" id="{EF5CC028-DB8E-4619-9FF7-DC7E5325D244}"/>
+                <a16:creationId xmlns:a16="http://schemas.microsoft.com/office/drawing/2014/main" id="{22FDC896-D550-4BCF-AF61-D3718469B22F}"/>
               </a:ext>
             </a:extLst>
           </p:cNvPr>
@@ -19911,7 +19911,7 @@
           <p:cNvPr id="8" name="Rectangle 7">
             <a:extLst>
               <a:ext uri="{FF2B5EF4-FFF2-40B4-BE49-F238E27FC236}">
-                <a16:creationId xmlns:a16="http://schemas.microsoft.com/office/drawing/2014/main" id="{8CA18D47-154B-4173-B0D7-06C336F2174E}"/>
+                <a16:creationId xmlns:a16="http://schemas.microsoft.com/office/drawing/2014/main" id="{0193A2CC-94CE-4086-839D-5C769DA2DB5B}"/>
               </a:ext>
             </a:extLst>
           </p:cNvPr>
@@ -19973,7 +19973,7 @@
           <p:cNvPr id="9" name="Rectangle 8">
             <a:extLst>
               <a:ext uri="{FF2B5EF4-FFF2-40B4-BE49-F238E27FC236}">
-                <a16:creationId xmlns:a16="http://schemas.microsoft.com/office/drawing/2014/main" id="{941A00C2-D54A-407B-9303-8EC6C167FF54}"/>
+                <a16:creationId xmlns:a16="http://schemas.microsoft.com/office/drawing/2014/main" id="{9676F299-BBC3-4D22-926D-8D266D0B0D8C}"/>
               </a:ext>
             </a:extLst>
           </p:cNvPr>
@@ -20035,7 +20035,7 @@
           <p:cNvPr id="10" name="Rectangle 9">
             <a:extLst>
               <a:ext uri="{FF2B5EF4-FFF2-40B4-BE49-F238E27FC236}">
-                <a16:creationId xmlns:a16="http://schemas.microsoft.com/office/drawing/2014/main" id="{94BB839C-16A0-437A-885A-602E9295D172}"/>
+                <a16:creationId xmlns:a16="http://schemas.microsoft.com/office/drawing/2014/main" id="{B385B42A-02D0-4D8A-A96A-BA38192438D0}"/>
               </a:ext>
             </a:extLst>
           </p:cNvPr>
@@ -20097,7 +20097,7 @@
           <p:cNvPr id="11" name="Rectangle: Rounded Corners 10">
             <a:extLst>
               <a:ext uri="{FF2B5EF4-FFF2-40B4-BE49-F238E27FC236}">
-                <a16:creationId xmlns:a16="http://schemas.microsoft.com/office/drawing/2014/main" id="{1FCBD50D-55FA-406D-AFD4-00A135CCCDF5}"/>
+                <a16:creationId xmlns:a16="http://schemas.microsoft.com/office/drawing/2014/main" id="{4E25681A-2B94-43DA-B12C-0A3530A831C7}"/>
               </a:ext>
             </a:extLst>
           </p:cNvPr>
@@ -20130,7 +20130,7 @@
           <p:cNvPr id="12" name="Rectangle 11">
             <a:extLst>
               <a:ext uri="{FF2B5EF4-FFF2-40B4-BE49-F238E27FC236}">
-                <a16:creationId xmlns:a16="http://schemas.microsoft.com/office/drawing/2014/main" id="{FAF2739D-8B83-4BDB-BD82-85C9263A4D01}"/>
+                <a16:creationId xmlns:a16="http://schemas.microsoft.com/office/drawing/2014/main" id="{20A9E8C5-AA3B-499F-938E-FAE479FFF0F6}"/>
               </a:ext>
             </a:extLst>
           </p:cNvPr>
@@ -20192,7 +20192,7 @@
           <p:cNvPr id="13" name="Rectangle: Rounded Corners 12">
             <a:extLst>
               <a:ext uri="{FF2B5EF4-FFF2-40B4-BE49-F238E27FC236}">
-                <a16:creationId xmlns:a16="http://schemas.microsoft.com/office/drawing/2014/main" id="{EB14AB06-CDF2-4FA2-906C-5642A712CA38}"/>
+                <a16:creationId xmlns:a16="http://schemas.microsoft.com/office/drawing/2014/main" id="{6448193C-FEE5-448D-8371-0C5EA0E1962B}"/>
               </a:ext>
             </a:extLst>
           </p:cNvPr>
@@ -20225,7 +20225,7 @@
           <p:cNvPr id="14" name="Rectangle 13">
             <a:extLst>
               <a:ext uri="{FF2B5EF4-FFF2-40B4-BE49-F238E27FC236}">
-                <a16:creationId xmlns:a16="http://schemas.microsoft.com/office/drawing/2014/main" id="{8FA95B34-D32A-4930-A803-6AFBD04204CC}"/>
+                <a16:creationId xmlns:a16="http://schemas.microsoft.com/office/drawing/2014/main" id="{2E9F235F-93A6-4570-8765-5A11C352C568}"/>
               </a:ext>
             </a:extLst>
           </p:cNvPr>
@@ -20287,7 +20287,7 @@
           <p:cNvPr id="15" name="Rectangle 14">
             <a:extLst>
               <a:ext uri="{FF2B5EF4-FFF2-40B4-BE49-F238E27FC236}">
-                <a16:creationId xmlns:a16="http://schemas.microsoft.com/office/drawing/2014/main" id="{317D688D-9C9A-4068-B332-CC8B399F660D}"/>
+                <a16:creationId xmlns:a16="http://schemas.microsoft.com/office/drawing/2014/main" id="{42AC8E51-B47F-4B38-88CE-AD0987531639}"/>
               </a:ext>
             </a:extLst>
           </p:cNvPr>
@@ -20318,7 +20318,7 @@
           <p:cNvPr id="16" name="Rectangle 15">
             <a:extLst>
               <a:ext uri="{FF2B5EF4-FFF2-40B4-BE49-F238E27FC236}">
-                <a16:creationId xmlns:a16="http://schemas.microsoft.com/office/drawing/2014/main" id="{E3266DE2-3EB3-4FB0-A3CD-4A6BDA78BA0A}"/>
+                <a16:creationId xmlns:a16="http://schemas.microsoft.com/office/drawing/2014/main" id="{C6E4D136-D065-4B3F-8F67-A4791C3ED489}"/>
               </a:ext>
             </a:extLst>
           </p:cNvPr>
@@ -20380,7 +20380,7 @@
           <p:cNvPr id="17" name="Rectangle 16">
             <a:extLst>
               <a:ext uri="{FF2B5EF4-FFF2-40B4-BE49-F238E27FC236}">
-                <a16:creationId xmlns:a16="http://schemas.microsoft.com/office/drawing/2014/main" id="{3CDCFD9A-33EF-4D92-AE64-E9AA77E51BD9}"/>
+                <a16:creationId xmlns:a16="http://schemas.microsoft.com/office/drawing/2014/main" id="{FB783244-EE98-4D4E-ABD7-343C9056879B}"/>
               </a:ext>
             </a:extLst>
           </p:cNvPr>
@@ -20440,7 +20440,7 @@
     </p:spTree>
     <p:extLst>
       <p:ext uri="{BB962C8B-B14F-4D97-AF65-F5344CB8AC3E}">
-        <p14:creationId xmlns:p14="http://schemas.microsoft.com/office/powerpoint/2010/main" val="1079132304"/>
+        <p14:creationId xmlns:p14="http://schemas.microsoft.com/office/powerpoint/2010/main" val="946228654"/>
       </p:ext>
     </p:extLst>
   </p:cSld>
@@ -20481,7 +20481,7 @@
             <a:hlinkClick r:id="rId3"/>
             <a:extLst>
               <a:ext uri="{FF2B5EF4-FFF2-40B4-BE49-F238E27FC236}">
-                <a16:creationId xmlns:a16="http://schemas.microsoft.com/office/drawing/2014/main" id="{38BABFF3-A994-4F4F-A6F9-1FAA6DF7BC23}"/>
+                <a16:creationId xmlns:a16="http://schemas.microsoft.com/office/drawing/2014/main" id="{67CEF348-4078-4C6B-A292-32F5B70A84E6}"/>
               </a:ext>
             </a:extLst>
           </p:cNvPr>
@@ -20556,7 +20556,7 @@
             <a:hlinkClick r:id="rId4"/>
             <a:extLst>
               <a:ext uri="{FF2B5EF4-FFF2-40B4-BE49-F238E27FC236}">
-                <a16:creationId xmlns:a16="http://schemas.microsoft.com/office/drawing/2014/main" id="{169415CB-0650-4E30-964C-BCA0F85F6E75}"/>
+                <a16:creationId xmlns:a16="http://schemas.microsoft.com/office/drawing/2014/main" id="{262F40D2-8592-418E-BF93-B810F9F2D19D}"/>
               </a:ext>
             </a:extLst>
           </p:cNvPr>
@@ -20630,7 +20630,7 @@
           <p:cNvPr id="3" name="Rectangle 2">
             <a:extLst>
               <a:ext uri="{FF2B5EF4-FFF2-40B4-BE49-F238E27FC236}">
-                <a16:creationId xmlns:a16="http://schemas.microsoft.com/office/drawing/2014/main" id="{31B80862-83E5-4E3B-997B-F1B442D983CB}"/>
+                <a16:creationId xmlns:a16="http://schemas.microsoft.com/office/drawing/2014/main" id="{391C16F0-A81D-4F65-84C9-25120585DB7D}"/>
               </a:ext>
             </a:extLst>
           </p:cNvPr>
@@ -20692,7 +20692,7 @@
           <p:cNvPr id="4" name="Rectangle 3">
             <a:extLst>
               <a:ext uri="{FF2B5EF4-FFF2-40B4-BE49-F238E27FC236}">
-                <a16:creationId xmlns:a16="http://schemas.microsoft.com/office/drawing/2014/main" id="{5FB99DA5-9A06-4C9B-B769-3C39BFD56A78}"/>
+                <a16:creationId xmlns:a16="http://schemas.microsoft.com/office/drawing/2014/main" id="{7EDD8A0C-259F-4982-A9E2-6E32D9346AE8}"/>
               </a:ext>
             </a:extLst>
           </p:cNvPr>
@@ -20781,7 +20781,7 @@
           <p:cNvPr id="6" name="Rectangle: Rounded Corners 5">
             <a:extLst>
               <a:ext uri="{FF2B5EF4-FFF2-40B4-BE49-F238E27FC236}">
-                <a16:creationId xmlns:a16="http://schemas.microsoft.com/office/drawing/2014/main" id="{5B98ED65-4B53-447D-BF67-BB8C7263C151}"/>
+                <a16:creationId xmlns:a16="http://schemas.microsoft.com/office/drawing/2014/main" id="{64CC9035-0700-4AEE-9F75-EFCDC7F1AC18}"/>
               </a:ext>
             </a:extLst>
           </p:cNvPr>
@@ -20814,7 +20814,7 @@
           <p:cNvPr id="7" name="Oval 6">
             <a:extLst>
               <a:ext uri="{FF2B5EF4-FFF2-40B4-BE49-F238E27FC236}">
-                <a16:creationId xmlns:a16="http://schemas.microsoft.com/office/drawing/2014/main" id="{4AEF9CC4-034A-4475-BB40-7835C1A369B4}"/>
+                <a16:creationId xmlns:a16="http://schemas.microsoft.com/office/drawing/2014/main" id="{2FE6C0C3-C677-4181-929C-38B953AA9A24}"/>
               </a:ext>
             </a:extLst>
           </p:cNvPr>
@@ -20845,7 +20845,7 @@
           <p:cNvPr id="8" name="Rectangle 7">
             <a:extLst>
               <a:ext uri="{FF2B5EF4-FFF2-40B4-BE49-F238E27FC236}">
-                <a16:creationId xmlns:a16="http://schemas.microsoft.com/office/drawing/2014/main" id="{D63F53D2-3F94-42CC-B4DE-E11C2B47117B}"/>
+                <a16:creationId xmlns:a16="http://schemas.microsoft.com/office/drawing/2014/main" id="{D1F9041F-52DB-44B5-9D3B-C57003B9CD5B}"/>
               </a:ext>
             </a:extLst>
           </p:cNvPr>
@@ -20907,7 +20907,7 @@
           <p:cNvPr id="9" name="Rectangle: Rounded Corners 8">
             <a:extLst>
               <a:ext uri="{FF2B5EF4-FFF2-40B4-BE49-F238E27FC236}">
-                <a16:creationId xmlns:a16="http://schemas.microsoft.com/office/drawing/2014/main" id="{49A36368-E4A9-478F-A389-2D3D3019AD80}"/>
+                <a16:creationId xmlns:a16="http://schemas.microsoft.com/office/drawing/2014/main" id="{3BB80687-56B5-48AE-B127-85754A0BC39D}"/>
               </a:ext>
             </a:extLst>
           </p:cNvPr>
@@ -20942,7 +20942,7 @@
           <p:cNvPr id="10" name="Rectangle 9">
             <a:extLst>
               <a:ext uri="{FF2B5EF4-FFF2-40B4-BE49-F238E27FC236}">
-                <a16:creationId xmlns:a16="http://schemas.microsoft.com/office/drawing/2014/main" id="{9FBE394F-072F-4D57-8A2A-2734DE639E19}"/>
+                <a16:creationId xmlns:a16="http://schemas.microsoft.com/office/drawing/2014/main" id="{D30984E6-C58A-4021-94F1-E2C622BB22A1}"/>
               </a:ext>
             </a:extLst>
           </p:cNvPr>
@@ -21004,7 +21004,7 @@
           <p:cNvPr id="11" name="Oval 10">
             <a:extLst>
               <a:ext uri="{FF2B5EF4-FFF2-40B4-BE49-F238E27FC236}">
-                <a16:creationId xmlns:a16="http://schemas.microsoft.com/office/drawing/2014/main" id="{7CDD498B-9BBE-4B10-9BDD-989447BEE229}"/>
+                <a16:creationId xmlns:a16="http://schemas.microsoft.com/office/drawing/2014/main" id="{F2B4F2D9-28BF-40DD-B793-7E116C07F0D1}"/>
               </a:ext>
             </a:extLst>
           </p:cNvPr>
@@ -21035,7 +21035,7 @@
           <p:cNvPr id="12" name="Rectangle 11">
             <a:extLst>
               <a:ext uri="{FF2B5EF4-FFF2-40B4-BE49-F238E27FC236}">
-                <a16:creationId xmlns:a16="http://schemas.microsoft.com/office/drawing/2014/main" id="{B15E1D81-6204-4011-8843-3CB5269A61B9}"/>
+                <a16:creationId xmlns:a16="http://schemas.microsoft.com/office/drawing/2014/main" id="{F934F220-497E-4B66-A6FC-D0B1297CBF9E}"/>
               </a:ext>
             </a:extLst>
           </p:cNvPr>
@@ -21097,7 +21097,7 @@
           <p:cNvPr id="13" name="Rectangle: Rounded Corners 12">
             <a:extLst>
               <a:ext uri="{FF2B5EF4-FFF2-40B4-BE49-F238E27FC236}">
-                <a16:creationId xmlns:a16="http://schemas.microsoft.com/office/drawing/2014/main" id="{05E1C841-71E1-4ECC-87A9-744E1BC26E4A}"/>
+                <a16:creationId xmlns:a16="http://schemas.microsoft.com/office/drawing/2014/main" id="{0341FB45-AB1D-4893-B8AB-217EE6A1A978}"/>
               </a:ext>
             </a:extLst>
           </p:cNvPr>
@@ -21132,7 +21132,7 @@
           <p:cNvPr id="14" name="Rectangle 13">
             <a:extLst>
               <a:ext uri="{FF2B5EF4-FFF2-40B4-BE49-F238E27FC236}">
-                <a16:creationId xmlns:a16="http://schemas.microsoft.com/office/drawing/2014/main" id="{A2458FCB-ADD8-4FCB-A7B2-A58A29F3DC34}"/>
+                <a16:creationId xmlns:a16="http://schemas.microsoft.com/office/drawing/2014/main" id="{658961D9-E273-4E16-B1AA-6FC2D6089F09}"/>
               </a:ext>
             </a:extLst>
           </p:cNvPr>
@@ -21194,7 +21194,7 @@
           <p:cNvPr id="15" name="Oval 14">
             <a:extLst>
               <a:ext uri="{FF2B5EF4-FFF2-40B4-BE49-F238E27FC236}">
-                <a16:creationId xmlns:a16="http://schemas.microsoft.com/office/drawing/2014/main" id="{9682BA76-001E-48A5-9C7F-3538E4BBE972}"/>
+                <a16:creationId xmlns:a16="http://schemas.microsoft.com/office/drawing/2014/main" id="{07B96139-1A24-4986-A2C1-2F9C0D8F990B}"/>
               </a:ext>
             </a:extLst>
           </p:cNvPr>
@@ -21225,7 +21225,7 @@
           <p:cNvPr id="16" name="Rectangle 15">
             <a:extLst>
               <a:ext uri="{FF2B5EF4-FFF2-40B4-BE49-F238E27FC236}">
-                <a16:creationId xmlns:a16="http://schemas.microsoft.com/office/drawing/2014/main" id="{457CB69D-F6D9-4AE8-A7FC-453B3ECD74FB}"/>
+                <a16:creationId xmlns:a16="http://schemas.microsoft.com/office/drawing/2014/main" id="{71D4398C-09F9-4A7A-A309-8BECE636ECCE}"/>
               </a:ext>
             </a:extLst>
           </p:cNvPr>
@@ -21287,7 +21287,7 @@
           <p:cNvPr id="17" name="Rectangle: Rounded Corners 16">
             <a:extLst>
               <a:ext uri="{FF2B5EF4-FFF2-40B4-BE49-F238E27FC236}">
-                <a16:creationId xmlns:a16="http://schemas.microsoft.com/office/drawing/2014/main" id="{293094AA-6F64-4348-997C-F1FF53A1F6B1}"/>
+                <a16:creationId xmlns:a16="http://schemas.microsoft.com/office/drawing/2014/main" id="{7E4A1F65-BB92-4126-AB81-F066671B4044}"/>
               </a:ext>
             </a:extLst>
           </p:cNvPr>
@@ -21322,7 +21322,7 @@
           <p:cNvPr id="18" name="Rectangle 17">
             <a:extLst>
               <a:ext uri="{FF2B5EF4-FFF2-40B4-BE49-F238E27FC236}">
-                <a16:creationId xmlns:a16="http://schemas.microsoft.com/office/drawing/2014/main" id="{E5109702-C54A-4ADC-8E6C-47B3813B52A4}"/>
+                <a16:creationId xmlns:a16="http://schemas.microsoft.com/office/drawing/2014/main" id="{054D9C4C-B843-460F-BA67-0DE7A40F5A9A}"/>
               </a:ext>
             </a:extLst>
           </p:cNvPr>
@@ -21384,7 +21384,7 @@
           <p:cNvPr id="19" name="Rectangle 18">
             <a:extLst>
               <a:ext uri="{FF2B5EF4-FFF2-40B4-BE49-F238E27FC236}">
-                <a16:creationId xmlns:a16="http://schemas.microsoft.com/office/drawing/2014/main" id="{E93BC0DB-85BB-4D3C-948C-92701E5DBD9A}"/>
+                <a16:creationId xmlns:a16="http://schemas.microsoft.com/office/drawing/2014/main" id="{F64369ED-DB42-40AE-9414-2597D467CFC5}"/>
               </a:ext>
             </a:extLst>
           </p:cNvPr>
@@ -21415,7 +21415,7 @@
           <p:cNvPr id="20" name="Rectangle 19">
             <a:extLst>
               <a:ext uri="{FF2B5EF4-FFF2-40B4-BE49-F238E27FC236}">
-                <a16:creationId xmlns:a16="http://schemas.microsoft.com/office/drawing/2014/main" id="{D56FE17B-934D-43FB-A1FE-4475F2D96AA9}"/>
+                <a16:creationId xmlns:a16="http://schemas.microsoft.com/office/drawing/2014/main" id="{1A00AE32-3C97-40A3-8B96-70A28810DD6C}"/>
               </a:ext>
             </a:extLst>
           </p:cNvPr>
@@ -21477,7 +21477,7 @@
           <p:cNvPr id="21" name="Rectangle 20">
             <a:extLst>
               <a:ext uri="{FF2B5EF4-FFF2-40B4-BE49-F238E27FC236}">
-                <a16:creationId xmlns:a16="http://schemas.microsoft.com/office/drawing/2014/main" id="{EF05A0DE-50B3-44DE-9868-988EAD9415AA}"/>
+                <a16:creationId xmlns:a16="http://schemas.microsoft.com/office/drawing/2014/main" id="{D27F61DA-1A77-48AC-8B22-E6274B059A5E}"/>
               </a:ext>
             </a:extLst>
           </p:cNvPr>
@@ -21537,7 +21537,7 @@
     </p:spTree>
     <p:extLst>
       <p:ext uri="{BB962C8B-B14F-4D97-AF65-F5344CB8AC3E}">
-        <p14:creationId xmlns:p14="http://schemas.microsoft.com/office/powerpoint/2010/main" val="244821497"/>
+        <p14:creationId xmlns:p14="http://schemas.microsoft.com/office/powerpoint/2010/main" val="2017465503"/>
       </p:ext>
     </p:extLst>
   </p:cSld>
@@ -21578,7 +21578,7 @@
             <a:hlinkClick r:id="rId3"/>
             <a:extLst>
               <a:ext uri="{FF2B5EF4-FFF2-40B4-BE49-F238E27FC236}">
-                <a16:creationId xmlns:a16="http://schemas.microsoft.com/office/drawing/2014/main" id="{0751D279-D8F1-457F-8B93-BB582149CD97}"/>
+                <a16:creationId xmlns:a16="http://schemas.microsoft.com/office/drawing/2014/main" id="{D882B509-D4BD-4F6E-9B8A-67A2F352588B}"/>
               </a:ext>
             </a:extLst>
           </p:cNvPr>
@@ -21653,7 +21653,7 @@
             <a:hlinkClick r:id="rId4"/>
             <a:extLst>
               <a:ext uri="{FF2B5EF4-FFF2-40B4-BE49-F238E27FC236}">
-                <a16:creationId xmlns:a16="http://schemas.microsoft.com/office/drawing/2014/main" id="{E17A73C8-17E5-45F4-9E77-7B30A5D0934E}"/>
+                <a16:creationId xmlns:a16="http://schemas.microsoft.com/office/drawing/2014/main" id="{13568D2F-B81A-4F34-856A-F4E5E1659653}"/>
               </a:ext>
             </a:extLst>
           </p:cNvPr>
@@ -21727,7 +21727,7 @@
           <p:cNvPr id="3" name="Rectangle 2">
             <a:extLst>
               <a:ext uri="{FF2B5EF4-FFF2-40B4-BE49-F238E27FC236}">
-                <a16:creationId xmlns:a16="http://schemas.microsoft.com/office/drawing/2014/main" id="{A0C4D59E-BD73-4FDF-BEDC-0F05D8B70272}"/>
+                <a16:creationId xmlns:a16="http://schemas.microsoft.com/office/drawing/2014/main" id="{9632B410-C20C-414E-A800-08CAF64CC606}"/>
               </a:ext>
             </a:extLst>
           </p:cNvPr>
@@ -21789,7 +21789,7 @@
           <p:cNvPr id="4" name="Rectangle 3">
             <a:extLst>
               <a:ext uri="{FF2B5EF4-FFF2-40B4-BE49-F238E27FC236}">
-                <a16:creationId xmlns:a16="http://schemas.microsoft.com/office/drawing/2014/main" id="{C48D26A9-4A4F-42C1-B429-9241D06E7C1B}"/>
+                <a16:creationId xmlns:a16="http://schemas.microsoft.com/office/drawing/2014/main" id="{51ED17CC-0E23-4C23-ADD6-783031B77049}"/>
               </a:ext>
             </a:extLst>
           </p:cNvPr>
@@ -21878,7 +21878,7 @@
           <p:cNvPr id="6" name="Rectangle: Rounded Corners 5">
             <a:extLst>
               <a:ext uri="{FF2B5EF4-FFF2-40B4-BE49-F238E27FC236}">
-                <a16:creationId xmlns:a16="http://schemas.microsoft.com/office/drawing/2014/main" id="{FA88E6F0-BE76-412E-B0B9-994A7F573D4F}"/>
+                <a16:creationId xmlns:a16="http://schemas.microsoft.com/office/drawing/2014/main" id="{83D307BC-EFC9-4741-B7B4-11E2C6FC19F3}"/>
               </a:ext>
             </a:extLst>
           </p:cNvPr>
@@ -21911,7 +21911,7 @@
           <p:cNvPr id="7" name="Oval 6">
             <a:extLst>
               <a:ext uri="{FF2B5EF4-FFF2-40B4-BE49-F238E27FC236}">
-                <a16:creationId xmlns:a16="http://schemas.microsoft.com/office/drawing/2014/main" id="{D03424B4-E8E3-4BA3-AC61-18FD2E6F09BC}"/>
+                <a16:creationId xmlns:a16="http://schemas.microsoft.com/office/drawing/2014/main" id="{901674C0-0CD3-4D20-828A-6A0F00C58282}"/>
               </a:ext>
             </a:extLst>
           </p:cNvPr>
@@ -21942,7 +21942,7 @@
           <p:cNvPr id="8" name="Rectangle 7">
             <a:extLst>
               <a:ext uri="{FF2B5EF4-FFF2-40B4-BE49-F238E27FC236}">
-                <a16:creationId xmlns:a16="http://schemas.microsoft.com/office/drawing/2014/main" id="{9D64D563-2FCC-4595-AA51-B60BB9101EFB}"/>
+                <a16:creationId xmlns:a16="http://schemas.microsoft.com/office/drawing/2014/main" id="{E0110388-0F75-4793-9C24-ACAEF250635F}"/>
               </a:ext>
             </a:extLst>
           </p:cNvPr>
@@ -22004,7 +22004,7 @@
           <p:cNvPr id="9" name="Rectangle: Rounded Corners 8">
             <a:extLst>
               <a:ext uri="{FF2B5EF4-FFF2-40B4-BE49-F238E27FC236}">
-                <a16:creationId xmlns:a16="http://schemas.microsoft.com/office/drawing/2014/main" id="{27BD67A7-AA35-42FD-85E9-7044C861BA47}"/>
+                <a16:creationId xmlns:a16="http://schemas.microsoft.com/office/drawing/2014/main" id="{5BB123F4-8519-4D80-BCEE-97C93DA89898}"/>
               </a:ext>
             </a:extLst>
           </p:cNvPr>
@@ -22039,7 +22039,7 @@
           <p:cNvPr id="10" name="Rectangle 9">
             <a:extLst>
               <a:ext uri="{FF2B5EF4-FFF2-40B4-BE49-F238E27FC236}">
-                <a16:creationId xmlns:a16="http://schemas.microsoft.com/office/drawing/2014/main" id="{140BAC12-1375-4FAC-BB72-817752A655DB}"/>
+                <a16:creationId xmlns:a16="http://schemas.microsoft.com/office/drawing/2014/main" id="{44E6879A-F609-44E1-8E3C-A7269B41CBAA}"/>
               </a:ext>
             </a:extLst>
           </p:cNvPr>
@@ -22101,7 +22101,7 @@
           <p:cNvPr id="11" name="Oval 10">
             <a:extLst>
               <a:ext uri="{FF2B5EF4-FFF2-40B4-BE49-F238E27FC236}">
-                <a16:creationId xmlns:a16="http://schemas.microsoft.com/office/drawing/2014/main" id="{1BAC6BFF-76B3-47A7-8BCF-4B1383EDD216}"/>
+                <a16:creationId xmlns:a16="http://schemas.microsoft.com/office/drawing/2014/main" id="{9E7F4094-86C8-4DC1-BB9C-292CB401EC70}"/>
               </a:ext>
             </a:extLst>
           </p:cNvPr>
@@ -22132,7 +22132,7 @@
           <p:cNvPr id="12" name="Rectangle 11">
             <a:extLst>
               <a:ext uri="{FF2B5EF4-FFF2-40B4-BE49-F238E27FC236}">
-                <a16:creationId xmlns:a16="http://schemas.microsoft.com/office/drawing/2014/main" id="{B483E1CA-9B82-48B1-998E-01BF86C1F666}"/>
+                <a16:creationId xmlns:a16="http://schemas.microsoft.com/office/drawing/2014/main" id="{453A5858-F96F-49EA-9D21-F5D391BFA7F5}"/>
               </a:ext>
             </a:extLst>
           </p:cNvPr>
@@ -22194,7 +22194,7 @@
           <p:cNvPr id="13" name="Rectangle: Rounded Corners 12">
             <a:extLst>
               <a:ext uri="{FF2B5EF4-FFF2-40B4-BE49-F238E27FC236}">
-                <a16:creationId xmlns:a16="http://schemas.microsoft.com/office/drawing/2014/main" id="{CD97D84B-9B81-4CA8-BA6A-4BC41B48A696}"/>
+                <a16:creationId xmlns:a16="http://schemas.microsoft.com/office/drawing/2014/main" id="{F1EF5118-BA3C-4848-ADA7-A41918F920A2}"/>
               </a:ext>
             </a:extLst>
           </p:cNvPr>
@@ -22229,7 +22229,7 @@
           <p:cNvPr id="14" name="Rectangle 13">
             <a:extLst>
               <a:ext uri="{FF2B5EF4-FFF2-40B4-BE49-F238E27FC236}">
-                <a16:creationId xmlns:a16="http://schemas.microsoft.com/office/drawing/2014/main" id="{60308633-8ECD-4ABF-925B-390F638E2614}"/>
+                <a16:creationId xmlns:a16="http://schemas.microsoft.com/office/drawing/2014/main" id="{03AB9112-9A59-4B3C-9718-8C125060698A}"/>
               </a:ext>
             </a:extLst>
           </p:cNvPr>
@@ -22291,7 +22291,7 @@
           <p:cNvPr id="15" name="Oval 14">
             <a:extLst>
               <a:ext uri="{FF2B5EF4-FFF2-40B4-BE49-F238E27FC236}">
-                <a16:creationId xmlns:a16="http://schemas.microsoft.com/office/drawing/2014/main" id="{F4E867D7-87CD-4934-814D-AD8D53C0F806}"/>
+                <a16:creationId xmlns:a16="http://schemas.microsoft.com/office/drawing/2014/main" id="{DF493424-5D4C-481D-820F-ECA79C21C96D}"/>
               </a:ext>
             </a:extLst>
           </p:cNvPr>
@@ -22322,7 +22322,7 @@
           <p:cNvPr id="16" name="Rectangle 15">
             <a:extLst>
               <a:ext uri="{FF2B5EF4-FFF2-40B4-BE49-F238E27FC236}">
-                <a16:creationId xmlns:a16="http://schemas.microsoft.com/office/drawing/2014/main" id="{34F95559-88D5-478F-908C-01F4868B4A6E}"/>
+                <a16:creationId xmlns:a16="http://schemas.microsoft.com/office/drawing/2014/main" id="{B824B840-C8C0-48FC-9B5A-15F91D548049}"/>
               </a:ext>
             </a:extLst>
           </p:cNvPr>
@@ -22384,7 +22384,7 @@
           <p:cNvPr id="17" name="Rectangle: Rounded Corners 16">
             <a:extLst>
               <a:ext uri="{FF2B5EF4-FFF2-40B4-BE49-F238E27FC236}">
-                <a16:creationId xmlns:a16="http://schemas.microsoft.com/office/drawing/2014/main" id="{CF7C8369-1517-4091-A4F1-EA3D25FB8F6D}"/>
+                <a16:creationId xmlns:a16="http://schemas.microsoft.com/office/drawing/2014/main" id="{3A4C11C8-2EEF-4363-BF5F-8D419DBA479A}"/>
               </a:ext>
             </a:extLst>
           </p:cNvPr>
@@ -22419,7 +22419,7 @@
           <p:cNvPr id="18" name="Rectangle 17">
             <a:extLst>
               <a:ext uri="{FF2B5EF4-FFF2-40B4-BE49-F238E27FC236}">
-                <a16:creationId xmlns:a16="http://schemas.microsoft.com/office/drawing/2014/main" id="{4CF1D388-46F2-47BC-972F-B00EA5AC4210}"/>
+                <a16:creationId xmlns:a16="http://schemas.microsoft.com/office/drawing/2014/main" id="{F8E1110B-FB7A-4EF9-8F04-1E40F960FBB9}"/>
               </a:ext>
             </a:extLst>
           </p:cNvPr>
@@ -22481,7 +22481,7 @@
           <p:cNvPr id="19" name="Rectangle 18">
             <a:extLst>
               <a:ext uri="{FF2B5EF4-FFF2-40B4-BE49-F238E27FC236}">
-                <a16:creationId xmlns:a16="http://schemas.microsoft.com/office/drawing/2014/main" id="{27B55C50-4C5C-4466-8D71-584BDE4099F7}"/>
+                <a16:creationId xmlns:a16="http://schemas.microsoft.com/office/drawing/2014/main" id="{7E890F3E-AC6B-4AB3-B32F-135E6A963663}"/>
               </a:ext>
             </a:extLst>
           </p:cNvPr>
@@ -22512,7 +22512,7 @@
           <p:cNvPr id="20" name="Rectangle 19">
             <a:extLst>
               <a:ext uri="{FF2B5EF4-FFF2-40B4-BE49-F238E27FC236}">
-                <a16:creationId xmlns:a16="http://schemas.microsoft.com/office/drawing/2014/main" id="{84DA0336-1FDD-4471-BE3F-57E4AA36FC9F}"/>
+                <a16:creationId xmlns:a16="http://schemas.microsoft.com/office/drawing/2014/main" id="{AB582A65-A236-45F7-8680-F619C8FF664B}"/>
               </a:ext>
             </a:extLst>
           </p:cNvPr>
@@ -22574,7 +22574,7 @@
           <p:cNvPr id="21" name="Rectangle 20">
             <a:extLst>
               <a:ext uri="{FF2B5EF4-FFF2-40B4-BE49-F238E27FC236}">
-                <a16:creationId xmlns:a16="http://schemas.microsoft.com/office/drawing/2014/main" id="{1F194D82-54C5-43C7-B42A-F319583125A2}"/>
+                <a16:creationId xmlns:a16="http://schemas.microsoft.com/office/drawing/2014/main" id="{D4F93A76-E42C-4690-938E-CCD458D7C502}"/>
               </a:ext>
             </a:extLst>
           </p:cNvPr>
@@ -22634,7 +22634,7 @@
     </p:spTree>
     <p:extLst>
       <p:ext uri="{BB962C8B-B14F-4D97-AF65-F5344CB8AC3E}">
-        <p14:creationId xmlns:p14="http://schemas.microsoft.com/office/powerpoint/2010/main" val="216960900"/>
+        <p14:creationId xmlns:p14="http://schemas.microsoft.com/office/powerpoint/2010/main" val="883573992"/>
       </p:ext>
     </p:extLst>
   </p:cSld>
@@ -22675,7 +22675,7 @@
             <a:hlinkClick r:id="rId3"/>
             <a:extLst>
               <a:ext uri="{FF2B5EF4-FFF2-40B4-BE49-F238E27FC236}">
-                <a16:creationId xmlns:a16="http://schemas.microsoft.com/office/drawing/2014/main" id="{F5AA322F-C90B-4A7C-8833-5EC58C0AFC50}"/>
+                <a16:creationId xmlns:a16="http://schemas.microsoft.com/office/drawing/2014/main" id="{DEAB93E7-DD40-4ABC-9F10-7C2D229746A6}"/>
               </a:ext>
             </a:extLst>
           </p:cNvPr>
@@ -22750,7 +22750,7 @@
             <a:hlinkClick r:id="rId4"/>
             <a:extLst>
               <a:ext uri="{FF2B5EF4-FFF2-40B4-BE49-F238E27FC236}">
-                <a16:creationId xmlns:a16="http://schemas.microsoft.com/office/drawing/2014/main" id="{E86DAEF7-4FEE-4713-B2FD-45252A36DAC2}"/>
+                <a16:creationId xmlns:a16="http://schemas.microsoft.com/office/drawing/2014/main" id="{D0C92731-2FA0-4CCC-8B2D-586AFAF2C189}"/>
               </a:ext>
             </a:extLst>
           </p:cNvPr>
@@ -22824,7 +22824,7 @@
           <p:cNvPr id="3" name="Rectangle 2">
             <a:extLst>
               <a:ext uri="{FF2B5EF4-FFF2-40B4-BE49-F238E27FC236}">
-                <a16:creationId xmlns:a16="http://schemas.microsoft.com/office/drawing/2014/main" id="{75E24CCC-A23A-4641-965B-CFEB8E3D5393}"/>
+                <a16:creationId xmlns:a16="http://schemas.microsoft.com/office/drawing/2014/main" id="{62B0C79B-0A11-4901-BED3-9DC6DC6E5A43}"/>
               </a:ext>
             </a:extLst>
           </p:cNvPr>
@@ -22886,7 +22886,7 @@
           <p:cNvPr id="4" name="Rectangle 3">
             <a:extLst>
               <a:ext uri="{FF2B5EF4-FFF2-40B4-BE49-F238E27FC236}">
-                <a16:creationId xmlns:a16="http://schemas.microsoft.com/office/drawing/2014/main" id="{7C3C3EF0-1CD8-46A3-9E22-1F2CBC098819}"/>
+                <a16:creationId xmlns:a16="http://schemas.microsoft.com/office/drawing/2014/main" id="{F55A97C9-29E0-46C8-87D3-0804456388C1}"/>
               </a:ext>
             </a:extLst>
           </p:cNvPr>
@@ -22975,7 +22975,7 @@
           <p:cNvPr id="6" name="Rectangle: Rounded Corners 5">
             <a:extLst>
               <a:ext uri="{FF2B5EF4-FFF2-40B4-BE49-F238E27FC236}">
-                <a16:creationId xmlns:a16="http://schemas.microsoft.com/office/drawing/2014/main" id="{08A3EFFC-4B1C-428F-8B8A-7AA9B0388EB6}"/>
+                <a16:creationId xmlns:a16="http://schemas.microsoft.com/office/drawing/2014/main" id="{616D6C9D-0434-463D-AD87-4CDC333B09C9}"/>
               </a:ext>
             </a:extLst>
           </p:cNvPr>
@@ -23008,7 +23008,7 @@
           <p:cNvPr id="7" name="Oval 6">
             <a:extLst>
               <a:ext uri="{FF2B5EF4-FFF2-40B4-BE49-F238E27FC236}">
-                <a16:creationId xmlns:a16="http://schemas.microsoft.com/office/drawing/2014/main" id="{CC275937-E2CD-4663-B1C0-43DA227896DB}"/>
+                <a16:creationId xmlns:a16="http://schemas.microsoft.com/office/drawing/2014/main" id="{3B5354CC-5007-49EC-8655-D977F5CDCE24}"/>
               </a:ext>
             </a:extLst>
           </p:cNvPr>
@@ -23039,7 +23039,7 @@
           <p:cNvPr id="8" name="Rectangle 7">
             <a:extLst>
               <a:ext uri="{FF2B5EF4-FFF2-40B4-BE49-F238E27FC236}">
-                <a16:creationId xmlns:a16="http://schemas.microsoft.com/office/drawing/2014/main" id="{8FF69CCC-CFA6-4F37-8978-C05215903AA1}"/>
+                <a16:creationId xmlns:a16="http://schemas.microsoft.com/office/drawing/2014/main" id="{7012E723-BD1C-43FC-8C35-83C236D415AA}"/>
               </a:ext>
             </a:extLst>
           </p:cNvPr>
@@ -23101,7 +23101,7 @@
           <p:cNvPr id="9" name="Rectangle: Rounded Corners 8">
             <a:extLst>
               <a:ext uri="{FF2B5EF4-FFF2-40B4-BE49-F238E27FC236}">
-                <a16:creationId xmlns:a16="http://schemas.microsoft.com/office/drawing/2014/main" id="{5A1FE333-1DC4-4152-92DE-79CE16D1207F}"/>
+                <a16:creationId xmlns:a16="http://schemas.microsoft.com/office/drawing/2014/main" id="{1F827EAD-9882-456F-A5DD-5593CCDD3AE9}"/>
               </a:ext>
             </a:extLst>
           </p:cNvPr>
@@ -23136,7 +23136,7 @@
           <p:cNvPr id="10" name="Rectangle 9">
             <a:extLst>
               <a:ext uri="{FF2B5EF4-FFF2-40B4-BE49-F238E27FC236}">
-                <a16:creationId xmlns:a16="http://schemas.microsoft.com/office/drawing/2014/main" id="{AD205E9D-CCA7-4798-8408-171452789BAE}"/>
+                <a16:creationId xmlns:a16="http://schemas.microsoft.com/office/drawing/2014/main" id="{23AF2E16-181E-4CF4-8609-C4A2D97036BD}"/>
               </a:ext>
             </a:extLst>
           </p:cNvPr>
@@ -23198,7 +23198,7 @@
           <p:cNvPr id="11" name="Oval 10">
             <a:extLst>
               <a:ext uri="{FF2B5EF4-FFF2-40B4-BE49-F238E27FC236}">
-                <a16:creationId xmlns:a16="http://schemas.microsoft.com/office/drawing/2014/main" id="{6A492D1B-E3B3-4422-928A-C8F966379AD4}"/>
+                <a16:creationId xmlns:a16="http://schemas.microsoft.com/office/drawing/2014/main" id="{14F3D205-903D-4628-AC64-35CFF62A02AE}"/>
               </a:ext>
             </a:extLst>
           </p:cNvPr>
@@ -23229,7 +23229,7 @@
           <p:cNvPr id="12" name="Rectangle 11">
             <a:extLst>
               <a:ext uri="{FF2B5EF4-FFF2-40B4-BE49-F238E27FC236}">
-                <a16:creationId xmlns:a16="http://schemas.microsoft.com/office/drawing/2014/main" id="{2AE3A833-3275-40A2-A27B-AADC57983909}"/>
+                <a16:creationId xmlns:a16="http://schemas.microsoft.com/office/drawing/2014/main" id="{00C13844-08AD-413E-BC9A-117203AFAF28}"/>
               </a:ext>
             </a:extLst>
           </p:cNvPr>
@@ -23291,7 +23291,7 @@
           <p:cNvPr id="13" name="Rectangle: Rounded Corners 12">
             <a:extLst>
               <a:ext uri="{FF2B5EF4-FFF2-40B4-BE49-F238E27FC236}">
-                <a16:creationId xmlns:a16="http://schemas.microsoft.com/office/drawing/2014/main" id="{17CECDB2-181D-4BB4-B779-396E50C9CFB8}"/>
+                <a16:creationId xmlns:a16="http://schemas.microsoft.com/office/drawing/2014/main" id="{0DD958EA-0F33-4202-9606-0F431A9F6ADD}"/>
               </a:ext>
             </a:extLst>
           </p:cNvPr>
@@ -23326,7 +23326,7 @@
           <p:cNvPr id="14" name="Rectangle 13">
             <a:extLst>
               <a:ext uri="{FF2B5EF4-FFF2-40B4-BE49-F238E27FC236}">
-                <a16:creationId xmlns:a16="http://schemas.microsoft.com/office/drawing/2014/main" id="{45309562-3181-47B7-A879-AE3FCF34B44A}"/>
+                <a16:creationId xmlns:a16="http://schemas.microsoft.com/office/drawing/2014/main" id="{139E8AE8-198D-4F64-87FE-C087E97F2612}"/>
               </a:ext>
             </a:extLst>
           </p:cNvPr>
@@ -23388,7 +23388,7 @@
           <p:cNvPr id="15" name="Oval 14">
             <a:extLst>
               <a:ext uri="{FF2B5EF4-FFF2-40B4-BE49-F238E27FC236}">
-                <a16:creationId xmlns:a16="http://schemas.microsoft.com/office/drawing/2014/main" id="{8D86912F-9F39-4E1D-A324-E8EE0BE5D997}"/>
+                <a16:creationId xmlns:a16="http://schemas.microsoft.com/office/drawing/2014/main" id="{F46C6266-7496-423F-BFE8-28FC21140621}"/>
               </a:ext>
             </a:extLst>
           </p:cNvPr>
@@ -23419,7 +23419,7 @@
           <p:cNvPr id="16" name="Rectangle 15">
             <a:extLst>
               <a:ext uri="{FF2B5EF4-FFF2-40B4-BE49-F238E27FC236}">
-                <a16:creationId xmlns:a16="http://schemas.microsoft.com/office/drawing/2014/main" id="{BD8B92A3-C5ED-4146-8290-2CB166F06607}"/>
+                <a16:creationId xmlns:a16="http://schemas.microsoft.com/office/drawing/2014/main" id="{895BA89F-EF40-4A3E-8DEA-80D502265F33}"/>
               </a:ext>
             </a:extLst>
           </p:cNvPr>
@@ -23481,7 +23481,7 @@
           <p:cNvPr id="17" name="Rectangle: Rounded Corners 16">
             <a:extLst>
               <a:ext uri="{FF2B5EF4-FFF2-40B4-BE49-F238E27FC236}">
-                <a16:creationId xmlns:a16="http://schemas.microsoft.com/office/drawing/2014/main" id="{F840C937-D642-498F-8B6F-9F67F0159B42}"/>
+                <a16:creationId xmlns:a16="http://schemas.microsoft.com/office/drawing/2014/main" id="{F4458AA9-22AC-4A13-96A5-9984CCE22464}"/>
               </a:ext>
             </a:extLst>
           </p:cNvPr>
@@ -23516,7 +23516,7 @@
           <p:cNvPr id="18" name="Rectangle 17">
             <a:extLst>
               <a:ext uri="{FF2B5EF4-FFF2-40B4-BE49-F238E27FC236}">
-                <a16:creationId xmlns:a16="http://schemas.microsoft.com/office/drawing/2014/main" id="{87BF1082-93FD-47DF-97C4-D9B7324E8FAD}"/>
+                <a16:creationId xmlns:a16="http://schemas.microsoft.com/office/drawing/2014/main" id="{5A838CAE-1E47-4F2E-A0E2-0B24FAF1F180}"/>
               </a:ext>
             </a:extLst>
           </p:cNvPr>
@@ -23578,7 +23578,7 @@
           <p:cNvPr id="19" name="Rectangle 18">
             <a:extLst>
               <a:ext uri="{FF2B5EF4-FFF2-40B4-BE49-F238E27FC236}">
-                <a16:creationId xmlns:a16="http://schemas.microsoft.com/office/drawing/2014/main" id="{4DD8652C-686B-4A1E-AFAE-B3E2796F30CA}"/>
+                <a16:creationId xmlns:a16="http://schemas.microsoft.com/office/drawing/2014/main" id="{0E856976-A2E6-4332-BF7E-58C9849E2371}"/>
               </a:ext>
             </a:extLst>
           </p:cNvPr>
@@ -23609,7 +23609,7 @@
           <p:cNvPr id="20" name="Rectangle 19">
             <a:extLst>
               <a:ext uri="{FF2B5EF4-FFF2-40B4-BE49-F238E27FC236}">
-                <a16:creationId xmlns:a16="http://schemas.microsoft.com/office/drawing/2014/main" id="{7B46BBC5-5A48-4C98-BA6A-A0D84B8C78FF}"/>
+                <a16:creationId xmlns:a16="http://schemas.microsoft.com/office/drawing/2014/main" id="{5FB77010-1C28-4A8E-A6FD-6C86B122AC55}"/>
               </a:ext>
             </a:extLst>
           </p:cNvPr>
@@ -23671,7 +23671,7 @@
           <p:cNvPr id="21" name="Rectangle 20">
             <a:extLst>
               <a:ext uri="{FF2B5EF4-FFF2-40B4-BE49-F238E27FC236}">
-                <a16:creationId xmlns:a16="http://schemas.microsoft.com/office/drawing/2014/main" id="{75238E1C-3751-45DE-9465-14C056F40BC3}"/>
+                <a16:creationId xmlns:a16="http://schemas.microsoft.com/office/drawing/2014/main" id="{FE20D0DC-5530-4410-8ED6-901B3790F366}"/>
               </a:ext>
             </a:extLst>
           </p:cNvPr>
@@ -23731,7 +23731,7 @@
     </p:spTree>
     <p:extLst>
       <p:ext uri="{BB962C8B-B14F-4D97-AF65-F5344CB8AC3E}">
-        <p14:creationId xmlns:p14="http://schemas.microsoft.com/office/powerpoint/2010/main" val="1741773770"/>
+        <p14:creationId xmlns:p14="http://schemas.microsoft.com/office/powerpoint/2010/main" val="930857206"/>
       </p:ext>
     </p:extLst>
   </p:cSld>

</xml_diff>